<commit_message>
Add telemetry recorder slide to feature deck
</commit_message>
<xml_diff>
--- a/docs/presentations/Unitree-H1-Feature-Deck-v2.pptx
+++ b/docs/presentations/Unitree-H1-Feature-Deck-v2.pptx
@@ -2,16 +2,17 @@
 <file path=ppt/presentation.xml><?xml version="1.0" encoding="utf-8"?>
 <p:presentation xmlns:p="http://schemas.openxmlformats.org/presentationml/2006/main">
   <p:sldMasterIdLst>
-    <p:sldMasterId xmlns:r="http://schemas.openxmlformats.org/officeDocument/2006/relationships" id="2147483648" r:id="Rf98dca832cff4c7a"/>
+    <p:sldMasterId xmlns:r="http://schemas.openxmlformats.org/officeDocument/2006/relationships" id="2147483648" r:id="R6c3c97e8f2924969"/>
   </p:sldMasterIdLst>
   <p:notesMasterIdLst>
-    <p:notesMasterId xmlns:r="http://schemas.openxmlformats.org/officeDocument/2006/relationships" r:id="R3f4e99abe2464ffe"/>
+    <p:notesMasterId xmlns:r="http://schemas.openxmlformats.org/officeDocument/2006/relationships" r:id="R0f3e57e8d3704ff4"/>
   </p:notesMasterIdLst>
   <p:sldIdLst>
-    <p:sldId xmlns:r="http://schemas.openxmlformats.org/officeDocument/2006/relationships" id="256" r:id="Rff65dc16d92a4dec"/>
-    <p:sldId xmlns:r="http://schemas.openxmlformats.org/officeDocument/2006/relationships" id="257" r:id="R0dd30c8f9cb9409e"/>
-    <p:sldId xmlns:r="http://schemas.openxmlformats.org/officeDocument/2006/relationships" id="258" r:id="R41156d0adee244e1"/>
-    <p:sldId xmlns:r="http://schemas.openxmlformats.org/officeDocument/2006/relationships" id="259" r:id="Rac32cbce134648c6"/>
+    <p:sldId xmlns:r="http://schemas.openxmlformats.org/officeDocument/2006/relationships" id="256" r:id="R54e54cc62808464a"/>
+    <p:sldId xmlns:r="http://schemas.openxmlformats.org/officeDocument/2006/relationships" id="257" r:id="R66e6184c4cf74b4d"/>
+    <p:sldId xmlns:r="http://schemas.openxmlformats.org/officeDocument/2006/relationships" id="258" r:id="R6128ae49f6eb49f6"/>
+    <p:sldId xmlns:r="http://schemas.openxmlformats.org/officeDocument/2006/relationships" id="259" r:id="Rbe49ef344a6f4963"/>
+    <p:sldId xmlns:r="http://schemas.openxmlformats.org/officeDocument/2006/relationships" id="260" r:id="Rb3b43b5cfd754e7b"/>
   </p:sldIdLst>
   <p:sldSz cx="12192000" cy="6858000"/>
   <p:notesSz cx="6858000" cy="9144000"/>
@@ -764,6 +765,72 @@
 </p:notes>
 </file>
 
+<file path=ppt/notesSlides/notesSlide5.xml><?xml version="1.0" encoding="utf-8"?>
+<p:notes xmlns:p="http://schemas.openxmlformats.org/presentationml/2006/main">
+  <p:cSld>
+    <p:spTree>
+      <p:nvGrpSpPr>
+        <p:cNvPr id="1" name=""/>
+        <p:cNvGrpSpPr/>
+        <p:nvPr/>
+      </p:nvGrpSpPr>
+      <p:grpSpPr>
+        <a:xfrm xmlns:a="http://schemas.openxmlformats.org/drawingml/2006/main"/>
+      </p:grpSpPr>
+      <p:sp>
+        <p:nvSpPr>
+          <p:cNvPr id="2" name="Slide Image Placeholder 1"/>
+          <p:cNvSpPr>
+            <a:spLocks xmlns:a="http://schemas.openxmlformats.org/drawingml/2006/main" noGrp="1"/>
+          </p:cNvSpPr>
+          <p:nvPr>
+            <p:ph type="sldImg" idx="0"/>
+          </p:nvPr>
+        </p:nvSpPr>
+        <p:spPr/>
+      </p:sp>
+      <p:sp>
+        <p:nvSpPr>
+          <p:cNvPr id="3" name="Notes Placeholder 2"/>
+          <p:cNvSpPr>
+            <a:spLocks xmlns:a="http://schemas.openxmlformats.org/drawingml/2006/main" noGrp="1"/>
+          </p:cNvSpPr>
+          <p:nvPr>
+            <p:ph type="body" idx="1"/>
+          </p:nvPr>
+        </p:nvSpPr>
+        <p:spPr/>
+        <p:txBody>
+          <a:bodyPr xmlns:a="http://schemas.openxmlformats.org/drawingml/2006/main"/>
+          <a:lstStyle xmlns:a="http://schemas.openxmlformats.org/drawingml/2006/main"/>
+          <a:p xmlns:a="http://schemas.openxmlformats.org/drawingml/2006/main"/>
+        </p:txBody>
+      </p:sp>
+      <p:sp>
+        <p:nvSpPr>
+          <p:cNvPr id="4" name="Slide Number Placeholder 3"/>
+          <p:cNvSpPr>
+            <a:spLocks xmlns:a="http://schemas.openxmlformats.org/drawingml/2006/main" noGrp="1"/>
+          </p:cNvSpPr>
+          <p:nvPr>
+            <p:ph type="sldNum" idx="5"/>
+          </p:nvPr>
+        </p:nvSpPr>
+        <p:spPr/>
+        <p:txBody>
+          <a:bodyPr xmlns:a="http://schemas.openxmlformats.org/drawingml/2006/main"/>
+          <a:lstStyle xmlns:a="http://schemas.openxmlformats.org/drawingml/2006/main"/>
+          <a:p xmlns:a="http://schemas.openxmlformats.org/drawingml/2006/main"/>
+        </p:txBody>
+      </p:sp>
+    </p:spTree>
+  </p:cSld>
+  <p:clrMapOvr>
+    <a:masterClrMapping xmlns:a="http://schemas.openxmlformats.org/drawingml/2006/main"/>
+  </p:clrMapOvr>
+</p:notes>
+</file>
+
 <file path=ppt/slideLayouts/slideLayout1.xml><?xml version="1.0" encoding="utf-8"?>
 <p:sldLayout xmlns:p="http://schemas.openxmlformats.org/presentationml/2006/main" type="title">
   <p:cSld name="Title Slide">
@@ -802,7 +869,7 @@
   </p:cSld>
   <p:clrMap bg1="lt1" tx1="dk1" bg2="lt2" tx2="dk2" accent1="accent1" accent2="accent2" accent3="accent3" accent4="accent4" accent5="accent5" accent6="accent6" hlink="hlink" folHlink="folHlink"/>
   <p:sldLayoutIdLst>
-    <p:sldLayoutId xmlns:r="http://schemas.openxmlformats.org/officeDocument/2006/relationships" id="2147483649" r:id="R91f259771b8d48ab"/>
+    <p:sldLayoutId xmlns:r="http://schemas.openxmlformats.org/officeDocument/2006/relationships" id="2147483649" r:id="R97f54ec5c3aa4d52"/>
   </p:sldLayoutIdLst>
   <p:txStyles>
     <p:titleStyle>
@@ -1381,6 +1448,7 @@
           <a:lstStyle xmlns:a="http://schemas.openxmlformats.org/drawingml/2006/main"/>
           <a:p xmlns:a="http://schemas.openxmlformats.org/drawingml/2006/main">
             <a:pPr>
+              <a:buNone/>
               <a:defRPr sz="1125" b="1">
                 <a:solidFill>
                   <a:srgbClr val="555555"/>
@@ -1431,6 +1499,7 @@
           <a:lstStyle xmlns:a="http://schemas.openxmlformats.org/drawingml/2006/main"/>
           <a:p xmlns:a="http://schemas.openxmlformats.org/drawingml/2006/main">
             <a:pPr>
+              <a:buNone/>
               <a:defRPr sz="3000" b="1">
                 <a:solidFill>
                   <a:srgbClr val="070707"/>
@@ -1481,6 +1550,7 @@
           <a:lstStyle xmlns:a="http://schemas.openxmlformats.org/drawingml/2006/main"/>
           <a:p xmlns:a="http://schemas.openxmlformats.org/drawingml/2006/main">
             <a:pPr>
+              <a:buNone/>
               <a:defRPr sz="1725">
                 <a:solidFill>
                   <a:srgbClr val="555555"/>
@@ -1500,14 +1570,14 @@
       </p:sp>
       <p:pic>
         <p:nvPicPr>
-          <p:cNvPr id="16" name=""/>
+          <p:cNvPr id="17" name=""/>
           <p:cNvPicPr>
             <a:picLocks xmlns:a="http://schemas.openxmlformats.org/drawingml/2006/main" noChangeAspect="1"/>
           </p:cNvPicPr>
           <p:nvPr/>
         </p:nvPicPr>
         <p:blipFill>
-          <a:blip xmlns:r="http://schemas.openxmlformats.org/officeDocument/2006/relationships" xmlns:a="http://schemas.openxmlformats.org/drawingml/2006/main" r:embed="Re01c6fdd96464137"/>
+          <a:blip xmlns:r="http://schemas.openxmlformats.org/officeDocument/2006/relationships" xmlns:a="http://schemas.openxmlformats.org/drawingml/2006/main" r:embed="Rc8ad7f38452a47f7"/>
           <a:srcRect xmlns:a="http://schemas.openxmlformats.org/drawingml/2006/main" l="0" t="30309" r="0" b="30309"/>
           <a:stretch xmlns:a="http://schemas.openxmlformats.org/drawingml/2006/main">
             <a:fillRect l="0" t="0" r="0" b="0"/>
@@ -1589,6 +1659,7 @@
           <a:lstStyle xmlns:a="http://schemas.openxmlformats.org/drawingml/2006/main"/>
           <a:p xmlns:a="http://schemas.openxmlformats.org/drawingml/2006/main">
             <a:pPr>
+              <a:buNone/>
               <a:defRPr sz="1275" b="1">
                 <a:solidFill>
                   <a:srgbClr val="E60000"/>
@@ -1639,6 +1710,7 @@
           <a:lstStyle xmlns:a="http://schemas.openxmlformats.org/drawingml/2006/main"/>
           <a:p xmlns:a="http://schemas.openxmlformats.org/drawingml/2006/main">
             <a:pPr>
+              <a:buNone/>
               <a:defRPr sz="1800" b="1">
                 <a:solidFill>
                   <a:srgbClr val="070707"/>
@@ -1689,6 +1761,7 @@
           <a:lstStyle xmlns:a="http://schemas.openxmlformats.org/drawingml/2006/main"/>
           <a:p xmlns:a="http://schemas.openxmlformats.org/drawingml/2006/main">
             <a:pPr>
+              <a:buNone/>
               <a:defRPr sz="1275" b="1">
                 <a:solidFill>
                   <a:srgbClr val="E60000"/>
@@ -1739,6 +1812,7 @@
           <a:lstStyle xmlns:a="http://schemas.openxmlformats.org/drawingml/2006/main"/>
           <a:p xmlns:a="http://schemas.openxmlformats.org/drawingml/2006/main">
             <a:pPr>
+              <a:buNone/>
               <a:defRPr sz="1800" b="1">
                 <a:solidFill>
                   <a:srgbClr val="070707"/>
@@ -1789,6 +1863,7 @@
           <a:lstStyle xmlns:a="http://schemas.openxmlformats.org/drawingml/2006/main"/>
           <a:p xmlns:a="http://schemas.openxmlformats.org/drawingml/2006/main">
             <a:pPr>
+              <a:buNone/>
               <a:defRPr sz="1275" b="1">
                 <a:solidFill>
                   <a:srgbClr val="E60000"/>
@@ -1839,6 +1914,7 @@
           <a:lstStyle xmlns:a="http://schemas.openxmlformats.org/drawingml/2006/main"/>
           <a:p xmlns:a="http://schemas.openxmlformats.org/drawingml/2006/main">
             <a:pPr>
+              <a:buNone/>
               <a:defRPr sz="1800" b="1">
                 <a:solidFill>
                   <a:srgbClr val="070707"/>
@@ -1889,6 +1965,7 @@
           <a:lstStyle xmlns:a="http://schemas.openxmlformats.org/drawingml/2006/main"/>
           <a:p xmlns:a="http://schemas.openxmlformats.org/drawingml/2006/main">
             <a:pPr>
+              <a:buNone/>
               <a:defRPr sz="1800" b="1">
                 <a:solidFill>
                   <a:srgbClr val="E60000"/>
@@ -1968,6 +2045,7 @@
           <a:lstStyle xmlns:a="http://schemas.openxmlformats.org/drawingml/2006/main"/>
           <a:p xmlns:a="http://schemas.openxmlformats.org/drawingml/2006/main">
             <a:pPr>
+              <a:buNone/>
               <a:defRPr sz="1125" b="1">
                 <a:solidFill>
                   <a:srgbClr val="555555"/>
@@ -2018,6 +2096,7 @@
           <a:lstStyle xmlns:a="http://schemas.openxmlformats.org/drawingml/2006/main"/>
           <a:p xmlns:a="http://schemas.openxmlformats.org/drawingml/2006/main">
             <a:pPr>
+              <a:buNone/>
               <a:defRPr sz="3075" b="1">
                 <a:solidFill>
                   <a:srgbClr val="070707"/>
@@ -2068,6 +2147,7 @@
           <a:lstStyle xmlns:a="http://schemas.openxmlformats.org/drawingml/2006/main"/>
           <a:p xmlns:a="http://schemas.openxmlformats.org/drawingml/2006/main">
             <a:pPr>
+              <a:buNone/>
               <a:defRPr sz="1725">
                 <a:solidFill>
                   <a:srgbClr val="555555"/>
@@ -2087,14 +2167,14 @@
       </p:sp>
       <p:pic>
         <p:nvPicPr>
-          <p:cNvPr id="15" name=""/>
+          <p:cNvPr id="18" name=""/>
           <p:cNvPicPr>
             <a:picLocks xmlns:a="http://schemas.openxmlformats.org/drawingml/2006/main" noChangeAspect="1"/>
           </p:cNvPicPr>
           <p:nvPr/>
         </p:nvPicPr>
         <p:blipFill>
-          <a:blip xmlns:r="http://schemas.openxmlformats.org/officeDocument/2006/relationships" xmlns:a="http://schemas.openxmlformats.org/drawingml/2006/main" r:embed="R0b472e3b56994e5f"/>
+          <a:blip xmlns:r="http://schemas.openxmlformats.org/officeDocument/2006/relationships" xmlns:a="http://schemas.openxmlformats.org/drawingml/2006/main" r:embed="Rc8244b0d769046f2"/>
           <a:srcRect xmlns:a="http://schemas.openxmlformats.org/drawingml/2006/main" l="0" t="6000" r="0" b="6000"/>
           <a:stretch xmlns:a="http://schemas.openxmlformats.org/drawingml/2006/main">
             <a:fillRect l="0" t="0" r="0" b="0"/>
@@ -2112,14 +2192,14 @@
       </p:pic>
       <p:pic>
         <p:nvPicPr>
-          <p:cNvPr id="16" name=""/>
+          <p:cNvPr id="19" name=""/>
           <p:cNvPicPr>
             <a:picLocks xmlns:a="http://schemas.openxmlformats.org/drawingml/2006/main" noChangeAspect="1"/>
           </p:cNvPicPr>
           <p:nvPr/>
         </p:nvPicPr>
         <p:blipFill>
-          <a:blip xmlns:r="http://schemas.openxmlformats.org/officeDocument/2006/relationships" xmlns:a="http://schemas.openxmlformats.org/drawingml/2006/main" r:embed="R045c0e22e7604c9f"/>
+          <a:blip xmlns:r="http://schemas.openxmlformats.org/officeDocument/2006/relationships" xmlns:a="http://schemas.openxmlformats.org/drawingml/2006/main" r:embed="R2790fb7f346b49ef"/>
           <a:srcRect xmlns:a="http://schemas.openxmlformats.org/drawingml/2006/main" l="0" t="6000" r="0" b="6000"/>
           <a:stretch xmlns:a="http://schemas.openxmlformats.org/drawingml/2006/main">
             <a:fillRect l="0" t="0" r="0" b="0"/>
@@ -2137,14 +2217,14 @@
       </p:pic>
       <p:pic>
         <p:nvPicPr>
-          <p:cNvPr id="17" name=""/>
+          <p:cNvPr id="20" name=""/>
           <p:cNvPicPr>
             <a:picLocks xmlns:a="http://schemas.openxmlformats.org/drawingml/2006/main" noChangeAspect="1"/>
           </p:cNvPicPr>
           <p:nvPr/>
         </p:nvPicPr>
         <p:blipFill>
-          <a:blip xmlns:r="http://schemas.openxmlformats.org/officeDocument/2006/relationships" xmlns:a="http://schemas.openxmlformats.org/drawingml/2006/main" r:embed="Rb0d33a60aea147a0"/>
+          <a:blip xmlns:r="http://schemas.openxmlformats.org/officeDocument/2006/relationships" xmlns:a="http://schemas.openxmlformats.org/drawingml/2006/main" r:embed="Rc77cb5343f3e4147"/>
           <a:srcRect xmlns:a="http://schemas.openxmlformats.org/drawingml/2006/main" l="0" t="6000" r="0" b="6000"/>
           <a:stretch xmlns:a="http://schemas.openxmlformats.org/drawingml/2006/main">
             <a:fillRect l="0" t="0" r="0" b="0"/>
@@ -2226,6 +2306,7 @@
           <a:lstStyle xmlns:a="http://schemas.openxmlformats.org/drawingml/2006/main"/>
           <a:p xmlns:a="http://schemas.openxmlformats.org/drawingml/2006/main">
             <a:pPr>
+              <a:buNone/>
               <a:defRPr sz="1800" b="1">
                 <a:solidFill>
                   <a:srgbClr val="070707"/>
@@ -2276,6 +2357,7 @@
           <a:lstStyle xmlns:a="http://schemas.openxmlformats.org/drawingml/2006/main"/>
           <a:p xmlns:a="http://schemas.openxmlformats.org/drawingml/2006/main">
             <a:pPr>
+              <a:buNone/>
               <a:defRPr sz="1800" b="1">
                 <a:solidFill>
                   <a:srgbClr val="070707"/>
@@ -2326,6 +2408,7 @@
           <a:lstStyle xmlns:a="http://schemas.openxmlformats.org/drawingml/2006/main"/>
           <a:p xmlns:a="http://schemas.openxmlformats.org/drawingml/2006/main">
             <a:pPr>
+              <a:buNone/>
               <a:defRPr sz="1800" b="1">
                 <a:solidFill>
                   <a:srgbClr val="E60000"/>
@@ -2376,6 +2459,7 @@
           <a:lstStyle xmlns:a="http://schemas.openxmlformats.org/drawingml/2006/main"/>
           <a:p xmlns:a="http://schemas.openxmlformats.org/drawingml/2006/main">
             <a:pPr>
+              <a:buNone/>
               <a:defRPr sz="1650">
                 <a:solidFill>
                   <a:srgbClr val="555555"/>
@@ -2424,14 +2508,14 @@
       </p:grpSpPr>
       <p:pic>
         <p:nvPicPr>
-          <p:cNvPr id="13" name=""/>
+          <p:cNvPr id="14" name=""/>
           <p:cNvPicPr>
             <a:picLocks xmlns:a="http://schemas.openxmlformats.org/drawingml/2006/main" noChangeAspect="1"/>
           </p:cNvPicPr>
           <p:nvPr/>
         </p:nvPicPr>
         <p:blipFill>
-          <a:blip xmlns:r="http://schemas.openxmlformats.org/officeDocument/2006/relationships" xmlns:a="http://schemas.openxmlformats.org/drawingml/2006/main" r:embed="Rdcb4163aa69c431c"/>
+          <a:blip xmlns:r="http://schemas.openxmlformats.org/officeDocument/2006/relationships" xmlns:a="http://schemas.openxmlformats.org/drawingml/2006/main" r:embed="Re92814bae5e84041"/>
           <a:srcRect xmlns:a="http://schemas.openxmlformats.org/drawingml/2006/main" l="18895" t="0" r="18895" b="0"/>
           <a:stretch xmlns:a="http://schemas.openxmlformats.org/drawingml/2006/main">
             <a:fillRect l="0" t="0" r="0" b="0"/>
@@ -2511,6 +2595,7 @@
           <a:lstStyle xmlns:a="http://schemas.openxmlformats.org/drawingml/2006/main"/>
           <a:p xmlns:a="http://schemas.openxmlformats.org/drawingml/2006/main">
             <a:pPr>
+              <a:buNone/>
               <a:defRPr sz="1125" b="1">
                 <a:solidFill>
                   <a:srgbClr val="555555"/>
@@ -2561,6 +2646,7 @@
           <a:lstStyle xmlns:a="http://schemas.openxmlformats.org/drawingml/2006/main"/>
           <a:p xmlns:a="http://schemas.openxmlformats.org/drawingml/2006/main">
             <a:pPr>
+              <a:buNone/>
               <a:defRPr sz="3150" b="1">
                 <a:solidFill>
                   <a:srgbClr val="070707"/>
@@ -2611,6 +2697,7 @@
           <a:lstStyle xmlns:a="http://schemas.openxmlformats.org/drawingml/2006/main"/>
           <a:p xmlns:a="http://schemas.openxmlformats.org/drawingml/2006/main">
             <a:pPr>
+              <a:buNone/>
               <a:defRPr sz="1725">
                 <a:solidFill>
                   <a:srgbClr val="555555"/>
@@ -2694,6 +2781,7 @@
           <a:lstStyle xmlns:a="http://schemas.openxmlformats.org/drawingml/2006/main"/>
           <a:p xmlns:a="http://schemas.openxmlformats.org/drawingml/2006/main">
             <a:pPr>
+              <a:buNone/>
               <a:defRPr sz="1800" b="1">
                 <a:solidFill>
                   <a:srgbClr val="070707"/>
@@ -2744,6 +2832,7 @@
           <a:lstStyle xmlns:a="http://schemas.openxmlformats.org/drawingml/2006/main"/>
           <a:p xmlns:a="http://schemas.openxmlformats.org/drawingml/2006/main">
             <a:pPr>
+              <a:buNone/>
               <a:defRPr sz="1800" b="1">
                 <a:solidFill>
                   <a:srgbClr val="070707"/>
@@ -2794,6 +2883,7 @@
           <a:lstStyle xmlns:a="http://schemas.openxmlformats.org/drawingml/2006/main"/>
           <a:p xmlns:a="http://schemas.openxmlformats.org/drawingml/2006/main">
             <a:pPr>
+              <a:buNone/>
               <a:defRPr sz="1800" b="1">
                 <a:solidFill>
                   <a:srgbClr val="E60000"/>
@@ -2844,6 +2934,7 @@
           <a:lstStyle xmlns:a="http://schemas.openxmlformats.org/drawingml/2006/main"/>
           <a:p xmlns:a="http://schemas.openxmlformats.org/drawingml/2006/main">
             <a:pPr>
+              <a:buNone/>
               <a:defRPr sz="1800" b="1">
                 <a:solidFill>
                   <a:srgbClr val="070707"/>
@@ -2894,6 +2985,7 @@
           <a:lstStyle xmlns:a="http://schemas.openxmlformats.org/drawingml/2006/main"/>
           <a:p xmlns:a="http://schemas.openxmlformats.org/drawingml/2006/main">
             <a:pPr>
+              <a:buNone/>
               <a:defRPr sz="1800" b="1">
                 <a:solidFill>
                   <a:srgbClr val="E60000"/>
@@ -2944,6 +3036,7 @@
           <a:lstStyle xmlns:a="http://schemas.openxmlformats.org/drawingml/2006/main"/>
           <a:p xmlns:a="http://schemas.openxmlformats.org/drawingml/2006/main">
             <a:pPr>
+              <a:buNone/>
               <a:defRPr sz="1650">
                 <a:solidFill>
                   <a:srgbClr val="555555"/>
@@ -3023,6 +3116,7 @@
           <a:lstStyle xmlns:a="http://schemas.openxmlformats.org/drawingml/2006/main"/>
           <a:p xmlns:a="http://schemas.openxmlformats.org/drawingml/2006/main">
             <a:pPr>
+              <a:buNone/>
               <a:defRPr sz="1125" b="1">
                 <a:solidFill>
                   <a:srgbClr val="555555"/>
@@ -3073,6 +3167,7 @@
           <a:lstStyle xmlns:a="http://schemas.openxmlformats.org/drawingml/2006/main"/>
           <a:p xmlns:a="http://schemas.openxmlformats.org/drawingml/2006/main">
             <a:pPr>
+              <a:buNone/>
               <a:defRPr sz="3225" b="1">
                 <a:solidFill>
                   <a:srgbClr val="070707"/>
@@ -3092,14 +3187,14 @@
       </p:sp>
       <p:pic>
         <p:nvPicPr>
-          <p:cNvPr id="14" name=""/>
+          <p:cNvPr id="17" name=""/>
           <p:cNvPicPr>
             <a:picLocks xmlns:a="http://schemas.openxmlformats.org/drawingml/2006/main" noChangeAspect="1"/>
           </p:cNvPicPr>
           <p:nvPr/>
         </p:nvPicPr>
         <p:blipFill>
-          <a:blip xmlns:r="http://schemas.openxmlformats.org/officeDocument/2006/relationships" xmlns:a="http://schemas.openxmlformats.org/drawingml/2006/main" r:embed="Rff7a1ea42ca5450a"/>
+          <a:blip xmlns:r="http://schemas.openxmlformats.org/officeDocument/2006/relationships" xmlns:a="http://schemas.openxmlformats.org/drawingml/2006/main" r:embed="R395afb11aab44e26"/>
           <a:srcRect xmlns:a="http://schemas.openxmlformats.org/drawingml/2006/main" l="0" t="2134" r="0" b="2134"/>
           <a:stretch xmlns:a="http://schemas.openxmlformats.org/drawingml/2006/main">
             <a:fillRect l="0" t="0" r="0" b="0"/>
@@ -3117,14 +3212,14 @@
       </p:pic>
       <p:pic>
         <p:nvPicPr>
-          <p:cNvPr id="15" name=""/>
+          <p:cNvPr id="18" name=""/>
           <p:cNvPicPr>
             <a:picLocks xmlns:a="http://schemas.openxmlformats.org/drawingml/2006/main" noChangeAspect="1"/>
           </p:cNvPicPr>
           <p:nvPr/>
         </p:nvPicPr>
         <p:blipFill>
-          <a:blip xmlns:r="http://schemas.openxmlformats.org/officeDocument/2006/relationships" xmlns:a="http://schemas.openxmlformats.org/drawingml/2006/main" r:embed="R77bb9d285f5f4cf4"/>
+          <a:blip xmlns:r="http://schemas.openxmlformats.org/officeDocument/2006/relationships" xmlns:a="http://schemas.openxmlformats.org/drawingml/2006/main" r:embed="R0e118d0c6cfe4fc2"/>
           <a:srcRect xmlns:a="http://schemas.openxmlformats.org/drawingml/2006/main" l="0" t="2134" r="0" b="2134"/>
           <a:stretch xmlns:a="http://schemas.openxmlformats.org/drawingml/2006/main">
             <a:fillRect l="0" t="0" r="0" b="0"/>
@@ -3142,14 +3237,14 @@
       </p:pic>
       <p:pic>
         <p:nvPicPr>
-          <p:cNvPr id="16" name=""/>
+          <p:cNvPr id="19" name=""/>
           <p:cNvPicPr>
             <a:picLocks xmlns:a="http://schemas.openxmlformats.org/drawingml/2006/main" noChangeAspect="1"/>
           </p:cNvPicPr>
           <p:nvPr/>
         </p:nvPicPr>
         <p:blipFill>
-          <a:blip xmlns:r="http://schemas.openxmlformats.org/officeDocument/2006/relationships" xmlns:a="http://schemas.openxmlformats.org/drawingml/2006/main" r:embed="R5e608ffb837c44b1"/>
+          <a:blip xmlns:r="http://schemas.openxmlformats.org/officeDocument/2006/relationships" xmlns:a="http://schemas.openxmlformats.org/drawingml/2006/main" r:embed="R5e4ca588bfa94c50"/>
           <a:srcRect xmlns:a="http://schemas.openxmlformats.org/drawingml/2006/main" l="0" t="2134" r="0" b="2134"/>
           <a:stretch xmlns:a="http://schemas.openxmlformats.org/drawingml/2006/main">
             <a:fillRect l="0" t="0" r="0" b="0"/>
@@ -3231,6 +3326,7 @@
           <a:lstStyle xmlns:a="http://schemas.openxmlformats.org/drawingml/2006/main"/>
           <a:p xmlns:a="http://schemas.openxmlformats.org/drawingml/2006/main">
             <a:pPr>
+              <a:buNone/>
               <a:defRPr sz="1800" b="1">
                 <a:solidFill>
                   <a:srgbClr val="070707"/>
@@ -3281,6 +3377,7 @@
           <a:lstStyle xmlns:a="http://schemas.openxmlformats.org/drawingml/2006/main"/>
           <a:p xmlns:a="http://schemas.openxmlformats.org/drawingml/2006/main">
             <a:pPr>
+              <a:buNone/>
               <a:defRPr sz="1800" b="1">
                 <a:solidFill>
                   <a:srgbClr val="070707"/>
@@ -3331,6 +3428,7 @@
           <a:lstStyle xmlns:a="http://schemas.openxmlformats.org/drawingml/2006/main"/>
           <a:p xmlns:a="http://schemas.openxmlformats.org/drawingml/2006/main">
             <a:pPr>
+              <a:buNone/>
               <a:defRPr sz="1800" b="1">
                 <a:solidFill>
                   <a:srgbClr val="070707"/>
@@ -3381,6 +3479,7 @@
           <a:lstStyle xmlns:a="http://schemas.openxmlformats.org/drawingml/2006/main"/>
           <a:p xmlns:a="http://schemas.openxmlformats.org/drawingml/2006/main">
             <a:pPr>
+              <a:buNone/>
               <a:defRPr sz="1800" b="1">
                 <a:solidFill>
                   <a:srgbClr val="E60000"/>
@@ -3431,6 +3530,7 @@
           <a:lstStyle xmlns:a="http://schemas.openxmlformats.org/drawingml/2006/main"/>
           <a:p xmlns:a="http://schemas.openxmlformats.org/drawingml/2006/main">
             <a:pPr>
+              <a:buNone/>
               <a:defRPr sz="1875" b="1">
                 <a:solidFill>
                   <a:srgbClr val="070707"/>
@@ -3452,6 +3552,955 @@
     <p:extLst>
       <p:ext uri="{BB962C8B-B14F-4D97-AF65-F5344CB8AC3E}">
         <p14:creationId xmlns:p14="http://schemas.microsoft.com/office/powerpoint/2010/main" val="864857682"/>
+      </p:ext>
+    </p:extLst>
+  </p:cSld>
+</p:sld>
+</file>
+
+<file path=ppt/slides/slide5.xml><?xml version="1.0" encoding="utf-8"?>
+<p:sld xmlns:p="http://schemas.openxmlformats.org/presentationml/2006/main">
+  <p:cSld>
+    <p:bg>
+      <p:bgPr>
+        <a:solidFill xmlns:a="http://schemas.openxmlformats.org/drawingml/2006/main">
+          <a:srgbClr val="080B0F"/>
+        </a:solidFill>
+      </p:bgPr>
+    </p:bg>
+    <p:spTree>
+      <p:nvGrpSpPr>
+        <p:cNvPr id="1" name=""/>
+        <p:cNvGrpSpPr/>
+        <p:nvPr/>
+      </p:nvGrpSpPr>
+      <p:grpSpPr>
+        <a:xfrm xmlns:a="http://schemas.openxmlformats.org/drawingml/2006/main"/>
+      </p:grpSpPr>
+      <p:sp>
+        <p:nvSpPr>
+          <p:cNvPr id="1" name="telemetry-left-panel-soft-fill">
+            <a:extLst xmlns:a="http://schemas.openxmlformats.org/drawingml/2006/main">
+              <a:ext uri="{FF2B5EF4-FFF2-40B4-BE49-F238E27FC236}">
+                <a16:creationId xmlns:a16="http://schemas.microsoft.com/office/drawing/2014/main" id="{CBC62815-18EF-469D-8AF6-046FC619F186}"/>
+              </a:ext>
+            </a:extLst>
+          </p:cNvPr>
+          <p:cNvSpPr>
+            <a:spLocks xmlns:a="http://schemas.openxmlformats.org/drawingml/2006/main" noGrp="1"/>
+          </p:cNvSpPr>
+          <p:nvPr/>
+        </p:nvSpPr>
+        <p:spPr>
+          <a:xfrm xmlns:a="http://schemas.openxmlformats.org/drawingml/2006/main">
+            <a:off x="0" y="0"/>
+            <a:ext cx="5334000" cy="6858000"/>
+          </a:xfrm>
+          <a:prstGeom xmlns:a="http://schemas.openxmlformats.org/drawingml/2006/main" prst="rect">
+            <a:avLst/>
+          </a:prstGeom>
+          <a:solidFill xmlns:a="http://schemas.openxmlformats.org/drawingml/2006/main">
+            <a:srgbClr val="111318"/>
+          </a:solidFill>
+          <a:ln xmlns:a="http://schemas.openxmlformats.org/drawingml/2006/main" w="0">
+            <a:noFill/>
+            <a:prstDash val="solid"/>
+          </a:ln>
+        </p:spPr>
+      </p:sp>
+      <p:sp>
+        <p:nvSpPr>
+          <p:cNvPr id="2" name="telemetry-eyebrow">
+            <a:extLst xmlns:a="http://schemas.openxmlformats.org/drawingml/2006/main">
+              <a:ext uri="{FF2B5EF4-FFF2-40B4-BE49-F238E27FC236}">
+                <a16:creationId xmlns:a16="http://schemas.microsoft.com/office/drawing/2014/main" id="{E0530488-1AE3-44F2-92D7-4DFACCCD64CC}"/>
+              </a:ext>
+            </a:extLst>
+          </p:cNvPr>
+          <p:cNvSpPr>
+            <a:spLocks xmlns:a="http://schemas.openxmlformats.org/drawingml/2006/main" noGrp="1"/>
+          </p:cNvSpPr>
+          <p:nvPr/>
+        </p:nvSpPr>
+        <p:spPr>
+          <a:xfrm xmlns:a="http://schemas.openxmlformats.org/drawingml/2006/main">
+            <a:off x="514350" y="419100"/>
+            <a:ext cx="4095750" cy="228600"/>
+          </a:xfrm>
+          <a:prstGeom xmlns:a="http://schemas.openxmlformats.org/drawingml/2006/main" prst="rect">
+            <a:avLst/>
+          </a:prstGeom>
+          <a:noFill xmlns:a="http://schemas.openxmlformats.org/drawingml/2006/main"/>
+          <a:ln xmlns:a="http://schemas.openxmlformats.org/drawingml/2006/main" w="0">
+            <a:noFill/>
+            <a:prstDash val="solid"/>
+          </a:ln>
+        </p:spPr>
+        <p:txBody>
+          <a:bodyPr xmlns:a="http://schemas.openxmlformats.org/drawingml/2006/main"/>
+          <a:lstStyle xmlns:a="http://schemas.openxmlformats.org/drawingml/2006/main"/>
+          <a:p xmlns:a="http://schemas.openxmlformats.org/drawingml/2006/main">
+            <a:pPr>
+              <a:defRPr sz="1050" b="1">
+                <a:solidFill>
+                  <a:srgbClr val="22C55E"/>
+                </a:solidFill>
+              </a:defRPr>
+            </a:pPr>
+            <a:r>
+              <a:rPr sz="1050" b="1">
+                <a:solidFill>
+                  <a:srgbClr val="22C55E"/>
+                </a:solidFill>
+              </a:rPr>
+              <a:t>ROBOT TELEMETRY WORKFLOW</a:t>
+            </a:r>
+          </a:p>
+        </p:txBody>
+      </p:sp>
+      <p:sp>
+        <p:nvSpPr>
+          <p:cNvPr id="3" name="telemetry-title">
+            <a:extLst xmlns:a="http://schemas.openxmlformats.org/drawingml/2006/main">
+              <a:ext uri="{FF2B5EF4-FFF2-40B4-BE49-F238E27FC236}">
+                <a16:creationId xmlns:a16="http://schemas.microsoft.com/office/drawing/2014/main" id="{15A7CE41-3219-40BB-AE6C-BDEE049C0553}"/>
+              </a:ext>
+            </a:extLst>
+          </p:cNvPr>
+          <p:cNvSpPr>
+            <a:spLocks xmlns:a="http://schemas.openxmlformats.org/drawingml/2006/main" noGrp="1"/>
+          </p:cNvSpPr>
+          <p:nvPr/>
+        </p:nvSpPr>
+        <p:spPr>
+          <a:xfrm xmlns:a="http://schemas.openxmlformats.org/drawingml/2006/main">
+            <a:off x="514350" y="781050"/>
+            <a:ext cx="4457700" cy="990600"/>
+          </a:xfrm>
+          <a:prstGeom xmlns:a="http://schemas.openxmlformats.org/drawingml/2006/main" prst="rect">
+            <a:avLst/>
+          </a:prstGeom>
+          <a:noFill xmlns:a="http://schemas.openxmlformats.org/drawingml/2006/main"/>
+          <a:ln xmlns:a="http://schemas.openxmlformats.org/drawingml/2006/main" w="0">
+            <a:noFill/>
+            <a:prstDash val="solid"/>
+          </a:ln>
+        </p:spPr>
+        <p:txBody>
+          <a:bodyPr xmlns:a="http://schemas.openxmlformats.org/drawingml/2006/main"/>
+          <a:lstStyle xmlns:a="http://schemas.openxmlformats.org/drawingml/2006/main"/>
+          <a:p xmlns:a="http://schemas.openxmlformats.org/drawingml/2006/main">
+            <a:pPr>
+              <a:defRPr sz="2850" b="1">
+                <a:solidFill>
+                  <a:srgbClr val="FFFFFF"/>
+                </a:solidFill>
+              </a:defRPr>
+            </a:pPr>
+            <a:r>
+              <a:rPr sz="2850" b="1">
+                <a:solidFill>
+                  <a:srgbClr val="FFFFFF"/>
+                </a:solidFill>
+              </a:rPr>
+              <a:t>Telemetry Recorder</a:t>
+            </a:r>
+          </a:p>
+          <a:p xmlns:a="http://schemas.openxmlformats.org/drawingml/2006/main">
+            <a:pPr>
+              <a:defRPr sz="2850" b="1">
+                <a:solidFill>
+                  <a:srgbClr val="FFFFFF"/>
+                </a:solidFill>
+              </a:defRPr>
+            </a:pPr>
+            <a:r>
+              <a:rPr sz="2850" b="1">
+                <a:solidFill>
+                  <a:srgbClr val="FFFFFF"/>
+                </a:solidFill>
+              </a:rPr>
+              <a:t>hareketi doğruluyor</a:t>
+            </a:r>
+          </a:p>
+        </p:txBody>
+      </p:sp>
+      <p:sp>
+        <p:nvSpPr>
+          <p:cNvPr id="4" name="telemetry-subtitle">
+            <a:extLst xmlns:a="http://schemas.openxmlformats.org/drawingml/2006/main">
+              <a:ext uri="{FF2B5EF4-FFF2-40B4-BE49-F238E27FC236}">
+                <a16:creationId xmlns:a16="http://schemas.microsoft.com/office/drawing/2014/main" id="{E45BB33F-575A-492B-9A5A-956A57CFD5EA}"/>
+              </a:ext>
+            </a:extLst>
+          </p:cNvPr>
+          <p:cNvSpPr>
+            <a:spLocks xmlns:a="http://schemas.openxmlformats.org/drawingml/2006/main" noGrp="1"/>
+          </p:cNvSpPr>
+          <p:nvPr/>
+        </p:nvSpPr>
+        <p:spPr>
+          <a:xfrm xmlns:a="http://schemas.openxmlformats.org/drawingml/2006/main">
+            <a:off x="533400" y="1981200"/>
+            <a:ext cx="4343400" cy="742950"/>
+          </a:xfrm>
+          <a:prstGeom xmlns:a="http://schemas.openxmlformats.org/drawingml/2006/main" prst="rect">
+            <a:avLst/>
+          </a:prstGeom>
+          <a:noFill xmlns:a="http://schemas.openxmlformats.org/drawingml/2006/main"/>
+          <a:ln xmlns:a="http://schemas.openxmlformats.org/drawingml/2006/main" w="0">
+            <a:noFill/>
+            <a:prstDash val="solid"/>
+          </a:ln>
+        </p:spPr>
+        <p:txBody>
+          <a:bodyPr xmlns:a="http://schemas.openxmlformats.org/drawingml/2006/main"/>
+          <a:lstStyle xmlns:a="http://schemas.openxmlformats.org/drawingml/2006/main"/>
+          <a:p xmlns:a="http://schemas.openxmlformats.org/drawingml/2006/main">
+            <a:pPr>
+              <a:defRPr sz="1350">
+                <a:solidFill>
+                  <a:srgbClr val="CBD5E1"/>
+                </a:solidFill>
+              </a:defRPr>
+            </a:pPr>
+            <a:r>
+              <a:rPr sz="1350">
+                <a:solidFill>
+                  <a:srgbClr val="CBD5E1"/>
+                </a:solidFill>
+              </a:rPr>
+              <a:t>Ekran; motor örneklerinden sequence oluşturma, simülasyonla kontrol etme ve güvenli hareketi gerçek robota kaydetme akışını tek yerde topluyor.</a:t>
+            </a:r>
+          </a:p>
+        </p:txBody>
+      </p:sp>
+      <p:sp>
+        <p:nvSpPr>
+          <p:cNvPr id="5" name="telemetry-feature-accent-0">
+            <a:extLst xmlns:a="http://schemas.openxmlformats.org/drawingml/2006/main">
+              <a:ext uri="{FF2B5EF4-FFF2-40B4-BE49-F238E27FC236}">
+                <a16:creationId xmlns:a16="http://schemas.microsoft.com/office/drawing/2014/main" id="{8FC66A6B-49E4-41DE-87C3-C8CF754334EF}"/>
+              </a:ext>
+            </a:extLst>
+          </p:cNvPr>
+          <p:cNvSpPr>
+            <a:spLocks xmlns:a="http://schemas.openxmlformats.org/drawingml/2006/main" noGrp="1"/>
+          </p:cNvSpPr>
+          <p:nvPr/>
+        </p:nvSpPr>
+        <p:spPr>
+          <a:xfrm xmlns:a="http://schemas.openxmlformats.org/drawingml/2006/main">
+            <a:off x="514350" y="2914650"/>
+            <a:ext cx="76200" cy="742950"/>
+          </a:xfrm>
+          <a:prstGeom xmlns:a="http://schemas.openxmlformats.org/drawingml/2006/main" prst="roundRect">
+            <a:avLst>
+              <a:gd name="adj" fmla="val 50000"/>
+            </a:avLst>
+          </a:prstGeom>
+          <a:solidFill xmlns:a="http://schemas.openxmlformats.org/drawingml/2006/main">
+            <a:srgbClr val="22C55E"/>
+          </a:solidFill>
+          <a:ln xmlns:a="http://schemas.openxmlformats.org/drawingml/2006/main" w="0">
+            <a:noFill/>
+            <a:prstDash val="solid"/>
+          </a:ln>
+        </p:spPr>
+      </p:sp>
+      <p:sp>
+        <p:nvSpPr>
+          <p:cNvPr id="6" name="telemetry-feature-title-0">
+            <a:extLst xmlns:a="http://schemas.openxmlformats.org/drawingml/2006/main">
+              <a:ext uri="{FF2B5EF4-FFF2-40B4-BE49-F238E27FC236}">
+                <a16:creationId xmlns:a16="http://schemas.microsoft.com/office/drawing/2014/main" id="{8E20D219-CA99-478A-8D9D-DC5DD87E1959}"/>
+              </a:ext>
+            </a:extLst>
+          </p:cNvPr>
+          <p:cNvSpPr>
+            <a:spLocks xmlns:a="http://schemas.openxmlformats.org/drawingml/2006/main" noGrp="1"/>
+          </p:cNvSpPr>
+          <p:nvPr/>
+        </p:nvSpPr>
+        <p:spPr>
+          <a:xfrm xmlns:a="http://schemas.openxmlformats.org/drawingml/2006/main">
+            <a:off x="723900" y="2895600"/>
+            <a:ext cx="4210050" cy="247650"/>
+          </a:xfrm>
+          <a:prstGeom xmlns:a="http://schemas.openxmlformats.org/drawingml/2006/main" prst="rect">
+            <a:avLst/>
+          </a:prstGeom>
+          <a:noFill xmlns:a="http://schemas.openxmlformats.org/drawingml/2006/main"/>
+          <a:ln xmlns:a="http://schemas.openxmlformats.org/drawingml/2006/main" w="0">
+            <a:noFill/>
+            <a:prstDash val="solid"/>
+          </a:ln>
+        </p:spPr>
+        <p:txBody>
+          <a:bodyPr xmlns:a="http://schemas.openxmlformats.org/drawingml/2006/main"/>
+          <a:lstStyle xmlns:a="http://schemas.openxmlformats.org/drawingml/2006/main"/>
+          <a:p xmlns:a="http://schemas.openxmlformats.org/drawingml/2006/main">
+            <a:pPr>
+              <a:defRPr sz="1425" b="1">
+                <a:solidFill>
+                  <a:srgbClr val="F8FAFC"/>
+                </a:solidFill>
+              </a:defRPr>
+            </a:pPr>
+            <a:r>
+              <a:rPr sz="1425" b="1">
+                <a:solidFill>
+                  <a:srgbClr val="F8FAFC"/>
+                </a:solidFill>
+              </a:rPr>
+              <a:t>Sıralı hareket noktaları</a:t>
+            </a:r>
+          </a:p>
+        </p:txBody>
+      </p:sp>
+      <p:sp>
+        <p:nvSpPr>
+          <p:cNvPr id="7" name="telemetry-feature-body-0">
+            <a:extLst xmlns:a="http://schemas.openxmlformats.org/drawingml/2006/main">
+              <a:ext uri="{FF2B5EF4-FFF2-40B4-BE49-F238E27FC236}">
+                <a16:creationId xmlns:a16="http://schemas.microsoft.com/office/drawing/2014/main" id="{6B6E15C2-3727-42DB-BEE8-A0ABEEDBBAEE}"/>
+              </a:ext>
+            </a:extLst>
+          </p:cNvPr>
+          <p:cNvSpPr>
+            <a:spLocks xmlns:a="http://schemas.openxmlformats.org/drawingml/2006/main" noGrp="1"/>
+          </p:cNvSpPr>
+          <p:nvPr/>
+        </p:nvSpPr>
+        <p:spPr>
+          <a:xfrm xmlns:a="http://schemas.openxmlformats.org/drawingml/2006/main">
+            <a:off x="723900" y="3181350"/>
+            <a:ext cx="4286250" cy="495300"/>
+          </a:xfrm>
+          <a:prstGeom xmlns:a="http://schemas.openxmlformats.org/drawingml/2006/main" prst="rect">
+            <a:avLst/>
+          </a:prstGeom>
+          <a:noFill xmlns:a="http://schemas.openxmlformats.org/drawingml/2006/main"/>
+          <a:ln xmlns:a="http://schemas.openxmlformats.org/drawingml/2006/main" w="0">
+            <a:noFill/>
+            <a:prstDash val="solid"/>
+          </a:ln>
+        </p:spPr>
+        <p:txBody>
+          <a:bodyPr xmlns:a="http://schemas.openxmlformats.org/drawingml/2006/main"/>
+          <a:lstStyle xmlns:a="http://schemas.openxmlformats.org/drawingml/2006/main"/>
+          <a:p xmlns:a="http://schemas.openxmlformats.org/drawingml/2006/main">
+            <a:pPr>
+              <a:defRPr sz="1200">
+                <a:solidFill>
+                  <a:srgbClr val="CBD5E1"/>
+                </a:solidFill>
+              </a:defRPr>
+            </a:pPr>
+            <a:r>
+              <a:rPr sz="1200">
+                <a:solidFill>
+                  <a:srgbClr val="CBD5E1"/>
+                </a:solidFill>
+              </a:rPr>
+              <a:t>Her point; 27 motor, zaman damgası ve replay sırası ile tutuluyor. Seçili point anında izlenebiliyor.</a:t>
+            </a:r>
+          </a:p>
+        </p:txBody>
+      </p:sp>
+      <p:sp>
+        <p:nvSpPr>
+          <p:cNvPr id="8" name="telemetry-feature-accent-1">
+            <a:extLst xmlns:a="http://schemas.openxmlformats.org/drawingml/2006/main">
+              <a:ext uri="{FF2B5EF4-FFF2-40B4-BE49-F238E27FC236}">
+                <a16:creationId xmlns:a16="http://schemas.microsoft.com/office/drawing/2014/main" id="{DAB6BB22-EF92-47F1-BD41-BD907E6D5393}"/>
+              </a:ext>
+            </a:extLst>
+          </p:cNvPr>
+          <p:cNvSpPr>
+            <a:spLocks xmlns:a="http://schemas.openxmlformats.org/drawingml/2006/main" noGrp="1"/>
+          </p:cNvSpPr>
+          <p:nvPr/>
+        </p:nvSpPr>
+        <p:spPr>
+          <a:xfrm xmlns:a="http://schemas.openxmlformats.org/drawingml/2006/main">
+            <a:off x="514350" y="3848100"/>
+            <a:ext cx="76200" cy="742950"/>
+          </a:xfrm>
+          <a:prstGeom xmlns:a="http://schemas.openxmlformats.org/drawingml/2006/main" prst="roundRect">
+            <a:avLst>
+              <a:gd name="adj" fmla="val 50000"/>
+            </a:avLst>
+          </a:prstGeom>
+          <a:solidFill xmlns:a="http://schemas.openxmlformats.org/drawingml/2006/main">
+            <a:srgbClr val="38BDF8"/>
+          </a:solidFill>
+          <a:ln xmlns:a="http://schemas.openxmlformats.org/drawingml/2006/main" w="0">
+            <a:noFill/>
+            <a:prstDash val="solid"/>
+          </a:ln>
+        </p:spPr>
+      </p:sp>
+      <p:sp>
+        <p:nvSpPr>
+          <p:cNvPr id="9" name="telemetry-feature-title-1">
+            <a:extLst xmlns:a="http://schemas.openxmlformats.org/drawingml/2006/main">
+              <a:ext uri="{FF2B5EF4-FFF2-40B4-BE49-F238E27FC236}">
+                <a16:creationId xmlns:a16="http://schemas.microsoft.com/office/drawing/2014/main" id="{AC806578-7BBB-4540-9C57-85E01AF6DAB6}"/>
+              </a:ext>
+            </a:extLst>
+          </p:cNvPr>
+          <p:cNvSpPr>
+            <a:spLocks xmlns:a="http://schemas.openxmlformats.org/drawingml/2006/main" noGrp="1"/>
+          </p:cNvSpPr>
+          <p:nvPr/>
+        </p:nvSpPr>
+        <p:spPr>
+          <a:xfrm xmlns:a="http://schemas.openxmlformats.org/drawingml/2006/main">
+            <a:off x="723900" y="3829050"/>
+            <a:ext cx="4210050" cy="247650"/>
+          </a:xfrm>
+          <a:prstGeom xmlns:a="http://schemas.openxmlformats.org/drawingml/2006/main" prst="rect">
+            <a:avLst/>
+          </a:prstGeom>
+          <a:noFill xmlns:a="http://schemas.openxmlformats.org/drawingml/2006/main"/>
+          <a:ln xmlns:a="http://schemas.openxmlformats.org/drawingml/2006/main" w="0">
+            <a:noFill/>
+            <a:prstDash val="solid"/>
+          </a:ln>
+        </p:spPr>
+        <p:txBody>
+          <a:bodyPr xmlns:a="http://schemas.openxmlformats.org/drawingml/2006/main"/>
+          <a:lstStyle xmlns:a="http://schemas.openxmlformats.org/drawingml/2006/main"/>
+          <a:p xmlns:a="http://schemas.openxmlformats.org/drawingml/2006/main">
+            <a:pPr>
+              <a:defRPr sz="1425" b="1">
+                <a:solidFill>
+                  <a:srgbClr val="F8FAFC"/>
+                </a:solidFill>
+              </a:defRPr>
+            </a:pPr>
+            <a:r>
+              <a:rPr sz="1425" b="1">
+                <a:solidFill>
+                  <a:srgbClr val="F8FAFC"/>
+                </a:solidFill>
+              </a:rPr>
+              <a:t>IK ve sınır doğrulaması</a:t>
+            </a:r>
+          </a:p>
+        </p:txBody>
+      </p:sp>
+      <p:sp>
+        <p:nvSpPr>
+          <p:cNvPr id="10" name="telemetry-feature-body-1">
+            <a:extLst xmlns:a="http://schemas.openxmlformats.org/drawingml/2006/main">
+              <a:ext uri="{FF2B5EF4-FFF2-40B4-BE49-F238E27FC236}">
+                <a16:creationId xmlns:a16="http://schemas.microsoft.com/office/drawing/2014/main" id="{371BEEDB-9C55-457B-9D96-5B8730FA8042}"/>
+              </a:ext>
+            </a:extLst>
+          </p:cNvPr>
+          <p:cNvSpPr>
+            <a:spLocks xmlns:a="http://schemas.openxmlformats.org/drawingml/2006/main" noGrp="1"/>
+          </p:cNvSpPr>
+          <p:nvPr/>
+        </p:nvSpPr>
+        <p:spPr>
+          <a:xfrm xmlns:a="http://schemas.openxmlformats.org/drawingml/2006/main">
+            <a:off x="723900" y="4114800"/>
+            <a:ext cx="4286250" cy="495300"/>
+          </a:xfrm>
+          <a:prstGeom xmlns:a="http://schemas.openxmlformats.org/drawingml/2006/main" prst="rect">
+            <a:avLst/>
+          </a:prstGeom>
+          <a:noFill xmlns:a="http://schemas.openxmlformats.org/drawingml/2006/main"/>
+          <a:ln xmlns:a="http://schemas.openxmlformats.org/drawingml/2006/main" w="0">
+            <a:noFill/>
+            <a:prstDash val="solid"/>
+          </a:ln>
+        </p:spPr>
+        <p:txBody>
+          <a:bodyPr xmlns:a="http://schemas.openxmlformats.org/drawingml/2006/main"/>
+          <a:lstStyle xmlns:a="http://schemas.openxmlformats.org/drawingml/2006/main"/>
+          <a:p xmlns:a="http://schemas.openxmlformats.org/drawingml/2006/main">
+            <a:pPr>
+              <a:defRPr sz="1200">
+                <a:solidFill>
+                  <a:srgbClr val="CBD5E1"/>
+                </a:solidFill>
+              </a:defRPr>
+            </a:pPr>
+            <a:r>
+              <a:rPr sz="1200">
+                <a:solidFill>
+                  <a:srgbClr val="CBD5E1"/>
+                </a:solidFill>
+              </a:rPr>
+              <a:t>IK hatası cm seviyesinde gösteriliyor; bounds açıkken güvenli eklem limitleri korunuyor.</a:t>
+            </a:r>
+          </a:p>
+        </p:txBody>
+      </p:sp>
+      <p:sp>
+        <p:nvSpPr>
+          <p:cNvPr id="11" name="telemetry-feature-accent-2">
+            <a:extLst xmlns:a="http://schemas.openxmlformats.org/drawingml/2006/main">
+              <a:ext uri="{FF2B5EF4-FFF2-40B4-BE49-F238E27FC236}">
+                <a16:creationId xmlns:a16="http://schemas.microsoft.com/office/drawing/2014/main" id="{6503815F-41CD-47FB-B482-0A8376C0FBED}"/>
+              </a:ext>
+            </a:extLst>
+          </p:cNvPr>
+          <p:cNvSpPr>
+            <a:spLocks xmlns:a="http://schemas.openxmlformats.org/drawingml/2006/main" noGrp="1"/>
+          </p:cNvSpPr>
+          <p:nvPr/>
+        </p:nvSpPr>
+        <p:spPr>
+          <a:xfrm xmlns:a="http://schemas.openxmlformats.org/drawingml/2006/main">
+            <a:off x="514350" y="4781550"/>
+            <a:ext cx="76200" cy="742950"/>
+          </a:xfrm>
+          <a:prstGeom xmlns:a="http://schemas.openxmlformats.org/drawingml/2006/main" prst="roundRect">
+            <a:avLst>
+              <a:gd name="adj" fmla="val 50000"/>
+            </a:avLst>
+          </a:prstGeom>
+          <a:solidFill xmlns:a="http://schemas.openxmlformats.org/drawingml/2006/main">
+            <a:srgbClr val="F97316"/>
+          </a:solidFill>
+          <a:ln xmlns:a="http://schemas.openxmlformats.org/drawingml/2006/main" w="0">
+            <a:noFill/>
+            <a:prstDash val="solid"/>
+          </a:ln>
+        </p:spPr>
+      </p:sp>
+      <p:sp>
+        <p:nvSpPr>
+          <p:cNvPr id="12" name="telemetry-feature-title-2">
+            <a:extLst xmlns:a="http://schemas.openxmlformats.org/drawingml/2006/main">
+              <a:ext uri="{FF2B5EF4-FFF2-40B4-BE49-F238E27FC236}">
+                <a16:creationId xmlns:a16="http://schemas.microsoft.com/office/drawing/2014/main" id="{E1869618-7C79-449C-9698-2E8A8D2D8755}"/>
+              </a:ext>
+            </a:extLst>
+          </p:cNvPr>
+          <p:cNvSpPr>
+            <a:spLocks xmlns:a="http://schemas.openxmlformats.org/drawingml/2006/main" noGrp="1"/>
+          </p:cNvSpPr>
+          <p:nvPr/>
+        </p:nvSpPr>
+        <p:spPr>
+          <a:xfrm xmlns:a="http://schemas.openxmlformats.org/drawingml/2006/main">
+            <a:off x="723900" y="4762500"/>
+            <a:ext cx="4210050" cy="247650"/>
+          </a:xfrm>
+          <a:prstGeom xmlns:a="http://schemas.openxmlformats.org/drawingml/2006/main" prst="rect">
+            <a:avLst/>
+          </a:prstGeom>
+          <a:noFill xmlns:a="http://schemas.openxmlformats.org/drawingml/2006/main"/>
+          <a:ln xmlns:a="http://schemas.openxmlformats.org/drawingml/2006/main" w="0">
+            <a:noFill/>
+            <a:prstDash val="solid"/>
+          </a:ln>
+        </p:spPr>
+        <p:txBody>
+          <a:bodyPr xmlns:a="http://schemas.openxmlformats.org/drawingml/2006/main"/>
+          <a:lstStyle xmlns:a="http://schemas.openxmlformats.org/drawingml/2006/main"/>
+          <a:p xmlns:a="http://schemas.openxmlformats.org/drawingml/2006/main">
+            <a:pPr>
+              <a:defRPr sz="1425" b="1">
+                <a:solidFill>
+                  <a:srgbClr val="F8FAFC"/>
+                </a:solidFill>
+              </a:defRPr>
+            </a:pPr>
+            <a:r>
+              <a:rPr sz="1425" b="1">
+                <a:solidFill>
+                  <a:srgbClr val="F8FAFC"/>
+                </a:solidFill>
+              </a:rPr>
+              <a:t>Simülasyon ve replay karşılaştırması</a:t>
+            </a:r>
+          </a:p>
+        </p:txBody>
+      </p:sp>
+      <p:sp>
+        <p:nvSpPr>
+          <p:cNvPr id="13" name="telemetry-feature-body-2">
+            <a:extLst xmlns:a="http://schemas.openxmlformats.org/drawingml/2006/main">
+              <a:ext uri="{FF2B5EF4-FFF2-40B4-BE49-F238E27FC236}">
+                <a16:creationId xmlns:a16="http://schemas.microsoft.com/office/drawing/2014/main" id="{FF9752D7-79E3-4A21-A31F-FAC4A3CFFDD1}"/>
+              </a:ext>
+            </a:extLst>
+          </p:cNvPr>
+          <p:cNvSpPr>
+            <a:spLocks xmlns:a="http://schemas.openxmlformats.org/drawingml/2006/main" noGrp="1"/>
+          </p:cNvSpPr>
+          <p:nvPr/>
+        </p:nvSpPr>
+        <p:spPr>
+          <a:xfrm xmlns:a="http://schemas.openxmlformats.org/drawingml/2006/main">
+            <a:off x="723900" y="5048250"/>
+            <a:ext cx="4286250" cy="495300"/>
+          </a:xfrm>
+          <a:prstGeom xmlns:a="http://schemas.openxmlformats.org/drawingml/2006/main" prst="rect">
+            <a:avLst/>
+          </a:prstGeom>
+          <a:noFill xmlns:a="http://schemas.openxmlformats.org/drawingml/2006/main"/>
+          <a:ln xmlns:a="http://schemas.openxmlformats.org/drawingml/2006/main" w="0">
+            <a:noFill/>
+            <a:prstDash val="solid"/>
+          </a:ln>
+        </p:spPr>
+        <p:txBody>
+          <a:bodyPr xmlns:a="http://schemas.openxmlformats.org/drawingml/2006/main"/>
+          <a:lstStyle xmlns:a="http://schemas.openxmlformats.org/drawingml/2006/main"/>
+          <a:p xmlns:a="http://schemas.openxmlformats.org/drawingml/2006/main">
+            <a:pPr>
+              <a:defRPr sz="1200">
+                <a:solidFill>
+                  <a:srgbClr val="CBD5E1"/>
+                </a:solidFill>
+              </a:defRPr>
+            </a:pPr>
+            <a:r>
+              <a:rPr sz="1200">
+                <a:solidFill>
+                  <a:srgbClr val="CBD5E1"/>
+                </a:solidFill>
+              </a:rPr>
+              <a:t>Mavi referans, yeşil simülasyon ve kırmızı hedef hareket aynı sahnede üst üste okunuyor.</a:t>
+            </a:r>
+          </a:p>
+        </p:txBody>
+      </p:sp>
+      <p:sp>
+        <p:nvSpPr>
+          <p:cNvPr id="14" name="telemetry-feature-accent-3">
+            <a:extLst xmlns:a="http://schemas.openxmlformats.org/drawingml/2006/main">
+              <a:ext uri="{FF2B5EF4-FFF2-40B4-BE49-F238E27FC236}">
+                <a16:creationId xmlns:a16="http://schemas.microsoft.com/office/drawing/2014/main" id="{EB0989C0-18AE-4350-9C5B-3A02C6FB39AB}"/>
+              </a:ext>
+            </a:extLst>
+          </p:cNvPr>
+          <p:cNvSpPr>
+            <a:spLocks xmlns:a="http://schemas.openxmlformats.org/drawingml/2006/main" noGrp="1"/>
+          </p:cNvSpPr>
+          <p:nvPr/>
+        </p:nvSpPr>
+        <p:spPr>
+          <a:xfrm xmlns:a="http://schemas.openxmlformats.org/drawingml/2006/main">
+            <a:off x="514350" y="5715000"/>
+            <a:ext cx="76200" cy="742950"/>
+          </a:xfrm>
+          <a:prstGeom xmlns:a="http://schemas.openxmlformats.org/drawingml/2006/main" prst="roundRect">
+            <a:avLst>
+              <a:gd name="adj" fmla="val 50000"/>
+            </a:avLst>
+          </a:prstGeom>
+          <a:solidFill xmlns:a="http://schemas.openxmlformats.org/drawingml/2006/main">
+            <a:srgbClr val="E11D48"/>
+          </a:solidFill>
+          <a:ln xmlns:a="http://schemas.openxmlformats.org/drawingml/2006/main" w="0">
+            <a:noFill/>
+            <a:prstDash val="solid"/>
+          </a:ln>
+        </p:spPr>
+      </p:sp>
+      <p:sp>
+        <p:nvSpPr>
+          <p:cNvPr id="15" name="telemetry-feature-title-3">
+            <a:extLst xmlns:a="http://schemas.openxmlformats.org/drawingml/2006/main">
+              <a:ext uri="{FF2B5EF4-FFF2-40B4-BE49-F238E27FC236}">
+                <a16:creationId xmlns:a16="http://schemas.microsoft.com/office/drawing/2014/main" id="{B9FE1970-A69E-4F01-B94D-A2E730916868}"/>
+              </a:ext>
+            </a:extLst>
+          </p:cNvPr>
+          <p:cNvSpPr>
+            <a:spLocks xmlns:a="http://schemas.openxmlformats.org/drawingml/2006/main" noGrp="1"/>
+          </p:cNvSpPr>
+          <p:nvPr/>
+        </p:nvSpPr>
+        <p:spPr>
+          <a:xfrm xmlns:a="http://schemas.openxmlformats.org/drawingml/2006/main">
+            <a:off x="723900" y="5695950"/>
+            <a:ext cx="4210050" cy="247650"/>
+          </a:xfrm>
+          <a:prstGeom xmlns:a="http://schemas.openxmlformats.org/drawingml/2006/main" prst="rect">
+            <a:avLst/>
+          </a:prstGeom>
+          <a:noFill xmlns:a="http://schemas.openxmlformats.org/drawingml/2006/main"/>
+          <a:ln xmlns:a="http://schemas.openxmlformats.org/drawingml/2006/main" w="0">
+            <a:noFill/>
+            <a:prstDash val="solid"/>
+          </a:ln>
+        </p:spPr>
+        <p:txBody>
+          <a:bodyPr xmlns:a="http://schemas.openxmlformats.org/drawingml/2006/main"/>
+          <a:lstStyle xmlns:a="http://schemas.openxmlformats.org/drawingml/2006/main"/>
+          <a:p xmlns:a="http://schemas.openxmlformats.org/drawingml/2006/main">
+            <a:pPr>
+              <a:defRPr sz="1425" b="1">
+                <a:solidFill>
+                  <a:srgbClr val="F8FAFC"/>
+                </a:solidFill>
+              </a:defRPr>
+            </a:pPr>
+            <a:r>
+              <a:rPr sz="1425" b="1">
+                <a:solidFill>
+                  <a:srgbClr val="F8FAFC"/>
+                </a:solidFill>
+              </a:rPr>
+              <a:t>Gerçek robota aktarım kapısı</a:t>
+            </a:r>
+          </a:p>
+        </p:txBody>
+      </p:sp>
+      <p:sp>
+        <p:nvSpPr>
+          <p:cNvPr id="16" name="telemetry-feature-body-3">
+            <a:extLst xmlns:a="http://schemas.openxmlformats.org/drawingml/2006/main">
+              <a:ext uri="{FF2B5EF4-FFF2-40B4-BE49-F238E27FC236}">
+                <a16:creationId xmlns:a16="http://schemas.microsoft.com/office/drawing/2014/main" id="{367EAC65-924B-4414-A99D-5659B5C4706E}"/>
+              </a:ext>
+            </a:extLst>
+          </p:cNvPr>
+          <p:cNvSpPr>
+            <a:spLocks xmlns:a="http://schemas.openxmlformats.org/drawingml/2006/main" noGrp="1"/>
+          </p:cNvSpPr>
+          <p:nvPr/>
+        </p:nvSpPr>
+        <p:spPr>
+          <a:xfrm xmlns:a="http://schemas.openxmlformats.org/drawingml/2006/main">
+            <a:off x="723900" y="5981700"/>
+            <a:ext cx="4286250" cy="495300"/>
+          </a:xfrm>
+          <a:prstGeom xmlns:a="http://schemas.openxmlformats.org/drawingml/2006/main" prst="rect">
+            <a:avLst/>
+          </a:prstGeom>
+          <a:noFill xmlns:a="http://schemas.openxmlformats.org/drawingml/2006/main"/>
+          <a:ln xmlns:a="http://schemas.openxmlformats.org/drawingml/2006/main" w="0">
+            <a:noFill/>
+            <a:prstDash val="solid"/>
+          </a:ln>
+        </p:spPr>
+        <p:txBody>
+          <a:bodyPr xmlns:a="http://schemas.openxmlformats.org/drawingml/2006/main"/>
+          <a:lstStyle xmlns:a="http://schemas.openxmlformats.org/drawingml/2006/main"/>
+          <a:p xmlns:a="http://schemas.openxmlformats.org/drawingml/2006/main">
+            <a:pPr>
+              <a:defRPr sz="1200">
+                <a:solidFill>
+                  <a:srgbClr val="CBD5E1"/>
+                </a:solidFill>
+              </a:defRPr>
+            </a:pPr>
+            <a:r>
+              <a:rPr sz="1200">
+                <a:solidFill>
+                  <a:srgbClr val="CBD5E1"/>
+                </a:solidFill>
+              </a:rPr>
+              <a:t>Add Point, Simulate Trajectory, Move Arms ve Save Real Robot Motion adımları aynı operatör akışında.</a:t>
+            </a:r>
+          </a:p>
+        </p:txBody>
+      </p:sp>
+      <p:pic>
+        <p:nvPicPr>
+          <p:cNvPr id="38" name=""/>
+          <p:cNvPicPr>
+            <a:picLocks xmlns:a="http://schemas.openxmlformats.org/drawingml/2006/main" noChangeAspect="1"/>
+          </p:cNvPicPr>
+          <p:nvPr/>
+        </p:nvPicPr>
+        <p:blipFill>
+          <a:blip xmlns:r="http://schemas.openxmlformats.org/officeDocument/2006/relationships" xmlns:a="http://schemas.openxmlformats.org/drawingml/2006/main" r:embed="Rab9605ca1ad44492"/>
+          <a:stretch xmlns:a="http://schemas.openxmlformats.org/drawingml/2006/main"/>
+        </p:blipFill>
+        <p:spPr>
+          <a:xfrm xmlns:a="http://schemas.openxmlformats.org/drawingml/2006/main">
+            <a:off x="5623031" y="685800"/>
+            <a:ext cx="6089438" cy="4419600"/>
+          </a:xfrm>
+          <a:prstGeom xmlns:a="http://schemas.openxmlformats.org/drawingml/2006/main" prst="roundRect">
+            <a:avLst>
+              <a:gd name="adj" fmla="val 1724"/>
+            </a:avLst>
+          </a:prstGeom>
+        </p:spPr>
+      </p:pic>
+      <p:sp>
+        <p:nvSpPr>
+          <p:cNvPr id="18" name="telemetry-screenshot-outline">
+            <a:extLst xmlns:a="http://schemas.openxmlformats.org/drawingml/2006/main">
+              <a:ext uri="{FF2B5EF4-FFF2-40B4-BE49-F238E27FC236}">
+                <a16:creationId xmlns:a16="http://schemas.microsoft.com/office/drawing/2014/main" id="{082F7060-BDE9-409D-9804-92E493DCCE5E}"/>
+              </a:ext>
+            </a:extLst>
+          </p:cNvPr>
+          <p:cNvSpPr>
+            <a:spLocks xmlns:a="http://schemas.openxmlformats.org/drawingml/2006/main" noGrp="1"/>
+          </p:cNvSpPr>
+          <p:nvPr/>
+        </p:nvSpPr>
+        <p:spPr>
+          <a:xfrm xmlns:a="http://schemas.openxmlformats.org/drawingml/2006/main">
+            <a:off x="5619750" y="685800"/>
+            <a:ext cx="6096000" cy="4419600"/>
+          </a:xfrm>
+          <a:prstGeom xmlns:a="http://schemas.openxmlformats.org/drawingml/2006/main" prst="rect">
+            <a:avLst/>
+          </a:prstGeom>
+          <a:noFill xmlns:a="http://schemas.openxmlformats.org/drawingml/2006/main"/>
+          <a:ln xmlns:a="http://schemas.openxmlformats.org/drawingml/2006/main" w="19050">
+            <a:solidFill>
+              <a:srgbClr val="334155"/>
+            </a:solidFill>
+            <a:prstDash val="solid"/>
+          </a:ln>
+        </p:spPr>
+      </p:sp>
+      <p:sp>
+        <p:nvSpPr>
+          <p:cNvPr id="19" name="telemetry-screenshot-caption">
+            <a:extLst xmlns:a="http://schemas.openxmlformats.org/drawingml/2006/main">
+              <a:ext uri="{FF2B5EF4-FFF2-40B4-BE49-F238E27FC236}">
+                <a16:creationId xmlns:a16="http://schemas.microsoft.com/office/drawing/2014/main" id="{94A23EB0-00F6-4EF4-866E-D7181C9A2CF8}"/>
+              </a:ext>
+            </a:extLst>
+          </p:cNvPr>
+          <p:cNvSpPr>
+            <a:spLocks xmlns:a="http://schemas.openxmlformats.org/drawingml/2006/main" noGrp="1"/>
+          </p:cNvSpPr>
+          <p:nvPr/>
+        </p:nvSpPr>
+        <p:spPr>
+          <a:xfrm xmlns:a="http://schemas.openxmlformats.org/drawingml/2006/main">
+            <a:off x="5619750" y="5286375"/>
+            <a:ext cx="6096000" cy="457200"/>
+          </a:xfrm>
+          <a:prstGeom xmlns:a="http://schemas.openxmlformats.org/drawingml/2006/main" prst="rect">
+            <a:avLst/>
+          </a:prstGeom>
+          <a:noFill xmlns:a="http://schemas.openxmlformats.org/drawingml/2006/main"/>
+          <a:ln xmlns:a="http://schemas.openxmlformats.org/drawingml/2006/main" w="0">
+            <a:noFill/>
+            <a:prstDash val="solid"/>
+          </a:ln>
+        </p:spPr>
+        <p:txBody>
+          <a:bodyPr xmlns:a="http://schemas.openxmlformats.org/drawingml/2006/main"/>
+          <a:lstStyle xmlns:a="http://schemas.openxmlformats.org/drawingml/2006/main"/>
+          <a:p xmlns:a="http://schemas.openxmlformats.org/drawingml/2006/main">
+            <a:pPr>
+              <a:defRPr sz="1275">
+                <a:solidFill>
+                  <a:srgbClr val="E2E8F0"/>
+                </a:solidFill>
+              </a:defRPr>
+            </a:pPr>
+            <a:r>
+              <a:rPr sz="1275">
+                <a:solidFill>
+                  <a:srgbClr val="E2E8F0"/>
+                </a:solidFill>
+              </a:rPr>
+              <a:t>Canlı operatör görünümü: solda sequence listesi, ortada 3D robot replay, üstte güvenlik ve kayıt aksiyonları.</a:t>
+            </a:r>
+          </a:p>
+        </p:txBody>
+      </p:sp>
+      <p:sp>
+        <p:nvSpPr>
+          <p:cNvPr id="20" name="telemetry-bottom-safety-band">
+            <a:extLst xmlns:a="http://schemas.openxmlformats.org/drawingml/2006/main">
+              <a:ext uri="{FF2B5EF4-FFF2-40B4-BE49-F238E27FC236}">
+                <a16:creationId xmlns:a16="http://schemas.microsoft.com/office/drawing/2014/main" id="{2D0F7468-B38C-4A85-8788-F14226907CFB}"/>
+              </a:ext>
+            </a:extLst>
+          </p:cNvPr>
+          <p:cNvSpPr>
+            <a:spLocks xmlns:a="http://schemas.openxmlformats.org/drawingml/2006/main" noGrp="1"/>
+          </p:cNvSpPr>
+          <p:nvPr/>
+        </p:nvSpPr>
+        <p:spPr>
+          <a:xfrm xmlns:a="http://schemas.openxmlformats.org/drawingml/2006/main">
+            <a:off x="5619750" y="6000750"/>
+            <a:ext cx="6096000" cy="438150"/>
+          </a:xfrm>
+          <a:prstGeom xmlns:a="http://schemas.openxmlformats.org/drawingml/2006/main" prst="roundRect">
+            <a:avLst>
+              <a:gd name="adj" fmla="val 17391"/>
+            </a:avLst>
+          </a:prstGeom>
+          <a:solidFill xmlns:a="http://schemas.openxmlformats.org/drawingml/2006/main">
+            <a:srgbClr val="121923"/>
+          </a:solidFill>
+          <a:ln xmlns:a="http://schemas.openxmlformats.org/drawingml/2006/main" w="9525">
+            <a:solidFill>
+              <a:srgbClr val="1F2937"/>
+            </a:solidFill>
+            <a:prstDash val="solid"/>
+          </a:ln>
+        </p:spPr>
+      </p:sp>
+      <p:sp>
+        <p:nvSpPr>
+          <p:cNvPr id="21" name="telemetry-bottom-safety-copy">
+            <a:extLst xmlns:a="http://schemas.openxmlformats.org/drawingml/2006/main">
+              <a:ext uri="{FF2B5EF4-FFF2-40B4-BE49-F238E27FC236}">
+                <a16:creationId xmlns:a16="http://schemas.microsoft.com/office/drawing/2014/main" id="{C181BE3B-C677-4693-B18D-7B6FF35B6234}"/>
+              </a:ext>
+            </a:extLst>
+          </p:cNvPr>
+          <p:cNvSpPr>
+            <a:spLocks xmlns:a="http://schemas.openxmlformats.org/drawingml/2006/main" noGrp="1"/>
+          </p:cNvSpPr>
+          <p:nvPr/>
+        </p:nvSpPr>
+        <p:spPr>
+          <a:xfrm xmlns:a="http://schemas.openxmlformats.org/drawingml/2006/main">
+            <a:off x="5829300" y="6105525"/>
+            <a:ext cx="5676900" cy="247650"/>
+          </a:xfrm>
+          <a:prstGeom xmlns:a="http://schemas.openxmlformats.org/drawingml/2006/main" prst="rect">
+            <a:avLst/>
+          </a:prstGeom>
+          <a:noFill xmlns:a="http://schemas.openxmlformats.org/drawingml/2006/main"/>
+          <a:ln xmlns:a="http://schemas.openxmlformats.org/drawingml/2006/main" w="0">
+            <a:noFill/>
+            <a:prstDash val="solid"/>
+          </a:ln>
+        </p:spPr>
+        <p:txBody>
+          <a:bodyPr xmlns:a="http://schemas.openxmlformats.org/drawingml/2006/main"/>
+          <a:lstStyle xmlns:a="http://schemas.openxmlformats.org/drawingml/2006/main"/>
+          <a:p xmlns:a="http://schemas.openxmlformats.org/drawingml/2006/main">
+            <a:pPr>
+              <a:defRPr sz="1200" b="1">
+                <a:solidFill>
+                  <a:srgbClr val="F8FAFC"/>
+                </a:solidFill>
+              </a:defRPr>
+            </a:pPr>
+            <a:r>
+              <a:rPr sz="1200" b="1">
+                <a:solidFill>
+                  <a:srgbClr val="F8FAFC"/>
+                </a:solidFill>
+              </a:rPr>
+              <a:t>Amaç: hareket komutu gerçek robota gitmeden önce kayıt, görünürlük ve simülasyon doğrulaması tamamlanır.</a:t>
+            </a:r>
+          </a:p>
+        </p:txBody>
+      </p:sp>
+    </p:spTree>
+    <p:extLst>
+      <p:ext uri="{BB962C8B-B14F-4D97-AF65-F5344CB8AC3E}">
+        <p14:creationId xmlns:p14="http://schemas.microsoft.com/office/powerpoint/2010/main" val="1917662731"/>
       </p:ext>
     </p:extLst>
   </p:cSld>

</xml_diff>

<commit_message>
Add XR walking control slide
</commit_message>
<xml_diff>
--- a/docs/presentations/Unitree-H1-Feature-Deck-v2.pptx
+++ b/docs/presentations/Unitree-H1-Feature-Deck-v2.pptx
@@ -2,17 +2,18 @@
 <file path=ppt/presentation.xml><?xml version="1.0" encoding="utf-8"?>
 <p:presentation xmlns:p="http://schemas.openxmlformats.org/presentationml/2006/main">
   <p:sldMasterIdLst>
-    <p:sldMasterId xmlns:r="http://schemas.openxmlformats.org/officeDocument/2006/relationships" id="2147483648" r:id="R6c3c97e8f2924969"/>
+    <p:sldMasterId xmlns:r="http://schemas.openxmlformats.org/officeDocument/2006/relationships" id="2147483648" r:id="R69a67c41628a4c7b"/>
   </p:sldMasterIdLst>
   <p:notesMasterIdLst>
-    <p:notesMasterId xmlns:r="http://schemas.openxmlformats.org/officeDocument/2006/relationships" r:id="R0f3e57e8d3704ff4"/>
+    <p:notesMasterId xmlns:r="http://schemas.openxmlformats.org/officeDocument/2006/relationships" r:id="R2882106d4d49460d"/>
   </p:notesMasterIdLst>
   <p:sldIdLst>
-    <p:sldId xmlns:r="http://schemas.openxmlformats.org/officeDocument/2006/relationships" id="256" r:id="R54e54cc62808464a"/>
-    <p:sldId xmlns:r="http://schemas.openxmlformats.org/officeDocument/2006/relationships" id="257" r:id="R66e6184c4cf74b4d"/>
-    <p:sldId xmlns:r="http://schemas.openxmlformats.org/officeDocument/2006/relationships" id="258" r:id="R6128ae49f6eb49f6"/>
-    <p:sldId xmlns:r="http://schemas.openxmlformats.org/officeDocument/2006/relationships" id="259" r:id="Rbe49ef344a6f4963"/>
-    <p:sldId xmlns:r="http://schemas.openxmlformats.org/officeDocument/2006/relationships" id="260" r:id="Rb3b43b5cfd754e7b"/>
+    <p:sldId xmlns:r="http://schemas.openxmlformats.org/officeDocument/2006/relationships" id="256" r:id="Rbbd5296270174321"/>
+    <p:sldId xmlns:r="http://schemas.openxmlformats.org/officeDocument/2006/relationships" id="257" r:id="Rc425f46042aa4b37"/>
+    <p:sldId xmlns:r="http://schemas.openxmlformats.org/officeDocument/2006/relationships" id="258" r:id="Re93d5aeaa3104f7d"/>
+    <p:sldId xmlns:r="http://schemas.openxmlformats.org/officeDocument/2006/relationships" id="259" r:id="R11b17c7f41bd40ef"/>
+    <p:sldId xmlns:r="http://schemas.openxmlformats.org/officeDocument/2006/relationships" id="260" r:id="Re49bb65af09a4de8"/>
+    <p:sldId xmlns:r="http://schemas.openxmlformats.org/officeDocument/2006/relationships" id="261" r:id="Rc98da57abb9e4265"/>
   </p:sldIdLst>
   <p:sldSz cx="12192000" cy="6858000"/>
   <p:notesSz cx="6858000" cy="9144000"/>
@@ -831,6 +832,72 @@
 </p:notes>
 </file>
 
+<file path=ppt/notesSlides/notesSlide6.xml><?xml version="1.0" encoding="utf-8"?>
+<p:notes xmlns:p="http://schemas.openxmlformats.org/presentationml/2006/main">
+  <p:cSld>
+    <p:spTree>
+      <p:nvGrpSpPr>
+        <p:cNvPr id="1" name=""/>
+        <p:cNvGrpSpPr/>
+        <p:nvPr/>
+      </p:nvGrpSpPr>
+      <p:grpSpPr>
+        <a:xfrm xmlns:a="http://schemas.openxmlformats.org/drawingml/2006/main"/>
+      </p:grpSpPr>
+      <p:sp>
+        <p:nvSpPr>
+          <p:cNvPr id="2" name="Slide Image Placeholder 1"/>
+          <p:cNvSpPr>
+            <a:spLocks xmlns:a="http://schemas.openxmlformats.org/drawingml/2006/main" noGrp="1"/>
+          </p:cNvSpPr>
+          <p:nvPr>
+            <p:ph type="sldImg" idx="0"/>
+          </p:nvPr>
+        </p:nvSpPr>
+        <p:spPr/>
+      </p:sp>
+      <p:sp>
+        <p:nvSpPr>
+          <p:cNvPr id="3" name="Notes Placeholder 2"/>
+          <p:cNvSpPr>
+            <a:spLocks xmlns:a="http://schemas.openxmlformats.org/drawingml/2006/main" noGrp="1"/>
+          </p:cNvSpPr>
+          <p:nvPr>
+            <p:ph type="body" idx="1"/>
+          </p:nvPr>
+        </p:nvSpPr>
+        <p:spPr/>
+        <p:txBody>
+          <a:bodyPr xmlns:a="http://schemas.openxmlformats.org/drawingml/2006/main"/>
+          <a:lstStyle xmlns:a="http://schemas.openxmlformats.org/drawingml/2006/main"/>
+          <a:p xmlns:a="http://schemas.openxmlformats.org/drawingml/2006/main"/>
+        </p:txBody>
+      </p:sp>
+      <p:sp>
+        <p:nvSpPr>
+          <p:cNvPr id="4" name="Slide Number Placeholder 3"/>
+          <p:cNvSpPr>
+            <a:spLocks xmlns:a="http://schemas.openxmlformats.org/drawingml/2006/main" noGrp="1"/>
+          </p:cNvSpPr>
+          <p:nvPr>
+            <p:ph type="sldNum" idx="5"/>
+          </p:nvPr>
+        </p:nvSpPr>
+        <p:spPr/>
+        <p:txBody>
+          <a:bodyPr xmlns:a="http://schemas.openxmlformats.org/drawingml/2006/main"/>
+          <a:lstStyle xmlns:a="http://schemas.openxmlformats.org/drawingml/2006/main"/>
+          <a:p xmlns:a="http://schemas.openxmlformats.org/drawingml/2006/main"/>
+        </p:txBody>
+      </p:sp>
+    </p:spTree>
+  </p:cSld>
+  <p:clrMapOvr>
+    <a:masterClrMapping xmlns:a="http://schemas.openxmlformats.org/drawingml/2006/main"/>
+  </p:clrMapOvr>
+</p:notes>
+</file>
+
 <file path=ppt/slideLayouts/slideLayout1.xml><?xml version="1.0" encoding="utf-8"?>
 <p:sldLayout xmlns:p="http://schemas.openxmlformats.org/presentationml/2006/main" type="title">
   <p:cSld name="Title Slide">
@@ -869,7 +936,7 @@
   </p:cSld>
   <p:clrMap bg1="lt1" tx1="dk1" bg2="lt2" tx2="dk2" accent1="accent1" accent2="accent2" accent3="accent3" accent4="accent4" accent5="accent5" accent6="accent6" hlink="hlink" folHlink="folHlink"/>
   <p:sldLayoutIdLst>
-    <p:sldLayoutId xmlns:r="http://schemas.openxmlformats.org/officeDocument/2006/relationships" id="2147483649" r:id="R97f54ec5c3aa4d52"/>
+    <p:sldLayoutId xmlns:r="http://schemas.openxmlformats.org/officeDocument/2006/relationships" id="2147483649" r:id="R4efde446fdfa4066"/>
   </p:sldLayoutIdLst>
   <p:txStyles>
     <p:titleStyle>
@@ -1577,7 +1644,7 @@
           <p:nvPr/>
         </p:nvPicPr>
         <p:blipFill>
-          <a:blip xmlns:r="http://schemas.openxmlformats.org/officeDocument/2006/relationships" xmlns:a="http://schemas.openxmlformats.org/drawingml/2006/main" r:embed="Rc8ad7f38452a47f7"/>
+          <a:blip xmlns:r="http://schemas.openxmlformats.org/officeDocument/2006/relationships" xmlns:a="http://schemas.openxmlformats.org/drawingml/2006/main" r:embed="R0abf596416d14bcd"/>
           <a:srcRect xmlns:a="http://schemas.openxmlformats.org/drawingml/2006/main" l="0" t="30309" r="0" b="30309"/>
           <a:stretch xmlns:a="http://schemas.openxmlformats.org/drawingml/2006/main">
             <a:fillRect l="0" t="0" r="0" b="0"/>
@@ -2174,7 +2241,7 @@
           <p:nvPr/>
         </p:nvPicPr>
         <p:blipFill>
-          <a:blip xmlns:r="http://schemas.openxmlformats.org/officeDocument/2006/relationships" xmlns:a="http://schemas.openxmlformats.org/drawingml/2006/main" r:embed="Rc8244b0d769046f2"/>
+          <a:blip xmlns:r="http://schemas.openxmlformats.org/officeDocument/2006/relationships" xmlns:a="http://schemas.openxmlformats.org/drawingml/2006/main" r:embed="R6e1062985aa147f8"/>
           <a:srcRect xmlns:a="http://schemas.openxmlformats.org/drawingml/2006/main" l="0" t="6000" r="0" b="6000"/>
           <a:stretch xmlns:a="http://schemas.openxmlformats.org/drawingml/2006/main">
             <a:fillRect l="0" t="0" r="0" b="0"/>
@@ -2199,7 +2266,7 @@
           <p:nvPr/>
         </p:nvPicPr>
         <p:blipFill>
-          <a:blip xmlns:r="http://schemas.openxmlformats.org/officeDocument/2006/relationships" xmlns:a="http://schemas.openxmlformats.org/drawingml/2006/main" r:embed="R2790fb7f346b49ef"/>
+          <a:blip xmlns:r="http://schemas.openxmlformats.org/officeDocument/2006/relationships" xmlns:a="http://schemas.openxmlformats.org/drawingml/2006/main" r:embed="R416bf31f03804927"/>
           <a:srcRect xmlns:a="http://schemas.openxmlformats.org/drawingml/2006/main" l="0" t="6000" r="0" b="6000"/>
           <a:stretch xmlns:a="http://schemas.openxmlformats.org/drawingml/2006/main">
             <a:fillRect l="0" t="0" r="0" b="0"/>
@@ -2224,7 +2291,7 @@
           <p:nvPr/>
         </p:nvPicPr>
         <p:blipFill>
-          <a:blip xmlns:r="http://schemas.openxmlformats.org/officeDocument/2006/relationships" xmlns:a="http://schemas.openxmlformats.org/drawingml/2006/main" r:embed="Rc77cb5343f3e4147"/>
+          <a:blip xmlns:r="http://schemas.openxmlformats.org/officeDocument/2006/relationships" xmlns:a="http://schemas.openxmlformats.org/drawingml/2006/main" r:embed="R8e20d10087ea4fd2"/>
           <a:srcRect xmlns:a="http://schemas.openxmlformats.org/drawingml/2006/main" l="0" t="6000" r="0" b="6000"/>
           <a:stretch xmlns:a="http://schemas.openxmlformats.org/drawingml/2006/main">
             <a:fillRect l="0" t="0" r="0" b="0"/>
@@ -2515,7 +2582,7 @@
           <p:nvPr/>
         </p:nvPicPr>
         <p:blipFill>
-          <a:blip xmlns:r="http://schemas.openxmlformats.org/officeDocument/2006/relationships" xmlns:a="http://schemas.openxmlformats.org/drawingml/2006/main" r:embed="Re92814bae5e84041"/>
+          <a:blip xmlns:r="http://schemas.openxmlformats.org/officeDocument/2006/relationships" xmlns:a="http://schemas.openxmlformats.org/drawingml/2006/main" r:embed="R7357772901a44df0"/>
           <a:srcRect xmlns:a="http://schemas.openxmlformats.org/drawingml/2006/main" l="18895" t="0" r="18895" b="0"/>
           <a:stretch xmlns:a="http://schemas.openxmlformats.org/drawingml/2006/main">
             <a:fillRect l="0" t="0" r="0" b="0"/>
@@ -3194,7 +3261,7 @@
           <p:nvPr/>
         </p:nvPicPr>
         <p:blipFill>
-          <a:blip xmlns:r="http://schemas.openxmlformats.org/officeDocument/2006/relationships" xmlns:a="http://schemas.openxmlformats.org/drawingml/2006/main" r:embed="R395afb11aab44e26"/>
+          <a:blip xmlns:r="http://schemas.openxmlformats.org/officeDocument/2006/relationships" xmlns:a="http://schemas.openxmlformats.org/drawingml/2006/main" r:embed="R61af4a82a01e4bfe"/>
           <a:srcRect xmlns:a="http://schemas.openxmlformats.org/drawingml/2006/main" l="0" t="2134" r="0" b="2134"/>
           <a:stretch xmlns:a="http://schemas.openxmlformats.org/drawingml/2006/main">
             <a:fillRect l="0" t="0" r="0" b="0"/>
@@ -3219,7 +3286,7 @@
           <p:nvPr/>
         </p:nvPicPr>
         <p:blipFill>
-          <a:blip xmlns:r="http://schemas.openxmlformats.org/officeDocument/2006/relationships" xmlns:a="http://schemas.openxmlformats.org/drawingml/2006/main" r:embed="R0e118d0c6cfe4fc2"/>
+          <a:blip xmlns:r="http://schemas.openxmlformats.org/officeDocument/2006/relationships" xmlns:a="http://schemas.openxmlformats.org/drawingml/2006/main" r:embed="R3f71a3990b064d12"/>
           <a:srcRect xmlns:a="http://schemas.openxmlformats.org/drawingml/2006/main" l="0" t="2134" r="0" b="2134"/>
           <a:stretch xmlns:a="http://schemas.openxmlformats.org/drawingml/2006/main">
             <a:fillRect l="0" t="0" r="0" b="0"/>
@@ -3244,7 +3311,7 @@
           <p:nvPr/>
         </p:nvPicPr>
         <p:blipFill>
-          <a:blip xmlns:r="http://schemas.openxmlformats.org/officeDocument/2006/relationships" xmlns:a="http://schemas.openxmlformats.org/drawingml/2006/main" r:embed="R5e4ca588bfa94c50"/>
+          <a:blip xmlns:r="http://schemas.openxmlformats.org/officeDocument/2006/relationships" xmlns:a="http://schemas.openxmlformats.org/drawingml/2006/main" r:embed="Re883d2665de84d87"/>
           <a:srcRect xmlns:a="http://schemas.openxmlformats.org/drawingml/2006/main" l="0" t="2134" r="0" b="2134"/>
           <a:stretch xmlns:a="http://schemas.openxmlformats.org/drawingml/2006/main">
             <a:fillRect l="0" t="0" r="0" b="0"/>
@@ -3641,6 +3708,7 @@
           <a:lstStyle xmlns:a="http://schemas.openxmlformats.org/drawingml/2006/main"/>
           <a:p xmlns:a="http://schemas.openxmlformats.org/drawingml/2006/main">
             <a:pPr>
+              <a:buNone/>
               <a:defRPr sz="1050" b="1">
                 <a:solidFill>
                   <a:srgbClr val="22C55E"/>
@@ -3691,6 +3759,7 @@
           <a:lstStyle xmlns:a="http://schemas.openxmlformats.org/drawingml/2006/main"/>
           <a:p xmlns:a="http://schemas.openxmlformats.org/drawingml/2006/main">
             <a:pPr>
+              <a:buNone/>
               <a:defRPr sz="2850" b="1">
                 <a:solidFill>
                   <a:srgbClr val="FFFFFF"/>
@@ -3708,6 +3777,7 @@
           </a:p>
           <a:p xmlns:a="http://schemas.openxmlformats.org/drawingml/2006/main">
             <a:pPr>
+              <a:buNone/>
               <a:defRPr sz="2850" b="1">
                 <a:solidFill>
                   <a:srgbClr val="FFFFFF"/>
@@ -3758,6 +3828,7 @@
           <a:lstStyle xmlns:a="http://schemas.openxmlformats.org/drawingml/2006/main"/>
           <a:p xmlns:a="http://schemas.openxmlformats.org/drawingml/2006/main">
             <a:pPr>
+              <a:buNone/>
               <a:defRPr sz="1350">
                 <a:solidFill>
                   <a:srgbClr val="CBD5E1"/>
@@ -3841,6 +3912,7 @@
           <a:lstStyle xmlns:a="http://schemas.openxmlformats.org/drawingml/2006/main"/>
           <a:p xmlns:a="http://schemas.openxmlformats.org/drawingml/2006/main">
             <a:pPr>
+              <a:buNone/>
               <a:defRPr sz="1425" b="1">
                 <a:solidFill>
                   <a:srgbClr val="F8FAFC"/>
@@ -3891,6 +3963,7 @@
           <a:lstStyle xmlns:a="http://schemas.openxmlformats.org/drawingml/2006/main"/>
           <a:p xmlns:a="http://schemas.openxmlformats.org/drawingml/2006/main">
             <a:pPr>
+              <a:buNone/>
               <a:defRPr sz="1200">
                 <a:solidFill>
                   <a:srgbClr val="CBD5E1"/>
@@ -3974,6 +4047,7 @@
           <a:lstStyle xmlns:a="http://schemas.openxmlformats.org/drawingml/2006/main"/>
           <a:p xmlns:a="http://schemas.openxmlformats.org/drawingml/2006/main">
             <a:pPr>
+              <a:buNone/>
               <a:defRPr sz="1425" b="1">
                 <a:solidFill>
                   <a:srgbClr val="F8FAFC"/>
@@ -4024,6 +4098,7 @@
           <a:lstStyle xmlns:a="http://schemas.openxmlformats.org/drawingml/2006/main"/>
           <a:p xmlns:a="http://schemas.openxmlformats.org/drawingml/2006/main">
             <a:pPr>
+              <a:buNone/>
               <a:defRPr sz="1200">
                 <a:solidFill>
                   <a:srgbClr val="CBD5E1"/>
@@ -4107,6 +4182,7 @@
           <a:lstStyle xmlns:a="http://schemas.openxmlformats.org/drawingml/2006/main"/>
           <a:p xmlns:a="http://schemas.openxmlformats.org/drawingml/2006/main">
             <a:pPr>
+              <a:buNone/>
               <a:defRPr sz="1425" b="1">
                 <a:solidFill>
                   <a:srgbClr val="F8FAFC"/>
@@ -4157,6 +4233,7 @@
           <a:lstStyle xmlns:a="http://schemas.openxmlformats.org/drawingml/2006/main"/>
           <a:p xmlns:a="http://schemas.openxmlformats.org/drawingml/2006/main">
             <a:pPr>
+              <a:buNone/>
               <a:defRPr sz="1200">
                 <a:solidFill>
                   <a:srgbClr val="CBD5E1"/>
@@ -4240,6 +4317,7 @@
           <a:lstStyle xmlns:a="http://schemas.openxmlformats.org/drawingml/2006/main"/>
           <a:p xmlns:a="http://schemas.openxmlformats.org/drawingml/2006/main">
             <a:pPr>
+              <a:buNone/>
               <a:defRPr sz="1425" b="1">
                 <a:solidFill>
                   <a:srgbClr val="F8FAFC"/>
@@ -4290,6 +4368,7 @@
           <a:lstStyle xmlns:a="http://schemas.openxmlformats.org/drawingml/2006/main"/>
           <a:p xmlns:a="http://schemas.openxmlformats.org/drawingml/2006/main">
             <a:pPr>
+              <a:buNone/>
               <a:defRPr sz="1200">
                 <a:solidFill>
                   <a:srgbClr val="CBD5E1"/>
@@ -4309,14 +4388,14 @@
       </p:sp>
       <p:pic>
         <p:nvPicPr>
-          <p:cNvPr id="38" name=""/>
+          <p:cNvPr id="39" name=""/>
           <p:cNvPicPr>
             <a:picLocks xmlns:a="http://schemas.openxmlformats.org/drawingml/2006/main" noChangeAspect="1"/>
           </p:cNvPicPr>
           <p:nvPr/>
         </p:nvPicPr>
         <p:blipFill>
-          <a:blip xmlns:r="http://schemas.openxmlformats.org/officeDocument/2006/relationships" xmlns:a="http://schemas.openxmlformats.org/drawingml/2006/main" r:embed="Rab9605ca1ad44492"/>
+          <a:blip xmlns:r="http://schemas.openxmlformats.org/officeDocument/2006/relationships" xmlns:a="http://schemas.openxmlformats.org/drawingml/2006/main" r:embed="R704078eaa1e04be1"/>
           <a:stretch xmlns:a="http://schemas.openxmlformats.org/drawingml/2006/main"/>
         </p:blipFill>
         <p:spPr>
@@ -4325,9 +4404,7 @@
             <a:ext cx="6089438" cy="4419600"/>
           </a:xfrm>
           <a:prstGeom xmlns:a="http://schemas.openxmlformats.org/drawingml/2006/main" prst="roundRect">
-            <a:avLst>
-              <a:gd name="adj" fmla="val 1724"/>
-            </a:avLst>
+            <a:avLst/>
           </a:prstGeom>
         </p:spPr>
       </p:pic>
@@ -4395,6 +4472,7 @@
           <a:lstStyle xmlns:a="http://schemas.openxmlformats.org/drawingml/2006/main"/>
           <a:p xmlns:a="http://schemas.openxmlformats.org/drawingml/2006/main">
             <a:pPr>
+              <a:buNone/>
               <a:defRPr sz="1275">
                 <a:solidFill>
                   <a:srgbClr val="E2E8F0"/>
@@ -4480,6 +4558,7 @@
           <a:lstStyle xmlns:a="http://schemas.openxmlformats.org/drawingml/2006/main"/>
           <a:p xmlns:a="http://schemas.openxmlformats.org/drawingml/2006/main">
             <a:pPr>
+              <a:buNone/>
               <a:defRPr sz="1200" b="1">
                 <a:solidFill>
                   <a:srgbClr val="F8FAFC"/>
@@ -4501,6 +4580,969 @@
     <p:extLst>
       <p:ext uri="{BB962C8B-B14F-4D97-AF65-F5344CB8AC3E}">
         <p14:creationId xmlns:p14="http://schemas.microsoft.com/office/powerpoint/2010/main" val="1917662731"/>
+      </p:ext>
+    </p:extLst>
+  </p:cSld>
+</p:sld>
+</file>
+
+<file path=ppt/slides/slide6.xml><?xml version="1.0" encoding="utf-8"?>
+<p:sld xmlns:p="http://schemas.openxmlformats.org/presentationml/2006/main">
+  <p:cSld>
+    <p:bg>
+      <p:bgPr>
+        <a:solidFill xmlns:a="http://schemas.openxmlformats.org/drawingml/2006/main">
+          <a:srgbClr val="080B0F"/>
+        </a:solidFill>
+      </p:bgPr>
+    </p:bg>
+    <p:spTree>
+      <p:nvGrpSpPr>
+        <p:cNvPr id="1" name=""/>
+        <p:cNvGrpSpPr/>
+        <p:nvPr/>
+      </p:nvGrpSpPr>
+      <p:grpSpPr>
+        <a:xfrm xmlns:a="http://schemas.openxmlformats.org/drawingml/2006/main"/>
+      </p:grpSpPr>
+      <p:sp>
+        <p:nvSpPr>
+          <p:cNvPr id="1" name="xr-left-panel">
+            <a:extLst xmlns:a="http://schemas.openxmlformats.org/drawingml/2006/main">
+              <a:ext uri="{FF2B5EF4-FFF2-40B4-BE49-F238E27FC236}">
+                <a16:creationId xmlns:a16="http://schemas.microsoft.com/office/drawing/2014/main" id="{C340BB2D-AFBE-436C-B2BC-D8A68FF3D260}"/>
+              </a:ext>
+            </a:extLst>
+          </p:cNvPr>
+          <p:cNvSpPr>
+            <a:spLocks xmlns:a="http://schemas.openxmlformats.org/drawingml/2006/main" noGrp="1"/>
+          </p:cNvSpPr>
+          <p:nvPr/>
+        </p:nvSpPr>
+        <p:spPr>
+          <a:xfrm xmlns:a="http://schemas.openxmlformats.org/drawingml/2006/main">
+            <a:off x="0" y="0"/>
+            <a:ext cx="5219700" cy="6858000"/>
+          </a:xfrm>
+          <a:prstGeom xmlns:a="http://schemas.openxmlformats.org/drawingml/2006/main" prst="rect">
+            <a:avLst/>
+          </a:prstGeom>
+          <a:solidFill xmlns:a="http://schemas.openxmlformats.org/drawingml/2006/main">
+            <a:srgbClr val="111318"/>
+          </a:solidFill>
+          <a:ln xmlns:a="http://schemas.openxmlformats.org/drawingml/2006/main" w="0">
+            <a:noFill/>
+            <a:prstDash val="solid"/>
+          </a:ln>
+        </p:spPr>
+      </p:sp>
+      <p:sp>
+        <p:nvSpPr>
+          <p:cNvPr id="2" name="xr-eyebrow">
+            <a:extLst xmlns:a="http://schemas.openxmlformats.org/drawingml/2006/main">
+              <a:ext uri="{FF2B5EF4-FFF2-40B4-BE49-F238E27FC236}">
+                <a16:creationId xmlns:a16="http://schemas.microsoft.com/office/drawing/2014/main" id="{D9995331-F557-41F7-9910-491418D731C1}"/>
+              </a:ext>
+            </a:extLst>
+          </p:cNvPr>
+          <p:cNvSpPr>
+            <a:spLocks xmlns:a="http://schemas.openxmlformats.org/drawingml/2006/main" noGrp="1"/>
+          </p:cNvSpPr>
+          <p:nvPr/>
+        </p:nvSpPr>
+        <p:spPr>
+          <a:xfrm xmlns:a="http://schemas.openxmlformats.org/drawingml/2006/main">
+            <a:off x="590550" y="419100"/>
+            <a:ext cx="4000500" cy="228600"/>
+          </a:xfrm>
+          <a:prstGeom xmlns:a="http://schemas.openxmlformats.org/drawingml/2006/main" prst="rect">
+            <a:avLst/>
+          </a:prstGeom>
+          <a:noFill xmlns:a="http://schemas.openxmlformats.org/drawingml/2006/main"/>
+          <a:ln xmlns:a="http://schemas.openxmlformats.org/drawingml/2006/main" w="0">
+            <a:noFill/>
+            <a:prstDash val="solid"/>
+          </a:ln>
+        </p:spPr>
+        <p:txBody>
+          <a:bodyPr xmlns:a="http://schemas.openxmlformats.org/drawingml/2006/main"/>
+          <a:lstStyle xmlns:a="http://schemas.openxmlformats.org/drawingml/2006/main"/>
+          <a:p xmlns:a="http://schemas.openxmlformats.org/drawingml/2006/main">
+            <a:pPr>
+              <a:defRPr sz="1050" b="1">
+                <a:solidFill>
+                  <a:srgbClr val="38BDF8"/>
+                </a:solidFill>
+              </a:defRPr>
+            </a:pPr>
+            <a:r>
+              <a:rPr sz="1050" b="1">
+                <a:solidFill>
+                  <a:srgbClr val="38BDF8"/>
+                </a:solidFill>
+              </a:rPr>
+              <a:t>XR WALKING CONTROL</a:t>
+            </a:r>
+          </a:p>
+        </p:txBody>
+      </p:sp>
+      <p:sp>
+        <p:nvSpPr>
+          <p:cNvPr id="3" name="xr-title">
+            <a:extLst xmlns:a="http://schemas.openxmlformats.org/drawingml/2006/main">
+              <a:ext uri="{FF2B5EF4-FFF2-40B4-BE49-F238E27FC236}">
+                <a16:creationId xmlns:a16="http://schemas.microsoft.com/office/drawing/2014/main" id="{9ABBD2E8-B1C0-4DF6-9259-E5CD94386E02}"/>
+              </a:ext>
+            </a:extLst>
+          </p:cNvPr>
+          <p:cNvSpPr>
+            <a:spLocks xmlns:a="http://schemas.openxmlformats.org/drawingml/2006/main" noGrp="1"/>
+          </p:cNvSpPr>
+          <p:nvPr/>
+        </p:nvSpPr>
+        <p:spPr>
+          <a:xfrm xmlns:a="http://schemas.openxmlformats.org/drawingml/2006/main">
+            <a:off x="590550" y="838200"/>
+            <a:ext cx="4095750" cy="990600"/>
+          </a:xfrm>
+          <a:prstGeom xmlns:a="http://schemas.openxmlformats.org/drawingml/2006/main" prst="rect">
+            <a:avLst/>
+          </a:prstGeom>
+          <a:noFill xmlns:a="http://schemas.openxmlformats.org/drawingml/2006/main"/>
+          <a:ln xmlns:a="http://schemas.openxmlformats.org/drawingml/2006/main" w="0">
+            <a:noFill/>
+            <a:prstDash val="solid"/>
+          </a:ln>
+        </p:spPr>
+        <p:txBody>
+          <a:bodyPr xmlns:a="http://schemas.openxmlformats.org/drawingml/2006/main"/>
+          <a:lstStyle xmlns:a="http://schemas.openxmlformats.org/drawingml/2006/main"/>
+          <a:p xmlns:a="http://schemas.openxmlformats.org/drawingml/2006/main">
+            <a:pPr>
+              <a:defRPr sz="3150" b="1">
+                <a:solidFill>
+                  <a:srgbClr val="FFFFFF"/>
+                </a:solidFill>
+              </a:defRPr>
+            </a:pPr>
+            <a:r>
+              <a:rPr sz="3150" b="1">
+                <a:solidFill>
+                  <a:srgbClr val="FFFFFF"/>
+                </a:solidFill>
+              </a:rPr>
+              <a:t>Robotu yürütmenin</a:t>
+            </a:r>
+          </a:p>
+          <a:p xmlns:a="http://schemas.openxmlformats.org/drawingml/2006/main">
+            <a:pPr>
+              <a:defRPr sz="3150" b="1">
+                <a:solidFill>
+                  <a:srgbClr val="FFFFFF"/>
+                </a:solidFill>
+              </a:defRPr>
+            </a:pPr>
+            <a:r>
+              <a:rPr sz="3150" b="1">
+                <a:solidFill>
+                  <a:srgbClr val="FFFFFF"/>
+                </a:solidFill>
+              </a:rPr>
+              <a:t>üç yolu</a:t>
+            </a:r>
+          </a:p>
+        </p:txBody>
+      </p:sp>
+      <p:sp>
+        <p:nvSpPr>
+          <p:cNvPr id="4" name="xr-subtitle">
+            <a:extLst xmlns:a="http://schemas.openxmlformats.org/drawingml/2006/main">
+              <a:ext uri="{FF2B5EF4-FFF2-40B4-BE49-F238E27FC236}">
+                <a16:creationId xmlns:a16="http://schemas.microsoft.com/office/drawing/2014/main" id="{F69F51C3-D3BE-4412-B29D-510531BFF3A8}"/>
+              </a:ext>
+            </a:extLst>
+          </p:cNvPr>
+          <p:cNvSpPr>
+            <a:spLocks xmlns:a="http://schemas.openxmlformats.org/drawingml/2006/main" noGrp="1"/>
+          </p:cNvSpPr>
+          <p:nvPr/>
+        </p:nvSpPr>
+        <p:spPr>
+          <a:xfrm xmlns:a="http://schemas.openxmlformats.org/drawingml/2006/main">
+            <a:off x="609600" y="1962150"/>
+            <a:ext cx="4057650" cy="666750"/>
+          </a:xfrm>
+          <a:prstGeom xmlns:a="http://schemas.openxmlformats.org/drawingml/2006/main" prst="rect">
+            <a:avLst/>
+          </a:prstGeom>
+          <a:noFill xmlns:a="http://schemas.openxmlformats.org/drawingml/2006/main"/>
+          <a:ln xmlns:a="http://schemas.openxmlformats.org/drawingml/2006/main" w="0">
+            <a:noFill/>
+            <a:prstDash val="solid"/>
+          </a:ln>
+        </p:spPr>
+        <p:txBody>
+          <a:bodyPr xmlns:a="http://schemas.openxmlformats.org/drawingml/2006/main"/>
+          <a:lstStyle xmlns:a="http://schemas.openxmlformats.org/drawingml/2006/main"/>
+          <a:p xmlns:a="http://schemas.openxmlformats.org/drawingml/2006/main">
+            <a:pPr>
+              <a:defRPr sz="1350">
+                <a:solidFill>
+                  <a:srgbClr val="CBD5E1"/>
+                </a:solidFill>
+              </a:defRPr>
+            </a:pPr>
+            <a:r>
+              <a:rPr sz="1350">
+                <a:solidFill>
+                  <a:srgbClr val="CBD5E1"/>
+                </a:solidFill>
+              </a:rPr>
+              <a:t>Operatör; hassas manuel komut, baş yönüyle sezgisel sürüş veya pozisyon eşleme arasında geçiş yapabiliyor.</a:t>
+            </a:r>
+          </a:p>
+        </p:txBody>
+      </p:sp>
+      <p:sp>
+        <p:nvSpPr>
+          <p:cNvPr id="5" name="xr-control-index-1">
+            <a:extLst xmlns:a="http://schemas.openxmlformats.org/drawingml/2006/main">
+              <a:ext uri="{FF2B5EF4-FFF2-40B4-BE49-F238E27FC236}">
+                <a16:creationId xmlns:a16="http://schemas.microsoft.com/office/drawing/2014/main" id="{AAFDF8A3-9BC0-4402-A2E7-D39A8FAB67EE}"/>
+              </a:ext>
+            </a:extLst>
+          </p:cNvPr>
+          <p:cNvSpPr>
+            <a:spLocks xmlns:a="http://schemas.openxmlformats.org/drawingml/2006/main" noGrp="1"/>
+          </p:cNvSpPr>
+          <p:nvPr/>
+        </p:nvSpPr>
+        <p:spPr>
+          <a:xfrm xmlns:a="http://schemas.openxmlformats.org/drawingml/2006/main">
+            <a:off x="590550" y="2990850"/>
+            <a:ext cx="323850" cy="323850"/>
+          </a:xfrm>
+          <a:prstGeom xmlns:a="http://schemas.openxmlformats.org/drawingml/2006/main" prst="ellipse">
+            <a:avLst/>
+          </a:prstGeom>
+          <a:solidFill xmlns:a="http://schemas.openxmlformats.org/drawingml/2006/main">
+            <a:srgbClr val="22C55E"/>
+          </a:solidFill>
+          <a:ln xmlns:a="http://schemas.openxmlformats.org/drawingml/2006/main" w="0">
+            <a:noFill/>
+            <a:prstDash val="solid"/>
+          </a:ln>
+        </p:spPr>
+      </p:sp>
+      <p:sp>
+        <p:nvSpPr>
+          <p:cNvPr id="6" name="xr-control-index-text-1">
+            <a:extLst xmlns:a="http://schemas.openxmlformats.org/drawingml/2006/main">
+              <a:ext uri="{FF2B5EF4-FFF2-40B4-BE49-F238E27FC236}">
+                <a16:creationId xmlns:a16="http://schemas.microsoft.com/office/drawing/2014/main" id="{9D352A34-8BBB-43F2-A3E4-917DB779F87C}"/>
+              </a:ext>
+            </a:extLst>
+          </p:cNvPr>
+          <p:cNvSpPr>
+            <a:spLocks xmlns:a="http://schemas.openxmlformats.org/drawingml/2006/main" noGrp="1"/>
+          </p:cNvSpPr>
+          <p:nvPr/>
+        </p:nvSpPr>
+        <p:spPr>
+          <a:xfrm xmlns:a="http://schemas.openxmlformats.org/drawingml/2006/main">
+            <a:off x="590550" y="3038475"/>
+            <a:ext cx="323850" cy="209550"/>
+          </a:xfrm>
+          <a:prstGeom xmlns:a="http://schemas.openxmlformats.org/drawingml/2006/main" prst="rect">
+            <a:avLst/>
+          </a:prstGeom>
+          <a:noFill xmlns:a="http://schemas.openxmlformats.org/drawingml/2006/main"/>
+          <a:ln xmlns:a="http://schemas.openxmlformats.org/drawingml/2006/main" w="0">
+            <a:noFill/>
+            <a:prstDash val="solid"/>
+          </a:ln>
+        </p:spPr>
+        <p:txBody>
+          <a:bodyPr xmlns:a="http://schemas.openxmlformats.org/drawingml/2006/main"/>
+          <a:lstStyle xmlns:a="http://schemas.openxmlformats.org/drawingml/2006/main"/>
+          <a:p xmlns:a="http://schemas.openxmlformats.org/drawingml/2006/main">
+            <a:pPr algn="ctr">
+              <a:defRPr sz="1200" b="1">
+                <a:solidFill>
+                  <a:srgbClr val="FFFFFF"/>
+                </a:solidFill>
+              </a:defRPr>
+            </a:pPr>
+            <a:r>
+              <a:rPr sz="1200" b="1">
+                <a:solidFill>
+                  <a:srgbClr val="FFFFFF"/>
+                </a:solidFill>
+              </a:rPr>
+              <a:t>1</a:t>
+            </a:r>
+          </a:p>
+        </p:txBody>
+      </p:sp>
+      <p:sp>
+        <p:nvSpPr>
+          <p:cNvPr id="7" name="xr-control-title-1">
+            <a:extLst xmlns:a="http://schemas.openxmlformats.org/drawingml/2006/main">
+              <a:ext uri="{FF2B5EF4-FFF2-40B4-BE49-F238E27FC236}">
+                <a16:creationId xmlns:a16="http://schemas.microsoft.com/office/drawing/2014/main" id="{DCAD1547-2520-4F8C-AAEE-A66EC2947567}"/>
+              </a:ext>
+            </a:extLst>
+          </p:cNvPr>
+          <p:cNvSpPr>
+            <a:spLocks xmlns:a="http://schemas.openxmlformats.org/drawingml/2006/main" noGrp="1"/>
+          </p:cNvSpPr>
+          <p:nvPr/>
+        </p:nvSpPr>
+        <p:spPr>
+          <a:xfrm xmlns:a="http://schemas.openxmlformats.org/drawingml/2006/main">
+            <a:off x="1066800" y="2971800"/>
+            <a:ext cx="3733800" cy="247650"/>
+          </a:xfrm>
+          <a:prstGeom xmlns:a="http://schemas.openxmlformats.org/drawingml/2006/main" prst="rect">
+            <a:avLst/>
+          </a:prstGeom>
+          <a:noFill xmlns:a="http://schemas.openxmlformats.org/drawingml/2006/main"/>
+          <a:ln xmlns:a="http://schemas.openxmlformats.org/drawingml/2006/main" w="0">
+            <a:noFill/>
+            <a:prstDash val="solid"/>
+          </a:ln>
+        </p:spPr>
+        <p:txBody>
+          <a:bodyPr xmlns:a="http://schemas.openxmlformats.org/drawingml/2006/main"/>
+          <a:lstStyle xmlns:a="http://schemas.openxmlformats.org/drawingml/2006/main"/>
+          <a:p xmlns:a="http://schemas.openxmlformats.org/drawingml/2006/main">
+            <a:pPr>
+              <a:defRPr sz="1500" b="1">
+                <a:solidFill>
+                  <a:srgbClr val="F8FAFC"/>
+                </a:solidFill>
+              </a:defRPr>
+            </a:pPr>
+            <a:r>
+              <a:rPr sz="1500" b="1">
+                <a:solidFill>
+                  <a:srgbClr val="F8FAFC"/>
+                </a:solidFill>
+              </a:rPr>
+              <a:t>Floating VR Control Pad</a:t>
+            </a:r>
+          </a:p>
+        </p:txBody>
+      </p:sp>
+      <p:sp>
+        <p:nvSpPr>
+          <p:cNvPr id="8" name="xr-control-body-1">
+            <a:extLst xmlns:a="http://schemas.openxmlformats.org/drawingml/2006/main">
+              <a:ext uri="{FF2B5EF4-FFF2-40B4-BE49-F238E27FC236}">
+                <a16:creationId xmlns:a16="http://schemas.microsoft.com/office/drawing/2014/main" id="{DFB78ADE-ABED-47ED-9A14-96C1E42A501B}"/>
+              </a:ext>
+            </a:extLst>
+          </p:cNvPr>
+          <p:cNvSpPr>
+            <a:spLocks xmlns:a="http://schemas.openxmlformats.org/drawingml/2006/main" noGrp="1"/>
+          </p:cNvSpPr>
+          <p:nvPr/>
+        </p:nvSpPr>
+        <p:spPr>
+          <a:xfrm xmlns:a="http://schemas.openxmlformats.org/drawingml/2006/main">
+            <a:off x="1066800" y="3267075"/>
+            <a:ext cx="3790950" cy="514350"/>
+          </a:xfrm>
+          <a:prstGeom xmlns:a="http://schemas.openxmlformats.org/drawingml/2006/main" prst="rect">
+            <a:avLst/>
+          </a:prstGeom>
+          <a:noFill xmlns:a="http://schemas.openxmlformats.org/drawingml/2006/main"/>
+          <a:ln xmlns:a="http://schemas.openxmlformats.org/drawingml/2006/main" w="0">
+            <a:noFill/>
+            <a:prstDash val="solid"/>
+          </a:ln>
+        </p:spPr>
+        <p:txBody>
+          <a:bodyPr xmlns:a="http://schemas.openxmlformats.org/drawingml/2006/main"/>
+          <a:lstStyle xmlns:a="http://schemas.openxmlformats.org/drawingml/2006/main"/>
+          <a:p xmlns:a="http://schemas.openxmlformats.org/drawingml/2006/main">
+            <a:pPr>
+              <a:defRPr sz="1200">
+                <a:solidFill>
+                  <a:srgbClr val="CBD5E1"/>
+                </a:solidFill>
+              </a:defRPr>
+            </a:pPr>
+            <a:r>
+              <a:rPr sz="1200">
+                <a:solidFill>
+                  <a:srgbClr val="CBD5E1"/>
+                </a:solidFill>
+              </a:rPr>
+              <a:t>Sanal joystick/pad ile hız ve yön verilir. Demo, dar alan ve hassas manuel sürüş için uygun.</a:t>
+            </a:r>
+          </a:p>
+        </p:txBody>
+      </p:sp>
+      <p:sp>
+        <p:nvSpPr>
+          <p:cNvPr id="9" name="xr-control-index-2">
+            <a:extLst xmlns:a="http://schemas.openxmlformats.org/drawingml/2006/main">
+              <a:ext uri="{FF2B5EF4-FFF2-40B4-BE49-F238E27FC236}">
+                <a16:creationId xmlns:a16="http://schemas.microsoft.com/office/drawing/2014/main" id="{6B8E75E8-B335-41BC-8392-447E4CE82DF4}"/>
+              </a:ext>
+            </a:extLst>
+          </p:cNvPr>
+          <p:cNvSpPr>
+            <a:spLocks xmlns:a="http://schemas.openxmlformats.org/drawingml/2006/main" noGrp="1"/>
+          </p:cNvSpPr>
+          <p:nvPr/>
+        </p:nvSpPr>
+        <p:spPr>
+          <a:xfrm xmlns:a="http://schemas.openxmlformats.org/drawingml/2006/main">
+            <a:off x="590550" y="4076700"/>
+            <a:ext cx="323850" cy="323850"/>
+          </a:xfrm>
+          <a:prstGeom xmlns:a="http://schemas.openxmlformats.org/drawingml/2006/main" prst="ellipse">
+            <a:avLst/>
+          </a:prstGeom>
+          <a:solidFill xmlns:a="http://schemas.openxmlformats.org/drawingml/2006/main">
+            <a:srgbClr val="38BDF8"/>
+          </a:solidFill>
+          <a:ln xmlns:a="http://schemas.openxmlformats.org/drawingml/2006/main" w="0">
+            <a:noFill/>
+            <a:prstDash val="solid"/>
+          </a:ln>
+        </p:spPr>
+      </p:sp>
+      <p:sp>
+        <p:nvSpPr>
+          <p:cNvPr id="10" name="xr-control-index-text-2">
+            <a:extLst xmlns:a="http://schemas.openxmlformats.org/drawingml/2006/main">
+              <a:ext uri="{FF2B5EF4-FFF2-40B4-BE49-F238E27FC236}">
+                <a16:creationId xmlns:a16="http://schemas.microsoft.com/office/drawing/2014/main" id="{11F13662-6559-45B7-90F7-36A566BA58AA}"/>
+              </a:ext>
+            </a:extLst>
+          </p:cNvPr>
+          <p:cNvSpPr>
+            <a:spLocks xmlns:a="http://schemas.openxmlformats.org/drawingml/2006/main" noGrp="1"/>
+          </p:cNvSpPr>
+          <p:nvPr/>
+        </p:nvSpPr>
+        <p:spPr>
+          <a:xfrm xmlns:a="http://schemas.openxmlformats.org/drawingml/2006/main">
+            <a:off x="590550" y="4124325"/>
+            <a:ext cx="323850" cy="209550"/>
+          </a:xfrm>
+          <a:prstGeom xmlns:a="http://schemas.openxmlformats.org/drawingml/2006/main" prst="rect">
+            <a:avLst/>
+          </a:prstGeom>
+          <a:noFill xmlns:a="http://schemas.openxmlformats.org/drawingml/2006/main"/>
+          <a:ln xmlns:a="http://schemas.openxmlformats.org/drawingml/2006/main" w="0">
+            <a:noFill/>
+            <a:prstDash val="solid"/>
+          </a:ln>
+        </p:spPr>
+        <p:txBody>
+          <a:bodyPr xmlns:a="http://schemas.openxmlformats.org/drawingml/2006/main"/>
+          <a:lstStyle xmlns:a="http://schemas.openxmlformats.org/drawingml/2006/main"/>
+          <a:p xmlns:a="http://schemas.openxmlformats.org/drawingml/2006/main">
+            <a:pPr algn="ctr">
+              <a:defRPr sz="1200" b="1">
+                <a:solidFill>
+                  <a:srgbClr val="FFFFFF"/>
+                </a:solidFill>
+              </a:defRPr>
+            </a:pPr>
+            <a:r>
+              <a:rPr sz="1200" b="1">
+                <a:solidFill>
+                  <a:srgbClr val="FFFFFF"/>
+                </a:solidFill>
+              </a:rPr>
+              <a:t>2</a:t>
+            </a:r>
+          </a:p>
+        </p:txBody>
+      </p:sp>
+      <p:sp>
+        <p:nvSpPr>
+          <p:cNvPr id="11" name="xr-control-title-2">
+            <a:extLst xmlns:a="http://schemas.openxmlformats.org/drawingml/2006/main">
+              <a:ext uri="{FF2B5EF4-FFF2-40B4-BE49-F238E27FC236}">
+                <a16:creationId xmlns:a16="http://schemas.microsoft.com/office/drawing/2014/main" id="{58C1152E-2CEF-4CE8-BBEC-C7B8BF613CF9}"/>
+              </a:ext>
+            </a:extLst>
+          </p:cNvPr>
+          <p:cNvSpPr>
+            <a:spLocks xmlns:a="http://schemas.openxmlformats.org/drawingml/2006/main" noGrp="1"/>
+          </p:cNvSpPr>
+          <p:nvPr/>
+        </p:nvSpPr>
+        <p:spPr>
+          <a:xfrm xmlns:a="http://schemas.openxmlformats.org/drawingml/2006/main">
+            <a:off x="1066800" y="4057650"/>
+            <a:ext cx="3733800" cy="247650"/>
+          </a:xfrm>
+          <a:prstGeom xmlns:a="http://schemas.openxmlformats.org/drawingml/2006/main" prst="rect">
+            <a:avLst/>
+          </a:prstGeom>
+          <a:noFill xmlns:a="http://schemas.openxmlformats.org/drawingml/2006/main"/>
+          <a:ln xmlns:a="http://schemas.openxmlformats.org/drawingml/2006/main" w="0">
+            <a:noFill/>
+            <a:prstDash val="solid"/>
+          </a:ln>
+        </p:spPr>
+        <p:txBody>
+          <a:bodyPr xmlns:a="http://schemas.openxmlformats.org/drawingml/2006/main"/>
+          <a:lstStyle xmlns:a="http://schemas.openxmlformats.org/drawingml/2006/main"/>
+          <a:p xmlns:a="http://schemas.openxmlformats.org/drawingml/2006/main">
+            <a:pPr>
+              <a:defRPr sz="1500" b="1">
+                <a:solidFill>
+                  <a:srgbClr val="F8FAFC"/>
+                </a:solidFill>
+              </a:defRPr>
+            </a:pPr>
+            <a:r>
+              <a:rPr sz="1500" b="1">
+                <a:solidFill>
+                  <a:srgbClr val="F8FAFC"/>
+                </a:solidFill>
+              </a:rPr>
+              <a:t>Head Rotation Control</a:t>
+            </a:r>
+          </a:p>
+        </p:txBody>
+      </p:sp>
+      <p:sp>
+        <p:nvSpPr>
+          <p:cNvPr id="12" name="xr-control-body-2">
+            <a:extLst xmlns:a="http://schemas.openxmlformats.org/drawingml/2006/main">
+              <a:ext uri="{FF2B5EF4-FFF2-40B4-BE49-F238E27FC236}">
+                <a16:creationId xmlns:a16="http://schemas.microsoft.com/office/drawing/2014/main" id="{01C67911-163B-4008-8DDA-8EDFA506B250}"/>
+              </a:ext>
+            </a:extLst>
+          </p:cNvPr>
+          <p:cNvSpPr>
+            <a:spLocks xmlns:a="http://schemas.openxmlformats.org/drawingml/2006/main" noGrp="1"/>
+          </p:cNvSpPr>
+          <p:nvPr/>
+        </p:nvSpPr>
+        <p:spPr>
+          <a:xfrm xmlns:a="http://schemas.openxmlformats.org/drawingml/2006/main">
+            <a:off x="1066800" y="4352925"/>
+            <a:ext cx="3790950" cy="514350"/>
+          </a:xfrm>
+          <a:prstGeom xmlns:a="http://schemas.openxmlformats.org/drawingml/2006/main" prst="rect">
+            <a:avLst/>
+          </a:prstGeom>
+          <a:noFill xmlns:a="http://schemas.openxmlformats.org/drawingml/2006/main"/>
+          <a:ln xmlns:a="http://schemas.openxmlformats.org/drawingml/2006/main" w="0">
+            <a:noFill/>
+            <a:prstDash val="solid"/>
+          </a:ln>
+        </p:spPr>
+        <p:txBody>
+          <a:bodyPr xmlns:a="http://schemas.openxmlformats.org/drawingml/2006/main"/>
+          <a:lstStyle xmlns:a="http://schemas.openxmlformats.org/drawingml/2006/main"/>
+          <a:p xmlns:a="http://schemas.openxmlformats.org/drawingml/2006/main">
+            <a:pPr>
+              <a:defRPr sz="1200">
+                <a:solidFill>
+                  <a:srgbClr val="CBD5E1"/>
+                </a:solidFill>
+              </a:defRPr>
+            </a:pPr>
+            <a:r>
+              <a:rPr sz="1200">
+                <a:solidFill>
+                  <a:srgbClr val="CBD5E1"/>
+                </a:solidFill>
+              </a:rPr>
+              <a:t>Başın baktığı yön robotun yürüyüş niyetine çevrilir. Operatör robotu bakışla yönlendirir.</a:t>
+            </a:r>
+          </a:p>
+        </p:txBody>
+      </p:sp>
+      <p:sp>
+        <p:nvSpPr>
+          <p:cNvPr id="13" name="xr-control-index-3">
+            <a:extLst xmlns:a="http://schemas.openxmlformats.org/drawingml/2006/main">
+              <a:ext uri="{FF2B5EF4-FFF2-40B4-BE49-F238E27FC236}">
+                <a16:creationId xmlns:a16="http://schemas.microsoft.com/office/drawing/2014/main" id="{7B065A7C-ADAB-402C-B890-545E1E2FC834}"/>
+              </a:ext>
+            </a:extLst>
+          </p:cNvPr>
+          <p:cNvSpPr>
+            <a:spLocks xmlns:a="http://schemas.openxmlformats.org/drawingml/2006/main" noGrp="1"/>
+          </p:cNvSpPr>
+          <p:nvPr/>
+        </p:nvSpPr>
+        <p:spPr>
+          <a:xfrm xmlns:a="http://schemas.openxmlformats.org/drawingml/2006/main">
+            <a:off x="590550" y="5162550"/>
+            <a:ext cx="323850" cy="323850"/>
+          </a:xfrm>
+          <a:prstGeom xmlns:a="http://schemas.openxmlformats.org/drawingml/2006/main" prst="ellipse">
+            <a:avLst/>
+          </a:prstGeom>
+          <a:solidFill xmlns:a="http://schemas.openxmlformats.org/drawingml/2006/main">
+            <a:srgbClr val="F97316"/>
+          </a:solidFill>
+          <a:ln xmlns:a="http://schemas.openxmlformats.org/drawingml/2006/main" w="0">
+            <a:noFill/>
+            <a:prstDash val="solid"/>
+          </a:ln>
+        </p:spPr>
+      </p:sp>
+      <p:sp>
+        <p:nvSpPr>
+          <p:cNvPr id="14" name="xr-control-index-text-3">
+            <a:extLst xmlns:a="http://schemas.openxmlformats.org/drawingml/2006/main">
+              <a:ext uri="{FF2B5EF4-FFF2-40B4-BE49-F238E27FC236}">
+                <a16:creationId xmlns:a16="http://schemas.microsoft.com/office/drawing/2014/main" id="{76E20B3E-A826-4DAC-BDF7-A6899839F51A}"/>
+              </a:ext>
+            </a:extLst>
+          </p:cNvPr>
+          <p:cNvSpPr>
+            <a:spLocks xmlns:a="http://schemas.openxmlformats.org/drawingml/2006/main" noGrp="1"/>
+          </p:cNvSpPr>
+          <p:nvPr/>
+        </p:nvSpPr>
+        <p:spPr>
+          <a:xfrm xmlns:a="http://schemas.openxmlformats.org/drawingml/2006/main">
+            <a:off x="590550" y="5210175"/>
+            <a:ext cx="323850" cy="209550"/>
+          </a:xfrm>
+          <a:prstGeom xmlns:a="http://schemas.openxmlformats.org/drawingml/2006/main" prst="rect">
+            <a:avLst/>
+          </a:prstGeom>
+          <a:noFill xmlns:a="http://schemas.openxmlformats.org/drawingml/2006/main"/>
+          <a:ln xmlns:a="http://schemas.openxmlformats.org/drawingml/2006/main" w="0">
+            <a:noFill/>
+            <a:prstDash val="solid"/>
+          </a:ln>
+        </p:spPr>
+        <p:txBody>
+          <a:bodyPr xmlns:a="http://schemas.openxmlformats.org/drawingml/2006/main"/>
+          <a:lstStyle xmlns:a="http://schemas.openxmlformats.org/drawingml/2006/main"/>
+          <a:p xmlns:a="http://schemas.openxmlformats.org/drawingml/2006/main">
+            <a:pPr algn="ctr">
+              <a:defRPr sz="1200" b="1">
+                <a:solidFill>
+                  <a:srgbClr val="FFFFFF"/>
+                </a:solidFill>
+              </a:defRPr>
+            </a:pPr>
+            <a:r>
+              <a:rPr sz="1200" b="1">
+                <a:solidFill>
+                  <a:srgbClr val="FFFFFF"/>
+                </a:solidFill>
+              </a:rPr>
+              <a:t>3</a:t>
+            </a:r>
+          </a:p>
+        </p:txBody>
+      </p:sp>
+      <p:sp>
+        <p:nvSpPr>
+          <p:cNvPr id="15" name="xr-control-title-3">
+            <a:extLst xmlns:a="http://schemas.openxmlformats.org/drawingml/2006/main">
+              <a:ext uri="{FF2B5EF4-FFF2-40B4-BE49-F238E27FC236}">
+                <a16:creationId xmlns:a16="http://schemas.microsoft.com/office/drawing/2014/main" id="{4DE25A54-105F-4813-A6B2-F9D8C57178E2}"/>
+              </a:ext>
+            </a:extLst>
+          </p:cNvPr>
+          <p:cNvSpPr>
+            <a:spLocks xmlns:a="http://schemas.openxmlformats.org/drawingml/2006/main" noGrp="1"/>
+          </p:cNvSpPr>
+          <p:nvPr/>
+        </p:nvSpPr>
+        <p:spPr>
+          <a:xfrm xmlns:a="http://schemas.openxmlformats.org/drawingml/2006/main">
+            <a:off x="1066800" y="5143500"/>
+            <a:ext cx="3733800" cy="247650"/>
+          </a:xfrm>
+          <a:prstGeom xmlns:a="http://schemas.openxmlformats.org/drawingml/2006/main" prst="rect">
+            <a:avLst/>
+          </a:prstGeom>
+          <a:noFill xmlns:a="http://schemas.openxmlformats.org/drawingml/2006/main"/>
+          <a:ln xmlns:a="http://schemas.openxmlformats.org/drawingml/2006/main" w="0">
+            <a:noFill/>
+            <a:prstDash val="solid"/>
+          </a:ln>
+        </p:spPr>
+        <p:txBody>
+          <a:bodyPr xmlns:a="http://schemas.openxmlformats.org/drawingml/2006/main"/>
+          <a:lstStyle xmlns:a="http://schemas.openxmlformats.org/drawingml/2006/main"/>
+          <a:p xmlns:a="http://schemas.openxmlformats.org/drawingml/2006/main">
+            <a:pPr>
+              <a:defRPr sz="1500" b="1">
+                <a:solidFill>
+                  <a:srgbClr val="F8FAFC"/>
+                </a:solidFill>
+              </a:defRPr>
+            </a:pPr>
+            <a:r>
+              <a:rPr sz="1500" b="1">
+                <a:solidFill>
+                  <a:srgbClr val="F8FAFC"/>
+                </a:solidFill>
+              </a:rPr>
+              <a:t>Motion Mimic / Position Sync</a:t>
+            </a:r>
+          </a:p>
+        </p:txBody>
+      </p:sp>
+      <p:sp>
+        <p:nvSpPr>
+          <p:cNvPr id="16" name="xr-control-body-3">
+            <a:extLst xmlns:a="http://schemas.openxmlformats.org/drawingml/2006/main">
+              <a:ext uri="{FF2B5EF4-FFF2-40B4-BE49-F238E27FC236}">
+                <a16:creationId xmlns:a16="http://schemas.microsoft.com/office/drawing/2014/main" id="{8C344EE8-A8C2-44D9-919D-1BCE60C121ED}"/>
+              </a:ext>
+            </a:extLst>
+          </p:cNvPr>
+          <p:cNvSpPr>
+            <a:spLocks xmlns:a="http://schemas.openxmlformats.org/drawingml/2006/main" noGrp="1"/>
+          </p:cNvSpPr>
+          <p:nvPr/>
+        </p:nvSpPr>
+        <p:spPr>
+          <a:xfrm xmlns:a="http://schemas.openxmlformats.org/drawingml/2006/main">
+            <a:off x="1066800" y="5438775"/>
+            <a:ext cx="3790950" cy="514350"/>
+          </a:xfrm>
+          <a:prstGeom xmlns:a="http://schemas.openxmlformats.org/drawingml/2006/main" prst="rect">
+            <a:avLst/>
+          </a:prstGeom>
+          <a:noFill xmlns:a="http://schemas.openxmlformats.org/drawingml/2006/main"/>
+          <a:ln xmlns:a="http://schemas.openxmlformats.org/drawingml/2006/main" w="0">
+            <a:noFill/>
+            <a:prstDash val="solid"/>
+          </a:ln>
+        </p:spPr>
+        <p:txBody>
+          <a:bodyPr xmlns:a="http://schemas.openxmlformats.org/drawingml/2006/main"/>
+          <a:lstStyle xmlns:a="http://schemas.openxmlformats.org/drawingml/2006/main"/>
+          <a:p xmlns:a="http://schemas.openxmlformats.org/drawingml/2006/main">
+            <a:pPr>
+              <a:defRPr sz="1200">
+                <a:solidFill>
+                  <a:srgbClr val="CBD5E1"/>
+                </a:solidFill>
+              </a:defRPr>
+            </a:pPr>
+            <a:r>
+              <a:rPr sz="1200">
+                <a:solidFill>
+                  <a:srgbClr val="CBD5E1"/>
+                </a:solidFill>
+              </a:rPr>
+              <a:t>Operatörün pozisyonu ve yönelimi robot hareketine eşlenir. Telepresence hissini güçlendirir.</a:t>
+            </a:r>
+          </a:p>
+        </p:txBody>
+      </p:sp>
+      <p:pic>
+        <p:nvPicPr>
+          <p:cNvPr id="38" name=""/>
+          <p:cNvPicPr>
+            <a:picLocks xmlns:a="http://schemas.openxmlformats.org/drawingml/2006/main" noChangeAspect="1"/>
+          </p:cNvPicPr>
+          <p:nvPr/>
+        </p:nvPicPr>
+        <p:blipFill>
+          <a:blip xmlns:r="http://schemas.openxmlformats.org/officeDocument/2006/relationships" xmlns:a="http://schemas.openxmlformats.org/drawingml/2006/main" r:embed="Ra695b867f4cd46d8"/>
+          <a:srcRect xmlns:a="http://schemas.openxmlformats.org/drawingml/2006/main" l="28" t="0" r="28" b="0"/>
+          <a:stretch xmlns:a="http://schemas.openxmlformats.org/drawingml/2006/main">
+            <a:fillRect l="0" t="0" r="0" b="0"/>
+          </a:stretch>
+        </p:blipFill>
+        <p:spPr>
+          <a:xfrm xmlns:a="http://schemas.openxmlformats.org/drawingml/2006/main">
+            <a:off x="5581650" y="819150"/>
+            <a:ext cx="6191250" cy="3886200"/>
+          </a:xfrm>
+          <a:prstGeom xmlns:a="http://schemas.openxmlformats.org/drawingml/2006/main" prst="roundRect">
+            <a:avLst>
+              <a:gd name="adj" fmla="val 1961"/>
+            </a:avLst>
+          </a:prstGeom>
+        </p:spPr>
+      </p:pic>
+      <p:sp>
+        <p:nvSpPr>
+          <p:cNvPr id="18" name="xr-screenshot-outline">
+            <a:extLst xmlns:a="http://schemas.openxmlformats.org/drawingml/2006/main">
+              <a:ext uri="{FF2B5EF4-FFF2-40B4-BE49-F238E27FC236}">
+                <a16:creationId xmlns:a16="http://schemas.microsoft.com/office/drawing/2014/main" id="{3C8544A3-93A0-4302-89A7-10442316310A}"/>
+              </a:ext>
+            </a:extLst>
+          </p:cNvPr>
+          <p:cNvSpPr>
+            <a:spLocks xmlns:a="http://schemas.openxmlformats.org/drawingml/2006/main" noGrp="1"/>
+          </p:cNvSpPr>
+          <p:nvPr/>
+        </p:nvSpPr>
+        <p:spPr>
+          <a:xfrm xmlns:a="http://schemas.openxmlformats.org/drawingml/2006/main">
+            <a:off x="5581650" y="819150"/>
+            <a:ext cx="6191250" cy="3886200"/>
+          </a:xfrm>
+          <a:prstGeom xmlns:a="http://schemas.openxmlformats.org/drawingml/2006/main" prst="rect">
+            <a:avLst/>
+          </a:prstGeom>
+          <a:noFill xmlns:a="http://schemas.openxmlformats.org/drawingml/2006/main"/>
+          <a:ln xmlns:a="http://schemas.openxmlformats.org/drawingml/2006/main" w="19050">
+            <a:solidFill>
+              <a:srgbClr val="334155"/>
+            </a:solidFill>
+            <a:prstDash val="solid"/>
+          </a:ln>
+        </p:spPr>
+      </p:sp>
+      <p:sp>
+        <p:nvSpPr>
+          <p:cNvPr id="19" name="xr-caption">
+            <a:extLst xmlns:a="http://schemas.openxmlformats.org/drawingml/2006/main">
+              <a:ext uri="{FF2B5EF4-FFF2-40B4-BE49-F238E27FC236}">
+                <a16:creationId xmlns:a16="http://schemas.microsoft.com/office/drawing/2014/main" id="{C4187414-2472-4272-9FF5-67A7DD0FEEAC}"/>
+              </a:ext>
+            </a:extLst>
+          </p:cNvPr>
+          <p:cNvSpPr>
+            <a:spLocks xmlns:a="http://schemas.openxmlformats.org/drawingml/2006/main" noGrp="1"/>
+          </p:cNvSpPr>
+          <p:nvPr/>
+        </p:nvSpPr>
+        <p:spPr>
+          <a:xfrm xmlns:a="http://schemas.openxmlformats.org/drawingml/2006/main">
+            <a:off x="5600700" y="4953000"/>
+            <a:ext cx="6134100" cy="552450"/>
+          </a:xfrm>
+          <a:prstGeom xmlns:a="http://schemas.openxmlformats.org/drawingml/2006/main" prst="rect">
+            <a:avLst/>
+          </a:prstGeom>
+          <a:noFill xmlns:a="http://schemas.openxmlformats.org/drawingml/2006/main"/>
+          <a:ln xmlns:a="http://schemas.openxmlformats.org/drawingml/2006/main" w="0">
+            <a:noFill/>
+            <a:prstDash val="solid"/>
+          </a:ln>
+        </p:spPr>
+        <p:txBody>
+          <a:bodyPr xmlns:a="http://schemas.openxmlformats.org/drawingml/2006/main"/>
+          <a:lstStyle xmlns:a="http://schemas.openxmlformats.org/drawingml/2006/main"/>
+          <a:p xmlns:a="http://schemas.openxmlformats.org/drawingml/2006/main">
+            <a:pPr>
+              <a:defRPr sz="1350">
+                <a:solidFill>
+                  <a:srgbClr val="E2E8F0"/>
+                </a:solidFill>
+              </a:defRPr>
+            </a:pPr>
+            <a:r>
+              <a:rPr sz="1350">
+                <a:solidFill>
+                  <a:srgbClr val="E2E8F0"/>
+                </a:solidFill>
+              </a:rPr>
+              <a:t>Görüntüde Vision Pro arayüzü robot sahnesinin üzerine bindirilmiş: üç kontrol modu aynı seçim ekranında karşılaştırılıyor.</a:t>
+            </a:r>
+          </a:p>
+        </p:txBody>
+      </p:sp>
+      <p:sp>
+        <p:nvSpPr>
+          <p:cNvPr id="20" name="xr-bottom-band">
+            <a:extLst xmlns:a="http://schemas.openxmlformats.org/drawingml/2006/main">
+              <a:ext uri="{FF2B5EF4-FFF2-40B4-BE49-F238E27FC236}">
+                <a16:creationId xmlns:a16="http://schemas.microsoft.com/office/drawing/2014/main" id="{57876312-5A30-4144-95D1-274E33D4FFCC}"/>
+              </a:ext>
+            </a:extLst>
+          </p:cNvPr>
+          <p:cNvSpPr>
+            <a:spLocks xmlns:a="http://schemas.openxmlformats.org/drawingml/2006/main" noGrp="1"/>
+          </p:cNvSpPr>
+          <p:nvPr/>
+        </p:nvSpPr>
+        <p:spPr>
+          <a:xfrm xmlns:a="http://schemas.openxmlformats.org/drawingml/2006/main">
+            <a:off x="5581650" y="5886450"/>
+            <a:ext cx="6191250" cy="533400"/>
+          </a:xfrm>
+          <a:prstGeom xmlns:a="http://schemas.openxmlformats.org/drawingml/2006/main" prst="roundRect">
+            <a:avLst>
+              <a:gd name="adj" fmla="val 14286"/>
+            </a:avLst>
+          </a:prstGeom>
+          <a:solidFill xmlns:a="http://schemas.openxmlformats.org/drawingml/2006/main">
+            <a:srgbClr val="121923"/>
+          </a:solidFill>
+          <a:ln xmlns:a="http://schemas.openxmlformats.org/drawingml/2006/main" w="9525">
+            <a:solidFill>
+              <a:srgbClr val="1F2937"/>
+            </a:solidFill>
+            <a:prstDash val="solid"/>
+          </a:ln>
+        </p:spPr>
+      </p:sp>
+      <p:sp>
+        <p:nvSpPr>
+          <p:cNvPr id="21" name="xr-bottom-copy">
+            <a:extLst xmlns:a="http://schemas.openxmlformats.org/drawingml/2006/main">
+              <a:ext uri="{FF2B5EF4-FFF2-40B4-BE49-F238E27FC236}">
+                <a16:creationId xmlns:a16="http://schemas.microsoft.com/office/drawing/2014/main" id="{16098D38-1D12-4BC2-AC87-69FD5C764DF5}"/>
+              </a:ext>
+            </a:extLst>
+          </p:cNvPr>
+          <p:cNvSpPr>
+            <a:spLocks xmlns:a="http://schemas.openxmlformats.org/drawingml/2006/main" noGrp="1"/>
+          </p:cNvSpPr>
+          <p:nvPr/>
+        </p:nvSpPr>
+        <p:spPr>
+          <a:xfrm xmlns:a="http://schemas.openxmlformats.org/drawingml/2006/main">
+            <a:off x="5810250" y="6010275"/>
+            <a:ext cx="5753100" cy="304800"/>
+          </a:xfrm>
+          <a:prstGeom xmlns:a="http://schemas.openxmlformats.org/drawingml/2006/main" prst="rect">
+            <a:avLst/>
+          </a:prstGeom>
+          <a:noFill xmlns:a="http://schemas.openxmlformats.org/drawingml/2006/main"/>
+          <a:ln xmlns:a="http://schemas.openxmlformats.org/drawingml/2006/main" w="0">
+            <a:noFill/>
+            <a:prstDash val="solid"/>
+          </a:ln>
+        </p:spPr>
+        <p:txBody>
+          <a:bodyPr xmlns:a="http://schemas.openxmlformats.org/drawingml/2006/main"/>
+          <a:lstStyle xmlns:a="http://schemas.openxmlformats.org/drawingml/2006/main"/>
+          <a:p xmlns:a="http://schemas.openxmlformats.org/drawingml/2006/main">
+            <a:pPr>
+              <a:defRPr sz="1275" b="1">
+                <a:solidFill>
+                  <a:srgbClr val="F8FAFC"/>
+                </a:solidFill>
+              </a:defRPr>
+            </a:pPr>
+            <a:r>
+              <a:rPr sz="1275" b="1">
+                <a:solidFill>
+                  <a:srgbClr val="F8FAFC"/>
+                </a:solidFill>
+              </a:rPr>
+              <a:t>Yürütme katmanı tek bir kontrol biçimine kilitlenmez; görev, ortam ve operatör deneyimine göre mod seçilir.</a:t>
+            </a:r>
+          </a:p>
+        </p:txBody>
+      </p:sp>
+    </p:spTree>
+    <p:extLst>
+      <p:ext uri="{BB962C8B-B14F-4D97-AF65-F5344CB8AC3E}">
+        <p14:creationId xmlns:p14="http://schemas.microsoft.com/office/powerpoint/2010/main" val="1000082208"/>
       </p:ext>
     </p:extLst>
   </p:cSld>

</xml_diff>

<commit_message>
Use sharp corners for feature deck screenshots
</commit_message>
<xml_diff>
--- a/docs/presentations/Unitree-H1-Feature-Deck-v2.pptx
+++ b/docs/presentations/Unitree-H1-Feature-Deck-v2.pptx
@@ -2,18 +2,18 @@
 <file path=ppt/presentation.xml><?xml version="1.0" encoding="utf-8"?>
 <p:presentation xmlns:p="http://schemas.openxmlformats.org/presentationml/2006/main">
   <p:sldMasterIdLst>
-    <p:sldMasterId xmlns:r="http://schemas.openxmlformats.org/officeDocument/2006/relationships" id="2147483648" r:id="R69a67c41628a4c7b"/>
+    <p:sldMasterId xmlns:r="http://schemas.openxmlformats.org/officeDocument/2006/relationships" id="2147483648" r:id="R697beec15e684553"/>
   </p:sldMasterIdLst>
   <p:notesMasterIdLst>
-    <p:notesMasterId xmlns:r="http://schemas.openxmlformats.org/officeDocument/2006/relationships" r:id="R2882106d4d49460d"/>
+    <p:notesMasterId xmlns:r="http://schemas.openxmlformats.org/officeDocument/2006/relationships" r:id="R520bab3243ce489b"/>
   </p:notesMasterIdLst>
   <p:sldIdLst>
-    <p:sldId xmlns:r="http://schemas.openxmlformats.org/officeDocument/2006/relationships" id="256" r:id="Rbbd5296270174321"/>
-    <p:sldId xmlns:r="http://schemas.openxmlformats.org/officeDocument/2006/relationships" id="257" r:id="Rc425f46042aa4b37"/>
-    <p:sldId xmlns:r="http://schemas.openxmlformats.org/officeDocument/2006/relationships" id="258" r:id="Re93d5aeaa3104f7d"/>
-    <p:sldId xmlns:r="http://schemas.openxmlformats.org/officeDocument/2006/relationships" id="259" r:id="R11b17c7f41bd40ef"/>
-    <p:sldId xmlns:r="http://schemas.openxmlformats.org/officeDocument/2006/relationships" id="260" r:id="Re49bb65af09a4de8"/>
-    <p:sldId xmlns:r="http://schemas.openxmlformats.org/officeDocument/2006/relationships" id="261" r:id="Rc98da57abb9e4265"/>
+    <p:sldId xmlns:r="http://schemas.openxmlformats.org/officeDocument/2006/relationships" id="256" r:id="R3828bd6318f244e0"/>
+    <p:sldId xmlns:r="http://schemas.openxmlformats.org/officeDocument/2006/relationships" id="257" r:id="R2ffae0b2eaa74164"/>
+    <p:sldId xmlns:r="http://schemas.openxmlformats.org/officeDocument/2006/relationships" id="258" r:id="R2456f8c7f8f54263"/>
+    <p:sldId xmlns:r="http://schemas.openxmlformats.org/officeDocument/2006/relationships" id="259" r:id="Rb83169189250418a"/>
+    <p:sldId xmlns:r="http://schemas.openxmlformats.org/officeDocument/2006/relationships" id="260" r:id="Rba7e633c23594265"/>
+    <p:sldId xmlns:r="http://schemas.openxmlformats.org/officeDocument/2006/relationships" id="261" r:id="R6fda93389eab459a"/>
   </p:sldIdLst>
   <p:sldSz cx="12192000" cy="6858000"/>
   <p:notesSz cx="6858000" cy="9144000"/>
@@ -936,7 +936,7 @@
   </p:cSld>
   <p:clrMap bg1="lt1" tx1="dk1" bg2="lt2" tx2="dk2" accent1="accent1" accent2="accent2" accent3="accent3" accent4="accent4" accent5="accent5" accent6="accent6" hlink="hlink" folHlink="folHlink"/>
   <p:sldLayoutIdLst>
-    <p:sldLayoutId xmlns:r="http://schemas.openxmlformats.org/officeDocument/2006/relationships" id="2147483649" r:id="R4efde446fdfa4066"/>
+    <p:sldLayoutId xmlns:r="http://schemas.openxmlformats.org/officeDocument/2006/relationships" id="2147483649" r:id="R3c589f2e177d4778"/>
   </p:sldLayoutIdLst>
   <p:txStyles>
     <p:titleStyle>
@@ -1644,7 +1644,7 @@
           <p:nvPr/>
         </p:nvPicPr>
         <p:blipFill>
-          <a:blip xmlns:r="http://schemas.openxmlformats.org/officeDocument/2006/relationships" xmlns:a="http://schemas.openxmlformats.org/drawingml/2006/main" r:embed="R0abf596416d14bcd"/>
+          <a:blip xmlns:r="http://schemas.openxmlformats.org/officeDocument/2006/relationships" xmlns:a="http://schemas.openxmlformats.org/drawingml/2006/main" r:embed="R35a5c6a52f7544dd"/>
           <a:srcRect xmlns:a="http://schemas.openxmlformats.org/drawingml/2006/main" l="0" t="30309" r="0" b="30309"/>
           <a:stretch xmlns:a="http://schemas.openxmlformats.org/drawingml/2006/main">
             <a:fillRect l="0" t="0" r="0" b="0"/>
@@ -2241,7 +2241,7 @@
           <p:nvPr/>
         </p:nvPicPr>
         <p:blipFill>
-          <a:blip xmlns:r="http://schemas.openxmlformats.org/officeDocument/2006/relationships" xmlns:a="http://schemas.openxmlformats.org/drawingml/2006/main" r:embed="R6e1062985aa147f8"/>
+          <a:blip xmlns:r="http://schemas.openxmlformats.org/officeDocument/2006/relationships" xmlns:a="http://schemas.openxmlformats.org/drawingml/2006/main" r:embed="R901a454a95cd4a61"/>
           <a:srcRect xmlns:a="http://schemas.openxmlformats.org/drawingml/2006/main" l="0" t="6000" r="0" b="6000"/>
           <a:stretch xmlns:a="http://schemas.openxmlformats.org/drawingml/2006/main">
             <a:fillRect l="0" t="0" r="0" b="0"/>
@@ -2266,7 +2266,7 @@
           <p:nvPr/>
         </p:nvPicPr>
         <p:blipFill>
-          <a:blip xmlns:r="http://schemas.openxmlformats.org/officeDocument/2006/relationships" xmlns:a="http://schemas.openxmlformats.org/drawingml/2006/main" r:embed="R416bf31f03804927"/>
+          <a:blip xmlns:r="http://schemas.openxmlformats.org/officeDocument/2006/relationships" xmlns:a="http://schemas.openxmlformats.org/drawingml/2006/main" r:embed="Rc58ca7af93254888"/>
           <a:srcRect xmlns:a="http://schemas.openxmlformats.org/drawingml/2006/main" l="0" t="6000" r="0" b="6000"/>
           <a:stretch xmlns:a="http://schemas.openxmlformats.org/drawingml/2006/main">
             <a:fillRect l="0" t="0" r="0" b="0"/>
@@ -2291,7 +2291,7 @@
           <p:nvPr/>
         </p:nvPicPr>
         <p:blipFill>
-          <a:blip xmlns:r="http://schemas.openxmlformats.org/officeDocument/2006/relationships" xmlns:a="http://schemas.openxmlformats.org/drawingml/2006/main" r:embed="R8e20d10087ea4fd2"/>
+          <a:blip xmlns:r="http://schemas.openxmlformats.org/officeDocument/2006/relationships" xmlns:a="http://schemas.openxmlformats.org/drawingml/2006/main" r:embed="R072d7830247d4b39"/>
           <a:srcRect xmlns:a="http://schemas.openxmlformats.org/drawingml/2006/main" l="0" t="6000" r="0" b="6000"/>
           <a:stretch xmlns:a="http://schemas.openxmlformats.org/drawingml/2006/main">
             <a:fillRect l="0" t="0" r="0" b="0"/>
@@ -2582,7 +2582,7 @@
           <p:nvPr/>
         </p:nvPicPr>
         <p:blipFill>
-          <a:blip xmlns:r="http://schemas.openxmlformats.org/officeDocument/2006/relationships" xmlns:a="http://schemas.openxmlformats.org/drawingml/2006/main" r:embed="R7357772901a44df0"/>
+          <a:blip xmlns:r="http://schemas.openxmlformats.org/officeDocument/2006/relationships" xmlns:a="http://schemas.openxmlformats.org/drawingml/2006/main" r:embed="R02ae4d53a3c94884"/>
           <a:srcRect xmlns:a="http://schemas.openxmlformats.org/drawingml/2006/main" l="18895" t="0" r="18895" b="0"/>
           <a:stretch xmlns:a="http://schemas.openxmlformats.org/drawingml/2006/main">
             <a:fillRect l="0" t="0" r="0" b="0"/>
@@ -3261,7 +3261,7 @@
           <p:nvPr/>
         </p:nvPicPr>
         <p:blipFill>
-          <a:blip xmlns:r="http://schemas.openxmlformats.org/officeDocument/2006/relationships" xmlns:a="http://schemas.openxmlformats.org/drawingml/2006/main" r:embed="R61af4a82a01e4bfe"/>
+          <a:blip xmlns:r="http://schemas.openxmlformats.org/officeDocument/2006/relationships" xmlns:a="http://schemas.openxmlformats.org/drawingml/2006/main" r:embed="Rf7cefc1a84954155"/>
           <a:srcRect xmlns:a="http://schemas.openxmlformats.org/drawingml/2006/main" l="0" t="2134" r="0" b="2134"/>
           <a:stretch xmlns:a="http://schemas.openxmlformats.org/drawingml/2006/main">
             <a:fillRect l="0" t="0" r="0" b="0"/>
@@ -3286,7 +3286,7 @@
           <p:nvPr/>
         </p:nvPicPr>
         <p:blipFill>
-          <a:blip xmlns:r="http://schemas.openxmlformats.org/officeDocument/2006/relationships" xmlns:a="http://schemas.openxmlformats.org/drawingml/2006/main" r:embed="R3f71a3990b064d12"/>
+          <a:blip xmlns:r="http://schemas.openxmlformats.org/officeDocument/2006/relationships" xmlns:a="http://schemas.openxmlformats.org/drawingml/2006/main" r:embed="R19fc915154654e77"/>
           <a:srcRect xmlns:a="http://schemas.openxmlformats.org/drawingml/2006/main" l="0" t="2134" r="0" b="2134"/>
           <a:stretch xmlns:a="http://schemas.openxmlformats.org/drawingml/2006/main">
             <a:fillRect l="0" t="0" r="0" b="0"/>
@@ -3311,7 +3311,7 @@
           <p:nvPr/>
         </p:nvPicPr>
         <p:blipFill>
-          <a:blip xmlns:r="http://schemas.openxmlformats.org/officeDocument/2006/relationships" xmlns:a="http://schemas.openxmlformats.org/drawingml/2006/main" r:embed="Re883d2665de84d87"/>
+          <a:blip xmlns:r="http://schemas.openxmlformats.org/officeDocument/2006/relationships" xmlns:a="http://schemas.openxmlformats.org/drawingml/2006/main" r:embed="R557c9eb9071a4cfc"/>
           <a:srcRect xmlns:a="http://schemas.openxmlformats.org/drawingml/2006/main" l="0" t="2134" r="0" b="2134"/>
           <a:stretch xmlns:a="http://schemas.openxmlformats.org/drawingml/2006/main">
             <a:fillRect l="0" t="0" r="0" b="0"/>
@@ -4395,7 +4395,7 @@
           <p:nvPr/>
         </p:nvPicPr>
         <p:blipFill>
-          <a:blip xmlns:r="http://schemas.openxmlformats.org/officeDocument/2006/relationships" xmlns:a="http://schemas.openxmlformats.org/drawingml/2006/main" r:embed="R704078eaa1e04be1"/>
+          <a:blip xmlns:r="http://schemas.openxmlformats.org/officeDocument/2006/relationships" xmlns:a="http://schemas.openxmlformats.org/drawingml/2006/main" r:embed="Refaf110127554146"/>
           <a:stretch xmlns:a="http://schemas.openxmlformats.org/drawingml/2006/main"/>
         </p:blipFill>
         <p:spPr>
@@ -4403,7 +4403,7 @@
             <a:off x="5623031" y="685800"/>
             <a:ext cx="6089438" cy="4419600"/>
           </a:xfrm>
-          <a:prstGeom xmlns:a="http://schemas.openxmlformats.org/drawingml/2006/main" prst="roundRect">
+          <a:prstGeom xmlns:a="http://schemas.openxmlformats.org/drawingml/2006/main" prst="rect">
             <a:avLst/>
           </a:prstGeom>
         </p:spPr>
@@ -4669,6 +4669,7 @@
           <a:lstStyle xmlns:a="http://schemas.openxmlformats.org/drawingml/2006/main"/>
           <a:p xmlns:a="http://schemas.openxmlformats.org/drawingml/2006/main">
             <a:pPr>
+              <a:buNone/>
               <a:defRPr sz="1050" b="1">
                 <a:solidFill>
                   <a:srgbClr val="38BDF8"/>
@@ -4719,6 +4720,7 @@
           <a:lstStyle xmlns:a="http://schemas.openxmlformats.org/drawingml/2006/main"/>
           <a:p xmlns:a="http://schemas.openxmlformats.org/drawingml/2006/main">
             <a:pPr>
+              <a:buNone/>
               <a:defRPr sz="3150" b="1">
                 <a:solidFill>
                   <a:srgbClr val="FFFFFF"/>
@@ -4736,6 +4738,7 @@
           </a:p>
           <a:p xmlns:a="http://schemas.openxmlformats.org/drawingml/2006/main">
             <a:pPr>
+              <a:buNone/>
               <a:defRPr sz="3150" b="1">
                 <a:solidFill>
                   <a:srgbClr val="FFFFFF"/>
@@ -4786,6 +4789,7 @@
           <a:lstStyle xmlns:a="http://schemas.openxmlformats.org/drawingml/2006/main"/>
           <a:p xmlns:a="http://schemas.openxmlformats.org/drawingml/2006/main">
             <a:pPr>
+              <a:buNone/>
               <a:defRPr sz="1350">
                 <a:solidFill>
                   <a:srgbClr val="CBD5E1"/>
@@ -4867,6 +4871,7 @@
           <a:lstStyle xmlns:a="http://schemas.openxmlformats.org/drawingml/2006/main"/>
           <a:p xmlns:a="http://schemas.openxmlformats.org/drawingml/2006/main">
             <a:pPr algn="ctr">
+              <a:buNone/>
               <a:defRPr sz="1200" b="1">
                 <a:solidFill>
                   <a:srgbClr val="FFFFFF"/>
@@ -4917,6 +4922,7 @@
           <a:lstStyle xmlns:a="http://schemas.openxmlformats.org/drawingml/2006/main"/>
           <a:p xmlns:a="http://schemas.openxmlformats.org/drawingml/2006/main">
             <a:pPr>
+              <a:buNone/>
               <a:defRPr sz="1500" b="1">
                 <a:solidFill>
                   <a:srgbClr val="F8FAFC"/>
@@ -4967,6 +4973,7 @@
           <a:lstStyle xmlns:a="http://schemas.openxmlformats.org/drawingml/2006/main"/>
           <a:p xmlns:a="http://schemas.openxmlformats.org/drawingml/2006/main">
             <a:pPr>
+              <a:buNone/>
               <a:defRPr sz="1200">
                 <a:solidFill>
                   <a:srgbClr val="CBD5E1"/>
@@ -5048,6 +5055,7 @@
           <a:lstStyle xmlns:a="http://schemas.openxmlformats.org/drawingml/2006/main"/>
           <a:p xmlns:a="http://schemas.openxmlformats.org/drawingml/2006/main">
             <a:pPr algn="ctr">
+              <a:buNone/>
               <a:defRPr sz="1200" b="1">
                 <a:solidFill>
                   <a:srgbClr val="FFFFFF"/>
@@ -5098,6 +5106,7 @@
           <a:lstStyle xmlns:a="http://schemas.openxmlformats.org/drawingml/2006/main"/>
           <a:p xmlns:a="http://schemas.openxmlformats.org/drawingml/2006/main">
             <a:pPr>
+              <a:buNone/>
               <a:defRPr sz="1500" b="1">
                 <a:solidFill>
                   <a:srgbClr val="F8FAFC"/>
@@ -5148,6 +5157,7 @@
           <a:lstStyle xmlns:a="http://schemas.openxmlformats.org/drawingml/2006/main"/>
           <a:p xmlns:a="http://schemas.openxmlformats.org/drawingml/2006/main">
             <a:pPr>
+              <a:buNone/>
               <a:defRPr sz="1200">
                 <a:solidFill>
                   <a:srgbClr val="CBD5E1"/>
@@ -5229,6 +5239,7 @@
           <a:lstStyle xmlns:a="http://schemas.openxmlformats.org/drawingml/2006/main"/>
           <a:p xmlns:a="http://schemas.openxmlformats.org/drawingml/2006/main">
             <a:pPr algn="ctr">
+              <a:buNone/>
               <a:defRPr sz="1200" b="1">
                 <a:solidFill>
                   <a:srgbClr val="FFFFFF"/>
@@ -5279,6 +5290,7 @@
           <a:lstStyle xmlns:a="http://schemas.openxmlformats.org/drawingml/2006/main"/>
           <a:p xmlns:a="http://schemas.openxmlformats.org/drawingml/2006/main">
             <a:pPr>
+              <a:buNone/>
               <a:defRPr sz="1500" b="1">
                 <a:solidFill>
                   <a:srgbClr val="F8FAFC"/>
@@ -5329,6 +5341,7 @@
           <a:lstStyle xmlns:a="http://schemas.openxmlformats.org/drawingml/2006/main"/>
           <a:p xmlns:a="http://schemas.openxmlformats.org/drawingml/2006/main">
             <a:pPr>
+              <a:buNone/>
               <a:defRPr sz="1200">
                 <a:solidFill>
                   <a:srgbClr val="CBD5E1"/>
@@ -5348,14 +5361,14 @@
       </p:sp>
       <p:pic>
         <p:nvPicPr>
-          <p:cNvPr id="38" name=""/>
+          <p:cNvPr id="39" name=""/>
           <p:cNvPicPr>
             <a:picLocks xmlns:a="http://schemas.openxmlformats.org/drawingml/2006/main" noChangeAspect="1"/>
           </p:cNvPicPr>
           <p:nvPr/>
         </p:nvPicPr>
         <p:blipFill>
-          <a:blip xmlns:r="http://schemas.openxmlformats.org/officeDocument/2006/relationships" xmlns:a="http://schemas.openxmlformats.org/drawingml/2006/main" r:embed="Ra695b867f4cd46d8"/>
+          <a:blip xmlns:r="http://schemas.openxmlformats.org/officeDocument/2006/relationships" xmlns:a="http://schemas.openxmlformats.org/drawingml/2006/main" r:embed="R96e27fb6c1534558"/>
           <a:srcRect xmlns:a="http://schemas.openxmlformats.org/drawingml/2006/main" l="28" t="0" r="28" b="0"/>
           <a:stretch xmlns:a="http://schemas.openxmlformats.org/drawingml/2006/main">
             <a:fillRect l="0" t="0" r="0" b="0"/>
@@ -5366,10 +5379,8 @@
             <a:off x="5581650" y="819150"/>
             <a:ext cx="6191250" cy="3886200"/>
           </a:xfrm>
-          <a:prstGeom xmlns:a="http://schemas.openxmlformats.org/drawingml/2006/main" prst="roundRect">
-            <a:avLst>
-              <a:gd name="adj" fmla="val 1961"/>
-            </a:avLst>
+          <a:prstGeom xmlns:a="http://schemas.openxmlformats.org/drawingml/2006/main" prst="rect">
+            <a:avLst/>
           </a:prstGeom>
         </p:spPr>
       </p:pic>
@@ -5437,6 +5448,7 @@
           <a:lstStyle xmlns:a="http://schemas.openxmlformats.org/drawingml/2006/main"/>
           <a:p xmlns:a="http://schemas.openxmlformats.org/drawingml/2006/main">
             <a:pPr>
+              <a:buNone/>
               <a:defRPr sz="1350">
                 <a:solidFill>
                   <a:srgbClr val="E2E8F0"/>
@@ -5522,6 +5534,7 @@
           <a:lstStyle xmlns:a="http://schemas.openxmlformats.org/drawingml/2006/main"/>
           <a:p xmlns:a="http://schemas.openxmlformats.org/drawingml/2006/main">
             <a:pPr>
+              <a:buNone/>
               <a:defRPr sz="1275" b="1">
                 <a:solidFill>
                   <a:srgbClr val="F8FAFC"/>

</xml_diff>

<commit_message>
Add non-teleoperation feature summary slide
</commit_message>
<xml_diff>
--- a/docs/presentations/Unitree-H1-Feature-Deck-v2.pptx
+++ b/docs/presentations/Unitree-H1-Feature-Deck-v2.pptx
@@ -2,18 +2,19 @@
 <file path=ppt/presentation.xml><?xml version="1.0" encoding="utf-8"?>
 <p:presentation xmlns:p="http://schemas.openxmlformats.org/presentationml/2006/main">
   <p:sldMasterIdLst>
-    <p:sldMasterId xmlns:r="http://schemas.openxmlformats.org/officeDocument/2006/relationships" id="2147483648" r:id="R697beec15e684553"/>
+    <p:sldMasterId xmlns:r="http://schemas.openxmlformats.org/officeDocument/2006/relationships" id="2147483648" r:id="Rf5a708c8af804834"/>
   </p:sldMasterIdLst>
   <p:notesMasterIdLst>
-    <p:notesMasterId xmlns:r="http://schemas.openxmlformats.org/officeDocument/2006/relationships" r:id="R520bab3243ce489b"/>
+    <p:notesMasterId xmlns:r="http://schemas.openxmlformats.org/officeDocument/2006/relationships" r:id="R483f10ac9baf40ac"/>
   </p:notesMasterIdLst>
   <p:sldIdLst>
-    <p:sldId xmlns:r="http://schemas.openxmlformats.org/officeDocument/2006/relationships" id="256" r:id="R3828bd6318f244e0"/>
-    <p:sldId xmlns:r="http://schemas.openxmlformats.org/officeDocument/2006/relationships" id="257" r:id="R2ffae0b2eaa74164"/>
-    <p:sldId xmlns:r="http://schemas.openxmlformats.org/officeDocument/2006/relationships" id="258" r:id="R2456f8c7f8f54263"/>
-    <p:sldId xmlns:r="http://schemas.openxmlformats.org/officeDocument/2006/relationships" id="259" r:id="Rb83169189250418a"/>
-    <p:sldId xmlns:r="http://schemas.openxmlformats.org/officeDocument/2006/relationships" id="260" r:id="Rba7e633c23594265"/>
-    <p:sldId xmlns:r="http://schemas.openxmlformats.org/officeDocument/2006/relationships" id="261" r:id="R6fda93389eab459a"/>
+    <p:sldId xmlns:r="http://schemas.openxmlformats.org/officeDocument/2006/relationships" id="256" r:id="R928ba754636a4340"/>
+    <p:sldId xmlns:r="http://schemas.openxmlformats.org/officeDocument/2006/relationships" id="257" r:id="R9026cdac201a432e"/>
+    <p:sldId xmlns:r="http://schemas.openxmlformats.org/officeDocument/2006/relationships" id="258" r:id="R369ffc431f9f4686"/>
+    <p:sldId xmlns:r="http://schemas.openxmlformats.org/officeDocument/2006/relationships" id="259" r:id="R06519c45a0d24cdf"/>
+    <p:sldId xmlns:r="http://schemas.openxmlformats.org/officeDocument/2006/relationships" id="260" r:id="R3f389624006c4893"/>
+    <p:sldId xmlns:r="http://schemas.openxmlformats.org/officeDocument/2006/relationships" id="261" r:id="R7807236170ec4aa3"/>
+    <p:sldId xmlns:r="http://schemas.openxmlformats.org/officeDocument/2006/relationships" id="262" r:id="R1aa9750fa83f43a8"/>
   </p:sldIdLst>
   <p:sldSz cx="12192000" cy="6858000"/>
   <p:notesSz cx="6858000" cy="9144000"/>
@@ -898,6 +899,72 @@
 </p:notes>
 </file>
 
+<file path=ppt/notesSlides/notesSlide7.xml><?xml version="1.0" encoding="utf-8"?>
+<p:notes xmlns:p="http://schemas.openxmlformats.org/presentationml/2006/main">
+  <p:cSld>
+    <p:spTree>
+      <p:nvGrpSpPr>
+        <p:cNvPr id="1" name=""/>
+        <p:cNvGrpSpPr/>
+        <p:nvPr/>
+      </p:nvGrpSpPr>
+      <p:grpSpPr>
+        <a:xfrm xmlns:a="http://schemas.openxmlformats.org/drawingml/2006/main"/>
+      </p:grpSpPr>
+      <p:sp>
+        <p:nvSpPr>
+          <p:cNvPr id="2" name="Slide Image Placeholder 1"/>
+          <p:cNvSpPr>
+            <a:spLocks xmlns:a="http://schemas.openxmlformats.org/drawingml/2006/main" noGrp="1"/>
+          </p:cNvSpPr>
+          <p:nvPr>
+            <p:ph type="sldImg" idx="0"/>
+          </p:nvPr>
+        </p:nvSpPr>
+        <p:spPr/>
+      </p:sp>
+      <p:sp>
+        <p:nvSpPr>
+          <p:cNvPr id="3" name="Notes Placeholder 2"/>
+          <p:cNvSpPr>
+            <a:spLocks xmlns:a="http://schemas.openxmlformats.org/drawingml/2006/main" noGrp="1"/>
+          </p:cNvSpPr>
+          <p:nvPr>
+            <p:ph type="body" idx="1"/>
+          </p:nvPr>
+        </p:nvSpPr>
+        <p:spPr/>
+        <p:txBody>
+          <a:bodyPr xmlns:a="http://schemas.openxmlformats.org/drawingml/2006/main"/>
+          <a:lstStyle xmlns:a="http://schemas.openxmlformats.org/drawingml/2006/main"/>
+          <a:p xmlns:a="http://schemas.openxmlformats.org/drawingml/2006/main"/>
+        </p:txBody>
+      </p:sp>
+      <p:sp>
+        <p:nvSpPr>
+          <p:cNvPr id="4" name="Slide Number Placeholder 3"/>
+          <p:cNvSpPr>
+            <a:spLocks xmlns:a="http://schemas.openxmlformats.org/drawingml/2006/main" noGrp="1"/>
+          </p:cNvSpPr>
+          <p:nvPr>
+            <p:ph type="sldNum" idx="5"/>
+          </p:nvPr>
+        </p:nvSpPr>
+        <p:spPr/>
+        <p:txBody>
+          <a:bodyPr xmlns:a="http://schemas.openxmlformats.org/drawingml/2006/main"/>
+          <a:lstStyle xmlns:a="http://schemas.openxmlformats.org/drawingml/2006/main"/>
+          <a:p xmlns:a="http://schemas.openxmlformats.org/drawingml/2006/main"/>
+        </p:txBody>
+      </p:sp>
+    </p:spTree>
+  </p:cSld>
+  <p:clrMapOvr>
+    <a:masterClrMapping xmlns:a="http://schemas.openxmlformats.org/drawingml/2006/main"/>
+  </p:clrMapOvr>
+</p:notes>
+</file>
+
 <file path=ppt/slideLayouts/slideLayout1.xml><?xml version="1.0" encoding="utf-8"?>
 <p:sldLayout xmlns:p="http://schemas.openxmlformats.org/presentationml/2006/main" type="title">
   <p:cSld name="Title Slide">
@@ -936,7 +1003,7 @@
   </p:cSld>
   <p:clrMap bg1="lt1" tx1="dk1" bg2="lt2" tx2="dk2" accent1="accent1" accent2="accent2" accent3="accent3" accent4="accent4" accent5="accent5" accent6="accent6" hlink="hlink" folHlink="folHlink"/>
   <p:sldLayoutIdLst>
-    <p:sldLayoutId xmlns:r="http://schemas.openxmlformats.org/officeDocument/2006/relationships" id="2147483649" r:id="R3c589f2e177d4778"/>
+    <p:sldLayoutId xmlns:r="http://schemas.openxmlformats.org/officeDocument/2006/relationships" id="2147483649" r:id="R2263436caf824c8f"/>
   </p:sldLayoutIdLst>
   <p:txStyles>
     <p:titleStyle>
@@ -1644,7 +1711,7 @@
           <p:nvPr/>
         </p:nvPicPr>
         <p:blipFill>
-          <a:blip xmlns:r="http://schemas.openxmlformats.org/officeDocument/2006/relationships" xmlns:a="http://schemas.openxmlformats.org/drawingml/2006/main" r:embed="R35a5c6a52f7544dd"/>
+          <a:blip xmlns:r="http://schemas.openxmlformats.org/officeDocument/2006/relationships" xmlns:a="http://schemas.openxmlformats.org/drawingml/2006/main" r:embed="Rda6126f5332b4f33"/>
           <a:srcRect xmlns:a="http://schemas.openxmlformats.org/drawingml/2006/main" l="0" t="30309" r="0" b="30309"/>
           <a:stretch xmlns:a="http://schemas.openxmlformats.org/drawingml/2006/main">
             <a:fillRect l="0" t="0" r="0" b="0"/>
@@ -2241,7 +2308,7 @@
           <p:nvPr/>
         </p:nvPicPr>
         <p:blipFill>
-          <a:blip xmlns:r="http://schemas.openxmlformats.org/officeDocument/2006/relationships" xmlns:a="http://schemas.openxmlformats.org/drawingml/2006/main" r:embed="R901a454a95cd4a61"/>
+          <a:blip xmlns:r="http://schemas.openxmlformats.org/officeDocument/2006/relationships" xmlns:a="http://schemas.openxmlformats.org/drawingml/2006/main" r:embed="Rd379307b234445dd"/>
           <a:srcRect xmlns:a="http://schemas.openxmlformats.org/drawingml/2006/main" l="0" t="6000" r="0" b="6000"/>
           <a:stretch xmlns:a="http://schemas.openxmlformats.org/drawingml/2006/main">
             <a:fillRect l="0" t="0" r="0" b="0"/>
@@ -2266,7 +2333,7 @@
           <p:nvPr/>
         </p:nvPicPr>
         <p:blipFill>
-          <a:blip xmlns:r="http://schemas.openxmlformats.org/officeDocument/2006/relationships" xmlns:a="http://schemas.openxmlformats.org/drawingml/2006/main" r:embed="Rc58ca7af93254888"/>
+          <a:blip xmlns:r="http://schemas.openxmlformats.org/officeDocument/2006/relationships" xmlns:a="http://schemas.openxmlformats.org/drawingml/2006/main" r:embed="Rb18991a7f6c048e5"/>
           <a:srcRect xmlns:a="http://schemas.openxmlformats.org/drawingml/2006/main" l="0" t="6000" r="0" b="6000"/>
           <a:stretch xmlns:a="http://schemas.openxmlformats.org/drawingml/2006/main">
             <a:fillRect l="0" t="0" r="0" b="0"/>
@@ -2291,7 +2358,7 @@
           <p:nvPr/>
         </p:nvPicPr>
         <p:blipFill>
-          <a:blip xmlns:r="http://schemas.openxmlformats.org/officeDocument/2006/relationships" xmlns:a="http://schemas.openxmlformats.org/drawingml/2006/main" r:embed="R072d7830247d4b39"/>
+          <a:blip xmlns:r="http://schemas.openxmlformats.org/officeDocument/2006/relationships" xmlns:a="http://schemas.openxmlformats.org/drawingml/2006/main" r:embed="Rc08720ab3be146bc"/>
           <a:srcRect xmlns:a="http://schemas.openxmlformats.org/drawingml/2006/main" l="0" t="6000" r="0" b="6000"/>
           <a:stretch xmlns:a="http://schemas.openxmlformats.org/drawingml/2006/main">
             <a:fillRect l="0" t="0" r="0" b="0"/>
@@ -2582,7 +2649,7 @@
           <p:nvPr/>
         </p:nvPicPr>
         <p:blipFill>
-          <a:blip xmlns:r="http://schemas.openxmlformats.org/officeDocument/2006/relationships" xmlns:a="http://schemas.openxmlformats.org/drawingml/2006/main" r:embed="R02ae4d53a3c94884"/>
+          <a:blip xmlns:r="http://schemas.openxmlformats.org/officeDocument/2006/relationships" xmlns:a="http://schemas.openxmlformats.org/drawingml/2006/main" r:embed="Rac50aaae81734013"/>
           <a:srcRect xmlns:a="http://schemas.openxmlformats.org/drawingml/2006/main" l="18895" t="0" r="18895" b="0"/>
           <a:stretch xmlns:a="http://schemas.openxmlformats.org/drawingml/2006/main">
             <a:fillRect l="0" t="0" r="0" b="0"/>
@@ -3261,7 +3328,7 @@
           <p:nvPr/>
         </p:nvPicPr>
         <p:blipFill>
-          <a:blip xmlns:r="http://schemas.openxmlformats.org/officeDocument/2006/relationships" xmlns:a="http://schemas.openxmlformats.org/drawingml/2006/main" r:embed="Rf7cefc1a84954155"/>
+          <a:blip xmlns:r="http://schemas.openxmlformats.org/officeDocument/2006/relationships" xmlns:a="http://schemas.openxmlformats.org/drawingml/2006/main" r:embed="R90709b062ca5488e"/>
           <a:srcRect xmlns:a="http://schemas.openxmlformats.org/drawingml/2006/main" l="0" t="2134" r="0" b="2134"/>
           <a:stretch xmlns:a="http://schemas.openxmlformats.org/drawingml/2006/main">
             <a:fillRect l="0" t="0" r="0" b="0"/>
@@ -3286,7 +3353,7 @@
           <p:nvPr/>
         </p:nvPicPr>
         <p:blipFill>
-          <a:blip xmlns:r="http://schemas.openxmlformats.org/officeDocument/2006/relationships" xmlns:a="http://schemas.openxmlformats.org/drawingml/2006/main" r:embed="R19fc915154654e77"/>
+          <a:blip xmlns:r="http://schemas.openxmlformats.org/officeDocument/2006/relationships" xmlns:a="http://schemas.openxmlformats.org/drawingml/2006/main" r:embed="R554111e387914a7c"/>
           <a:srcRect xmlns:a="http://schemas.openxmlformats.org/drawingml/2006/main" l="0" t="2134" r="0" b="2134"/>
           <a:stretch xmlns:a="http://schemas.openxmlformats.org/drawingml/2006/main">
             <a:fillRect l="0" t="0" r="0" b="0"/>
@@ -3311,7 +3378,7 @@
           <p:nvPr/>
         </p:nvPicPr>
         <p:blipFill>
-          <a:blip xmlns:r="http://schemas.openxmlformats.org/officeDocument/2006/relationships" xmlns:a="http://schemas.openxmlformats.org/drawingml/2006/main" r:embed="R557c9eb9071a4cfc"/>
+          <a:blip xmlns:r="http://schemas.openxmlformats.org/officeDocument/2006/relationships" xmlns:a="http://schemas.openxmlformats.org/drawingml/2006/main" r:embed="R68604bdef6d74394"/>
           <a:srcRect xmlns:a="http://schemas.openxmlformats.org/drawingml/2006/main" l="0" t="2134" r="0" b="2134"/>
           <a:stretch xmlns:a="http://schemas.openxmlformats.org/drawingml/2006/main">
             <a:fillRect l="0" t="0" r="0" b="0"/>
@@ -4395,7 +4462,7 @@
           <p:nvPr/>
         </p:nvPicPr>
         <p:blipFill>
-          <a:blip xmlns:r="http://schemas.openxmlformats.org/officeDocument/2006/relationships" xmlns:a="http://schemas.openxmlformats.org/drawingml/2006/main" r:embed="Refaf110127554146"/>
+          <a:blip xmlns:r="http://schemas.openxmlformats.org/officeDocument/2006/relationships" xmlns:a="http://schemas.openxmlformats.org/drawingml/2006/main" r:embed="Re539b7c951f3428b"/>
           <a:stretch xmlns:a="http://schemas.openxmlformats.org/drawingml/2006/main"/>
         </p:blipFill>
         <p:spPr>
@@ -5368,7 +5435,7 @@
           <p:nvPr/>
         </p:nvPicPr>
         <p:blipFill>
-          <a:blip xmlns:r="http://schemas.openxmlformats.org/officeDocument/2006/relationships" xmlns:a="http://schemas.openxmlformats.org/drawingml/2006/main" r:embed="R96e27fb6c1534558"/>
+          <a:blip xmlns:r="http://schemas.openxmlformats.org/officeDocument/2006/relationships" xmlns:a="http://schemas.openxmlformats.org/drawingml/2006/main" r:embed="R9cec525d4b6745dd"/>
           <a:srcRect xmlns:a="http://schemas.openxmlformats.org/drawingml/2006/main" l="28" t="0" r="28" b="0"/>
           <a:stretch xmlns:a="http://schemas.openxmlformats.org/drawingml/2006/main">
             <a:fillRect l="0" t="0" r="0" b="0"/>
@@ -5556,6 +5623,1910 @@
     <p:extLst>
       <p:ext uri="{BB962C8B-B14F-4D97-AF65-F5344CB8AC3E}">
         <p14:creationId xmlns:p14="http://schemas.microsoft.com/office/powerpoint/2010/main" val="1000082208"/>
+      </p:ext>
+    </p:extLst>
+  </p:cSld>
+</p:sld>
+</file>
+
+<file path=ppt/slides/slide7.xml><?xml version="1.0" encoding="utf-8"?>
+<p:sld xmlns:p="http://schemas.openxmlformats.org/presentationml/2006/main">
+  <p:cSld>
+    <p:bg>
+      <p:bgPr>
+        <a:solidFill xmlns:a="http://schemas.openxmlformats.org/drawingml/2006/main">
+          <a:srgbClr val="F8FAFC"/>
+        </a:solidFill>
+      </p:bgPr>
+    </p:bg>
+    <p:spTree>
+      <p:nvGrpSpPr>
+        <p:cNvPr id="1" name=""/>
+        <p:cNvGrpSpPr/>
+        <p:nvPr/>
+      </p:nvGrpSpPr>
+      <p:grpSpPr>
+        <a:xfrm xmlns:a="http://schemas.openxmlformats.org/drawingml/2006/main"/>
+      </p:grpSpPr>
+      <p:sp>
+        <p:nvSpPr>
+          <p:cNvPr id="1" name="summary-eyebrow">
+            <a:extLst xmlns:a="http://schemas.openxmlformats.org/drawingml/2006/main">
+              <a:ext uri="{FF2B5EF4-FFF2-40B4-BE49-F238E27FC236}">
+                <a16:creationId xmlns:a16="http://schemas.microsoft.com/office/drawing/2014/main" id="{886992DE-3408-416A-B8FF-1AC80747AF8F}"/>
+              </a:ext>
+            </a:extLst>
+          </p:cNvPr>
+          <p:cNvSpPr>
+            <a:spLocks xmlns:a="http://schemas.openxmlformats.org/drawingml/2006/main" noGrp="1"/>
+          </p:cNvSpPr>
+          <p:nvPr/>
+        </p:nvSpPr>
+        <p:spPr>
+          <a:xfrm xmlns:a="http://schemas.openxmlformats.org/drawingml/2006/main">
+            <a:off x="552450" y="381000"/>
+            <a:ext cx="3048000" cy="247650"/>
+          </a:xfrm>
+          <a:prstGeom xmlns:a="http://schemas.openxmlformats.org/drawingml/2006/main" prst="rect">
+            <a:avLst/>
+          </a:prstGeom>
+          <a:noFill xmlns:a="http://schemas.openxmlformats.org/drawingml/2006/main"/>
+          <a:ln xmlns:a="http://schemas.openxmlformats.org/drawingml/2006/main" w="0">
+            <a:noFill/>
+            <a:prstDash val="solid"/>
+          </a:ln>
+        </p:spPr>
+        <p:txBody>
+          <a:bodyPr xmlns:a="http://schemas.openxmlformats.org/drawingml/2006/main"/>
+          <a:lstStyle xmlns:a="http://schemas.openxmlformats.org/drawingml/2006/main"/>
+          <a:p xmlns:a="http://schemas.openxmlformats.org/drawingml/2006/main">
+            <a:pPr>
+              <a:buNone/>
+              <a:defRPr sz="1050" b="1">
+                <a:solidFill>
+                  <a:srgbClr val="DC2626"/>
+                </a:solidFill>
+              </a:defRPr>
+            </a:pPr>
+            <a:r>
+              <a:rPr sz="1050" b="1">
+                <a:solidFill>
+                  <a:srgbClr val="DC2626"/>
+                </a:solidFill>
+              </a:rPr>
+              <a:t>FEATURE SCOPE</a:t>
+            </a:r>
+          </a:p>
+        </p:txBody>
+      </p:sp>
+      <p:sp>
+        <p:nvSpPr>
+          <p:cNvPr id="2" name="summary-title">
+            <a:extLst xmlns:a="http://schemas.openxmlformats.org/drawingml/2006/main">
+              <a:ext uri="{FF2B5EF4-FFF2-40B4-BE49-F238E27FC236}">
+                <a16:creationId xmlns:a16="http://schemas.microsoft.com/office/drawing/2014/main" id="{A8CB66A5-8391-4BDA-A9AF-7C397E077D4D}"/>
+              </a:ext>
+            </a:extLst>
+          </p:cNvPr>
+          <p:cNvSpPr>
+            <a:spLocks xmlns:a="http://schemas.openxmlformats.org/drawingml/2006/main" noGrp="1"/>
+          </p:cNvSpPr>
+          <p:nvPr/>
+        </p:nvSpPr>
+        <p:spPr>
+          <a:xfrm xmlns:a="http://schemas.openxmlformats.org/drawingml/2006/main">
+            <a:off x="552450" y="800100"/>
+            <a:ext cx="10668000" cy="552450"/>
+          </a:xfrm>
+          <a:prstGeom xmlns:a="http://schemas.openxmlformats.org/drawingml/2006/main" prst="rect">
+            <a:avLst/>
+          </a:prstGeom>
+          <a:noFill xmlns:a="http://schemas.openxmlformats.org/drawingml/2006/main"/>
+          <a:ln xmlns:a="http://schemas.openxmlformats.org/drawingml/2006/main" w="0">
+            <a:noFill/>
+            <a:prstDash val="solid"/>
+          </a:ln>
+        </p:spPr>
+        <p:txBody>
+          <a:bodyPr xmlns:a="http://schemas.openxmlformats.org/drawingml/2006/main"/>
+          <a:lstStyle xmlns:a="http://schemas.openxmlformats.org/drawingml/2006/main"/>
+          <a:p xmlns:a="http://schemas.openxmlformats.org/drawingml/2006/main">
+            <a:pPr>
+              <a:buNone/>
+              <a:defRPr sz="2850" b="1">
+                <a:solidFill>
+                  <a:srgbClr val="0F172A"/>
+                </a:solidFill>
+              </a:defRPr>
+            </a:pPr>
+            <a:r>
+              <a:rPr sz="3000" b="1">
+                <a:solidFill>
+                  <a:srgbClr val="0F172A"/>
+                </a:solidFill>
+              </a:rPr>
+              <a:t>Camera Stream ve Teleoperation dışındaki özellikler</a:t>
+            </a:r>
+          </a:p>
+        </p:txBody>
+      </p:sp>
+      <p:sp>
+        <p:nvSpPr>
+          <p:cNvPr id="3" name="summary-subtitle">
+            <a:extLst xmlns:a="http://schemas.openxmlformats.org/drawingml/2006/main">
+              <a:ext uri="{FF2B5EF4-FFF2-40B4-BE49-F238E27FC236}">
+                <a16:creationId xmlns:a16="http://schemas.microsoft.com/office/drawing/2014/main" id="{085C0BBD-E7D4-4EE5-876C-E31DEEB4C7CC}"/>
+              </a:ext>
+            </a:extLst>
+          </p:cNvPr>
+          <p:cNvSpPr>
+            <a:spLocks xmlns:a="http://schemas.openxmlformats.org/drawingml/2006/main" noGrp="1"/>
+          </p:cNvSpPr>
+          <p:nvPr/>
+        </p:nvSpPr>
+        <p:spPr>
+          <a:xfrm xmlns:a="http://schemas.openxmlformats.org/drawingml/2006/main">
+            <a:off x="571500" y="1504950"/>
+            <a:ext cx="9906000" cy="400050"/>
+          </a:xfrm>
+          <a:prstGeom xmlns:a="http://schemas.openxmlformats.org/drawingml/2006/main" prst="rect">
+            <a:avLst/>
+          </a:prstGeom>
+          <a:noFill xmlns:a="http://schemas.openxmlformats.org/drawingml/2006/main"/>
+          <a:ln xmlns:a="http://schemas.openxmlformats.org/drawingml/2006/main" w="0">
+            <a:noFill/>
+            <a:prstDash val="solid"/>
+          </a:ln>
+        </p:spPr>
+        <p:txBody>
+          <a:bodyPr xmlns:a="http://schemas.openxmlformats.org/drawingml/2006/main"/>
+          <a:lstStyle xmlns:a="http://schemas.openxmlformats.org/drawingml/2006/main"/>
+          <a:p xmlns:a="http://schemas.openxmlformats.org/drawingml/2006/main">
+            <a:pPr>
+              <a:buNone/>
+              <a:defRPr sz="1500">
+                <a:solidFill>
+                  <a:srgbClr val="475569"/>
+                </a:solidFill>
+              </a:defRPr>
+            </a:pPr>
+            <a:r>
+              <a:rPr sz="1500">
+                <a:solidFill>
+                  <a:srgbClr val="475569"/>
+                </a:solidFill>
+              </a:rPr>
+              <a:t>Platformun değerini kamera yayını veya uzaktan yürütme modlarına dayanmadan anlatan ürün katmanları.</a:t>
+            </a:r>
+          </a:p>
+        </p:txBody>
+      </p:sp>
+      <p:sp>
+        <p:nvSpPr>
+          <p:cNvPr id="4" name="summary-accent-1">
+            <a:extLst xmlns:a="http://schemas.openxmlformats.org/drawingml/2006/main">
+              <a:ext uri="{FF2B5EF4-FFF2-40B4-BE49-F238E27FC236}">
+                <a16:creationId xmlns:a16="http://schemas.microsoft.com/office/drawing/2014/main" id="{153ABE25-DE31-492F-9B5C-1F16266B271E}"/>
+              </a:ext>
+            </a:extLst>
+          </p:cNvPr>
+          <p:cNvSpPr>
+            <a:spLocks xmlns:a="http://schemas.openxmlformats.org/drawingml/2006/main" noGrp="1"/>
+          </p:cNvSpPr>
+          <p:nvPr/>
+        </p:nvSpPr>
+        <p:spPr>
+          <a:xfrm xmlns:a="http://schemas.openxmlformats.org/drawingml/2006/main">
+            <a:off x="571500" y="2247900"/>
+            <a:ext cx="2324100" cy="47625"/>
+          </a:xfrm>
+          <a:prstGeom xmlns:a="http://schemas.openxmlformats.org/drawingml/2006/main" prst="rect">
+            <a:avLst/>
+          </a:prstGeom>
+          <a:solidFill xmlns:a="http://schemas.openxmlformats.org/drawingml/2006/main">
+            <a:srgbClr val="DC2626"/>
+          </a:solidFill>
+          <a:ln xmlns:a="http://schemas.openxmlformats.org/drawingml/2006/main" w="0">
+            <a:noFill/>
+            <a:prstDash val="solid"/>
+          </a:ln>
+        </p:spPr>
+      </p:sp>
+      <p:sp>
+        <p:nvSpPr>
+          <p:cNvPr id="5" name="summary-column-title-1">
+            <a:extLst xmlns:a="http://schemas.openxmlformats.org/drawingml/2006/main">
+              <a:ext uri="{FF2B5EF4-FFF2-40B4-BE49-F238E27FC236}">
+                <a16:creationId xmlns:a16="http://schemas.microsoft.com/office/drawing/2014/main" id="{23C6B5C8-67D6-4712-AEE4-2B746EFF5FD9}"/>
+              </a:ext>
+            </a:extLst>
+          </p:cNvPr>
+          <p:cNvSpPr>
+            <a:spLocks xmlns:a="http://schemas.openxmlformats.org/drawingml/2006/main" noGrp="1"/>
+          </p:cNvSpPr>
+          <p:nvPr/>
+        </p:nvSpPr>
+        <p:spPr>
+          <a:xfrm xmlns:a="http://schemas.openxmlformats.org/drawingml/2006/main">
+            <a:off x="571500" y="2457450"/>
+            <a:ext cx="2324100" cy="323850"/>
+          </a:xfrm>
+          <a:prstGeom xmlns:a="http://schemas.openxmlformats.org/drawingml/2006/main" prst="rect">
+            <a:avLst/>
+          </a:prstGeom>
+          <a:noFill xmlns:a="http://schemas.openxmlformats.org/drawingml/2006/main"/>
+          <a:ln xmlns:a="http://schemas.openxmlformats.org/drawingml/2006/main" w="0">
+            <a:noFill/>
+            <a:prstDash val="solid"/>
+          </a:ln>
+        </p:spPr>
+        <p:txBody>
+          <a:bodyPr xmlns:a="http://schemas.openxmlformats.org/drawingml/2006/main"/>
+          <a:lstStyle xmlns:a="http://schemas.openxmlformats.org/drawingml/2006/main"/>
+          <a:p xmlns:a="http://schemas.openxmlformats.org/drawingml/2006/main">
+            <a:pPr>
+              <a:buNone/>
+              <a:defRPr sz="1650" b="1">
+                <a:solidFill>
+                  <a:srgbClr val="111827"/>
+                </a:solidFill>
+              </a:defRPr>
+            </a:pPr>
+            <a:r>
+              <a:rPr sz="1650" b="1">
+                <a:solidFill>
+                  <a:srgbClr val="111827"/>
+                </a:solidFill>
+              </a:rPr>
+              <a:t>Cockpit ve AI</a:t>
+            </a:r>
+          </a:p>
+        </p:txBody>
+      </p:sp>
+      <p:sp>
+        <p:nvSpPr>
+          <p:cNvPr id="6" name="summary-dot-1-0">
+            <a:extLst xmlns:a="http://schemas.openxmlformats.org/drawingml/2006/main">
+              <a:ext uri="{FF2B5EF4-FFF2-40B4-BE49-F238E27FC236}">
+                <a16:creationId xmlns:a16="http://schemas.microsoft.com/office/drawing/2014/main" id="{E782920F-02C3-4BE3-A23F-A49B48200628}"/>
+              </a:ext>
+            </a:extLst>
+          </p:cNvPr>
+          <p:cNvSpPr>
+            <a:spLocks xmlns:a="http://schemas.openxmlformats.org/drawingml/2006/main" noGrp="1"/>
+          </p:cNvSpPr>
+          <p:nvPr/>
+        </p:nvSpPr>
+        <p:spPr>
+          <a:xfrm xmlns:a="http://schemas.openxmlformats.org/drawingml/2006/main">
+            <a:off x="571500" y="3086100"/>
+            <a:ext cx="76200" cy="76200"/>
+          </a:xfrm>
+          <a:prstGeom xmlns:a="http://schemas.openxmlformats.org/drawingml/2006/main" prst="ellipse">
+            <a:avLst/>
+          </a:prstGeom>
+          <a:solidFill xmlns:a="http://schemas.openxmlformats.org/drawingml/2006/main">
+            <a:srgbClr val="DC2626"/>
+          </a:solidFill>
+          <a:ln xmlns:a="http://schemas.openxmlformats.org/drawingml/2006/main" w="0">
+            <a:noFill/>
+            <a:prstDash val="solid"/>
+          </a:ln>
+        </p:spPr>
+      </p:sp>
+      <p:sp>
+        <p:nvSpPr>
+          <p:cNvPr id="7" name="summary-item-1-0">
+            <a:extLst xmlns:a="http://schemas.openxmlformats.org/drawingml/2006/main">
+              <a:ext uri="{FF2B5EF4-FFF2-40B4-BE49-F238E27FC236}">
+                <a16:creationId xmlns:a16="http://schemas.microsoft.com/office/drawing/2014/main" id="{82752ACF-2A1E-408B-94EB-E53764A0BD6B}"/>
+              </a:ext>
+            </a:extLst>
+          </p:cNvPr>
+          <p:cNvSpPr>
+            <a:spLocks xmlns:a="http://schemas.openxmlformats.org/drawingml/2006/main" noGrp="1"/>
+          </p:cNvSpPr>
+          <p:nvPr/>
+        </p:nvSpPr>
+        <p:spPr>
+          <a:xfrm xmlns:a="http://schemas.openxmlformats.org/drawingml/2006/main">
+            <a:off x="762000" y="3009900"/>
+            <a:ext cx="2133600" cy="438150"/>
+          </a:xfrm>
+          <a:prstGeom xmlns:a="http://schemas.openxmlformats.org/drawingml/2006/main" prst="rect">
+            <a:avLst/>
+          </a:prstGeom>
+          <a:noFill xmlns:a="http://schemas.openxmlformats.org/drawingml/2006/main"/>
+          <a:ln xmlns:a="http://schemas.openxmlformats.org/drawingml/2006/main" w="0">
+            <a:noFill/>
+            <a:prstDash val="solid"/>
+          </a:ln>
+        </p:spPr>
+        <p:txBody>
+          <a:bodyPr xmlns:a="http://schemas.openxmlformats.org/drawingml/2006/main"/>
+          <a:lstStyle xmlns:a="http://schemas.openxmlformats.org/drawingml/2006/main"/>
+          <a:p xmlns:a="http://schemas.openxmlformats.org/drawingml/2006/main">
+            <a:pPr>
+              <a:buNone/>
+              <a:defRPr sz="1275">
+                <a:solidFill>
+                  <a:srgbClr val="374151"/>
+                </a:solidFill>
+              </a:defRPr>
+            </a:pPr>
+            <a:r>
+              <a:rPr sz="1275">
+                <a:solidFill>
+                  <a:srgbClr val="374151"/>
+                </a:solidFill>
+              </a:rPr>
+              <a:t>AI Chatbot ile doğal dil komut ve cevap akışı</a:t>
+            </a:r>
+          </a:p>
+        </p:txBody>
+      </p:sp>
+      <p:sp>
+        <p:nvSpPr>
+          <p:cNvPr id="8" name="summary-dot-1-1">
+            <a:extLst xmlns:a="http://schemas.openxmlformats.org/drawingml/2006/main">
+              <a:ext uri="{FF2B5EF4-FFF2-40B4-BE49-F238E27FC236}">
+                <a16:creationId xmlns:a16="http://schemas.microsoft.com/office/drawing/2014/main" id="{C9E43975-E384-4751-86AB-7B1BEA92C35B}"/>
+              </a:ext>
+            </a:extLst>
+          </p:cNvPr>
+          <p:cNvSpPr>
+            <a:spLocks xmlns:a="http://schemas.openxmlformats.org/drawingml/2006/main" noGrp="1"/>
+          </p:cNvSpPr>
+          <p:nvPr/>
+        </p:nvSpPr>
+        <p:spPr>
+          <a:xfrm xmlns:a="http://schemas.openxmlformats.org/drawingml/2006/main">
+            <a:off x="571500" y="3638550"/>
+            <a:ext cx="76200" cy="76200"/>
+          </a:xfrm>
+          <a:prstGeom xmlns:a="http://schemas.openxmlformats.org/drawingml/2006/main" prst="ellipse">
+            <a:avLst/>
+          </a:prstGeom>
+          <a:solidFill xmlns:a="http://schemas.openxmlformats.org/drawingml/2006/main">
+            <a:srgbClr val="DC2626"/>
+          </a:solidFill>
+          <a:ln xmlns:a="http://schemas.openxmlformats.org/drawingml/2006/main" w="0">
+            <a:noFill/>
+            <a:prstDash val="solid"/>
+          </a:ln>
+        </p:spPr>
+      </p:sp>
+      <p:sp>
+        <p:nvSpPr>
+          <p:cNvPr id="9" name="summary-item-1-1">
+            <a:extLst xmlns:a="http://schemas.openxmlformats.org/drawingml/2006/main">
+              <a:ext uri="{FF2B5EF4-FFF2-40B4-BE49-F238E27FC236}">
+                <a16:creationId xmlns:a16="http://schemas.microsoft.com/office/drawing/2014/main" id="{71A3217D-8F84-4FA9-9A63-F6D21C84F01F}"/>
+              </a:ext>
+            </a:extLst>
+          </p:cNvPr>
+          <p:cNvSpPr>
+            <a:spLocks xmlns:a="http://schemas.openxmlformats.org/drawingml/2006/main" noGrp="1"/>
+          </p:cNvSpPr>
+          <p:nvPr/>
+        </p:nvSpPr>
+        <p:spPr>
+          <a:xfrm xmlns:a="http://schemas.openxmlformats.org/drawingml/2006/main">
+            <a:off x="762000" y="3562350"/>
+            <a:ext cx="2133600" cy="438150"/>
+          </a:xfrm>
+          <a:prstGeom xmlns:a="http://schemas.openxmlformats.org/drawingml/2006/main" prst="rect">
+            <a:avLst/>
+          </a:prstGeom>
+          <a:noFill xmlns:a="http://schemas.openxmlformats.org/drawingml/2006/main"/>
+          <a:ln xmlns:a="http://schemas.openxmlformats.org/drawingml/2006/main" w="0">
+            <a:noFill/>
+            <a:prstDash val="solid"/>
+          </a:ln>
+        </p:spPr>
+        <p:txBody>
+          <a:bodyPr xmlns:a="http://schemas.openxmlformats.org/drawingml/2006/main"/>
+          <a:lstStyle xmlns:a="http://schemas.openxmlformats.org/drawingml/2006/main"/>
+          <a:p xmlns:a="http://schemas.openxmlformats.org/drawingml/2006/main">
+            <a:pPr>
+              <a:buNone/>
+              <a:defRPr sz="1275">
+                <a:solidFill>
+                  <a:srgbClr val="374151"/>
+                </a:solidFill>
+              </a:defRPr>
+            </a:pPr>
+            <a:r>
+              <a:rPr sz="1275">
+                <a:solidFill>
+                  <a:srgbClr val="374151"/>
+                </a:solidFill>
+              </a:rPr>
+              <a:t>Bilgi akışı / RAG ile robot bağlamını toplama</a:t>
+            </a:r>
+          </a:p>
+        </p:txBody>
+      </p:sp>
+      <p:sp>
+        <p:nvSpPr>
+          <p:cNvPr id="10" name="summary-dot-1-2">
+            <a:extLst xmlns:a="http://schemas.openxmlformats.org/drawingml/2006/main">
+              <a:ext uri="{FF2B5EF4-FFF2-40B4-BE49-F238E27FC236}">
+                <a16:creationId xmlns:a16="http://schemas.microsoft.com/office/drawing/2014/main" id="{BF43D49A-E3E9-4F68-94F4-2B3931406C83}"/>
+              </a:ext>
+            </a:extLst>
+          </p:cNvPr>
+          <p:cNvSpPr>
+            <a:spLocks xmlns:a="http://schemas.openxmlformats.org/drawingml/2006/main" noGrp="1"/>
+          </p:cNvSpPr>
+          <p:nvPr/>
+        </p:nvSpPr>
+        <p:spPr>
+          <a:xfrm xmlns:a="http://schemas.openxmlformats.org/drawingml/2006/main">
+            <a:off x="571500" y="4191000"/>
+            <a:ext cx="76200" cy="76200"/>
+          </a:xfrm>
+          <a:prstGeom xmlns:a="http://schemas.openxmlformats.org/drawingml/2006/main" prst="ellipse">
+            <a:avLst/>
+          </a:prstGeom>
+          <a:solidFill xmlns:a="http://schemas.openxmlformats.org/drawingml/2006/main">
+            <a:srgbClr val="DC2626"/>
+          </a:solidFill>
+          <a:ln xmlns:a="http://schemas.openxmlformats.org/drawingml/2006/main" w="0">
+            <a:noFill/>
+            <a:prstDash val="solid"/>
+          </a:ln>
+        </p:spPr>
+      </p:sp>
+      <p:sp>
+        <p:nvSpPr>
+          <p:cNvPr id="11" name="summary-item-1-2">
+            <a:extLst xmlns:a="http://schemas.openxmlformats.org/drawingml/2006/main">
+              <a:ext uri="{FF2B5EF4-FFF2-40B4-BE49-F238E27FC236}">
+                <a16:creationId xmlns:a16="http://schemas.microsoft.com/office/drawing/2014/main" id="{71EB9F1E-E26F-430E-8ED0-0C507D067486}"/>
+              </a:ext>
+            </a:extLst>
+          </p:cNvPr>
+          <p:cNvSpPr>
+            <a:spLocks xmlns:a="http://schemas.openxmlformats.org/drawingml/2006/main" noGrp="1"/>
+          </p:cNvSpPr>
+          <p:nvPr/>
+        </p:nvSpPr>
+        <p:spPr>
+          <a:xfrm xmlns:a="http://schemas.openxmlformats.org/drawingml/2006/main">
+            <a:off x="762000" y="4114800"/>
+            <a:ext cx="2133600" cy="438150"/>
+          </a:xfrm>
+          <a:prstGeom xmlns:a="http://schemas.openxmlformats.org/drawingml/2006/main" prst="rect">
+            <a:avLst/>
+          </a:prstGeom>
+          <a:noFill xmlns:a="http://schemas.openxmlformats.org/drawingml/2006/main"/>
+          <a:ln xmlns:a="http://schemas.openxmlformats.org/drawingml/2006/main" w="0">
+            <a:noFill/>
+            <a:prstDash val="solid"/>
+          </a:ln>
+        </p:spPr>
+        <p:txBody>
+          <a:bodyPr xmlns:a="http://schemas.openxmlformats.org/drawingml/2006/main"/>
+          <a:lstStyle xmlns:a="http://schemas.openxmlformats.org/drawingml/2006/main"/>
+          <a:p xmlns:a="http://schemas.openxmlformats.org/drawingml/2006/main">
+            <a:pPr>
+              <a:buNone/>
+              <a:defRPr sz="1275">
+                <a:solidFill>
+                  <a:srgbClr val="374151"/>
+                </a:solidFill>
+              </a:defRPr>
+            </a:pPr>
+            <a:r>
+              <a:rPr sz="1275">
+                <a:solidFill>
+                  <a:srgbClr val="374151"/>
+                </a:solidFill>
+              </a:rPr>
+              <a:t>Robot Twin ile dijital sahne ve durum hissi</a:t>
+            </a:r>
+          </a:p>
+        </p:txBody>
+      </p:sp>
+      <p:sp>
+        <p:nvSpPr>
+          <p:cNvPr id="12" name="summary-dot-1-3">
+            <a:extLst xmlns:a="http://schemas.openxmlformats.org/drawingml/2006/main">
+              <a:ext uri="{FF2B5EF4-FFF2-40B4-BE49-F238E27FC236}">
+                <a16:creationId xmlns:a16="http://schemas.microsoft.com/office/drawing/2014/main" id="{D0110764-0F71-46B5-9DF9-3EDEA65E4024}"/>
+              </a:ext>
+            </a:extLst>
+          </p:cNvPr>
+          <p:cNvSpPr>
+            <a:spLocks xmlns:a="http://schemas.openxmlformats.org/drawingml/2006/main" noGrp="1"/>
+          </p:cNvSpPr>
+          <p:nvPr/>
+        </p:nvSpPr>
+        <p:spPr>
+          <a:xfrm xmlns:a="http://schemas.openxmlformats.org/drawingml/2006/main">
+            <a:off x="571500" y="4743450"/>
+            <a:ext cx="76200" cy="76200"/>
+          </a:xfrm>
+          <a:prstGeom xmlns:a="http://schemas.openxmlformats.org/drawingml/2006/main" prst="ellipse">
+            <a:avLst/>
+          </a:prstGeom>
+          <a:solidFill xmlns:a="http://schemas.openxmlformats.org/drawingml/2006/main">
+            <a:srgbClr val="DC2626"/>
+          </a:solidFill>
+          <a:ln xmlns:a="http://schemas.openxmlformats.org/drawingml/2006/main" w="0">
+            <a:noFill/>
+            <a:prstDash val="solid"/>
+          </a:ln>
+        </p:spPr>
+      </p:sp>
+      <p:sp>
+        <p:nvSpPr>
+          <p:cNvPr id="13" name="summary-item-1-3">
+            <a:extLst xmlns:a="http://schemas.openxmlformats.org/drawingml/2006/main">
+              <a:ext uri="{FF2B5EF4-FFF2-40B4-BE49-F238E27FC236}">
+                <a16:creationId xmlns:a16="http://schemas.microsoft.com/office/drawing/2014/main" id="{BAA415C0-742B-4962-8DE9-97C16EB58596}"/>
+              </a:ext>
+            </a:extLst>
+          </p:cNvPr>
+          <p:cNvSpPr>
+            <a:spLocks xmlns:a="http://schemas.openxmlformats.org/drawingml/2006/main" noGrp="1"/>
+          </p:cNvSpPr>
+          <p:nvPr/>
+        </p:nvSpPr>
+        <p:spPr>
+          <a:xfrm xmlns:a="http://schemas.openxmlformats.org/drawingml/2006/main">
+            <a:off x="762000" y="4667250"/>
+            <a:ext cx="2133600" cy="438150"/>
+          </a:xfrm>
+          <a:prstGeom xmlns:a="http://schemas.openxmlformats.org/drawingml/2006/main" prst="rect">
+            <a:avLst/>
+          </a:prstGeom>
+          <a:noFill xmlns:a="http://schemas.openxmlformats.org/drawingml/2006/main"/>
+          <a:ln xmlns:a="http://schemas.openxmlformats.org/drawingml/2006/main" w="0">
+            <a:noFill/>
+            <a:prstDash val="solid"/>
+          </a:ln>
+        </p:spPr>
+        <p:txBody>
+          <a:bodyPr xmlns:a="http://schemas.openxmlformats.org/drawingml/2006/main"/>
+          <a:lstStyle xmlns:a="http://schemas.openxmlformats.org/drawingml/2006/main"/>
+          <a:p xmlns:a="http://schemas.openxmlformats.org/drawingml/2006/main">
+            <a:pPr>
+              <a:buNone/>
+              <a:defRPr sz="1275">
+                <a:solidFill>
+                  <a:srgbClr val="374151"/>
+                </a:solidFill>
+              </a:defRPr>
+            </a:pPr>
+            <a:r>
+              <a:rPr sz="1275">
+                <a:solidFill>
+                  <a:srgbClr val="374151"/>
+                </a:solidFill>
+              </a:rPr>
+              <a:t>Tek cockpit içinde operatör karar ekranı</a:t>
+            </a:r>
+          </a:p>
+        </p:txBody>
+      </p:sp>
+      <p:sp>
+        <p:nvSpPr>
+          <p:cNvPr id="14" name="summary-accent-2">
+            <a:extLst xmlns:a="http://schemas.openxmlformats.org/drawingml/2006/main">
+              <a:ext uri="{FF2B5EF4-FFF2-40B4-BE49-F238E27FC236}">
+                <a16:creationId xmlns:a16="http://schemas.microsoft.com/office/drawing/2014/main" id="{3BB516E3-7CCC-43C9-A41C-8D0154D1B788}"/>
+              </a:ext>
+            </a:extLst>
+          </p:cNvPr>
+          <p:cNvSpPr>
+            <a:spLocks xmlns:a="http://schemas.openxmlformats.org/drawingml/2006/main" noGrp="1"/>
+          </p:cNvSpPr>
+          <p:nvPr/>
+        </p:nvSpPr>
+        <p:spPr>
+          <a:xfrm xmlns:a="http://schemas.openxmlformats.org/drawingml/2006/main">
+            <a:off x="3448050" y="2247900"/>
+            <a:ext cx="2324100" cy="47625"/>
+          </a:xfrm>
+          <a:prstGeom xmlns:a="http://schemas.openxmlformats.org/drawingml/2006/main" prst="rect">
+            <a:avLst/>
+          </a:prstGeom>
+          <a:solidFill xmlns:a="http://schemas.openxmlformats.org/drawingml/2006/main">
+            <a:srgbClr val="0EA5E9"/>
+          </a:solidFill>
+          <a:ln xmlns:a="http://schemas.openxmlformats.org/drawingml/2006/main" w="0">
+            <a:noFill/>
+            <a:prstDash val="solid"/>
+          </a:ln>
+        </p:spPr>
+      </p:sp>
+      <p:sp>
+        <p:nvSpPr>
+          <p:cNvPr id="15" name="summary-column-title-2">
+            <a:extLst xmlns:a="http://schemas.openxmlformats.org/drawingml/2006/main">
+              <a:ext uri="{FF2B5EF4-FFF2-40B4-BE49-F238E27FC236}">
+                <a16:creationId xmlns:a16="http://schemas.microsoft.com/office/drawing/2014/main" id="{09F93FB2-4CD9-4A11-AA0F-4875ACAE2D15}"/>
+              </a:ext>
+            </a:extLst>
+          </p:cNvPr>
+          <p:cNvSpPr>
+            <a:spLocks xmlns:a="http://schemas.openxmlformats.org/drawingml/2006/main" noGrp="1"/>
+          </p:cNvSpPr>
+          <p:nvPr/>
+        </p:nvSpPr>
+        <p:spPr>
+          <a:xfrm xmlns:a="http://schemas.openxmlformats.org/drawingml/2006/main">
+            <a:off x="3448050" y="2457450"/>
+            <a:ext cx="2324100" cy="323850"/>
+          </a:xfrm>
+          <a:prstGeom xmlns:a="http://schemas.openxmlformats.org/drawingml/2006/main" prst="rect">
+            <a:avLst/>
+          </a:prstGeom>
+          <a:noFill xmlns:a="http://schemas.openxmlformats.org/drawingml/2006/main"/>
+          <a:ln xmlns:a="http://schemas.openxmlformats.org/drawingml/2006/main" w="0">
+            <a:noFill/>
+            <a:prstDash val="solid"/>
+          </a:ln>
+        </p:spPr>
+        <p:txBody>
+          <a:bodyPr xmlns:a="http://schemas.openxmlformats.org/drawingml/2006/main"/>
+          <a:lstStyle xmlns:a="http://schemas.openxmlformats.org/drawingml/2006/main"/>
+          <a:p xmlns:a="http://schemas.openxmlformats.org/drawingml/2006/main">
+            <a:pPr>
+              <a:buNone/>
+              <a:defRPr sz="1650" b="1">
+                <a:solidFill>
+                  <a:srgbClr val="111827"/>
+                </a:solidFill>
+              </a:defRPr>
+            </a:pPr>
+            <a:r>
+              <a:rPr sz="1650" b="1">
+                <a:solidFill>
+                  <a:srgbClr val="111827"/>
+                </a:solidFill>
+              </a:rPr>
+              <a:t>Telemetry</a:t>
+            </a:r>
+          </a:p>
+        </p:txBody>
+      </p:sp>
+      <p:sp>
+        <p:nvSpPr>
+          <p:cNvPr id="16" name="summary-dot-2-0">
+            <a:extLst xmlns:a="http://schemas.openxmlformats.org/drawingml/2006/main">
+              <a:ext uri="{FF2B5EF4-FFF2-40B4-BE49-F238E27FC236}">
+                <a16:creationId xmlns:a16="http://schemas.microsoft.com/office/drawing/2014/main" id="{275B9D02-32DD-4752-AD2E-3608401DA707}"/>
+              </a:ext>
+            </a:extLst>
+          </p:cNvPr>
+          <p:cNvSpPr>
+            <a:spLocks xmlns:a="http://schemas.openxmlformats.org/drawingml/2006/main" noGrp="1"/>
+          </p:cNvSpPr>
+          <p:nvPr/>
+        </p:nvSpPr>
+        <p:spPr>
+          <a:xfrm xmlns:a="http://schemas.openxmlformats.org/drawingml/2006/main">
+            <a:off x="3448050" y="3086100"/>
+            <a:ext cx="76200" cy="76200"/>
+          </a:xfrm>
+          <a:prstGeom xmlns:a="http://schemas.openxmlformats.org/drawingml/2006/main" prst="ellipse">
+            <a:avLst/>
+          </a:prstGeom>
+          <a:solidFill xmlns:a="http://schemas.openxmlformats.org/drawingml/2006/main">
+            <a:srgbClr val="0EA5E9"/>
+          </a:solidFill>
+          <a:ln xmlns:a="http://schemas.openxmlformats.org/drawingml/2006/main" w="0">
+            <a:noFill/>
+            <a:prstDash val="solid"/>
+          </a:ln>
+        </p:spPr>
+      </p:sp>
+      <p:sp>
+        <p:nvSpPr>
+          <p:cNvPr id="17" name="summary-item-2-0">
+            <a:extLst xmlns:a="http://schemas.openxmlformats.org/drawingml/2006/main">
+              <a:ext uri="{FF2B5EF4-FFF2-40B4-BE49-F238E27FC236}">
+                <a16:creationId xmlns:a16="http://schemas.microsoft.com/office/drawing/2014/main" id="{06400A28-3AF6-4DB5-BE61-07951529246C}"/>
+              </a:ext>
+            </a:extLst>
+          </p:cNvPr>
+          <p:cNvSpPr>
+            <a:spLocks xmlns:a="http://schemas.openxmlformats.org/drawingml/2006/main" noGrp="1"/>
+          </p:cNvSpPr>
+          <p:nvPr/>
+        </p:nvSpPr>
+        <p:spPr>
+          <a:xfrm xmlns:a="http://schemas.openxmlformats.org/drawingml/2006/main">
+            <a:off x="3638550" y="3009900"/>
+            <a:ext cx="2133600" cy="438150"/>
+          </a:xfrm>
+          <a:prstGeom xmlns:a="http://schemas.openxmlformats.org/drawingml/2006/main" prst="rect">
+            <a:avLst/>
+          </a:prstGeom>
+          <a:noFill xmlns:a="http://schemas.openxmlformats.org/drawingml/2006/main"/>
+          <a:ln xmlns:a="http://schemas.openxmlformats.org/drawingml/2006/main" w="0">
+            <a:noFill/>
+            <a:prstDash val="solid"/>
+          </a:ln>
+        </p:spPr>
+        <p:txBody>
+          <a:bodyPr xmlns:a="http://schemas.openxmlformats.org/drawingml/2006/main"/>
+          <a:lstStyle xmlns:a="http://schemas.openxmlformats.org/drawingml/2006/main"/>
+          <a:p xmlns:a="http://schemas.openxmlformats.org/drawingml/2006/main">
+            <a:pPr>
+              <a:buNone/>
+              <a:defRPr sz="1275">
+                <a:solidFill>
+                  <a:srgbClr val="374151"/>
+                </a:solidFill>
+              </a:defRPr>
+            </a:pPr>
+            <a:r>
+              <a:rPr sz="1275">
+                <a:solidFill>
+                  <a:srgbClr val="374151"/>
+                </a:solidFill>
+              </a:rPr>
+              <a:t>Live Dashboard ile anlık robot durumu</a:t>
+            </a:r>
+          </a:p>
+        </p:txBody>
+      </p:sp>
+      <p:sp>
+        <p:nvSpPr>
+          <p:cNvPr id="18" name="summary-dot-2-1">
+            <a:extLst xmlns:a="http://schemas.openxmlformats.org/drawingml/2006/main">
+              <a:ext uri="{FF2B5EF4-FFF2-40B4-BE49-F238E27FC236}">
+                <a16:creationId xmlns:a16="http://schemas.microsoft.com/office/drawing/2014/main" id="{BD3D500E-9961-45BB-BA34-8FF112FDFC6F}"/>
+              </a:ext>
+            </a:extLst>
+          </p:cNvPr>
+          <p:cNvSpPr>
+            <a:spLocks xmlns:a="http://schemas.openxmlformats.org/drawingml/2006/main" noGrp="1"/>
+          </p:cNvSpPr>
+          <p:nvPr/>
+        </p:nvSpPr>
+        <p:spPr>
+          <a:xfrm xmlns:a="http://schemas.openxmlformats.org/drawingml/2006/main">
+            <a:off x="3448050" y="3638550"/>
+            <a:ext cx="76200" cy="76200"/>
+          </a:xfrm>
+          <a:prstGeom xmlns:a="http://schemas.openxmlformats.org/drawingml/2006/main" prst="ellipse">
+            <a:avLst/>
+          </a:prstGeom>
+          <a:solidFill xmlns:a="http://schemas.openxmlformats.org/drawingml/2006/main">
+            <a:srgbClr val="0EA5E9"/>
+          </a:solidFill>
+          <a:ln xmlns:a="http://schemas.openxmlformats.org/drawingml/2006/main" w="0">
+            <a:noFill/>
+            <a:prstDash val="solid"/>
+          </a:ln>
+        </p:spPr>
+      </p:sp>
+      <p:sp>
+        <p:nvSpPr>
+          <p:cNvPr id="19" name="summary-item-2-1">
+            <a:extLst xmlns:a="http://schemas.openxmlformats.org/drawingml/2006/main">
+              <a:ext uri="{FF2B5EF4-FFF2-40B4-BE49-F238E27FC236}">
+                <a16:creationId xmlns:a16="http://schemas.microsoft.com/office/drawing/2014/main" id="{039C0838-D042-4CA0-AF8A-220B0B40DCBD}"/>
+              </a:ext>
+            </a:extLst>
+          </p:cNvPr>
+          <p:cNvSpPr>
+            <a:spLocks xmlns:a="http://schemas.openxmlformats.org/drawingml/2006/main" noGrp="1"/>
+          </p:cNvSpPr>
+          <p:nvPr/>
+        </p:nvSpPr>
+        <p:spPr>
+          <a:xfrm xmlns:a="http://schemas.openxmlformats.org/drawingml/2006/main">
+            <a:off x="3638550" y="3562350"/>
+            <a:ext cx="2133600" cy="438150"/>
+          </a:xfrm>
+          <a:prstGeom xmlns:a="http://schemas.openxmlformats.org/drawingml/2006/main" prst="rect">
+            <a:avLst/>
+          </a:prstGeom>
+          <a:noFill xmlns:a="http://schemas.openxmlformats.org/drawingml/2006/main"/>
+          <a:ln xmlns:a="http://schemas.openxmlformats.org/drawingml/2006/main" w="0">
+            <a:noFill/>
+            <a:prstDash val="solid"/>
+          </a:ln>
+        </p:spPr>
+        <p:txBody>
+          <a:bodyPr xmlns:a="http://schemas.openxmlformats.org/drawingml/2006/main"/>
+          <a:lstStyle xmlns:a="http://schemas.openxmlformats.org/drawingml/2006/main"/>
+          <a:p xmlns:a="http://schemas.openxmlformats.org/drawingml/2006/main">
+            <a:pPr>
+              <a:buNone/>
+              <a:defRPr sz="1275">
+                <a:solidFill>
+                  <a:srgbClr val="374151"/>
+                </a:solidFill>
+              </a:defRPr>
+            </a:pPr>
+            <a:r>
+              <a:rPr sz="1275">
+                <a:solidFill>
+                  <a:srgbClr val="374151"/>
+                </a:solidFill>
+              </a:rPr>
+              <a:t>Motor ve sistem örneklerini okunabilir hale getirme</a:t>
+            </a:r>
+          </a:p>
+        </p:txBody>
+      </p:sp>
+      <p:sp>
+        <p:nvSpPr>
+          <p:cNvPr id="20" name="summary-dot-2-2">
+            <a:extLst xmlns:a="http://schemas.openxmlformats.org/drawingml/2006/main">
+              <a:ext uri="{FF2B5EF4-FFF2-40B4-BE49-F238E27FC236}">
+                <a16:creationId xmlns:a16="http://schemas.microsoft.com/office/drawing/2014/main" id="{8A5E66CF-4E3F-4C37-9286-98BE9CD24468}"/>
+              </a:ext>
+            </a:extLst>
+          </p:cNvPr>
+          <p:cNvSpPr>
+            <a:spLocks xmlns:a="http://schemas.openxmlformats.org/drawingml/2006/main" noGrp="1"/>
+          </p:cNvSpPr>
+          <p:nvPr/>
+        </p:nvSpPr>
+        <p:spPr>
+          <a:xfrm xmlns:a="http://schemas.openxmlformats.org/drawingml/2006/main">
+            <a:off x="3448050" y="4191000"/>
+            <a:ext cx="76200" cy="76200"/>
+          </a:xfrm>
+          <a:prstGeom xmlns:a="http://schemas.openxmlformats.org/drawingml/2006/main" prst="ellipse">
+            <a:avLst/>
+          </a:prstGeom>
+          <a:solidFill xmlns:a="http://schemas.openxmlformats.org/drawingml/2006/main">
+            <a:srgbClr val="0EA5E9"/>
+          </a:solidFill>
+          <a:ln xmlns:a="http://schemas.openxmlformats.org/drawingml/2006/main" w="0">
+            <a:noFill/>
+            <a:prstDash val="solid"/>
+          </a:ln>
+        </p:spPr>
+      </p:sp>
+      <p:sp>
+        <p:nvSpPr>
+          <p:cNvPr id="21" name="summary-item-2-2">
+            <a:extLst xmlns:a="http://schemas.openxmlformats.org/drawingml/2006/main">
+              <a:ext uri="{FF2B5EF4-FFF2-40B4-BE49-F238E27FC236}">
+                <a16:creationId xmlns:a16="http://schemas.microsoft.com/office/drawing/2014/main" id="{A2392BB0-778B-48CF-82CC-AA99B9E85A99}"/>
+              </a:ext>
+            </a:extLst>
+          </p:cNvPr>
+          <p:cNvSpPr>
+            <a:spLocks xmlns:a="http://schemas.openxmlformats.org/drawingml/2006/main" noGrp="1"/>
+          </p:cNvSpPr>
+          <p:nvPr/>
+        </p:nvSpPr>
+        <p:spPr>
+          <a:xfrm xmlns:a="http://schemas.openxmlformats.org/drawingml/2006/main">
+            <a:off x="3638550" y="4114800"/>
+            <a:ext cx="2133600" cy="438150"/>
+          </a:xfrm>
+          <a:prstGeom xmlns:a="http://schemas.openxmlformats.org/drawingml/2006/main" prst="rect">
+            <a:avLst/>
+          </a:prstGeom>
+          <a:noFill xmlns:a="http://schemas.openxmlformats.org/drawingml/2006/main"/>
+          <a:ln xmlns:a="http://schemas.openxmlformats.org/drawingml/2006/main" w="0">
+            <a:noFill/>
+            <a:prstDash val="solid"/>
+          </a:ln>
+        </p:spPr>
+        <p:txBody>
+          <a:bodyPr xmlns:a="http://schemas.openxmlformats.org/drawingml/2006/main"/>
+          <a:lstStyle xmlns:a="http://schemas.openxmlformats.org/drawingml/2006/main"/>
+          <a:p xmlns:a="http://schemas.openxmlformats.org/drawingml/2006/main">
+            <a:pPr>
+              <a:buNone/>
+              <a:defRPr sz="1275">
+                <a:solidFill>
+                  <a:srgbClr val="374151"/>
+                </a:solidFill>
+              </a:defRPr>
+            </a:pPr>
+            <a:r>
+              <a:rPr sz="1275">
+                <a:solidFill>
+                  <a:srgbClr val="374151"/>
+                </a:solidFill>
+              </a:rPr>
+              <a:t>ROS Visibility ile altyapı sinyallerini görünür kılma</a:t>
+            </a:r>
+          </a:p>
+        </p:txBody>
+      </p:sp>
+      <p:sp>
+        <p:nvSpPr>
+          <p:cNvPr id="22" name="summary-dot-2-3">
+            <a:extLst xmlns:a="http://schemas.openxmlformats.org/drawingml/2006/main">
+              <a:ext uri="{FF2B5EF4-FFF2-40B4-BE49-F238E27FC236}">
+                <a16:creationId xmlns:a16="http://schemas.microsoft.com/office/drawing/2014/main" id="{3BAC5C97-2047-4C1E-A9A9-855964911244}"/>
+              </a:ext>
+            </a:extLst>
+          </p:cNvPr>
+          <p:cNvSpPr>
+            <a:spLocks xmlns:a="http://schemas.openxmlformats.org/drawingml/2006/main" noGrp="1"/>
+          </p:cNvSpPr>
+          <p:nvPr/>
+        </p:nvSpPr>
+        <p:spPr>
+          <a:xfrm xmlns:a="http://schemas.openxmlformats.org/drawingml/2006/main">
+            <a:off x="3448050" y="4743450"/>
+            <a:ext cx="76200" cy="76200"/>
+          </a:xfrm>
+          <a:prstGeom xmlns:a="http://schemas.openxmlformats.org/drawingml/2006/main" prst="ellipse">
+            <a:avLst/>
+          </a:prstGeom>
+          <a:solidFill xmlns:a="http://schemas.openxmlformats.org/drawingml/2006/main">
+            <a:srgbClr val="0EA5E9"/>
+          </a:solidFill>
+          <a:ln xmlns:a="http://schemas.openxmlformats.org/drawingml/2006/main" w="0">
+            <a:noFill/>
+            <a:prstDash val="solid"/>
+          </a:ln>
+        </p:spPr>
+      </p:sp>
+      <p:sp>
+        <p:nvSpPr>
+          <p:cNvPr id="23" name="summary-item-2-3">
+            <a:extLst xmlns:a="http://schemas.openxmlformats.org/drawingml/2006/main">
+              <a:ext uri="{FF2B5EF4-FFF2-40B4-BE49-F238E27FC236}">
+                <a16:creationId xmlns:a16="http://schemas.microsoft.com/office/drawing/2014/main" id="{08E9C1E0-9197-484B-B25A-43905A97C0AC}"/>
+              </a:ext>
+            </a:extLst>
+          </p:cNvPr>
+          <p:cNvSpPr>
+            <a:spLocks xmlns:a="http://schemas.openxmlformats.org/drawingml/2006/main" noGrp="1"/>
+          </p:cNvSpPr>
+          <p:nvPr/>
+        </p:nvSpPr>
+        <p:spPr>
+          <a:xfrm xmlns:a="http://schemas.openxmlformats.org/drawingml/2006/main">
+            <a:off x="3638550" y="4667250"/>
+            <a:ext cx="2133600" cy="438150"/>
+          </a:xfrm>
+          <a:prstGeom xmlns:a="http://schemas.openxmlformats.org/drawingml/2006/main" prst="rect">
+            <a:avLst/>
+          </a:prstGeom>
+          <a:noFill xmlns:a="http://schemas.openxmlformats.org/drawingml/2006/main"/>
+          <a:ln xmlns:a="http://schemas.openxmlformats.org/drawingml/2006/main" w="0">
+            <a:noFill/>
+            <a:prstDash val="solid"/>
+          </a:ln>
+        </p:spPr>
+        <p:txBody>
+          <a:bodyPr xmlns:a="http://schemas.openxmlformats.org/drawingml/2006/main"/>
+          <a:lstStyle xmlns:a="http://schemas.openxmlformats.org/drawingml/2006/main"/>
+          <a:p xmlns:a="http://schemas.openxmlformats.org/drawingml/2006/main">
+            <a:pPr>
+              <a:buNone/>
+              <a:defRPr sz="1275">
+                <a:solidFill>
+                  <a:srgbClr val="374151"/>
+                </a:solidFill>
+              </a:defRPr>
+            </a:pPr>
+            <a:r>
+              <a:rPr sz="1275">
+                <a:solidFill>
+                  <a:srgbClr val="374151"/>
+                </a:solidFill>
+              </a:rPr>
+              <a:t>Log, durum ve hata bilgisini aynı deneyime bağlama</a:t>
+            </a:r>
+          </a:p>
+        </p:txBody>
+      </p:sp>
+      <p:sp>
+        <p:nvSpPr>
+          <p:cNvPr id="24" name="summary-accent-3">
+            <a:extLst xmlns:a="http://schemas.openxmlformats.org/drawingml/2006/main">
+              <a:ext uri="{FF2B5EF4-FFF2-40B4-BE49-F238E27FC236}">
+                <a16:creationId xmlns:a16="http://schemas.microsoft.com/office/drawing/2014/main" id="{DB4E2D7A-CD0B-4BE6-9D46-C5C24FECAF9C}"/>
+              </a:ext>
+            </a:extLst>
+          </p:cNvPr>
+          <p:cNvSpPr>
+            <a:spLocks xmlns:a="http://schemas.openxmlformats.org/drawingml/2006/main" noGrp="1"/>
+          </p:cNvSpPr>
+          <p:nvPr/>
+        </p:nvSpPr>
+        <p:spPr>
+          <a:xfrm xmlns:a="http://schemas.openxmlformats.org/drawingml/2006/main">
+            <a:off x="6324600" y="2247900"/>
+            <a:ext cx="2324100" cy="47625"/>
+          </a:xfrm>
+          <a:prstGeom xmlns:a="http://schemas.openxmlformats.org/drawingml/2006/main" prst="rect">
+            <a:avLst/>
+          </a:prstGeom>
+          <a:solidFill xmlns:a="http://schemas.openxmlformats.org/drawingml/2006/main">
+            <a:srgbClr val="22C55E"/>
+          </a:solidFill>
+          <a:ln xmlns:a="http://schemas.openxmlformats.org/drawingml/2006/main" w="0">
+            <a:noFill/>
+            <a:prstDash val="solid"/>
+          </a:ln>
+        </p:spPr>
+      </p:sp>
+      <p:sp>
+        <p:nvSpPr>
+          <p:cNvPr id="25" name="summary-column-title-3">
+            <a:extLst xmlns:a="http://schemas.openxmlformats.org/drawingml/2006/main">
+              <a:ext uri="{FF2B5EF4-FFF2-40B4-BE49-F238E27FC236}">
+                <a16:creationId xmlns:a16="http://schemas.microsoft.com/office/drawing/2014/main" id="{9542CB7D-BD85-4453-9A8F-BDF5C68A3215}"/>
+              </a:ext>
+            </a:extLst>
+          </p:cNvPr>
+          <p:cNvSpPr>
+            <a:spLocks xmlns:a="http://schemas.openxmlformats.org/drawingml/2006/main" noGrp="1"/>
+          </p:cNvSpPr>
+          <p:nvPr/>
+        </p:nvSpPr>
+        <p:spPr>
+          <a:xfrm xmlns:a="http://schemas.openxmlformats.org/drawingml/2006/main">
+            <a:off x="6324600" y="2457450"/>
+            <a:ext cx="2324100" cy="323850"/>
+          </a:xfrm>
+          <a:prstGeom xmlns:a="http://schemas.openxmlformats.org/drawingml/2006/main" prst="rect">
+            <a:avLst/>
+          </a:prstGeom>
+          <a:noFill xmlns:a="http://schemas.openxmlformats.org/drawingml/2006/main"/>
+          <a:ln xmlns:a="http://schemas.openxmlformats.org/drawingml/2006/main" w="0">
+            <a:noFill/>
+            <a:prstDash val="solid"/>
+          </a:ln>
+        </p:spPr>
+        <p:txBody>
+          <a:bodyPr xmlns:a="http://schemas.openxmlformats.org/drawingml/2006/main"/>
+          <a:lstStyle xmlns:a="http://schemas.openxmlformats.org/drawingml/2006/main"/>
+          <a:p xmlns:a="http://schemas.openxmlformats.org/drawingml/2006/main">
+            <a:pPr>
+              <a:buNone/>
+              <a:defRPr sz="1650" b="1">
+                <a:solidFill>
+                  <a:srgbClr val="111827"/>
+                </a:solidFill>
+              </a:defRPr>
+            </a:pPr>
+            <a:r>
+              <a:rPr sz="1650" b="1">
+                <a:solidFill>
+                  <a:srgbClr val="111827"/>
+                </a:solidFill>
+              </a:rPr>
+              <a:t>Sequence Planning</a:t>
+            </a:r>
+          </a:p>
+        </p:txBody>
+      </p:sp>
+      <p:sp>
+        <p:nvSpPr>
+          <p:cNvPr id="26" name="summary-dot-3-0">
+            <a:extLst xmlns:a="http://schemas.openxmlformats.org/drawingml/2006/main">
+              <a:ext uri="{FF2B5EF4-FFF2-40B4-BE49-F238E27FC236}">
+                <a16:creationId xmlns:a16="http://schemas.microsoft.com/office/drawing/2014/main" id="{57462B64-BB98-4779-B659-4B499F2FE7C7}"/>
+              </a:ext>
+            </a:extLst>
+          </p:cNvPr>
+          <p:cNvSpPr>
+            <a:spLocks xmlns:a="http://schemas.openxmlformats.org/drawingml/2006/main" noGrp="1"/>
+          </p:cNvSpPr>
+          <p:nvPr/>
+        </p:nvSpPr>
+        <p:spPr>
+          <a:xfrm xmlns:a="http://schemas.openxmlformats.org/drawingml/2006/main">
+            <a:off x="6324600" y="3086100"/>
+            <a:ext cx="76200" cy="76200"/>
+          </a:xfrm>
+          <a:prstGeom xmlns:a="http://schemas.openxmlformats.org/drawingml/2006/main" prst="ellipse">
+            <a:avLst/>
+          </a:prstGeom>
+          <a:solidFill xmlns:a="http://schemas.openxmlformats.org/drawingml/2006/main">
+            <a:srgbClr val="22C55E"/>
+          </a:solidFill>
+          <a:ln xmlns:a="http://schemas.openxmlformats.org/drawingml/2006/main" w="0">
+            <a:noFill/>
+            <a:prstDash val="solid"/>
+          </a:ln>
+        </p:spPr>
+      </p:sp>
+      <p:sp>
+        <p:nvSpPr>
+          <p:cNvPr id="27" name="summary-item-3-0">
+            <a:extLst xmlns:a="http://schemas.openxmlformats.org/drawingml/2006/main">
+              <a:ext uri="{FF2B5EF4-FFF2-40B4-BE49-F238E27FC236}">
+                <a16:creationId xmlns:a16="http://schemas.microsoft.com/office/drawing/2014/main" id="{085F348E-0A53-4897-8173-B558CBC1733D}"/>
+              </a:ext>
+            </a:extLst>
+          </p:cNvPr>
+          <p:cNvSpPr>
+            <a:spLocks xmlns:a="http://schemas.openxmlformats.org/drawingml/2006/main" noGrp="1"/>
+          </p:cNvSpPr>
+          <p:nvPr/>
+        </p:nvSpPr>
+        <p:spPr>
+          <a:xfrm xmlns:a="http://schemas.openxmlformats.org/drawingml/2006/main">
+            <a:off x="6515100" y="3009900"/>
+            <a:ext cx="2133600" cy="438150"/>
+          </a:xfrm>
+          <a:prstGeom xmlns:a="http://schemas.openxmlformats.org/drawingml/2006/main" prst="rect">
+            <a:avLst/>
+          </a:prstGeom>
+          <a:noFill xmlns:a="http://schemas.openxmlformats.org/drawingml/2006/main"/>
+          <a:ln xmlns:a="http://schemas.openxmlformats.org/drawingml/2006/main" w="0">
+            <a:noFill/>
+            <a:prstDash val="solid"/>
+          </a:ln>
+        </p:spPr>
+        <p:txBody>
+          <a:bodyPr xmlns:a="http://schemas.openxmlformats.org/drawingml/2006/main"/>
+          <a:lstStyle xmlns:a="http://schemas.openxmlformats.org/drawingml/2006/main"/>
+          <a:p xmlns:a="http://schemas.openxmlformats.org/drawingml/2006/main">
+            <a:pPr>
+              <a:buNone/>
+              <a:defRPr sz="1275">
+                <a:solidFill>
+                  <a:srgbClr val="374151"/>
+                </a:solidFill>
+              </a:defRPr>
+            </a:pPr>
+            <a:r>
+              <a:rPr sz="1275">
+                <a:solidFill>
+                  <a:srgbClr val="374151"/>
+                </a:solidFill>
+              </a:rPr>
+              <a:t>Add Point ve Pose Capture ile hareket noktası kaydı</a:t>
+            </a:r>
+          </a:p>
+        </p:txBody>
+      </p:sp>
+      <p:sp>
+        <p:nvSpPr>
+          <p:cNvPr id="28" name="summary-dot-3-1">
+            <a:extLst xmlns:a="http://schemas.openxmlformats.org/drawingml/2006/main">
+              <a:ext uri="{FF2B5EF4-FFF2-40B4-BE49-F238E27FC236}">
+                <a16:creationId xmlns:a16="http://schemas.microsoft.com/office/drawing/2014/main" id="{798A8D34-1722-480C-941A-F7BF126B33E5}"/>
+              </a:ext>
+            </a:extLst>
+          </p:cNvPr>
+          <p:cNvSpPr>
+            <a:spLocks xmlns:a="http://schemas.openxmlformats.org/drawingml/2006/main" noGrp="1"/>
+          </p:cNvSpPr>
+          <p:nvPr/>
+        </p:nvSpPr>
+        <p:spPr>
+          <a:xfrm xmlns:a="http://schemas.openxmlformats.org/drawingml/2006/main">
+            <a:off x="6324600" y="3638550"/>
+            <a:ext cx="76200" cy="76200"/>
+          </a:xfrm>
+          <a:prstGeom xmlns:a="http://schemas.openxmlformats.org/drawingml/2006/main" prst="ellipse">
+            <a:avLst/>
+          </a:prstGeom>
+          <a:solidFill xmlns:a="http://schemas.openxmlformats.org/drawingml/2006/main">
+            <a:srgbClr val="22C55E"/>
+          </a:solidFill>
+          <a:ln xmlns:a="http://schemas.openxmlformats.org/drawingml/2006/main" w="0">
+            <a:noFill/>
+            <a:prstDash val="solid"/>
+          </a:ln>
+        </p:spPr>
+      </p:sp>
+      <p:sp>
+        <p:nvSpPr>
+          <p:cNvPr id="29" name="summary-item-3-1">
+            <a:extLst xmlns:a="http://schemas.openxmlformats.org/drawingml/2006/main">
+              <a:ext uri="{FF2B5EF4-FFF2-40B4-BE49-F238E27FC236}">
+                <a16:creationId xmlns:a16="http://schemas.microsoft.com/office/drawing/2014/main" id="{A30FF992-1702-4567-9D98-7D9D21ED0241}"/>
+              </a:ext>
+            </a:extLst>
+          </p:cNvPr>
+          <p:cNvSpPr>
+            <a:spLocks xmlns:a="http://schemas.openxmlformats.org/drawingml/2006/main" noGrp="1"/>
+          </p:cNvSpPr>
+          <p:nvPr/>
+        </p:nvSpPr>
+        <p:spPr>
+          <a:xfrm xmlns:a="http://schemas.openxmlformats.org/drawingml/2006/main">
+            <a:off x="6515100" y="3562350"/>
+            <a:ext cx="2133600" cy="438150"/>
+          </a:xfrm>
+          <a:prstGeom xmlns:a="http://schemas.openxmlformats.org/drawingml/2006/main" prst="rect">
+            <a:avLst/>
+          </a:prstGeom>
+          <a:noFill xmlns:a="http://schemas.openxmlformats.org/drawingml/2006/main"/>
+          <a:ln xmlns:a="http://schemas.openxmlformats.org/drawingml/2006/main" w="0">
+            <a:noFill/>
+            <a:prstDash val="solid"/>
+          </a:ln>
+        </p:spPr>
+        <p:txBody>
+          <a:bodyPr xmlns:a="http://schemas.openxmlformats.org/drawingml/2006/main"/>
+          <a:lstStyle xmlns:a="http://schemas.openxmlformats.org/drawingml/2006/main"/>
+          <a:p xmlns:a="http://schemas.openxmlformats.org/drawingml/2006/main">
+            <a:pPr>
+              <a:buNone/>
+              <a:defRPr sz="1275">
+                <a:solidFill>
+                  <a:srgbClr val="374151"/>
+                </a:solidFill>
+              </a:defRPr>
+            </a:pPr>
+            <a:r>
+              <a:rPr sz="1275">
+                <a:solidFill>
+                  <a:srgbClr val="374151"/>
+                </a:solidFill>
+              </a:rPr>
+              <a:t>Sequence Builder ile tekrar oynatılabilir hareket</a:t>
+            </a:r>
+          </a:p>
+        </p:txBody>
+      </p:sp>
+      <p:sp>
+        <p:nvSpPr>
+          <p:cNvPr id="30" name="summary-dot-3-2">
+            <a:extLst xmlns:a="http://schemas.openxmlformats.org/drawingml/2006/main">
+              <a:ext uri="{FF2B5EF4-FFF2-40B4-BE49-F238E27FC236}">
+                <a16:creationId xmlns:a16="http://schemas.microsoft.com/office/drawing/2014/main" id="{CC2DDA57-9192-4ED7-BF8A-78A9F479042D}"/>
+              </a:ext>
+            </a:extLst>
+          </p:cNvPr>
+          <p:cNvSpPr>
+            <a:spLocks xmlns:a="http://schemas.openxmlformats.org/drawingml/2006/main" noGrp="1"/>
+          </p:cNvSpPr>
+          <p:nvPr/>
+        </p:nvSpPr>
+        <p:spPr>
+          <a:xfrm xmlns:a="http://schemas.openxmlformats.org/drawingml/2006/main">
+            <a:off x="6324600" y="4191000"/>
+            <a:ext cx="76200" cy="76200"/>
+          </a:xfrm>
+          <a:prstGeom xmlns:a="http://schemas.openxmlformats.org/drawingml/2006/main" prst="ellipse">
+            <a:avLst/>
+          </a:prstGeom>
+          <a:solidFill xmlns:a="http://schemas.openxmlformats.org/drawingml/2006/main">
+            <a:srgbClr val="22C55E"/>
+          </a:solidFill>
+          <a:ln xmlns:a="http://schemas.openxmlformats.org/drawingml/2006/main" w="0">
+            <a:noFill/>
+            <a:prstDash val="solid"/>
+          </a:ln>
+        </p:spPr>
+      </p:sp>
+      <p:sp>
+        <p:nvSpPr>
+          <p:cNvPr id="31" name="summary-item-3-2">
+            <a:extLst xmlns:a="http://schemas.openxmlformats.org/drawingml/2006/main">
+              <a:ext uri="{FF2B5EF4-FFF2-40B4-BE49-F238E27FC236}">
+                <a16:creationId xmlns:a16="http://schemas.microsoft.com/office/drawing/2014/main" id="{44C264DE-0344-4E9E-B0B5-3BA72D057EAA}"/>
+              </a:ext>
+            </a:extLst>
+          </p:cNvPr>
+          <p:cNvSpPr>
+            <a:spLocks xmlns:a="http://schemas.openxmlformats.org/drawingml/2006/main" noGrp="1"/>
+          </p:cNvSpPr>
+          <p:nvPr/>
+        </p:nvSpPr>
+        <p:spPr>
+          <a:xfrm xmlns:a="http://schemas.openxmlformats.org/drawingml/2006/main">
+            <a:off x="6515100" y="4114800"/>
+            <a:ext cx="2133600" cy="438150"/>
+          </a:xfrm>
+          <a:prstGeom xmlns:a="http://schemas.openxmlformats.org/drawingml/2006/main" prst="rect">
+            <a:avLst/>
+          </a:prstGeom>
+          <a:noFill xmlns:a="http://schemas.openxmlformats.org/drawingml/2006/main"/>
+          <a:ln xmlns:a="http://schemas.openxmlformats.org/drawingml/2006/main" w="0">
+            <a:noFill/>
+            <a:prstDash val="solid"/>
+          </a:ln>
+        </p:spPr>
+        <p:txBody>
+          <a:bodyPr xmlns:a="http://schemas.openxmlformats.org/drawingml/2006/main"/>
+          <a:lstStyle xmlns:a="http://schemas.openxmlformats.org/drawingml/2006/main"/>
+          <a:p xmlns:a="http://schemas.openxmlformats.org/drawingml/2006/main">
+            <a:pPr>
+              <a:buNone/>
+              <a:defRPr sz="1275">
+                <a:solidFill>
+                  <a:srgbClr val="374151"/>
+                </a:solidFill>
+              </a:defRPr>
+            </a:pPr>
+            <a:r>
+              <a:rPr sz="1275">
+                <a:solidFill>
+                  <a:srgbClr val="374151"/>
+                </a:solidFill>
+              </a:rPr>
+              <a:t>Trajectory Planning ile hareket önizleme</a:t>
+            </a:r>
+          </a:p>
+        </p:txBody>
+      </p:sp>
+      <p:sp>
+        <p:nvSpPr>
+          <p:cNvPr id="32" name="summary-dot-3-3">
+            <a:extLst xmlns:a="http://schemas.openxmlformats.org/drawingml/2006/main">
+              <a:ext uri="{FF2B5EF4-FFF2-40B4-BE49-F238E27FC236}">
+                <a16:creationId xmlns:a16="http://schemas.microsoft.com/office/drawing/2014/main" id="{77F26244-1A37-4C2C-8191-EF0A43F386EB}"/>
+              </a:ext>
+            </a:extLst>
+          </p:cNvPr>
+          <p:cNvSpPr>
+            <a:spLocks xmlns:a="http://schemas.openxmlformats.org/drawingml/2006/main" noGrp="1"/>
+          </p:cNvSpPr>
+          <p:nvPr/>
+        </p:nvSpPr>
+        <p:spPr>
+          <a:xfrm xmlns:a="http://schemas.openxmlformats.org/drawingml/2006/main">
+            <a:off x="6324600" y="4743450"/>
+            <a:ext cx="76200" cy="76200"/>
+          </a:xfrm>
+          <a:prstGeom xmlns:a="http://schemas.openxmlformats.org/drawingml/2006/main" prst="ellipse">
+            <a:avLst/>
+          </a:prstGeom>
+          <a:solidFill xmlns:a="http://schemas.openxmlformats.org/drawingml/2006/main">
+            <a:srgbClr val="22C55E"/>
+          </a:solidFill>
+          <a:ln xmlns:a="http://schemas.openxmlformats.org/drawingml/2006/main" w="0">
+            <a:noFill/>
+            <a:prstDash val="solid"/>
+          </a:ln>
+        </p:spPr>
+      </p:sp>
+      <p:sp>
+        <p:nvSpPr>
+          <p:cNvPr id="33" name="summary-item-3-3">
+            <a:extLst xmlns:a="http://schemas.openxmlformats.org/drawingml/2006/main">
+              <a:ext uri="{FF2B5EF4-FFF2-40B4-BE49-F238E27FC236}">
+                <a16:creationId xmlns:a16="http://schemas.microsoft.com/office/drawing/2014/main" id="{4A34C9D7-E7A7-4B69-9B46-432A309D0C93}"/>
+              </a:ext>
+            </a:extLst>
+          </p:cNvPr>
+          <p:cNvSpPr>
+            <a:spLocks xmlns:a="http://schemas.openxmlformats.org/drawingml/2006/main" noGrp="1"/>
+          </p:cNvSpPr>
+          <p:nvPr/>
+        </p:nvSpPr>
+        <p:spPr>
+          <a:xfrm xmlns:a="http://schemas.openxmlformats.org/drawingml/2006/main">
+            <a:off x="6515100" y="4667250"/>
+            <a:ext cx="2133600" cy="438150"/>
+          </a:xfrm>
+          <a:prstGeom xmlns:a="http://schemas.openxmlformats.org/drawingml/2006/main" prst="rect">
+            <a:avLst/>
+          </a:prstGeom>
+          <a:noFill xmlns:a="http://schemas.openxmlformats.org/drawingml/2006/main"/>
+          <a:ln xmlns:a="http://schemas.openxmlformats.org/drawingml/2006/main" w="0">
+            <a:noFill/>
+            <a:prstDash val="solid"/>
+          </a:ln>
+        </p:spPr>
+        <p:txBody>
+          <a:bodyPr xmlns:a="http://schemas.openxmlformats.org/drawingml/2006/main"/>
+          <a:lstStyle xmlns:a="http://schemas.openxmlformats.org/drawingml/2006/main"/>
+          <a:p xmlns:a="http://schemas.openxmlformats.org/drawingml/2006/main">
+            <a:pPr>
+              <a:buNone/>
+              <a:defRPr sz="1275">
+                <a:solidFill>
+                  <a:srgbClr val="374151"/>
+                </a:solidFill>
+              </a:defRPr>
+            </a:pPr>
+            <a:r>
+              <a:rPr sz="1275">
+                <a:solidFill>
+                  <a:srgbClr val="374151"/>
+                </a:solidFill>
+              </a:rPr>
+              <a:t>Crazy Seconds / demo timing ile sahneye hazır akış</a:t>
+            </a:r>
+          </a:p>
+        </p:txBody>
+      </p:sp>
+      <p:sp>
+        <p:nvSpPr>
+          <p:cNvPr id="34" name="summary-accent-4">
+            <a:extLst xmlns:a="http://schemas.openxmlformats.org/drawingml/2006/main">
+              <a:ext uri="{FF2B5EF4-FFF2-40B4-BE49-F238E27FC236}">
+                <a16:creationId xmlns:a16="http://schemas.microsoft.com/office/drawing/2014/main" id="{2B3B6C7C-D2B3-4E47-8004-DF727B22BF4D}"/>
+              </a:ext>
+            </a:extLst>
+          </p:cNvPr>
+          <p:cNvSpPr>
+            <a:spLocks xmlns:a="http://schemas.openxmlformats.org/drawingml/2006/main" noGrp="1"/>
+          </p:cNvSpPr>
+          <p:nvPr/>
+        </p:nvSpPr>
+        <p:spPr>
+          <a:xfrm xmlns:a="http://schemas.openxmlformats.org/drawingml/2006/main">
+            <a:off x="9201150" y="2247900"/>
+            <a:ext cx="2324100" cy="47625"/>
+          </a:xfrm>
+          <a:prstGeom xmlns:a="http://schemas.openxmlformats.org/drawingml/2006/main" prst="rect">
+            <a:avLst/>
+          </a:prstGeom>
+          <a:solidFill xmlns:a="http://schemas.openxmlformats.org/drawingml/2006/main">
+            <a:srgbClr val="F97316"/>
+          </a:solidFill>
+          <a:ln xmlns:a="http://schemas.openxmlformats.org/drawingml/2006/main" w="0">
+            <a:noFill/>
+            <a:prstDash val="solid"/>
+          </a:ln>
+        </p:spPr>
+      </p:sp>
+      <p:sp>
+        <p:nvSpPr>
+          <p:cNvPr id="35" name="summary-column-title-4">
+            <a:extLst xmlns:a="http://schemas.openxmlformats.org/drawingml/2006/main">
+              <a:ext uri="{FF2B5EF4-FFF2-40B4-BE49-F238E27FC236}">
+                <a16:creationId xmlns:a16="http://schemas.microsoft.com/office/drawing/2014/main" id="{DF069BEB-1216-48D1-A984-4C1A8245CFC5}"/>
+              </a:ext>
+            </a:extLst>
+          </p:cNvPr>
+          <p:cNvSpPr>
+            <a:spLocks xmlns:a="http://schemas.openxmlformats.org/drawingml/2006/main" noGrp="1"/>
+          </p:cNvSpPr>
+          <p:nvPr/>
+        </p:nvSpPr>
+        <p:spPr>
+          <a:xfrm xmlns:a="http://schemas.openxmlformats.org/drawingml/2006/main">
+            <a:off x="9201150" y="2457450"/>
+            <a:ext cx="2324100" cy="323850"/>
+          </a:xfrm>
+          <a:prstGeom xmlns:a="http://schemas.openxmlformats.org/drawingml/2006/main" prst="rect">
+            <a:avLst/>
+          </a:prstGeom>
+          <a:noFill xmlns:a="http://schemas.openxmlformats.org/drawingml/2006/main"/>
+          <a:ln xmlns:a="http://schemas.openxmlformats.org/drawingml/2006/main" w="0">
+            <a:noFill/>
+            <a:prstDash val="solid"/>
+          </a:ln>
+        </p:spPr>
+        <p:txBody>
+          <a:bodyPr xmlns:a="http://schemas.openxmlformats.org/drawingml/2006/main"/>
+          <a:lstStyle xmlns:a="http://schemas.openxmlformats.org/drawingml/2006/main"/>
+          <a:p xmlns:a="http://schemas.openxmlformats.org/drawingml/2006/main">
+            <a:pPr>
+              <a:buNone/>
+              <a:defRPr sz="1650" b="1">
+                <a:solidFill>
+                  <a:srgbClr val="111827"/>
+                </a:solidFill>
+              </a:defRPr>
+            </a:pPr>
+            <a:r>
+              <a:rPr sz="1650" b="1">
+                <a:solidFill>
+                  <a:srgbClr val="111827"/>
+                </a:solidFill>
+              </a:rPr>
+              <a:t>Doğrulama</a:t>
+            </a:r>
+          </a:p>
+        </p:txBody>
+      </p:sp>
+      <p:sp>
+        <p:nvSpPr>
+          <p:cNvPr id="36" name="summary-dot-4-0">
+            <a:extLst xmlns:a="http://schemas.openxmlformats.org/drawingml/2006/main">
+              <a:ext uri="{FF2B5EF4-FFF2-40B4-BE49-F238E27FC236}">
+                <a16:creationId xmlns:a16="http://schemas.microsoft.com/office/drawing/2014/main" id="{46BF30B7-66F6-45ED-B6EF-6A64DD8D99D1}"/>
+              </a:ext>
+            </a:extLst>
+          </p:cNvPr>
+          <p:cNvSpPr>
+            <a:spLocks xmlns:a="http://schemas.openxmlformats.org/drawingml/2006/main" noGrp="1"/>
+          </p:cNvSpPr>
+          <p:nvPr/>
+        </p:nvSpPr>
+        <p:spPr>
+          <a:xfrm xmlns:a="http://schemas.openxmlformats.org/drawingml/2006/main">
+            <a:off x="9201150" y="3086100"/>
+            <a:ext cx="76200" cy="76200"/>
+          </a:xfrm>
+          <a:prstGeom xmlns:a="http://schemas.openxmlformats.org/drawingml/2006/main" prst="ellipse">
+            <a:avLst/>
+          </a:prstGeom>
+          <a:solidFill xmlns:a="http://schemas.openxmlformats.org/drawingml/2006/main">
+            <a:srgbClr val="F97316"/>
+          </a:solidFill>
+          <a:ln xmlns:a="http://schemas.openxmlformats.org/drawingml/2006/main" w="0">
+            <a:noFill/>
+            <a:prstDash val="solid"/>
+          </a:ln>
+        </p:spPr>
+      </p:sp>
+      <p:sp>
+        <p:nvSpPr>
+          <p:cNvPr id="37" name="summary-item-4-0">
+            <a:extLst xmlns:a="http://schemas.openxmlformats.org/drawingml/2006/main">
+              <a:ext uri="{FF2B5EF4-FFF2-40B4-BE49-F238E27FC236}">
+                <a16:creationId xmlns:a16="http://schemas.microsoft.com/office/drawing/2014/main" id="{CCC25C07-1392-47D4-A6DC-1C519829BF9D}"/>
+              </a:ext>
+            </a:extLst>
+          </p:cNvPr>
+          <p:cNvSpPr>
+            <a:spLocks xmlns:a="http://schemas.openxmlformats.org/drawingml/2006/main" noGrp="1"/>
+          </p:cNvSpPr>
+          <p:nvPr/>
+        </p:nvSpPr>
+        <p:spPr>
+          <a:xfrm xmlns:a="http://schemas.openxmlformats.org/drawingml/2006/main">
+            <a:off x="9391650" y="3009900"/>
+            <a:ext cx="2133600" cy="438150"/>
+          </a:xfrm>
+          <a:prstGeom xmlns:a="http://schemas.openxmlformats.org/drawingml/2006/main" prst="rect">
+            <a:avLst/>
+          </a:prstGeom>
+          <a:noFill xmlns:a="http://schemas.openxmlformats.org/drawingml/2006/main"/>
+          <a:ln xmlns:a="http://schemas.openxmlformats.org/drawingml/2006/main" w="0">
+            <a:noFill/>
+            <a:prstDash val="solid"/>
+          </a:ln>
+        </p:spPr>
+        <p:txBody>
+          <a:bodyPr xmlns:a="http://schemas.openxmlformats.org/drawingml/2006/main"/>
+          <a:lstStyle xmlns:a="http://schemas.openxmlformats.org/drawingml/2006/main"/>
+          <a:p xmlns:a="http://schemas.openxmlformats.org/drawingml/2006/main">
+            <a:pPr>
+              <a:buNone/>
+              <a:defRPr sz="1275">
+                <a:solidFill>
+                  <a:srgbClr val="374151"/>
+                </a:solidFill>
+              </a:defRPr>
+            </a:pPr>
+            <a:r>
+              <a:rPr sz="1275">
+                <a:solidFill>
+                  <a:srgbClr val="374151"/>
+                </a:solidFill>
+              </a:rPr>
+              <a:t>IK çözüm hatasını cm seviyesinde izleme</a:t>
+            </a:r>
+          </a:p>
+        </p:txBody>
+      </p:sp>
+      <p:sp>
+        <p:nvSpPr>
+          <p:cNvPr id="38" name="summary-dot-4-1">
+            <a:extLst xmlns:a="http://schemas.openxmlformats.org/drawingml/2006/main">
+              <a:ext uri="{FF2B5EF4-FFF2-40B4-BE49-F238E27FC236}">
+                <a16:creationId xmlns:a16="http://schemas.microsoft.com/office/drawing/2014/main" id="{59DCD151-D03D-49E5-BAF1-54119ECDF6C0}"/>
+              </a:ext>
+            </a:extLst>
+          </p:cNvPr>
+          <p:cNvSpPr>
+            <a:spLocks xmlns:a="http://schemas.openxmlformats.org/drawingml/2006/main" noGrp="1"/>
+          </p:cNvSpPr>
+          <p:nvPr/>
+        </p:nvSpPr>
+        <p:spPr>
+          <a:xfrm xmlns:a="http://schemas.openxmlformats.org/drawingml/2006/main">
+            <a:off x="9201150" y="3638550"/>
+            <a:ext cx="76200" cy="76200"/>
+          </a:xfrm>
+          <a:prstGeom xmlns:a="http://schemas.openxmlformats.org/drawingml/2006/main" prst="ellipse">
+            <a:avLst/>
+          </a:prstGeom>
+          <a:solidFill xmlns:a="http://schemas.openxmlformats.org/drawingml/2006/main">
+            <a:srgbClr val="F97316"/>
+          </a:solidFill>
+          <a:ln xmlns:a="http://schemas.openxmlformats.org/drawingml/2006/main" w="0">
+            <a:noFill/>
+            <a:prstDash val="solid"/>
+          </a:ln>
+        </p:spPr>
+      </p:sp>
+      <p:sp>
+        <p:nvSpPr>
+          <p:cNvPr id="39" name="summary-item-4-1">
+            <a:extLst xmlns:a="http://schemas.openxmlformats.org/drawingml/2006/main">
+              <a:ext uri="{FF2B5EF4-FFF2-40B4-BE49-F238E27FC236}">
+                <a16:creationId xmlns:a16="http://schemas.microsoft.com/office/drawing/2014/main" id="{1C934687-CCD9-413D-BBFA-1CC914303840}"/>
+              </a:ext>
+            </a:extLst>
+          </p:cNvPr>
+          <p:cNvSpPr>
+            <a:spLocks xmlns:a="http://schemas.openxmlformats.org/drawingml/2006/main" noGrp="1"/>
+          </p:cNvSpPr>
+          <p:nvPr/>
+        </p:nvSpPr>
+        <p:spPr>
+          <a:xfrm xmlns:a="http://schemas.openxmlformats.org/drawingml/2006/main">
+            <a:off x="9391650" y="3562350"/>
+            <a:ext cx="2133600" cy="438150"/>
+          </a:xfrm>
+          <a:prstGeom xmlns:a="http://schemas.openxmlformats.org/drawingml/2006/main" prst="rect">
+            <a:avLst/>
+          </a:prstGeom>
+          <a:noFill xmlns:a="http://schemas.openxmlformats.org/drawingml/2006/main"/>
+          <a:ln xmlns:a="http://schemas.openxmlformats.org/drawingml/2006/main" w="0">
+            <a:noFill/>
+            <a:prstDash val="solid"/>
+          </a:ln>
+        </p:spPr>
+        <p:txBody>
+          <a:bodyPr xmlns:a="http://schemas.openxmlformats.org/drawingml/2006/main"/>
+          <a:lstStyle xmlns:a="http://schemas.openxmlformats.org/drawingml/2006/main"/>
+          <a:p xmlns:a="http://schemas.openxmlformats.org/drawingml/2006/main">
+            <a:pPr>
+              <a:buNone/>
+              <a:defRPr sz="1275">
+                <a:solidFill>
+                  <a:srgbClr val="374151"/>
+                </a:solidFill>
+              </a:defRPr>
+            </a:pPr>
+            <a:r>
+              <a:rPr sz="1275">
+                <a:solidFill>
+                  <a:srgbClr val="374151"/>
+                </a:solidFill>
+              </a:rPr>
+              <a:t>Bounds ve eklem limitleriyle güvenli sınır kontrolü</a:t>
+            </a:r>
+          </a:p>
+        </p:txBody>
+      </p:sp>
+      <p:sp>
+        <p:nvSpPr>
+          <p:cNvPr id="40" name="summary-dot-4-2">
+            <a:extLst xmlns:a="http://schemas.openxmlformats.org/drawingml/2006/main">
+              <a:ext uri="{FF2B5EF4-FFF2-40B4-BE49-F238E27FC236}">
+                <a16:creationId xmlns:a16="http://schemas.microsoft.com/office/drawing/2014/main" id="{876A55B3-C675-4707-B33C-7575D67B8BC1}"/>
+              </a:ext>
+            </a:extLst>
+          </p:cNvPr>
+          <p:cNvSpPr>
+            <a:spLocks xmlns:a="http://schemas.openxmlformats.org/drawingml/2006/main" noGrp="1"/>
+          </p:cNvSpPr>
+          <p:nvPr/>
+        </p:nvSpPr>
+        <p:spPr>
+          <a:xfrm xmlns:a="http://schemas.openxmlformats.org/drawingml/2006/main">
+            <a:off x="9201150" y="4191000"/>
+            <a:ext cx="76200" cy="76200"/>
+          </a:xfrm>
+          <a:prstGeom xmlns:a="http://schemas.openxmlformats.org/drawingml/2006/main" prst="ellipse">
+            <a:avLst/>
+          </a:prstGeom>
+          <a:solidFill xmlns:a="http://schemas.openxmlformats.org/drawingml/2006/main">
+            <a:srgbClr val="F97316"/>
+          </a:solidFill>
+          <a:ln xmlns:a="http://schemas.openxmlformats.org/drawingml/2006/main" w="0">
+            <a:noFill/>
+            <a:prstDash val="solid"/>
+          </a:ln>
+        </p:spPr>
+      </p:sp>
+      <p:sp>
+        <p:nvSpPr>
+          <p:cNvPr id="41" name="summary-item-4-2">
+            <a:extLst xmlns:a="http://schemas.openxmlformats.org/drawingml/2006/main">
+              <a:ext uri="{FF2B5EF4-FFF2-40B4-BE49-F238E27FC236}">
+                <a16:creationId xmlns:a16="http://schemas.microsoft.com/office/drawing/2014/main" id="{7BD7F432-15B1-49E2-9039-A400CC69987B}"/>
+              </a:ext>
+            </a:extLst>
+          </p:cNvPr>
+          <p:cNvSpPr>
+            <a:spLocks xmlns:a="http://schemas.openxmlformats.org/drawingml/2006/main" noGrp="1"/>
+          </p:cNvSpPr>
+          <p:nvPr/>
+        </p:nvSpPr>
+        <p:spPr>
+          <a:xfrm xmlns:a="http://schemas.openxmlformats.org/drawingml/2006/main">
+            <a:off x="9391650" y="4114800"/>
+            <a:ext cx="2133600" cy="438150"/>
+          </a:xfrm>
+          <a:prstGeom xmlns:a="http://schemas.openxmlformats.org/drawingml/2006/main" prst="rect">
+            <a:avLst/>
+          </a:prstGeom>
+          <a:noFill xmlns:a="http://schemas.openxmlformats.org/drawingml/2006/main"/>
+          <a:ln xmlns:a="http://schemas.openxmlformats.org/drawingml/2006/main" w="0">
+            <a:noFill/>
+            <a:prstDash val="solid"/>
+          </a:ln>
+        </p:spPr>
+        <p:txBody>
+          <a:bodyPr xmlns:a="http://schemas.openxmlformats.org/drawingml/2006/main"/>
+          <a:lstStyle xmlns:a="http://schemas.openxmlformats.org/drawingml/2006/main"/>
+          <a:p xmlns:a="http://schemas.openxmlformats.org/drawingml/2006/main">
+            <a:pPr>
+              <a:buNone/>
+              <a:defRPr sz="1275">
+                <a:solidFill>
+                  <a:srgbClr val="374151"/>
+                </a:solidFill>
+              </a:defRPr>
+            </a:pPr>
+            <a:r>
+              <a:rPr sz="1275">
+                <a:solidFill>
+                  <a:srgbClr val="374151"/>
+                </a:solidFill>
+              </a:rPr>
+              <a:t>Simülasyon, hedef replay ve referans karşılaştırması</a:t>
+            </a:r>
+          </a:p>
+        </p:txBody>
+      </p:sp>
+      <p:sp>
+        <p:nvSpPr>
+          <p:cNvPr id="42" name="summary-dot-4-3">
+            <a:extLst xmlns:a="http://schemas.openxmlformats.org/drawingml/2006/main">
+              <a:ext uri="{FF2B5EF4-FFF2-40B4-BE49-F238E27FC236}">
+                <a16:creationId xmlns:a16="http://schemas.microsoft.com/office/drawing/2014/main" id="{5E75EF89-CD79-4D07-9D0D-AA682D58DD24}"/>
+              </a:ext>
+            </a:extLst>
+          </p:cNvPr>
+          <p:cNvSpPr>
+            <a:spLocks xmlns:a="http://schemas.openxmlformats.org/drawingml/2006/main" noGrp="1"/>
+          </p:cNvSpPr>
+          <p:nvPr/>
+        </p:nvSpPr>
+        <p:spPr>
+          <a:xfrm xmlns:a="http://schemas.openxmlformats.org/drawingml/2006/main">
+            <a:off x="9201150" y="4743450"/>
+            <a:ext cx="76200" cy="76200"/>
+          </a:xfrm>
+          <a:prstGeom xmlns:a="http://schemas.openxmlformats.org/drawingml/2006/main" prst="ellipse">
+            <a:avLst/>
+          </a:prstGeom>
+          <a:solidFill xmlns:a="http://schemas.openxmlformats.org/drawingml/2006/main">
+            <a:srgbClr val="F97316"/>
+          </a:solidFill>
+          <a:ln xmlns:a="http://schemas.openxmlformats.org/drawingml/2006/main" w="0">
+            <a:noFill/>
+            <a:prstDash val="solid"/>
+          </a:ln>
+        </p:spPr>
+      </p:sp>
+      <p:sp>
+        <p:nvSpPr>
+          <p:cNvPr id="43" name="summary-item-4-3">
+            <a:extLst xmlns:a="http://schemas.openxmlformats.org/drawingml/2006/main">
+              <a:ext uri="{FF2B5EF4-FFF2-40B4-BE49-F238E27FC236}">
+                <a16:creationId xmlns:a16="http://schemas.microsoft.com/office/drawing/2014/main" id="{28B2257B-7CF8-47A6-898F-B0327ABB3D2E}"/>
+              </a:ext>
+            </a:extLst>
+          </p:cNvPr>
+          <p:cNvSpPr>
+            <a:spLocks xmlns:a="http://schemas.openxmlformats.org/drawingml/2006/main" noGrp="1"/>
+          </p:cNvSpPr>
+          <p:nvPr/>
+        </p:nvSpPr>
+        <p:spPr>
+          <a:xfrm xmlns:a="http://schemas.openxmlformats.org/drawingml/2006/main">
+            <a:off x="9391650" y="4667250"/>
+            <a:ext cx="2133600" cy="438150"/>
+          </a:xfrm>
+          <a:prstGeom xmlns:a="http://schemas.openxmlformats.org/drawingml/2006/main" prst="rect">
+            <a:avLst/>
+          </a:prstGeom>
+          <a:noFill xmlns:a="http://schemas.openxmlformats.org/drawingml/2006/main"/>
+          <a:ln xmlns:a="http://schemas.openxmlformats.org/drawingml/2006/main" w="0">
+            <a:noFill/>
+            <a:prstDash val="solid"/>
+          </a:ln>
+        </p:spPr>
+        <p:txBody>
+          <a:bodyPr xmlns:a="http://schemas.openxmlformats.org/drawingml/2006/main"/>
+          <a:lstStyle xmlns:a="http://schemas.openxmlformats.org/drawingml/2006/main"/>
+          <a:p xmlns:a="http://schemas.openxmlformats.org/drawingml/2006/main">
+            <a:pPr>
+              <a:buNone/>
+              <a:defRPr sz="1275">
+                <a:solidFill>
+                  <a:srgbClr val="374151"/>
+                </a:solidFill>
+              </a:defRPr>
+            </a:pPr>
+            <a:r>
+              <a:rPr sz="1275">
+                <a:solidFill>
+                  <a:srgbClr val="374151"/>
+                </a:solidFill>
+              </a:rPr>
+              <a:t>Save Real Robot Motion için doğrulama kapısı</a:t>
+            </a:r>
+          </a:p>
+        </p:txBody>
+      </p:sp>
+      <p:sp>
+        <p:nvSpPr>
+          <p:cNvPr id="44" name="summary-footer-line">
+            <a:extLst xmlns:a="http://schemas.openxmlformats.org/drawingml/2006/main">
+              <a:ext uri="{FF2B5EF4-FFF2-40B4-BE49-F238E27FC236}">
+                <a16:creationId xmlns:a16="http://schemas.microsoft.com/office/drawing/2014/main" id="{A61945C7-053D-4731-AC9B-9DC5B7AD1B46}"/>
+              </a:ext>
+            </a:extLst>
+          </p:cNvPr>
+          <p:cNvSpPr>
+            <a:spLocks xmlns:a="http://schemas.openxmlformats.org/drawingml/2006/main" noGrp="1"/>
+          </p:cNvSpPr>
+          <p:nvPr/>
+        </p:nvSpPr>
+        <p:spPr>
+          <a:xfrm xmlns:a="http://schemas.openxmlformats.org/drawingml/2006/main">
+            <a:off x="552450" y="6324600"/>
+            <a:ext cx="11087100" cy="19050"/>
+          </a:xfrm>
+          <a:prstGeom xmlns:a="http://schemas.openxmlformats.org/drawingml/2006/main" prst="rect">
+            <a:avLst/>
+          </a:prstGeom>
+          <a:solidFill xmlns:a="http://schemas.openxmlformats.org/drawingml/2006/main">
+            <a:srgbClr val="E5E7EB"/>
+          </a:solidFill>
+          <a:ln xmlns:a="http://schemas.openxmlformats.org/drawingml/2006/main" w="0">
+            <a:noFill/>
+            <a:prstDash val="solid"/>
+          </a:ln>
+        </p:spPr>
+      </p:sp>
+      <p:sp>
+        <p:nvSpPr>
+          <p:cNvPr id="45" name="summary-footer">
+            <a:extLst xmlns:a="http://schemas.openxmlformats.org/drawingml/2006/main">
+              <a:ext uri="{FF2B5EF4-FFF2-40B4-BE49-F238E27FC236}">
+                <a16:creationId xmlns:a16="http://schemas.microsoft.com/office/drawing/2014/main" id="{A1392C9E-70A5-4E90-B45F-5740DA031D18}"/>
+              </a:ext>
+            </a:extLst>
+          </p:cNvPr>
+          <p:cNvSpPr>
+            <a:spLocks xmlns:a="http://schemas.openxmlformats.org/drawingml/2006/main" noGrp="1"/>
+          </p:cNvSpPr>
+          <p:nvPr/>
+        </p:nvSpPr>
+        <p:spPr>
+          <a:xfrm xmlns:a="http://schemas.openxmlformats.org/drawingml/2006/main">
+            <a:off x="571500" y="6496050"/>
+            <a:ext cx="10287000" cy="266700"/>
+          </a:xfrm>
+          <a:prstGeom xmlns:a="http://schemas.openxmlformats.org/drawingml/2006/main" prst="rect">
+            <a:avLst/>
+          </a:prstGeom>
+          <a:noFill xmlns:a="http://schemas.openxmlformats.org/drawingml/2006/main"/>
+          <a:ln xmlns:a="http://schemas.openxmlformats.org/drawingml/2006/main" w="0">
+            <a:noFill/>
+            <a:prstDash val="solid"/>
+          </a:ln>
+        </p:spPr>
+        <p:txBody>
+          <a:bodyPr xmlns:a="http://schemas.openxmlformats.org/drawingml/2006/main"/>
+          <a:lstStyle xmlns:a="http://schemas.openxmlformats.org/drawingml/2006/main"/>
+          <a:p xmlns:a="http://schemas.openxmlformats.org/drawingml/2006/main">
+            <a:pPr>
+              <a:buNone/>
+              <a:defRPr sz="1200">
+                <a:solidFill>
+                  <a:srgbClr val="64748B"/>
+                </a:solidFill>
+              </a:defRPr>
+            </a:pPr>
+            <a:r>
+              <a:rPr sz="1200">
+                <a:solidFill>
+                  <a:srgbClr val="64748B"/>
+                </a:solidFill>
+              </a:rPr>
+              <a:t>Kapsam dışı bırakılanlar: Camera Stream, Teleoperation / Remote Presence, VR walking control modes.</a:t>
+            </a:r>
+          </a:p>
+        </p:txBody>
+      </p:sp>
+    </p:spTree>
+    <p:extLst>
+      <p:ext uri="{BB962C8B-B14F-4D97-AF65-F5344CB8AC3E}">
+        <p14:creationId xmlns:p14="http://schemas.microsoft.com/office/powerpoint/2010/main" val="1369150701"/>
       </p:ext>
     </p:extLst>
   </p:cSld>

</xml_diff>

<commit_message>
Rewrite feature summary slide
</commit_message>
<xml_diff>
--- a/docs/presentations/Unitree-H1-Feature-Deck-v2.pptx
+++ b/docs/presentations/Unitree-H1-Feature-Deck-v2.pptx
@@ -2,19 +2,19 @@
 <file path=ppt/presentation.xml><?xml version="1.0" encoding="utf-8"?>
 <p:presentation xmlns:p="http://schemas.openxmlformats.org/presentationml/2006/main">
   <p:sldMasterIdLst>
-    <p:sldMasterId xmlns:r="http://schemas.openxmlformats.org/officeDocument/2006/relationships" id="2147483648" r:id="Rf5a708c8af804834"/>
+    <p:sldMasterId xmlns:r="http://schemas.openxmlformats.org/officeDocument/2006/relationships" id="2147483648" r:id="Rd52834c0a897429f"/>
   </p:sldMasterIdLst>
   <p:notesMasterIdLst>
-    <p:notesMasterId xmlns:r="http://schemas.openxmlformats.org/officeDocument/2006/relationships" r:id="R483f10ac9baf40ac"/>
+    <p:notesMasterId xmlns:r="http://schemas.openxmlformats.org/officeDocument/2006/relationships" r:id="R35954d57ec044653"/>
   </p:notesMasterIdLst>
   <p:sldIdLst>
-    <p:sldId xmlns:r="http://schemas.openxmlformats.org/officeDocument/2006/relationships" id="256" r:id="R928ba754636a4340"/>
-    <p:sldId xmlns:r="http://schemas.openxmlformats.org/officeDocument/2006/relationships" id="257" r:id="R9026cdac201a432e"/>
-    <p:sldId xmlns:r="http://schemas.openxmlformats.org/officeDocument/2006/relationships" id="258" r:id="R369ffc431f9f4686"/>
-    <p:sldId xmlns:r="http://schemas.openxmlformats.org/officeDocument/2006/relationships" id="259" r:id="R06519c45a0d24cdf"/>
-    <p:sldId xmlns:r="http://schemas.openxmlformats.org/officeDocument/2006/relationships" id="260" r:id="R3f389624006c4893"/>
-    <p:sldId xmlns:r="http://schemas.openxmlformats.org/officeDocument/2006/relationships" id="261" r:id="R7807236170ec4aa3"/>
-    <p:sldId xmlns:r="http://schemas.openxmlformats.org/officeDocument/2006/relationships" id="262" r:id="R1aa9750fa83f43a8"/>
+    <p:sldId xmlns:r="http://schemas.openxmlformats.org/officeDocument/2006/relationships" id="256" r:id="R43f99809b85043b1"/>
+    <p:sldId xmlns:r="http://schemas.openxmlformats.org/officeDocument/2006/relationships" id="257" r:id="R63d9557e32024a80"/>
+    <p:sldId xmlns:r="http://schemas.openxmlformats.org/officeDocument/2006/relationships" id="258" r:id="R4b65a4fadf4940d1"/>
+    <p:sldId xmlns:r="http://schemas.openxmlformats.org/officeDocument/2006/relationships" id="259" r:id="Rd9824f2f56d040a2"/>
+    <p:sldId xmlns:r="http://schemas.openxmlformats.org/officeDocument/2006/relationships" id="260" r:id="R1f66acc3f48148a7"/>
+    <p:sldId xmlns:r="http://schemas.openxmlformats.org/officeDocument/2006/relationships" id="261" r:id="Re7478522cd014b3a"/>
+    <p:sldId xmlns:r="http://schemas.openxmlformats.org/officeDocument/2006/relationships" id="262" r:id="R1157df7de8d0495d"/>
   </p:sldIdLst>
   <p:sldSz cx="12192000" cy="6858000"/>
   <p:notesSz cx="6858000" cy="9144000"/>
@@ -1003,7 +1003,7 @@
   </p:cSld>
   <p:clrMap bg1="lt1" tx1="dk1" bg2="lt2" tx2="dk2" accent1="accent1" accent2="accent2" accent3="accent3" accent4="accent4" accent5="accent5" accent6="accent6" hlink="hlink" folHlink="folHlink"/>
   <p:sldLayoutIdLst>
-    <p:sldLayoutId xmlns:r="http://schemas.openxmlformats.org/officeDocument/2006/relationships" id="2147483649" r:id="R2263436caf824c8f"/>
+    <p:sldLayoutId xmlns:r="http://schemas.openxmlformats.org/officeDocument/2006/relationships" id="2147483649" r:id="R30a9627f31e34770"/>
   </p:sldLayoutIdLst>
   <p:txStyles>
     <p:titleStyle>
@@ -1711,7 +1711,7 @@
           <p:nvPr/>
         </p:nvPicPr>
         <p:blipFill>
-          <a:blip xmlns:r="http://schemas.openxmlformats.org/officeDocument/2006/relationships" xmlns:a="http://schemas.openxmlformats.org/drawingml/2006/main" r:embed="Rda6126f5332b4f33"/>
+          <a:blip xmlns:r="http://schemas.openxmlformats.org/officeDocument/2006/relationships" xmlns:a="http://schemas.openxmlformats.org/drawingml/2006/main" r:embed="R451fee041b934acb"/>
           <a:srcRect xmlns:a="http://schemas.openxmlformats.org/drawingml/2006/main" l="0" t="30309" r="0" b="30309"/>
           <a:stretch xmlns:a="http://schemas.openxmlformats.org/drawingml/2006/main">
             <a:fillRect l="0" t="0" r="0" b="0"/>
@@ -2308,7 +2308,7 @@
           <p:nvPr/>
         </p:nvPicPr>
         <p:blipFill>
-          <a:blip xmlns:r="http://schemas.openxmlformats.org/officeDocument/2006/relationships" xmlns:a="http://schemas.openxmlformats.org/drawingml/2006/main" r:embed="Rd379307b234445dd"/>
+          <a:blip xmlns:r="http://schemas.openxmlformats.org/officeDocument/2006/relationships" xmlns:a="http://schemas.openxmlformats.org/drawingml/2006/main" r:embed="R47415d6e1adc46c0"/>
           <a:srcRect xmlns:a="http://schemas.openxmlformats.org/drawingml/2006/main" l="0" t="6000" r="0" b="6000"/>
           <a:stretch xmlns:a="http://schemas.openxmlformats.org/drawingml/2006/main">
             <a:fillRect l="0" t="0" r="0" b="0"/>
@@ -2333,7 +2333,7 @@
           <p:nvPr/>
         </p:nvPicPr>
         <p:blipFill>
-          <a:blip xmlns:r="http://schemas.openxmlformats.org/officeDocument/2006/relationships" xmlns:a="http://schemas.openxmlformats.org/drawingml/2006/main" r:embed="Rb18991a7f6c048e5"/>
+          <a:blip xmlns:r="http://schemas.openxmlformats.org/officeDocument/2006/relationships" xmlns:a="http://schemas.openxmlformats.org/drawingml/2006/main" r:embed="R7be6f6dc22324c79"/>
           <a:srcRect xmlns:a="http://schemas.openxmlformats.org/drawingml/2006/main" l="0" t="6000" r="0" b="6000"/>
           <a:stretch xmlns:a="http://schemas.openxmlformats.org/drawingml/2006/main">
             <a:fillRect l="0" t="0" r="0" b="0"/>
@@ -2358,7 +2358,7 @@
           <p:nvPr/>
         </p:nvPicPr>
         <p:blipFill>
-          <a:blip xmlns:r="http://schemas.openxmlformats.org/officeDocument/2006/relationships" xmlns:a="http://schemas.openxmlformats.org/drawingml/2006/main" r:embed="Rc08720ab3be146bc"/>
+          <a:blip xmlns:r="http://schemas.openxmlformats.org/officeDocument/2006/relationships" xmlns:a="http://schemas.openxmlformats.org/drawingml/2006/main" r:embed="R031300d2d2e94e30"/>
           <a:srcRect xmlns:a="http://schemas.openxmlformats.org/drawingml/2006/main" l="0" t="6000" r="0" b="6000"/>
           <a:stretch xmlns:a="http://schemas.openxmlformats.org/drawingml/2006/main">
             <a:fillRect l="0" t="0" r="0" b="0"/>
@@ -2649,7 +2649,7 @@
           <p:nvPr/>
         </p:nvPicPr>
         <p:blipFill>
-          <a:blip xmlns:r="http://schemas.openxmlformats.org/officeDocument/2006/relationships" xmlns:a="http://schemas.openxmlformats.org/drawingml/2006/main" r:embed="Rac50aaae81734013"/>
+          <a:blip xmlns:r="http://schemas.openxmlformats.org/officeDocument/2006/relationships" xmlns:a="http://schemas.openxmlformats.org/drawingml/2006/main" r:embed="Rafdd3da0a7544309"/>
           <a:srcRect xmlns:a="http://schemas.openxmlformats.org/drawingml/2006/main" l="18895" t="0" r="18895" b="0"/>
           <a:stretch xmlns:a="http://schemas.openxmlformats.org/drawingml/2006/main">
             <a:fillRect l="0" t="0" r="0" b="0"/>
@@ -3328,7 +3328,7 @@
           <p:nvPr/>
         </p:nvPicPr>
         <p:blipFill>
-          <a:blip xmlns:r="http://schemas.openxmlformats.org/officeDocument/2006/relationships" xmlns:a="http://schemas.openxmlformats.org/drawingml/2006/main" r:embed="R90709b062ca5488e"/>
+          <a:blip xmlns:r="http://schemas.openxmlformats.org/officeDocument/2006/relationships" xmlns:a="http://schemas.openxmlformats.org/drawingml/2006/main" r:embed="R71ba9ca9ea374fc5"/>
           <a:srcRect xmlns:a="http://schemas.openxmlformats.org/drawingml/2006/main" l="0" t="2134" r="0" b="2134"/>
           <a:stretch xmlns:a="http://schemas.openxmlformats.org/drawingml/2006/main">
             <a:fillRect l="0" t="0" r="0" b="0"/>
@@ -3353,7 +3353,7 @@
           <p:nvPr/>
         </p:nvPicPr>
         <p:blipFill>
-          <a:blip xmlns:r="http://schemas.openxmlformats.org/officeDocument/2006/relationships" xmlns:a="http://schemas.openxmlformats.org/drawingml/2006/main" r:embed="R554111e387914a7c"/>
+          <a:blip xmlns:r="http://schemas.openxmlformats.org/officeDocument/2006/relationships" xmlns:a="http://schemas.openxmlformats.org/drawingml/2006/main" r:embed="R0858e9d2f8db4ee3"/>
           <a:srcRect xmlns:a="http://schemas.openxmlformats.org/drawingml/2006/main" l="0" t="2134" r="0" b="2134"/>
           <a:stretch xmlns:a="http://schemas.openxmlformats.org/drawingml/2006/main">
             <a:fillRect l="0" t="0" r="0" b="0"/>
@@ -3378,7 +3378,7 @@
           <p:nvPr/>
         </p:nvPicPr>
         <p:blipFill>
-          <a:blip xmlns:r="http://schemas.openxmlformats.org/officeDocument/2006/relationships" xmlns:a="http://schemas.openxmlformats.org/drawingml/2006/main" r:embed="R68604bdef6d74394"/>
+          <a:blip xmlns:r="http://schemas.openxmlformats.org/officeDocument/2006/relationships" xmlns:a="http://schemas.openxmlformats.org/drawingml/2006/main" r:embed="R4949040a535440fd"/>
           <a:srcRect xmlns:a="http://schemas.openxmlformats.org/drawingml/2006/main" l="0" t="2134" r="0" b="2134"/>
           <a:stretch xmlns:a="http://schemas.openxmlformats.org/drawingml/2006/main">
             <a:fillRect l="0" t="0" r="0" b="0"/>
@@ -4462,7 +4462,7 @@
           <p:nvPr/>
         </p:nvPicPr>
         <p:blipFill>
-          <a:blip xmlns:r="http://schemas.openxmlformats.org/officeDocument/2006/relationships" xmlns:a="http://schemas.openxmlformats.org/drawingml/2006/main" r:embed="Re539b7c951f3428b"/>
+          <a:blip xmlns:r="http://schemas.openxmlformats.org/officeDocument/2006/relationships" xmlns:a="http://schemas.openxmlformats.org/drawingml/2006/main" r:embed="Rffa330312e9b4e14"/>
           <a:stretch xmlns:a="http://schemas.openxmlformats.org/drawingml/2006/main"/>
         </p:blipFill>
         <p:spPr>
@@ -5435,7 +5435,7 @@
           <p:nvPr/>
         </p:nvPicPr>
         <p:blipFill>
-          <a:blip xmlns:r="http://schemas.openxmlformats.org/officeDocument/2006/relationships" xmlns:a="http://schemas.openxmlformats.org/drawingml/2006/main" r:embed="R9cec525d4b6745dd"/>
+          <a:blip xmlns:r="http://schemas.openxmlformats.org/officeDocument/2006/relationships" xmlns:a="http://schemas.openxmlformats.org/drawingml/2006/main" r:embed="R522a2e3186cb45d7"/>
           <a:srcRect xmlns:a="http://schemas.openxmlformats.org/drawingml/2006/main" l="28" t="0" r="28" b="0"/>
           <a:stretch xmlns:a="http://schemas.openxmlformats.org/drawingml/2006/main">
             <a:fillRect l="0" t="0" r="0" b="0"/>
@@ -5715,37 +5715,37 @@
         </p:nvSpPr>
         <p:spPr>
           <a:xfrm xmlns:a="http://schemas.openxmlformats.org/drawingml/2006/main">
-            <a:off x="552450" y="800100"/>
-            <a:ext cx="10668000" cy="552450"/>
-          </a:xfrm>
-          <a:prstGeom xmlns:a="http://schemas.openxmlformats.org/drawingml/2006/main" prst="rect">
-            <a:avLst/>
-          </a:prstGeom>
-          <a:noFill xmlns:a="http://schemas.openxmlformats.org/drawingml/2006/main"/>
-          <a:ln xmlns:a="http://schemas.openxmlformats.org/drawingml/2006/main" w="0">
-            <a:noFill/>
-            <a:prstDash val="solid"/>
-          </a:ln>
-        </p:spPr>
-        <p:txBody>
-          <a:bodyPr xmlns:a="http://schemas.openxmlformats.org/drawingml/2006/main"/>
-          <a:lstStyle xmlns:a="http://schemas.openxmlformats.org/drawingml/2006/main"/>
-          <a:p xmlns:a="http://schemas.openxmlformats.org/drawingml/2006/main">
-            <a:pPr>
-              <a:buNone/>
-              <a:defRPr sz="2850" b="1">
+            <a:off x="552450" y="781050"/>
+            <a:ext cx="11049000" cy="552450"/>
+          </a:xfrm>
+          <a:prstGeom xmlns:a="http://schemas.openxmlformats.org/drawingml/2006/main" prst="rect">
+            <a:avLst/>
+          </a:prstGeom>
+          <a:noFill xmlns:a="http://schemas.openxmlformats.org/drawingml/2006/main"/>
+          <a:ln xmlns:a="http://schemas.openxmlformats.org/drawingml/2006/main" w="0">
+            <a:noFill/>
+            <a:prstDash val="solid"/>
+          </a:ln>
+        </p:spPr>
+        <p:txBody>
+          <a:bodyPr xmlns:a="http://schemas.openxmlformats.org/drawingml/2006/main"/>
+          <a:lstStyle xmlns:a="http://schemas.openxmlformats.org/drawingml/2006/main"/>
+          <a:p xmlns:a="http://schemas.openxmlformats.org/drawingml/2006/main">
+            <a:pPr>
+              <a:buNone/>
+              <a:defRPr sz="2550" b="1">
                 <a:solidFill>
                   <a:srgbClr val="0F172A"/>
                 </a:solidFill>
               </a:defRPr>
             </a:pPr>
             <a:r>
-              <a:rPr sz="3000" b="1">
+              <a:rPr sz="2550" b="1">
                 <a:solidFill>
                   <a:srgbClr val="0F172A"/>
                 </a:solidFill>
               </a:rPr>
-              <a:t>Camera Stream ve Teleoperation dışındaki özellikler</a:t>
+              <a:t>Camera Stream, Teleoperation ve kayıt akışları hariç özellikler</a:t>
             </a:r>
           </a:p>
         </p:txBody>
@@ -5766,37 +5766,37 @@
         </p:nvSpPr>
         <p:spPr>
           <a:xfrm xmlns:a="http://schemas.openxmlformats.org/drawingml/2006/main">
-            <a:off x="571500" y="1504950"/>
-            <a:ext cx="9906000" cy="400050"/>
-          </a:xfrm>
-          <a:prstGeom xmlns:a="http://schemas.openxmlformats.org/drawingml/2006/main" prst="rect">
-            <a:avLst/>
-          </a:prstGeom>
-          <a:noFill xmlns:a="http://schemas.openxmlformats.org/drawingml/2006/main"/>
-          <a:ln xmlns:a="http://schemas.openxmlformats.org/drawingml/2006/main" w="0">
-            <a:noFill/>
-            <a:prstDash val="solid"/>
-          </a:ln>
-        </p:spPr>
-        <p:txBody>
-          <a:bodyPr xmlns:a="http://schemas.openxmlformats.org/drawingml/2006/main"/>
-          <a:lstStyle xmlns:a="http://schemas.openxmlformats.org/drawingml/2006/main"/>
-          <a:p xmlns:a="http://schemas.openxmlformats.org/drawingml/2006/main">
-            <a:pPr>
-              <a:buNone/>
-              <a:defRPr sz="1500">
+            <a:off x="571500" y="1466850"/>
+            <a:ext cx="10572750" cy="419100"/>
+          </a:xfrm>
+          <a:prstGeom xmlns:a="http://schemas.openxmlformats.org/drawingml/2006/main" prst="rect">
+            <a:avLst/>
+          </a:prstGeom>
+          <a:noFill xmlns:a="http://schemas.openxmlformats.org/drawingml/2006/main"/>
+          <a:ln xmlns:a="http://schemas.openxmlformats.org/drawingml/2006/main" w="0">
+            <a:noFill/>
+            <a:prstDash val="solid"/>
+          </a:ln>
+        </p:spPr>
+        <p:txBody>
+          <a:bodyPr xmlns:a="http://schemas.openxmlformats.org/drawingml/2006/main"/>
+          <a:lstStyle xmlns:a="http://schemas.openxmlformats.org/drawingml/2006/main"/>
+          <a:p xmlns:a="http://schemas.openxmlformats.org/drawingml/2006/main">
+            <a:pPr>
+              <a:buNone/>
+              <a:defRPr sz="1425">
                 <a:solidFill>
                   <a:srgbClr val="475569"/>
                 </a:solidFill>
               </a:defRPr>
             </a:pPr>
             <a:r>
-              <a:rPr sz="1500">
+              <a:rPr sz="1425">
                 <a:solidFill>
                   <a:srgbClr val="475569"/>
                 </a:solidFill>
               </a:rPr>
-              <a:t>Platformun değerini kamera yayını veya uzaktan yürütme modlarına dayanmadan anlatan ürün katmanları.</a:t>
+              <a:t>Robot deneyimini kamera yayını, teleoperation ve kayıt/sequence akışlarına dayanmadan anlatan ürün katmanları.</a:t>
             </a:r>
           </a:p>
         </p:txBody>
@@ -6288,7 +6288,7 @@
                   <a:srgbClr val="111827"/>
                 </a:solidFill>
               </a:rPr>
-              <a:t>Telemetry</a:t>
+              <a:t>Robot Twin</a:t>
             </a:r>
           </a:p>
         </p:txBody>
@@ -6370,7 +6370,7 @@
                   <a:srgbClr val="374151"/>
                 </a:solidFill>
               </a:rPr>
-              <a:t>Live Dashboard ile anlık robot durumu</a:t>
+              <a:t>Dijital robot görünümüyle sahneyi okuma</a:t>
             </a:r>
           </a:p>
         </p:txBody>
@@ -6452,7 +6452,7 @@
                   <a:srgbClr val="374151"/>
                 </a:solidFill>
               </a:rPr>
-              <a:t>Motor ve sistem örneklerini okunabilir hale getirme</a:t>
+              <a:t>Robot durumunu görsel olarak takip etme</a:t>
             </a:r>
           </a:p>
         </p:txBody>
@@ -6534,7 +6534,7 @@
                   <a:srgbClr val="374151"/>
                 </a:solidFill>
               </a:rPr>
-              <a:t>ROS Visibility ile altyapı sinyallerini görünür kılma</a:t>
+              <a:t>Operatöre tek bakışta sahne farkındalığı verme</a:t>
             </a:r>
           </a:p>
         </p:txBody>
@@ -6616,7 +6616,7 @@
                   <a:srgbClr val="374151"/>
                 </a:solidFill>
               </a:rPr>
-              <a:t>Log, durum ve hata bilgisini aynı deneyime bağlama</a:t>
+              <a:t>Gerçek robot ile dijital bağlamı aynı hikayede toplama</a:t>
             </a:r>
           </a:p>
         </p:txBody>
@@ -6698,7 +6698,7 @@
                   <a:srgbClr val="111827"/>
                 </a:solidFill>
               </a:rPr>
-              <a:t>Sequence Planning</a:t>
+              <a:t>Live Dashboard</a:t>
             </a:r>
           </a:p>
         </p:txBody>
@@ -6780,7 +6780,7 @@
                   <a:srgbClr val="374151"/>
                 </a:solidFill>
               </a:rPr>
-              <a:t>Add Point ve Pose Capture ile hareket noktası kaydı</a:t>
+              <a:t>Anlık robot durumunu okunabilir hale getirme</a:t>
             </a:r>
           </a:p>
         </p:txBody>
@@ -6862,7 +6862,7 @@
                   <a:srgbClr val="374151"/>
                 </a:solidFill>
               </a:rPr>
-              <a:t>Sequence Builder ile tekrar oynatılabilir hareket</a:t>
+              <a:t>Sistem sağlığı ve bağlantı bilgisini takip etme</a:t>
             </a:r>
           </a:p>
         </p:txBody>
@@ -6944,7 +6944,7 @@
                   <a:srgbClr val="374151"/>
                 </a:solidFill>
               </a:rPr>
-              <a:t>Trajectory Planning ile hareket önizleme</a:t>
+              <a:t>Operasyon ekranında hızlı kontrol hissi verme</a:t>
             </a:r>
           </a:p>
         </p:txBody>
@@ -7026,7 +7026,7 @@
                   <a:srgbClr val="374151"/>
                 </a:solidFill>
               </a:rPr>
-              <a:t>Crazy Seconds / demo timing ile sahneye hazır akış</a:t>
+              <a:t>Log, durum ve hata bilgisini tek deneyime bağlama</a:t>
             </a:r>
           </a:p>
         </p:txBody>
@@ -7096,19 +7096,19 @@
           <a:p xmlns:a="http://schemas.openxmlformats.org/drawingml/2006/main">
             <a:pPr>
               <a:buNone/>
-              <a:defRPr sz="1650" b="1">
+              <a:defRPr sz="1500" b="1">
                 <a:solidFill>
                   <a:srgbClr val="111827"/>
                 </a:solidFill>
               </a:defRPr>
             </a:pPr>
             <a:r>
-              <a:rPr sz="1650" b="1">
+              <a:rPr sz="1500" b="1">
                 <a:solidFill>
                   <a:srgbClr val="111827"/>
                 </a:solidFill>
               </a:rPr>
-              <a:t>Doğrulama</a:t>
+              <a:t>Entegrasyon ve Demo Hazırlığı</a:t>
             </a:r>
           </a:p>
         </p:txBody>
@@ -7190,7 +7190,7 @@
                   <a:srgbClr val="374151"/>
                 </a:solidFill>
               </a:rPr>
-              <a:t>IK çözüm hatasını cm seviyesinde izleme</a:t>
+              <a:t>ROS Visibility ile altyapı görünürlüğü</a:t>
             </a:r>
           </a:p>
         </p:txBody>
@@ -7272,7 +7272,7 @@
                   <a:srgbClr val="374151"/>
                 </a:solidFill>
               </a:rPr>
-              <a:t>Bounds ve eklem limitleriyle güvenli sınır kontrolü</a:t>
+              <a:t>Modüler kontrol katmanları</a:t>
             </a:r>
           </a:p>
         </p:txBody>
@@ -7354,7 +7354,7 @@
                   <a:srgbClr val="374151"/>
                 </a:solidFill>
               </a:rPr>
-              <a:t>Simülasyon, hedef replay ve referans karşılaştırması</a:t>
+              <a:t>Pilot/demo için tek ekran deneyimi</a:t>
             </a:r>
           </a:p>
         </p:txBody>
@@ -7436,7 +7436,7 @@
                   <a:srgbClr val="374151"/>
                 </a:solidFill>
               </a:rPr>
-              <a:t>Save Real Robot Motion için doğrulama kapısı</a:t>
+              <a:t>Premium control layer ile ürün hissi</a:t>
             </a:r>
           </a:p>
         </p:txBody>
@@ -7518,7 +7518,7 @@
                   <a:srgbClr val="64748B"/>
                 </a:solidFill>
               </a:rPr>
-              <a:t>Kapsam dışı bırakılanlar: Camera Stream, Teleoperation / Remote Presence, VR walking control modes.</a:t>
+              <a:t>Kapsam dışı: Camera Stream, Teleoperation / Remote Presence, kayıt-sequence akışları, IK/simülasyon ve XR walking control modes.</a:t>
             </a:r>
           </a:p>
         </p:txBody>

</xml_diff>

<commit_message>
Match summary slide dark styling
</commit_message>
<xml_diff>
--- a/docs/presentations/Unitree-H1-Feature-Deck-v2.pptx
+++ b/docs/presentations/Unitree-H1-Feature-Deck-v2.pptx
@@ -2,19 +2,19 @@
 <file path=ppt/presentation.xml><?xml version="1.0" encoding="utf-8"?>
 <p:presentation xmlns:p="http://schemas.openxmlformats.org/presentationml/2006/main">
   <p:sldMasterIdLst>
-    <p:sldMasterId xmlns:r="http://schemas.openxmlformats.org/officeDocument/2006/relationships" id="2147483648" r:id="Rd52834c0a897429f"/>
+    <p:sldMasterId xmlns:r="http://schemas.openxmlformats.org/officeDocument/2006/relationships" id="2147483648" r:id="R081f6b3714904aa6"/>
   </p:sldMasterIdLst>
   <p:notesMasterIdLst>
-    <p:notesMasterId xmlns:r="http://schemas.openxmlformats.org/officeDocument/2006/relationships" r:id="R35954d57ec044653"/>
+    <p:notesMasterId xmlns:r="http://schemas.openxmlformats.org/officeDocument/2006/relationships" r:id="Rf5ba500429de4674"/>
   </p:notesMasterIdLst>
   <p:sldIdLst>
-    <p:sldId xmlns:r="http://schemas.openxmlformats.org/officeDocument/2006/relationships" id="256" r:id="R43f99809b85043b1"/>
-    <p:sldId xmlns:r="http://schemas.openxmlformats.org/officeDocument/2006/relationships" id="257" r:id="R63d9557e32024a80"/>
-    <p:sldId xmlns:r="http://schemas.openxmlformats.org/officeDocument/2006/relationships" id="258" r:id="R4b65a4fadf4940d1"/>
-    <p:sldId xmlns:r="http://schemas.openxmlformats.org/officeDocument/2006/relationships" id="259" r:id="Rd9824f2f56d040a2"/>
-    <p:sldId xmlns:r="http://schemas.openxmlformats.org/officeDocument/2006/relationships" id="260" r:id="R1f66acc3f48148a7"/>
-    <p:sldId xmlns:r="http://schemas.openxmlformats.org/officeDocument/2006/relationships" id="261" r:id="Re7478522cd014b3a"/>
-    <p:sldId xmlns:r="http://schemas.openxmlformats.org/officeDocument/2006/relationships" id="262" r:id="R1157df7de8d0495d"/>
+    <p:sldId xmlns:r="http://schemas.openxmlformats.org/officeDocument/2006/relationships" id="256" r:id="R61d83feee5a54770"/>
+    <p:sldId xmlns:r="http://schemas.openxmlformats.org/officeDocument/2006/relationships" id="257" r:id="R5b52d474cb8042da"/>
+    <p:sldId xmlns:r="http://schemas.openxmlformats.org/officeDocument/2006/relationships" id="258" r:id="R4d1c8150e3104917"/>
+    <p:sldId xmlns:r="http://schemas.openxmlformats.org/officeDocument/2006/relationships" id="259" r:id="R3aaf94a7221e4bc2"/>
+    <p:sldId xmlns:r="http://schemas.openxmlformats.org/officeDocument/2006/relationships" id="260" r:id="Rea0c5748b33d4938"/>
+    <p:sldId xmlns:r="http://schemas.openxmlformats.org/officeDocument/2006/relationships" id="261" r:id="Rb535e83eb8fe4daa"/>
+    <p:sldId xmlns:r="http://schemas.openxmlformats.org/officeDocument/2006/relationships" id="262" r:id="Ra6defa4f2b9e4ba9"/>
   </p:sldIdLst>
   <p:sldSz cx="12192000" cy="6858000"/>
   <p:notesSz cx="6858000" cy="9144000"/>
@@ -1003,7 +1003,7 @@
   </p:cSld>
   <p:clrMap bg1="lt1" tx1="dk1" bg2="lt2" tx2="dk2" accent1="accent1" accent2="accent2" accent3="accent3" accent4="accent4" accent5="accent5" accent6="accent6" hlink="hlink" folHlink="folHlink"/>
   <p:sldLayoutIdLst>
-    <p:sldLayoutId xmlns:r="http://schemas.openxmlformats.org/officeDocument/2006/relationships" id="2147483649" r:id="R30a9627f31e34770"/>
+    <p:sldLayoutId xmlns:r="http://schemas.openxmlformats.org/officeDocument/2006/relationships" id="2147483649" r:id="R114349db2c62456f"/>
   </p:sldLayoutIdLst>
   <p:txStyles>
     <p:titleStyle>
@@ -1711,7 +1711,7 @@
           <p:nvPr/>
         </p:nvPicPr>
         <p:blipFill>
-          <a:blip xmlns:r="http://schemas.openxmlformats.org/officeDocument/2006/relationships" xmlns:a="http://schemas.openxmlformats.org/drawingml/2006/main" r:embed="R451fee041b934acb"/>
+          <a:blip xmlns:r="http://schemas.openxmlformats.org/officeDocument/2006/relationships" xmlns:a="http://schemas.openxmlformats.org/drawingml/2006/main" r:embed="Rc6ef9d62a7324169"/>
           <a:srcRect xmlns:a="http://schemas.openxmlformats.org/drawingml/2006/main" l="0" t="30309" r="0" b="30309"/>
           <a:stretch xmlns:a="http://schemas.openxmlformats.org/drawingml/2006/main">
             <a:fillRect l="0" t="0" r="0" b="0"/>
@@ -2308,7 +2308,7 @@
           <p:nvPr/>
         </p:nvPicPr>
         <p:blipFill>
-          <a:blip xmlns:r="http://schemas.openxmlformats.org/officeDocument/2006/relationships" xmlns:a="http://schemas.openxmlformats.org/drawingml/2006/main" r:embed="R47415d6e1adc46c0"/>
+          <a:blip xmlns:r="http://schemas.openxmlformats.org/officeDocument/2006/relationships" xmlns:a="http://schemas.openxmlformats.org/drawingml/2006/main" r:embed="Ref94799c15ce4644"/>
           <a:srcRect xmlns:a="http://schemas.openxmlformats.org/drawingml/2006/main" l="0" t="6000" r="0" b="6000"/>
           <a:stretch xmlns:a="http://schemas.openxmlformats.org/drawingml/2006/main">
             <a:fillRect l="0" t="0" r="0" b="0"/>
@@ -2333,7 +2333,7 @@
           <p:nvPr/>
         </p:nvPicPr>
         <p:blipFill>
-          <a:blip xmlns:r="http://schemas.openxmlformats.org/officeDocument/2006/relationships" xmlns:a="http://schemas.openxmlformats.org/drawingml/2006/main" r:embed="R7be6f6dc22324c79"/>
+          <a:blip xmlns:r="http://schemas.openxmlformats.org/officeDocument/2006/relationships" xmlns:a="http://schemas.openxmlformats.org/drawingml/2006/main" r:embed="R4445adb522c74a8b"/>
           <a:srcRect xmlns:a="http://schemas.openxmlformats.org/drawingml/2006/main" l="0" t="6000" r="0" b="6000"/>
           <a:stretch xmlns:a="http://schemas.openxmlformats.org/drawingml/2006/main">
             <a:fillRect l="0" t="0" r="0" b="0"/>
@@ -2358,7 +2358,7 @@
           <p:nvPr/>
         </p:nvPicPr>
         <p:blipFill>
-          <a:blip xmlns:r="http://schemas.openxmlformats.org/officeDocument/2006/relationships" xmlns:a="http://schemas.openxmlformats.org/drawingml/2006/main" r:embed="R031300d2d2e94e30"/>
+          <a:blip xmlns:r="http://schemas.openxmlformats.org/officeDocument/2006/relationships" xmlns:a="http://schemas.openxmlformats.org/drawingml/2006/main" r:embed="Ra02cd01d70c44074"/>
           <a:srcRect xmlns:a="http://schemas.openxmlformats.org/drawingml/2006/main" l="0" t="6000" r="0" b="6000"/>
           <a:stretch xmlns:a="http://schemas.openxmlformats.org/drawingml/2006/main">
             <a:fillRect l="0" t="0" r="0" b="0"/>
@@ -2649,7 +2649,7 @@
           <p:nvPr/>
         </p:nvPicPr>
         <p:blipFill>
-          <a:blip xmlns:r="http://schemas.openxmlformats.org/officeDocument/2006/relationships" xmlns:a="http://schemas.openxmlformats.org/drawingml/2006/main" r:embed="Rafdd3da0a7544309"/>
+          <a:blip xmlns:r="http://schemas.openxmlformats.org/officeDocument/2006/relationships" xmlns:a="http://schemas.openxmlformats.org/drawingml/2006/main" r:embed="R6b391aa0ccf6402b"/>
           <a:srcRect xmlns:a="http://schemas.openxmlformats.org/drawingml/2006/main" l="18895" t="0" r="18895" b="0"/>
           <a:stretch xmlns:a="http://schemas.openxmlformats.org/drawingml/2006/main">
             <a:fillRect l="0" t="0" r="0" b="0"/>
@@ -3328,7 +3328,7 @@
           <p:nvPr/>
         </p:nvPicPr>
         <p:blipFill>
-          <a:blip xmlns:r="http://schemas.openxmlformats.org/officeDocument/2006/relationships" xmlns:a="http://schemas.openxmlformats.org/drawingml/2006/main" r:embed="R71ba9ca9ea374fc5"/>
+          <a:blip xmlns:r="http://schemas.openxmlformats.org/officeDocument/2006/relationships" xmlns:a="http://schemas.openxmlformats.org/drawingml/2006/main" r:embed="Rb021f0edf2be47f3"/>
           <a:srcRect xmlns:a="http://schemas.openxmlformats.org/drawingml/2006/main" l="0" t="2134" r="0" b="2134"/>
           <a:stretch xmlns:a="http://schemas.openxmlformats.org/drawingml/2006/main">
             <a:fillRect l="0" t="0" r="0" b="0"/>
@@ -3353,7 +3353,7 @@
           <p:nvPr/>
         </p:nvPicPr>
         <p:blipFill>
-          <a:blip xmlns:r="http://schemas.openxmlformats.org/officeDocument/2006/relationships" xmlns:a="http://schemas.openxmlformats.org/drawingml/2006/main" r:embed="R0858e9d2f8db4ee3"/>
+          <a:blip xmlns:r="http://schemas.openxmlformats.org/officeDocument/2006/relationships" xmlns:a="http://schemas.openxmlformats.org/drawingml/2006/main" r:embed="R604df325b0504853"/>
           <a:srcRect xmlns:a="http://schemas.openxmlformats.org/drawingml/2006/main" l="0" t="2134" r="0" b="2134"/>
           <a:stretch xmlns:a="http://schemas.openxmlformats.org/drawingml/2006/main">
             <a:fillRect l="0" t="0" r="0" b="0"/>
@@ -3378,7 +3378,7 @@
           <p:nvPr/>
         </p:nvPicPr>
         <p:blipFill>
-          <a:blip xmlns:r="http://schemas.openxmlformats.org/officeDocument/2006/relationships" xmlns:a="http://schemas.openxmlformats.org/drawingml/2006/main" r:embed="R4949040a535440fd"/>
+          <a:blip xmlns:r="http://schemas.openxmlformats.org/officeDocument/2006/relationships" xmlns:a="http://schemas.openxmlformats.org/drawingml/2006/main" r:embed="Rca78078e8ca44f5b"/>
           <a:srcRect xmlns:a="http://schemas.openxmlformats.org/drawingml/2006/main" l="0" t="2134" r="0" b="2134"/>
           <a:stretch xmlns:a="http://schemas.openxmlformats.org/drawingml/2006/main">
             <a:fillRect l="0" t="0" r="0" b="0"/>
@@ -4462,7 +4462,7 @@
           <p:nvPr/>
         </p:nvPicPr>
         <p:blipFill>
-          <a:blip xmlns:r="http://schemas.openxmlformats.org/officeDocument/2006/relationships" xmlns:a="http://schemas.openxmlformats.org/drawingml/2006/main" r:embed="Rffa330312e9b4e14"/>
+          <a:blip xmlns:r="http://schemas.openxmlformats.org/officeDocument/2006/relationships" xmlns:a="http://schemas.openxmlformats.org/drawingml/2006/main" r:embed="Rf50a52fca330482a"/>
           <a:stretch xmlns:a="http://schemas.openxmlformats.org/drawingml/2006/main"/>
         </p:blipFill>
         <p:spPr>
@@ -5435,7 +5435,7 @@
           <p:nvPr/>
         </p:nvPicPr>
         <p:blipFill>
-          <a:blip xmlns:r="http://schemas.openxmlformats.org/officeDocument/2006/relationships" xmlns:a="http://schemas.openxmlformats.org/drawingml/2006/main" r:embed="R522a2e3186cb45d7"/>
+          <a:blip xmlns:r="http://schemas.openxmlformats.org/officeDocument/2006/relationships" xmlns:a="http://schemas.openxmlformats.org/drawingml/2006/main" r:embed="Rbb88c84c8f2e431d"/>
           <a:srcRect xmlns:a="http://schemas.openxmlformats.org/drawingml/2006/main" l="28" t="0" r="28" b="0"/>
           <a:stretch xmlns:a="http://schemas.openxmlformats.org/drawingml/2006/main">
             <a:fillRect l="0" t="0" r="0" b="0"/>
@@ -5635,7 +5635,7 @@
     <p:bg>
       <p:bgPr>
         <a:solidFill xmlns:a="http://schemas.openxmlformats.org/drawingml/2006/main">
-          <a:srgbClr val="F8FAFC"/>
+          <a:srgbClr val="080B0F"/>
         </a:solidFill>
       </p:bgPr>
     </p:bg>
@@ -5684,7 +5684,7 @@
               <a:buNone/>
               <a:defRPr sz="1050" b="1">
                 <a:solidFill>
-                  <a:srgbClr val="DC2626"/>
+                  <a:srgbClr val="22C55E"/>
                 </a:solidFill>
               </a:defRPr>
             </a:pPr>
@@ -5735,7 +5735,7 @@
               <a:buNone/>
               <a:defRPr sz="2550" b="1">
                 <a:solidFill>
-                  <a:srgbClr val="0F172A"/>
+                  <a:srgbClr val="FFFFFF"/>
                 </a:solidFill>
               </a:defRPr>
             </a:pPr>
@@ -5786,7 +5786,7 @@
               <a:buNone/>
               <a:defRPr sz="1425">
                 <a:solidFill>
-                  <a:srgbClr val="475569"/>
+                  <a:srgbClr val="CBD5E1"/>
                 </a:solidFill>
               </a:defRPr>
             </a:pPr>
@@ -5868,7 +5868,7 @@
               <a:buNone/>
               <a:defRPr sz="1650" b="1">
                 <a:solidFill>
-                  <a:srgbClr val="111827"/>
+                  <a:srgbClr val="F8FAFC"/>
                 </a:solidFill>
               </a:defRPr>
             </a:pPr>
@@ -5950,7 +5950,7 @@
               <a:buNone/>
               <a:defRPr sz="1275">
                 <a:solidFill>
-                  <a:srgbClr val="374151"/>
+                  <a:srgbClr val="CBD5E1"/>
                 </a:solidFill>
               </a:defRPr>
             </a:pPr>
@@ -6032,7 +6032,7 @@
               <a:buNone/>
               <a:defRPr sz="1275">
                 <a:solidFill>
-                  <a:srgbClr val="374151"/>
+                  <a:srgbClr val="CBD5E1"/>
                 </a:solidFill>
               </a:defRPr>
             </a:pPr>
@@ -6114,7 +6114,7 @@
               <a:buNone/>
               <a:defRPr sz="1275">
                 <a:solidFill>
-                  <a:srgbClr val="374151"/>
+                  <a:srgbClr val="CBD5E1"/>
                 </a:solidFill>
               </a:defRPr>
             </a:pPr>
@@ -6196,7 +6196,7 @@
               <a:buNone/>
               <a:defRPr sz="1275">
                 <a:solidFill>
-                  <a:srgbClr val="374151"/>
+                  <a:srgbClr val="CBD5E1"/>
                 </a:solidFill>
               </a:defRPr>
             </a:pPr>
@@ -6278,7 +6278,7 @@
               <a:buNone/>
               <a:defRPr sz="1650" b="1">
                 <a:solidFill>
-                  <a:srgbClr val="111827"/>
+                  <a:srgbClr val="F8FAFC"/>
                 </a:solidFill>
               </a:defRPr>
             </a:pPr>
@@ -6360,7 +6360,7 @@
               <a:buNone/>
               <a:defRPr sz="1275">
                 <a:solidFill>
-                  <a:srgbClr val="374151"/>
+                  <a:srgbClr val="CBD5E1"/>
                 </a:solidFill>
               </a:defRPr>
             </a:pPr>
@@ -6442,7 +6442,7 @@
               <a:buNone/>
               <a:defRPr sz="1275">
                 <a:solidFill>
-                  <a:srgbClr val="374151"/>
+                  <a:srgbClr val="CBD5E1"/>
                 </a:solidFill>
               </a:defRPr>
             </a:pPr>
@@ -6524,7 +6524,7 @@
               <a:buNone/>
               <a:defRPr sz="1275">
                 <a:solidFill>
-                  <a:srgbClr val="374151"/>
+                  <a:srgbClr val="CBD5E1"/>
                 </a:solidFill>
               </a:defRPr>
             </a:pPr>
@@ -6606,7 +6606,7 @@
               <a:buNone/>
               <a:defRPr sz="1275">
                 <a:solidFill>
-                  <a:srgbClr val="374151"/>
+                  <a:srgbClr val="CBD5E1"/>
                 </a:solidFill>
               </a:defRPr>
             </a:pPr>
@@ -6688,7 +6688,7 @@
               <a:buNone/>
               <a:defRPr sz="1650" b="1">
                 <a:solidFill>
-                  <a:srgbClr val="111827"/>
+                  <a:srgbClr val="F8FAFC"/>
                 </a:solidFill>
               </a:defRPr>
             </a:pPr>
@@ -6770,7 +6770,7 @@
               <a:buNone/>
               <a:defRPr sz="1275">
                 <a:solidFill>
-                  <a:srgbClr val="374151"/>
+                  <a:srgbClr val="CBD5E1"/>
                 </a:solidFill>
               </a:defRPr>
             </a:pPr>
@@ -6852,7 +6852,7 @@
               <a:buNone/>
               <a:defRPr sz="1275">
                 <a:solidFill>
-                  <a:srgbClr val="374151"/>
+                  <a:srgbClr val="CBD5E1"/>
                 </a:solidFill>
               </a:defRPr>
             </a:pPr>
@@ -6934,7 +6934,7 @@
               <a:buNone/>
               <a:defRPr sz="1275">
                 <a:solidFill>
-                  <a:srgbClr val="374151"/>
+                  <a:srgbClr val="CBD5E1"/>
                 </a:solidFill>
               </a:defRPr>
             </a:pPr>
@@ -7016,7 +7016,7 @@
               <a:buNone/>
               <a:defRPr sz="1275">
                 <a:solidFill>
-                  <a:srgbClr val="374151"/>
+                  <a:srgbClr val="CBD5E1"/>
                 </a:solidFill>
               </a:defRPr>
             </a:pPr>
@@ -7098,7 +7098,7 @@
               <a:buNone/>
               <a:defRPr sz="1500" b="1">
                 <a:solidFill>
-                  <a:srgbClr val="111827"/>
+                  <a:srgbClr val="F8FAFC"/>
                 </a:solidFill>
               </a:defRPr>
             </a:pPr>
@@ -7180,7 +7180,7 @@
               <a:buNone/>
               <a:defRPr sz="1275">
                 <a:solidFill>
-                  <a:srgbClr val="374151"/>
+                  <a:srgbClr val="CBD5E1"/>
                 </a:solidFill>
               </a:defRPr>
             </a:pPr>
@@ -7262,7 +7262,7 @@
               <a:buNone/>
               <a:defRPr sz="1275">
                 <a:solidFill>
-                  <a:srgbClr val="374151"/>
+                  <a:srgbClr val="CBD5E1"/>
                 </a:solidFill>
               </a:defRPr>
             </a:pPr>
@@ -7344,7 +7344,7 @@
               <a:buNone/>
               <a:defRPr sz="1275">
                 <a:solidFill>
-                  <a:srgbClr val="374151"/>
+                  <a:srgbClr val="CBD5E1"/>
                 </a:solidFill>
               </a:defRPr>
             </a:pPr>
@@ -7426,7 +7426,7 @@
               <a:buNone/>
               <a:defRPr sz="1275">
                 <a:solidFill>
-                  <a:srgbClr val="374151"/>
+                  <a:srgbClr val="CBD5E1"/>
                 </a:solidFill>
               </a:defRPr>
             </a:pPr>
@@ -7464,7 +7464,7 @@
             <a:avLst/>
           </a:prstGeom>
           <a:solidFill xmlns:a="http://schemas.openxmlformats.org/drawingml/2006/main">
-            <a:srgbClr val="E5E7EB"/>
+            <a:srgbClr val="1F2937"/>
           </a:solidFill>
           <a:ln xmlns:a="http://schemas.openxmlformats.org/drawingml/2006/main" w="0">
             <a:noFill/>
@@ -7508,7 +7508,7 @@
               <a:buNone/>
               <a:defRPr sz="1200">
                 <a:solidFill>
-                  <a:srgbClr val="64748B"/>
+                  <a:srgbClr val="94A3B8"/>
                 </a:solidFill>
               </a:defRPr>
             </a:pPr>

</xml_diff>

<commit_message>
Improve summary slide readability
</commit_message>
<xml_diff>
--- a/docs/presentations/Unitree-H1-Feature-Deck-v2.pptx
+++ b/docs/presentations/Unitree-H1-Feature-Deck-v2.pptx
@@ -2,19 +2,19 @@
 <file path=ppt/presentation.xml><?xml version="1.0" encoding="utf-8"?>
 <p:presentation xmlns:p="http://schemas.openxmlformats.org/presentationml/2006/main">
   <p:sldMasterIdLst>
-    <p:sldMasterId xmlns:r="http://schemas.openxmlformats.org/officeDocument/2006/relationships" id="2147483648" r:id="R081f6b3714904aa6"/>
+    <p:sldMasterId xmlns:r="http://schemas.openxmlformats.org/officeDocument/2006/relationships" id="2147483648" r:id="Rcd28775364254e38"/>
   </p:sldMasterIdLst>
   <p:notesMasterIdLst>
-    <p:notesMasterId xmlns:r="http://schemas.openxmlformats.org/officeDocument/2006/relationships" r:id="Rf5ba500429de4674"/>
+    <p:notesMasterId xmlns:r="http://schemas.openxmlformats.org/officeDocument/2006/relationships" r:id="Rbc37d91d4a90491b"/>
   </p:notesMasterIdLst>
   <p:sldIdLst>
-    <p:sldId xmlns:r="http://schemas.openxmlformats.org/officeDocument/2006/relationships" id="256" r:id="R61d83feee5a54770"/>
-    <p:sldId xmlns:r="http://schemas.openxmlformats.org/officeDocument/2006/relationships" id="257" r:id="R5b52d474cb8042da"/>
-    <p:sldId xmlns:r="http://schemas.openxmlformats.org/officeDocument/2006/relationships" id="258" r:id="R4d1c8150e3104917"/>
-    <p:sldId xmlns:r="http://schemas.openxmlformats.org/officeDocument/2006/relationships" id="259" r:id="R3aaf94a7221e4bc2"/>
-    <p:sldId xmlns:r="http://schemas.openxmlformats.org/officeDocument/2006/relationships" id="260" r:id="Rea0c5748b33d4938"/>
-    <p:sldId xmlns:r="http://schemas.openxmlformats.org/officeDocument/2006/relationships" id="261" r:id="Rb535e83eb8fe4daa"/>
-    <p:sldId xmlns:r="http://schemas.openxmlformats.org/officeDocument/2006/relationships" id="262" r:id="Ra6defa4f2b9e4ba9"/>
+    <p:sldId xmlns:r="http://schemas.openxmlformats.org/officeDocument/2006/relationships" id="256" r:id="Rdc5d718d2e7e4fb9"/>
+    <p:sldId xmlns:r="http://schemas.openxmlformats.org/officeDocument/2006/relationships" id="257" r:id="Rf5678d10d4f248ac"/>
+    <p:sldId xmlns:r="http://schemas.openxmlformats.org/officeDocument/2006/relationships" id="258" r:id="Rc7e73f86f6ce486f"/>
+    <p:sldId xmlns:r="http://schemas.openxmlformats.org/officeDocument/2006/relationships" id="259" r:id="R1b6d3e9e0d034260"/>
+    <p:sldId xmlns:r="http://schemas.openxmlformats.org/officeDocument/2006/relationships" id="260" r:id="R262a19597abc47d0"/>
+    <p:sldId xmlns:r="http://schemas.openxmlformats.org/officeDocument/2006/relationships" id="261" r:id="Ra80c764aa98a44aa"/>
+    <p:sldId xmlns:r="http://schemas.openxmlformats.org/officeDocument/2006/relationships" id="262" r:id="Re99c09358c0b4ff4"/>
   </p:sldIdLst>
   <p:sldSz cx="12192000" cy="6858000"/>
   <p:notesSz cx="6858000" cy="9144000"/>
@@ -1003,7 +1003,7 @@
   </p:cSld>
   <p:clrMap bg1="lt1" tx1="dk1" bg2="lt2" tx2="dk2" accent1="accent1" accent2="accent2" accent3="accent3" accent4="accent4" accent5="accent5" accent6="accent6" hlink="hlink" folHlink="folHlink"/>
   <p:sldLayoutIdLst>
-    <p:sldLayoutId xmlns:r="http://schemas.openxmlformats.org/officeDocument/2006/relationships" id="2147483649" r:id="R114349db2c62456f"/>
+    <p:sldLayoutId xmlns:r="http://schemas.openxmlformats.org/officeDocument/2006/relationships" id="2147483649" r:id="Rdeef2eb1cca74730"/>
   </p:sldLayoutIdLst>
   <p:txStyles>
     <p:titleStyle>
@@ -1711,7 +1711,7 @@
           <p:nvPr/>
         </p:nvPicPr>
         <p:blipFill>
-          <a:blip xmlns:r="http://schemas.openxmlformats.org/officeDocument/2006/relationships" xmlns:a="http://schemas.openxmlformats.org/drawingml/2006/main" r:embed="Rc6ef9d62a7324169"/>
+          <a:blip xmlns:r="http://schemas.openxmlformats.org/officeDocument/2006/relationships" xmlns:a="http://schemas.openxmlformats.org/drawingml/2006/main" r:embed="R906b1f59e49b4977"/>
           <a:srcRect xmlns:a="http://schemas.openxmlformats.org/drawingml/2006/main" l="0" t="30309" r="0" b="30309"/>
           <a:stretch xmlns:a="http://schemas.openxmlformats.org/drawingml/2006/main">
             <a:fillRect l="0" t="0" r="0" b="0"/>
@@ -2308,7 +2308,7 @@
           <p:nvPr/>
         </p:nvPicPr>
         <p:blipFill>
-          <a:blip xmlns:r="http://schemas.openxmlformats.org/officeDocument/2006/relationships" xmlns:a="http://schemas.openxmlformats.org/drawingml/2006/main" r:embed="Ref94799c15ce4644"/>
+          <a:blip xmlns:r="http://schemas.openxmlformats.org/officeDocument/2006/relationships" xmlns:a="http://schemas.openxmlformats.org/drawingml/2006/main" r:embed="R4c40f2c458fb4f57"/>
           <a:srcRect xmlns:a="http://schemas.openxmlformats.org/drawingml/2006/main" l="0" t="6000" r="0" b="6000"/>
           <a:stretch xmlns:a="http://schemas.openxmlformats.org/drawingml/2006/main">
             <a:fillRect l="0" t="0" r="0" b="0"/>
@@ -2333,7 +2333,7 @@
           <p:nvPr/>
         </p:nvPicPr>
         <p:blipFill>
-          <a:blip xmlns:r="http://schemas.openxmlformats.org/officeDocument/2006/relationships" xmlns:a="http://schemas.openxmlformats.org/drawingml/2006/main" r:embed="R4445adb522c74a8b"/>
+          <a:blip xmlns:r="http://schemas.openxmlformats.org/officeDocument/2006/relationships" xmlns:a="http://schemas.openxmlformats.org/drawingml/2006/main" r:embed="R5930bac50ce64625"/>
           <a:srcRect xmlns:a="http://schemas.openxmlformats.org/drawingml/2006/main" l="0" t="6000" r="0" b="6000"/>
           <a:stretch xmlns:a="http://schemas.openxmlformats.org/drawingml/2006/main">
             <a:fillRect l="0" t="0" r="0" b="0"/>
@@ -2358,7 +2358,7 @@
           <p:nvPr/>
         </p:nvPicPr>
         <p:blipFill>
-          <a:blip xmlns:r="http://schemas.openxmlformats.org/officeDocument/2006/relationships" xmlns:a="http://schemas.openxmlformats.org/drawingml/2006/main" r:embed="Ra02cd01d70c44074"/>
+          <a:blip xmlns:r="http://schemas.openxmlformats.org/officeDocument/2006/relationships" xmlns:a="http://schemas.openxmlformats.org/drawingml/2006/main" r:embed="Rca7b931ee8e84706"/>
           <a:srcRect xmlns:a="http://schemas.openxmlformats.org/drawingml/2006/main" l="0" t="6000" r="0" b="6000"/>
           <a:stretch xmlns:a="http://schemas.openxmlformats.org/drawingml/2006/main">
             <a:fillRect l="0" t="0" r="0" b="0"/>
@@ -2649,7 +2649,7 @@
           <p:nvPr/>
         </p:nvPicPr>
         <p:blipFill>
-          <a:blip xmlns:r="http://schemas.openxmlformats.org/officeDocument/2006/relationships" xmlns:a="http://schemas.openxmlformats.org/drawingml/2006/main" r:embed="R6b391aa0ccf6402b"/>
+          <a:blip xmlns:r="http://schemas.openxmlformats.org/officeDocument/2006/relationships" xmlns:a="http://schemas.openxmlformats.org/drawingml/2006/main" r:embed="Rdc1592a1d89343d6"/>
           <a:srcRect xmlns:a="http://schemas.openxmlformats.org/drawingml/2006/main" l="18895" t="0" r="18895" b="0"/>
           <a:stretch xmlns:a="http://schemas.openxmlformats.org/drawingml/2006/main">
             <a:fillRect l="0" t="0" r="0" b="0"/>
@@ -3328,7 +3328,7 @@
           <p:nvPr/>
         </p:nvPicPr>
         <p:blipFill>
-          <a:blip xmlns:r="http://schemas.openxmlformats.org/officeDocument/2006/relationships" xmlns:a="http://schemas.openxmlformats.org/drawingml/2006/main" r:embed="Rb021f0edf2be47f3"/>
+          <a:blip xmlns:r="http://schemas.openxmlformats.org/officeDocument/2006/relationships" xmlns:a="http://schemas.openxmlformats.org/drawingml/2006/main" r:embed="R5a9b2f3eeba0497b"/>
           <a:srcRect xmlns:a="http://schemas.openxmlformats.org/drawingml/2006/main" l="0" t="2134" r="0" b="2134"/>
           <a:stretch xmlns:a="http://schemas.openxmlformats.org/drawingml/2006/main">
             <a:fillRect l="0" t="0" r="0" b="0"/>
@@ -3353,7 +3353,7 @@
           <p:nvPr/>
         </p:nvPicPr>
         <p:blipFill>
-          <a:blip xmlns:r="http://schemas.openxmlformats.org/officeDocument/2006/relationships" xmlns:a="http://schemas.openxmlformats.org/drawingml/2006/main" r:embed="R604df325b0504853"/>
+          <a:blip xmlns:r="http://schemas.openxmlformats.org/officeDocument/2006/relationships" xmlns:a="http://schemas.openxmlformats.org/drawingml/2006/main" r:embed="Reba2e6d9678b434b"/>
           <a:srcRect xmlns:a="http://schemas.openxmlformats.org/drawingml/2006/main" l="0" t="2134" r="0" b="2134"/>
           <a:stretch xmlns:a="http://schemas.openxmlformats.org/drawingml/2006/main">
             <a:fillRect l="0" t="0" r="0" b="0"/>
@@ -3378,7 +3378,7 @@
           <p:nvPr/>
         </p:nvPicPr>
         <p:blipFill>
-          <a:blip xmlns:r="http://schemas.openxmlformats.org/officeDocument/2006/relationships" xmlns:a="http://schemas.openxmlformats.org/drawingml/2006/main" r:embed="Rca78078e8ca44f5b"/>
+          <a:blip xmlns:r="http://schemas.openxmlformats.org/officeDocument/2006/relationships" xmlns:a="http://schemas.openxmlformats.org/drawingml/2006/main" r:embed="R564870bbe1c44541"/>
           <a:srcRect xmlns:a="http://schemas.openxmlformats.org/drawingml/2006/main" l="0" t="2134" r="0" b="2134"/>
           <a:stretch xmlns:a="http://schemas.openxmlformats.org/drawingml/2006/main">
             <a:fillRect l="0" t="0" r="0" b="0"/>
@@ -4462,7 +4462,7 @@
           <p:nvPr/>
         </p:nvPicPr>
         <p:blipFill>
-          <a:blip xmlns:r="http://schemas.openxmlformats.org/officeDocument/2006/relationships" xmlns:a="http://schemas.openxmlformats.org/drawingml/2006/main" r:embed="Rf50a52fca330482a"/>
+          <a:blip xmlns:r="http://schemas.openxmlformats.org/officeDocument/2006/relationships" xmlns:a="http://schemas.openxmlformats.org/drawingml/2006/main" r:embed="Rfab19316ab3346ae"/>
           <a:stretch xmlns:a="http://schemas.openxmlformats.org/drawingml/2006/main"/>
         </p:blipFill>
         <p:spPr>
@@ -5435,7 +5435,7 @@
           <p:nvPr/>
         </p:nvPicPr>
         <p:blipFill>
-          <a:blip xmlns:r="http://schemas.openxmlformats.org/officeDocument/2006/relationships" xmlns:a="http://schemas.openxmlformats.org/drawingml/2006/main" r:embed="Rbb88c84c8f2e431d"/>
+          <a:blip xmlns:r="http://schemas.openxmlformats.org/officeDocument/2006/relationships" xmlns:a="http://schemas.openxmlformats.org/drawingml/2006/main" r:embed="R0af0afe155304f28"/>
           <a:srcRect xmlns:a="http://schemas.openxmlformats.org/drawingml/2006/main" l="28" t="0" r="28" b="0"/>
           <a:stretch xmlns:a="http://schemas.openxmlformats.org/drawingml/2006/main">
             <a:fillRect l="0" t="0" r="0" b="0"/>
@@ -7519,6 +7519,3259 @@
                 </a:solidFill>
               </a:rPr>
               <a:t>Kapsam dışı: Camera Stream, Teleoperation / Remote Presence, kayıt-sequence akışları, IK/simülasyon ve XR walking control modes.</a:t>
+            </a:r>
+          </a:p>
+        </p:txBody>
+      </p:sp>
+      <p:sp>
+        <p:nvSpPr>
+          <p:cNvPr id="46" name="readable-summary-cover">
+            <a:extLst xmlns:a="http://schemas.openxmlformats.org/drawingml/2006/main">
+              <a:ext uri="{FF2B5EF4-FFF2-40B4-BE49-F238E27FC236}">
+                <a16:creationId xmlns:a16="http://schemas.microsoft.com/office/drawing/2014/main" id="{45F86A79-AB78-4FD5-A9DC-88863D3B69A3}"/>
+              </a:ext>
+            </a:extLst>
+          </p:cNvPr>
+          <p:cNvSpPr>
+            <a:spLocks xmlns:a="http://schemas.openxmlformats.org/drawingml/2006/main" noGrp="1"/>
+          </p:cNvSpPr>
+          <p:nvPr/>
+        </p:nvSpPr>
+        <p:spPr>
+          <a:xfrm xmlns:a="http://schemas.openxmlformats.org/drawingml/2006/main">
+            <a:off x="0" y="0"/>
+            <a:ext cx="12192000" cy="6858000"/>
+          </a:xfrm>
+          <a:prstGeom xmlns:a="http://schemas.openxmlformats.org/drawingml/2006/main" prst="rect">
+            <a:avLst/>
+          </a:prstGeom>
+          <a:solidFill xmlns:a="http://schemas.openxmlformats.org/drawingml/2006/main">
+            <a:srgbClr val="080B0F"/>
+          </a:solidFill>
+          <a:ln xmlns:a="http://schemas.openxmlformats.org/drawingml/2006/main" w="0">
+            <a:noFill/>
+            <a:prstDash val="solid"/>
+          </a:ln>
+        </p:spPr>
+      </p:sp>
+      <p:sp>
+        <p:nvSpPr>
+          <p:cNvPr id="47" name="readable-summary-eyebrow">
+            <a:extLst xmlns:a="http://schemas.openxmlformats.org/drawingml/2006/main">
+              <a:ext uri="{FF2B5EF4-FFF2-40B4-BE49-F238E27FC236}">
+                <a16:creationId xmlns:a16="http://schemas.microsoft.com/office/drawing/2014/main" id="{90FCF8CF-CEF4-40FF-BB96-A93F03DFD526}"/>
+              </a:ext>
+            </a:extLst>
+          </p:cNvPr>
+          <p:cNvSpPr>
+            <a:spLocks xmlns:a="http://schemas.openxmlformats.org/drawingml/2006/main" noGrp="1"/>
+          </p:cNvSpPr>
+          <p:nvPr/>
+        </p:nvSpPr>
+        <p:spPr>
+          <a:xfrm xmlns:a="http://schemas.openxmlformats.org/drawingml/2006/main">
+            <a:off x="552450" y="381000"/>
+            <a:ext cx="2857500" cy="228600"/>
+          </a:xfrm>
+          <a:prstGeom xmlns:a="http://schemas.openxmlformats.org/drawingml/2006/main" prst="rect">
+            <a:avLst/>
+          </a:prstGeom>
+          <a:noFill xmlns:a="http://schemas.openxmlformats.org/drawingml/2006/main"/>
+          <a:ln xmlns:a="http://schemas.openxmlformats.org/drawingml/2006/main" w="0">
+            <a:noFill/>
+            <a:prstDash val="solid"/>
+          </a:ln>
+        </p:spPr>
+        <p:txBody>
+          <a:bodyPr xmlns:a="http://schemas.openxmlformats.org/drawingml/2006/main"/>
+          <a:lstStyle xmlns:a="http://schemas.openxmlformats.org/drawingml/2006/main"/>
+          <a:p xmlns:a="http://schemas.openxmlformats.org/drawingml/2006/main">
+            <a:pPr>
+              <a:buNone/>
+              <a:defRPr sz="1125" b="1">
+                <a:solidFill>
+                  <a:srgbClr val="22C55E"/>
+                </a:solidFill>
+              </a:defRPr>
+            </a:pPr>
+            <a:r>
+              <a:rPr sz="1125" b="1">
+                <a:solidFill>
+                  <a:srgbClr val="22C55E"/>
+                </a:solidFill>
+              </a:rPr>
+              <a:t>FEATURE SCOPE</a:t>
+            </a:r>
+          </a:p>
+        </p:txBody>
+      </p:sp>
+      <p:sp>
+        <p:nvSpPr>
+          <p:cNvPr id="48" name="readable-summary-heading">
+            <a:extLst xmlns:a="http://schemas.openxmlformats.org/drawingml/2006/main">
+              <a:ext uri="{FF2B5EF4-FFF2-40B4-BE49-F238E27FC236}">
+                <a16:creationId xmlns:a16="http://schemas.microsoft.com/office/drawing/2014/main" id="{718F1B2F-52CA-479A-A2F1-F80BDCB36DA7}"/>
+              </a:ext>
+            </a:extLst>
+          </p:cNvPr>
+          <p:cNvSpPr>
+            <a:spLocks xmlns:a="http://schemas.openxmlformats.org/drawingml/2006/main" noGrp="1"/>
+          </p:cNvSpPr>
+          <p:nvPr/>
+        </p:nvSpPr>
+        <p:spPr>
+          <a:xfrm xmlns:a="http://schemas.openxmlformats.org/drawingml/2006/main">
+            <a:off x="552450" y="781050"/>
+            <a:ext cx="6858000" cy="514350"/>
+          </a:xfrm>
+          <a:prstGeom xmlns:a="http://schemas.openxmlformats.org/drawingml/2006/main" prst="rect">
+            <a:avLst/>
+          </a:prstGeom>
+          <a:noFill xmlns:a="http://schemas.openxmlformats.org/drawingml/2006/main"/>
+          <a:ln xmlns:a="http://schemas.openxmlformats.org/drawingml/2006/main" w="0">
+            <a:noFill/>
+            <a:prstDash val="solid"/>
+          </a:ln>
+        </p:spPr>
+        <p:txBody>
+          <a:bodyPr xmlns:a="http://schemas.openxmlformats.org/drawingml/2006/main"/>
+          <a:lstStyle xmlns:a="http://schemas.openxmlformats.org/drawingml/2006/main"/>
+          <a:p xmlns:a="http://schemas.openxmlformats.org/drawingml/2006/main">
+            <a:pPr>
+              <a:buNone/>
+              <a:defRPr sz="3150" b="1">
+                <a:solidFill>
+                  <a:srgbClr val="FFFFFF"/>
+                </a:solidFill>
+              </a:defRPr>
+            </a:pPr>
+            <a:r>
+              <a:rPr sz="3150" b="1">
+                <a:solidFill>
+                  <a:srgbClr val="FFFFFF"/>
+                </a:solidFill>
+              </a:rPr>
+              <a:t>Kalan ürün özellikleri</a:t>
+            </a:r>
+          </a:p>
+        </p:txBody>
+      </p:sp>
+      <p:sp>
+        <p:nvSpPr>
+          <p:cNvPr id="49" name="readable-summary-subtitle">
+            <a:extLst xmlns:a="http://schemas.openxmlformats.org/drawingml/2006/main">
+              <a:ext uri="{FF2B5EF4-FFF2-40B4-BE49-F238E27FC236}">
+                <a16:creationId xmlns:a16="http://schemas.microsoft.com/office/drawing/2014/main" id="{426C8D26-C2FA-4200-9A10-DC701161DFFD}"/>
+              </a:ext>
+            </a:extLst>
+          </p:cNvPr>
+          <p:cNvSpPr>
+            <a:spLocks xmlns:a="http://schemas.openxmlformats.org/drawingml/2006/main" noGrp="1"/>
+          </p:cNvSpPr>
+          <p:nvPr/>
+        </p:nvSpPr>
+        <p:spPr>
+          <a:xfrm xmlns:a="http://schemas.openxmlformats.org/drawingml/2006/main">
+            <a:off x="571500" y="1409700"/>
+            <a:ext cx="8382000" cy="323850"/>
+          </a:xfrm>
+          <a:prstGeom xmlns:a="http://schemas.openxmlformats.org/drawingml/2006/main" prst="rect">
+            <a:avLst/>
+          </a:prstGeom>
+          <a:noFill xmlns:a="http://schemas.openxmlformats.org/drawingml/2006/main"/>
+          <a:ln xmlns:a="http://schemas.openxmlformats.org/drawingml/2006/main" w="0">
+            <a:noFill/>
+            <a:prstDash val="solid"/>
+          </a:ln>
+        </p:spPr>
+        <p:txBody>
+          <a:bodyPr xmlns:a="http://schemas.openxmlformats.org/drawingml/2006/main"/>
+          <a:lstStyle xmlns:a="http://schemas.openxmlformats.org/drawingml/2006/main"/>
+          <a:p xmlns:a="http://schemas.openxmlformats.org/drawingml/2006/main">
+            <a:pPr>
+              <a:buNone/>
+              <a:defRPr sz="1650">
+                <a:solidFill>
+                  <a:srgbClr val="CBD5E1"/>
+                </a:solidFill>
+              </a:defRPr>
+            </a:pPr>
+            <a:r>
+              <a:rPr sz="1650">
+                <a:solidFill>
+                  <a:srgbClr val="CBD5E1"/>
+                </a:solidFill>
+              </a:rPr>
+              <a:t>Camera Stream, Teleoperation ve kayıt akışları hariç.</a:t>
+            </a:r>
+          </a:p>
+        </p:txBody>
+      </p:sp>
+      <p:sp>
+        <p:nvSpPr>
+          <p:cNvPr id="50" name="readable-summary-block-1">
+            <a:extLst xmlns:a="http://schemas.openxmlformats.org/drawingml/2006/main">
+              <a:ext uri="{FF2B5EF4-FFF2-40B4-BE49-F238E27FC236}">
+                <a16:creationId xmlns:a16="http://schemas.microsoft.com/office/drawing/2014/main" id="{85326EB4-3520-4398-90D6-053CC2043C59}"/>
+              </a:ext>
+            </a:extLst>
+          </p:cNvPr>
+          <p:cNvSpPr>
+            <a:spLocks xmlns:a="http://schemas.openxmlformats.org/drawingml/2006/main" noGrp="1"/>
+          </p:cNvSpPr>
+          <p:nvPr/>
+        </p:nvSpPr>
+        <p:spPr>
+          <a:xfrm xmlns:a="http://schemas.openxmlformats.org/drawingml/2006/main">
+            <a:off x="552450" y="2076450"/>
+            <a:ext cx="5257800" cy="1790700"/>
+          </a:xfrm>
+          <a:prstGeom xmlns:a="http://schemas.openxmlformats.org/drawingml/2006/main" prst="roundRect">
+            <a:avLst>
+              <a:gd name="adj" fmla="val 4255"/>
+            </a:avLst>
+          </a:prstGeom>
+          <a:solidFill xmlns:a="http://schemas.openxmlformats.org/drawingml/2006/main">
+            <a:srgbClr val="111822"/>
+          </a:solidFill>
+          <a:ln xmlns:a="http://schemas.openxmlformats.org/drawingml/2006/main" w="9525">
+            <a:solidFill>
+              <a:srgbClr val="1F2937"/>
+            </a:solidFill>
+            <a:prstDash val="solid"/>
+          </a:ln>
+        </p:spPr>
+      </p:sp>
+      <p:sp>
+        <p:nvSpPr>
+          <p:cNvPr id="51" name="readable-summary-accent-1">
+            <a:extLst xmlns:a="http://schemas.openxmlformats.org/drawingml/2006/main">
+              <a:ext uri="{FF2B5EF4-FFF2-40B4-BE49-F238E27FC236}">
+                <a16:creationId xmlns:a16="http://schemas.microsoft.com/office/drawing/2014/main" id="{D5538E78-F572-4D3B-BC02-A4D929A1F21C}"/>
+              </a:ext>
+            </a:extLst>
+          </p:cNvPr>
+          <p:cNvSpPr>
+            <a:spLocks xmlns:a="http://schemas.openxmlformats.org/drawingml/2006/main" noGrp="1"/>
+          </p:cNvSpPr>
+          <p:nvPr/>
+        </p:nvSpPr>
+        <p:spPr>
+          <a:xfrm xmlns:a="http://schemas.openxmlformats.org/drawingml/2006/main">
+            <a:off x="762000" y="2286000"/>
+            <a:ext cx="1143000" cy="47625"/>
+          </a:xfrm>
+          <a:prstGeom xmlns:a="http://schemas.openxmlformats.org/drawingml/2006/main" prst="rect">
+            <a:avLst/>
+          </a:prstGeom>
+          <a:solidFill xmlns:a="http://schemas.openxmlformats.org/drawingml/2006/main">
+            <a:srgbClr val="EF4444"/>
+          </a:solidFill>
+          <a:ln xmlns:a="http://schemas.openxmlformats.org/drawingml/2006/main" w="0">
+            <a:noFill/>
+            <a:prstDash val="solid"/>
+          </a:ln>
+        </p:spPr>
+      </p:sp>
+      <p:sp>
+        <p:nvSpPr>
+          <p:cNvPr id="52" name="readable-summary-title-1">
+            <a:extLst xmlns:a="http://schemas.openxmlformats.org/drawingml/2006/main">
+              <a:ext uri="{FF2B5EF4-FFF2-40B4-BE49-F238E27FC236}">
+                <a16:creationId xmlns:a16="http://schemas.microsoft.com/office/drawing/2014/main" id="{05E9F8B8-1BDC-4008-B024-5710CA257D0A}"/>
+              </a:ext>
+            </a:extLst>
+          </p:cNvPr>
+          <p:cNvSpPr>
+            <a:spLocks xmlns:a="http://schemas.openxmlformats.org/drawingml/2006/main" noGrp="1"/>
+          </p:cNvSpPr>
+          <p:nvPr/>
+        </p:nvSpPr>
+        <p:spPr>
+          <a:xfrm xmlns:a="http://schemas.openxmlformats.org/drawingml/2006/main">
+            <a:off x="762000" y="2476500"/>
+            <a:ext cx="4762500" cy="304800"/>
+          </a:xfrm>
+          <a:prstGeom xmlns:a="http://schemas.openxmlformats.org/drawingml/2006/main" prst="rect">
+            <a:avLst/>
+          </a:prstGeom>
+          <a:noFill xmlns:a="http://schemas.openxmlformats.org/drawingml/2006/main"/>
+          <a:ln xmlns:a="http://schemas.openxmlformats.org/drawingml/2006/main" w="0">
+            <a:noFill/>
+            <a:prstDash val="solid"/>
+          </a:ln>
+        </p:spPr>
+        <p:txBody>
+          <a:bodyPr xmlns:a="http://schemas.openxmlformats.org/drawingml/2006/main"/>
+          <a:lstStyle xmlns:a="http://schemas.openxmlformats.org/drawingml/2006/main"/>
+          <a:p xmlns:a="http://schemas.openxmlformats.org/drawingml/2006/main">
+            <a:pPr>
+              <a:buNone/>
+              <a:defRPr sz="1875" b="1">
+                <a:solidFill>
+                  <a:srgbClr val="FFFFFF"/>
+                </a:solidFill>
+              </a:defRPr>
+            </a:pPr>
+            <a:r>
+              <a:rPr sz="1875" b="1">
+                <a:solidFill>
+                  <a:srgbClr val="FFFFFF"/>
+                </a:solidFill>
+              </a:rPr>
+              <a:t>Cockpit ve AI</a:t>
+            </a:r>
+          </a:p>
+        </p:txBody>
+      </p:sp>
+      <p:sp>
+        <p:nvSpPr>
+          <p:cNvPr id="53" name="readable-summary-dot-1-0">
+            <a:extLst xmlns:a="http://schemas.openxmlformats.org/drawingml/2006/main">
+              <a:ext uri="{FF2B5EF4-FFF2-40B4-BE49-F238E27FC236}">
+                <a16:creationId xmlns:a16="http://schemas.microsoft.com/office/drawing/2014/main" id="{CD822141-F1A4-46E7-840F-C0CB44AA2B15}"/>
+              </a:ext>
+            </a:extLst>
+          </p:cNvPr>
+          <p:cNvSpPr>
+            <a:spLocks xmlns:a="http://schemas.openxmlformats.org/drawingml/2006/main" noGrp="1"/>
+          </p:cNvSpPr>
+          <p:nvPr/>
+        </p:nvSpPr>
+        <p:spPr>
+          <a:xfrm xmlns:a="http://schemas.openxmlformats.org/drawingml/2006/main">
+            <a:off x="790575" y="2990850"/>
+            <a:ext cx="76200" cy="76200"/>
+          </a:xfrm>
+          <a:prstGeom xmlns:a="http://schemas.openxmlformats.org/drawingml/2006/main" prst="ellipse">
+            <a:avLst/>
+          </a:prstGeom>
+          <a:solidFill xmlns:a="http://schemas.openxmlformats.org/drawingml/2006/main">
+            <a:srgbClr val="EF4444"/>
+          </a:solidFill>
+          <a:ln xmlns:a="http://schemas.openxmlformats.org/drawingml/2006/main" w="0">
+            <a:noFill/>
+            <a:prstDash val="solid"/>
+          </a:ln>
+        </p:spPr>
+      </p:sp>
+      <p:sp>
+        <p:nvSpPr>
+          <p:cNvPr id="54" name="readable-summary-item-1-0">
+            <a:extLst xmlns:a="http://schemas.openxmlformats.org/drawingml/2006/main">
+              <a:ext uri="{FF2B5EF4-FFF2-40B4-BE49-F238E27FC236}">
+                <a16:creationId xmlns:a16="http://schemas.microsoft.com/office/drawing/2014/main" id="{FB2135DA-962B-4EF6-9A92-C96A602629CA}"/>
+              </a:ext>
+            </a:extLst>
+          </p:cNvPr>
+          <p:cNvSpPr>
+            <a:spLocks xmlns:a="http://schemas.openxmlformats.org/drawingml/2006/main" noGrp="1"/>
+          </p:cNvSpPr>
+          <p:nvPr/>
+        </p:nvSpPr>
+        <p:spPr>
+          <a:xfrm xmlns:a="http://schemas.openxmlformats.org/drawingml/2006/main">
+            <a:off x="990600" y="2914650"/>
+            <a:ext cx="4476750" cy="266700"/>
+          </a:xfrm>
+          <a:prstGeom xmlns:a="http://schemas.openxmlformats.org/drawingml/2006/main" prst="rect">
+            <a:avLst/>
+          </a:prstGeom>
+          <a:noFill xmlns:a="http://schemas.openxmlformats.org/drawingml/2006/main"/>
+          <a:ln xmlns:a="http://schemas.openxmlformats.org/drawingml/2006/main" w="0">
+            <a:noFill/>
+            <a:prstDash val="solid"/>
+          </a:ln>
+        </p:spPr>
+        <p:txBody>
+          <a:bodyPr xmlns:a="http://schemas.openxmlformats.org/drawingml/2006/main"/>
+          <a:lstStyle xmlns:a="http://schemas.openxmlformats.org/drawingml/2006/main"/>
+          <a:p xmlns:a="http://schemas.openxmlformats.org/drawingml/2006/main">
+            <a:pPr>
+              <a:buNone/>
+              <a:defRPr sz="1500">
+                <a:solidFill>
+                  <a:srgbClr val="DBE4EF"/>
+                </a:solidFill>
+              </a:defRPr>
+            </a:pPr>
+            <a:r>
+              <a:rPr sz="1500">
+                <a:solidFill>
+                  <a:srgbClr val="DBE4EF"/>
+                </a:solidFill>
+              </a:rPr>
+              <a:t>AI Chatbot</a:t>
+            </a:r>
+          </a:p>
+        </p:txBody>
+      </p:sp>
+      <p:sp>
+        <p:nvSpPr>
+          <p:cNvPr id="55" name="readable-summary-dot-1-1">
+            <a:extLst xmlns:a="http://schemas.openxmlformats.org/drawingml/2006/main">
+              <a:ext uri="{FF2B5EF4-FFF2-40B4-BE49-F238E27FC236}">
+                <a16:creationId xmlns:a16="http://schemas.microsoft.com/office/drawing/2014/main" id="{84D62CF7-42FD-40E0-9818-0181E2458EB3}"/>
+              </a:ext>
+            </a:extLst>
+          </p:cNvPr>
+          <p:cNvSpPr>
+            <a:spLocks xmlns:a="http://schemas.openxmlformats.org/drawingml/2006/main" noGrp="1"/>
+          </p:cNvSpPr>
+          <p:nvPr/>
+        </p:nvSpPr>
+        <p:spPr>
+          <a:xfrm xmlns:a="http://schemas.openxmlformats.org/drawingml/2006/main">
+            <a:off x="790575" y="3333750"/>
+            <a:ext cx="76200" cy="76200"/>
+          </a:xfrm>
+          <a:prstGeom xmlns:a="http://schemas.openxmlformats.org/drawingml/2006/main" prst="ellipse">
+            <a:avLst/>
+          </a:prstGeom>
+          <a:solidFill xmlns:a="http://schemas.openxmlformats.org/drawingml/2006/main">
+            <a:srgbClr val="EF4444"/>
+          </a:solidFill>
+          <a:ln xmlns:a="http://schemas.openxmlformats.org/drawingml/2006/main" w="0">
+            <a:noFill/>
+            <a:prstDash val="solid"/>
+          </a:ln>
+        </p:spPr>
+      </p:sp>
+      <p:sp>
+        <p:nvSpPr>
+          <p:cNvPr id="56" name="readable-summary-item-1-1">
+            <a:extLst xmlns:a="http://schemas.openxmlformats.org/drawingml/2006/main">
+              <a:ext uri="{FF2B5EF4-FFF2-40B4-BE49-F238E27FC236}">
+                <a16:creationId xmlns:a16="http://schemas.microsoft.com/office/drawing/2014/main" id="{9ABF595C-4CF9-4ED2-BF52-554AFB514FCE}"/>
+              </a:ext>
+            </a:extLst>
+          </p:cNvPr>
+          <p:cNvSpPr>
+            <a:spLocks xmlns:a="http://schemas.openxmlformats.org/drawingml/2006/main" noGrp="1"/>
+          </p:cNvSpPr>
+          <p:nvPr/>
+        </p:nvSpPr>
+        <p:spPr>
+          <a:xfrm xmlns:a="http://schemas.openxmlformats.org/drawingml/2006/main">
+            <a:off x="990600" y="3257550"/>
+            <a:ext cx="4476750" cy="266700"/>
+          </a:xfrm>
+          <a:prstGeom xmlns:a="http://schemas.openxmlformats.org/drawingml/2006/main" prst="rect">
+            <a:avLst/>
+          </a:prstGeom>
+          <a:noFill xmlns:a="http://schemas.openxmlformats.org/drawingml/2006/main"/>
+          <a:ln xmlns:a="http://schemas.openxmlformats.org/drawingml/2006/main" w="0">
+            <a:noFill/>
+            <a:prstDash val="solid"/>
+          </a:ln>
+        </p:spPr>
+        <p:txBody>
+          <a:bodyPr xmlns:a="http://schemas.openxmlformats.org/drawingml/2006/main"/>
+          <a:lstStyle xmlns:a="http://schemas.openxmlformats.org/drawingml/2006/main"/>
+          <a:p xmlns:a="http://schemas.openxmlformats.org/drawingml/2006/main">
+            <a:pPr>
+              <a:buNone/>
+              <a:defRPr sz="1500">
+                <a:solidFill>
+                  <a:srgbClr val="DBE4EF"/>
+                </a:solidFill>
+              </a:defRPr>
+            </a:pPr>
+            <a:r>
+              <a:rPr sz="1500">
+                <a:solidFill>
+                  <a:srgbClr val="DBE4EF"/>
+                </a:solidFill>
+              </a:rPr>
+              <a:t>Bilgi Akışı / RAG</a:t>
+            </a:r>
+          </a:p>
+        </p:txBody>
+      </p:sp>
+      <p:sp>
+        <p:nvSpPr>
+          <p:cNvPr id="57" name="readable-summary-dot-1-2">
+            <a:extLst xmlns:a="http://schemas.openxmlformats.org/drawingml/2006/main">
+              <a:ext uri="{FF2B5EF4-FFF2-40B4-BE49-F238E27FC236}">
+                <a16:creationId xmlns:a16="http://schemas.microsoft.com/office/drawing/2014/main" id="{6FACE029-B6E2-4F1A-94AA-97501F7FD294}"/>
+              </a:ext>
+            </a:extLst>
+          </p:cNvPr>
+          <p:cNvSpPr>
+            <a:spLocks xmlns:a="http://schemas.openxmlformats.org/drawingml/2006/main" noGrp="1"/>
+          </p:cNvSpPr>
+          <p:nvPr/>
+        </p:nvSpPr>
+        <p:spPr>
+          <a:xfrm xmlns:a="http://schemas.openxmlformats.org/drawingml/2006/main">
+            <a:off x="790575" y="3676650"/>
+            <a:ext cx="76200" cy="76200"/>
+          </a:xfrm>
+          <a:prstGeom xmlns:a="http://schemas.openxmlformats.org/drawingml/2006/main" prst="ellipse">
+            <a:avLst/>
+          </a:prstGeom>
+          <a:solidFill xmlns:a="http://schemas.openxmlformats.org/drawingml/2006/main">
+            <a:srgbClr val="EF4444"/>
+          </a:solidFill>
+          <a:ln xmlns:a="http://schemas.openxmlformats.org/drawingml/2006/main" w="0">
+            <a:noFill/>
+            <a:prstDash val="solid"/>
+          </a:ln>
+        </p:spPr>
+      </p:sp>
+      <p:sp>
+        <p:nvSpPr>
+          <p:cNvPr id="58" name="readable-summary-item-1-2">
+            <a:extLst xmlns:a="http://schemas.openxmlformats.org/drawingml/2006/main">
+              <a:ext uri="{FF2B5EF4-FFF2-40B4-BE49-F238E27FC236}">
+                <a16:creationId xmlns:a16="http://schemas.microsoft.com/office/drawing/2014/main" id="{2FF4E693-89A7-4FC6-8701-23E4384169B4}"/>
+              </a:ext>
+            </a:extLst>
+          </p:cNvPr>
+          <p:cNvSpPr>
+            <a:spLocks xmlns:a="http://schemas.openxmlformats.org/drawingml/2006/main" noGrp="1"/>
+          </p:cNvSpPr>
+          <p:nvPr/>
+        </p:nvSpPr>
+        <p:spPr>
+          <a:xfrm xmlns:a="http://schemas.openxmlformats.org/drawingml/2006/main">
+            <a:off x="990600" y="3600450"/>
+            <a:ext cx="4476750" cy="266700"/>
+          </a:xfrm>
+          <a:prstGeom xmlns:a="http://schemas.openxmlformats.org/drawingml/2006/main" prst="rect">
+            <a:avLst/>
+          </a:prstGeom>
+          <a:noFill xmlns:a="http://schemas.openxmlformats.org/drawingml/2006/main"/>
+          <a:ln xmlns:a="http://schemas.openxmlformats.org/drawingml/2006/main" w="0">
+            <a:noFill/>
+            <a:prstDash val="solid"/>
+          </a:ln>
+        </p:spPr>
+        <p:txBody>
+          <a:bodyPr xmlns:a="http://schemas.openxmlformats.org/drawingml/2006/main"/>
+          <a:lstStyle xmlns:a="http://schemas.openxmlformats.org/drawingml/2006/main"/>
+          <a:p xmlns:a="http://schemas.openxmlformats.org/drawingml/2006/main">
+            <a:pPr>
+              <a:buNone/>
+              <a:defRPr sz="1500">
+                <a:solidFill>
+                  <a:srgbClr val="DBE4EF"/>
+                </a:solidFill>
+              </a:defRPr>
+            </a:pPr>
+            <a:r>
+              <a:rPr sz="1500">
+                <a:solidFill>
+                  <a:srgbClr val="DBE4EF"/>
+                </a:solidFill>
+              </a:rPr>
+              <a:t>Tek cockpit deneyimi</a:t>
+            </a:r>
+          </a:p>
+        </p:txBody>
+      </p:sp>
+      <p:sp>
+        <p:nvSpPr>
+          <p:cNvPr id="59" name="readable-summary-block-2">
+            <a:extLst xmlns:a="http://schemas.openxmlformats.org/drawingml/2006/main">
+              <a:ext uri="{FF2B5EF4-FFF2-40B4-BE49-F238E27FC236}">
+                <a16:creationId xmlns:a16="http://schemas.microsoft.com/office/drawing/2014/main" id="{3913600C-4679-4BD8-939A-02EE8BEEEA81}"/>
+              </a:ext>
+            </a:extLst>
+          </p:cNvPr>
+          <p:cNvSpPr>
+            <a:spLocks xmlns:a="http://schemas.openxmlformats.org/drawingml/2006/main" noGrp="1"/>
+          </p:cNvSpPr>
+          <p:nvPr/>
+        </p:nvSpPr>
+        <p:spPr>
+          <a:xfrm xmlns:a="http://schemas.openxmlformats.org/drawingml/2006/main">
+            <a:off x="6381750" y="2076450"/>
+            <a:ext cx="5257800" cy="1790700"/>
+          </a:xfrm>
+          <a:prstGeom xmlns:a="http://schemas.openxmlformats.org/drawingml/2006/main" prst="roundRect">
+            <a:avLst>
+              <a:gd name="adj" fmla="val 4255"/>
+            </a:avLst>
+          </a:prstGeom>
+          <a:solidFill xmlns:a="http://schemas.openxmlformats.org/drawingml/2006/main">
+            <a:srgbClr val="111822"/>
+          </a:solidFill>
+          <a:ln xmlns:a="http://schemas.openxmlformats.org/drawingml/2006/main" w="9525">
+            <a:solidFill>
+              <a:srgbClr val="1F2937"/>
+            </a:solidFill>
+            <a:prstDash val="solid"/>
+          </a:ln>
+        </p:spPr>
+      </p:sp>
+      <p:sp>
+        <p:nvSpPr>
+          <p:cNvPr id="60" name="readable-summary-accent-2">
+            <a:extLst xmlns:a="http://schemas.openxmlformats.org/drawingml/2006/main">
+              <a:ext uri="{FF2B5EF4-FFF2-40B4-BE49-F238E27FC236}">
+                <a16:creationId xmlns:a16="http://schemas.microsoft.com/office/drawing/2014/main" id="{BE0D91B6-A502-4AC1-9D9E-B84A7007350B}"/>
+              </a:ext>
+            </a:extLst>
+          </p:cNvPr>
+          <p:cNvSpPr>
+            <a:spLocks xmlns:a="http://schemas.openxmlformats.org/drawingml/2006/main" noGrp="1"/>
+          </p:cNvSpPr>
+          <p:nvPr/>
+        </p:nvSpPr>
+        <p:spPr>
+          <a:xfrm xmlns:a="http://schemas.openxmlformats.org/drawingml/2006/main">
+            <a:off x="6591300" y="2286000"/>
+            <a:ext cx="1143000" cy="47625"/>
+          </a:xfrm>
+          <a:prstGeom xmlns:a="http://schemas.openxmlformats.org/drawingml/2006/main" prst="rect">
+            <a:avLst/>
+          </a:prstGeom>
+          <a:solidFill xmlns:a="http://schemas.openxmlformats.org/drawingml/2006/main">
+            <a:srgbClr val="38BDF8"/>
+          </a:solidFill>
+          <a:ln xmlns:a="http://schemas.openxmlformats.org/drawingml/2006/main" w="0">
+            <a:noFill/>
+            <a:prstDash val="solid"/>
+          </a:ln>
+        </p:spPr>
+      </p:sp>
+      <p:sp>
+        <p:nvSpPr>
+          <p:cNvPr id="61" name="readable-summary-title-2">
+            <a:extLst xmlns:a="http://schemas.openxmlformats.org/drawingml/2006/main">
+              <a:ext uri="{FF2B5EF4-FFF2-40B4-BE49-F238E27FC236}">
+                <a16:creationId xmlns:a16="http://schemas.microsoft.com/office/drawing/2014/main" id="{55F6837D-2064-412D-B071-DF64870FB52B}"/>
+              </a:ext>
+            </a:extLst>
+          </p:cNvPr>
+          <p:cNvSpPr>
+            <a:spLocks xmlns:a="http://schemas.openxmlformats.org/drawingml/2006/main" noGrp="1"/>
+          </p:cNvSpPr>
+          <p:nvPr/>
+        </p:nvSpPr>
+        <p:spPr>
+          <a:xfrm xmlns:a="http://schemas.openxmlformats.org/drawingml/2006/main">
+            <a:off x="6591300" y="2476500"/>
+            <a:ext cx="4762500" cy="304800"/>
+          </a:xfrm>
+          <a:prstGeom xmlns:a="http://schemas.openxmlformats.org/drawingml/2006/main" prst="rect">
+            <a:avLst/>
+          </a:prstGeom>
+          <a:noFill xmlns:a="http://schemas.openxmlformats.org/drawingml/2006/main"/>
+          <a:ln xmlns:a="http://schemas.openxmlformats.org/drawingml/2006/main" w="0">
+            <a:noFill/>
+            <a:prstDash val="solid"/>
+          </a:ln>
+        </p:spPr>
+        <p:txBody>
+          <a:bodyPr xmlns:a="http://schemas.openxmlformats.org/drawingml/2006/main"/>
+          <a:lstStyle xmlns:a="http://schemas.openxmlformats.org/drawingml/2006/main"/>
+          <a:p xmlns:a="http://schemas.openxmlformats.org/drawingml/2006/main">
+            <a:pPr>
+              <a:buNone/>
+              <a:defRPr sz="1875" b="1">
+                <a:solidFill>
+                  <a:srgbClr val="FFFFFF"/>
+                </a:solidFill>
+              </a:defRPr>
+            </a:pPr>
+            <a:r>
+              <a:rPr sz="1875" b="1">
+                <a:solidFill>
+                  <a:srgbClr val="FFFFFF"/>
+                </a:solidFill>
+              </a:rPr>
+              <a:t>Robot Twin</a:t>
+            </a:r>
+          </a:p>
+        </p:txBody>
+      </p:sp>
+      <p:sp>
+        <p:nvSpPr>
+          <p:cNvPr id="62" name="readable-summary-dot-2-0">
+            <a:extLst xmlns:a="http://schemas.openxmlformats.org/drawingml/2006/main">
+              <a:ext uri="{FF2B5EF4-FFF2-40B4-BE49-F238E27FC236}">
+                <a16:creationId xmlns:a16="http://schemas.microsoft.com/office/drawing/2014/main" id="{91C75C38-F8BD-4045-9B36-BA836BEC73E4}"/>
+              </a:ext>
+            </a:extLst>
+          </p:cNvPr>
+          <p:cNvSpPr>
+            <a:spLocks xmlns:a="http://schemas.openxmlformats.org/drawingml/2006/main" noGrp="1"/>
+          </p:cNvSpPr>
+          <p:nvPr/>
+        </p:nvSpPr>
+        <p:spPr>
+          <a:xfrm xmlns:a="http://schemas.openxmlformats.org/drawingml/2006/main">
+            <a:off x="6619875" y="2990850"/>
+            <a:ext cx="76200" cy="76200"/>
+          </a:xfrm>
+          <a:prstGeom xmlns:a="http://schemas.openxmlformats.org/drawingml/2006/main" prst="ellipse">
+            <a:avLst/>
+          </a:prstGeom>
+          <a:solidFill xmlns:a="http://schemas.openxmlformats.org/drawingml/2006/main">
+            <a:srgbClr val="38BDF8"/>
+          </a:solidFill>
+          <a:ln xmlns:a="http://schemas.openxmlformats.org/drawingml/2006/main" w="0">
+            <a:noFill/>
+            <a:prstDash val="solid"/>
+          </a:ln>
+        </p:spPr>
+      </p:sp>
+      <p:sp>
+        <p:nvSpPr>
+          <p:cNvPr id="63" name="readable-summary-item-2-0">
+            <a:extLst xmlns:a="http://schemas.openxmlformats.org/drawingml/2006/main">
+              <a:ext uri="{FF2B5EF4-FFF2-40B4-BE49-F238E27FC236}">
+                <a16:creationId xmlns:a16="http://schemas.microsoft.com/office/drawing/2014/main" id="{08D6FE2B-6EEE-4297-B074-7A2646BEAA3F}"/>
+              </a:ext>
+            </a:extLst>
+          </p:cNvPr>
+          <p:cNvSpPr>
+            <a:spLocks xmlns:a="http://schemas.openxmlformats.org/drawingml/2006/main" noGrp="1"/>
+          </p:cNvSpPr>
+          <p:nvPr/>
+        </p:nvSpPr>
+        <p:spPr>
+          <a:xfrm xmlns:a="http://schemas.openxmlformats.org/drawingml/2006/main">
+            <a:off x="6819900" y="2914650"/>
+            <a:ext cx="4476750" cy="266700"/>
+          </a:xfrm>
+          <a:prstGeom xmlns:a="http://schemas.openxmlformats.org/drawingml/2006/main" prst="rect">
+            <a:avLst/>
+          </a:prstGeom>
+          <a:noFill xmlns:a="http://schemas.openxmlformats.org/drawingml/2006/main"/>
+          <a:ln xmlns:a="http://schemas.openxmlformats.org/drawingml/2006/main" w="0">
+            <a:noFill/>
+            <a:prstDash val="solid"/>
+          </a:ln>
+        </p:spPr>
+        <p:txBody>
+          <a:bodyPr xmlns:a="http://schemas.openxmlformats.org/drawingml/2006/main"/>
+          <a:lstStyle xmlns:a="http://schemas.openxmlformats.org/drawingml/2006/main"/>
+          <a:p xmlns:a="http://schemas.openxmlformats.org/drawingml/2006/main">
+            <a:pPr>
+              <a:buNone/>
+              <a:defRPr sz="1500">
+                <a:solidFill>
+                  <a:srgbClr val="DBE4EF"/>
+                </a:solidFill>
+              </a:defRPr>
+            </a:pPr>
+            <a:r>
+              <a:rPr sz="1500">
+                <a:solidFill>
+                  <a:srgbClr val="DBE4EF"/>
+                </a:solidFill>
+              </a:rPr>
+              <a:t>Dijital robot görünümü</a:t>
+            </a:r>
+          </a:p>
+        </p:txBody>
+      </p:sp>
+      <p:sp>
+        <p:nvSpPr>
+          <p:cNvPr id="64" name="readable-summary-dot-2-1">
+            <a:extLst xmlns:a="http://schemas.openxmlformats.org/drawingml/2006/main">
+              <a:ext uri="{FF2B5EF4-FFF2-40B4-BE49-F238E27FC236}">
+                <a16:creationId xmlns:a16="http://schemas.microsoft.com/office/drawing/2014/main" id="{B0016F89-894C-4BFC-8776-F31E7F6830F9}"/>
+              </a:ext>
+            </a:extLst>
+          </p:cNvPr>
+          <p:cNvSpPr>
+            <a:spLocks xmlns:a="http://schemas.openxmlformats.org/drawingml/2006/main" noGrp="1"/>
+          </p:cNvSpPr>
+          <p:nvPr/>
+        </p:nvSpPr>
+        <p:spPr>
+          <a:xfrm xmlns:a="http://schemas.openxmlformats.org/drawingml/2006/main">
+            <a:off x="6619875" y="3333750"/>
+            <a:ext cx="76200" cy="76200"/>
+          </a:xfrm>
+          <a:prstGeom xmlns:a="http://schemas.openxmlformats.org/drawingml/2006/main" prst="ellipse">
+            <a:avLst/>
+          </a:prstGeom>
+          <a:solidFill xmlns:a="http://schemas.openxmlformats.org/drawingml/2006/main">
+            <a:srgbClr val="38BDF8"/>
+          </a:solidFill>
+          <a:ln xmlns:a="http://schemas.openxmlformats.org/drawingml/2006/main" w="0">
+            <a:noFill/>
+            <a:prstDash val="solid"/>
+          </a:ln>
+        </p:spPr>
+      </p:sp>
+      <p:sp>
+        <p:nvSpPr>
+          <p:cNvPr id="65" name="readable-summary-item-2-1">
+            <a:extLst xmlns:a="http://schemas.openxmlformats.org/drawingml/2006/main">
+              <a:ext uri="{FF2B5EF4-FFF2-40B4-BE49-F238E27FC236}">
+                <a16:creationId xmlns:a16="http://schemas.microsoft.com/office/drawing/2014/main" id="{07F6F198-693B-4B4C-A5E3-50E67E32FF4C}"/>
+              </a:ext>
+            </a:extLst>
+          </p:cNvPr>
+          <p:cNvSpPr>
+            <a:spLocks xmlns:a="http://schemas.openxmlformats.org/drawingml/2006/main" noGrp="1"/>
+          </p:cNvSpPr>
+          <p:nvPr/>
+        </p:nvSpPr>
+        <p:spPr>
+          <a:xfrm xmlns:a="http://schemas.openxmlformats.org/drawingml/2006/main">
+            <a:off x="6819900" y="3257550"/>
+            <a:ext cx="4476750" cy="266700"/>
+          </a:xfrm>
+          <a:prstGeom xmlns:a="http://schemas.openxmlformats.org/drawingml/2006/main" prst="rect">
+            <a:avLst/>
+          </a:prstGeom>
+          <a:noFill xmlns:a="http://schemas.openxmlformats.org/drawingml/2006/main"/>
+          <a:ln xmlns:a="http://schemas.openxmlformats.org/drawingml/2006/main" w="0">
+            <a:noFill/>
+            <a:prstDash val="solid"/>
+          </a:ln>
+        </p:spPr>
+        <p:txBody>
+          <a:bodyPr xmlns:a="http://schemas.openxmlformats.org/drawingml/2006/main"/>
+          <a:lstStyle xmlns:a="http://schemas.openxmlformats.org/drawingml/2006/main"/>
+          <a:p xmlns:a="http://schemas.openxmlformats.org/drawingml/2006/main">
+            <a:pPr>
+              <a:buNone/>
+              <a:defRPr sz="1500">
+                <a:solidFill>
+                  <a:srgbClr val="DBE4EF"/>
+                </a:solidFill>
+              </a:defRPr>
+            </a:pPr>
+            <a:r>
+              <a:rPr sz="1500">
+                <a:solidFill>
+                  <a:srgbClr val="DBE4EF"/>
+                </a:solidFill>
+              </a:rPr>
+              <a:t>Sahne farkındalığı</a:t>
+            </a:r>
+          </a:p>
+        </p:txBody>
+      </p:sp>
+      <p:sp>
+        <p:nvSpPr>
+          <p:cNvPr id="66" name="readable-summary-dot-2-2">
+            <a:extLst xmlns:a="http://schemas.openxmlformats.org/drawingml/2006/main">
+              <a:ext uri="{FF2B5EF4-FFF2-40B4-BE49-F238E27FC236}">
+                <a16:creationId xmlns:a16="http://schemas.microsoft.com/office/drawing/2014/main" id="{4661C53A-89B0-414B-8E40-A0BBB59963AE}"/>
+              </a:ext>
+            </a:extLst>
+          </p:cNvPr>
+          <p:cNvSpPr>
+            <a:spLocks xmlns:a="http://schemas.openxmlformats.org/drawingml/2006/main" noGrp="1"/>
+          </p:cNvSpPr>
+          <p:nvPr/>
+        </p:nvSpPr>
+        <p:spPr>
+          <a:xfrm xmlns:a="http://schemas.openxmlformats.org/drawingml/2006/main">
+            <a:off x="6619875" y="3676650"/>
+            <a:ext cx="76200" cy="76200"/>
+          </a:xfrm>
+          <a:prstGeom xmlns:a="http://schemas.openxmlformats.org/drawingml/2006/main" prst="ellipse">
+            <a:avLst/>
+          </a:prstGeom>
+          <a:solidFill xmlns:a="http://schemas.openxmlformats.org/drawingml/2006/main">
+            <a:srgbClr val="38BDF8"/>
+          </a:solidFill>
+          <a:ln xmlns:a="http://schemas.openxmlformats.org/drawingml/2006/main" w="0">
+            <a:noFill/>
+            <a:prstDash val="solid"/>
+          </a:ln>
+        </p:spPr>
+      </p:sp>
+      <p:sp>
+        <p:nvSpPr>
+          <p:cNvPr id="67" name="readable-summary-item-2-2">
+            <a:extLst xmlns:a="http://schemas.openxmlformats.org/drawingml/2006/main">
+              <a:ext uri="{FF2B5EF4-FFF2-40B4-BE49-F238E27FC236}">
+                <a16:creationId xmlns:a16="http://schemas.microsoft.com/office/drawing/2014/main" id="{BC1B2816-A240-4543-8883-273132E01FE2}"/>
+              </a:ext>
+            </a:extLst>
+          </p:cNvPr>
+          <p:cNvSpPr>
+            <a:spLocks xmlns:a="http://schemas.openxmlformats.org/drawingml/2006/main" noGrp="1"/>
+          </p:cNvSpPr>
+          <p:nvPr/>
+        </p:nvSpPr>
+        <p:spPr>
+          <a:xfrm xmlns:a="http://schemas.openxmlformats.org/drawingml/2006/main">
+            <a:off x="6819900" y="3600450"/>
+            <a:ext cx="4476750" cy="266700"/>
+          </a:xfrm>
+          <a:prstGeom xmlns:a="http://schemas.openxmlformats.org/drawingml/2006/main" prst="rect">
+            <a:avLst/>
+          </a:prstGeom>
+          <a:noFill xmlns:a="http://schemas.openxmlformats.org/drawingml/2006/main"/>
+          <a:ln xmlns:a="http://schemas.openxmlformats.org/drawingml/2006/main" w="0">
+            <a:noFill/>
+            <a:prstDash val="solid"/>
+          </a:ln>
+        </p:spPr>
+        <p:txBody>
+          <a:bodyPr xmlns:a="http://schemas.openxmlformats.org/drawingml/2006/main"/>
+          <a:lstStyle xmlns:a="http://schemas.openxmlformats.org/drawingml/2006/main"/>
+          <a:p xmlns:a="http://schemas.openxmlformats.org/drawingml/2006/main">
+            <a:pPr>
+              <a:buNone/>
+              <a:defRPr sz="1500">
+                <a:solidFill>
+                  <a:srgbClr val="DBE4EF"/>
+                </a:solidFill>
+              </a:defRPr>
+            </a:pPr>
+            <a:r>
+              <a:rPr sz="1500">
+                <a:solidFill>
+                  <a:srgbClr val="DBE4EF"/>
+                </a:solidFill>
+              </a:rPr>
+              <a:t>Robot bağlamını toplama</a:t>
+            </a:r>
+          </a:p>
+        </p:txBody>
+      </p:sp>
+      <p:sp>
+        <p:nvSpPr>
+          <p:cNvPr id="68" name="readable-summary-block-3">
+            <a:extLst xmlns:a="http://schemas.openxmlformats.org/drawingml/2006/main">
+              <a:ext uri="{FF2B5EF4-FFF2-40B4-BE49-F238E27FC236}">
+                <a16:creationId xmlns:a16="http://schemas.microsoft.com/office/drawing/2014/main" id="{5BA7B1CD-337D-4234-998F-25014C2A98BA}"/>
+              </a:ext>
+            </a:extLst>
+          </p:cNvPr>
+          <p:cNvSpPr>
+            <a:spLocks xmlns:a="http://schemas.openxmlformats.org/drawingml/2006/main" noGrp="1"/>
+          </p:cNvSpPr>
+          <p:nvPr/>
+        </p:nvSpPr>
+        <p:spPr>
+          <a:xfrm xmlns:a="http://schemas.openxmlformats.org/drawingml/2006/main">
+            <a:off x="552450" y="4343400"/>
+            <a:ext cx="5257800" cy="1790700"/>
+          </a:xfrm>
+          <a:prstGeom xmlns:a="http://schemas.openxmlformats.org/drawingml/2006/main" prst="roundRect">
+            <a:avLst>
+              <a:gd name="adj" fmla="val 4255"/>
+            </a:avLst>
+          </a:prstGeom>
+          <a:solidFill xmlns:a="http://schemas.openxmlformats.org/drawingml/2006/main">
+            <a:srgbClr val="111822"/>
+          </a:solidFill>
+          <a:ln xmlns:a="http://schemas.openxmlformats.org/drawingml/2006/main" w="9525">
+            <a:solidFill>
+              <a:srgbClr val="1F2937"/>
+            </a:solidFill>
+            <a:prstDash val="solid"/>
+          </a:ln>
+        </p:spPr>
+      </p:sp>
+      <p:sp>
+        <p:nvSpPr>
+          <p:cNvPr id="69" name="readable-summary-accent-3">
+            <a:extLst xmlns:a="http://schemas.openxmlformats.org/drawingml/2006/main">
+              <a:ext uri="{FF2B5EF4-FFF2-40B4-BE49-F238E27FC236}">
+                <a16:creationId xmlns:a16="http://schemas.microsoft.com/office/drawing/2014/main" id="{4E3992C2-C1D8-4340-9318-EF3AF94BDD1B}"/>
+              </a:ext>
+            </a:extLst>
+          </p:cNvPr>
+          <p:cNvSpPr>
+            <a:spLocks xmlns:a="http://schemas.openxmlformats.org/drawingml/2006/main" noGrp="1"/>
+          </p:cNvSpPr>
+          <p:nvPr/>
+        </p:nvSpPr>
+        <p:spPr>
+          <a:xfrm xmlns:a="http://schemas.openxmlformats.org/drawingml/2006/main">
+            <a:off x="762000" y="4552950"/>
+            <a:ext cx="1143000" cy="47625"/>
+          </a:xfrm>
+          <a:prstGeom xmlns:a="http://schemas.openxmlformats.org/drawingml/2006/main" prst="rect">
+            <a:avLst/>
+          </a:prstGeom>
+          <a:solidFill xmlns:a="http://schemas.openxmlformats.org/drawingml/2006/main">
+            <a:srgbClr val="22C55E"/>
+          </a:solidFill>
+          <a:ln xmlns:a="http://schemas.openxmlformats.org/drawingml/2006/main" w="0">
+            <a:noFill/>
+            <a:prstDash val="solid"/>
+          </a:ln>
+        </p:spPr>
+      </p:sp>
+      <p:sp>
+        <p:nvSpPr>
+          <p:cNvPr id="70" name="readable-summary-title-3">
+            <a:extLst xmlns:a="http://schemas.openxmlformats.org/drawingml/2006/main">
+              <a:ext uri="{FF2B5EF4-FFF2-40B4-BE49-F238E27FC236}">
+                <a16:creationId xmlns:a16="http://schemas.microsoft.com/office/drawing/2014/main" id="{029F0BA4-E249-4E4D-93E1-573D109C8950}"/>
+              </a:ext>
+            </a:extLst>
+          </p:cNvPr>
+          <p:cNvSpPr>
+            <a:spLocks xmlns:a="http://schemas.openxmlformats.org/drawingml/2006/main" noGrp="1"/>
+          </p:cNvSpPr>
+          <p:nvPr/>
+        </p:nvSpPr>
+        <p:spPr>
+          <a:xfrm xmlns:a="http://schemas.openxmlformats.org/drawingml/2006/main">
+            <a:off x="762000" y="4743450"/>
+            <a:ext cx="4762500" cy="304800"/>
+          </a:xfrm>
+          <a:prstGeom xmlns:a="http://schemas.openxmlformats.org/drawingml/2006/main" prst="rect">
+            <a:avLst/>
+          </a:prstGeom>
+          <a:noFill xmlns:a="http://schemas.openxmlformats.org/drawingml/2006/main"/>
+          <a:ln xmlns:a="http://schemas.openxmlformats.org/drawingml/2006/main" w="0">
+            <a:noFill/>
+            <a:prstDash val="solid"/>
+          </a:ln>
+        </p:spPr>
+        <p:txBody>
+          <a:bodyPr xmlns:a="http://schemas.openxmlformats.org/drawingml/2006/main"/>
+          <a:lstStyle xmlns:a="http://schemas.openxmlformats.org/drawingml/2006/main"/>
+          <a:p xmlns:a="http://schemas.openxmlformats.org/drawingml/2006/main">
+            <a:pPr>
+              <a:buNone/>
+              <a:defRPr sz="1875" b="1">
+                <a:solidFill>
+                  <a:srgbClr val="FFFFFF"/>
+                </a:solidFill>
+              </a:defRPr>
+            </a:pPr>
+            <a:r>
+              <a:rPr sz="1875" b="1">
+                <a:solidFill>
+                  <a:srgbClr val="FFFFFF"/>
+                </a:solidFill>
+              </a:rPr>
+              <a:t>Live Dashboard</a:t>
+            </a:r>
+          </a:p>
+        </p:txBody>
+      </p:sp>
+      <p:sp>
+        <p:nvSpPr>
+          <p:cNvPr id="71" name="readable-summary-dot-3-0">
+            <a:extLst xmlns:a="http://schemas.openxmlformats.org/drawingml/2006/main">
+              <a:ext uri="{FF2B5EF4-FFF2-40B4-BE49-F238E27FC236}">
+                <a16:creationId xmlns:a16="http://schemas.microsoft.com/office/drawing/2014/main" id="{B7AAF0FF-39F1-4AA7-A0A3-2BFB318270D6}"/>
+              </a:ext>
+            </a:extLst>
+          </p:cNvPr>
+          <p:cNvSpPr>
+            <a:spLocks xmlns:a="http://schemas.openxmlformats.org/drawingml/2006/main" noGrp="1"/>
+          </p:cNvSpPr>
+          <p:nvPr/>
+        </p:nvSpPr>
+        <p:spPr>
+          <a:xfrm xmlns:a="http://schemas.openxmlformats.org/drawingml/2006/main">
+            <a:off x="790575" y="5257800"/>
+            <a:ext cx="76200" cy="76200"/>
+          </a:xfrm>
+          <a:prstGeom xmlns:a="http://schemas.openxmlformats.org/drawingml/2006/main" prst="ellipse">
+            <a:avLst/>
+          </a:prstGeom>
+          <a:solidFill xmlns:a="http://schemas.openxmlformats.org/drawingml/2006/main">
+            <a:srgbClr val="22C55E"/>
+          </a:solidFill>
+          <a:ln xmlns:a="http://schemas.openxmlformats.org/drawingml/2006/main" w="0">
+            <a:noFill/>
+            <a:prstDash val="solid"/>
+          </a:ln>
+        </p:spPr>
+      </p:sp>
+      <p:sp>
+        <p:nvSpPr>
+          <p:cNvPr id="72" name="readable-summary-item-3-0">
+            <a:extLst xmlns:a="http://schemas.openxmlformats.org/drawingml/2006/main">
+              <a:ext uri="{FF2B5EF4-FFF2-40B4-BE49-F238E27FC236}">
+                <a16:creationId xmlns:a16="http://schemas.microsoft.com/office/drawing/2014/main" id="{7276D2F7-458F-4734-9D17-2E600EF9FC41}"/>
+              </a:ext>
+            </a:extLst>
+          </p:cNvPr>
+          <p:cNvSpPr>
+            <a:spLocks xmlns:a="http://schemas.openxmlformats.org/drawingml/2006/main" noGrp="1"/>
+          </p:cNvSpPr>
+          <p:nvPr/>
+        </p:nvSpPr>
+        <p:spPr>
+          <a:xfrm xmlns:a="http://schemas.openxmlformats.org/drawingml/2006/main">
+            <a:off x="990600" y="5181600"/>
+            <a:ext cx="4476750" cy="266700"/>
+          </a:xfrm>
+          <a:prstGeom xmlns:a="http://schemas.openxmlformats.org/drawingml/2006/main" prst="rect">
+            <a:avLst/>
+          </a:prstGeom>
+          <a:noFill xmlns:a="http://schemas.openxmlformats.org/drawingml/2006/main"/>
+          <a:ln xmlns:a="http://schemas.openxmlformats.org/drawingml/2006/main" w="0">
+            <a:noFill/>
+            <a:prstDash val="solid"/>
+          </a:ln>
+        </p:spPr>
+        <p:txBody>
+          <a:bodyPr xmlns:a="http://schemas.openxmlformats.org/drawingml/2006/main"/>
+          <a:lstStyle xmlns:a="http://schemas.openxmlformats.org/drawingml/2006/main"/>
+          <a:p xmlns:a="http://schemas.openxmlformats.org/drawingml/2006/main">
+            <a:pPr>
+              <a:buNone/>
+              <a:defRPr sz="1500">
+                <a:solidFill>
+                  <a:srgbClr val="DBE4EF"/>
+                </a:solidFill>
+              </a:defRPr>
+            </a:pPr>
+            <a:r>
+              <a:rPr sz="1500">
+                <a:solidFill>
+                  <a:srgbClr val="DBE4EF"/>
+                </a:solidFill>
+              </a:rPr>
+              <a:t>Anlık robot durumu</a:t>
+            </a:r>
+          </a:p>
+        </p:txBody>
+      </p:sp>
+      <p:sp>
+        <p:nvSpPr>
+          <p:cNvPr id="73" name="readable-summary-dot-3-1">
+            <a:extLst xmlns:a="http://schemas.openxmlformats.org/drawingml/2006/main">
+              <a:ext uri="{FF2B5EF4-FFF2-40B4-BE49-F238E27FC236}">
+                <a16:creationId xmlns:a16="http://schemas.microsoft.com/office/drawing/2014/main" id="{628A70B5-D994-47FE-BC87-2229446C4D26}"/>
+              </a:ext>
+            </a:extLst>
+          </p:cNvPr>
+          <p:cNvSpPr>
+            <a:spLocks xmlns:a="http://schemas.openxmlformats.org/drawingml/2006/main" noGrp="1"/>
+          </p:cNvSpPr>
+          <p:nvPr/>
+        </p:nvSpPr>
+        <p:spPr>
+          <a:xfrm xmlns:a="http://schemas.openxmlformats.org/drawingml/2006/main">
+            <a:off x="790575" y="5600700"/>
+            <a:ext cx="76200" cy="76200"/>
+          </a:xfrm>
+          <a:prstGeom xmlns:a="http://schemas.openxmlformats.org/drawingml/2006/main" prst="ellipse">
+            <a:avLst/>
+          </a:prstGeom>
+          <a:solidFill xmlns:a="http://schemas.openxmlformats.org/drawingml/2006/main">
+            <a:srgbClr val="22C55E"/>
+          </a:solidFill>
+          <a:ln xmlns:a="http://schemas.openxmlformats.org/drawingml/2006/main" w="0">
+            <a:noFill/>
+            <a:prstDash val="solid"/>
+          </a:ln>
+        </p:spPr>
+      </p:sp>
+      <p:sp>
+        <p:nvSpPr>
+          <p:cNvPr id="74" name="readable-summary-item-3-1">
+            <a:extLst xmlns:a="http://schemas.openxmlformats.org/drawingml/2006/main">
+              <a:ext uri="{FF2B5EF4-FFF2-40B4-BE49-F238E27FC236}">
+                <a16:creationId xmlns:a16="http://schemas.microsoft.com/office/drawing/2014/main" id="{9D4C8F58-C4B5-4041-ABE1-017716618765}"/>
+              </a:ext>
+            </a:extLst>
+          </p:cNvPr>
+          <p:cNvSpPr>
+            <a:spLocks xmlns:a="http://schemas.openxmlformats.org/drawingml/2006/main" noGrp="1"/>
+          </p:cNvSpPr>
+          <p:nvPr/>
+        </p:nvSpPr>
+        <p:spPr>
+          <a:xfrm xmlns:a="http://schemas.openxmlformats.org/drawingml/2006/main">
+            <a:off x="990600" y="5524500"/>
+            <a:ext cx="4476750" cy="266700"/>
+          </a:xfrm>
+          <a:prstGeom xmlns:a="http://schemas.openxmlformats.org/drawingml/2006/main" prst="rect">
+            <a:avLst/>
+          </a:prstGeom>
+          <a:noFill xmlns:a="http://schemas.openxmlformats.org/drawingml/2006/main"/>
+          <a:ln xmlns:a="http://schemas.openxmlformats.org/drawingml/2006/main" w="0">
+            <a:noFill/>
+            <a:prstDash val="solid"/>
+          </a:ln>
+        </p:spPr>
+        <p:txBody>
+          <a:bodyPr xmlns:a="http://schemas.openxmlformats.org/drawingml/2006/main"/>
+          <a:lstStyle xmlns:a="http://schemas.openxmlformats.org/drawingml/2006/main"/>
+          <a:p xmlns:a="http://schemas.openxmlformats.org/drawingml/2006/main">
+            <a:pPr>
+              <a:buNone/>
+              <a:defRPr sz="1500">
+                <a:solidFill>
+                  <a:srgbClr val="DBE4EF"/>
+                </a:solidFill>
+              </a:defRPr>
+            </a:pPr>
+            <a:r>
+              <a:rPr sz="1500">
+                <a:solidFill>
+                  <a:srgbClr val="DBE4EF"/>
+                </a:solidFill>
+              </a:rPr>
+              <a:t>Sistem sağlığı</a:t>
+            </a:r>
+          </a:p>
+        </p:txBody>
+      </p:sp>
+      <p:sp>
+        <p:nvSpPr>
+          <p:cNvPr id="75" name="readable-summary-dot-3-2">
+            <a:extLst xmlns:a="http://schemas.openxmlformats.org/drawingml/2006/main">
+              <a:ext uri="{FF2B5EF4-FFF2-40B4-BE49-F238E27FC236}">
+                <a16:creationId xmlns:a16="http://schemas.microsoft.com/office/drawing/2014/main" id="{00AEC786-2AD8-436A-B801-B1AC93FE1665}"/>
+              </a:ext>
+            </a:extLst>
+          </p:cNvPr>
+          <p:cNvSpPr>
+            <a:spLocks xmlns:a="http://schemas.openxmlformats.org/drawingml/2006/main" noGrp="1"/>
+          </p:cNvSpPr>
+          <p:nvPr/>
+        </p:nvSpPr>
+        <p:spPr>
+          <a:xfrm xmlns:a="http://schemas.openxmlformats.org/drawingml/2006/main">
+            <a:off x="790575" y="5943600"/>
+            <a:ext cx="76200" cy="76200"/>
+          </a:xfrm>
+          <a:prstGeom xmlns:a="http://schemas.openxmlformats.org/drawingml/2006/main" prst="ellipse">
+            <a:avLst/>
+          </a:prstGeom>
+          <a:solidFill xmlns:a="http://schemas.openxmlformats.org/drawingml/2006/main">
+            <a:srgbClr val="22C55E"/>
+          </a:solidFill>
+          <a:ln xmlns:a="http://schemas.openxmlformats.org/drawingml/2006/main" w="0">
+            <a:noFill/>
+            <a:prstDash val="solid"/>
+          </a:ln>
+        </p:spPr>
+      </p:sp>
+      <p:sp>
+        <p:nvSpPr>
+          <p:cNvPr id="76" name="readable-summary-item-3-2">
+            <a:extLst xmlns:a="http://schemas.openxmlformats.org/drawingml/2006/main">
+              <a:ext uri="{FF2B5EF4-FFF2-40B4-BE49-F238E27FC236}">
+                <a16:creationId xmlns:a16="http://schemas.microsoft.com/office/drawing/2014/main" id="{0FA5379D-120A-4F6C-B0F0-E2AA7D3FA098}"/>
+              </a:ext>
+            </a:extLst>
+          </p:cNvPr>
+          <p:cNvSpPr>
+            <a:spLocks xmlns:a="http://schemas.openxmlformats.org/drawingml/2006/main" noGrp="1"/>
+          </p:cNvSpPr>
+          <p:nvPr/>
+        </p:nvSpPr>
+        <p:spPr>
+          <a:xfrm xmlns:a="http://schemas.openxmlformats.org/drawingml/2006/main">
+            <a:off x="990600" y="5867400"/>
+            <a:ext cx="4476750" cy="266700"/>
+          </a:xfrm>
+          <a:prstGeom xmlns:a="http://schemas.openxmlformats.org/drawingml/2006/main" prst="rect">
+            <a:avLst/>
+          </a:prstGeom>
+          <a:noFill xmlns:a="http://schemas.openxmlformats.org/drawingml/2006/main"/>
+          <a:ln xmlns:a="http://schemas.openxmlformats.org/drawingml/2006/main" w="0">
+            <a:noFill/>
+            <a:prstDash val="solid"/>
+          </a:ln>
+        </p:spPr>
+        <p:txBody>
+          <a:bodyPr xmlns:a="http://schemas.openxmlformats.org/drawingml/2006/main"/>
+          <a:lstStyle xmlns:a="http://schemas.openxmlformats.org/drawingml/2006/main"/>
+          <a:p xmlns:a="http://schemas.openxmlformats.org/drawingml/2006/main">
+            <a:pPr>
+              <a:buNone/>
+              <a:defRPr sz="1500">
+                <a:solidFill>
+                  <a:srgbClr val="DBE4EF"/>
+                </a:solidFill>
+              </a:defRPr>
+            </a:pPr>
+            <a:r>
+              <a:rPr sz="1500">
+                <a:solidFill>
+                  <a:srgbClr val="DBE4EF"/>
+                </a:solidFill>
+              </a:rPr>
+              <a:t>Log ve hata görünürlüğü</a:t>
+            </a:r>
+          </a:p>
+        </p:txBody>
+      </p:sp>
+      <p:sp>
+        <p:nvSpPr>
+          <p:cNvPr id="77" name="readable-summary-block-4">
+            <a:extLst xmlns:a="http://schemas.openxmlformats.org/drawingml/2006/main">
+              <a:ext uri="{FF2B5EF4-FFF2-40B4-BE49-F238E27FC236}">
+                <a16:creationId xmlns:a16="http://schemas.microsoft.com/office/drawing/2014/main" id="{9E243C49-4A95-48C8-B31F-5A9946254AF6}"/>
+              </a:ext>
+            </a:extLst>
+          </p:cNvPr>
+          <p:cNvSpPr>
+            <a:spLocks xmlns:a="http://schemas.openxmlformats.org/drawingml/2006/main" noGrp="1"/>
+          </p:cNvSpPr>
+          <p:nvPr/>
+        </p:nvSpPr>
+        <p:spPr>
+          <a:xfrm xmlns:a="http://schemas.openxmlformats.org/drawingml/2006/main">
+            <a:off x="6381750" y="4343400"/>
+            <a:ext cx="5257800" cy="1790700"/>
+          </a:xfrm>
+          <a:prstGeom xmlns:a="http://schemas.openxmlformats.org/drawingml/2006/main" prst="roundRect">
+            <a:avLst>
+              <a:gd name="adj" fmla="val 4255"/>
+            </a:avLst>
+          </a:prstGeom>
+          <a:solidFill xmlns:a="http://schemas.openxmlformats.org/drawingml/2006/main">
+            <a:srgbClr val="111822"/>
+          </a:solidFill>
+          <a:ln xmlns:a="http://schemas.openxmlformats.org/drawingml/2006/main" w="9525">
+            <a:solidFill>
+              <a:srgbClr val="1F2937"/>
+            </a:solidFill>
+            <a:prstDash val="solid"/>
+          </a:ln>
+        </p:spPr>
+      </p:sp>
+      <p:sp>
+        <p:nvSpPr>
+          <p:cNvPr id="78" name="readable-summary-accent-4">
+            <a:extLst xmlns:a="http://schemas.openxmlformats.org/drawingml/2006/main">
+              <a:ext uri="{FF2B5EF4-FFF2-40B4-BE49-F238E27FC236}">
+                <a16:creationId xmlns:a16="http://schemas.microsoft.com/office/drawing/2014/main" id="{326D67E0-9447-44C5-9BF7-F4AB52F2F80C}"/>
+              </a:ext>
+            </a:extLst>
+          </p:cNvPr>
+          <p:cNvSpPr>
+            <a:spLocks xmlns:a="http://schemas.openxmlformats.org/drawingml/2006/main" noGrp="1"/>
+          </p:cNvSpPr>
+          <p:nvPr/>
+        </p:nvSpPr>
+        <p:spPr>
+          <a:xfrm xmlns:a="http://schemas.openxmlformats.org/drawingml/2006/main">
+            <a:off x="6591300" y="4552950"/>
+            <a:ext cx="1143000" cy="47625"/>
+          </a:xfrm>
+          <a:prstGeom xmlns:a="http://schemas.openxmlformats.org/drawingml/2006/main" prst="rect">
+            <a:avLst/>
+          </a:prstGeom>
+          <a:solidFill xmlns:a="http://schemas.openxmlformats.org/drawingml/2006/main">
+            <a:srgbClr val="F97316"/>
+          </a:solidFill>
+          <a:ln xmlns:a="http://schemas.openxmlformats.org/drawingml/2006/main" w="0">
+            <a:noFill/>
+            <a:prstDash val="solid"/>
+          </a:ln>
+        </p:spPr>
+      </p:sp>
+      <p:sp>
+        <p:nvSpPr>
+          <p:cNvPr id="79" name="readable-summary-title-4">
+            <a:extLst xmlns:a="http://schemas.openxmlformats.org/drawingml/2006/main">
+              <a:ext uri="{FF2B5EF4-FFF2-40B4-BE49-F238E27FC236}">
+                <a16:creationId xmlns:a16="http://schemas.microsoft.com/office/drawing/2014/main" id="{697E2787-EF34-4FDC-979A-8743A064A6D4}"/>
+              </a:ext>
+            </a:extLst>
+          </p:cNvPr>
+          <p:cNvSpPr>
+            <a:spLocks xmlns:a="http://schemas.openxmlformats.org/drawingml/2006/main" noGrp="1"/>
+          </p:cNvSpPr>
+          <p:nvPr/>
+        </p:nvSpPr>
+        <p:spPr>
+          <a:xfrm xmlns:a="http://schemas.openxmlformats.org/drawingml/2006/main">
+            <a:off x="6591300" y="4743450"/>
+            <a:ext cx="4762500" cy="304800"/>
+          </a:xfrm>
+          <a:prstGeom xmlns:a="http://schemas.openxmlformats.org/drawingml/2006/main" prst="rect">
+            <a:avLst/>
+          </a:prstGeom>
+          <a:noFill xmlns:a="http://schemas.openxmlformats.org/drawingml/2006/main"/>
+          <a:ln xmlns:a="http://schemas.openxmlformats.org/drawingml/2006/main" w="0">
+            <a:noFill/>
+            <a:prstDash val="solid"/>
+          </a:ln>
+        </p:spPr>
+        <p:txBody>
+          <a:bodyPr xmlns:a="http://schemas.openxmlformats.org/drawingml/2006/main"/>
+          <a:lstStyle xmlns:a="http://schemas.openxmlformats.org/drawingml/2006/main"/>
+          <a:p xmlns:a="http://schemas.openxmlformats.org/drawingml/2006/main">
+            <a:pPr>
+              <a:buNone/>
+              <a:defRPr sz="1875" b="1">
+                <a:solidFill>
+                  <a:srgbClr val="FFFFFF"/>
+                </a:solidFill>
+              </a:defRPr>
+            </a:pPr>
+            <a:r>
+              <a:rPr sz="1875" b="1">
+                <a:solidFill>
+                  <a:srgbClr val="FFFFFF"/>
+                </a:solidFill>
+              </a:rPr>
+              <a:t>Entegrasyon ve Demo</a:t>
+            </a:r>
+          </a:p>
+        </p:txBody>
+      </p:sp>
+      <p:sp>
+        <p:nvSpPr>
+          <p:cNvPr id="80" name="readable-summary-dot-4-0">
+            <a:extLst xmlns:a="http://schemas.openxmlformats.org/drawingml/2006/main">
+              <a:ext uri="{FF2B5EF4-FFF2-40B4-BE49-F238E27FC236}">
+                <a16:creationId xmlns:a16="http://schemas.microsoft.com/office/drawing/2014/main" id="{9A9DAE35-FC9F-4A66-A1A9-E134ECE6E59F}"/>
+              </a:ext>
+            </a:extLst>
+          </p:cNvPr>
+          <p:cNvSpPr>
+            <a:spLocks xmlns:a="http://schemas.openxmlformats.org/drawingml/2006/main" noGrp="1"/>
+          </p:cNvSpPr>
+          <p:nvPr/>
+        </p:nvSpPr>
+        <p:spPr>
+          <a:xfrm xmlns:a="http://schemas.openxmlformats.org/drawingml/2006/main">
+            <a:off x="6619875" y="5257800"/>
+            <a:ext cx="76200" cy="76200"/>
+          </a:xfrm>
+          <a:prstGeom xmlns:a="http://schemas.openxmlformats.org/drawingml/2006/main" prst="ellipse">
+            <a:avLst/>
+          </a:prstGeom>
+          <a:solidFill xmlns:a="http://schemas.openxmlformats.org/drawingml/2006/main">
+            <a:srgbClr val="F97316"/>
+          </a:solidFill>
+          <a:ln xmlns:a="http://schemas.openxmlformats.org/drawingml/2006/main" w="0">
+            <a:noFill/>
+            <a:prstDash val="solid"/>
+          </a:ln>
+        </p:spPr>
+      </p:sp>
+      <p:sp>
+        <p:nvSpPr>
+          <p:cNvPr id="81" name="readable-summary-item-4-0">
+            <a:extLst xmlns:a="http://schemas.openxmlformats.org/drawingml/2006/main">
+              <a:ext uri="{FF2B5EF4-FFF2-40B4-BE49-F238E27FC236}">
+                <a16:creationId xmlns:a16="http://schemas.microsoft.com/office/drawing/2014/main" id="{D0F50B50-D820-430C-8061-A81A9E93A3C7}"/>
+              </a:ext>
+            </a:extLst>
+          </p:cNvPr>
+          <p:cNvSpPr>
+            <a:spLocks xmlns:a="http://schemas.openxmlformats.org/drawingml/2006/main" noGrp="1"/>
+          </p:cNvSpPr>
+          <p:nvPr/>
+        </p:nvSpPr>
+        <p:spPr>
+          <a:xfrm xmlns:a="http://schemas.openxmlformats.org/drawingml/2006/main">
+            <a:off x="6819900" y="5181600"/>
+            <a:ext cx="4476750" cy="266700"/>
+          </a:xfrm>
+          <a:prstGeom xmlns:a="http://schemas.openxmlformats.org/drawingml/2006/main" prst="rect">
+            <a:avLst/>
+          </a:prstGeom>
+          <a:noFill xmlns:a="http://schemas.openxmlformats.org/drawingml/2006/main"/>
+          <a:ln xmlns:a="http://schemas.openxmlformats.org/drawingml/2006/main" w="0">
+            <a:noFill/>
+            <a:prstDash val="solid"/>
+          </a:ln>
+        </p:spPr>
+        <p:txBody>
+          <a:bodyPr xmlns:a="http://schemas.openxmlformats.org/drawingml/2006/main"/>
+          <a:lstStyle xmlns:a="http://schemas.openxmlformats.org/drawingml/2006/main"/>
+          <a:p xmlns:a="http://schemas.openxmlformats.org/drawingml/2006/main">
+            <a:pPr>
+              <a:buNone/>
+              <a:defRPr sz="1500">
+                <a:solidFill>
+                  <a:srgbClr val="DBE4EF"/>
+                </a:solidFill>
+              </a:defRPr>
+            </a:pPr>
+            <a:r>
+              <a:rPr sz="1500">
+                <a:solidFill>
+                  <a:srgbClr val="DBE4EF"/>
+                </a:solidFill>
+              </a:rPr>
+              <a:t>ROS Visibility</a:t>
+            </a:r>
+          </a:p>
+        </p:txBody>
+      </p:sp>
+      <p:sp>
+        <p:nvSpPr>
+          <p:cNvPr id="82" name="readable-summary-dot-4-1">
+            <a:extLst xmlns:a="http://schemas.openxmlformats.org/drawingml/2006/main">
+              <a:ext uri="{FF2B5EF4-FFF2-40B4-BE49-F238E27FC236}">
+                <a16:creationId xmlns:a16="http://schemas.microsoft.com/office/drawing/2014/main" id="{03AFDA01-5111-4175-94DD-F9370156CA94}"/>
+              </a:ext>
+            </a:extLst>
+          </p:cNvPr>
+          <p:cNvSpPr>
+            <a:spLocks xmlns:a="http://schemas.openxmlformats.org/drawingml/2006/main" noGrp="1"/>
+          </p:cNvSpPr>
+          <p:nvPr/>
+        </p:nvSpPr>
+        <p:spPr>
+          <a:xfrm xmlns:a="http://schemas.openxmlformats.org/drawingml/2006/main">
+            <a:off x="6619875" y="5600700"/>
+            <a:ext cx="76200" cy="76200"/>
+          </a:xfrm>
+          <a:prstGeom xmlns:a="http://schemas.openxmlformats.org/drawingml/2006/main" prst="ellipse">
+            <a:avLst/>
+          </a:prstGeom>
+          <a:solidFill xmlns:a="http://schemas.openxmlformats.org/drawingml/2006/main">
+            <a:srgbClr val="F97316"/>
+          </a:solidFill>
+          <a:ln xmlns:a="http://schemas.openxmlformats.org/drawingml/2006/main" w="0">
+            <a:noFill/>
+            <a:prstDash val="solid"/>
+          </a:ln>
+        </p:spPr>
+      </p:sp>
+      <p:sp>
+        <p:nvSpPr>
+          <p:cNvPr id="83" name="readable-summary-item-4-1">
+            <a:extLst xmlns:a="http://schemas.openxmlformats.org/drawingml/2006/main">
+              <a:ext uri="{FF2B5EF4-FFF2-40B4-BE49-F238E27FC236}">
+                <a16:creationId xmlns:a16="http://schemas.microsoft.com/office/drawing/2014/main" id="{9F905AA8-EC8B-45ED-948C-56A9E53279E3}"/>
+              </a:ext>
+            </a:extLst>
+          </p:cNvPr>
+          <p:cNvSpPr>
+            <a:spLocks xmlns:a="http://schemas.openxmlformats.org/drawingml/2006/main" noGrp="1"/>
+          </p:cNvSpPr>
+          <p:nvPr/>
+        </p:nvSpPr>
+        <p:spPr>
+          <a:xfrm xmlns:a="http://schemas.openxmlformats.org/drawingml/2006/main">
+            <a:off x="6819900" y="5524500"/>
+            <a:ext cx="4476750" cy="266700"/>
+          </a:xfrm>
+          <a:prstGeom xmlns:a="http://schemas.openxmlformats.org/drawingml/2006/main" prst="rect">
+            <a:avLst/>
+          </a:prstGeom>
+          <a:noFill xmlns:a="http://schemas.openxmlformats.org/drawingml/2006/main"/>
+          <a:ln xmlns:a="http://schemas.openxmlformats.org/drawingml/2006/main" w="0">
+            <a:noFill/>
+            <a:prstDash val="solid"/>
+          </a:ln>
+        </p:spPr>
+        <p:txBody>
+          <a:bodyPr xmlns:a="http://schemas.openxmlformats.org/drawingml/2006/main"/>
+          <a:lstStyle xmlns:a="http://schemas.openxmlformats.org/drawingml/2006/main"/>
+          <a:p xmlns:a="http://schemas.openxmlformats.org/drawingml/2006/main">
+            <a:pPr>
+              <a:buNone/>
+              <a:defRPr sz="1500">
+                <a:solidFill>
+                  <a:srgbClr val="DBE4EF"/>
+                </a:solidFill>
+              </a:defRPr>
+            </a:pPr>
+            <a:r>
+              <a:rPr sz="1500">
+                <a:solidFill>
+                  <a:srgbClr val="DBE4EF"/>
+                </a:solidFill>
+              </a:rPr>
+              <a:t>Modüler kontrol katmanları</a:t>
+            </a:r>
+          </a:p>
+        </p:txBody>
+      </p:sp>
+      <p:sp>
+        <p:nvSpPr>
+          <p:cNvPr id="84" name="readable-summary-dot-4-2">
+            <a:extLst xmlns:a="http://schemas.openxmlformats.org/drawingml/2006/main">
+              <a:ext uri="{FF2B5EF4-FFF2-40B4-BE49-F238E27FC236}">
+                <a16:creationId xmlns:a16="http://schemas.microsoft.com/office/drawing/2014/main" id="{7E5B3F53-38E4-4A3E-8DF5-CDFB0A20A2E2}"/>
+              </a:ext>
+            </a:extLst>
+          </p:cNvPr>
+          <p:cNvSpPr>
+            <a:spLocks xmlns:a="http://schemas.openxmlformats.org/drawingml/2006/main" noGrp="1"/>
+          </p:cNvSpPr>
+          <p:nvPr/>
+        </p:nvSpPr>
+        <p:spPr>
+          <a:xfrm xmlns:a="http://schemas.openxmlformats.org/drawingml/2006/main">
+            <a:off x="6619875" y="5943600"/>
+            <a:ext cx="76200" cy="76200"/>
+          </a:xfrm>
+          <a:prstGeom xmlns:a="http://schemas.openxmlformats.org/drawingml/2006/main" prst="ellipse">
+            <a:avLst/>
+          </a:prstGeom>
+          <a:solidFill xmlns:a="http://schemas.openxmlformats.org/drawingml/2006/main">
+            <a:srgbClr val="F97316"/>
+          </a:solidFill>
+          <a:ln xmlns:a="http://schemas.openxmlformats.org/drawingml/2006/main" w="0">
+            <a:noFill/>
+            <a:prstDash val="solid"/>
+          </a:ln>
+        </p:spPr>
+      </p:sp>
+      <p:sp>
+        <p:nvSpPr>
+          <p:cNvPr id="85" name="readable-summary-item-4-2">
+            <a:extLst xmlns:a="http://schemas.openxmlformats.org/drawingml/2006/main">
+              <a:ext uri="{FF2B5EF4-FFF2-40B4-BE49-F238E27FC236}">
+                <a16:creationId xmlns:a16="http://schemas.microsoft.com/office/drawing/2014/main" id="{73EA5967-96F2-4F20-AA41-1DBFAFE168A0}"/>
+              </a:ext>
+            </a:extLst>
+          </p:cNvPr>
+          <p:cNvSpPr>
+            <a:spLocks xmlns:a="http://schemas.openxmlformats.org/drawingml/2006/main" noGrp="1"/>
+          </p:cNvSpPr>
+          <p:nvPr/>
+        </p:nvSpPr>
+        <p:spPr>
+          <a:xfrm xmlns:a="http://schemas.openxmlformats.org/drawingml/2006/main">
+            <a:off x="6819900" y="5867400"/>
+            <a:ext cx="4476750" cy="266700"/>
+          </a:xfrm>
+          <a:prstGeom xmlns:a="http://schemas.openxmlformats.org/drawingml/2006/main" prst="rect">
+            <a:avLst/>
+          </a:prstGeom>
+          <a:noFill xmlns:a="http://schemas.openxmlformats.org/drawingml/2006/main"/>
+          <a:ln xmlns:a="http://schemas.openxmlformats.org/drawingml/2006/main" w="0">
+            <a:noFill/>
+            <a:prstDash val="solid"/>
+          </a:ln>
+        </p:spPr>
+        <p:txBody>
+          <a:bodyPr xmlns:a="http://schemas.openxmlformats.org/drawingml/2006/main"/>
+          <a:lstStyle xmlns:a="http://schemas.openxmlformats.org/drawingml/2006/main"/>
+          <a:p xmlns:a="http://schemas.openxmlformats.org/drawingml/2006/main">
+            <a:pPr>
+              <a:buNone/>
+              <a:defRPr sz="1500">
+                <a:solidFill>
+                  <a:srgbClr val="DBE4EF"/>
+                </a:solidFill>
+              </a:defRPr>
+            </a:pPr>
+            <a:r>
+              <a:rPr sz="1500">
+                <a:solidFill>
+                  <a:srgbClr val="DBE4EF"/>
+                </a:solidFill>
+              </a:rPr>
+              <a:t>Demo-ready ürün hissi</a:t>
+            </a:r>
+          </a:p>
+        </p:txBody>
+      </p:sp>
+      <p:sp>
+        <p:nvSpPr>
+          <p:cNvPr id="86" name="readable-summary-cover">
+            <a:extLst xmlns:a="http://schemas.openxmlformats.org/drawingml/2006/main">
+              <a:ext uri="{FF2B5EF4-FFF2-40B4-BE49-F238E27FC236}">
+                <a16:creationId xmlns:a16="http://schemas.microsoft.com/office/drawing/2014/main" id="{9D076F0F-9466-4C01-A788-BF81B470A641}"/>
+              </a:ext>
+            </a:extLst>
+          </p:cNvPr>
+          <p:cNvSpPr>
+            <a:spLocks xmlns:a="http://schemas.openxmlformats.org/drawingml/2006/main" noGrp="1"/>
+          </p:cNvSpPr>
+          <p:nvPr/>
+        </p:nvSpPr>
+        <p:spPr>
+          <a:xfrm xmlns:a="http://schemas.openxmlformats.org/drawingml/2006/main">
+            <a:off x="0" y="0"/>
+            <a:ext cx="12192000" cy="6858000"/>
+          </a:xfrm>
+          <a:prstGeom xmlns:a="http://schemas.openxmlformats.org/drawingml/2006/main" prst="rect">
+            <a:avLst/>
+          </a:prstGeom>
+          <a:solidFill xmlns:a="http://schemas.openxmlformats.org/drawingml/2006/main">
+            <a:srgbClr val="080B0F"/>
+          </a:solidFill>
+          <a:ln xmlns:a="http://schemas.openxmlformats.org/drawingml/2006/main" w="0">
+            <a:noFill/>
+            <a:prstDash val="solid"/>
+          </a:ln>
+        </p:spPr>
+      </p:sp>
+      <p:sp>
+        <p:nvSpPr>
+          <p:cNvPr id="87" name="readable-summary-eyebrow">
+            <a:extLst xmlns:a="http://schemas.openxmlformats.org/drawingml/2006/main">
+              <a:ext uri="{FF2B5EF4-FFF2-40B4-BE49-F238E27FC236}">
+                <a16:creationId xmlns:a16="http://schemas.microsoft.com/office/drawing/2014/main" id="{587186D5-6727-44ED-B2D1-B623633A9E06}"/>
+              </a:ext>
+            </a:extLst>
+          </p:cNvPr>
+          <p:cNvSpPr>
+            <a:spLocks xmlns:a="http://schemas.openxmlformats.org/drawingml/2006/main" noGrp="1"/>
+          </p:cNvSpPr>
+          <p:nvPr/>
+        </p:nvSpPr>
+        <p:spPr>
+          <a:xfrm xmlns:a="http://schemas.openxmlformats.org/drawingml/2006/main">
+            <a:off x="552450" y="381000"/>
+            <a:ext cx="2857500" cy="228600"/>
+          </a:xfrm>
+          <a:prstGeom xmlns:a="http://schemas.openxmlformats.org/drawingml/2006/main" prst="rect">
+            <a:avLst/>
+          </a:prstGeom>
+          <a:noFill xmlns:a="http://schemas.openxmlformats.org/drawingml/2006/main"/>
+          <a:ln xmlns:a="http://schemas.openxmlformats.org/drawingml/2006/main" w="0">
+            <a:noFill/>
+            <a:prstDash val="solid"/>
+          </a:ln>
+        </p:spPr>
+        <p:txBody>
+          <a:bodyPr xmlns:a="http://schemas.openxmlformats.org/drawingml/2006/main"/>
+          <a:lstStyle xmlns:a="http://schemas.openxmlformats.org/drawingml/2006/main"/>
+          <a:p xmlns:a="http://schemas.openxmlformats.org/drawingml/2006/main">
+            <a:pPr>
+              <a:defRPr sz="1125" b="1">
+                <a:solidFill>
+                  <a:srgbClr val="22C55E"/>
+                </a:solidFill>
+              </a:defRPr>
+            </a:pPr>
+            <a:r>
+              <a:rPr sz="1125" b="1">
+                <a:solidFill>
+                  <a:srgbClr val="22C55E"/>
+                </a:solidFill>
+              </a:rPr>
+              <a:t>FEATURE SCOPE</a:t>
+            </a:r>
+          </a:p>
+        </p:txBody>
+      </p:sp>
+      <p:sp>
+        <p:nvSpPr>
+          <p:cNvPr id="88" name="readable-summary-heading">
+            <a:extLst xmlns:a="http://schemas.openxmlformats.org/drawingml/2006/main">
+              <a:ext uri="{FF2B5EF4-FFF2-40B4-BE49-F238E27FC236}">
+                <a16:creationId xmlns:a16="http://schemas.microsoft.com/office/drawing/2014/main" id="{8BBC60FD-7BC2-46CC-B317-FE09FFD26772}"/>
+              </a:ext>
+            </a:extLst>
+          </p:cNvPr>
+          <p:cNvSpPr>
+            <a:spLocks xmlns:a="http://schemas.openxmlformats.org/drawingml/2006/main" noGrp="1"/>
+          </p:cNvSpPr>
+          <p:nvPr/>
+        </p:nvSpPr>
+        <p:spPr>
+          <a:xfrm xmlns:a="http://schemas.openxmlformats.org/drawingml/2006/main">
+            <a:off x="552450" y="781050"/>
+            <a:ext cx="6858000" cy="514350"/>
+          </a:xfrm>
+          <a:prstGeom xmlns:a="http://schemas.openxmlformats.org/drawingml/2006/main" prst="rect">
+            <a:avLst/>
+          </a:prstGeom>
+          <a:noFill xmlns:a="http://schemas.openxmlformats.org/drawingml/2006/main"/>
+          <a:ln xmlns:a="http://schemas.openxmlformats.org/drawingml/2006/main" w="0">
+            <a:noFill/>
+            <a:prstDash val="solid"/>
+          </a:ln>
+        </p:spPr>
+        <p:txBody>
+          <a:bodyPr xmlns:a="http://schemas.openxmlformats.org/drawingml/2006/main"/>
+          <a:lstStyle xmlns:a="http://schemas.openxmlformats.org/drawingml/2006/main"/>
+          <a:p xmlns:a="http://schemas.openxmlformats.org/drawingml/2006/main">
+            <a:pPr>
+              <a:defRPr sz="3150" b="1">
+                <a:solidFill>
+                  <a:srgbClr val="FFFFFF"/>
+                </a:solidFill>
+              </a:defRPr>
+            </a:pPr>
+            <a:r>
+              <a:rPr sz="3150" b="1">
+                <a:solidFill>
+                  <a:srgbClr val="FFFFFF"/>
+                </a:solidFill>
+              </a:rPr>
+              <a:t>Kalan ürün özellikleri</a:t>
+            </a:r>
+          </a:p>
+        </p:txBody>
+      </p:sp>
+      <p:sp>
+        <p:nvSpPr>
+          <p:cNvPr id="89" name="readable-summary-subtitle">
+            <a:extLst xmlns:a="http://schemas.openxmlformats.org/drawingml/2006/main">
+              <a:ext uri="{FF2B5EF4-FFF2-40B4-BE49-F238E27FC236}">
+                <a16:creationId xmlns:a16="http://schemas.microsoft.com/office/drawing/2014/main" id="{E159289E-2146-4AD8-A16C-DF2225483E54}"/>
+              </a:ext>
+            </a:extLst>
+          </p:cNvPr>
+          <p:cNvSpPr>
+            <a:spLocks xmlns:a="http://schemas.openxmlformats.org/drawingml/2006/main" noGrp="1"/>
+          </p:cNvSpPr>
+          <p:nvPr/>
+        </p:nvSpPr>
+        <p:spPr>
+          <a:xfrm xmlns:a="http://schemas.openxmlformats.org/drawingml/2006/main">
+            <a:off x="571500" y="1409700"/>
+            <a:ext cx="8382000" cy="323850"/>
+          </a:xfrm>
+          <a:prstGeom xmlns:a="http://schemas.openxmlformats.org/drawingml/2006/main" prst="rect">
+            <a:avLst/>
+          </a:prstGeom>
+          <a:noFill xmlns:a="http://schemas.openxmlformats.org/drawingml/2006/main"/>
+          <a:ln xmlns:a="http://schemas.openxmlformats.org/drawingml/2006/main" w="0">
+            <a:noFill/>
+            <a:prstDash val="solid"/>
+          </a:ln>
+        </p:spPr>
+        <p:txBody>
+          <a:bodyPr xmlns:a="http://schemas.openxmlformats.org/drawingml/2006/main"/>
+          <a:lstStyle xmlns:a="http://schemas.openxmlformats.org/drawingml/2006/main"/>
+          <a:p xmlns:a="http://schemas.openxmlformats.org/drawingml/2006/main">
+            <a:pPr>
+              <a:defRPr sz="1650">
+                <a:solidFill>
+                  <a:srgbClr val="CBD5E1"/>
+                </a:solidFill>
+              </a:defRPr>
+            </a:pPr>
+            <a:r>
+              <a:rPr sz="1650">
+                <a:solidFill>
+                  <a:srgbClr val="CBD5E1"/>
+                </a:solidFill>
+              </a:rPr>
+              <a:t>Camera Stream, Teleoperation ve kayıt akışları hariç.</a:t>
+            </a:r>
+          </a:p>
+        </p:txBody>
+      </p:sp>
+      <p:sp>
+        <p:nvSpPr>
+          <p:cNvPr id="90" name="readable-summary-block-1">
+            <a:extLst xmlns:a="http://schemas.openxmlformats.org/drawingml/2006/main">
+              <a:ext uri="{FF2B5EF4-FFF2-40B4-BE49-F238E27FC236}">
+                <a16:creationId xmlns:a16="http://schemas.microsoft.com/office/drawing/2014/main" id="{65C4E347-E9A9-4E01-9F14-F274BBE21453}"/>
+              </a:ext>
+            </a:extLst>
+          </p:cNvPr>
+          <p:cNvSpPr>
+            <a:spLocks xmlns:a="http://schemas.openxmlformats.org/drawingml/2006/main" noGrp="1"/>
+          </p:cNvSpPr>
+          <p:nvPr/>
+        </p:nvSpPr>
+        <p:spPr>
+          <a:xfrm xmlns:a="http://schemas.openxmlformats.org/drawingml/2006/main">
+            <a:off x="552450" y="2000250"/>
+            <a:ext cx="5257800" cy="1943100"/>
+          </a:xfrm>
+          <a:prstGeom xmlns:a="http://schemas.openxmlformats.org/drawingml/2006/main" prst="roundRect">
+            <a:avLst>
+              <a:gd name="adj" fmla="val 3922"/>
+            </a:avLst>
+          </a:prstGeom>
+          <a:solidFill xmlns:a="http://schemas.openxmlformats.org/drawingml/2006/main">
+            <a:srgbClr val="111822"/>
+          </a:solidFill>
+          <a:ln xmlns:a="http://schemas.openxmlformats.org/drawingml/2006/main" w="9525">
+            <a:solidFill>
+              <a:srgbClr val="1F2937"/>
+            </a:solidFill>
+            <a:prstDash val="solid"/>
+          </a:ln>
+        </p:spPr>
+      </p:sp>
+      <p:sp>
+        <p:nvSpPr>
+          <p:cNvPr id="91" name="readable-summary-accent-1">
+            <a:extLst xmlns:a="http://schemas.openxmlformats.org/drawingml/2006/main">
+              <a:ext uri="{FF2B5EF4-FFF2-40B4-BE49-F238E27FC236}">
+                <a16:creationId xmlns:a16="http://schemas.microsoft.com/office/drawing/2014/main" id="{69C17588-4776-40E7-A54A-51744EF76B16}"/>
+              </a:ext>
+            </a:extLst>
+          </p:cNvPr>
+          <p:cNvSpPr>
+            <a:spLocks xmlns:a="http://schemas.openxmlformats.org/drawingml/2006/main" noGrp="1"/>
+          </p:cNvSpPr>
+          <p:nvPr/>
+        </p:nvSpPr>
+        <p:spPr>
+          <a:xfrm xmlns:a="http://schemas.openxmlformats.org/drawingml/2006/main">
+            <a:off x="762000" y="2209800"/>
+            <a:ext cx="1143000" cy="47625"/>
+          </a:xfrm>
+          <a:prstGeom xmlns:a="http://schemas.openxmlformats.org/drawingml/2006/main" prst="rect">
+            <a:avLst/>
+          </a:prstGeom>
+          <a:solidFill xmlns:a="http://schemas.openxmlformats.org/drawingml/2006/main">
+            <a:srgbClr val="EF4444"/>
+          </a:solidFill>
+          <a:ln xmlns:a="http://schemas.openxmlformats.org/drawingml/2006/main" w="0">
+            <a:noFill/>
+            <a:prstDash val="solid"/>
+          </a:ln>
+        </p:spPr>
+      </p:sp>
+      <p:sp>
+        <p:nvSpPr>
+          <p:cNvPr id="92" name="readable-summary-title-1">
+            <a:extLst xmlns:a="http://schemas.openxmlformats.org/drawingml/2006/main">
+              <a:ext uri="{FF2B5EF4-FFF2-40B4-BE49-F238E27FC236}">
+                <a16:creationId xmlns:a16="http://schemas.microsoft.com/office/drawing/2014/main" id="{B4C1161F-CAA3-49D4-8D7F-7354CF853187}"/>
+              </a:ext>
+            </a:extLst>
+          </p:cNvPr>
+          <p:cNvSpPr>
+            <a:spLocks xmlns:a="http://schemas.openxmlformats.org/drawingml/2006/main" noGrp="1"/>
+          </p:cNvSpPr>
+          <p:nvPr/>
+        </p:nvSpPr>
+        <p:spPr>
+          <a:xfrm xmlns:a="http://schemas.openxmlformats.org/drawingml/2006/main">
+            <a:off x="762000" y="2400300"/>
+            <a:ext cx="4762500" cy="304800"/>
+          </a:xfrm>
+          <a:prstGeom xmlns:a="http://schemas.openxmlformats.org/drawingml/2006/main" prst="rect">
+            <a:avLst/>
+          </a:prstGeom>
+          <a:noFill xmlns:a="http://schemas.openxmlformats.org/drawingml/2006/main"/>
+          <a:ln xmlns:a="http://schemas.openxmlformats.org/drawingml/2006/main" w="0">
+            <a:noFill/>
+            <a:prstDash val="solid"/>
+          </a:ln>
+        </p:spPr>
+        <p:txBody>
+          <a:bodyPr xmlns:a="http://schemas.openxmlformats.org/drawingml/2006/main"/>
+          <a:lstStyle xmlns:a="http://schemas.openxmlformats.org/drawingml/2006/main"/>
+          <a:p xmlns:a="http://schemas.openxmlformats.org/drawingml/2006/main">
+            <a:pPr>
+              <a:defRPr sz="1875" b="1">
+                <a:solidFill>
+                  <a:srgbClr val="FFFFFF"/>
+                </a:solidFill>
+              </a:defRPr>
+            </a:pPr>
+            <a:r>
+              <a:rPr sz="1875" b="1">
+                <a:solidFill>
+                  <a:srgbClr val="FFFFFF"/>
+                </a:solidFill>
+              </a:rPr>
+              <a:t>Cockpit ve AI</a:t>
+            </a:r>
+          </a:p>
+        </p:txBody>
+      </p:sp>
+      <p:sp>
+        <p:nvSpPr>
+          <p:cNvPr id="93" name="readable-summary-dot-1-0">
+            <a:extLst xmlns:a="http://schemas.openxmlformats.org/drawingml/2006/main">
+              <a:ext uri="{FF2B5EF4-FFF2-40B4-BE49-F238E27FC236}">
+                <a16:creationId xmlns:a16="http://schemas.microsoft.com/office/drawing/2014/main" id="{1A815D3A-E7AF-41C6-9C74-37A5BD40F704}"/>
+              </a:ext>
+            </a:extLst>
+          </p:cNvPr>
+          <p:cNvSpPr>
+            <a:spLocks xmlns:a="http://schemas.openxmlformats.org/drawingml/2006/main" noGrp="1"/>
+          </p:cNvSpPr>
+          <p:nvPr/>
+        </p:nvSpPr>
+        <p:spPr>
+          <a:xfrm xmlns:a="http://schemas.openxmlformats.org/drawingml/2006/main">
+            <a:off x="790575" y="2914650"/>
+            <a:ext cx="76200" cy="76200"/>
+          </a:xfrm>
+          <a:prstGeom xmlns:a="http://schemas.openxmlformats.org/drawingml/2006/main" prst="ellipse">
+            <a:avLst/>
+          </a:prstGeom>
+          <a:solidFill xmlns:a="http://schemas.openxmlformats.org/drawingml/2006/main">
+            <a:srgbClr val="EF4444"/>
+          </a:solidFill>
+          <a:ln xmlns:a="http://schemas.openxmlformats.org/drawingml/2006/main" w="0">
+            <a:noFill/>
+            <a:prstDash val="solid"/>
+          </a:ln>
+        </p:spPr>
+      </p:sp>
+      <p:sp>
+        <p:nvSpPr>
+          <p:cNvPr id="94" name="readable-summary-item-1-0">
+            <a:extLst xmlns:a="http://schemas.openxmlformats.org/drawingml/2006/main">
+              <a:ext uri="{FF2B5EF4-FFF2-40B4-BE49-F238E27FC236}">
+                <a16:creationId xmlns:a16="http://schemas.microsoft.com/office/drawing/2014/main" id="{2FF85769-1605-4525-9439-05D58882558D}"/>
+              </a:ext>
+            </a:extLst>
+          </p:cNvPr>
+          <p:cNvSpPr>
+            <a:spLocks xmlns:a="http://schemas.openxmlformats.org/drawingml/2006/main" noGrp="1"/>
+          </p:cNvSpPr>
+          <p:nvPr/>
+        </p:nvSpPr>
+        <p:spPr>
+          <a:xfrm xmlns:a="http://schemas.openxmlformats.org/drawingml/2006/main">
+            <a:off x="990600" y="2838450"/>
+            <a:ext cx="4476750" cy="266700"/>
+          </a:xfrm>
+          <a:prstGeom xmlns:a="http://schemas.openxmlformats.org/drawingml/2006/main" prst="rect">
+            <a:avLst/>
+          </a:prstGeom>
+          <a:noFill xmlns:a="http://schemas.openxmlformats.org/drawingml/2006/main"/>
+          <a:ln xmlns:a="http://schemas.openxmlformats.org/drawingml/2006/main" w="0">
+            <a:noFill/>
+            <a:prstDash val="solid"/>
+          </a:ln>
+        </p:spPr>
+        <p:txBody>
+          <a:bodyPr xmlns:a="http://schemas.openxmlformats.org/drawingml/2006/main"/>
+          <a:lstStyle xmlns:a="http://schemas.openxmlformats.org/drawingml/2006/main"/>
+          <a:p xmlns:a="http://schemas.openxmlformats.org/drawingml/2006/main">
+            <a:pPr>
+              <a:defRPr sz="1500">
+                <a:solidFill>
+                  <a:srgbClr val="DBE4EF"/>
+                </a:solidFill>
+              </a:defRPr>
+            </a:pPr>
+            <a:r>
+              <a:rPr sz="1500">
+                <a:solidFill>
+                  <a:srgbClr val="DBE4EF"/>
+                </a:solidFill>
+              </a:rPr>
+              <a:t>AI Chatbot</a:t>
+            </a:r>
+          </a:p>
+        </p:txBody>
+      </p:sp>
+      <p:sp>
+        <p:nvSpPr>
+          <p:cNvPr id="95" name="readable-summary-dot-1-1">
+            <a:extLst xmlns:a="http://schemas.openxmlformats.org/drawingml/2006/main">
+              <a:ext uri="{FF2B5EF4-FFF2-40B4-BE49-F238E27FC236}">
+                <a16:creationId xmlns:a16="http://schemas.microsoft.com/office/drawing/2014/main" id="{8BF0B9F3-BA19-4859-950D-343F68839929}"/>
+              </a:ext>
+            </a:extLst>
+          </p:cNvPr>
+          <p:cNvSpPr>
+            <a:spLocks xmlns:a="http://schemas.openxmlformats.org/drawingml/2006/main" noGrp="1"/>
+          </p:cNvSpPr>
+          <p:nvPr/>
+        </p:nvSpPr>
+        <p:spPr>
+          <a:xfrm xmlns:a="http://schemas.openxmlformats.org/drawingml/2006/main">
+            <a:off x="790575" y="3257550"/>
+            <a:ext cx="76200" cy="76200"/>
+          </a:xfrm>
+          <a:prstGeom xmlns:a="http://schemas.openxmlformats.org/drawingml/2006/main" prst="ellipse">
+            <a:avLst/>
+          </a:prstGeom>
+          <a:solidFill xmlns:a="http://schemas.openxmlformats.org/drawingml/2006/main">
+            <a:srgbClr val="EF4444"/>
+          </a:solidFill>
+          <a:ln xmlns:a="http://schemas.openxmlformats.org/drawingml/2006/main" w="0">
+            <a:noFill/>
+            <a:prstDash val="solid"/>
+          </a:ln>
+        </p:spPr>
+      </p:sp>
+      <p:sp>
+        <p:nvSpPr>
+          <p:cNvPr id="96" name="readable-summary-item-1-1">
+            <a:extLst xmlns:a="http://schemas.openxmlformats.org/drawingml/2006/main">
+              <a:ext uri="{FF2B5EF4-FFF2-40B4-BE49-F238E27FC236}">
+                <a16:creationId xmlns:a16="http://schemas.microsoft.com/office/drawing/2014/main" id="{F4B62EA2-35D8-45A0-80E4-29EB42E3FFE2}"/>
+              </a:ext>
+            </a:extLst>
+          </p:cNvPr>
+          <p:cNvSpPr>
+            <a:spLocks xmlns:a="http://schemas.openxmlformats.org/drawingml/2006/main" noGrp="1"/>
+          </p:cNvSpPr>
+          <p:nvPr/>
+        </p:nvSpPr>
+        <p:spPr>
+          <a:xfrm xmlns:a="http://schemas.openxmlformats.org/drawingml/2006/main">
+            <a:off x="990600" y="3181350"/>
+            <a:ext cx="4476750" cy="266700"/>
+          </a:xfrm>
+          <a:prstGeom xmlns:a="http://schemas.openxmlformats.org/drawingml/2006/main" prst="rect">
+            <a:avLst/>
+          </a:prstGeom>
+          <a:noFill xmlns:a="http://schemas.openxmlformats.org/drawingml/2006/main"/>
+          <a:ln xmlns:a="http://schemas.openxmlformats.org/drawingml/2006/main" w="0">
+            <a:noFill/>
+            <a:prstDash val="solid"/>
+          </a:ln>
+        </p:spPr>
+        <p:txBody>
+          <a:bodyPr xmlns:a="http://schemas.openxmlformats.org/drawingml/2006/main"/>
+          <a:lstStyle xmlns:a="http://schemas.openxmlformats.org/drawingml/2006/main"/>
+          <a:p xmlns:a="http://schemas.openxmlformats.org/drawingml/2006/main">
+            <a:pPr>
+              <a:defRPr sz="1500">
+                <a:solidFill>
+                  <a:srgbClr val="DBE4EF"/>
+                </a:solidFill>
+              </a:defRPr>
+            </a:pPr>
+            <a:r>
+              <a:rPr sz="1500">
+                <a:solidFill>
+                  <a:srgbClr val="DBE4EF"/>
+                </a:solidFill>
+              </a:rPr>
+              <a:t>Bilgi Akışı / RAG</a:t>
+            </a:r>
+          </a:p>
+        </p:txBody>
+      </p:sp>
+      <p:sp>
+        <p:nvSpPr>
+          <p:cNvPr id="97" name="readable-summary-dot-1-2">
+            <a:extLst xmlns:a="http://schemas.openxmlformats.org/drawingml/2006/main">
+              <a:ext uri="{FF2B5EF4-FFF2-40B4-BE49-F238E27FC236}">
+                <a16:creationId xmlns:a16="http://schemas.microsoft.com/office/drawing/2014/main" id="{366F0646-0247-40AF-9052-2B2D1587BD61}"/>
+              </a:ext>
+            </a:extLst>
+          </p:cNvPr>
+          <p:cNvSpPr>
+            <a:spLocks xmlns:a="http://schemas.openxmlformats.org/drawingml/2006/main" noGrp="1"/>
+          </p:cNvSpPr>
+          <p:nvPr/>
+        </p:nvSpPr>
+        <p:spPr>
+          <a:xfrm xmlns:a="http://schemas.openxmlformats.org/drawingml/2006/main">
+            <a:off x="790575" y="3600450"/>
+            <a:ext cx="76200" cy="76200"/>
+          </a:xfrm>
+          <a:prstGeom xmlns:a="http://schemas.openxmlformats.org/drawingml/2006/main" prst="ellipse">
+            <a:avLst/>
+          </a:prstGeom>
+          <a:solidFill xmlns:a="http://schemas.openxmlformats.org/drawingml/2006/main">
+            <a:srgbClr val="EF4444"/>
+          </a:solidFill>
+          <a:ln xmlns:a="http://schemas.openxmlformats.org/drawingml/2006/main" w="0">
+            <a:noFill/>
+            <a:prstDash val="solid"/>
+          </a:ln>
+        </p:spPr>
+      </p:sp>
+      <p:sp>
+        <p:nvSpPr>
+          <p:cNvPr id="98" name="readable-summary-item-1-2">
+            <a:extLst xmlns:a="http://schemas.openxmlformats.org/drawingml/2006/main">
+              <a:ext uri="{FF2B5EF4-FFF2-40B4-BE49-F238E27FC236}">
+                <a16:creationId xmlns:a16="http://schemas.microsoft.com/office/drawing/2014/main" id="{3ACF285E-A434-43B7-AB64-323E7029F9E4}"/>
+              </a:ext>
+            </a:extLst>
+          </p:cNvPr>
+          <p:cNvSpPr>
+            <a:spLocks xmlns:a="http://schemas.openxmlformats.org/drawingml/2006/main" noGrp="1"/>
+          </p:cNvSpPr>
+          <p:nvPr/>
+        </p:nvSpPr>
+        <p:spPr>
+          <a:xfrm xmlns:a="http://schemas.openxmlformats.org/drawingml/2006/main">
+            <a:off x="990600" y="3524250"/>
+            <a:ext cx="4476750" cy="266700"/>
+          </a:xfrm>
+          <a:prstGeom xmlns:a="http://schemas.openxmlformats.org/drawingml/2006/main" prst="rect">
+            <a:avLst/>
+          </a:prstGeom>
+          <a:noFill xmlns:a="http://schemas.openxmlformats.org/drawingml/2006/main"/>
+          <a:ln xmlns:a="http://schemas.openxmlformats.org/drawingml/2006/main" w="0">
+            <a:noFill/>
+            <a:prstDash val="solid"/>
+          </a:ln>
+        </p:spPr>
+        <p:txBody>
+          <a:bodyPr xmlns:a="http://schemas.openxmlformats.org/drawingml/2006/main"/>
+          <a:lstStyle xmlns:a="http://schemas.openxmlformats.org/drawingml/2006/main"/>
+          <a:p xmlns:a="http://schemas.openxmlformats.org/drawingml/2006/main">
+            <a:pPr>
+              <a:defRPr sz="1500">
+                <a:solidFill>
+                  <a:srgbClr val="DBE4EF"/>
+                </a:solidFill>
+              </a:defRPr>
+            </a:pPr>
+            <a:r>
+              <a:rPr sz="1500">
+                <a:solidFill>
+                  <a:srgbClr val="DBE4EF"/>
+                </a:solidFill>
+              </a:rPr>
+              <a:t>Tek cockpit deneyimi</a:t>
+            </a:r>
+          </a:p>
+        </p:txBody>
+      </p:sp>
+      <p:sp>
+        <p:nvSpPr>
+          <p:cNvPr id="99" name="readable-summary-block-2">
+            <a:extLst xmlns:a="http://schemas.openxmlformats.org/drawingml/2006/main">
+              <a:ext uri="{FF2B5EF4-FFF2-40B4-BE49-F238E27FC236}">
+                <a16:creationId xmlns:a16="http://schemas.microsoft.com/office/drawing/2014/main" id="{A72982D6-01D5-4348-BD52-D1479866DED5}"/>
+              </a:ext>
+            </a:extLst>
+          </p:cNvPr>
+          <p:cNvSpPr>
+            <a:spLocks xmlns:a="http://schemas.openxmlformats.org/drawingml/2006/main" noGrp="1"/>
+          </p:cNvSpPr>
+          <p:nvPr/>
+        </p:nvSpPr>
+        <p:spPr>
+          <a:xfrm xmlns:a="http://schemas.openxmlformats.org/drawingml/2006/main">
+            <a:off x="6381750" y="2000250"/>
+            <a:ext cx="5257800" cy="1943100"/>
+          </a:xfrm>
+          <a:prstGeom xmlns:a="http://schemas.openxmlformats.org/drawingml/2006/main" prst="roundRect">
+            <a:avLst>
+              <a:gd name="adj" fmla="val 3922"/>
+            </a:avLst>
+          </a:prstGeom>
+          <a:solidFill xmlns:a="http://schemas.openxmlformats.org/drawingml/2006/main">
+            <a:srgbClr val="111822"/>
+          </a:solidFill>
+          <a:ln xmlns:a="http://schemas.openxmlformats.org/drawingml/2006/main" w="9525">
+            <a:solidFill>
+              <a:srgbClr val="1F2937"/>
+            </a:solidFill>
+            <a:prstDash val="solid"/>
+          </a:ln>
+        </p:spPr>
+      </p:sp>
+      <p:sp>
+        <p:nvSpPr>
+          <p:cNvPr id="100" name="readable-summary-accent-2">
+            <a:extLst xmlns:a="http://schemas.openxmlformats.org/drawingml/2006/main">
+              <a:ext uri="{FF2B5EF4-FFF2-40B4-BE49-F238E27FC236}">
+                <a16:creationId xmlns:a16="http://schemas.microsoft.com/office/drawing/2014/main" id="{B604548B-D030-470B-9C9D-FCA9C96270D9}"/>
+              </a:ext>
+            </a:extLst>
+          </p:cNvPr>
+          <p:cNvSpPr>
+            <a:spLocks xmlns:a="http://schemas.openxmlformats.org/drawingml/2006/main" noGrp="1"/>
+          </p:cNvSpPr>
+          <p:nvPr/>
+        </p:nvSpPr>
+        <p:spPr>
+          <a:xfrm xmlns:a="http://schemas.openxmlformats.org/drawingml/2006/main">
+            <a:off x="6591300" y="2209800"/>
+            <a:ext cx="1143000" cy="47625"/>
+          </a:xfrm>
+          <a:prstGeom xmlns:a="http://schemas.openxmlformats.org/drawingml/2006/main" prst="rect">
+            <a:avLst/>
+          </a:prstGeom>
+          <a:solidFill xmlns:a="http://schemas.openxmlformats.org/drawingml/2006/main">
+            <a:srgbClr val="38BDF8"/>
+          </a:solidFill>
+          <a:ln xmlns:a="http://schemas.openxmlformats.org/drawingml/2006/main" w="0">
+            <a:noFill/>
+            <a:prstDash val="solid"/>
+          </a:ln>
+        </p:spPr>
+      </p:sp>
+      <p:sp>
+        <p:nvSpPr>
+          <p:cNvPr id="101" name="readable-summary-title-2">
+            <a:extLst xmlns:a="http://schemas.openxmlformats.org/drawingml/2006/main">
+              <a:ext uri="{FF2B5EF4-FFF2-40B4-BE49-F238E27FC236}">
+                <a16:creationId xmlns:a16="http://schemas.microsoft.com/office/drawing/2014/main" id="{ADA075A7-F073-4CA5-A3E4-B923F026EAE5}"/>
+              </a:ext>
+            </a:extLst>
+          </p:cNvPr>
+          <p:cNvSpPr>
+            <a:spLocks xmlns:a="http://schemas.openxmlformats.org/drawingml/2006/main" noGrp="1"/>
+          </p:cNvSpPr>
+          <p:nvPr/>
+        </p:nvSpPr>
+        <p:spPr>
+          <a:xfrm xmlns:a="http://schemas.openxmlformats.org/drawingml/2006/main">
+            <a:off x="6591300" y="2400300"/>
+            <a:ext cx="4762500" cy="304800"/>
+          </a:xfrm>
+          <a:prstGeom xmlns:a="http://schemas.openxmlformats.org/drawingml/2006/main" prst="rect">
+            <a:avLst/>
+          </a:prstGeom>
+          <a:noFill xmlns:a="http://schemas.openxmlformats.org/drawingml/2006/main"/>
+          <a:ln xmlns:a="http://schemas.openxmlformats.org/drawingml/2006/main" w="0">
+            <a:noFill/>
+            <a:prstDash val="solid"/>
+          </a:ln>
+        </p:spPr>
+        <p:txBody>
+          <a:bodyPr xmlns:a="http://schemas.openxmlformats.org/drawingml/2006/main"/>
+          <a:lstStyle xmlns:a="http://schemas.openxmlformats.org/drawingml/2006/main"/>
+          <a:p xmlns:a="http://schemas.openxmlformats.org/drawingml/2006/main">
+            <a:pPr>
+              <a:defRPr sz="1875" b="1">
+                <a:solidFill>
+                  <a:srgbClr val="FFFFFF"/>
+                </a:solidFill>
+              </a:defRPr>
+            </a:pPr>
+            <a:r>
+              <a:rPr sz="1875" b="1">
+                <a:solidFill>
+                  <a:srgbClr val="FFFFFF"/>
+                </a:solidFill>
+              </a:rPr>
+              <a:t>Robot Twin</a:t>
+            </a:r>
+          </a:p>
+        </p:txBody>
+      </p:sp>
+      <p:sp>
+        <p:nvSpPr>
+          <p:cNvPr id="102" name="readable-summary-dot-2-0">
+            <a:extLst xmlns:a="http://schemas.openxmlformats.org/drawingml/2006/main">
+              <a:ext uri="{FF2B5EF4-FFF2-40B4-BE49-F238E27FC236}">
+                <a16:creationId xmlns:a16="http://schemas.microsoft.com/office/drawing/2014/main" id="{479326B9-4ACB-4FE5-AB3F-9FA902BDE209}"/>
+              </a:ext>
+            </a:extLst>
+          </p:cNvPr>
+          <p:cNvSpPr>
+            <a:spLocks xmlns:a="http://schemas.openxmlformats.org/drawingml/2006/main" noGrp="1"/>
+          </p:cNvSpPr>
+          <p:nvPr/>
+        </p:nvSpPr>
+        <p:spPr>
+          <a:xfrm xmlns:a="http://schemas.openxmlformats.org/drawingml/2006/main">
+            <a:off x="6619875" y="2914650"/>
+            <a:ext cx="76200" cy="76200"/>
+          </a:xfrm>
+          <a:prstGeom xmlns:a="http://schemas.openxmlformats.org/drawingml/2006/main" prst="ellipse">
+            <a:avLst/>
+          </a:prstGeom>
+          <a:solidFill xmlns:a="http://schemas.openxmlformats.org/drawingml/2006/main">
+            <a:srgbClr val="38BDF8"/>
+          </a:solidFill>
+          <a:ln xmlns:a="http://schemas.openxmlformats.org/drawingml/2006/main" w="0">
+            <a:noFill/>
+            <a:prstDash val="solid"/>
+          </a:ln>
+        </p:spPr>
+      </p:sp>
+      <p:sp>
+        <p:nvSpPr>
+          <p:cNvPr id="103" name="readable-summary-item-2-0">
+            <a:extLst xmlns:a="http://schemas.openxmlformats.org/drawingml/2006/main">
+              <a:ext uri="{FF2B5EF4-FFF2-40B4-BE49-F238E27FC236}">
+                <a16:creationId xmlns:a16="http://schemas.microsoft.com/office/drawing/2014/main" id="{B0CDCB50-8121-4F30-B3B4-0D2F69AA5AD6}"/>
+              </a:ext>
+            </a:extLst>
+          </p:cNvPr>
+          <p:cNvSpPr>
+            <a:spLocks xmlns:a="http://schemas.openxmlformats.org/drawingml/2006/main" noGrp="1"/>
+          </p:cNvSpPr>
+          <p:nvPr/>
+        </p:nvSpPr>
+        <p:spPr>
+          <a:xfrm xmlns:a="http://schemas.openxmlformats.org/drawingml/2006/main">
+            <a:off x="6819900" y="2838450"/>
+            <a:ext cx="4476750" cy="266700"/>
+          </a:xfrm>
+          <a:prstGeom xmlns:a="http://schemas.openxmlformats.org/drawingml/2006/main" prst="rect">
+            <a:avLst/>
+          </a:prstGeom>
+          <a:noFill xmlns:a="http://schemas.openxmlformats.org/drawingml/2006/main"/>
+          <a:ln xmlns:a="http://schemas.openxmlformats.org/drawingml/2006/main" w="0">
+            <a:noFill/>
+            <a:prstDash val="solid"/>
+          </a:ln>
+        </p:spPr>
+        <p:txBody>
+          <a:bodyPr xmlns:a="http://schemas.openxmlformats.org/drawingml/2006/main"/>
+          <a:lstStyle xmlns:a="http://schemas.openxmlformats.org/drawingml/2006/main"/>
+          <a:p xmlns:a="http://schemas.openxmlformats.org/drawingml/2006/main">
+            <a:pPr>
+              <a:defRPr sz="1500">
+                <a:solidFill>
+                  <a:srgbClr val="DBE4EF"/>
+                </a:solidFill>
+              </a:defRPr>
+            </a:pPr>
+            <a:r>
+              <a:rPr sz="1500">
+                <a:solidFill>
+                  <a:srgbClr val="DBE4EF"/>
+                </a:solidFill>
+              </a:rPr>
+              <a:t>Dijital robot görünümü</a:t>
+            </a:r>
+          </a:p>
+        </p:txBody>
+      </p:sp>
+      <p:sp>
+        <p:nvSpPr>
+          <p:cNvPr id="104" name="readable-summary-dot-2-1">
+            <a:extLst xmlns:a="http://schemas.openxmlformats.org/drawingml/2006/main">
+              <a:ext uri="{FF2B5EF4-FFF2-40B4-BE49-F238E27FC236}">
+                <a16:creationId xmlns:a16="http://schemas.microsoft.com/office/drawing/2014/main" id="{B5F37ACF-3DE3-4DEC-8F5E-1A954CB2D796}"/>
+              </a:ext>
+            </a:extLst>
+          </p:cNvPr>
+          <p:cNvSpPr>
+            <a:spLocks xmlns:a="http://schemas.openxmlformats.org/drawingml/2006/main" noGrp="1"/>
+          </p:cNvSpPr>
+          <p:nvPr/>
+        </p:nvSpPr>
+        <p:spPr>
+          <a:xfrm xmlns:a="http://schemas.openxmlformats.org/drawingml/2006/main">
+            <a:off x="6619875" y="3257550"/>
+            <a:ext cx="76200" cy="76200"/>
+          </a:xfrm>
+          <a:prstGeom xmlns:a="http://schemas.openxmlformats.org/drawingml/2006/main" prst="ellipse">
+            <a:avLst/>
+          </a:prstGeom>
+          <a:solidFill xmlns:a="http://schemas.openxmlformats.org/drawingml/2006/main">
+            <a:srgbClr val="38BDF8"/>
+          </a:solidFill>
+          <a:ln xmlns:a="http://schemas.openxmlformats.org/drawingml/2006/main" w="0">
+            <a:noFill/>
+            <a:prstDash val="solid"/>
+          </a:ln>
+        </p:spPr>
+      </p:sp>
+      <p:sp>
+        <p:nvSpPr>
+          <p:cNvPr id="105" name="readable-summary-item-2-1">
+            <a:extLst xmlns:a="http://schemas.openxmlformats.org/drawingml/2006/main">
+              <a:ext uri="{FF2B5EF4-FFF2-40B4-BE49-F238E27FC236}">
+                <a16:creationId xmlns:a16="http://schemas.microsoft.com/office/drawing/2014/main" id="{F6957BEF-F626-46BA-8B17-12AA10929CA0}"/>
+              </a:ext>
+            </a:extLst>
+          </p:cNvPr>
+          <p:cNvSpPr>
+            <a:spLocks xmlns:a="http://schemas.openxmlformats.org/drawingml/2006/main" noGrp="1"/>
+          </p:cNvSpPr>
+          <p:nvPr/>
+        </p:nvSpPr>
+        <p:spPr>
+          <a:xfrm xmlns:a="http://schemas.openxmlformats.org/drawingml/2006/main">
+            <a:off x="6819900" y="3181350"/>
+            <a:ext cx="4476750" cy="266700"/>
+          </a:xfrm>
+          <a:prstGeom xmlns:a="http://schemas.openxmlformats.org/drawingml/2006/main" prst="rect">
+            <a:avLst/>
+          </a:prstGeom>
+          <a:noFill xmlns:a="http://schemas.openxmlformats.org/drawingml/2006/main"/>
+          <a:ln xmlns:a="http://schemas.openxmlformats.org/drawingml/2006/main" w="0">
+            <a:noFill/>
+            <a:prstDash val="solid"/>
+          </a:ln>
+        </p:spPr>
+        <p:txBody>
+          <a:bodyPr xmlns:a="http://schemas.openxmlformats.org/drawingml/2006/main"/>
+          <a:lstStyle xmlns:a="http://schemas.openxmlformats.org/drawingml/2006/main"/>
+          <a:p xmlns:a="http://schemas.openxmlformats.org/drawingml/2006/main">
+            <a:pPr>
+              <a:defRPr sz="1500">
+                <a:solidFill>
+                  <a:srgbClr val="DBE4EF"/>
+                </a:solidFill>
+              </a:defRPr>
+            </a:pPr>
+            <a:r>
+              <a:rPr sz="1500">
+                <a:solidFill>
+                  <a:srgbClr val="DBE4EF"/>
+                </a:solidFill>
+              </a:rPr>
+              <a:t>Sahne farkındalığı</a:t>
+            </a:r>
+          </a:p>
+        </p:txBody>
+      </p:sp>
+      <p:sp>
+        <p:nvSpPr>
+          <p:cNvPr id="106" name="readable-summary-dot-2-2">
+            <a:extLst xmlns:a="http://schemas.openxmlformats.org/drawingml/2006/main">
+              <a:ext uri="{FF2B5EF4-FFF2-40B4-BE49-F238E27FC236}">
+                <a16:creationId xmlns:a16="http://schemas.microsoft.com/office/drawing/2014/main" id="{22BBAE40-858A-477B-9755-741284E5D18F}"/>
+              </a:ext>
+            </a:extLst>
+          </p:cNvPr>
+          <p:cNvSpPr>
+            <a:spLocks xmlns:a="http://schemas.openxmlformats.org/drawingml/2006/main" noGrp="1"/>
+          </p:cNvSpPr>
+          <p:nvPr/>
+        </p:nvSpPr>
+        <p:spPr>
+          <a:xfrm xmlns:a="http://schemas.openxmlformats.org/drawingml/2006/main">
+            <a:off x="6619875" y="3600450"/>
+            <a:ext cx="76200" cy="76200"/>
+          </a:xfrm>
+          <a:prstGeom xmlns:a="http://schemas.openxmlformats.org/drawingml/2006/main" prst="ellipse">
+            <a:avLst/>
+          </a:prstGeom>
+          <a:solidFill xmlns:a="http://schemas.openxmlformats.org/drawingml/2006/main">
+            <a:srgbClr val="38BDF8"/>
+          </a:solidFill>
+          <a:ln xmlns:a="http://schemas.openxmlformats.org/drawingml/2006/main" w="0">
+            <a:noFill/>
+            <a:prstDash val="solid"/>
+          </a:ln>
+        </p:spPr>
+      </p:sp>
+      <p:sp>
+        <p:nvSpPr>
+          <p:cNvPr id="107" name="readable-summary-item-2-2">
+            <a:extLst xmlns:a="http://schemas.openxmlformats.org/drawingml/2006/main">
+              <a:ext uri="{FF2B5EF4-FFF2-40B4-BE49-F238E27FC236}">
+                <a16:creationId xmlns:a16="http://schemas.microsoft.com/office/drawing/2014/main" id="{9B580936-C72F-4C02-B48C-5752DABCBDD7}"/>
+              </a:ext>
+            </a:extLst>
+          </p:cNvPr>
+          <p:cNvSpPr>
+            <a:spLocks xmlns:a="http://schemas.openxmlformats.org/drawingml/2006/main" noGrp="1"/>
+          </p:cNvSpPr>
+          <p:nvPr/>
+        </p:nvSpPr>
+        <p:spPr>
+          <a:xfrm xmlns:a="http://schemas.openxmlformats.org/drawingml/2006/main">
+            <a:off x="6819900" y="3524250"/>
+            <a:ext cx="4476750" cy="266700"/>
+          </a:xfrm>
+          <a:prstGeom xmlns:a="http://schemas.openxmlformats.org/drawingml/2006/main" prst="rect">
+            <a:avLst/>
+          </a:prstGeom>
+          <a:noFill xmlns:a="http://schemas.openxmlformats.org/drawingml/2006/main"/>
+          <a:ln xmlns:a="http://schemas.openxmlformats.org/drawingml/2006/main" w="0">
+            <a:noFill/>
+            <a:prstDash val="solid"/>
+          </a:ln>
+        </p:spPr>
+        <p:txBody>
+          <a:bodyPr xmlns:a="http://schemas.openxmlformats.org/drawingml/2006/main"/>
+          <a:lstStyle xmlns:a="http://schemas.openxmlformats.org/drawingml/2006/main"/>
+          <a:p xmlns:a="http://schemas.openxmlformats.org/drawingml/2006/main">
+            <a:pPr>
+              <a:defRPr sz="1500">
+                <a:solidFill>
+                  <a:srgbClr val="DBE4EF"/>
+                </a:solidFill>
+              </a:defRPr>
+            </a:pPr>
+            <a:r>
+              <a:rPr sz="1500">
+                <a:solidFill>
+                  <a:srgbClr val="DBE4EF"/>
+                </a:solidFill>
+              </a:rPr>
+              <a:t>Robot bağlamını toplama</a:t>
+            </a:r>
+          </a:p>
+        </p:txBody>
+      </p:sp>
+      <p:sp>
+        <p:nvSpPr>
+          <p:cNvPr id="108" name="readable-summary-block-3">
+            <a:extLst xmlns:a="http://schemas.openxmlformats.org/drawingml/2006/main">
+              <a:ext uri="{FF2B5EF4-FFF2-40B4-BE49-F238E27FC236}">
+                <a16:creationId xmlns:a16="http://schemas.microsoft.com/office/drawing/2014/main" id="{F1457C8C-7A78-427B-A6FF-104B8DFDA44A}"/>
+              </a:ext>
+            </a:extLst>
+          </p:cNvPr>
+          <p:cNvSpPr>
+            <a:spLocks xmlns:a="http://schemas.openxmlformats.org/drawingml/2006/main" noGrp="1"/>
+          </p:cNvSpPr>
+          <p:nvPr/>
+        </p:nvSpPr>
+        <p:spPr>
+          <a:xfrm xmlns:a="http://schemas.openxmlformats.org/drawingml/2006/main">
+            <a:off x="552450" y="4324350"/>
+            <a:ext cx="5257800" cy="1943100"/>
+          </a:xfrm>
+          <a:prstGeom xmlns:a="http://schemas.openxmlformats.org/drawingml/2006/main" prst="roundRect">
+            <a:avLst>
+              <a:gd name="adj" fmla="val 3922"/>
+            </a:avLst>
+          </a:prstGeom>
+          <a:solidFill xmlns:a="http://schemas.openxmlformats.org/drawingml/2006/main">
+            <a:srgbClr val="111822"/>
+          </a:solidFill>
+          <a:ln xmlns:a="http://schemas.openxmlformats.org/drawingml/2006/main" w="9525">
+            <a:solidFill>
+              <a:srgbClr val="1F2937"/>
+            </a:solidFill>
+            <a:prstDash val="solid"/>
+          </a:ln>
+        </p:spPr>
+      </p:sp>
+      <p:sp>
+        <p:nvSpPr>
+          <p:cNvPr id="109" name="readable-summary-accent-3">
+            <a:extLst xmlns:a="http://schemas.openxmlformats.org/drawingml/2006/main">
+              <a:ext uri="{FF2B5EF4-FFF2-40B4-BE49-F238E27FC236}">
+                <a16:creationId xmlns:a16="http://schemas.microsoft.com/office/drawing/2014/main" id="{DD41653D-C97F-4019-A03E-CA4C86B74FEE}"/>
+              </a:ext>
+            </a:extLst>
+          </p:cNvPr>
+          <p:cNvSpPr>
+            <a:spLocks xmlns:a="http://schemas.openxmlformats.org/drawingml/2006/main" noGrp="1"/>
+          </p:cNvSpPr>
+          <p:nvPr/>
+        </p:nvSpPr>
+        <p:spPr>
+          <a:xfrm xmlns:a="http://schemas.openxmlformats.org/drawingml/2006/main">
+            <a:off x="762000" y="4533900"/>
+            <a:ext cx="1143000" cy="47625"/>
+          </a:xfrm>
+          <a:prstGeom xmlns:a="http://schemas.openxmlformats.org/drawingml/2006/main" prst="rect">
+            <a:avLst/>
+          </a:prstGeom>
+          <a:solidFill xmlns:a="http://schemas.openxmlformats.org/drawingml/2006/main">
+            <a:srgbClr val="22C55E"/>
+          </a:solidFill>
+          <a:ln xmlns:a="http://schemas.openxmlformats.org/drawingml/2006/main" w="0">
+            <a:noFill/>
+            <a:prstDash val="solid"/>
+          </a:ln>
+        </p:spPr>
+      </p:sp>
+      <p:sp>
+        <p:nvSpPr>
+          <p:cNvPr id="110" name="readable-summary-title-3">
+            <a:extLst xmlns:a="http://schemas.openxmlformats.org/drawingml/2006/main">
+              <a:ext uri="{FF2B5EF4-FFF2-40B4-BE49-F238E27FC236}">
+                <a16:creationId xmlns:a16="http://schemas.microsoft.com/office/drawing/2014/main" id="{6D91BE63-9127-42F7-94D1-B9D794DA64FA}"/>
+              </a:ext>
+            </a:extLst>
+          </p:cNvPr>
+          <p:cNvSpPr>
+            <a:spLocks xmlns:a="http://schemas.openxmlformats.org/drawingml/2006/main" noGrp="1"/>
+          </p:cNvSpPr>
+          <p:nvPr/>
+        </p:nvSpPr>
+        <p:spPr>
+          <a:xfrm xmlns:a="http://schemas.openxmlformats.org/drawingml/2006/main">
+            <a:off x="762000" y="4724400"/>
+            <a:ext cx="4762500" cy="304800"/>
+          </a:xfrm>
+          <a:prstGeom xmlns:a="http://schemas.openxmlformats.org/drawingml/2006/main" prst="rect">
+            <a:avLst/>
+          </a:prstGeom>
+          <a:noFill xmlns:a="http://schemas.openxmlformats.org/drawingml/2006/main"/>
+          <a:ln xmlns:a="http://schemas.openxmlformats.org/drawingml/2006/main" w="0">
+            <a:noFill/>
+            <a:prstDash val="solid"/>
+          </a:ln>
+        </p:spPr>
+        <p:txBody>
+          <a:bodyPr xmlns:a="http://schemas.openxmlformats.org/drawingml/2006/main"/>
+          <a:lstStyle xmlns:a="http://schemas.openxmlformats.org/drawingml/2006/main"/>
+          <a:p xmlns:a="http://schemas.openxmlformats.org/drawingml/2006/main">
+            <a:pPr>
+              <a:defRPr sz="1875" b="1">
+                <a:solidFill>
+                  <a:srgbClr val="FFFFFF"/>
+                </a:solidFill>
+              </a:defRPr>
+            </a:pPr>
+            <a:r>
+              <a:rPr sz="1875" b="1">
+                <a:solidFill>
+                  <a:srgbClr val="FFFFFF"/>
+                </a:solidFill>
+              </a:rPr>
+              <a:t>Live Dashboard</a:t>
+            </a:r>
+          </a:p>
+        </p:txBody>
+      </p:sp>
+      <p:sp>
+        <p:nvSpPr>
+          <p:cNvPr id="111" name="readable-summary-dot-3-0">
+            <a:extLst xmlns:a="http://schemas.openxmlformats.org/drawingml/2006/main">
+              <a:ext uri="{FF2B5EF4-FFF2-40B4-BE49-F238E27FC236}">
+                <a16:creationId xmlns:a16="http://schemas.microsoft.com/office/drawing/2014/main" id="{41E7FDE1-D5B6-4A92-B8CF-143757886F61}"/>
+              </a:ext>
+            </a:extLst>
+          </p:cNvPr>
+          <p:cNvSpPr>
+            <a:spLocks xmlns:a="http://schemas.openxmlformats.org/drawingml/2006/main" noGrp="1"/>
+          </p:cNvSpPr>
+          <p:nvPr/>
+        </p:nvSpPr>
+        <p:spPr>
+          <a:xfrm xmlns:a="http://schemas.openxmlformats.org/drawingml/2006/main">
+            <a:off x="790575" y="5238750"/>
+            <a:ext cx="76200" cy="76200"/>
+          </a:xfrm>
+          <a:prstGeom xmlns:a="http://schemas.openxmlformats.org/drawingml/2006/main" prst="ellipse">
+            <a:avLst/>
+          </a:prstGeom>
+          <a:solidFill xmlns:a="http://schemas.openxmlformats.org/drawingml/2006/main">
+            <a:srgbClr val="22C55E"/>
+          </a:solidFill>
+          <a:ln xmlns:a="http://schemas.openxmlformats.org/drawingml/2006/main" w="0">
+            <a:noFill/>
+            <a:prstDash val="solid"/>
+          </a:ln>
+        </p:spPr>
+      </p:sp>
+      <p:sp>
+        <p:nvSpPr>
+          <p:cNvPr id="112" name="readable-summary-item-3-0">
+            <a:extLst xmlns:a="http://schemas.openxmlformats.org/drawingml/2006/main">
+              <a:ext uri="{FF2B5EF4-FFF2-40B4-BE49-F238E27FC236}">
+                <a16:creationId xmlns:a16="http://schemas.microsoft.com/office/drawing/2014/main" id="{674DE82D-8199-47F3-9219-F633101EE2E6}"/>
+              </a:ext>
+            </a:extLst>
+          </p:cNvPr>
+          <p:cNvSpPr>
+            <a:spLocks xmlns:a="http://schemas.openxmlformats.org/drawingml/2006/main" noGrp="1"/>
+          </p:cNvSpPr>
+          <p:nvPr/>
+        </p:nvSpPr>
+        <p:spPr>
+          <a:xfrm xmlns:a="http://schemas.openxmlformats.org/drawingml/2006/main">
+            <a:off x="990600" y="5162550"/>
+            <a:ext cx="4476750" cy="266700"/>
+          </a:xfrm>
+          <a:prstGeom xmlns:a="http://schemas.openxmlformats.org/drawingml/2006/main" prst="rect">
+            <a:avLst/>
+          </a:prstGeom>
+          <a:noFill xmlns:a="http://schemas.openxmlformats.org/drawingml/2006/main"/>
+          <a:ln xmlns:a="http://schemas.openxmlformats.org/drawingml/2006/main" w="0">
+            <a:noFill/>
+            <a:prstDash val="solid"/>
+          </a:ln>
+        </p:spPr>
+        <p:txBody>
+          <a:bodyPr xmlns:a="http://schemas.openxmlformats.org/drawingml/2006/main"/>
+          <a:lstStyle xmlns:a="http://schemas.openxmlformats.org/drawingml/2006/main"/>
+          <a:p xmlns:a="http://schemas.openxmlformats.org/drawingml/2006/main">
+            <a:pPr>
+              <a:defRPr sz="1500">
+                <a:solidFill>
+                  <a:srgbClr val="DBE4EF"/>
+                </a:solidFill>
+              </a:defRPr>
+            </a:pPr>
+            <a:r>
+              <a:rPr sz="1500">
+                <a:solidFill>
+                  <a:srgbClr val="DBE4EF"/>
+                </a:solidFill>
+              </a:rPr>
+              <a:t>Anlık robot durumu</a:t>
+            </a:r>
+          </a:p>
+        </p:txBody>
+      </p:sp>
+      <p:sp>
+        <p:nvSpPr>
+          <p:cNvPr id="113" name="readable-summary-dot-3-1">
+            <a:extLst xmlns:a="http://schemas.openxmlformats.org/drawingml/2006/main">
+              <a:ext uri="{FF2B5EF4-FFF2-40B4-BE49-F238E27FC236}">
+                <a16:creationId xmlns:a16="http://schemas.microsoft.com/office/drawing/2014/main" id="{23A360EB-516A-4CEC-B13F-467CA6F4C2D1}"/>
+              </a:ext>
+            </a:extLst>
+          </p:cNvPr>
+          <p:cNvSpPr>
+            <a:spLocks xmlns:a="http://schemas.openxmlformats.org/drawingml/2006/main" noGrp="1"/>
+          </p:cNvSpPr>
+          <p:nvPr/>
+        </p:nvSpPr>
+        <p:spPr>
+          <a:xfrm xmlns:a="http://schemas.openxmlformats.org/drawingml/2006/main">
+            <a:off x="790575" y="5581650"/>
+            <a:ext cx="76200" cy="76200"/>
+          </a:xfrm>
+          <a:prstGeom xmlns:a="http://schemas.openxmlformats.org/drawingml/2006/main" prst="ellipse">
+            <a:avLst/>
+          </a:prstGeom>
+          <a:solidFill xmlns:a="http://schemas.openxmlformats.org/drawingml/2006/main">
+            <a:srgbClr val="22C55E"/>
+          </a:solidFill>
+          <a:ln xmlns:a="http://schemas.openxmlformats.org/drawingml/2006/main" w="0">
+            <a:noFill/>
+            <a:prstDash val="solid"/>
+          </a:ln>
+        </p:spPr>
+      </p:sp>
+      <p:sp>
+        <p:nvSpPr>
+          <p:cNvPr id="114" name="readable-summary-item-3-1">
+            <a:extLst xmlns:a="http://schemas.openxmlformats.org/drawingml/2006/main">
+              <a:ext uri="{FF2B5EF4-FFF2-40B4-BE49-F238E27FC236}">
+                <a16:creationId xmlns:a16="http://schemas.microsoft.com/office/drawing/2014/main" id="{ED1210F5-2B2C-47D7-8A9B-137991188BD6}"/>
+              </a:ext>
+            </a:extLst>
+          </p:cNvPr>
+          <p:cNvSpPr>
+            <a:spLocks xmlns:a="http://schemas.openxmlformats.org/drawingml/2006/main" noGrp="1"/>
+          </p:cNvSpPr>
+          <p:nvPr/>
+        </p:nvSpPr>
+        <p:spPr>
+          <a:xfrm xmlns:a="http://schemas.openxmlformats.org/drawingml/2006/main">
+            <a:off x="990600" y="5505450"/>
+            <a:ext cx="4476750" cy="266700"/>
+          </a:xfrm>
+          <a:prstGeom xmlns:a="http://schemas.openxmlformats.org/drawingml/2006/main" prst="rect">
+            <a:avLst/>
+          </a:prstGeom>
+          <a:noFill xmlns:a="http://schemas.openxmlformats.org/drawingml/2006/main"/>
+          <a:ln xmlns:a="http://schemas.openxmlformats.org/drawingml/2006/main" w="0">
+            <a:noFill/>
+            <a:prstDash val="solid"/>
+          </a:ln>
+        </p:spPr>
+        <p:txBody>
+          <a:bodyPr xmlns:a="http://schemas.openxmlformats.org/drawingml/2006/main"/>
+          <a:lstStyle xmlns:a="http://schemas.openxmlformats.org/drawingml/2006/main"/>
+          <a:p xmlns:a="http://schemas.openxmlformats.org/drawingml/2006/main">
+            <a:pPr>
+              <a:defRPr sz="1500">
+                <a:solidFill>
+                  <a:srgbClr val="DBE4EF"/>
+                </a:solidFill>
+              </a:defRPr>
+            </a:pPr>
+            <a:r>
+              <a:rPr sz="1500">
+                <a:solidFill>
+                  <a:srgbClr val="DBE4EF"/>
+                </a:solidFill>
+              </a:rPr>
+              <a:t>Sistem sağlığı</a:t>
+            </a:r>
+          </a:p>
+        </p:txBody>
+      </p:sp>
+      <p:sp>
+        <p:nvSpPr>
+          <p:cNvPr id="115" name="readable-summary-dot-3-2">
+            <a:extLst xmlns:a="http://schemas.openxmlformats.org/drawingml/2006/main">
+              <a:ext uri="{FF2B5EF4-FFF2-40B4-BE49-F238E27FC236}">
+                <a16:creationId xmlns:a16="http://schemas.microsoft.com/office/drawing/2014/main" id="{E575D08E-4289-47C6-8A80-E6DE98BE0FA4}"/>
+              </a:ext>
+            </a:extLst>
+          </p:cNvPr>
+          <p:cNvSpPr>
+            <a:spLocks xmlns:a="http://schemas.openxmlformats.org/drawingml/2006/main" noGrp="1"/>
+          </p:cNvSpPr>
+          <p:nvPr/>
+        </p:nvSpPr>
+        <p:spPr>
+          <a:xfrm xmlns:a="http://schemas.openxmlformats.org/drawingml/2006/main">
+            <a:off x="790575" y="5924550"/>
+            <a:ext cx="76200" cy="76200"/>
+          </a:xfrm>
+          <a:prstGeom xmlns:a="http://schemas.openxmlformats.org/drawingml/2006/main" prst="ellipse">
+            <a:avLst/>
+          </a:prstGeom>
+          <a:solidFill xmlns:a="http://schemas.openxmlformats.org/drawingml/2006/main">
+            <a:srgbClr val="22C55E"/>
+          </a:solidFill>
+          <a:ln xmlns:a="http://schemas.openxmlformats.org/drawingml/2006/main" w="0">
+            <a:noFill/>
+            <a:prstDash val="solid"/>
+          </a:ln>
+        </p:spPr>
+      </p:sp>
+      <p:sp>
+        <p:nvSpPr>
+          <p:cNvPr id="116" name="readable-summary-item-3-2">
+            <a:extLst xmlns:a="http://schemas.openxmlformats.org/drawingml/2006/main">
+              <a:ext uri="{FF2B5EF4-FFF2-40B4-BE49-F238E27FC236}">
+                <a16:creationId xmlns:a16="http://schemas.microsoft.com/office/drawing/2014/main" id="{243EB5D9-DAB5-4643-BB09-22D1E3474115}"/>
+              </a:ext>
+            </a:extLst>
+          </p:cNvPr>
+          <p:cNvSpPr>
+            <a:spLocks xmlns:a="http://schemas.openxmlformats.org/drawingml/2006/main" noGrp="1"/>
+          </p:cNvSpPr>
+          <p:nvPr/>
+        </p:nvSpPr>
+        <p:spPr>
+          <a:xfrm xmlns:a="http://schemas.openxmlformats.org/drawingml/2006/main">
+            <a:off x="990600" y="5848350"/>
+            <a:ext cx="4476750" cy="266700"/>
+          </a:xfrm>
+          <a:prstGeom xmlns:a="http://schemas.openxmlformats.org/drawingml/2006/main" prst="rect">
+            <a:avLst/>
+          </a:prstGeom>
+          <a:noFill xmlns:a="http://schemas.openxmlformats.org/drawingml/2006/main"/>
+          <a:ln xmlns:a="http://schemas.openxmlformats.org/drawingml/2006/main" w="0">
+            <a:noFill/>
+            <a:prstDash val="solid"/>
+          </a:ln>
+        </p:spPr>
+        <p:txBody>
+          <a:bodyPr xmlns:a="http://schemas.openxmlformats.org/drawingml/2006/main"/>
+          <a:lstStyle xmlns:a="http://schemas.openxmlformats.org/drawingml/2006/main"/>
+          <a:p xmlns:a="http://schemas.openxmlformats.org/drawingml/2006/main">
+            <a:pPr>
+              <a:defRPr sz="1500">
+                <a:solidFill>
+                  <a:srgbClr val="DBE4EF"/>
+                </a:solidFill>
+              </a:defRPr>
+            </a:pPr>
+            <a:r>
+              <a:rPr sz="1500">
+                <a:solidFill>
+                  <a:srgbClr val="DBE4EF"/>
+                </a:solidFill>
+              </a:rPr>
+              <a:t>Log ve hata görünürlüğü</a:t>
+            </a:r>
+          </a:p>
+        </p:txBody>
+      </p:sp>
+      <p:sp>
+        <p:nvSpPr>
+          <p:cNvPr id="117" name="readable-summary-block-4">
+            <a:extLst xmlns:a="http://schemas.openxmlformats.org/drawingml/2006/main">
+              <a:ext uri="{FF2B5EF4-FFF2-40B4-BE49-F238E27FC236}">
+                <a16:creationId xmlns:a16="http://schemas.microsoft.com/office/drawing/2014/main" id="{01D787B7-DEF1-4E3F-80DE-2D2E640854A3}"/>
+              </a:ext>
+            </a:extLst>
+          </p:cNvPr>
+          <p:cNvSpPr>
+            <a:spLocks xmlns:a="http://schemas.openxmlformats.org/drawingml/2006/main" noGrp="1"/>
+          </p:cNvSpPr>
+          <p:nvPr/>
+        </p:nvSpPr>
+        <p:spPr>
+          <a:xfrm xmlns:a="http://schemas.openxmlformats.org/drawingml/2006/main">
+            <a:off x="6381750" y="4324350"/>
+            <a:ext cx="5257800" cy="1943100"/>
+          </a:xfrm>
+          <a:prstGeom xmlns:a="http://schemas.openxmlformats.org/drawingml/2006/main" prst="roundRect">
+            <a:avLst>
+              <a:gd name="adj" fmla="val 3922"/>
+            </a:avLst>
+          </a:prstGeom>
+          <a:solidFill xmlns:a="http://schemas.openxmlformats.org/drawingml/2006/main">
+            <a:srgbClr val="111822"/>
+          </a:solidFill>
+          <a:ln xmlns:a="http://schemas.openxmlformats.org/drawingml/2006/main" w="9525">
+            <a:solidFill>
+              <a:srgbClr val="1F2937"/>
+            </a:solidFill>
+            <a:prstDash val="solid"/>
+          </a:ln>
+        </p:spPr>
+      </p:sp>
+      <p:sp>
+        <p:nvSpPr>
+          <p:cNvPr id="118" name="readable-summary-accent-4">
+            <a:extLst xmlns:a="http://schemas.openxmlformats.org/drawingml/2006/main">
+              <a:ext uri="{FF2B5EF4-FFF2-40B4-BE49-F238E27FC236}">
+                <a16:creationId xmlns:a16="http://schemas.microsoft.com/office/drawing/2014/main" id="{09C73115-0D63-4D76-8E2E-567F50441E39}"/>
+              </a:ext>
+            </a:extLst>
+          </p:cNvPr>
+          <p:cNvSpPr>
+            <a:spLocks xmlns:a="http://schemas.openxmlformats.org/drawingml/2006/main" noGrp="1"/>
+          </p:cNvSpPr>
+          <p:nvPr/>
+        </p:nvSpPr>
+        <p:spPr>
+          <a:xfrm xmlns:a="http://schemas.openxmlformats.org/drawingml/2006/main">
+            <a:off x="6591300" y="4533900"/>
+            <a:ext cx="1143000" cy="47625"/>
+          </a:xfrm>
+          <a:prstGeom xmlns:a="http://schemas.openxmlformats.org/drawingml/2006/main" prst="rect">
+            <a:avLst/>
+          </a:prstGeom>
+          <a:solidFill xmlns:a="http://schemas.openxmlformats.org/drawingml/2006/main">
+            <a:srgbClr val="F97316"/>
+          </a:solidFill>
+          <a:ln xmlns:a="http://schemas.openxmlformats.org/drawingml/2006/main" w="0">
+            <a:noFill/>
+            <a:prstDash val="solid"/>
+          </a:ln>
+        </p:spPr>
+      </p:sp>
+      <p:sp>
+        <p:nvSpPr>
+          <p:cNvPr id="119" name="readable-summary-title-4">
+            <a:extLst xmlns:a="http://schemas.openxmlformats.org/drawingml/2006/main">
+              <a:ext uri="{FF2B5EF4-FFF2-40B4-BE49-F238E27FC236}">
+                <a16:creationId xmlns:a16="http://schemas.microsoft.com/office/drawing/2014/main" id="{350929BB-3D7F-49E4-AC34-B16EA1B239E7}"/>
+              </a:ext>
+            </a:extLst>
+          </p:cNvPr>
+          <p:cNvSpPr>
+            <a:spLocks xmlns:a="http://schemas.openxmlformats.org/drawingml/2006/main" noGrp="1"/>
+          </p:cNvSpPr>
+          <p:nvPr/>
+        </p:nvSpPr>
+        <p:spPr>
+          <a:xfrm xmlns:a="http://schemas.openxmlformats.org/drawingml/2006/main">
+            <a:off x="6591300" y="4724400"/>
+            <a:ext cx="4762500" cy="304800"/>
+          </a:xfrm>
+          <a:prstGeom xmlns:a="http://schemas.openxmlformats.org/drawingml/2006/main" prst="rect">
+            <a:avLst/>
+          </a:prstGeom>
+          <a:noFill xmlns:a="http://schemas.openxmlformats.org/drawingml/2006/main"/>
+          <a:ln xmlns:a="http://schemas.openxmlformats.org/drawingml/2006/main" w="0">
+            <a:noFill/>
+            <a:prstDash val="solid"/>
+          </a:ln>
+        </p:spPr>
+        <p:txBody>
+          <a:bodyPr xmlns:a="http://schemas.openxmlformats.org/drawingml/2006/main"/>
+          <a:lstStyle xmlns:a="http://schemas.openxmlformats.org/drawingml/2006/main"/>
+          <a:p xmlns:a="http://schemas.openxmlformats.org/drawingml/2006/main">
+            <a:pPr>
+              <a:defRPr sz="1875" b="1">
+                <a:solidFill>
+                  <a:srgbClr val="FFFFFF"/>
+                </a:solidFill>
+              </a:defRPr>
+            </a:pPr>
+            <a:r>
+              <a:rPr sz="1875" b="1">
+                <a:solidFill>
+                  <a:srgbClr val="FFFFFF"/>
+                </a:solidFill>
+              </a:rPr>
+              <a:t>Entegrasyon ve Demo</a:t>
+            </a:r>
+          </a:p>
+        </p:txBody>
+      </p:sp>
+      <p:sp>
+        <p:nvSpPr>
+          <p:cNvPr id="120" name="readable-summary-dot-4-0">
+            <a:extLst xmlns:a="http://schemas.openxmlformats.org/drawingml/2006/main">
+              <a:ext uri="{FF2B5EF4-FFF2-40B4-BE49-F238E27FC236}">
+                <a16:creationId xmlns:a16="http://schemas.microsoft.com/office/drawing/2014/main" id="{FEDD0B10-C167-46EA-89A1-7B933C90225A}"/>
+              </a:ext>
+            </a:extLst>
+          </p:cNvPr>
+          <p:cNvSpPr>
+            <a:spLocks xmlns:a="http://schemas.openxmlformats.org/drawingml/2006/main" noGrp="1"/>
+          </p:cNvSpPr>
+          <p:nvPr/>
+        </p:nvSpPr>
+        <p:spPr>
+          <a:xfrm xmlns:a="http://schemas.openxmlformats.org/drawingml/2006/main">
+            <a:off x="6619875" y="5238750"/>
+            <a:ext cx="76200" cy="76200"/>
+          </a:xfrm>
+          <a:prstGeom xmlns:a="http://schemas.openxmlformats.org/drawingml/2006/main" prst="ellipse">
+            <a:avLst/>
+          </a:prstGeom>
+          <a:solidFill xmlns:a="http://schemas.openxmlformats.org/drawingml/2006/main">
+            <a:srgbClr val="F97316"/>
+          </a:solidFill>
+          <a:ln xmlns:a="http://schemas.openxmlformats.org/drawingml/2006/main" w="0">
+            <a:noFill/>
+            <a:prstDash val="solid"/>
+          </a:ln>
+        </p:spPr>
+      </p:sp>
+      <p:sp>
+        <p:nvSpPr>
+          <p:cNvPr id="121" name="readable-summary-item-4-0">
+            <a:extLst xmlns:a="http://schemas.openxmlformats.org/drawingml/2006/main">
+              <a:ext uri="{FF2B5EF4-FFF2-40B4-BE49-F238E27FC236}">
+                <a16:creationId xmlns:a16="http://schemas.microsoft.com/office/drawing/2014/main" id="{9AB95D9E-3A2F-48A4-81F9-1CA4468C94F6}"/>
+              </a:ext>
+            </a:extLst>
+          </p:cNvPr>
+          <p:cNvSpPr>
+            <a:spLocks xmlns:a="http://schemas.openxmlformats.org/drawingml/2006/main" noGrp="1"/>
+          </p:cNvSpPr>
+          <p:nvPr/>
+        </p:nvSpPr>
+        <p:spPr>
+          <a:xfrm xmlns:a="http://schemas.openxmlformats.org/drawingml/2006/main">
+            <a:off x="6819900" y="5162550"/>
+            <a:ext cx="4476750" cy="266700"/>
+          </a:xfrm>
+          <a:prstGeom xmlns:a="http://schemas.openxmlformats.org/drawingml/2006/main" prst="rect">
+            <a:avLst/>
+          </a:prstGeom>
+          <a:noFill xmlns:a="http://schemas.openxmlformats.org/drawingml/2006/main"/>
+          <a:ln xmlns:a="http://schemas.openxmlformats.org/drawingml/2006/main" w="0">
+            <a:noFill/>
+            <a:prstDash val="solid"/>
+          </a:ln>
+        </p:spPr>
+        <p:txBody>
+          <a:bodyPr xmlns:a="http://schemas.openxmlformats.org/drawingml/2006/main"/>
+          <a:lstStyle xmlns:a="http://schemas.openxmlformats.org/drawingml/2006/main"/>
+          <a:p xmlns:a="http://schemas.openxmlformats.org/drawingml/2006/main">
+            <a:pPr>
+              <a:defRPr sz="1500">
+                <a:solidFill>
+                  <a:srgbClr val="DBE4EF"/>
+                </a:solidFill>
+              </a:defRPr>
+            </a:pPr>
+            <a:r>
+              <a:rPr sz="1500">
+                <a:solidFill>
+                  <a:srgbClr val="DBE4EF"/>
+                </a:solidFill>
+              </a:rPr>
+              <a:t>ROS Visibility</a:t>
+            </a:r>
+          </a:p>
+        </p:txBody>
+      </p:sp>
+      <p:sp>
+        <p:nvSpPr>
+          <p:cNvPr id="122" name="readable-summary-dot-4-1">
+            <a:extLst xmlns:a="http://schemas.openxmlformats.org/drawingml/2006/main">
+              <a:ext uri="{FF2B5EF4-FFF2-40B4-BE49-F238E27FC236}">
+                <a16:creationId xmlns:a16="http://schemas.microsoft.com/office/drawing/2014/main" id="{6026E1BB-4D03-4FB7-94C0-48017EA3DE5E}"/>
+              </a:ext>
+            </a:extLst>
+          </p:cNvPr>
+          <p:cNvSpPr>
+            <a:spLocks xmlns:a="http://schemas.openxmlformats.org/drawingml/2006/main" noGrp="1"/>
+          </p:cNvSpPr>
+          <p:nvPr/>
+        </p:nvSpPr>
+        <p:spPr>
+          <a:xfrm xmlns:a="http://schemas.openxmlformats.org/drawingml/2006/main">
+            <a:off x="6619875" y="5581650"/>
+            <a:ext cx="76200" cy="76200"/>
+          </a:xfrm>
+          <a:prstGeom xmlns:a="http://schemas.openxmlformats.org/drawingml/2006/main" prst="ellipse">
+            <a:avLst/>
+          </a:prstGeom>
+          <a:solidFill xmlns:a="http://schemas.openxmlformats.org/drawingml/2006/main">
+            <a:srgbClr val="F97316"/>
+          </a:solidFill>
+          <a:ln xmlns:a="http://schemas.openxmlformats.org/drawingml/2006/main" w="0">
+            <a:noFill/>
+            <a:prstDash val="solid"/>
+          </a:ln>
+        </p:spPr>
+      </p:sp>
+      <p:sp>
+        <p:nvSpPr>
+          <p:cNvPr id="123" name="readable-summary-item-4-1">
+            <a:extLst xmlns:a="http://schemas.openxmlformats.org/drawingml/2006/main">
+              <a:ext uri="{FF2B5EF4-FFF2-40B4-BE49-F238E27FC236}">
+                <a16:creationId xmlns:a16="http://schemas.microsoft.com/office/drawing/2014/main" id="{FD7BF46F-14FB-4B60-8574-6FE0B64DAAC4}"/>
+              </a:ext>
+            </a:extLst>
+          </p:cNvPr>
+          <p:cNvSpPr>
+            <a:spLocks xmlns:a="http://schemas.openxmlformats.org/drawingml/2006/main" noGrp="1"/>
+          </p:cNvSpPr>
+          <p:nvPr/>
+        </p:nvSpPr>
+        <p:spPr>
+          <a:xfrm xmlns:a="http://schemas.openxmlformats.org/drawingml/2006/main">
+            <a:off x="6819900" y="5505450"/>
+            <a:ext cx="4476750" cy="266700"/>
+          </a:xfrm>
+          <a:prstGeom xmlns:a="http://schemas.openxmlformats.org/drawingml/2006/main" prst="rect">
+            <a:avLst/>
+          </a:prstGeom>
+          <a:noFill xmlns:a="http://schemas.openxmlformats.org/drawingml/2006/main"/>
+          <a:ln xmlns:a="http://schemas.openxmlformats.org/drawingml/2006/main" w="0">
+            <a:noFill/>
+            <a:prstDash val="solid"/>
+          </a:ln>
+        </p:spPr>
+        <p:txBody>
+          <a:bodyPr xmlns:a="http://schemas.openxmlformats.org/drawingml/2006/main"/>
+          <a:lstStyle xmlns:a="http://schemas.openxmlformats.org/drawingml/2006/main"/>
+          <a:p xmlns:a="http://schemas.openxmlformats.org/drawingml/2006/main">
+            <a:pPr>
+              <a:defRPr sz="1500">
+                <a:solidFill>
+                  <a:srgbClr val="DBE4EF"/>
+                </a:solidFill>
+              </a:defRPr>
+            </a:pPr>
+            <a:r>
+              <a:rPr sz="1500">
+                <a:solidFill>
+                  <a:srgbClr val="DBE4EF"/>
+                </a:solidFill>
+              </a:rPr>
+              <a:t>Modüler kontrol katmanları</a:t>
+            </a:r>
+          </a:p>
+        </p:txBody>
+      </p:sp>
+      <p:sp>
+        <p:nvSpPr>
+          <p:cNvPr id="124" name="readable-summary-dot-4-2">
+            <a:extLst xmlns:a="http://schemas.openxmlformats.org/drawingml/2006/main">
+              <a:ext uri="{FF2B5EF4-FFF2-40B4-BE49-F238E27FC236}">
+                <a16:creationId xmlns:a16="http://schemas.microsoft.com/office/drawing/2014/main" id="{35DCAEBE-A549-47CC-AB1B-88B94CB5EEC8}"/>
+              </a:ext>
+            </a:extLst>
+          </p:cNvPr>
+          <p:cNvSpPr>
+            <a:spLocks xmlns:a="http://schemas.openxmlformats.org/drawingml/2006/main" noGrp="1"/>
+          </p:cNvSpPr>
+          <p:nvPr/>
+        </p:nvSpPr>
+        <p:spPr>
+          <a:xfrm xmlns:a="http://schemas.openxmlformats.org/drawingml/2006/main">
+            <a:off x="6619875" y="5924550"/>
+            <a:ext cx="76200" cy="76200"/>
+          </a:xfrm>
+          <a:prstGeom xmlns:a="http://schemas.openxmlformats.org/drawingml/2006/main" prst="ellipse">
+            <a:avLst/>
+          </a:prstGeom>
+          <a:solidFill xmlns:a="http://schemas.openxmlformats.org/drawingml/2006/main">
+            <a:srgbClr val="F97316"/>
+          </a:solidFill>
+          <a:ln xmlns:a="http://schemas.openxmlformats.org/drawingml/2006/main" w="0">
+            <a:noFill/>
+            <a:prstDash val="solid"/>
+          </a:ln>
+        </p:spPr>
+      </p:sp>
+      <p:sp>
+        <p:nvSpPr>
+          <p:cNvPr id="125" name="readable-summary-item-4-2">
+            <a:extLst xmlns:a="http://schemas.openxmlformats.org/drawingml/2006/main">
+              <a:ext uri="{FF2B5EF4-FFF2-40B4-BE49-F238E27FC236}">
+                <a16:creationId xmlns:a16="http://schemas.microsoft.com/office/drawing/2014/main" id="{E40C75FF-89FC-48FE-9B24-1E53EA36C1B9}"/>
+              </a:ext>
+            </a:extLst>
+          </p:cNvPr>
+          <p:cNvSpPr>
+            <a:spLocks xmlns:a="http://schemas.openxmlformats.org/drawingml/2006/main" noGrp="1"/>
+          </p:cNvSpPr>
+          <p:nvPr/>
+        </p:nvSpPr>
+        <p:spPr>
+          <a:xfrm xmlns:a="http://schemas.openxmlformats.org/drawingml/2006/main">
+            <a:off x="6819900" y="5848350"/>
+            <a:ext cx="4476750" cy="266700"/>
+          </a:xfrm>
+          <a:prstGeom xmlns:a="http://schemas.openxmlformats.org/drawingml/2006/main" prst="rect">
+            <a:avLst/>
+          </a:prstGeom>
+          <a:noFill xmlns:a="http://schemas.openxmlformats.org/drawingml/2006/main"/>
+          <a:ln xmlns:a="http://schemas.openxmlformats.org/drawingml/2006/main" w="0">
+            <a:noFill/>
+            <a:prstDash val="solid"/>
+          </a:ln>
+        </p:spPr>
+        <p:txBody>
+          <a:bodyPr xmlns:a="http://schemas.openxmlformats.org/drawingml/2006/main"/>
+          <a:lstStyle xmlns:a="http://schemas.openxmlformats.org/drawingml/2006/main"/>
+          <a:p xmlns:a="http://schemas.openxmlformats.org/drawingml/2006/main">
+            <a:pPr>
+              <a:defRPr sz="1500">
+                <a:solidFill>
+                  <a:srgbClr val="DBE4EF"/>
+                </a:solidFill>
+              </a:defRPr>
+            </a:pPr>
+            <a:r>
+              <a:rPr sz="1500">
+                <a:solidFill>
+                  <a:srgbClr val="DBE4EF"/>
+                </a:solidFill>
+              </a:rPr>
+              <a:t>Demo-ready ürün hissi</a:t>
             </a:r>
           </a:p>
         </p:txBody>

</xml_diff>

<commit_message>
Update Unitree deck teleoperation intro
</commit_message>
<xml_diff>
--- a/docs/presentations/Unitree-H1-Feature-Deck-v2.pptx
+++ b/docs/presentations/Unitree-H1-Feature-Deck-v2.pptx
@@ -2,19 +2,16 @@
 <file path=ppt/presentation.xml><?xml version="1.0" encoding="utf-8"?>
 <p:presentation xmlns:p="http://schemas.openxmlformats.org/presentationml/2006/main">
   <p:sldMasterIdLst>
-    <p:sldMasterId xmlns:r="http://schemas.openxmlformats.org/officeDocument/2006/relationships" id="2147483648" r:id="Rcd28775364254e38"/>
+    <p:sldMasterId xmlns:r="http://schemas.openxmlformats.org/officeDocument/2006/relationships" id="2147483648" r:id="R24d431db9af3406e"/>
   </p:sldMasterIdLst>
   <p:notesMasterIdLst>
-    <p:notesMasterId xmlns:r="http://schemas.openxmlformats.org/officeDocument/2006/relationships" r:id="Rbc37d91d4a90491b"/>
+    <p:notesMasterId xmlns:r="http://schemas.openxmlformats.org/officeDocument/2006/relationships" r:id="R93b8855e66c046f6"/>
   </p:notesMasterIdLst>
   <p:sldIdLst>
-    <p:sldId xmlns:r="http://schemas.openxmlformats.org/officeDocument/2006/relationships" id="256" r:id="Rdc5d718d2e7e4fb9"/>
-    <p:sldId xmlns:r="http://schemas.openxmlformats.org/officeDocument/2006/relationships" id="257" r:id="Rf5678d10d4f248ac"/>
-    <p:sldId xmlns:r="http://schemas.openxmlformats.org/officeDocument/2006/relationships" id="258" r:id="Rc7e73f86f6ce486f"/>
-    <p:sldId xmlns:r="http://schemas.openxmlformats.org/officeDocument/2006/relationships" id="259" r:id="R1b6d3e9e0d034260"/>
-    <p:sldId xmlns:r="http://schemas.openxmlformats.org/officeDocument/2006/relationships" id="260" r:id="R262a19597abc47d0"/>
-    <p:sldId xmlns:r="http://schemas.openxmlformats.org/officeDocument/2006/relationships" id="261" r:id="Ra80c764aa98a44aa"/>
-    <p:sldId xmlns:r="http://schemas.openxmlformats.org/officeDocument/2006/relationships" id="262" r:id="Re99c09358c0b4ff4"/>
+    <p:sldId xmlns:r="http://schemas.openxmlformats.org/officeDocument/2006/relationships" id="256" r:id="R88f2b6d67c774c5b"/>
+    <p:sldId xmlns:r="http://schemas.openxmlformats.org/officeDocument/2006/relationships" id="257" r:id="R65eda291838c4209"/>
+    <p:sldId xmlns:r="http://schemas.openxmlformats.org/officeDocument/2006/relationships" id="258" r:id="Rc96c792c534d424a"/>
+    <p:sldId xmlns:r="http://schemas.openxmlformats.org/officeDocument/2006/relationships" id="259" r:id="R8dbd919872ca4e54"/>
   </p:sldIdLst>
   <p:sldSz cx="12192000" cy="6858000"/>
   <p:notesSz cx="6858000" cy="9144000"/>
@@ -767,204 +764,6 @@
 </p:notes>
 </file>
 
-<file path=ppt/notesSlides/notesSlide5.xml><?xml version="1.0" encoding="utf-8"?>
-<p:notes xmlns:p="http://schemas.openxmlformats.org/presentationml/2006/main">
-  <p:cSld>
-    <p:spTree>
-      <p:nvGrpSpPr>
-        <p:cNvPr id="1" name=""/>
-        <p:cNvGrpSpPr/>
-        <p:nvPr/>
-      </p:nvGrpSpPr>
-      <p:grpSpPr>
-        <a:xfrm xmlns:a="http://schemas.openxmlformats.org/drawingml/2006/main"/>
-      </p:grpSpPr>
-      <p:sp>
-        <p:nvSpPr>
-          <p:cNvPr id="2" name="Slide Image Placeholder 1"/>
-          <p:cNvSpPr>
-            <a:spLocks xmlns:a="http://schemas.openxmlformats.org/drawingml/2006/main" noGrp="1"/>
-          </p:cNvSpPr>
-          <p:nvPr>
-            <p:ph type="sldImg" idx="0"/>
-          </p:nvPr>
-        </p:nvSpPr>
-        <p:spPr/>
-      </p:sp>
-      <p:sp>
-        <p:nvSpPr>
-          <p:cNvPr id="3" name="Notes Placeholder 2"/>
-          <p:cNvSpPr>
-            <a:spLocks xmlns:a="http://schemas.openxmlformats.org/drawingml/2006/main" noGrp="1"/>
-          </p:cNvSpPr>
-          <p:nvPr>
-            <p:ph type="body" idx="1"/>
-          </p:nvPr>
-        </p:nvSpPr>
-        <p:spPr/>
-        <p:txBody>
-          <a:bodyPr xmlns:a="http://schemas.openxmlformats.org/drawingml/2006/main"/>
-          <a:lstStyle xmlns:a="http://schemas.openxmlformats.org/drawingml/2006/main"/>
-          <a:p xmlns:a="http://schemas.openxmlformats.org/drawingml/2006/main"/>
-        </p:txBody>
-      </p:sp>
-      <p:sp>
-        <p:nvSpPr>
-          <p:cNvPr id="4" name="Slide Number Placeholder 3"/>
-          <p:cNvSpPr>
-            <a:spLocks xmlns:a="http://schemas.openxmlformats.org/drawingml/2006/main" noGrp="1"/>
-          </p:cNvSpPr>
-          <p:nvPr>
-            <p:ph type="sldNum" idx="5"/>
-          </p:nvPr>
-        </p:nvSpPr>
-        <p:spPr/>
-        <p:txBody>
-          <a:bodyPr xmlns:a="http://schemas.openxmlformats.org/drawingml/2006/main"/>
-          <a:lstStyle xmlns:a="http://schemas.openxmlformats.org/drawingml/2006/main"/>
-          <a:p xmlns:a="http://schemas.openxmlformats.org/drawingml/2006/main"/>
-        </p:txBody>
-      </p:sp>
-    </p:spTree>
-  </p:cSld>
-  <p:clrMapOvr>
-    <a:masterClrMapping xmlns:a="http://schemas.openxmlformats.org/drawingml/2006/main"/>
-  </p:clrMapOvr>
-</p:notes>
-</file>
-
-<file path=ppt/notesSlides/notesSlide6.xml><?xml version="1.0" encoding="utf-8"?>
-<p:notes xmlns:p="http://schemas.openxmlformats.org/presentationml/2006/main">
-  <p:cSld>
-    <p:spTree>
-      <p:nvGrpSpPr>
-        <p:cNvPr id="1" name=""/>
-        <p:cNvGrpSpPr/>
-        <p:nvPr/>
-      </p:nvGrpSpPr>
-      <p:grpSpPr>
-        <a:xfrm xmlns:a="http://schemas.openxmlformats.org/drawingml/2006/main"/>
-      </p:grpSpPr>
-      <p:sp>
-        <p:nvSpPr>
-          <p:cNvPr id="2" name="Slide Image Placeholder 1"/>
-          <p:cNvSpPr>
-            <a:spLocks xmlns:a="http://schemas.openxmlformats.org/drawingml/2006/main" noGrp="1"/>
-          </p:cNvSpPr>
-          <p:nvPr>
-            <p:ph type="sldImg" idx="0"/>
-          </p:nvPr>
-        </p:nvSpPr>
-        <p:spPr/>
-      </p:sp>
-      <p:sp>
-        <p:nvSpPr>
-          <p:cNvPr id="3" name="Notes Placeholder 2"/>
-          <p:cNvSpPr>
-            <a:spLocks xmlns:a="http://schemas.openxmlformats.org/drawingml/2006/main" noGrp="1"/>
-          </p:cNvSpPr>
-          <p:nvPr>
-            <p:ph type="body" idx="1"/>
-          </p:nvPr>
-        </p:nvSpPr>
-        <p:spPr/>
-        <p:txBody>
-          <a:bodyPr xmlns:a="http://schemas.openxmlformats.org/drawingml/2006/main"/>
-          <a:lstStyle xmlns:a="http://schemas.openxmlformats.org/drawingml/2006/main"/>
-          <a:p xmlns:a="http://schemas.openxmlformats.org/drawingml/2006/main"/>
-        </p:txBody>
-      </p:sp>
-      <p:sp>
-        <p:nvSpPr>
-          <p:cNvPr id="4" name="Slide Number Placeholder 3"/>
-          <p:cNvSpPr>
-            <a:spLocks xmlns:a="http://schemas.openxmlformats.org/drawingml/2006/main" noGrp="1"/>
-          </p:cNvSpPr>
-          <p:nvPr>
-            <p:ph type="sldNum" idx="5"/>
-          </p:nvPr>
-        </p:nvSpPr>
-        <p:spPr/>
-        <p:txBody>
-          <a:bodyPr xmlns:a="http://schemas.openxmlformats.org/drawingml/2006/main"/>
-          <a:lstStyle xmlns:a="http://schemas.openxmlformats.org/drawingml/2006/main"/>
-          <a:p xmlns:a="http://schemas.openxmlformats.org/drawingml/2006/main"/>
-        </p:txBody>
-      </p:sp>
-    </p:spTree>
-  </p:cSld>
-  <p:clrMapOvr>
-    <a:masterClrMapping xmlns:a="http://schemas.openxmlformats.org/drawingml/2006/main"/>
-  </p:clrMapOvr>
-</p:notes>
-</file>
-
-<file path=ppt/notesSlides/notesSlide7.xml><?xml version="1.0" encoding="utf-8"?>
-<p:notes xmlns:p="http://schemas.openxmlformats.org/presentationml/2006/main">
-  <p:cSld>
-    <p:spTree>
-      <p:nvGrpSpPr>
-        <p:cNvPr id="1" name=""/>
-        <p:cNvGrpSpPr/>
-        <p:nvPr/>
-      </p:nvGrpSpPr>
-      <p:grpSpPr>
-        <a:xfrm xmlns:a="http://schemas.openxmlformats.org/drawingml/2006/main"/>
-      </p:grpSpPr>
-      <p:sp>
-        <p:nvSpPr>
-          <p:cNvPr id="2" name="Slide Image Placeholder 1"/>
-          <p:cNvSpPr>
-            <a:spLocks xmlns:a="http://schemas.openxmlformats.org/drawingml/2006/main" noGrp="1"/>
-          </p:cNvSpPr>
-          <p:nvPr>
-            <p:ph type="sldImg" idx="0"/>
-          </p:nvPr>
-        </p:nvSpPr>
-        <p:spPr/>
-      </p:sp>
-      <p:sp>
-        <p:nvSpPr>
-          <p:cNvPr id="3" name="Notes Placeholder 2"/>
-          <p:cNvSpPr>
-            <a:spLocks xmlns:a="http://schemas.openxmlformats.org/drawingml/2006/main" noGrp="1"/>
-          </p:cNvSpPr>
-          <p:nvPr>
-            <p:ph type="body" idx="1"/>
-          </p:nvPr>
-        </p:nvSpPr>
-        <p:spPr/>
-        <p:txBody>
-          <a:bodyPr xmlns:a="http://schemas.openxmlformats.org/drawingml/2006/main"/>
-          <a:lstStyle xmlns:a="http://schemas.openxmlformats.org/drawingml/2006/main"/>
-          <a:p xmlns:a="http://schemas.openxmlformats.org/drawingml/2006/main"/>
-        </p:txBody>
-      </p:sp>
-      <p:sp>
-        <p:nvSpPr>
-          <p:cNvPr id="4" name="Slide Number Placeholder 3"/>
-          <p:cNvSpPr>
-            <a:spLocks xmlns:a="http://schemas.openxmlformats.org/drawingml/2006/main" noGrp="1"/>
-          </p:cNvSpPr>
-          <p:nvPr>
-            <p:ph type="sldNum" idx="5"/>
-          </p:nvPr>
-        </p:nvSpPr>
-        <p:spPr/>
-        <p:txBody>
-          <a:bodyPr xmlns:a="http://schemas.openxmlformats.org/drawingml/2006/main"/>
-          <a:lstStyle xmlns:a="http://schemas.openxmlformats.org/drawingml/2006/main"/>
-          <a:p xmlns:a="http://schemas.openxmlformats.org/drawingml/2006/main"/>
-        </p:txBody>
-      </p:sp>
-    </p:spTree>
-  </p:cSld>
-  <p:clrMapOvr>
-    <a:masterClrMapping xmlns:a="http://schemas.openxmlformats.org/drawingml/2006/main"/>
-  </p:clrMapOvr>
-</p:notes>
-</file>
-
 <file path=ppt/slideLayouts/slideLayout1.xml><?xml version="1.0" encoding="utf-8"?>
 <p:sldLayout xmlns:p="http://schemas.openxmlformats.org/presentationml/2006/main" type="title">
   <p:cSld name="Title Slide">
@@ -1003,7 +802,7 @@
   </p:cSld>
   <p:clrMap bg1="lt1" tx1="dk1" bg2="lt2" tx2="dk2" accent1="accent1" accent2="accent2" accent3="accent3" accent4="accent4" accent5="accent5" accent6="accent6" hlink="hlink" folHlink="folHlink"/>
   <p:sldLayoutIdLst>
-    <p:sldLayoutId xmlns:r="http://schemas.openxmlformats.org/officeDocument/2006/relationships" id="2147483649" r:id="Rdeef2eb1cca74730"/>
+    <p:sldLayoutId xmlns:r="http://schemas.openxmlformats.org/officeDocument/2006/relationships" id="2147483649" r:id="R0052c369eb174303"/>
   </p:sldLayoutIdLst>
   <p:txStyles>
     <p:titleStyle>
@@ -1536,7 +1335,7 @@
     <p:bg>
       <p:bgPr>
         <a:solidFill xmlns:a="http://schemas.openxmlformats.org/drawingml/2006/main">
-          <a:srgbClr val="FFFFFF"/>
+          <a:srgbClr val="080B0F"/>
         </a:solidFill>
       </p:bgPr>
     </p:bg>
@@ -1551,176 +1350,777 @@
       </p:grpSpPr>
       <p:sp>
         <p:nvSpPr>
-          <p:cNvPr id="1" name="">
-            <a:extLst xmlns:a="http://schemas.openxmlformats.org/drawingml/2006/main">
-              <a:ext uri="{FF2B5EF4-FFF2-40B4-BE49-F238E27FC236}">
-                <a16:creationId xmlns:a16="http://schemas.microsoft.com/office/drawing/2014/main" id="{91F7A2D1-144D-4C72-8EF7-440FD84901CE}"/>
-              </a:ext>
-            </a:extLst>
-          </p:cNvPr>
-          <p:cNvSpPr>
-            <a:spLocks xmlns:a="http://schemas.openxmlformats.org/drawingml/2006/main" noGrp="1"/>
-          </p:cNvSpPr>
-          <p:nvPr/>
-        </p:nvSpPr>
-        <p:spPr>
-          <a:xfrm xmlns:a="http://schemas.openxmlformats.org/drawingml/2006/main">
-            <a:off x="419100" y="342900"/>
-            <a:ext cx="3048000" cy="266700"/>
-          </a:xfrm>
-          <a:prstGeom xmlns:a="http://schemas.openxmlformats.org/drawingml/2006/main" prst="rect">
-            <a:avLst/>
-          </a:prstGeom>
-          <a:noFill xmlns:a="http://schemas.openxmlformats.org/drawingml/2006/main"/>
-          <a:ln xmlns:a="http://schemas.openxmlformats.org/drawingml/2006/main" w="0">
-            <a:noFill/>
-            <a:prstDash val="solid"/>
-          </a:ln>
-        </p:spPr>
-        <p:txBody>
-          <a:bodyPr xmlns:a="http://schemas.openxmlformats.org/drawingml/2006/main"/>
-          <a:lstStyle xmlns:a="http://schemas.openxmlformats.org/drawingml/2006/main"/>
-          <a:p xmlns:a="http://schemas.openxmlformats.org/drawingml/2006/main">
-            <a:pPr>
-              <a:buNone/>
-              <a:defRPr sz="1125" b="1">
-                <a:solidFill>
-                  <a:srgbClr val="555555"/>
-                </a:solidFill>
-              </a:defRPr>
-            </a:pPr>
-            <a:r>
-              <a:rPr sz="1125" b="1">
-                <a:solidFill>
-                  <a:srgbClr val="555555"/>
-                </a:solidFill>
-              </a:rPr>
-              <a:t>ANA EKRAN</a:t>
-            </a:r>
-          </a:p>
-        </p:txBody>
-      </p:sp>
-      <p:sp>
-        <p:nvSpPr>
-          <p:cNvPr id="2" name="">
-            <a:extLst xmlns:a="http://schemas.openxmlformats.org/drawingml/2006/main">
-              <a:ext uri="{FF2B5EF4-FFF2-40B4-BE49-F238E27FC236}">
-                <a16:creationId xmlns:a16="http://schemas.microsoft.com/office/drawing/2014/main" id="{333E9EAE-E09B-410F-92E0-B7BD5C30DBF4}"/>
-              </a:ext>
-            </a:extLst>
-          </p:cNvPr>
-          <p:cNvSpPr>
-            <a:spLocks xmlns:a="http://schemas.openxmlformats.org/drawingml/2006/main" noGrp="1"/>
-          </p:cNvSpPr>
-          <p:nvPr/>
-        </p:nvSpPr>
-        <p:spPr>
-          <a:xfrm xmlns:a="http://schemas.openxmlformats.org/drawingml/2006/main">
-            <a:off x="419100" y="723900"/>
-            <a:ext cx="7239000" cy="1123950"/>
-          </a:xfrm>
-          <a:prstGeom xmlns:a="http://schemas.openxmlformats.org/drawingml/2006/main" prst="rect">
-            <a:avLst/>
-          </a:prstGeom>
-          <a:noFill xmlns:a="http://schemas.openxmlformats.org/drawingml/2006/main"/>
-          <a:ln xmlns:a="http://schemas.openxmlformats.org/drawingml/2006/main" w="0">
-            <a:noFill/>
-            <a:prstDash val="solid"/>
-          </a:ln>
-        </p:spPr>
-        <p:txBody>
-          <a:bodyPr xmlns:a="http://schemas.openxmlformats.org/drawingml/2006/main"/>
-          <a:lstStyle xmlns:a="http://schemas.openxmlformats.org/drawingml/2006/main"/>
-          <a:p xmlns:a="http://schemas.openxmlformats.org/drawingml/2006/main">
-            <a:pPr>
-              <a:buNone/>
-              <a:defRPr sz="3000" b="1">
-                <a:solidFill>
-                  <a:srgbClr val="070707"/>
-                </a:solidFill>
-              </a:defRPr>
-            </a:pPr>
-            <a:r>
-              <a:rPr sz="3000" b="1">
-                <a:solidFill>
-                  <a:srgbClr val="070707"/>
-                </a:solidFill>
-              </a:rPr>
-              <a:t>Robotun bütün hikayesi tek cockpit içinde.</a:t>
-            </a:r>
-          </a:p>
-        </p:txBody>
-      </p:sp>
-      <p:sp>
-        <p:nvSpPr>
-          <p:cNvPr id="3" name="">
-            <a:extLst xmlns:a="http://schemas.openxmlformats.org/drawingml/2006/main">
-              <a:ext uri="{FF2B5EF4-FFF2-40B4-BE49-F238E27FC236}">
-                <a16:creationId xmlns:a16="http://schemas.microsoft.com/office/drawing/2014/main" id="{E7914283-5AB7-4449-B66E-705168030822}"/>
-              </a:ext>
-            </a:extLst>
-          </p:cNvPr>
-          <p:cNvSpPr>
-            <a:spLocks xmlns:a="http://schemas.openxmlformats.org/drawingml/2006/main" noGrp="1"/>
-          </p:cNvSpPr>
-          <p:nvPr/>
-        </p:nvSpPr>
-        <p:spPr>
-          <a:xfrm xmlns:a="http://schemas.openxmlformats.org/drawingml/2006/main">
-            <a:off x="419100" y="1809750"/>
-            <a:ext cx="8191500" cy="476250"/>
-          </a:xfrm>
-          <a:prstGeom xmlns:a="http://schemas.openxmlformats.org/drawingml/2006/main" prst="rect">
-            <a:avLst/>
-          </a:prstGeom>
-          <a:noFill xmlns:a="http://schemas.openxmlformats.org/drawingml/2006/main"/>
-          <a:ln xmlns:a="http://schemas.openxmlformats.org/drawingml/2006/main" w="0">
-            <a:noFill/>
-            <a:prstDash val="solid"/>
-          </a:ln>
-        </p:spPr>
-        <p:txBody>
-          <a:bodyPr xmlns:a="http://schemas.openxmlformats.org/drawingml/2006/main"/>
-          <a:lstStyle xmlns:a="http://schemas.openxmlformats.org/drawingml/2006/main"/>
-          <a:p xmlns:a="http://schemas.openxmlformats.org/drawingml/2006/main">
-            <a:pPr>
-              <a:buNone/>
-              <a:defRPr sz="1725">
-                <a:solidFill>
-                  <a:srgbClr val="555555"/>
-                </a:solidFill>
-              </a:defRPr>
-            </a:pPr>
-            <a:r>
-              <a:rPr sz="1725">
-                <a:solidFill>
-                  <a:srgbClr val="555555"/>
-                </a:solidFill>
-              </a:rPr>
-              <a:t>Solda AI Chatbot, ortada canlı bilgi akışı, sağda Robot Twin. Tek bakışta kontrol hissi.</a:t>
+          <p:cNvPr id="1" name="xr-left-panel">
+            <a:extLst xmlns:a="http://schemas.openxmlformats.org/drawingml/2006/main">
+              <a:ext uri="{FF2B5EF4-FFF2-40B4-BE49-F238E27FC236}">
+                <a16:creationId xmlns:a16="http://schemas.microsoft.com/office/drawing/2014/main" id="{C340BB2D-AFBE-436C-B2BC-D8A68FF3D260}"/>
+              </a:ext>
+            </a:extLst>
+          </p:cNvPr>
+          <p:cNvSpPr>
+            <a:spLocks xmlns:a="http://schemas.openxmlformats.org/drawingml/2006/main" noGrp="1"/>
+          </p:cNvSpPr>
+          <p:nvPr/>
+        </p:nvSpPr>
+        <p:spPr>
+          <a:xfrm xmlns:a="http://schemas.openxmlformats.org/drawingml/2006/main">
+            <a:off x="0" y="0"/>
+            <a:ext cx="5219700" cy="6858000"/>
+          </a:xfrm>
+          <a:prstGeom xmlns:a="http://schemas.openxmlformats.org/drawingml/2006/main" prst="rect">
+            <a:avLst/>
+          </a:prstGeom>
+          <a:solidFill xmlns:a="http://schemas.openxmlformats.org/drawingml/2006/main">
+            <a:srgbClr val="111318"/>
+          </a:solidFill>
+          <a:ln xmlns:a="http://schemas.openxmlformats.org/drawingml/2006/main" w="0">
+            <a:noFill/>
+            <a:prstDash val="solid"/>
+          </a:ln>
+        </p:spPr>
+      </p:sp>
+      <p:sp>
+        <p:nvSpPr>
+          <p:cNvPr id="2" name="xr-eyebrow">
+            <a:extLst xmlns:a="http://schemas.openxmlformats.org/drawingml/2006/main">
+              <a:ext uri="{FF2B5EF4-FFF2-40B4-BE49-F238E27FC236}">
+                <a16:creationId xmlns:a16="http://schemas.microsoft.com/office/drawing/2014/main" id="{D9995331-F557-41F7-9910-491418D731C1}"/>
+              </a:ext>
+            </a:extLst>
+          </p:cNvPr>
+          <p:cNvSpPr>
+            <a:spLocks xmlns:a="http://schemas.openxmlformats.org/drawingml/2006/main" noGrp="1"/>
+          </p:cNvSpPr>
+          <p:nvPr/>
+        </p:nvSpPr>
+        <p:spPr>
+          <a:xfrm xmlns:a="http://schemas.openxmlformats.org/drawingml/2006/main">
+            <a:off x="590550" y="419100"/>
+            <a:ext cx="4000500" cy="228600"/>
+          </a:xfrm>
+          <a:prstGeom xmlns:a="http://schemas.openxmlformats.org/drawingml/2006/main" prst="rect">
+            <a:avLst/>
+          </a:prstGeom>
+          <a:noFill xmlns:a="http://schemas.openxmlformats.org/drawingml/2006/main"/>
+          <a:ln xmlns:a="http://schemas.openxmlformats.org/drawingml/2006/main" w="0">
+            <a:noFill/>
+            <a:prstDash val="solid"/>
+          </a:ln>
+        </p:spPr>
+        <p:txBody>
+          <a:bodyPr xmlns:a="http://schemas.openxmlformats.org/drawingml/2006/main"/>
+          <a:lstStyle xmlns:a="http://schemas.openxmlformats.org/drawingml/2006/main"/>
+          <a:p xmlns:a="http://schemas.openxmlformats.org/drawingml/2006/main">
+            <a:pPr>
+              <a:buNone/>
+              <a:defRPr sz="1050" b="1">
+                <a:solidFill>
+                  <a:srgbClr val="38BDF8"/>
+                </a:solidFill>
+              </a:defRPr>
+            </a:pPr>
+            <a:r>
+              <a:rPr sz="1050" b="1">
+                <a:solidFill>
+                  <a:srgbClr val="38BDF8"/>
+                </a:solidFill>
+              </a:rPr>
+              <a:t>VISION PRO TELEOPERATION</a:t>
+            </a:r>
+          </a:p>
+        </p:txBody>
+      </p:sp>
+      <p:sp>
+        <p:nvSpPr>
+          <p:cNvPr id="3" name="xr-title">
+            <a:extLst xmlns:a="http://schemas.openxmlformats.org/drawingml/2006/main">
+              <a:ext uri="{FF2B5EF4-FFF2-40B4-BE49-F238E27FC236}">
+                <a16:creationId xmlns:a16="http://schemas.microsoft.com/office/drawing/2014/main" id="{9ABBD2E8-B1C0-4DF6-9259-E5CD94386E02}"/>
+              </a:ext>
+            </a:extLst>
+          </p:cNvPr>
+          <p:cNvSpPr>
+            <a:spLocks xmlns:a="http://schemas.openxmlformats.org/drawingml/2006/main" noGrp="1"/>
+          </p:cNvSpPr>
+          <p:nvPr/>
+        </p:nvSpPr>
+        <p:spPr>
+          <a:xfrm xmlns:a="http://schemas.openxmlformats.org/drawingml/2006/main">
+            <a:off x="590550" y="838200"/>
+            <a:ext cx="4095750" cy="990600"/>
+          </a:xfrm>
+          <a:prstGeom xmlns:a="http://schemas.openxmlformats.org/drawingml/2006/main" prst="rect">
+            <a:avLst/>
+          </a:prstGeom>
+          <a:noFill xmlns:a="http://schemas.openxmlformats.org/drawingml/2006/main"/>
+          <a:ln xmlns:a="http://schemas.openxmlformats.org/drawingml/2006/main" w="0">
+            <a:noFill/>
+            <a:prstDash val="solid"/>
+          </a:ln>
+        </p:spPr>
+        <p:txBody>
+          <a:bodyPr xmlns:a="http://schemas.openxmlformats.org/drawingml/2006/main"/>
+          <a:lstStyle xmlns:a="http://schemas.openxmlformats.org/drawingml/2006/main"/>
+          <a:p xmlns:a="http://schemas.openxmlformats.org/drawingml/2006/main">
+            <a:pPr>
+              <a:buNone/>
+              <a:defRPr sz="3150" b="1">
+                <a:solidFill>
+                  <a:srgbClr val="FFFFFF"/>
+                </a:solidFill>
+              </a:defRPr>
+            </a:pPr>
+            <a:r>
+              <a:rPr sz="3150" b="1">
+                <a:solidFill>
+                  <a:srgbClr val="FFFFFF"/>
+                </a:solidFill>
+              </a:rPr>
+              <a:t>Robotu ellerle</a:t>
+            </a:r>
+          </a:p>
+          <a:p xmlns:a="http://schemas.openxmlformats.org/drawingml/2006/main">
+            <a:pPr>
+              <a:buNone/>
+              <a:defRPr sz="3150" b="1">
+                <a:solidFill>
+                  <a:srgbClr val="FFFFFF"/>
+                </a:solidFill>
+              </a:defRPr>
+            </a:pPr>
+            <a:r>
+              <a:rPr sz="3150" b="1">
+                <a:solidFill>
+                  <a:srgbClr val="FFFFFF"/>
+                </a:solidFill>
+              </a:rPr>
+              <a:t>teleoperate ediyoruz</a:t>
+            </a:r>
+          </a:p>
+        </p:txBody>
+      </p:sp>
+      <p:sp>
+        <p:nvSpPr>
+          <p:cNvPr id="4" name="xr-subtitle">
+            <a:extLst xmlns:a="http://schemas.openxmlformats.org/drawingml/2006/main">
+              <a:ext uri="{FF2B5EF4-FFF2-40B4-BE49-F238E27FC236}">
+                <a16:creationId xmlns:a16="http://schemas.microsoft.com/office/drawing/2014/main" id="{F69F51C3-D3BE-4412-B29D-510531BFF3A8}"/>
+              </a:ext>
+            </a:extLst>
+          </p:cNvPr>
+          <p:cNvSpPr>
+            <a:spLocks xmlns:a="http://schemas.openxmlformats.org/drawingml/2006/main" noGrp="1"/>
+          </p:cNvSpPr>
+          <p:nvPr/>
+        </p:nvSpPr>
+        <p:spPr>
+          <a:xfrm xmlns:a="http://schemas.openxmlformats.org/drawingml/2006/main">
+            <a:off x="609600" y="1962150"/>
+            <a:ext cx="4057650" cy="666750"/>
+          </a:xfrm>
+          <a:prstGeom xmlns:a="http://schemas.openxmlformats.org/drawingml/2006/main" prst="rect">
+            <a:avLst/>
+          </a:prstGeom>
+          <a:noFill xmlns:a="http://schemas.openxmlformats.org/drawingml/2006/main"/>
+          <a:ln xmlns:a="http://schemas.openxmlformats.org/drawingml/2006/main" w="0">
+            <a:noFill/>
+            <a:prstDash val="solid"/>
+          </a:ln>
+        </p:spPr>
+        <p:txBody>
+          <a:bodyPr xmlns:a="http://schemas.openxmlformats.org/drawingml/2006/main"/>
+          <a:lstStyle xmlns:a="http://schemas.openxmlformats.org/drawingml/2006/main"/>
+          <a:p xmlns:a="http://schemas.openxmlformats.org/drawingml/2006/main">
+            <a:pPr>
+              <a:buNone/>
+              <a:defRPr sz="1350">
+                <a:solidFill>
+                  <a:srgbClr val="CBD5E1"/>
+                </a:solidFill>
+              </a:defRPr>
+            </a:pPr>
+            <a:r>
+              <a:rPr sz="1350">
+                <a:solidFill>
+                  <a:srgbClr val="CBD5E1"/>
+                </a:solidFill>
+              </a:rPr>
+              <a:t>Vision Pro el iskeleti ve bilek yönelimi, düşük gecikmeli bir kontrol katmanında robot el-kol hedeflerine dönüştürülüyor.</a:t>
+            </a:r>
+          </a:p>
+        </p:txBody>
+      </p:sp>
+      <p:sp>
+        <p:nvSpPr>
+          <p:cNvPr id="5" name="xr-control-index-1">
+            <a:extLst xmlns:a="http://schemas.openxmlformats.org/drawingml/2006/main">
+              <a:ext uri="{FF2B5EF4-FFF2-40B4-BE49-F238E27FC236}">
+                <a16:creationId xmlns:a16="http://schemas.microsoft.com/office/drawing/2014/main" id="{AAFDF8A3-9BC0-4402-A2E7-D39A8FAB67EE}"/>
+              </a:ext>
+            </a:extLst>
+          </p:cNvPr>
+          <p:cNvSpPr>
+            <a:spLocks xmlns:a="http://schemas.openxmlformats.org/drawingml/2006/main" noGrp="1"/>
+          </p:cNvSpPr>
+          <p:nvPr/>
+        </p:nvSpPr>
+        <p:spPr>
+          <a:xfrm xmlns:a="http://schemas.openxmlformats.org/drawingml/2006/main">
+            <a:off x="590550" y="2990850"/>
+            <a:ext cx="323850" cy="323850"/>
+          </a:xfrm>
+          <a:prstGeom xmlns:a="http://schemas.openxmlformats.org/drawingml/2006/main" prst="ellipse">
+            <a:avLst/>
+          </a:prstGeom>
+          <a:solidFill xmlns:a="http://schemas.openxmlformats.org/drawingml/2006/main">
+            <a:srgbClr val="22C55E"/>
+          </a:solidFill>
+          <a:ln xmlns:a="http://schemas.openxmlformats.org/drawingml/2006/main" w="0">
+            <a:noFill/>
+            <a:prstDash val="solid"/>
+          </a:ln>
+        </p:spPr>
+      </p:sp>
+      <p:sp>
+        <p:nvSpPr>
+          <p:cNvPr id="6" name="xr-control-index-text-1">
+            <a:extLst xmlns:a="http://schemas.openxmlformats.org/drawingml/2006/main">
+              <a:ext uri="{FF2B5EF4-FFF2-40B4-BE49-F238E27FC236}">
+                <a16:creationId xmlns:a16="http://schemas.microsoft.com/office/drawing/2014/main" id="{9D352A34-8BBB-43F2-A3E4-917DB779F87C}"/>
+              </a:ext>
+            </a:extLst>
+          </p:cNvPr>
+          <p:cNvSpPr>
+            <a:spLocks xmlns:a="http://schemas.openxmlformats.org/drawingml/2006/main" noGrp="1"/>
+          </p:cNvSpPr>
+          <p:nvPr/>
+        </p:nvSpPr>
+        <p:spPr>
+          <a:xfrm xmlns:a="http://schemas.openxmlformats.org/drawingml/2006/main">
+            <a:off x="590550" y="3038475"/>
+            <a:ext cx="323850" cy="209550"/>
+          </a:xfrm>
+          <a:prstGeom xmlns:a="http://schemas.openxmlformats.org/drawingml/2006/main" prst="rect">
+            <a:avLst/>
+          </a:prstGeom>
+          <a:noFill xmlns:a="http://schemas.openxmlformats.org/drawingml/2006/main"/>
+          <a:ln xmlns:a="http://schemas.openxmlformats.org/drawingml/2006/main" w="0">
+            <a:noFill/>
+            <a:prstDash val="solid"/>
+          </a:ln>
+        </p:spPr>
+        <p:txBody>
+          <a:bodyPr xmlns:a="http://schemas.openxmlformats.org/drawingml/2006/main"/>
+          <a:lstStyle xmlns:a="http://schemas.openxmlformats.org/drawingml/2006/main"/>
+          <a:p xmlns:a="http://schemas.openxmlformats.org/drawingml/2006/main">
+            <a:pPr algn="ctr">
+              <a:buNone/>
+              <a:defRPr sz="1200" b="1">
+                <a:solidFill>
+                  <a:srgbClr val="FFFFFF"/>
+                </a:solidFill>
+              </a:defRPr>
+            </a:pPr>
+            <a:r>
+              <a:rPr sz="1200" b="1">
+                <a:solidFill>
+                  <a:srgbClr val="FFFFFF"/>
+                </a:solidFill>
+              </a:rPr>
+              <a:t>1</a:t>
+            </a:r>
+          </a:p>
+        </p:txBody>
+      </p:sp>
+      <p:sp>
+        <p:nvSpPr>
+          <p:cNvPr id="7" name="xr-control-title-1">
+            <a:extLst xmlns:a="http://schemas.openxmlformats.org/drawingml/2006/main">
+              <a:ext uri="{FF2B5EF4-FFF2-40B4-BE49-F238E27FC236}">
+                <a16:creationId xmlns:a16="http://schemas.microsoft.com/office/drawing/2014/main" id="{DCAD1547-2520-4F8C-AAEE-A66EC2947567}"/>
+              </a:ext>
+            </a:extLst>
+          </p:cNvPr>
+          <p:cNvSpPr>
+            <a:spLocks xmlns:a="http://schemas.openxmlformats.org/drawingml/2006/main" noGrp="1"/>
+          </p:cNvSpPr>
+          <p:nvPr/>
+        </p:nvSpPr>
+        <p:spPr>
+          <a:xfrm xmlns:a="http://schemas.openxmlformats.org/drawingml/2006/main">
+            <a:off x="1066800" y="2971800"/>
+            <a:ext cx="3733800" cy="247650"/>
+          </a:xfrm>
+          <a:prstGeom xmlns:a="http://schemas.openxmlformats.org/drawingml/2006/main" prst="rect">
+            <a:avLst/>
+          </a:prstGeom>
+          <a:noFill xmlns:a="http://schemas.openxmlformats.org/drawingml/2006/main"/>
+          <a:ln xmlns:a="http://schemas.openxmlformats.org/drawingml/2006/main" w="0">
+            <a:noFill/>
+            <a:prstDash val="solid"/>
+          </a:ln>
+        </p:spPr>
+        <p:txBody>
+          <a:bodyPr xmlns:a="http://schemas.openxmlformats.org/drawingml/2006/main"/>
+          <a:lstStyle xmlns:a="http://schemas.openxmlformats.org/drawingml/2006/main"/>
+          <a:p xmlns:a="http://schemas.openxmlformats.org/drawingml/2006/main">
+            <a:pPr>
+              <a:buNone/>
+              <a:defRPr sz="1500" b="1">
+                <a:solidFill>
+                  <a:srgbClr val="F8FAFC"/>
+                </a:solidFill>
+              </a:defRPr>
+            </a:pPr>
+            <a:r>
+              <a:rPr sz="1500" b="1">
+                <a:solidFill>
+                  <a:srgbClr val="F8FAFC"/>
+                </a:solidFill>
+              </a:rPr>
+              <a:t>Spatial hand pose capture</a:t>
+            </a:r>
+          </a:p>
+        </p:txBody>
+      </p:sp>
+      <p:sp>
+        <p:nvSpPr>
+          <p:cNvPr id="8" name="xr-control-body-1">
+            <a:extLst xmlns:a="http://schemas.openxmlformats.org/drawingml/2006/main">
+              <a:ext uri="{FF2B5EF4-FFF2-40B4-BE49-F238E27FC236}">
+                <a16:creationId xmlns:a16="http://schemas.microsoft.com/office/drawing/2014/main" id="{DFB78ADE-ABED-47ED-9A14-96C1E42A501B}"/>
+              </a:ext>
+            </a:extLst>
+          </p:cNvPr>
+          <p:cNvSpPr>
+            <a:spLocks xmlns:a="http://schemas.openxmlformats.org/drawingml/2006/main" noGrp="1"/>
+          </p:cNvSpPr>
+          <p:nvPr/>
+        </p:nvSpPr>
+        <p:spPr>
+          <a:xfrm xmlns:a="http://schemas.openxmlformats.org/drawingml/2006/main">
+            <a:off x="1066800" y="3267075"/>
+            <a:ext cx="3790950" cy="514350"/>
+          </a:xfrm>
+          <a:prstGeom xmlns:a="http://schemas.openxmlformats.org/drawingml/2006/main" prst="rect">
+            <a:avLst/>
+          </a:prstGeom>
+          <a:noFill xmlns:a="http://schemas.openxmlformats.org/drawingml/2006/main"/>
+          <a:ln xmlns:a="http://schemas.openxmlformats.org/drawingml/2006/main" w="0">
+            <a:noFill/>
+            <a:prstDash val="solid"/>
+          </a:ln>
+        </p:spPr>
+        <p:txBody>
+          <a:bodyPr xmlns:a="http://schemas.openxmlformats.org/drawingml/2006/main"/>
+          <a:lstStyle xmlns:a="http://schemas.openxmlformats.org/drawingml/2006/main"/>
+          <a:p xmlns:a="http://schemas.openxmlformats.org/drawingml/2006/main">
+            <a:pPr>
+              <a:buNone/>
+              <a:defRPr sz="1200">
+                <a:solidFill>
+                  <a:srgbClr val="CBD5E1"/>
+                </a:solidFill>
+              </a:defRPr>
+            </a:pPr>
+            <a:r>
+              <a:rPr sz="1200">
+                <a:solidFill>
+                  <a:srgbClr val="CBD5E1"/>
+                </a:solidFill>
+              </a:rPr>
+              <a:t>İki elin 3D iskeleti, pinch/finger curl ve bilek yönelimi sahne koordinatlarında okunur.</a:t>
+            </a:r>
+          </a:p>
+        </p:txBody>
+      </p:sp>
+      <p:sp>
+        <p:nvSpPr>
+          <p:cNvPr id="9" name="xr-control-index-2">
+            <a:extLst xmlns:a="http://schemas.openxmlformats.org/drawingml/2006/main">
+              <a:ext uri="{FF2B5EF4-FFF2-40B4-BE49-F238E27FC236}">
+                <a16:creationId xmlns:a16="http://schemas.microsoft.com/office/drawing/2014/main" id="{6B8E75E8-B335-41BC-8392-447E4CE82DF4}"/>
+              </a:ext>
+            </a:extLst>
+          </p:cNvPr>
+          <p:cNvSpPr>
+            <a:spLocks xmlns:a="http://schemas.openxmlformats.org/drawingml/2006/main" noGrp="1"/>
+          </p:cNvSpPr>
+          <p:nvPr/>
+        </p:nvSpPr>
+        <p:spPr>
+          <a:xfrm xmlns:a="http://schemas.openxmlformats.org/drawingml/2006/main">
+            <a:off x="590550" y="4076700"/>
+            <a:ext cx="323850" cy="323850"/>
+          </a:xfrm>
+          <a:prstGeom xmlns:a="http://schemas.openxmlformats.org/drawingml/2006/main" prst="ellipse">
+            <a:avLst/>
+          </a:prstGeom>
+          <a:solidFill xmlns:a="http://schemas.openxmlformats.org/drawingml/2006/main">
+            <a:srgbClr val="38BDF8"/>
+          </a:solidFill>
+          <a:ln xmlns:a="http://schemas.openxmlformats.org/drawingml/2006/main" w="0">
+            <a:noFill/>
+            <a:prstDash val="solid"/>
+          </a:ln>
+        </p:spPr>
+      </p:sp>
+      <p:sp>
+        <p:nvSpPr>
+          <p:cNvPr id="10" name="xr-control-index-text-2">
+            <a:extLst xmlns:a="http://schemas.openxmlformats.org/drawingml/2006/main">
+              <a:ext uri="{FF2B5EF4-FFF2-40B4-BE49-F238E27FC236}">
+                <a16:creationId xmlns:a16="http://schemas.microsoft.com/office/drawing/2014/main" id="{11F13662-6559-45B7-90F7-36A566BA58AA}"/>
+              </a:ext>
+            </a:extLst>
+          </p:cNvPr>
+          <p:cNvSpPr>
+            <a:spLocks xmlns:a="http://schemas.openxmlformats.org/drawingml/2006/main" noGrp="1"/>
+          </p:cNvSpPr>
+          <p:nvPr/>
+        </p:nvSpPr>
+        <p:spPr>
+          <a:xfrm xmlns:a="http://schemas.openxmlformats.org/drawingml/2006/main">
+            <a:off x="590550" y="4124325"/>
+            <a:ext cx="323850" cy="209550"/>
+          </a:xfrm>
+          <a:prstGeom xmlns:a="http://schemas.openxmlformats.org/drawingml/2006/main" prst="rect">
+            <a:avLst/>
+          </a:prstGeom>
+          <a:noFill xmlns:a="http://schemas.openxmlformats.org/drawingml/2006/main"/>
+          <a:ln xmlns:a="http://schemas.openxmlformats.org/drawingml/2006/main" w="0">
+            <a:noFill/>
+            <a:prstDash val="solid"/>
+          </a:ln>
+        </p:spPr>
+        <p:txBody>
+          <a:bodyPr xmlns:a="http://schemas.openxmlformats.org/drawingml/2006/main"/>
+          <a:lstStyle xmlns:a="http://schemas.openxmlformats.org/drawingml/2006/main"/>
+          <a:p xmlns:a="http://schemas.openxmlformats.org/drawingml/2006/main">
+            <a:pPr algn="ctr">
+              <a:buNone/>
+              <a:defRPr sz="1200" b="1">
+                <a:solidFill>
+                  <a:srgbClr val="FFFFFF"/>
+                </a:solidFill>
+              </a:defRPr>
+            </a:pPr>
+            <a:r>
+              <a:rPr sz="1200" b="1">
+                <a:solidFill>
+                  <a:srgbClr val="FFFFFF"/>
+                </a:solidFill>
+              </a:rPr>
+              <a:t>2</a:t>
+            </a:r>
+          </a:p>
+        </p:txBody>
+      </p:sp>
+      <p:sp>
+        <p:nvSpPr>
+          <p:cNvPr id="11" name="xr-control-title-2">
+            <a:extLst xmlns:a="http://schemas.openxmlformats.org/drawingml/2006/main">
+              <a:ext uri="{FF2B5EF4-FFF2-40B4-BE49-F238E27FC236}">
+                <a16:creationId xmlns:a16="http://schemas.microsoft.com/office/drawing/2014/main" id="{58C1152E-2CEF-4CE8-BBEC-C7B8BF613CF9}"/>
+              </a:ext>
+            </a:extLst>
+          </p:cNvPr>
+          <p:cNvSpPr>
+            <a:spLocks xmlns:a="http://schemas.openxmlformats.org/drawingml/2006/main" noGrp="1"/>
+          </p:cNvSpPr>
+          <p:nvPr/>
+        </p:nvSpPr>
+        <p:spPr>
+          <a:xfrm xmlns:a="http://schemas.openxmlformats.org/drawingml/2006/main">
+            <a:off x="1066800" y="4057650"/>
+            <a:ext cx="3733800" cy="247650"/>
+          </a:xfrm>
+          <a:prstGeom xmlns:a="http://schemas.openxmlformats.org/drawingml/2006/main" prst="rect">
+            <a:avLst/>
+          </a:prstGeom>
+          <a:noFill xmlns:a="http://schemas.openxmlformats.org/drawingml/2006/main"/>
+          <a:ln xmlns:a="http://schemas.openxmlformats.org/drawingml/2006/main" w="0">
+            <a:noFill/>
+            <a:prstDash val="solid"/>
+          </a:ln>
+        </p:spPr>
+        <p:txBody>
+          <a:bodyPr xmlns:a="http://schemas.openxmlformats.org/drawingml/2006/main"/>
+          <a:lstStyle xmlns:a="http://schemas.openxmlformats.org/drawingml/2006/main"/>
+          <a:p xmlns:a="http://schemas.openxmlformats.org/drawingml/2006/main">
+            <a:pPr>
+              <a:buNone/>
+              <a:defRPr sz="1500" b="1">
+                <a:solidFill>
+                  <a:srgbClr val="F8FAFC"/>
+                </a:solidFill>
+              </a:defRPr>
+            </a:pPr>
+            <a:r>
+              <a:rPr sz="1500" b="1">
+                <a:solidFill>
+                  <a:srgbClr val="F8FAFC"/>
+                </a:solidFill>
+              </a:rPr>
+              <a:t>Low-latency retargeting</a:t>
+            </a:r>
+          </a:p>
+        </p:txBody>
+      </p:sp>
+      <p:sp>
+        <p:nvSpPr>
+          <p:cNvPr id="12" name="xr-control-body-2">
+            <a:extLst xmlns:a="http://schemas.openxmlformats.org/drawingml/2006/main">
+              <a:ext uri="{FF2B5EF4-FFF2-40B4-BE49-F238E27FC236}">
+                <a16:creationId xmlns:a16="http://schemas.microsoft.com/office/drawing/2014/main" id="{01C67911-163B-4008-8DDA-8EDFA506B250}"/>
+              </a:ext>
+            </a:extLst>
+          </p:cNvPr>
+          <p:cNvSpPr>
+            <a:spLocks xmlns:a="http://schemas.openxmlformats.org/drawingml/2006/main" noGrp="1"/>
+          </p:cNvSpPr>
+          <p:nvPr/>
+        </p:nvSpPr>
+        <p:spPr>
+          <a:xfrm xmlns:a="http://schemas.openxmlformats.org/drawingml/2006/main">
+            <a:off x="1066800" y="4352925"/>
+            <a:ext cx="3790950" cy="514350"/>
+          </a:xfrm>
+          <a:prstGeom xmlns:a="http://schemas.openxmlformats.org/drawingml/2006/main" prst="rect">
+            <a:avLst/>
+          </a:prstGeom>
+          <a:noFill xmlns:a="http://schemas.openxmlformats.org/drawingml/2006/main"/>
+          <a:ln xmlns:a="http://schemas.openxmlformats.org/drawingml/2006/main" w="0">
+            <a:noFill/>
+            <a:prstDash val="solid"/>
+          </a:ln>
+        </p:spPr>
+        <p:txBody>
+          <a:bodyPr xmlns:a="http://schemas.openxmlformats.org/drawingml/2006/main"/>
+          <a:lstStyle xmlns:a="http://schemas.openxmlformats.org/drawingml/2006/main"/>
+          <a:p xmlns:a="http://schemas.openxmlformats.org/drawingml/2006/main">
+            <a:pPr>
+              <a:buNone/>
+              <a:defRPr sz="1200">
+                <a:solidFill>
+                  <a:srgbClr val="CBD5E1"/>
+                </a:solidFill>
+              </a:defRPr>
+            </a:pPr>
+            <a:r>
+              <a:rPr sz="1200">
+                <a:solidFill>
+                  <a:srgbClr val="CBD5E1"/>
+                </a:solidFill>
+              </a:rPr>
+              <a:t>Pose akışı filtrelenir, ölçeklenir ve eklem limitleri içinde Inspire el hedeflerine retarget edilir.</a:t>
+            </a:r>
+          </a:p>
+        </p:txBody>
+      </p:sp>
+      <p:sp>
+        <p:nvSpPr>
+          <p:cNvPr id="13" name="xr-control-index-3">
+            <a:extLst xmlns:a="http://schemas.openxmlformats.org/drawingml/2006/main">
+              <a:ext uri="{FF2B5EF4-FFF2-40B4-BE49-F238E27FC236}">
+                <a16:creationId xmlns:a16="http://schemas.microsoft.com/office/drawing/2014/main" id="{7B065A7C-ADAB-402C-B890-545E1E2FC834}"/>
+              </a:ext>
+            </a:extLst>
+          </p:cNvPr>
+          <p:cNvSpPr>
+            <a:spLocks xmlns:a="http://schemas.openxmlformats.org/drawingml/2006/main" noGrp="1"/>
+          </p:cNvSpPr>
+          <p:nvPr/>
+        </p:nvSpPr>
+        <p:spPr>
+          <a:xfrm xmlns:a="http://schemas.openxmlformats.org/drawingml/2006/main">
+            <a:off x="590550" y="5162550"/>
+            <a:ext cx="323850" cy="323850"/>
+          </a:xfrm>
+          <a:prstGeom xmlns:a="http://schemas.openxmlformats.org/drawingml/2006/main" prst="ellipse">
+            <a:avLst/>
+          </a:prstGeom>
+          <a:solidFill xmlns:a="http://schemas.openxmlformats.org/drawingml/2006/main">
+            <a:srgbClr val="F97316"/>
+          </a:solidFill>
+          <a:ln xmlns:a="http://schemas.openxmlformats.org/drawingml/2006/main" w="0">
+            <a:noFill/>
+            <a:prstDash val="solid"/>
+          </a:ln>
+        </p:spPr>
+      </p:sp>
+      <p:sp>
+        <p:nvSpPr>
+          <p:cNvPr id="14" name="xr-control-index-text-3">
+            <a:extLst xmlns:a="http://schemas.openxmlformats.org/drawingml/2006/main">
+              <a:ext uri="{FF2B5EF4-FFF2-40B4-BE49-F238E27FC236}">
+                <a16:creationId xmlns:a16="http://schemas.microsoft.com/office/drawing/2014/main" id="{76E20B3E-A826-4DAC-BDF7-A6899839F51A}"/>
+              </a:ext>
+            </a:extLst>
+          </p:cNvPr>
+          <p:cNvSpPr>
+            <a:spLocks xmlns:a="http://schemas.openxmlformats.org/drawingml/2006/main" noGrp="1"/>
+          </p:cNvSpPr>
+          <p:nvPr/>
+        </p:nvSpPr>
+        <p:spPr>
+          <a:xfrm xmlns:a="http://schemas.openxmlformats.org/drawingml/2006/main">
+            <a:off x="590550" y="5210175"/>
+            <a:ext cx="323850" cy="209550"/>
+          </a:xfrm>
+          <a:prstGeom xmlns:a="http://schemas.openxmlformats.org/drawingml/2006/main" prst="rect">
+            <a:avLst/>
+          </a:prstGeom>
+          <a:noFill xmlns:a="http://schemas.openxmlformats.org/drawingml/2006/main"/>
+          <a:ln xmlns:a="http://schemas.openxmlformats.org/drawingml/2006/main" w="0">
+            <a:noFill/>
+            <a:prstDash val="solid"/>
+          </a:ln>
+        </p:spPr>
+        <p:txBody>
+          <a:bodyPr xmlns:a="http://schemas.openxmlformats.org/drawingml/2006/main"/>
+          <a:lstStyle xmlns:a="http://schemas.openxmlformats.org/drawingml/2006/main"/>
+          <a:p xmlns:a="http://schemas.openxmlformats.org/drawingml/2006/main">
+            <a:pPr algn="ctr">
+              <a:buNone/>
+              <a:defRPr sz="1200" b="1">
+                <a:solidFill>
+                  <a:srgbClr val="FFFFFF"/>
+                </a:solidFill>
+              </a:defRPr>
+            </a:pPr>
+            <a:r>
+              <a:rPr sz="1200" b="1">
+                <a:solidFill>
+                  <a:srgbClr val="FFFFFF"/>
+                </a:solidFill>
+              </a:rPr>
+              <a:t>3</a:t>
+            </a:r>
+          </a:p>
+        </p:txBody>
+      </p:sp>
+      <p:sp>
+        <p:nvSpPr>
+          <p:cNvPr id="15" name="xr-control-title-3">
+            <a:extLst xmlns:a="http://schemas.openxmlformats.org/drawingml/2006/main">
+              <a:ext uri="{FF2B5EF4-FFF2-40B4-BE49-F238E27FC236}">
+                <a16:creationId xmlns:a16="http://schemas.microsoft.com/office/drawing/2014/main" id="{4DE25A54-105F-4813-A6B2-F9D8C57178E2}"/>
+              </a:ext>
+            </a:extLst>
+          </p:cNvPr>
+          <p:cNvSpPr>
+            <a:spLocks xmlns:a="http://schemas.openxmlformats.org/drawingml/2006/main" noGrp="1"/>
+          </p:cNvSpPr>
+          <p:nvPr/>
+        </p:nvSpPr>
+        <p:spPr>
+          <a:xfrm xmlns:a="http://schemas.openxmlformats.org/drawingml/2006/main">
+            <a:off x="1066800" y="5143500"/>
+            <a:ext cx="3733800" cy="247650"/>
+          </a:xfrm>
+          <a:prstGeom xmlns:a="http://schemas.openxmlformats.org/drawingml/2006/main" prst="rect">
+            <a:avLst/>
+          </a:prstGeom>
+          <a:noFill xmlns:a="http://schemas.openxmlformats.org/drawingml/2006/main"/>
+          <a:ln xmlns:a="http://schemas.openxmlformats.org/drawingml/2006/main" w="0">
+            <a:noFill/>
+            <a:prstDash val="solid"/>
+          </a:ln>
+        </p:spPr>
+        <p:txBody>
+          <a:bodyPr xmlns:a="http://schemas.openxmlformats.org/drawingml/2006/main"/>
+          <a:lstStyle xmlns:a="http://schemas.openxmlformats.org/drawingml/2006/main"/>
+          <a:p xmlns:a="http://schemas.openxmlformats.org/drawingml/2006/main">
+            <a:pPr>
+              <a:buNone/>
+              <a:defRPr sz="1500" b="1">
+                <a:solidFill>
+                  <a:srgbClr val="F8FAFC"/>
+                </a:solidFill>
+              </a:defRPr>
+            </a:pPr>
+            <a:r>
+              <a:rPr sz="1500" b="1">
+                <a:solidFill>
+                  <a:srgbClr val="F8FAFC"/>
+                </a:solidFill>
+              </a:rPr>
+              <a:t>Robot hands in the loop</a:t>
+            </a:r>
+          </a:p>
+        </p:txBody>
+      </p:sp>
+      <p:sp>
+        <p:nvSpPr>
+          <p:cNvPr id="16" name="xr-control-body-3">
+            <a:extLst xmlns:a="http://schemas.openxmlformats.org/drawingml/2006/main">
+              <a:ext uri="{FF2B5EF4-FFF2-40B4-BE49-F238E27FC236}">
+                <a16:creationId xmlns:a16="http://schemas.microsoft.com/office/drawing/2014/main" id="{8C344EE8-A8C2-44D9-919D-1BCE60C121ED}"/>
+              </a:ext>
+            </a:extLst>
+          </p:cNvPr>
+          <p:cNvSpPr>
+            <a:spLocks xmlns:a="http://schemas.openxmlformats.org/drawingml/2006/main" noGrp="1"/>
+          </p:cNvSpPr>
+          <p:nvPr/>
+        </p:nvSpPr>
+        <p:spPr>
+          <a:xfrm xmlns:a="http://schemas.openxmlformats.org/drawingml/2006/main">
+            <a:off x="1066800" y="5438775"/>
+            <a:ext cx="3790950" cy="514350"/>
+          </a:xfrm>
+          <a:prstGeom xmlns:a="http://schemas.openxmlformats.org/drawingml/2006/main" prst="rect">
+            <a:avLst/>
+          </a:prstGeom>
+          <a:noFill xmlns:a="http://schemas.openxmlformats.org/drawingml/2006/main"/>
+          <a:ln xmlns:a="http://schemas.openxmlformats.org/drawingml/2006/main" w="0">
+            <a:noFill/>
+            <a:prstDash val="solid"/>
+          </a:ln>
+        </p:spPr>
+        <p:txBody>
+          <a:bodyPr xmlns:a="http://schemas.openxmlformats.org/drawingml/2006/main"/>
+          <a:lstStyle xmlns:a="http://schemas.openxmlformats.org/drawingml/2006/main"/>
+          <a:p xmlns:a="http://schemas.openxmlformats.org/drawingml/2006/main">
+            <a:pPr>
+              <a:buNone/>
+              <a:defRPr sz="1200">
+                <a:solidFill>
+                  <a:srgbClr val="CBD5E1"/>
+                </a:solidFill>
+              </a:defRPr>
+            </a:pPr>
+            <a:r>
+              <a:rPr sz="1200">
+                <a:solidFill>
+                  <a:srgbClr val="CBD5E1"/>
+                </a:solidFill>
+              </a:rPr>
+              <a:t>Kamera ve XR geri beslemesi aynı döngüdedir; operatör robot ellerini kendi elleri gibi görür.</a:t>
             </a:r>
           </a:p>
         </p:txBody>
       </p:sp>
       <p:pic>
         <p:nvPicPr>
-          <p:cNvPr id="17" name=""/>
+          <p:cNvPr id="40" name=""/>
           <p:cNvPicPr>
             <a:picLocks xmlns:a="http://schemas.openxmlformats.org/drawingml/2006/main" noChangeAspect="1"/>
           </p:cNvPicPr>
           <p:nvPr/>
         </p:nvPicPr>
         <p:blipFill>
-          <a:blip xmlns:r="http://schemas.openxmlformats.org/officeDocument/2006/relationships" xmlns:a="http://schemas.openxmlformats.org/drawingml/2006/main" r:embed="R906b1f59e49b4977"/>
-          <a:srcRect xmlns:a="http://schemas.openxmlformats.org/drawingml/2006/main" l="0" t="30309" r="0" b="30309"/>
+          <a:blip xmlns:r="http://schemas.openxmlformats.org/officeDocument/2006/relationships" xmlns:a="http://schemas.openxmlformats.org/drawingml/2006/main" r:embed="R7827df59152b46e0"/>
+          <a:srcRect xmlns:a="http://schemas.openxmlformats.org/drawingml/2006/main" l="2206" t="0" r="2206" b="0"/>
           <a:stretch xmlns:a="http://schemas.openxmlformats.org/drawingml/2006/main">
             <a:fillRect l="0" t="0" r="0" b="0"/>
           </a:stretch>
         </p:blipFill>
         <p:spPr>
           <a:xfrm xmlns:a="http://schemas.openxmlformats.org/drawingml/2006/main">
-            <a:off x="419100" y="2495550"/>
-            <a:ext cx="11353800" cy="3105150"/>
+            <a:off x="5581650" y="819150"/>
+            <a:ext cx="6191250" cy="3886200"/>
           </a:xfrm>
           <a:prstGeom xmlns:a="http://schemas.openxmlformats.org/drawingml/2006/main" prst="rect">
             <a:avLst/>
@@ -1729,32 +2129,116 @@
       </p:pic>
       <p:sp>
         <p:nvSpPr>
-          <p:cNvPr id="5" name="">
-            <a:extLst xmlns:a="http://schemas.openxmlformats.org/drawingml/2006/main">
-              <a:ext uri="{FF2B5EF4-FFF2-40B4-BE49-F238E27FC236}">
-                <a16:creationId xmlns:a16="http://schemas.microsoft.com/office/drawing/2014/main" id="{98D46ADD-7EAC-46E4-8F34-98F16ED974D4}"/>
-              </a:ext>
-            </a:extLst>
-          </p:cNvPr>
-          <p:cNvSpPr>
-            <a:spLocks xmlns:a="http://schemas.openxmlformats.org/drawingml/2006/main" noGrp="1"/>
-          </p:cNvSpPr>
-          <p:nvPr/>
-        </p:nvSpPr>
-        <p:spPr>
-          <a:xfrm xmlns:a="http://schemas.openxmlformats.org/drawingml/2006/main">
-            <a:off x="419100" y="5943600"/>
-            <a:ext cx="11353800" cy="19050"/>
-          </a:xfrm>
-          <a:prstGeom xmlns:a="http://schemas.openxmlformats.org/drawingml/2006/main" prst="rect">
-            <a:avLst/>
+          <p:cNvPr id="18" name="xr-screenshot-outline">
+            <a:extLst xmlns:a="http://schemas.openxmlformats.org/drawingml/2006/main">
+              <a:ext uri="{FF2B5EF4-FFF2-40B4-BE49-F238E27FC236}">
+                <a16:creationId xmlns:a16="http://schemas.microsoft.com/office/drawing/2014/main" id="{3C8544A3-93A0-4302-89A7-10442316310A}"/>
+              </a:ext>
+            </a:extLst>
+          </p:cNvPr>
+          <p:cNvSpPr>
+            <a:spLocks xmlns:a="http://schemas.openxmlformats.org/drawingml/2006/main" noGrp="1"/>
+          </p:cNvSpPr>
+          <p:nvPr/>
+        </p:nvSpPr>
+        <p:spPr>
+          <a:xfrm xmlns:a="http://schemas.openxmlformats.org/drawingml/2006/main">
+            <a:off x="5581650" y="819150"/>
+            <a:ext cx="6191250" cy="3886200"/>
+          </a:xfrm>
+          <a:prstGeom xmlns:a="http://schemas.openxmlformats.org/drawingml/2006/main" prst="rect">
+            <a:avLst/>
+          </a:prstGeom>
+          <a:noFill xmlns:a="http://schemas.openxmlformats.org/drawingml/2006/main"/>
+          <a:ln xmlns:a="http://schemas.openxmlformats.org/drawingml/2006/main" w="19050">
+            <a:solidFill>
+              <a:srgbClr val="334155"/>
+            </a:solidFill>
+            <a:prstDash val="solid"/>
+          </a:ln>
+        </p:spPr>
+      </p:sp>
+      <p:sp>
+        <p:nvSpPr>
+          <p:cNvPr id="19" name="xr-caption">
+            <a:extLst xmlns:a="http://schemas.openxmlformats.org/drawingml/2006/main">
+              <a:ext uri="{FF2B5EF4-FFF2-40B4-BE49-F238E27FC236}">
+                <a16:creationId xmlns:a16="http://schemas.microsoft.com/office/drawing/2014/main" id="{C4187414-2472-4272-9FF5-67A7DD0FEEAC}"/>
+              </a:ext>
+            </a:extLst>
+          </p:cNvPr>
+          <p:cNvSpPr>
+            <a:spLocks xmlns:a="http://schemas.openxmlformats.org/drawingml/2006/main" noGrp="1"/>
+          </p:cNvSpPr>
+          <p:nvPr/>
+        </p:nvSpPr>
+        <p:spPr>
+          <a:xfrm xmlns:a="http://schemas.openxmlformats.org/drawingml/2006/main">
+            <a:off x="5600700" y="4953000"/>
+            <a:ext cx="6134100" cy="552450"/>
+          </a:xfrm>
+          <a:prstGeom xmlns:a="http://schemas.openxmlformats.org/drawingml/2006/main" prst="rect">
+            <a:avLst/>
+          </a:prstGeom>
+          <a:noFill xmlns:a="http://schemas.openxmlformats.org/drawingml/2006/main"/>
+          <a:ln xmlns:a="http://schemas.openxmlformats.org/drawingml/2006/main" w="0">
+            <a:noFill/>
+            <a:prstDash val="solid"/>
+          </a:ln>
+        </p:spPr>
+        <p:txBody>
+          <a:bodyPr xmlns:a="http://schemas.openxmlformats.org/drawingml/2006/main"/>
+          <a:lstStyle xmlns:a="http://schemas.openxmlformats.org/drawingml/2006/main"/>
+          <a:p xmlns:a="http://schemas.openxmlformats.org/drawingml/2006/main">
+            <a:pPr>
+              <a:buNone/>
+              <a:defRPr sz="1350">
+                <a:solidFill>
+                  <a:srgbClr val="E2E8F0"/>
+                </a:solidFill>
+              </a:defRPr>
+            </a:pPr>
+            <a:r>
+              <a:rPr sz="1350">
+                <a:solidFill>
+                  <a:srgbClr val="E2E8F0"/>
+                </a:solidFill>
+              </a:rPr>
+              <a:t>Canlı robot görünümü: iki robot el, Vision Pro hand tracking girdisiyle operatörün jestlerine eşleniyor.</a:t>
+            </a:r>
+          </a:p>
+        </p:txBody>
+      </p:sp>
+      <p:sp>
+        <p:nvSpPr>
+          <p:cNvPr id="20" name="xr-bottom-band">
+            <a:extLst xmlns:a="http://schemas.openxmlformats.org/drawingml/2006/main">
+              <a:ext uri="{FF2B5EF4-FFF2-40B4-BE49-F238E27FC236}">
+                <a16:creationId xmlns:a16="http://schemas.microsoft.com/office/drawing/2014/main" id="{57876312-5A30-4144-95D1-274E33D4FFCC}"/>
+              </a:ext>
+            </a:extLst>
+          </p:cNvPr>
+          <p:cNvSpPr>
+            <a:spLocks xmlns:a="http://schemas.openxmlformats.org/drawingml/2006/main" noGrp="1"/>
+          </p:cNvSpPr>
+          <p:nvPr/>
+        </p:nvSpPr>
+        <p:spPr>
+          <a:xfrm xmlns:a="http://schemas.openxmlformats.org/drawingml/2006/main">
+            <a:off x="5581650" y="5886450"/>
+            <a:ext cx="6191250" cy="533400"/>
+          </a:xfrm>
+          <a:prstGeom xmlns:a="http://schemas.openxmlformats.org/drawingml/2006/main" prst="roundRect">
+            <a:avLst>
+              <a:gd name="adj" fmla="val 14286"/>
+            </a:avLst>
           </a:prstGeom>
           <a:solidFill xmlns:a="http://schemas.openxmlformats.org/drawingml/2006/main">
-            <a:srgbClr val="B8BCC4"/>
-          </a:solidFill>
-          <a:ln xmlns:a="http://schemas.openxmlformats.org/drawingml/2006/main" w="0">
+            <a:srgbClr val="121923"/>
+          </a:solidFill>
+          <a:ln xmlns:a="http://schemas.openxmlformats.org/drawingml/2006/main" w="9525">
             <a:solidFill>
-              <a:srgbClr val="B8BCC4"/>
+              <a:srgbClr val="1F2937"/>
             </a:solidFill>
             <a:prstDash val="solid"/>
           </a:ln>
@@ -1762,22 +2246,22 @@
       </p:sp>
       <p:sp>
         <p:nvSpPr>
-          <p:cNvPr id="6" name="">
-            <a:extLst xmlns:a="http://schemas.openxmlformats.org/drawingml/2006/main">
-              <a:ext uri="{FF2B5EF4-FFF2-40B4-BE49-F238E27FC236}">
-                <a16:creationId xmlns:a16="http://schemas.microsoft.com/office/drawing/2014/main" id="{E742FF94-086B-4A12-ADD8-538354CA9C79}"/>
-              </a:ext>
-            </a:extLst>
-          </p:cNvPr>
-          <p:cNvSpPr>
-            <a:spLocks xmlns:a="http://schemas.openxmlformats.org/drawingml/2006/main" noGrp="1"/>
-          </p:cNvSpPr>
-          <p:nvPr/>
-        </p:nvSpPr>
-        <p:spPr>
-          <a:xfrm xmlns:a="http://schemas.openxmlformats.org/drawingml/2006/main">
-            <a:off x="419100" y="6191250"/>
-            <a:ext cx="685800" cy="266700"/>
+          <p:cNvPr id="21" name="xr-bottom-copy">
+            <a:extLst xmlns:a="http://schemas.openxmlformats.org/drawingml/2006/main">
+              <a:ext uri="{FF2B5EF4-FFF2-40B4-BE49-F238E27FC236}">
+                <a16:creationId xmlns:a16="http://schemas.microsoft.com/office/drawing/2014/main" id="{16098D38-1D12-4BC2-AC87-69FD5C764DF5}"/>
+              </a:ext>
+            </a:extLst>
+          </p:cNvPr>
+          <p:cNvSpPr>
+            <a:spLocks xmlns:a="http://schemas.openxmlformats.org/drawingml/2006/main" noGrp="1"/>
+          </p:cNvSpPr>
+          <p:nvPr/>
+        </p:nvSpPr>
+        <p:spPr>
+          <a:xfrm xmlns:a="http://schemas.openxmlformats.org/drawingml/2006/main">
+            <a:off x="5810250" y="6010275"/>
+            <a:ext cx="5753100" cy="304800"/>
           </a:xfrm>
           <a:prstGeom xmlns:a="http://schemas.openxmlformats.org/drawingml/2006/main" prst="rect">
             <a:avLst/>
@@ -1796,331 +2280,50 @@
               <a:buNone/>
               <a:defRPr sz="1275" b="1">
                 <a:solidFill>
-                  <a:srgbClr val="E60000"/>
+                  <a:srgbClr val="F8FAFC"/>
                 </a:solidFill>
               </a:defRPr>
             </a:pPr>
             <a:r>
               <a:rPr sz="1275" b="1">
                 <a:solidFill>
-                  <a:srgbClr val="E60000"/>
-                </a:solidFill>
-              </a:rPr>
-              <a:t>SOL</a:t>
-            </a:r>
-          </a:p>
-        </p:txBody>
-      </p:sp>
-      <p:sp>
-        <p:nvSpPr>
-          <p:cNvPr id="7" name="">
-            <a:extLst xmlns:a="http://schemas.openxmlformats.org/drawingml/2006/main">
-              <a:ext uri="{FF2B5EF4-FFF2-40B4-BE49-F238E27FC236}">
-                <a16:creationId xmlns:a16="http://schemas.microsoft.com/office/drawing/2014/main" id="{DA75FEEB-D1FC-44CB-9B1D-DB662F8419B4}"/>
-              </a:ext>
-            </a:extLst>
-          </p:cNvPr>
-          <p:cNvSpPr>
-            <a:spLocks xmlns:a="http://schemas.openxmlformats.org/drawingml/2006/main" noGrp="1"/>
-          </p:cNvSpPr>
-          <p:nvPr/>
-        </p:nvSpPr>
-        <p:spPr>
-          <a:xfrm xmlns:a="http://schemas.openxmlformats.org/drawingml/2006/main">
-            <a:off x="1104900" y="6134100"/>
-            <a:ext cx="1714500" cy="323850"/>
-          </a:xfrm>
-          <a:prstGeom xmlns:a="http://schemas.openxmlformats.org/drawingml/2006/main" prst="rect">
-            <a:avLst/>
-          </a:prstGeom>
-          <a:noFill xmlns:a="http://schemas.openxmlformats.org/drawingml/2006/main"/>
-          <a:ln xmlns:a="http://schemas.openxmlformats.org/drawingml/2006/main" w="0">
-            <a:noFill/>
-            <a:prstDash val="solid"/>
-          </a:ln>
-        </p:spPr>
-        <p:txBody>
-          <a:bodyPr xmlns:a="http://schemas.openxmlformats.org/drawingml/2006/main"/>
-          <a:lstStyle xmlns:a="http://schemas.openxmlformats.org/drawingml/2006/main"/>
-          <a:p xmlns:a="http://schemas.openxmlformats.org/drawingml/2006/main">
-            <a:pPr>
-              <a:buNone/>
-              <a:defRPr sz="1800" b="1">
-                <a:solidFill>
-                  <a:srgbClr val="070707"/>
-                </a:solidFill>
-              </a:defRPr>
-            </a:pPr>
-            <a:r>
-              <a:rPr sz="1800" b="1">
-                <a:solidFill>
-                  <a:srgbClr val="070707"/>
-                </a:solidFill>
-              </a:rPr>
-              <a:t>AI Chatbot</a:t>
-            </a:r>
-          </a:p>
-        </p:txBody>
-      </p:sp>
-      <p:sp>
-        <p:nvSpPr>
-          <p:cNvPr id="8" name="">
-            <a:extLst xmlns:a="http://schemas.openxmlformats.org/drawingml/2006/main">
-              <a:ext uri="{FF2B5EF4-FFF2-40B4-BE49-F238E27FC236}">
-                <a16:creationId xmlns:a16="http://schemas.microsoft.com/office/drawing/2014/main" id="{03138E02-F313-4204-B463-19B43645EC2F}"/>
-              </a:ext>
-            </a:extLst>
-          </p:cNvPr>
-          <p:cNvSpPr>
-            <a:spLocks xmlns:a="http://schemas.openxmlformats.org/drawingml/2006/main" noGrp="1"/>
-          </p:cNvSpPr>
-          <p:nvPr/>
-        </p:nvSpPr>
-        <p:spPr>
-          <a:xfrm xmlns:a="http://schemas.openxmlformats.org/drawingml/2006/main">
-            <a:off x="3314700" y="6191250"/>
-            <a:ext cx="781050" cy="266700"/>
-          </a:xfrm>
-          <a:prstGeom xmlns:a="http://schemas.openxmlformats.org/drawingml/2006/main" prst="rect">
-            <a:avLst/>
-          </a:prstGeom>
-          <a:noFill xmlns:a="http://schemas.openxmlformats.org/drawingml/2006/main"/>
-          <a:ln xmlns:a="http://schemas.openxmlformats.org/drawingml/2006/main" w="0">
-            <a:noFill/>
-            <a:prstDash val="solid"/>
-          </a:ln>
-        </p:spPr>
-        <p:txBody>
-          <a:bodyPr xmlns:a="http://schemas.openxmlformats.org/drawingml/2006/main"/>
-          <a:lstStyle xmlns:a="http://schemas.openxmlformats.org/drawingml/2006/main"/>
-          <a:p xmlns:a="http://schemas.openxmlformats.org/drawingml/2006/main">
-            <a:pPr>
-              <a:buNone/>
-              <a:defRPr sz="1275" b="1">
-                <a:solidFill>
-                  <a:srgbClr val="E60000"/>
-                </a:solidFill>
-              </a:defRPr>
-            </a:pPr>
-            <a:r>
-              <a:rPr sz="1275" b="1">
-                <a:solidFill>
-                  <a:srgbClr val="E60000"/>
-                </a:solidFill>
-              </a:rPr>
-              <a:t>ORTA</a:t>
-            </a:r>
-          </a:p>
-        </p:txBody>
-      </p:sp>
-      <p:sp>
-        <p:nvSpPr>
-          <p:cNvPr id="9" name="">
-            <a:extLst xmlns:a="http://schemas.openxmlformats.org/drawingml/2006/main">
-              <a:ext uri="{FF2B5EF4-FFF2-40B4-BE49-F238E27FC236}">
-                <a16:creationId xmlns:a16="http://schemas.microsoft.com/office/drawing/2014/main" id="{9C7C28C3-8A19-4898-A224-88195F970E88}"/>
-              </a:ext>
-            </a:extLst>
-          </p:cNvPr>
-          <p:cNvSpPr>
-            <a:spLocks xmlns:a="http://schemas.openxmlformats.org/drawingml/2006/main" noGrp="1"/>
-          </p:cNvSpPr>
-          <p:nvPr/>
-        </p:nvSpPr>
-        <p:spPr>
-          <a:xfrm xmlns:a="http://schemas.openxmlformats.org/drawingml/2006/main">
-            <a:off x="4095750" y="6134100"/>
-            <a:ext cx="1905000" cy="323850"/>
-          </a:xfrm>
-          <a:prstGeom xmlns:a="http://schemas.openxmlformats.org/drawingml/2006/main" prst="rect">
-            <a:avLst/>
-          </a:prstGeom>
-          <a:noFill xmlns:a="http://schemas.openxmlformats.org/drawingml/2006/main"/>
-          <a:ln xmlns:a="http://schemas.openxmlformats.org/drawingml/2006/main" w="0">
-            <a:noFill/>
-            <a:prstDash val="solid"/>
-          </a:ln>
-        </p:spPr>
-        <p:txBody>
-          <a:bodyPr xmlns:a="http://schemas.openxmlformats.org/drawingml/2006/main"/>
-          <a:lstStyle xmlns:a="http://schemas.openxmlformats.org/drawingml/2006/main"/>
-          <a:p xmlns:a="http://schemas.openxmlformats.org/drawingml/2006/main">
-            <a:pPr>
-              <a:buNone/>
-              <a:defRPr sz="1800" b="1">
-                <a:solidFill>
-                  <a:srgbClr val="070707"/>
-                </a:solidFill>
-              </a:defRPr>
-            </a:pPr>
-            <a:r>
-              <a:rPr sz="1800" b="1">
-                <a:solidFill>
-                  <a:srgbClr val="070707"/>
-                </a:solidFill>
-              </a:rPr>
-              <a:t>Bilgi Akışı</a:t>
-            </a:r>
-          </a:p>
-        </p:txBody>
-      </p:sp>
-      <p:sp>
-        <p:nvSpPr>
-          <p:cNvPr id="10" name="">
-            <a:extLst xmlns:a="http://schemas.openxmlformats.org/drawingml/2006/main">
-              <a:ext uri="{FF2B5EF4-FFF2-40B4-BE49-F238E27FC236}">
-                <a16:creationId xmlns:a16="http://schemas.microsoft.com/office/drawing/2014/main" id="{B276B340-E5ED-4627-B36B-6DCEC1326639}"/>
-              </a:ext>
-            </a:extLst>
-          </p:cNvPr>
-          <p:cNvSpPr>
-            <a:spLocks xmlns:a="http://schemas.openxmlformats.org/drawingml/2006/main" noGrp="1"/>
-          </p:cNvSpPr>
-          <p:nvPr/>
-        </p:nvSpPr>
-        <p:spPr>
-          <a:xfrm xmlns:a="http://schemas.openxmlformats.org/drawingml/2006/main">
-            <a:off x="6781800" y="6191250"/>
-            <a:ext cx="685800" cy="266700"/>
-          </a:xfrm>
-          <a:prstGeom xmlns:a="http://schemas.openxmlformats.org/drawingml/2006/main" prst="rect">
-            <a:avLst/>
-          </a:prstGeom>
-          <a:noFill xmlns:a="http://schemas.openxmlformats.org/drawingml/2006/main"/>
-          <a:ln xmlns:a="http://schemas.openxmlformats.org/drawingml/2006/main" w="0">
-            <a:noFill/>
-            <a:prstDash val="solid"/>
-          </a:ln>
-        </p:spPr>
-        <p:txBody>
-          <a:bodyPr xmlns:a="http://schemas.openxmlformats.org/drawingml/2006/main"/>
-          <a:lstStyle xmlns:a="http://schemas.openxmlformats.org/drawingml/2006/main"/>
-          <a:p xmlns:a="http://schemas.openxmlformats.org/drawingml/2006/main">
-            <a:pPr>
-              <a:buNone/>
-              <a:defRPr sz="1275" b="1">
-                <a:solidFill>
-                  <a:srgbClr val="E60000"/>
-                </a:solidFill>
-              </a:defRPr>
-            </a:pPr>
-            <a:r>
-              <a:rPr sz="1275" b="1">
-                <a:solidFill>
-                  <a:srgbClr val="E60000"/>
-                </a:solidFill>
-              </a:rPr>
-              <a:t>SAG</a:t>
-            </a:r>
-          </a:p>
-        </p:txBody>
-      </p:sp>
-      <p:sp>
-        <p:nvSpPr>
-          <p:cNvPr id="11" name="">
-            <a:extLst xmlns:a="http://schemas.openxmlformats.org/drawingml/2006/main">
-              <a:ext uri="{FF2B5EF4-FFF2-40B4-BE49-F238E27FC236}">
-                <a16:creationId xmlns:a16="http://schemas.microsoft.com/office/drawing/2014/main" id="{FA4A2FD2-7A5B-40BF-AC20-963573BFD92B}"/>
-              </a:ext>
-            </a:extLst>
-          </p:cNvPr>
-          <p:cNvSpPr>
-            <a:spLocks xmlns:a="http://schemas.openxmlformats.org/drawingml/2006/main" noGrp="1"/>
-          </p:cNvSpPr>
-          <p:nvPr/>
-        </p:nvSpPr>
-        <p:spPr>
-          <a:xfrm xmlns:a="http://schemas.openxmlformats.org/drawingml/2006/main">
-            <a:off x="7467600" y="6134100"/>
-            <a:ext cx="1714500" cy="323850"/>
-          </a:xfrm>
-          <a:prstGeom xmlns:a="http://schemas.openxmlformats.org/drawingml/2006/main" prst="rect">
-            <a:avLst/>
-          </a:prstGeom>
-          <a:noFill xmlns:a="http://schemas.openxmlformats.org/drawingml/2006/main"/>
-          <a:ln xmlns:a="http://schemas.openxmlformats.org/drawingml/2006/main" w="0">
-            <a:noFill/>
-            <a:prstDash val="solid"/>
-          </a:ln>
-        </p:spPr>
-        <p:txBody>
-          <a:bodyPr xmlns:a="http://schemas.openxmlformats.org/drawingml/2006/main"/>
-          <a:lstStyle xmlns:a="http://schemas.openxmlformats.org/drawingml/2006/main"/>
-          <a:p xmlns:a="http://schemas.openxmlformats.org/drawingml/2006/main">
-            <a:pPr>
-              <a:buNone/>
-              <a:defRPr sz="1800" b="1">
-                <a:solidFill>
-                  <a:srgbClr val="070707"/>
-                </a:solidFill>
-              </a:defRPr>
-            </a:pPr>
-            <a:r>
-              <a:rPr sz="1800" b="1">
-                <a:solidFill>
-                  <a:srgbClr val="070707"/>
-                </a:solidFill>
-              </a:rPr>
-              <a:t>Robot Twin</a:t>
-            </a:r>
-          </a:p>
-        </p:txBody>
-      </p:sp>
-      <p:sp>
-        <p:nvSpPr>
-          <p:cNvPr id="12" name="">
-            <a:extLst xmlns:a="http://schemas.openxmlformats.org/drawingml/2006/main">
-              <a:ext uri="{FF2B5EF4-FFF2-40B4-BE49-F238E27FC236}">
-                <a16:creationId xmlns:a16="http://schemas.microsoft.com/office/drawing/2014/main" id="{923CBAA1-9A23-4559-90FD-2A02009D3AD8}"/>
-              </a:ext>
-            </a:extLst>
-          </p:cNvPr>
-          <p:cNvSpPr>
-            <a:spLocks xmlns:a="http://schemas.openxmlformats.org/drawingml/2006/main" noGrp="1"/>
-          </p:cNvSpPr>
-          <p:nvPr/>
-        </p:nvSpPr>
-        <p:spPr>
-          <a:xfrm xmlns:a="http://schemas.openxmlformats.org/drawingml/2006/main">
-            <a:off x="9334500" y="6134100"/>
-            <a:ext cx="2476500" cy="323850"/>
-          </a:xfrm>
-          <a:prstGeom xmlns:a="http://schemas.openxmlformats.org/drawingml/2006/main" prst="rect">
-            <a:avLst/>
-          </a:prstGeom>
-          <a:noFill xmlns:a="http://schemas.openxmlformats.org/drawingml/2006/main"/>
-          <a:ln xmlns:a="http://schemas.openxmlformats.org/drawingml/2006/main" w="0">
-            <a:noFill/>
-            <a:prstDash val="solid"/>
-          </a:ln>
-        </p:spPr>
-        <p:txBody>
-          <a:bodyPr xmlns:a="http://schemas.openxmlformats.org/drawingml/2006/main"/>
-          <a:lstStyle xmlns:a="http://schemas.openxmlformats.org/drawingml/2006/main"/>
-          <a:p xmlns:a="http://schemas.openxmlformats.org/drawingml/2006/main">
-            <a:pPr>
-              <a:buNone/>
-              <a:defRPr sz="1800" b="1">
-                <a:solidFill>
-                  <a:srgbClr val="E60000"/>
-                </a:solidFill>
-              </a:defRPr>
-            </a:pPr>
-            <a:r>
-              <a:rPr sz="1800" b="1">
-                <a:solidFill>
-                  <a:srgbClr val="E60000"/>
-                </a:solidFill>
-              </a:rPr>
-              <a:t>Premium control layer</a:t>
-            </a:r>
-          </a:p>
-        </p:txBody>
-      </p:sp>
+                  <a:srgbClr val="F8FAFC"/>
+                </a:solidFill>
+              </a:rPr>
+              <a:t>Operatör soyut komut vermiyor; doğal el hareketi güvenli robot hareketine dönüşüyor.</a:t>
+            </a:r>
+          </a:p>
+        </p:txBody>
+      </p:sp>
+      <p:pic>
+        <p:nvPicPr>
+          <p:cNvPr id="45" name=""/>
+          <p:cNvPicPr>
+            <a:picLocks xmlns:a="http://schemas.openxmlformats.org/drawingml/2006/main" noChangeAspect="1"/>
+          </p:cNvPicPr>
+          <p:nvPr/>
+        </p:nvPicPr>
+        <p:blipFill>
+          <a:blip xmlns:r="http://schemas.openxmlformats.org/officeDocument/2006/relationships" xmlns:a="http://schemas.openxmlformats.org/drawingml/2006/main" r:embed="Rb2cb422796ca4766"/>
+          <a:srcRect xmlns:a="http://schemas.openxmlformats.org/drawingml/2006/main" l="2118" t="0" r="2118" b="0"/>
+          <a:stretch xmlns:a="http://schemas.openxmlformats.org/drawingml/2006/main">
+            <a:fillRect l="0" t="0" r="0" b="0"/>
+          </a:stretch>
+        </p:blipFill>
+        <p:spPr>
+          <a:xfrm xmlns:a="http://schemas.openxmlformats.org/drawingml/2006/main">
+            <a:off x="5591175" y="828675"/>
+            <a:ext cx="6172200" cy="3867150"/>
+          </a:xfrm>
+          <a:prstGeom xmlns:a="http://schemas.openxmlformats.org/drawingml/2006/main" prst="rect">
+            <a:avLst/>
+          </a:prstGeom>
+        </p:spPr>
+      </p:pic>
     </p:spTree>
     <p:extLst>
       <p:ext uri="{BB962C8B-B14F-4D97-AF65-F5344CB8AC3E}">
-        <p14:creationId xmlns:p14="http://schemas.microsoft.com/office/powerpoint/2010/main" val="949906919"/>
+        <p14:creationId xmlns:p14="http://schemas.microsoft.com/office/powerpoint/2010/main" val="1000082208"/>
       </p:ext>
     </p:extLst>
   </p:cSld>
@@ -2128,1571 +2331,6 @@
 </file>
 
 <file path=ppt/slides/slide2.xml><?xml version="1.0" encoding="utf-8"?>
-<p:sld xmlns:p="http://schemas.openxmlformats.org/presentationml/2006/main">
-  <p:cSld>
-    <p:bg>
-      <p:bgPr>
-        <a:solidFill xmlns:a="http://schemas.openxmlformats.org/drawingml/2006/main">
-          <a:srgbClr val="FFFFFF"/>
-        </a:solidFill>
-      </p:bgPr>
-    </p:bg>
-    <p:spTree>
-      <p:nvGrpSpPr>
-        <p:cNvPr id="1" name=""/>
-        <p:cNvGrpSpPr/>
-        <p:nvPr/>
-      </p:nvGrpSpPr>
-      <p:grpSpPr>
-        <a:xfrm xmlns:a="http://schemas.openxmlformats.org/drawingml/2006/main"/>
-      </p:grpSpPr>
-      <p:sp>
-        <p:nvSpPr>
-          <p:cNvPr id="1" name="">
-            <a:extLst xmlns:a="http://schemas.openxmlformats.org/drawingml/2006/main">
-              <a:ext uri="{FF2B5EF4-FFF2-40B4-BE49-F238E27FC236}">
-                <a16:creationId xmlns:a16="http://schemas.microsoft.com/office/drawing/2014/main" id="{E9391501-F59A-4B77-896A-597E6C90D625}"/>
-              </a:ext>
-            </a:extLst>
-          </p:cNvPr>
-          <p:cNvSpPr>
-            <a:spLocks xmlns:a="http://schemas.openxmlformats.org/drawingml/2006/main" noGrp="1"/>
-          </p:cNvSpPr>
-          <p:nvPr/>
-        </p:nvSpPr>
-        <p:spPr>
-          <a:xfrm xmlns:a="http://schemas.openxmlformats.org/drawingml/2006/main">
-            <a:off x="419100" y="342900"/>
-            <a:ext cx="3048000" cy="266700"/>
-          </a:xfrm>
-          <a:prstGeom xmlns:a="http://schemas.openxmlformats.org/drawingml/2006/main" prst="rect">
-            <a:avLst/>
-          </a:prstGeom>
-          <a:noFill xmlns:a="http://schemas.openxmlformats.org/drawingml/2006/main"/>
-          <a:ln xmlns:a="http://schemas.openxmlformats.org/drawingml/2006/main" w="0">
-            <a:noFill/>
-            <a:prstDash val="solid"/>
-          </a:ln>
-        </p:spPr>
-        <p:txBody>
-          <a:bodyPr xmlns:a="http://schemas.openxmlformats.org/drawingml/2006/main"/>
-          <a:lstStyle xmlns:a="http://schemas.openxmlformats.org/drawingml/2006/main"/>
-          <a:p xmlns:a="http://schemas.openxmlformats.org/drawingml/2006/main">
-            <a:pPr>
-              <a:buNone/>
-              <a:defRPr sz="1125" b="1">
-                <a:solidFill>
-                  <a:srgbClr val="555555"/>
-                </a:solidFill>
-              </a:defRPr>
-            </a:pPr>
-            <a:r>
-              <a:rPr sz="1125" b="1">
-                <a:solidFill>
-                  <a:srgbClr val="555555"/>
-                </a:solidFill>
-              </a:rPr>
-              <a:t>ROBOT TELEMETRI</a:t>
-            </a:r>
-          </a:p>
-        </p:txBody>
-      </p:sp>
-      <p:sp>
-        <p:nvSpPr>
-          <p:cNvPr id="2" name="">
-            <a:extLst xmlns:a="http://schemas.openxmlformats.org/drawingml/2006/main">
-              <a:ext uri="{FF2B5EF4-FFF2-40B4-BE49-F238E27FC236}">
-                <a16:creationId xmlns:a16="http://schemas.microsoft.com/office/drawing/2014/main" id="{40BE3168-44F3-49F2-B2D9-5CB7D12EC301}"/>
-              </a:ext>
-            </a:extLst>
-          </p:cNvPr>
-          <p:cNvSpPr>
-            <a:spLocks xmlns:a="http://schemas.openxmlformats.org/drawingml/2006/main" noGrp="1"/>
-          </p:cNvSpPr>
-          <p:nvPr/>
-        </p:nvSpPr>
-        <p:spPr>
-          <a:xfrm xmlns:a="http://schemas.openxmlformats.org/drawingml/2006/main">
-            <a:off x="419100" y="723900"/>
-            <a:ext cx="8191500" cy="1123950"/>
-          </a:xfrm>
-          <a:prstGeom xmlns:a="http://schemas.openxmlformats.org/drawingml/2006/main" prst="rect">
-            <a:avLst/>
-          </a:prstGeom>
-          <a:noFill xmlns:a="http://schemas.openxmlformats.org/drawingml/2006/main"/>
-          <a:ln xmlns:a="http://schemas.openxmlformats.org/drawingml/2006/main" w="0">
-            <a:noFill/>
-            <a:prstDash val="solid"/>
-          </a:ln>
-        </p:spPr>
-        <p:txBody>
-          <a:bodyPr xmlns:a="http://schemas.openxmlformats.org/drawingml/2006/main"/>
-          <a:lstStyle xmlns:a="http://schemas.openxmlformats.org/drawingml/2006/main"/>
-          <a:p xmlns:a="http://schemas.openxmlformats.org/drawingml/2006/main">
-            <a:pPr>
-              <a:buNone/>
-              <a:defRPr sz="3075" b="1">
-                <a:solidFill>
-                  <a:srgbClr val="070707"/>
-                </a:solidFill>
-              </a:defRPr>
-            </a:pPr>
-            <a:r>
-              <a:rPr sz="3075" b="1">
-                <a:solidFill>
-                  <a:srgbClr val="070707"/>
-                </a:solidFill>
-              </a:rPr>
-              <a:t>Uc farkli telemetry hissi ayni deneyime akar.</a:t>
-            </a:r>
-          </a:p>
-        </p:txBody>
-      </p:sp>
-      <p:sp>
-        <p:nvSpPr>
-          <p:cNvPr id="3" name="">
-            <a:extLst xmlns:a="http://schemas.openxmlformats.org/drawingml/2006/main">
-              <a:ext uri="{FF2B5EF4-FFF2-40B4-BE49-F238E27FC236}">
-                <a16:creationId xmlns:a16="http://schemas.microsoft.com/office/drawing/2014/main" id="{4E92559D-A593-4B14-9757-06DC1A15928A}"/>
-              </a:ext>
-            </a:extLst>
-          </p:cNvPr>
-          <p:cNvSpPr>
-            <a:spLocks xmlns:a="http://schemas.openxmlformats.org/drawingml/2006/main" noGrp="1"/>
-          </p:cNvSpPr>
-          <p:nvPr/>
-        </p:nvSpPr>
-        <p:spPr>
-          <a:xfrm xmlns:a="http://schemas.openxmlformats.org/drawingml/2006/main">
-            <a:off x="419100" y="1809750"/>
-            <a:ext cx="8001000" cy="495300"/>
-          </a:xfrm>
-          <a:prstGeom xmlns:a="http://schemas.openxmlformats.org/drawingml/2006/main" prst="rect">
-            <a:avLst/>
-          </a:prstGeom>
-          <a:noFill xmlns:a="http://schemas.openxmlformats.org/drawingml/2006/main"/>
-          <a:ln xmlns:a="http://schemas.openxmlformats.org/drawingml/2006/main" w="0">
-            <a:noFill/>
-            <a:prstDash val="solid"/>
-          </a:ln>
-        </p:spPr>
-        <p:txBody>
-          <a:bodyPr xmlns:a="http://schemas.openxmlformats.org/drawingml/2006/main"/>
-          <a:lstStyle xmlns:a="http://schemas.openxmlformats.org/drawingml/2006/main"/>
-          <a:p xmlns:a="http://schemas.openxmlformats.org/drawingml/2006/main">
-            <a:pPr>
-              <a:buNone/>
-              <a:defRPr sz="1725">
-                <a:solidFill>
-                  <a:srgbClr val="555555"/>
-                </a:solidFill>
-              </a:defRPr>
-            </a:pPr>
-            <a:r>
-              <a:rPr sz="1725">
-                <a:solidFill>
-                  <a:srgbClr val="555555"/>
-                </a:solidFill>
-              </a:rPr>
-              <a:t>Dashboard telemetry, camera stream ve Apple Vision Pro ile robotun sahnesi her yerden okunur.</a:t>
-            </a:r>
-          </a:p>
-        </p:txBody>
-      </p:sp>
-      <p:pic>
-        <p:nvPicPr>
-          <p:cNvPr id="18" name=""/>
-          <p:cNvPicPr>
-            <a:picLocks xmlns:a="http://schemas.openxmlformats.org/drawingml/2006/main" noChangeAspect="1"/>
-          </p:cNvPicPr>
-          <p:nvPr/>
-        </p:nvPicPr>
-        <p:blipFill>
-          <a:blip xmlns:r="http://schemas.openxmlformats.org/officeDocument/2006/relationships" xmlns:a="http://schemas.openxmlformats.org/drawingml/2006/main" r:embed="R4c40f2c458fb4f57"/>
-          <a:srcRect xmlns:a="http://schemas.openxmlformats.org/drawingml/2006/main" l="0" t="6000" r="0" b="6000"/>
-          <a:stretch xmlns:a="http://schemas.openxmlformats.org/drawingml/2006/main">
-            <a:fillRect l="0" t="0" r="0" b="0"/>
-          </a:stretch>
-        </p:blipFill>
-        <p:spPr>
-          <a:xfrm xmlns:a="http://schemas.openxmlformats.org/drawingml/2006/main">
-            <a:off x="419100" y="2571750"/>
-            <a:ext cx="3429000" cy="2095500"/>
-          </a:xfrm>
-          <a:prstGeom xmlns:a="http://schemas.openxmlformats.org/drawingml/2006/main" prst="rect">
-            <a:avLst/>
-          </a:prstGeom>
-        </p:spPr>
-      </p:pic>
-      <p:pic>
-        <p:nvPicPr>
-          <p:cNvPr id="19" name=""/>
-          <p:cNvPicPr>
-            <a:picLocks xmlns:a="http://schemas.openxmlformats.org/drawingml/2006/main" noChangeAspect="1"/>
-          </p:cNvPicPr>
-          <p:nvPr/>
-        </p:nvPicPr>
-        <p:blipFill>
-          <a:blip xmlns:r="http://schemas.openxmlformats.org/officeDocument/2006/relationships" xmlns:a="http://schemas.openxmlformats.org/drawingml/2006/main" r:embed="R5930bac50ce64625"/>
-          <a:srcRect xmlns:a="http://schemas.openxmlformats.org/drawingml/2006/main" l="0" t="6000" r="0" b="6000"/>
-          <a:stretch xmlns:a="http://schemas.openxmlformats.org/drawingml/2006/main">
-            <a:fillRect l="0" t="0" r="0" b="0"/>
-          </a:stretch>
-        </p:blipFill>
-        <p:spPr>
-          <a:xfrm xmlns:a="http://schemas.openxmlformats.org/drawingml/2006/main">
-            <a:off x="4381500" y="2571750"/>
-            <a:ext cx="3429000" cy="2095500"/>
-          </a:xfrm>
-          <a:prstGeom xmlns:a="http://schemas.openxmlformats.org/drawingml/2006/main" prst="rect">
-            <a:avLst/>
-          </a:prstGeom>
-        </p:spPr>
-      </p:pic>
-      <p:pic>
-        <p:nvPicPr>
-          <p:cNvPr id="20" name=""/>
-          <p:cNvPicPr>
-            <a:picLocks xmlns:a="http://schemas.openxmlformats.org/drawingml/2006/main" noChangeAspect="1"/>
-          </p:cNvPicPr>
-          <p:nvPr/>
-        </p:nvPicPr>
-        <p:blipFill>
-          <a:blip xmlns:r="http://schemas.openxmlformats.org/officeDocument/2006/relationships" xmlns:a="http://schemas.openxmlformats.org/drawingml/2006/main" r:embed="Rca7b931ee8e84706"/>
-          <a:srcRect xmlns:a="http://schemas.openxmlformats.org/drawingml/2006/main" l="0" t="6000" r="0" b="6000"/>
-          <a:stretch xmlns:a="http://schemas.openxmlformats.org/drawingml/2006/main">
-            <a:fillRect l="0" t="0" r="0" b="0"/>
-          </a:stretch>
-        </p:blipFill>
-        <p:spPr>
-          <a:xfrm xmlns:a="http://schemas.openxmlformats.org/drawingml/2006/main">
-            <a:off x="8343900" y="2571750"/>
-            <a:ext cx="3429000" cy="2095500"/>
-          </a:xfrm>
-          <a:prstGeom xmlns:a="http://schemas.openxmlformats.org/drawingml/2006/main" prst="rect">
-            <a:avLst/>
-          </a:prstGeom>
-        </p:spPr>
-      </p:pic>
-      <p:sp>
-        <p:nvSpPr>
-          <p:cNvPr id="7" name="">
-            <a:extLst xmlns:a="http://schemas.openxmlformats.org/drawingml/2006/main">
-              <a:ext uri="{FF2B5EF4-FFF2-40B4-BE49-F238E27FC236}">
-                <a16:creationId xmlns:a16="http://schemas.microsoft.com/office/drawing/2014/main" id="{32787206-3F73-43B7-91C7-BAA0BCE30355}"/>
-              </a:ext>
-            </a:extLst>
-          </p:cNvPr>
-          <p:cNvSpPr>
-            <a:spLocks xmlns:a="http://schemas.openxmlformats.org/drawingml/2006/main" noGrp="1"/>
-          </p:cNvSpPr>
-          <p:nvPr/>
-        </p:nvSpPr>
-        <p:spPr>
-          <a:xfrm xmlns:a="http://schemas.openxmlformats.org/drawingml/2006/main">
-            <a:off x="419100" y="5029200"/>
-            <a:ext cx="11353800" cy="19050"/>
-          </a:xfrm>
-          <a:prstGeom xmlns:a="http://schemas.openxmlformats.org/drawingml/2006/main" prst="rect">
-            <a:avLst/>
-          </a:prstGeom>
-          <a:solidFill xmlns:a="http://schemas.openxmlformats.org/drawingml/2006/main">
-            <a:srgbClr val="B8BCC4"/>
-          </a:solidFill>
-          <a:ln xmlns:a="http://schemas.openxmlformats.org/drawingml/2006/main" w="0">
-            <a:solidFill>
-              <a:srgbClr val="B8BCC4"/>
-            </a:solidFill>
-            <a:prstDash val="solid"/>
-          </a:ln>
-        </p:spPr>
-      </p:sp>
-      <p:sp>
-        <p:nvSpPr>
-          <p:cNvPr id="8" name="">
-            <a:extLst xmlns:a="http://schemas.openxmlformats.org/drawingml/2006/main">
-              <a:ext uri="{FF2B5EF4-FFF2-40B4-BE49-F238E27FC236}">
-                <a16:creationId xmlns:a16="http://schemas.microsoft.com/office/drawing/2014/main" id="{9B59EDD2-F6A7-4DCD-9453-BD8D3C7E3CE3}"/>
-              </a:ext>
-            </a:extLst>
-          </p:cNvPr>
-          <p:cNvSpPr>
-            <a:spLocks xmlns:a="http://schemas.openxmlformats.org/drawingml/2006/main" noGrp="1"/>
-          </p:cNvSpPr>
-          <p:nvPr/>
-        </p:nvSpPr>
-        <p:spPr>
-          <a:xfrm xmlns:a="http://schemas.openxmlformats.org/drawingml/2006/main">
-            <a:off x="419100" y="5391150"/>
-            <a:ext cx="2667000" cy="323850"/>
-          </a:xfrm>
-          <a:prstGeom xmlns:a="http://schemas.openxmlformats.org/drawingml/2006/main" prst="rect">
-            <a:avLst/>
-          </a:prstGeom>
-          <a:noFill xmlns:a="http://schemas.openxmlformats.org/drawingml/2006/main"/>
-          <a:ln xmlns:a="http://schemas.openxmlformats.org/drawingml/2006/main" w="0">
-            <a:noFill/>
-            <a:prstDash val="solid"/>
-          </a:ln>
-        </p:spPr>
-        <p:txBody>
-          <a:bodyPr xmlns:a="http://schemas.openxmlformats.org/drawingml/2006/main"/>
-          <a:lstStyle xmlns:a="http://schemas.openxmlformats.org/drawingml/2006/main"/>
-          <a:p xmlns:a="http://schemas.openxmlformats.org/drawingml/2006/main">
-            <a:pPr>
-              <a:buNone/>
-              <a:defRPr sz="1800" b="1">
-                <a:solidFill>
-                  <a:srgbClr val="070707"/>
-                </a:solidFill>
-              </a:defRPr>
-            </a:pPr>
-            <a:r>
-              <a:rPr sz="1800" b="1">
-                <a:solidFill>
-                  <a:srgbClr val="070707"/>
-                </a:solidFill>
-              </a:rPr>
-              <a:t>1. Live Dashboard</a:t>
-            </a:r>
-          </a:p>
-        </p:txBody>
-      </p:sp>
-      <p:sp>
-        <p:nvSpPr>
-          <p:cNvPr id="9" name="">
-            <a:extLst xmlns:a="http://schemas.openxmlformats.org/drawingml/2006/main">
-              <a:ext uri="{FF2B5EF4-FFF2-40B4-BE49-F238E27FC236}">
-                <a16:creationId xmlns:a16="http://schemas.microsoft.com/office/drawing/2014/main" id="{1E24DB14-D666-4BB4-9E6C-B0A7EFC0887E}"/>
-              </a:ext>
-            </a:extLst>
-          </p:cNvPr>
-          <p:cNvSpPr>
-            <a:spLocks xmlns:a="http://schemas.openxmlformats.org/drawingml/2006/main" noGrp="1"/>
-          </p:cNvSpPr>
-          <p:nvPr/>
-        </p:nvSpPr>
-        <p:spPr>
-          <a:xfrm xmlns:a="http://schemas.openxmlformats.org/drawingml/2006/main">
-            <a:off x="4381500" y="5391150"/>
-            <a:ext cx="2762250" cy="323850"/>
-          </a:xfrm>
-          <a:prstGeom xmlns:a="http://schemas.openxmlformats.org/drawingml/2006/main" prst="rect">
-            <a:avLst/>
-          </a:prstGeom>
-          <a:noFill xmlns:a="http://schemas.openxmlformats.org/drawingml/2006/main"/>
-          <a:ln xmlns:a="http://schemas.openxmlformats.org/drawingml/2006/main" w="0">
-            <a:noFill/>
-            <a:prstDash val="solid"/>
-          </a:ln>
-        </p:spPr>
-        <p:txBody>
-          <a:bodyPr xmlns:a="http://schemas.openxmlformats.org/drawingml/2006/main"/>
-          <a:lstStyle xmlns:a="http://schemas.openxmlformats.org/drawingml/2006/main"/>
-          <a:p xmlns:a="http://schemas.openxmlformats.org/drawingml/2006/main">
-            <a:pPr>
-              <a:buNone/>
-              <a:defRPr sz="1800" b="1">
-                <a:solidFill>
-                  <a:srgbClr val="070707"/>
-                </a:solidFill>
-              </a:defRPr>
-            </a:pPr>
-            <a:r>
-              <a:rPr sz="1800" b="1">
-                <a:solidFill>
-                  <a:srgbClr val="070707"/>
-                </a:solidFill>
-              </a:rPr>
-              <a:t>2. Camera Stream</a:t>
-            </a:r>
-          </a:p>
-        </p:txBody>
-      </p:sp>
-      <p:sp>
-        <p:nvSpPr>
-          <p:cNvPr id="10" name="">
-            <a:extLst xmlns:a="http://schemas.openxmlformats.org/drawingml/2006/main">
-              <a:ext uri="{FF2B5EF4-FFF2-40B4-BE49-F238E27FC236}">
-                <a16:creationId xmlns:a16="http://schemas.microsoft.com/office/drawing/2014/main" id="{345C3BDC-BC9E-4535-B5A2-2032A05C7295}"/>
-              </a:ext>
-            </a:extLst>
-          </p:cNvPr>
-          <p:cNvSpPr>
-            <a:spLocks xmlns:a="http://schemas.openxmlformats.org/drawingml/2006/main" noGrp="1"/>
-          </p:cNvSpPr>
-          <p:nvPr/>
-        </p:nvSpPr>
-        <p:spPr>
-          <a:xfrm xmlns:a="http://schemas.openxmlformats.org/drawingml/2006/main">
-            <a:off x="8343900" y="5391150"/>
-            <a:ext cx="2952750" cy="323850"/>
-          </a:xfrm>
-          <a:prstGeom xmlns:a="http://schemas.openxmlformats.org/drawingml/2006/main" prst="rect">
-            <a:avLst/>
-          </a:prstGeom>
-          <a:noFill xmlns:a="http://schemas.openxmlformats.org/drawingml/2006/main"/>
-          <a:ln xmlns:a="http://schemas.openxmlformats.org/drawingml/2006/main" w="0">
-            <a:noFill/>
-            <a:prstDash val="solid"/>
-          </a:ln>
-        </p:spPr>
-        <p:txBody>
-          <a:bodyPr xmlns:a="http://schemas.openxmlformats.org/drawingml/2006/main"/>
-          <a:lstStyle xmlns:a="http://schemas.openxmlformats.org/drawingml/2006/main"/>
-          <a:p xmlns:a="http://schemas.openxmlformats.org/drawingml/2006/main">
-            <a:pPr>
-              <a:buNone/>
-              <a:defRPr sz="1800" b="1">
-                <a:solidFill>
-                  <a:srgbClr val="E60000"/>
-                </a:solidFill>
-              </a:defRPr>
-            </a:pPr>
-            <a:r>
-              <a:rPr sz="1800" b="1">
-                <a:solidFill>
-                  <a:srgbClr val="E60000"/>
-                </a:solidFill>
-              </a:rPr>
-              <a:t>3. Apple Vision Pro</a:t>
-            </a:r>
-          </a:p>
-        </p:txBody>
-      </p:sp>
-      <p:sp>
-        <p:nvSpPr>
-          <p:cNvPr id="11" name="">
-            <a:extLst xmlns:a="http://schemas.openxmlformats.org/drawingml/2006/main">
-              <a:ext uri="{FF2B5EF4-FFF2-40B4-BE49-F238E27FC236}">
-                <a16:creationId xmlns:a16="http://schemas.microsoft.com/office/drawing/2014/main" id="{050630EB-4448-4F88-8542-00BA4D8E514D}"/>
-              </a:ext>
-            </a:extLst>
-          </p:cNvPr>
-          <p:cNvSpPr>
-            <a:spLocks xmlns:a="http://schemas.openxmlformats.org/drawingml/2006/main" noGrp="1"/>
-          </p:cNvSpPr>
-          <p:nvPr/>
-        </p:nvSpPr>
-        <p:spPr>
-          <a:xfrm xmlns:a="http://schemas.openxmlformats.org/drawingml/2006/main">
-            <a:off x="419100" y="6076950"/>
-            <a:ext cx="7620000" cy="285750"/>
-          </a:xfrm>
-          <a:prstGeom xmlns:a="http://schemas.openxmlformats.org/drawingml/2006/main" prst="rect">
-            <a:avLst/>
-          </a:prstGeom>
-          <a:noFill xmlns:a="http://schemas.openxmlformats.org/drawingml/2006/main"/>
-          <a:ln xmlns:a="http://schemas.openxmlformats.org/drawingml/2006/main" w="0">
-            <a:noFill/>
-            <a:prstDash val="solid"/>
-          </a:ln>
-        </p:spPr>
-        <p:txBody>
-          <a:bodyPr xmlns:a="http://schemas.openxmlformats.org/drawingml/2006/main"/>
-          <a:lstStyle xmlns:a="http://schemas.openxmlformats.org/drawingml/2006/main"/>
-          <a:p xmlns:a="http://schemas.openxmlformats.org/drawingml/2006/main">
-            <a:pPr>
-              <a:buNone/>
-              <a:defRPr sz="1650">
-                <a:solidFill>
-                  <a:srgbClr val="555555"/>
-                </a:solidFill>
-              </a:defRPr>
-            </a:pPr>
-            <a:r>
-              <a:rPr sz="1650">
-                <a:solidFill>
-                  <a:srgbClr val="555555"/>
-                </a:solidFill>
-              </a:rPr>
-              <a:t>Real-time awareness / XR presence / Operator confidence</a:t>
-            </a:r>
-          </a:p>
-        </p:txBody>
-      </p:sp>
-    </p:spTree>
-    <p:extLst>
-      <p:ext uri="{BB962C8B-B14F-4D97-AF65-F5344CB8AC3E}">
-        <p14:creationId xmlns:p14="http://schemas.microsoft.com/office/powerpoint/2010/main" val="524761687"/>
-      </p:ext>
-    </p:extLst>
-  </p:cSld>
-</p:sld>
-</file>
-
-<file path=ppt/slides/slide3.xml><?xml version="1.0" encoding="utf-8"?>
-<p:sld xmlns:p="http://schemas.openxmlformats.org/presentationml/2006/main">
-  <p:cSld>
-    <p:bg>
-      <p:bgPr>
-        <a:solidFill xmlns:a="http://schemas.openxmlformats.org/drawingml/2006/main">
-          <a:srgbClr val="FFFFFF"/>
-        </a:solidFill>
-      </p:bgPr>
-    </p:bg>
-    <p:spTree>
-      <p:nvGrpSpPr>
-        <p:cNvPr id="1" name=""/>
-        <p:cNvGrpSpPr/>
-        <p:nvPr/>
-      </p:nvGrpSpPr>
-      <p:grpSpPr>
-        <a:xfrm xmlns:a="http://schemas.openxmlformats.org/drawingml/2006/main"/>
-      </p:grpSpPr>
-      <p:pic>
-        <p:nvPicPr>
-          <p:cNvPr id="14" name=""/>
-          <p:cNvPicPr>
-            <a:picLocks xmlns:a="http://schemas.openxmlformats.org/drawingml/2006/main" noChangeAspect="1"/>
-          </p:cNvPicPr>
-          <p:nvPr/>
-        </p:nvPicPr>
-        <p:blipFill>
-          <a:blip xmlns:r="http://schemas.openxmlformats.org/officeDocument/2006/relationships" xmlns:a="http://schemas.openxmlformats.org/drawingml/2006/main" r:embed="Rdc1592a1d89343d6"/>
-          <a:srcRect xmlns:a="http://schemas.openxmlformats.org/drawingml/2006/main" l="18895" t="0" r="18895" b="0"/>
-          <a:stretch xmlns:a="http://schemas.openxmlformats.org/drawingml/2006/main">
-            <a:fillRect l="0" t="0" r="0" b="0"/>
-          </a:stretch>
-        </p:blipFill>
-        <p:spPr>
-          <a:xfrm xmlns:a="http://schemas.openxmlformats.org/drawingml/2006/main">
-            <a:off x="0" y="0"/>
-            <a:ext cx="6143625" cy="6858000"/>
-          </a:xfrm>
-          <a:prstGeom xmlns:a="http://schemas.openxmlformats.org/drawingml/2006/main" prst="rect">
-            <a:avLst/>
-          </a:prstGeom>
-        </p:spPr>
-      </p:pic>
-      <p:sp>
-        <p:nvSpPr>
-          <p:cNvPr id="2" name="">
-            <a:extLst xmlns:a="http://schemas.openxmlformats.org/drawingml/2006/main">
-              <a:ext uri="{FF2B5EF4-FFF2-40B4-BE49-F238E27FC236}">
-                <a16:creationId xmlns:a16="http://schemas.microsoft.com/office/drawing/2014/main" id="{D77E6AED-FC7B-499D-AEF4-C828A2EEF758}"/>
-              </a:ext>
-            </a:extLst>
-          </p:cNvPr>
-          <p:cNvSpPr>
-            <a:spLocks xmlns:a="http://schemas.openxmlformats.org/drawingml/2006/main" noGrp="1"/>
-          </p:cNvSpPr>
-          <p:nvPr/>
-        </p:nvSpPr>
-        <p:spPr>
-          <a:xfrm xmlns:a="http://schemas.openxmlformats.org/drawingml/2006/main">
-            <a:off x="6143625" y="0"/>
-            <a:ext cx="6048375" cy="6858000"/>
-          </a:xfrm>
-          <a:prstGeom xmlns:a="http://schemas.openxmlformats.org/drawingml/2006/main" prst="rect">
-            <a:avLst/>
-          </a:prstGeom>
-          <a:solidFill xmlns:a="http://schemas.openxmlformats.org/drawingml/2006/main">
-            <a:srgbClr val="FFFFFF"/>
-          </a:solidFill>
-          <a:ln xmlns:a="http://schemas.openxmlformats.org/drawingml/2006/main" w="0">
-            <a:noFill/>
-            <a:prstDash val="solid"/>
-          </a:ln>
-        </p:spPr>
-      </p:sp>
-      <p:sp>
-        <p:nvSpPr>
-          <p:cNvPr id="3" name="">
-            <a:extLst xmlns:a="http://schemas.openxmlformats.org/drawingml/2006/main">
-              <a:ext uri="{FF2B5EF4-FFF2-40B4-BE49-F238E27FC236}">
-                <a16:creationId xmlns:a16="http://schemas.microsoft.com/office/drawing/2014/main" id="{1AC42EDA-D3A7-4652-A87C-406291FD54EB}"/>
-              </a:ext>
-            </a:extLst>
-          </p:cNvPr>
-          <p:cNvSpPr>
-            <a:spLocks xmlns:a="http://schemas.openxmlformats.org/drawingml/2006/main" noGrp="1"/>
-          </p:cNvSpPr>
-          <p:nvPr/>
-        </p:nvSpPr>
-        <p:spPr>
-          <a:xfrm xmlns:a="http://schemas.openxmlformats.org/drawingml/2006/main">
-            <a:off x="6705600" y="514350"/>
-            <a:ext cx="3048000" cy="266700"/>
-          </a:xfrm>
-          <a:prstGeom xmlns:a="http://schemas.openxmlformats.org/drawingml/2006/main" prst="rect">
-            <a:avLst/>
-          </a:prstGeom>
-          <a:noFill xmlns:a="http://schemas.openxmlformats.org/drawingml/2006/main"/>
-          <a:ln xmlns:a="http://schemas.openxmlformats.org/drawingml/2006/main" w="0">
-            <a:noFill/>
-            <a:prstDash val="solid"/>
-          </a:ln>
-        </p:spPr>
-        <p:txBody>
-          <a:bodyPr xmlns:a="http://schemas.openxmlformats.org/drawingml/2006/main"/>
-          <a:lstStyle xmlns:a="http://schemas.openxmlformats.org/drawingml/2006/main"/>
-          <a:p xmlns:a="http://schemas.openxmlformats.org/drawingml/2006/main">
-            <a:pPr>
-              <a:buNone/>
-              <a:defRPr sz="1125" b="1">
-                <a:solidFill>
-                  <a:srgbClr val="555555"/>
-                </a:solidFill>
-              </a:defRPr>
-            </a:pPr>
-            <a:r>
-              <a:rPr sz="1125" b="1">
-                <a:solidFill>
-                  <a:srgbClr val="555555"/>
-                </a:solidFill>
-              </a:rPr>
-              <a:t>MOTION SEQUENCE PLANNING</a:t>
-            </a:r>
-          </a:p>
-        </p:txBody>
-      </p:sp>
-      <p:sp>
-        <p:nvSpPr>
-          <p:cNvPr id="4" name="">
-            <a:extLst xmlns:a="http://schemas.openxmlformats.org/drawingml/2006/main">
-              <a:ext uri="{FF2B5EF4-FFF2-40B4-BE49-F238E27FC236}">
-                <a16:creationId xmlns:a16="http://schemas.microsoft.com/office/drawing/2014/main" id="{C0CCD265-0705-4970-9E51-8691E25A430B}"/>
-              </a:ext>
-            </a:extLst>
-          </p:cNvPr>
-          <p:cNvSpPr>
-            <a:spLocks xmlns:a="http://schemas.openxmlformats.org/drawingml/2006/main" noGrp="1"/>
-          </p:cNvSpPr>
-          <p:nvPr/>
-        </p:nvSpPr>
-        <p:spPr>
-          <a:xfrm xmlns:a="http://schemas.openxmlformats.org/drawingml/2006/main">
-            <a:off x="6705600" y="952500"/>
-            <a:ext cx="4629150" cy="1123950"/>
-          </a:xfrm>
-          <a:prstGeom xmlns:a="http://schemas.openxmlformats.org/drawingml/2006/main" prst="rect">
-            <a:avLst/>
-          </a:prstGeom>
-          <a:noFill xmlns:a="http://schemas.openxmlformats.org/drawingml/2006/main"/>
-          <a:ln xmlns:a="http://schemas.openxmlformats.org/drawingml/2006/main" w="0">
-            <a:noFill/>
-            <a:prstDash val="solid"/>
-          </a:ln>
-        </p:spPr>
-        <p:txBody>
-          <a:bodyPr xmlns:a="http://schemas.openxmlformats.org/drawingml/2006/main"/>
-          <a:lstStyle xmlns:a="http://schemas.openxmlformats.org/drawingml/2006/main"/>
-          <a:p xmlns:a="http://schemas.openxmlformats.org/drawingml/2006/main">
-            <a:pPr>
-              <a:buNone/>
-              <a:defRPr sz="3150" b="1">
-                <a:solidFill>
-                  <a:srgbClr val="070707"/>
-                </a:solidFill>
-              </a:defRPr>
-            </a:pPr>
-            <a:r>
-              <a:rPr sz="3150" b="1">
-                <a:solidFill>
-                  <a:srgbClr val="070707"/>
-                </a:solidFill>
-              </a:rPr>
-              <a:t>Hareket artik bir sequence haline geliyor.</a:t>
-            </a:r>
-          </a:p>
-        </p:txBody>
-      </p:sp>
-      <p:sp>
-        <p:nvSpPr>
-          <p:cNvPr id="5" name="">
-            <a:extLst xmlns:a="http://schemas.openxmlformats.org/drawingml/2006/main">
-              <a:ext uri="{FF2B5EF4-FFF2-40B4-BE49-F238E27FC236}">
-                <a16:creationId xmlns:a16="http://schemas.microsoft.com/office/drawing/2014/main" id="{C2A9C5E7-ED72-4920-9BF8-2D096BF2DB3F}"/>
-              </a:ext>
-            </a:extLst>
-          </p:cNvPr>
-          <p:cNvSpPr>
-            <a:spLocks xmlns:a="http://schemas.openxmlformats.org/drawingml/2006/main" noGrp="1"/>
-          </p:cNvSpPr>
-          <p:nvPr/>
-        </p:nvSpPr>
-        <p:spPr>
-          <a:xfrm xmlns:a="http://schemas.openxmlformats.org/drawingml/2006/main">
-            <a:off x="6743700" y="2724150"/>
-            <a:ext cx="4457700" cy="666750"/>
-          </a:xfrm>
-          <a:prstGeom xmlns:a="http://schemas.openxmlformats.org/drawingml/2006/main" prst="rect">
-            <a:avLst/>
-          </a:prstGeom>
-          <a:noFill xmlns:a="http://schemas.openxmlformats.org/drawingml/2006/main"/>
-          <a:ln xmlns:a="http://schemas.openxmlformats.org/drawingml/2006/main" w="0">
-            <a:noFill/>
-            <a:prstDash val="solid"/>
-          </a:ln>
-        </p:spPr>
-        <p:txBody>
-          <a:bodyPr xmlns:a="http://schemas.openxmlformats.org/drawingml/2006/main"/>
-          <a:lstStyle xmlns:a="http://schemas.openxmlformats.org/drawingml/2006/main"/>
-          <a:p xmlns:a="http://schemas.openxmlformats.org/drawingml/2006/main">
-            <a:pPr>
-              <a:buNone/>
-              <a:defRPr sz="1725">
-                <a:solidFill>
-                  <a:srgbClr val="555555"/>
-                </a:solidFill>
-              </a:defRPr>
-            </a:pPr>
-            <a:r>
-              <a:rPr sz="1725">
-                <a:solidFill>
-                  <a:srgbClr val="555555"/>
-                </a:solidFill>
-              </a:rPr>
-              <a:t>Pose point kaydet, sequence kur, trajectory preview izle. Robot hareketi demo diline donusur.</a:t>
-            </a:r>
-          </a:p>
-        </p:txBody>
-      </p:sp>
-      <p:sp>
-        <p:nvSpPr>
-          <p:cNvPr id="6" name="">
-            <a:extLst xmlns:a="http://schemas.openxmlformats.org/drawingml/2006/main">
-              <a:ext uri="{FF2B5EF4-FFF2-40B4-BE49-F238E27FC236}">
-                <a16:creationId xmlns:a16="http://schemas.microsoft.com/office/drawing/2014/main" id="{849968E8-43A1-463A-AF5C-DB49A522AD17}"/>
-              </a:ext>
-            </a:extLst>
-          </p:cNvPr>
-          <p:cNvSpPr>
-            <a:spLocks xmlns:a="http://schemas.openxmlformats.org/drawingml/2006/main" noGrp="1"/>
-          </p:cNvSpPr>
-          <p:nvPr/>
-        </p:nvSpPr>
-        <p:spPr>
-          <a:xfrm xmlns:a="http://schemas.openxmlformats.org/drawingml/2006/main">
-            <a:off x="6705600" y="3638550"/>
-            <a:ext cx="4114800" cy="19050"/>
-          </a:xfrm>
-          <a:prstGeom xmlns:a="http://schemas.openxmlformats.org/drawingml/2006/main" prst="rect">
-            <a:avLst/>
-          </a:prstGeom>
-          <a:solidFill xmlns:a="http://schemas.openxmlformats.org/drawingml/2006/main">
-            <a:srgbClr val="E60000"/>
-          </a:solidFill>
-          <a:ln xmlns:a="http://schemas.openxmlformats.org/drawingml/2006/main" w="0">
-            <a:solidFill>
-              <a:srgbClr val="E60000"/>
-            </a:solidFill>
-            <a:prstDash val="solid"/>
-          </a:ln>
-        </p:spPr>
-      </p:sp>
-      <p:sp>
-        <p:nvSpPr>
-          <p:cNvPr id="7" name="">
-            <a:extLst xmlns:a="http://schemas.openxmlformats.org/drawingml/2006/main">
-              <a:ext uri="{FF2B5EF4-FFF2-40B4-BE49-F238E27FC236}">
-                <a16:creationId xmlns:a16="http://schemas.microsoft.com/office/drawing/2014/main" id="{FFA18113-6B5A-4B47-94AE-68E4A0067557}"/>
-              </a:ext>
-            </a:extLst>
-          </p:cNvPr>
-          <p:cNvSpPr>
-            <a:spLocks xmlns:a="http://schemas.openxmlformats.org/drawingml/2006/main" noGrp="1"/>
-          </p:cNvSpPr>
-          <p:nvPr/>
-        </p:nvSpPr>
-        <p:spPr>
-          <a:xfrm xmlns:a="http://schemas.openxmlformats.org/drawingml/2006/main">
-            <a:off x="6705600" y="3981450"/>
-            <a:ext cx="1905000" cy="323850"/>
-          </a:xfrm>
-          <a:prstGeom xmlns:a="http://schemas.openxmlformats.org/drawingml/2006/main" prst="rect">
-            <a:avLst/>
-          </a:prstGeom>
-          <a:noFill xmlns:a="http://schemas.openxmlformats.org/drawingml/2006/main"/>
-          <a:ln xmlns:a="http://schemas.openxmlformats.org/drawingml/2006/main" w="0">
-            <a:noFill/>
-            <a:prstDash val="solid"/>
-          </a:ln>
-        </p:spPr>
-        <p:txBody>
-          <a:bodyPr xmlns:a="http://schemas.openxmlformats.org/drawingml/2006/main"/>
-          <a:lstStyle xmlns:a="http://schemas.openxmlformats.org/drawingml/2006/main"/>
-          <a:p xmlns:a="http://schemas.openxmlformats.org/drawingml/2006/main">
-            <a:pPr>
-              <a:buNone/>
-              <a:defRPr sz="1800" b="1">
-                <a:solidFill>
-                  <a:srgbClr val="070707"/>
-                </a:solidFill>
-              </a:defRPr>
-            </a:pPr>
-            <a:r>
-              <a:rPr sz="1800" b="1">
-                <a:solidFill>
-                  <a:srgbClr val="070707"/>
-                </a:solidFill>
-              </a:rPr>
-              <a:t>Add Point</a:t>
-            </a:r>
-          </a:p>
-        </p:txBody>
-      </p:sp>
-      <p:sp>
-        <p:nvSpPr>
-          <p:cNvPr id="8" name="">
-            <a:extLst xmlns:a="http://schemas.openxmlformats.org/drawingml/2006/main">
-              <a:ext uri="{FF2B5EF4-FFF2-40B4-BE49-F238E27FC236}">
-                <a16:creationId xmlns:a16="http://schemas.microsoft.com/office/drawing/2014/main" id="{2F3951D8-2870-43F2-A0E0-EF591516EFB7}"/>
-              </a:ext>
-            </a:extLst>
-          </p:cNvPr>
-          <p:cNvSpPr>
-            <a:spLocks xmlns:a="http://schemas.openxmlformats.org/drawingml/2006/main" noGrp="1"/>
-          </p:cNvSpPr>
-          <p:nvPr/>
-        </p:nvSpPr>
-        <p:spPr>
-          <a:xfrm xmlns:a="http://schemas.openxmlformats.org/drawingml/2006/main">
-            <a:off x="6705600" y="4362450"/>
-            <a:ext cx="2095500" cy="323850"/>
-          </a:xfrm>
-          <a:prstGeom xmlns:a="http://schemas.openxmlformats.org/drawingml/2006/main" prst="rect">
-            <a:avLst/>
-          </a:prstGeom>
-          <a:noFill xmlns:a="http://schemas.openxmlformats.org/drawingml/2006/main"/>
-          <a:ln xmlns:a="http://schemas.openxmlformats.org/drawingml/2006/main" w="0">
-            <a:noFill/>
-            <a:prstDash val="solid"/>
-          </a:ln>
-        </p:spPr>
-        <p:txBody>
-          <a:bodyPr xmlns:a="http://schemas.openxmlformats.org/drawingml/2006/main"/>
-          <a:lstStyle xmlns:a="http://schemas.openxmlformats.org/drawingml/2006/main"/>
-          <a:p xmlns:a="http://schemas.openxmlformats.org/drawingml/2006/main">
-            <a:pPr>
-              <a:buNone/>
-              <a:defRPr sz="1800" b="1">
-                <a:solidFill>
-                  <a:srgbClr val="070707"/>
-                </a:solidFill>
-              </a:defRPr>
-            </a:pPr>
-            <a:r>
-              <a:rPr sz="1800" b="1">
-                <a:solidFill>
-                  <a:srgbClr val="070707"/>
-                </a:solidFill>
-              </a:rPr>
-              <a:t>Pose Capture</a:t>
-            </a:r>
-          </a:p>
-        </p:txBody>
-      </p:sp>
-      <p:sp>
-        <p:nvSpPr>
-          <p:cNvPr id="9" name="">
-            <a:extLst xmlns:a="http://schemas.openxmlformats.org/drawingml/2006/main">
-              <a:ext uri="{FF2B5EF4-FFF2-40B4-BE49-F238E27FC236}">
-                <a16:creationId xmlns:a16="http://schemas.microsoft.com/office/drawing/2014/main" id="{579D0AFF-419D-4B44-8ADB-61ADA585AF94}"/>
-              </a:ext>
-            </a:extLst>
-          </p:cNvPr>
-          <p:cNvSpPr>
-            <a:spLocks xmlns:a="http://schemas.openxmlformats.org/drawingml/2006/main" noGrp="1"/>
-          </p:cNvSpPr>
-          <p:nvPr/>
-        </p:nvSpPr>
-        <p:spPr>
-          <a:xfrm xmlns:a="http://schemas.openxmlformats.org/drawingml/2006/main">
-            <a:off x="6705600" y="4743450"/>
-            <a:ext cx="2476500" cy="323850"/>
-          </a:xfrm>
-          <a:prstGeom xmlns:a="http://schemas.openxmlformats.org/drawingml/2006/main" prst="rect">
-            <a:avLst/>
-          </a:prstGeom>
-          <a:noFill xmlns:a="http://schemas.openxmlformats.org/drawingml/2006/main"/>
-          <a:ln xmlns:a="http://schemas.openxmlformats.org/drawingml/2006/main" w="0">
-            <a:noFill/>
-            <a:prstDash val="solid"/>
-          </a:ln>
-        </p:spPr>
-        <p:txBody>
-          <a:bodyPr xmlns:a="http://schemas.openxmlformats.org/drawingml/2006/main"/>
-          <a:lstStyle xmlns:a="http://schemas.openxmlformats.org/drawingml/2006/main"/>
-          <a:p xmlns:a="http://schemas.openxmlformats.org/drawingml/2006/main">
-            <a:pPr>
-              <a:buNone/>
-              <a:defRPr sz="1800" b="1">
-                <a:solidFill>
-                  <a:srgbClr val="E60000"/>
-                </a:solidFill>
-              </a:defRPr>
-            </a:pPr>
-            <a:r>
-              <a:rPr sz="1800" b="1">
-                <a:solidFill>
-                  <a:srgbClr val="E60000"/>
-                </a:solidFill>
-              </a:rPr>
-              <a:t>Sequence Builder</a:t>
-            </a:r>
-          </a:p>
-        </p:txBody>
-      </p:sp>
-      <p:sp>
-        <p:nvSpPr>
-          <p:cNvPr id="10" name="">
-            <a:extLst xmlns:a="http://schemas.openxmlformats.org/drawingml/2006/main">
-              <a:ext uri="{FF2B5EF4-FFF2-40B4-BE49-F238E27FC236}">
-                <a16:creationId xmlns:a16="http://schemas.microsoft.com/office/drawing/2014/main" id="{E7F372EA-DA9E-44AD-8AA1-C3D897C2E15C}"/>
-              </a:ext>
-            </a:extLst>
-          </p:cNvPr>
-          <p:cNvSpPr>
-            <a:spLocks xmlns:a="http://schemas.openxmlformats.org/drawingml/2006/main" noGrp="1"/>
-          </p:cNvSpPr>
-          <p:nvPr/>
-        </p:nvSpPr>
-        <p:spPr>
-          <a:xfrm xmlns:a="http://schemas.openxmlformats.org/drawingml/2006/main">
-            <a:off x="6705600" y="5124450"/>
-            <a:ext cx="2857500" cy="323850"/>
-          </a:xfrm>
-          <a:prstGeom xmlns:a="http://schemas.openxmlformats.org/drawingml/2006/main" prst="rect">
-            <a:avLst/>
-          </a:prstGeom>
-          <a:noFill xmlns:a="http://schemas.openxmlformats.org/drawingml/2006/main"/>
-          <a:ln xmlns:a="http://schemas.openxmlformats.org/drawingml/2006/main" w="0">
-            <a:noFill/>
-            <a:prstDash val="solid"/>
-          </a:ln>
-        </p:spPr>
-        <p:txBody>
-          <a:bodyPr xmlns:a="http://schemas.openxmlformats.org/drawingml/2006/main"/>
-          <a:lstStyle xmlns:a="http://schemas.openxmlformats.org/drawingml/2006/main"/>
-          <a:p xmlns:a="http://schemas.openxmlformats.org/drawingml/2006/main">
-            <a:pPr>
-              <a:buNone/>
-              <a:defRPr sz="1800" b="1">
-                <a:solidFill>
-                  <a:srgbClr val="070707"/>
-                </a:solidFill>
-              </a:defRPr>
-            </a:pPr>
-            <a:r>
-              <a:rPr sz="1800" b="1">
-                <a:solidFill>
-                  <a:srgbClr val="070707"/>
-                </a:solidFill>
-              </a:rPr>
-              <a:t>Trajectory Planning</a:t>
-            </a:r>
-          </a:p>
-        </p:txBody>
-      </p:sp>
-      <p:sp>
-        <p:nvSpPr>
-          <p:cNvPr id="11" name="">
-            <a:extLst xmlns:a="http://schemas.openxmlformats.org/drawingml/2006/main">
-              <a:ext uri="{FF2B5EF4-FFF2-40B4-BE49-F238E27FC236}">
-                <a16:creationId xmlns:a16="http://schemas.microsoft.com/office/drawing/2014/main" id="{8EF780E9-59D1-464C-807F-F724C90BC883}"/>
-              </a:ext>
-            </a:extLst>
-          </p:cNvPr>
-          <p:cNvSpPr>
-            <a:spLocks xmlns:a="http://schemas.openxmlformats.org/drawingml/2006/main" noGrp="1"/>
-          </p:cNvSpPr>
-          <p:nvPr/>
-        </p:nvSpPr>
-        <p:spPr>
-          <a:xfrm xmlns:a="http://schemas.openxmlformats.org/drawingml/2006/main">
-            <a:off x="6705600" y="5505450"/>
-            <a:ext cx="2476500" cy="323850"/>
-          </a:xfrm>
-          <a:prstGeom xmlns:a="http://schemas.openxmlformats.org/drawingml/2006/main" prst="rect">
-            <a:avLst/>
-          </a:prstGeom>
-          <a:noFill xmlns:a="http://schemas.openxmlformats.org/drawingml/2006/main"/>
-          <a:ln xmlns:a="http://schemas.openxmlformats.org/drawingml/2006/main" w="0">
-            <a:noFill/>
-            <a:prstDash val="solid"/>
-          </a:ln>
-        </p:spPr>
-        <p:txBody>
-          <a:bodyPr xmlns:a="http://schemas.openxmlformats.org/drawingml/2006/main"/>
-          <a:lstStyle xmlns:a="http://schemas.openxmlformats.org/drawingml/2006/main"/>
-          <a:p xmlns:a="http://schemas.openxmlformats.org/drawingml/2006/main">
-            <a:pPr>
-              <a:buNone/>
-              <a:defRPr sz="1800" b="1">
-                <a:solidFill>
-                  <a:srgbClr val="E60000"/>
-                </a:solidFill>
-              </a:defRPr>
-            </a:pPr>
-            <a:r>
-              <a:rPr sz="1800" b="1">
-                <a:solidFill>
-                  <a:srgbClr val="E60000"/>
-                </a:solidFill>
-              </a:rPr>
-              <a:t>Crazy Seconds</a:t>
-            </a:r>
-          </a:p>
-        </p:txBody>
-      </p:sp>
-      <p:sp>
-        <p:nvSpPr>
-          <p:cNvPr id="12" name="">
-            <a:extLst xmlns:a="http://schemas.openxmlformats.org/drawingml/2006/main">
-              <a:ext uri="{FF2B5EF4-FFF2-40B4-BE49-F238E27FC236}">
-                <a16:creationId xmlns:a16="http://schemas.microsoft.com/office/drawing/2014/main" id="{1EA9B32B-3B39-47E1-9089-B395C63B0BD0}"/>
-              </a:ext>
-            </a:extLst>
-          </p:cNvPr>
-          <p:cNvSpPr>
-            <a:spLocks xmlns:a="http://schemas.openxmlformats.org/drawingml/2006/main" noGrp="1"/>
-          </p:cNvSpPr>
-          <p:nvPr/>
-        </p:nvSpPr>
-        <p:spPr>
-          <a:xfrm xmlns:a="http://schemas.openxmlformats.org/drawingml/2006/main">
-            <a:off x="6705600" y="5943600"/>
-            <a:ext cx="4667250" cy="381000"/>
-          </a:xfrm>
-          <a:prstGeom xmlns:a="http://schemas.openxmlformats.org/drawingml/2006/main" prst="rect">
-            <a:avLst/>
-          </a:prstGeom>
-          <a:noFill xmlns:a="http://schemas.openxmlformats.org/drawingml/2006/main"/>
-          <a:ln xmlns:a="http://schemas.openxmlformats.org/drawingml/2006/main" w="0">
-            <a:noFill/>
-            <a:prstDash val="solid"/>
-          </a:ln>
-        </p:spPr>
-        <p:txBody>
-          <a:bodyPr xmlns:a="http://schemas.openxmlformats.org/drawingml/2006/main"/>
-          <a:lstStyle xmlns:a="http://schemas.openxmlformats.org/drawingml/2006/main"/>
-          <a:p xmlns:a="http://schemas.openxmlformats.org/drawingml/2006/main">
-            <a:pPr>
-              <a:buNone/>
-              <a:defRPr sz="1650">
-                <a:solidFill>
-                  <a:srgbClr val="555555"/>
-                </a:solidFill>
-              </a:defRPr>
-            </a:pPr>
-            <a:r>
-              <a:rPr sz="1650">
-                <a:solidFill>
-                  <a:srgbClr val="555555"/>
-                </a:solidFill>
-              </a:rPr>
-              <a:t>Repeatable motion / stage-ready timing / replayable moments</a:t>
-            </a:r>
-          </a:p>
-        </p:txBody>
-      </p:sp>
-    </p:spTree>
-    <p:extLst>
-      <p:ext uri="{BB962C8B-B14F-4D97-AF65-F5344CB8AC3E}">
-        <p14:creationId xmlns:p14="http://schemas.microsoft.com/office/powerpoint/2010/main" val="24782925"/>
-      </p:ext>
-    </p:extLst>
-  </p:cSld>
-</p:sld>
-</file>
-
-<file path=ppt/slides/slide4.xml><?xml version="1.0" encoding="utf-8"?>
-<p:sld xmlns:p="http://schemas.openxmlformats.org/presentationml/2006/main">
-  <p:cSld>
-    <p:bg>
-      <p:bgPr>
-        <a:solidFill xmlns:a="http://schemas.openxmlformats.org/drawingml/2006/main">
-          <a:srgbClr val="FFFFFF"/>
-        </a:solidFill>
-      </p:bgPr>
-    </p:bg>
-    <p:spTree>
-      <p:nvGrpSpPr>
-        <p:cNvPr id="1" name=""/>
-        <p:cNvGrpSpPr/>
-        <p:nvPr/>
-      </p:nvGrpSpPr>
-      <p:grpSpPr>
-        <a:xfrm xmlns:a="http://schemas.openxmlformats.org/drawingml/2006/main"/>
-      </p:grpSpPr>
-      <p:sp>
-        <p:nvSpPr>
-          <p:cNvPr id="1" name="">
-            <a:extLst xmlns:a="http://schemas.openxmlformats.org/drawingml/2006/main">
-              <a:ext uri="{FF2B5EF4-FFF2-40B4-BE49-F238E27FC236}">
-                <a16:creationId xmlns:a16="http://schemas.microsoft.com/office/drawing/2014/main" id="{9DA2AB7E-4838-4FE4-BF7A-E5097EA71E67}"/>
-              </a:ext>
-            </a:extLst>
-          </p:cNvPr>
-          <p:cNvSpPr>
-            <a:spLocks xmlns:a="http://schemas.openxmlformats.org/drawingml/2006/main" noGrp="1"/>
-          </p:cNvSpPr>
-          <p:nvPr/>
-        </p:nvSpPr>
-        <p:spPr>
-          <a:xfrm xmlns:a="http://schemas.openxmlformats.org/drawingml/2006/main">
-            <a:off x="419100" y="342900"/>
-            <a:ext cx="3048000" cy="266700"/>
-          </a:xfrm>
-          <a:prstGeom xmlns:a="http://schemas.openxmlformats.org/drawingml/2006/main" prst="rect">
-            <a:avLst/>
-          </a:prstGeom>
-          <a:noFill xmlns:a="http://schemas.openxmlformats.org/drawingml/2006/main"/>
-          <a:ln xmlns:a="http://schemas.openxmlformats.org/drawingml/2006/main" w="0">
-            <a:noFill/>
-            <a:prstDash val="solid"/>
-          </a:ln>
-        </p:spPr>
-        <p:txBody>
-          <a:bodyPr xmlns:a="http://schemas.openxmlformats.org/drawingml/2006/main"/>
-          <a:lstStyle xmlns:a="http://schemas.openxmlformats.org/drawingml/2006/main"/>
-          <a:p xmlns:a="http://schemas.openxmlformats.org/drawingml/2006/main">
-            <a:pPr>
-              <a:buNone/>
-              <a:defRPr sz="1125" b="1">
-                <a:solidFill>
-                  <a:srgbClr val="555555"/>
-                </a:solidFill>
-              </a:defRPr>
-            </a:pPr>
-            <a:r>
-              <a:rPr sz="1125" b="1">
-                <a:solidFill>
-                  <a:srgbClr val="555555"/>
-                </a:solidFill>
-              </a:rPr>
-              <a:t>DEMO VE OPERASYON</a:t>
-            </a:r>
-          </a:p>
-        </p:txBody>
-      </p:sp>
-      <p:sp>
-        <p:nvSpPr>
-          <p:cNvPr id="2" name="">
-            <a:extLst xmlns:a="http://schemas.openxmlformats.org/drawingml/2006/main">
-              <a:ext uri="{FF2B5EF4-FFF2-40B4-BE49-F238E27FC236}">
-                <a16:creationId xmlns:a16="http://schemas.microsoft.com/office/drawing/2014/main" id="{E0AEB975-0AF5-4386-979D-9E32E3F44E0C}"/>
-              </a:ext>
-            </a:extLst>
-          </p:cNvPr>
-          <p:cNvSpPr>
-            <a:spLocks xmlns:a="http://schemas.openxmlformats.org/drawingml/2006/main" noGrp="1"/>
-          </p:cNvSpPr>
-          <p:nvPr/>
-        </p:nvSpPr>
-        <p:spPr>
-          <a:xfrm xmlns:a="http://schemas.openxmlformats.org/drawingml/2006/main">
-            <a:off x="419100" y="723900"/>
-            <a:ext cx="8382000" cy="1123950"/>
-          </a:xfrm>
-          <a:prstGeom xmlns:a="http://schemas.openxmlformats.org/drawingml/2006/main" prst="rect">
-            <a:avLst/>
-          </a:prstGeom>
-          <a:noFill xmlns:a="http://schemas.openxmlformats.org/drawingml/2006/main"/>
-          <a:ln xmlns:a="http://schemas.openxmlformats.org/drawingml/2006/main" w="0">
-            <a:noFill/>
-            <a:prstDash val="solid"/>
-          </a:ln>
-        </p:spPr>
-        <p:txBody>
-          <a:bodyPr xmlns:a="http://schemas.openxmlformats.org/drawingml/2006/main"/>
-          <a:lstStyle xmlns:a="http://schemas.openxmlformats.org/drawingml/2006/main"/>
-          <a:p xmlns:a="http://schemas.openxmlformats.org/drawingml/2006/main">
-            <a:pPr>
-              <a:buNone/>
-              <a:defRPr sz="3225" b="1">
-                <a:solidFill>
-                  <a:srgbClr val="070707"/>
-                </a:solidFill>
-              </a:defRPr>
-            </a:pPr>
-            <a:r>
-              <a:rPr sz="3225" b="1">
-                <a:solidFill>
-                  <a:srgbClr val="070707"/>
-                </a:solidFill>
-              </a:rPr>
-              <a:t>Pilot, demo ve remote presence icin hazir bir robot platformu.</a:t>
-            </a:r>
-          </a:p>
-        </p:txBody>
-      </p:sp>
-      <p:pic>
-        <p:nvPicPr>
-          <p:cNvPr id="17" name=""/>
-          <p:cNvPicPr>
-            <a:picLocks xmlns:a="http://schemas.openxmlformats.org/drawingml/2006/main" noChangeAspect="1"/>
-          </p:cNvPicPr>
-          <p:nvPr/>
-        </p:nvPicPr>
-        <p:blipFill>
-          <a:blip xmlns:r="http://schemas.openxmlformats.org/officeDocument/2006/relationships" xmlns:a="http://schemas.openxmlformats.org/drawingml/2006/main" r:embed="R5a9b2f3eeba0497b"/>
-          <a:srcRect xmlns:a="http://schemas.openxmlformats.org/drawingml/2006/main" l="0" t="2134" r="0" b="2134"/>
-          <a:stretch xmlns:a="http://schemas.openxmlformats.org/drawingml/2006/main">
-            <a:fillRect l="0" t="0" r="0" b="0"/>
-          </a:stretch>
-        </p:blipFill>
-        <p:spPr>
-          <a:xfrm xmlns:a="http://schemas.openxmlformats.org/drawingml/2006/main">
-            <a:off x="419100" y="2266950"/>
-            <a:ext cx="3409950" cy="2266950"/>
-          </a:xfrm>
-          <a:prstGeom xmlns:a="http://schemas.openxmlformats.org/drawingml/2006/main" prst="rect">
-            <a:avLst/>
-          </a:prstGeom>
-        </p:spPr>
-      </p:pic>
-      <p:pic>
-        <p:nvPicPr>
-          <p:cNvPr id="18" name=""/>
-          <p:cNvPicPr>
-            <a:picLocks xmlns:a="http://schemas.openxmlformats.org/drawingml/2006/main" noChangeAspect="1"/>
-          </p:cNvPicPr>
-          <p:nvPr/>
-        </p:nvPicPr>
-        <p:blipFill>
-          <a:blip xmlns:r="http://schemas.openxmlformats.org/officeDocument/2006/relationships" xmlns:a="http://schemas.openxmlformats.org/drawingml/2006/main" r:embed="Reba2e6d9678b434b"/>
-          <a:srcRect xmlns:a="http://schemas.openxmlformats.org/drawingml/2006/main" l="0" t="2134" r="0" b="2134"/>
-          <a:stretch xmlns:a="http://schemas.openxmlformats.org/drawingml/2006/main">
-            <a:fillRect l="0" t="0" r="0" b="0"/>
-          </a:stretch>
-        </p:blipFill>
-        <p:spPr>
-          <a:xfrm xmlns:a="http://schemas.openxmlformats.org/drawingml/2006/main">
-            <a:off x="4400550" y="2266950"/>
-            <a:ext cx="3409950" cy="2266950"/>
-          </a:xfrm>
-          <a:prstGeom xmlns:a="http://schemas.openxmlformats.org/drawingml/2006/main" prst="rect">
-            <a:avLst/>
-          </a:prstGeom>
-        </p:spPr>
-      </p:pic>
-      <p:pic>
-        <p:nvPicPr>
-          <p:cNvPr id="19" name=""/>
-          <p:cNvPicPr>
-            <a:picLocks xmlns:a="http://schemas.openxmlformats.org/drawingml/2006/main" noChangeAspect="1"/>
-          </p:cNvPicPr>
-          <p:nvPr/>
-        </p:nvPicPr>
-        <p:blipFill>
-          <a:blip xmlns:r="http://schemas.openxmlformats.org/officeDocument/2006/relationships" xmlns:a="http://schemas.openxmlformats.org/drawingml/2006/main" r:embed="R564870bbe1c44541"/>
-          <a:srcRect xmlns:a="http://schemas.openxmlformats.org/drawingml/2006/main" l="0" t="2134" r="0" b="2134"/>
-          <a:stretch xmlns:a="http://schemas.openxmlformats.org/drawingml/2006/main">
-            <a:fillRect l="0" t="0" r="0" b="0"/>
-          </a:stretch>
-        </p:blipFill>
-        <p:spPr>
-          <a:xfrm xmlns:a="http://schemas.openxmlformats.org/drawingml/2006/main">
-            <a:off x="8362950" y="2266950"/>
-            <a:ext cx="3409950" cy="2266950"/>
-          </a:xfrm>
-          <a:prstGeom xmlns:a="http://schemas.openxmlformats.org/drawingml/2006/main" prst="rect">
-            <a:avLst/>
-          </a:prstGeom>
-        </p:spPr>
-      </p:pic>
-      <p:sp>
-        <p:nvSpPr>
-          <p:cNvPr id="6" name="">
-            <a:extLst xmlns:a="http://schemas.openxmlformats.org/drawingml/2006/main">
-              <a:ext uri="{FF2B5EF4-FFF2-40B4-BE49-F238E27FC236}">
-                <a16:creationId xmlns:a16="http://schemas.microsoft.com/office/drawing/2014/main" id="{44955C71-8B62-458E-ADDB-118DB5303C61}"/>
-              </a:ext>
-            </a:extLst>
-          </p:cNvPr>
-          <p:cNvSpPr>
-            <a:spLocks xmlns:a="http://schemas.openxmlformats.org/drawingml/2006/main" noGrp="1"/>
-          </p:cNvSpPr>
-          <p:nvPr/>
-        </p:nvSpPr>
-        <p:spPr>
-          <a:xfrm xmlns:a="http://schemas.openxmlformats.org/drawingml/2006/main">
-            <a:off x="419100" y="4953000"/>
-            <a:ext cx="11353800" cy="19050"/>
-          </a:xfrm>
-          <a:prstGeom xmlns:a="http://schemas.openxmlformats.org/drawingml/2006/main" prst="rect">
-            <a:avLst/>
-          </a:prstGeom>
-          <a:solidFill xmlns:a="http://schemas.openxmlformats.org/drawingml/2006/main">
-            <a:srgbClr val="B8BCC4"/>
-          </a:solidFill>
-          <a:ln xmlns:a="http://schemas.openxmlformats.org/drawingml/2006/main" w="0">
-            <a:solidFill>
-              <a:srgbClr val="B8BCC4"/>
-            </a:solidFill>
-            <a:prstDash val="solid"/>
-          </a:ln>
-        </p:spPr>
-      </p:sp>
-      <p:sp>
-        <p:nvSpPr>
-          <p:cNvPr id="7" name="">
-            <a:extLst xmlns:a="http://schemas.openxmlformats.org/drawingml/2006/main">
-              <a:ext uri="{FF2B5EF4-FFF2-40B4-BE49-F238E27FC236}">
-                <a16:creationId xmlns:a16="http://schemas.microsoft.com/office/drawing/2014/main" id="{B3860A04-2F96-4730-9E6F-04646C5690D3}"/>
-              </a:ext>
-            </a:extLst>
-          </p:cNvPr>
-          <p:cNvSpPr>
-            <a:spLocks xmlns:a="http://schemas.openxmlformats.org/drawingml/2006/main" noGrp="1"/>
-          </p:cNvSpPr>
-          <p:nvPr/>
-        </p:nvSpPr>
-        <p:spPr>
-          <a:xfrm xmlns:a="http://schemas.openxmlformats.org/drawingml/2006/main">
-            <a:off x="419100" y="5314950"/>
-            <a:ext cx="2667000" cy="323850"/>
-          </a:xfrm>
-          <a:prstGeom xmlns:a="http://schemas.openxmlformats.org/drawingml/2006/main" prst="rect">
-            <a:avLst/>
-          </a:prstGeom>
-          <a:noFill xmlns:a="http://schemas.openxmlformats.org/drawingml/2006/main"/>
-          <a:ln xmlns:a="http://schemas.openxmlformats.org/drawingml/2006/main" w="0">
-            <a:noFill/>
-            <a:prstDash val="solid"/>
-          </a:ln>
-        </p:spPr>
-        <p:txBody>
-          <a:bodyPr xmlns:a="http://schemas.openxmlformats.org/drawingml/2006/main"/>
-          <a:lstStyle xmlns:a="http://schemas.openxmlformats.org/drawingml/2006/main"/>
-          <a:p xmlns:a="http://schemas.openxmlformats.org/drawingml/2006/main">
-            <a:pPr>
-              <a:buNone/>
-              <a:defRPr sz="1800" b="1">
-                <a:solidFill>
-                  <a:srgbClr val="070707"/>
-                </a:solidFill>
-              </a:defRPr>
-            </a:pPr>
-            <a:r>
-              <a:rPr sz="1800" b="1">
-                <a:solidFill>
-                  <a:srgbClr val="070707"/>
-                </a:solidFill>
-              </a:rPr>
-              <a:t>Locomotion Layer</a:t>
-            </a:r>
-          </a:p>
-        </p:txBody>
-      </p:sp>
-      <p:sp>
-        <p:nvSpPr>
-          <p:cNvPr id="8" name="">
-            <a:extLst xmlns:a="http://schemas.openxmlformats.org/drawingml/2006/main">
-              <a:ext uri="{FF2B5EF4-FFF2-40B4-BE49-F238E27FC236}">
-                <a16:creationId xmlns:a16="http://schemas.microsoft.com/office/drawing/2014/main" id="{FC56E640-C385-460D-8533-B8CC42FD015F}"/>
-              </a:ext>
-            </a:extLst>
-          </p:cNvPr>
-          <p:cNvSpPr>
-            <a:spLocks xmlns:a="http://schemas.openxmlformats.org/drawingml/2006/main" noGrp="1"/>
-          </p:cNvSpPr>
-          <p:nvPr/>
-        </p:nvSpPr>
-        <p:spPr>
-          <a:xfrm xmlns:a="http://schemas.openxmlformats.org/drawingml/2006/main">
-            <a:off x="3467100" y="5314950"/>
-            <a:ext cx="2286000" cy="323850"/>
-          </a:xfrm>
-          <a:prstGeom xmlns:a="http://schemas.openxmlformats.org/drawingml/2006/main" prst="rect">
-            <a:avLst/>
-          </a:prstGeom>
-          <a:noFill xmlns:a="http://schemas.openxmlformats.org/drawingml/2006/main"/>
-          <a:ln xmlns:a="http://schemas.openxmlformats.org/drawingml/2006/main" w="0">
-            <a:noFill/>
-            <a:prstDash val="solid"/>
-          </a:ln>
-        </p:spPr>
-        <p:txBody>
-          <a:bodyPr xmlns:a="http://schemas.openxmlformats.org/drawingml/2006/main"/>
-          <a:lstStyle xmlns:a="http://schemas.openxmlformats.org/drawingml/2006/main"/>
-          <a:p xmlns:a="http://schemas.openxmlformats.org/drawingml/2006/main">
-            <a:pPr>
-              <a:buNone/>
-              <a:defRPr sz="1800" b="1">
-                <a:solidFill>
-                  <a:srgbClr val="070707"/>
-                </a:solidFill>
-              </a:defRPr>
-            </a:pPr>
-            <a:r>
-              <a:rPr sz="1800" b="1">
-                <a:solidFill>
-                  <a:srgbClr val="070707"/>
-                </a:solidFill>
-              </a:rPr>
-              <a:t>Gesture Layer</a:t>
-            </a:r>
-          </a:p>
-        </p:txBody>
-      </p:sp>
-      <p:sp>
-        <p:nvSpPr>
-          <p:cNvPr id="9" name="">
-            <a:extLst xmlns:a="http://schemas.openxmlformats.org/drawingml/2006/main">
-              <a:ext uri="{FF2B5EF4-FFF2-40B4-BE49-F238E27FC236}">
-                <a16:creationId xmlns:a16="http://schemas.microsoft.com/office/drawing/2014/main" id="{D35E5330-8ECE-4906-B351-909D631B86B6}"/>
-              </a:ext>
-            </a:extLst>
-          </p:cNvPr>
-          <p:cNvSpPr>
-            <a:spLocks xmlns:a="http://schemas.openxmlformats.org/drawingml/2006/main" noGrp="1"/>
-          </p:cNvSpPr>
-          <p:nvPr/>
-        </p:nvSpPr>
-        <p:spPr>
-          <a:xfrm xmlns:a="http://schemas.openxmlformats.org/drawingml/2006/main">
-            <a:off x="6191250" y="5314950"/>
-            <a:ext cx="2286000" cy="323850"/>
-          </a:xfrm>
-          <a:prstGeom xmlns:a="http://schemas.openxmlformats.org/drawingml/2006/main" prst="rect">
-            <a:avLst/>
-          </a:prstGeom>
-          <a:noFill xmlns:a="http://schemas.openxmlformats.org/drawingml/2006/main"/>
-          <a:ln xmlns:a="http://schemas.openxmlformats.org/drawingml/2006/main" w="0">
-            <a:noFill/>
-            <a:prstDash val="solid"/>
-          </a:ln>
-        </p:spPr>
-        <p:txBody>
-          <a:bodyPr xmlns:a="http://schemas.openxmlformats.org/drawingml/2006/main"/>
-          <a:lstStyle xmlns:a="http://schemas.openxmlformats.org/drawingml/2006/main"/>
-          <a:p xmlns:a="http://schemas.openxmlformats.org/drawingml/2006/main">
-            <a:pPr>
-              <a:buNone/>
-              <a:defRPr sz="1800" b="1">
-                <a:solidFill>
-                  <a:srgbClr val="070707"/>
-                </a:solidFill>
-              </a:defRPr>
-            </a:pPr>
-            <a:r>
-              <a:rPr sz="1800" b="1">
-                <a:solidFill>
-                  <a:srgbClr val="070707"/>
-                </a:solidFill>
-              </a:rPr>
-              <a:t>ROS Visibility</a:t>
-            </a:r>
-          </a:p>
-        </p:txBody>
-      </p:sp>
-      <p:sp>
-        <p:nvSpPr>
-          <p:cNvPr id="10" name="">
-            <a:extLst xmlns:a="http://schemas.openxmlformats.org/drawingml/2006/main">
-              <a:ext uri="{FF2B5EF4-FFF2-40B4-BE49-F238E27FC236}">
-                <a16:creationId xmlns:a16="http://schemas.microsoft.com/office/drawing/2014/main" id="{492712AF-C995-4CA5-9F9D-7F68B509AFB0}"/>
-              </a:ext>
-            </a:extLst>
-          </p:cNvPr>
-          <p:cNvSpPr>
-            <a:spLocks xmlns:a="http://schemas.openxmlformats.org/drawingml/2006/main" noGrp="1"/>
-          </p:cNvSpPr>
-          <p:nvPr/>
-        </p:nvSpPr>
-        <p:spPr>
-          <a:xfrm xmlns:a="http://schemas.openxmlformats.org/drawingml/2006/main">
-            <a:off x="9010650" y="5314950"/>
-            <a:ext cx="2476500" cy="323850"/>
-          </a:xfrm>
-          <a:prstGeom xmlns:a="http://schemas.openxmlformats.org/drawingml/2006/main" prst="rect">
-            <a:avLst/>
-          </a:prstGeom>
-          <a:noFill xmlns:a="http://schemas.openxmlformats.org/drawingml/2006/main"/>
-          <a:ln xmlns:a="http://schemas.openxmlformats.org/drawingml/2006/main" w="0">
-            <a:noFill/>
-            <a:prstDash val="solid"/>
-          </a:ln>
-        </p:spPr>
-        <p:txBody>
-          <a:bodyPr xmlns:a="http://schemas.openxmlformats.org/drawingml/2006/main"/>
-          <a:lstStyle xmlns:a="http://schemas.openxmlformats.org/drawingml/2006/main"/>
-          <a:p xmlns:a="http://schemas.openxmlformats.org/drawingml/2006/main">
-            <a:pPr>
-              <a:buNone/>
-              <a:defRPr sz="1800" b="1">
-                <a:solidFill>
-                  <a:srgbClr val="E60000"/>
-                </a:solidFill>
-              </a:defRPr>
-            </a:pPr>
-            <a:r>
-              <a:rPr sz="1800" b="1">
-                <a:solidFill>
-                  <a:srgbClr val="E60000"/>
-                </a:solidFill>
-              </a:rPr>
-              <a:t>Remote Presence</a:t>
-            </a:r>
-          </a:p>
-        </p:txBody>
-      </p:sp>
-      <p:sp>
-        <p:nvSpPr>
-          <p:cNvPr id="11" name="">
-            <a:extLst xmlns:a="http://schemas.openxmlformats.org/drawingml/2006/main">
-              <a:ext uri="{FF2B5EF4-FFF2-40B4-BE49-F238E27FC236}">
-                <a16:creationId xmlns:a16="http://schemas.microsoft.com/office/drawing/2014/main" id="{D8AE3223-7490-4358-9575-AEE96F5170F7}"/>
-              </a:ext>
-            </a:extLst>
-          </p:cNvPr>
-          <p:cNvSpPr>
-            <a:spLocks xmlns:a="http://schemas.openxmlformats.org/drawingml/2006/main" noGrp="1"/>
-          </p:cNvSpPr>
-          <p:nvPr/>
-        </p:nvSpPr>
-        <p:spPr>
-          <a:xfrm xmlns:a="http://schemas.openxmlformats.org/drawingml/2006/main">
-            <a:off x="419100" y="6076950"/>
-            <a:ext cx="8096250" cy="381000"/>
-          </a:xfrm>
-          <a:prstGeom xmlns:a="http://schemas.openxmlformats.org/drawingml/2006/main" prst="rect">
-            <a:avLst/>
-          </a:prstGeom>
-          <a:noFill xmlns:a="http://schemas.openxmlformats.org/drawingml/2006/main"/>
-          <a:ln xmlns:a="http://schemas.openxmlformats.org/drawingml/2006/main" w="0">
-            <a:noFill/>
-            <a:prstDash val="solid"/>
-          </a:ln>
-        </p:spPr>
-        <p:txBody>
-          <a:bodyPr xmlns:a="http://schemas.openxmlformats.org/drawingml/2006/main"/>
-          <a:lstStyle xmlns:a="http://schemas.openxmlformats.org/drawingml/2006/main"/>
-          <a:p xmlns:a="http://schemas.openxmlformats.org/drawingml/2006/main">
-            <a:pPr>
-              <a:buNone/>
-              <a:defRPr sz="1875" b="1">
-                <a:solidFill>
-                  <a:srgbClr val="070707"/>
-                </a:solidFill>
-              </a:defRPr>
-            </a:pPr>
-            <a:r>
-              <a:rPr sz="1875" b="1">
-                <a:solidFill>
-                  <a:srgbClr val="070707"/>
-                </a:solidFill>
-              </a:rPr>
-              <a:t>Premium robotics experience. Fast demo loop. Clear operator story.</a:t>
-            </a:r>
-          </a:p>
-        </p:txBody>
-      </p:sp>
-    </p:spTree>
-    <p:extLst>
-      <p:ext uri="{BB962C8B-B14F-4D97-AF65-F5344CB8AC3E}">
-        <p14:creationId xmlns:p14="http://schemas.microsoft.com/office/powerpoint/2010/main" val="864857682"/>
-      </p:ext>
-    </p:extLst>
-  </p:cSld>
-</p:sld>
-</file>
-
-<file path=ppt/slides/slide5.xml><?xml version="1.0" encoding="utf-8"?>
 <p:sld xmlns:p="http://schemas.openxmlformats.org/presentationml/2006/main">
   <p:cSld>
     <p:bg>
@@ -4462,7 +3100,7 @@
           <p:nvPr/>
         </p:nvPicPr>
         <p:blipFill>
-          <a:blip xmlns:r="http://schemas.openxmlformats.org/officeDocument/2006/relationships" xmlns:a="http://schemas.openxmlformats.org/drawingml/2006/main" r:embed="Rfab19316ab3346ae"/>
+          <a:blip xmlns:r="http://schemas.openxmlformats.org/officeDocument/2006/relationships" xmlns:a="http://schemas.openxmlformats.org/drawingml/2006/main" r:embed="R067c94588b164367"/>
           <a:stretch xmlns:a="http://schemas.openxmlformats.org/drawingml/2006/main"/>
         </p:blipFill>
         <p:spPr>
@@ -4653,7 +3291,7 @@
 </p:sld>
 </file>
 
-<file path=ppt/slides/slide6.xml><?xml version="1.0" encoding="utf-8"?>
+<file path=ppt/slides/slide3.xml><?xml version="1.0" encoding="utf-8"?>
 <p:sld xmlns:p="http://schemas.openxmlformats.org/presentationml/2006/main">
   <p:cSld>
     <p:bg>
@@ -5435,7 +4073,7 @@
           <p:nvPr/>
         </p:nvPicPr>
         <p:blipFill>
-          <a:blip xmlns:r="http://schemas.openxmlformats.org/officeDocument/2006/relationships" xmlns:a="http://schemas.openxmlformats.org/drawingml/2006/main" r:embed="R0af0afe155304f28"/>
+          <a:blip xmlns:r="http://schemas.openxmlformats.org/officeDocument/2006/relationships" xmlns:a="http://schemas.openxmlformats.org/drawingml/2006/main" r:embed="Ra77092ffe2e64bd8"/>
           <a:srcRect xmlns:a="http://schemas.openxmlformats.org/drawingml/2006/main" l="28" t="0" r="28" b="0"/>
           <a:stretch xmlns:a="http://schemas.openxmlformats.org/drawingml/2006/main">
             <a:fillRect l="0" t="0" r="0" b="0"/>
@@ -5629,7 +4267,7 @@
 </p:sld>
 </file>
 
-<file path=ppt/slides/slide7.xml><?xml version="1.0" encoding="utf-8"?>
+<file path=ppt/slides/slide4.xml><?xml version="1.0" encoding="utf-8"?>
 <p:sld xmlns:p="http://schemas.openxmlformats.org/presentationml/2006/main">
   <p:cSld>
     <p:bg>
@@ -9223,6 +7861,7 @@
           <a:lstStyle xmlns:a="http://schemas.openxmlformats.org/drawingml/2006/main"/>
           <a:p xmlns:a="http://schemas.openxmlformats.org/drawingml/2006/main">
             <a:pPr>
+              <a:buNone/>
               <a:defRPr sz="1125" b="1">
                 <a:solidFill>
                   <a:srgbClr val="22C55E"/>
@@ -9273,6 +7912,7 @@
           <a:lstStyle xmlns:a="http://schemas.openxmlformats.org/drawingml/2006/main"/>
           <a:p xmlns:a="http://schemas.openxmlformats.org/drawingml/2006/main">
             <a:pPr>
+              <a:buNone/>
               <a:defRPr sz="3150" b="1">
                 <a:solidFill>
                   <a:srgbClr val="FFFFFF"/>
@@ -9323,6 +7963,7 @@
           <a:lstStyle xmlns:a="http://schemas.openxmlformats.org/drawingml/2006/main"/>
           <a:p xmlns:a="http://schemas.openxmlformats.org/drawingml/2006/main">
             <a:pPr>
+              <a:buNone/>
               <a:defRPr sz="1650">
                 <a:solidFill>
                   <a:srgbClr val="CBD5E1"/>
@@ -9439,6 +8080,7 @@
           <a:lstStyle xmlns:a="http://schemas.openxmlformats.org/drawingml/2006/main"/>
           <a:p xmlns:a="http://schemas.openxmlformats.org/drawingml/2006/main">
             <a:pPr>
+              <a:buNone/>
               <a:defRPr sz="1875" b="1">
                 <a:solidFill>
                   <a:srgbClr val="FFFFFF"/>
@@ -9520,6 +8162,7 @@
           <a:lstStyle xmlns:a="http://schemas.openxmlformats.org/drawingml/2006/main"/>
           <a:p xmlns:a="http://schemas.openxmlformats.org/drawingml/2006/main">
             <a:pPr>
+              <a:buNone/>
               <a:defRPr sz="1500">
                 <a:solidFill>
                   <a:srgbClr val="DBE4EF"/>
@@ -9601,6 +8244,7 @@
           <a:lstStyle xmlns:a="http://schemas.openxmlformats.org/drawingml/2006/main"/>
           <a:p xmlns:a="http://schemas.openxmlformats.org/drawingml/2006/main">
             <a:pPr>
+              <a:buNone/>
               <a:defRPr sz="1500">
                 <a:solidFill>
                   <a:srgbClr val="DBE4EF"/>
@@ -9682,6 +8326,7 @@
           <a:lstStyle xmlns:a="http://schemas.openxmlformats.org/drawingml/2006/main"/>
           <a:p xmlns:a="http://schemas.openxmlformats.org/drawingml/2006/main">
             <a:pPr>
+              <a:buNone/>
               <a:defRPr sz="1500">
                 <a:solidFill>
                   <a:srgbClr val="DBE4EF"/>
@@ -9798,6 +8443,7 @@
           <a:lstStyle xmlns:a="http://schemas.openxmlformats.org/drawingml/2006/main"/>
           <a:p xmlns:a="http://schemas.openxmlformats.org/drawingml/2006/main">
             <a:pPr>
+              <a:buNone/>
               <a:defRPr sz="1875" b="1">
                 <a:solidFill>
                   <a:srgbClr val="FFFFFF"/>
@@ -9879,6 +8525,7 @@
           <a:lstStyle xmlns:a="http://schemas.openxmlformats.org/drawingml/2006/main"/>
           <a:p xmlns:a="http://schemas.openxmlformats.org/drawingml/2006/main">
             <a:pPr>
+              <a:buNone/>
               <a:defRPr sz="1500">
                 <a:solidFill>
                   <a:srgbClr val="DBE4EF"/>
@@ -9960,6 +8607,7 @@
           <a:lstStyle xmlns:a="http://schemas.openxmlformats.org/drawingml/2006/main"/>
           <a:p xmlns:a="http://schemas.openxmlformats.org/drawingml/2006/main">
             <a:pPr>
+              <a:buNone/>
               <a:defRPr sz="1500">
                 <a:solidFill>
                   <a:srgbClr val="DBE4EF"/>
@@ -10041,6 +8689,7 @@
           <a:lstStyle xmlns:a="http://schemas.openxmlformats.org/drawingml/2006/main"/>
           <a:p xmlns:a="http://schemas.openxmlformats.org/drawingml/2006/main">
             <a:pPr>
+              <a:buNone/>
               <a:defRPr sz="1500">
                 <a:solidFill>
                   <a:srgbClr val="DBE4EF"/>
@@ -10157,6 +8806,7 @@
           <a:lstStyle xmlns:a="http://schemas.openxmlformats.org/drawingml/2006/main"/>
           <a:p xmlns:a="http://schemas.openxmlformats.org/drawingml/2006/main">
             <a:pPr>
+              <a:buNone/>
               <a:defRPr sz="1875" b="1">
                 <a:solidFill>
                   <a:srgbClr val="FFFFFF"/>
@@ -10238,6 +8888,7 @@
           <a:lstStyle xmlns:a="http://schemas.openxmlformats.org/drawingml/2006/main"/>
           <a:p xmlns:a="http://schemas.openxmlformats.org/drawingml/2006/main">
             <a:pPr>
+              <a:buNone/>
               <a:defRPr sz="1500">
                 <a:solidFill>
                   <a:srgbClr val="DBE4EF"/>
@@ -10319,6 +8970,7 @@
           <a:lstStyle xmlns:a="http://schemas.openxmlformats.org/drawingml/2006/main"/>
           <a:p xmlns:a="http://schemas.openxmlformats.org/drawingml/2006/main">
             <a:pPr>
+              <a:buNone/>
               <a:defRPr sz="1500">
                 <a:solidFill>
                   <a:srgbClr val="DBE4EF"/>
@@ -10400,6 +9052,7 @@
           <a:lstStyle xmlns:a="http://schemas.openxmlformats.org/drawingml/2006/main"/>
           <a:p xmlns:a="http://schemas.openxmlformats.org/drawingml/2006/main">
             <a:pPr>
+              <a:buNone/>
               <a:defRPr sz="1500">
                 <a:solidFill>
                   <a:srgbClr val="DBE4EF"/>
@@ -10516,6 +9169,7 @@
           <a:lstStyle xmlns:a="http://schemas.openxmlformats.org/drawingml/2006/main"/>
           <a:p xmlns:a="http://schemas.openxmlformats.org/drawingml/2006/main">
             <a:pPr>
+              <a:buNone/>
               <a:defRPr sz="1875" b="1">
                 <a:solidFill>
                   <a:srgbClr val="FFFFFF"/>
@@ -10597,6 +9251,7 @@
           <a:lstStyle xmlns:a="http://schemas.openxmlformats.org/drawingml/2006/main"/>
           <a:p xmlns:a="http://schemas.openxmlformats.org/drawingml/2006/main">
             <a:pPr>
+              <a:buNone/>
               <a:defRPr sz="1500">
                 <a:solidFill>
                   <a:srgbClr val="DBE4EF"/>
@@ -10678,6 +9333,7 @@
           <a:lstStyle xmlns:a="http://schemas.openxmlformats.org/drawingml/2006/main"/>
           <a:p xmlns:a="http://schemas.openxmlformats.org/drawingml/2006/main">
             <a:pPr>
+              <a:buNone/>
               <a:defRPr sz="1500">
                 <a:solidFill>
                   <a:srgbClr val="DBE4EF"/>
@@ -10759,6 +9415,7 @@
           <a:lstStyle xmlns:a="http://schemas.openxmlformats.org/drawingml/2006/main"/>
           <a:p xmlns:a="http://schemas.openxmlformats.org/drawingml/2006/main">
             <a:pPr>
+              <a:buNone/>
               <a:defRPr sz="1500">
                 <a:solidFill>
                   <a:srgbClr val="DBE4EF"/>

</xml_diff>

<commit_message>
Translate Unitree deck to German red theme
</commit_message>
<xml_diff>
--- a/docs/presentations/Unitree-H1-Feature-Deck-v2.pptx
+++ b/docs/presentations/Unitree-H1-Feature-Deck-v2.pptx
@@ -2,16 +2,16 @@
 <file path=ppt/presentation.xml><?xml version="1.0" encoding="utf-8"?>
 <p:presentation xmlns:p="http://schemas.openxmlformats.org/presentationml/2006/main">
   <p:sldMasterIdLst>
-    <p:sldMasterId xmlns:r="http://schemas.openxmlformats.org/officeDocument/2006/relationships" id="2147483648" r:id="R24d431db9af3406e"/>
+    <p:sldMasterId xmlns:r="http://schemas.openxmlformats.org/officeDocument/2006/relationships" id="2147483648" r:id="R229e84b2cb254e5e"/>
   </p:sldMasterIdLst>
   <p:notesMasterIdLst>
-    <p:notesMasterId xmlns:r="http://schemas.openxmlformats.org/officeDocument/2006/relationships" r:id="R93b8855e66c046f6"/>
+    <p:notesMasterId xmlns:r="http://schemas.openxmlformats.org/officeDocument/2006/relationships" r:id="R26a5685048df4a6d"/>
   </p:notesMasterIdLst>
   <p:sldIdLst>
-    <p:sldId xmlns:r="http://schemas.openxmlformats.org/officeDocument/2006/relationships" id="256" r:id="R88f2b6d67c774c5b"/>
-    <p:sldId xmlns:r="http://schemas.openxmlformats.org/officeDocument/2006/relationships" id="257" r:id="R65eda291838c4209"/>
-    <p:sldId xmlns:r="http://schemas.openxmlformats.org/officeDocument/2006/relationships" id="258" r:id="Rc96c792c534d424a"/>
-    <p:sldId xmlns:r="http://schemas.openxmlformats.org/officeDocument/2006/relationships" id="259" r:id="R8dbd919872ca4e54"/>
+    <p:sldId xmlns:r="http://schemas.openxmlformats.org/officeDocument/2006/relationships" id="256" r:id="Raddc1bd6ec02400e"/>
+    <p:sldId xmlns:r="http://schemas.openxmlformats.org/officeDocument/2006/relationships" id="257" r:id="R8282c36231ef4fc9"/>
+    <p:sldId xmlns:r="http://schemas.openxmlformats.org/officeDocument/2006/relationships" id="258" r:id="R10d775a78be944fb"/>
+    <p:sldId xmlns:r="http://schemas.openxmlformats.org/officeDocument/2006/relationships" id="259" r:id="R47df6d1ff9ec4bb3"/>
   </p:sldIdLst>
   <p:sldSz cx="12192000" cy="6858000"/>
   <p:notesSz cx="6858000" cy="9144000"/>
@@ -802,7 +802,7 @@
   </p:cSld>
   <p:clrMap bg1="lt1" tx1="dk1" bg2="lt2" tx2="dk2" accent1="accent1" accent2="accent2" accent3="accent3" accent4="accent4" accent5="accent5" accent6="accent6" hlink="hlink" folHlink="folHlink"/>
   <p:sldLayoutIdLst>
-    <p:sldLayoutId xmlns:r="http://schemas.openxmlformats.org/officeDocument/2006/relationships" id="2147483649" r:id="R0052c369eb174303"/>
+    <p:sldLayoutId xmlns:r="http://schemas.openxmlformats.org/officeDocument/2006/relationships" id="2147483649" r:id="R6a1ebf77b5f84c76"/>
   </p:sldLayoutIdLst>
   <p:txStyles>
     <p:titleStyle>
@@ -1335,7 +1335,7 @@
     <p:bg>
       <p:bgPr>
         <a:solidFill xmlns:a="http://schemas.openxmlformats.org/drawingml/2006/main">
-          <a:srgbClr val="080B0F"/>
+          <a:srgbClr val="050506"/>
         </a:solidFill>
       </p:bgPr>
     </p:bg>
@@ -1371,10 +1371,12 @@
             <a:avLst/>
           </a:prstGeom>
           <a:solidFill xmlns:a="http://schemas.openxmlformats.org/drawingml/2006/main">
-            <a:srgbClr val="111318"/>
-          </a:solidFill>
-          <a:ln xmlns:a="http://schemas.openxmlformats.org/drawingml/2006/main" w="0">
-            <a:noFill/>
+            <a:srgbClr val="0B0B0D"/>
+          </a:solidFill>
+          <a:ln xmlns:a="http://schemas.openxmlformats.org/drawingml/2006/main" w="0">
+            <a:solidFill>
+              <a:srgbClr val="0B0B0D"/>
+            </a:solidFill>
             <a:prstDash val="solid"/>
           </a:ln>
         </p:spPr>
@@ -1415,14 +1417,14 @@
               <a:buNone/>
               <a:defRPr sz="1050" b="1">
                 <a:solidFill>
-                  <a:srgbClr val="38BDF8"/>
+                  <a:srgbClr val="FF4D5E"/>
                 </a:solidFill>
               </a:defRPr>
             </a:pPr>
             <a:r>
               <a:rPr sz="1050" b="1">
                 <a:solidFill>
-                  <a:srgbClr val="38BDF8"/>
+                  <a:srgbClr val="FF4D5E"/>
                 </a:solidFill>
               </a:rPr>
               <a:t>VISION PRO TELEOPERATION</a:t>
@@ -1466,17 +1468,17 @@
               <a:buNone/>
               <a:defRPr sz="3150" b="1">
                 <a:solidFill>
-                  <a:srgbClr val="FFFFFF"/>
+                  <a:srgbClr val="F8FAFC"/>
                 </a:solidFill>
               </a:defRPr>
             </a:pPr>
             <a:r>
               <a:rPr sz="3150" b="1">
                 <a:solidFill>
-                  <a:srgbClr val="FFFFFF"/>
-                </a:solidFill>
-              </a:rPr>
-              <a:t>Robotu ellerle</a:t>
+                  <a:srgbClr val="F8FAFC"/>
+                </a:solidFill>
+              </a:rPr>
+              <a:t>Vision Pro steuert</a:t>
             </a:r>
           </a:p>
           <a:p xmlns:a="http://schemas.openxmlformats.org/drawingml/2006/main">
@@ -1484,17 +1486,17 @@
               <a:buNone/>
               <a:defRPr sz="3150" b="1">
                 <a:solidFill>
-                  <a:srgbClr val="FFFFFF"/>
+                  <a:srgbClr val="F8FAFC"/>
                 </a:solidFill>
               </a:defRPr>
             </a:pPr>
             <a:r>
               <a:rPr sz="3150" b="1">
                 <a:solidFill>
-                  <a:srgbClr val="FFFFFF"/>
-                </a:solidFill>
-              </a:rPr>
-              <a:t>teleoperate ediyoruz</a:t>
+                  <a:srgbClr val="F8FAFC"/>
+                </a:solidFill>
+              </a:rPr>
+              <a:t>Roboterhände</a:t>
             </a:r>
           </a:p>
         </p:txBody>
@@ -1535,17 +1537,17 @@
               <a:buNone/>
               <a:defRPr sz="1350">
                 <a:solidFill>
-                  <a:srgbClr val="CBD5E1"/>
+                  <a:srgbClr val="F8FAFC"/>
                 </a:solidFill>
               </a:defRPr>
             </a:pPr>
             <a:r>
               <a:rPr sz="1350">
                 <a:solidFill>
-                  <a:srgbClr val="CBD5E1"/>
-                </a:solidFill>
-              </a:rPr>
-              <a:t>Vision Pro el iskeleti ve bilek yönelimi, düşük gecikmeli bir kontrol katmanında robot el-kol hedeflerine dönüştürülüyor.</a:t>
+                  <a:srgbClr val="F8FAFC"/>
+                </a:solidFill>
+              </a:rPr>
+              <a:t>Handskelette und Wrist Pose werden latenzarm in Zielposen für Roboterhand und -arm übersetzt.</a:t>
             </a:r>
           </a:p>
         </p:txBody>
@@ -1573,10 +1575,12 @@
             <a:avLst/>
           </a:prstGeom>
           <a:solidFill xmlns:a="http://schemas.openxmlformats.org/drawingml/2006/main">
-            <a:srgbClr val="22C55E"/>
-          </a:solidFill>
-          <a:ln xmlns:a="http://schemas.openxmlformats.org/drawingml/2006/main" w="0">
-            <a:noFill/>
+            <a:srgbClr val="EF233C"/>
+          </a:solidFill>
+          <a:ln xmlns:a="http://schemas.openxmlformats.org/drawingml/2006/main" w="0">
+            <a:solidFill>
+              <a:srgbClr val="EF233C"/>
+            </a:solidFill>
             <a:prstDash val="solid"/>
           </a:ln>
         </p:spPr>
@@ -1617,7 +1621,7 @@
               <a:buNone/>
               <a:defRPr sz="1200" b="1">
                 <a:solidFill>
-                  <a:srgbClr val="FFFFFF"/>
+                  <a:srgbClr val="C7C2C2"/>
                 </a:solidFill>
               </a:defRPr>
             </a:pPr>
@@ -1678,7 +1682,7 @@
                   <a:srgbClr val="F8FAFC"/>
                 </a:solidFill>
               </a:rPr>
-              <a:t>Spatial hand pose capture</a:t>
+              <a:t>Räumliche Handpose-Erfassung</a:t>
             </a:r>
           </a:p>
         </p:txBody>
@@ -1719,17 +1723,17 @@
               <a:buNone/>
               <a:defRPr sz="1200">
                 <a:solidFill>
-                  <a:srgbClr val="CBD5E1"/>
+                  <a:srgbClr val="C7C2C2"/>
                 </a:solidFill>
               </a:defRPr>
             </a:pPr>
             <a:r>
               <a:rPr sz="1200">
                 <a:solidFill>
-                  <a:srgbClr val="CBD5E1"/>
-                </a:solidFill>
-              </a:rPr>
-              <a:t>İki elin 3D iskeleti, pinch/finger curl ve bilek yönelimi sahne koordinatlarında okunur.</a:t>
+                  <a:srgbClr val="C7C2C2"/>
+                </a:solidFill>
+              </a:rPr>
+              <a:t>Das 3D-Skelett beider Hände, Pinch, Finger-Curl und Wrist Pose werden in Szenenkoordinaten gelesen.</a:t>
             </a:r>
           </a:p>
         </p:txBody>
@@ -1757,10 +1761,12 @@
             <a:avLst/>
           </a:prstGeom>
           <a:solidFill xmlns:a="http://schemas.openxmlformats.org/drawingml/2006/main">
-            <a:srgbClr val="38BDF8"/>
-          </a:solidFill>
-          <a:ln xmlns:a="http://schemas.openxmlformats.org/drawingml/2006/main" w="0">
-            <a:noFill/>
+            <a:srgbClr val="C1121F"/>
+          </a:solidFill>
+          <a:ln xmlns:a="http://schemas.openxmlformats.org/drawingml/2006/main" w="0">
+            <a:solidFill>
+              <a:srgbClr val="C1121F"/>
+            </a:solidFill>
             <a:prstDash val="solid"/>
           </a:ln>
         </p:spPr>
@@ -1801,7 +1807,7 @@
               <a:buNone/>
               <a:defRPr sz="1200" b="1">
                 <a:solidFill>
-                  <a:srgbClr val="FFFFFF"/>
+                  <a:srgbClr val="C7C2C2"/>
                 </a:solidFill>
               </a:defRPr>
             </a:pPr>
@@ -1862,7 +1868,7 @@
                   <a:srgbClr val="F8FAFC"/>
                 </a:solidFill>
               </a:rPr>
-              <a:t>Low-latency retargeting</a:t>
+              <a:t>Retargeting mit niedriger Latenz</a:t>
             </a:r>
           </a:p>
         </p:txBody>
@@ -1903,17 +1909,17 @@
               <a:buNone/>
               <a:defRPr sz="1200">
                 <a:solidFill>
-                  <a:srgbClr val="CBD5E1"/>
+                  <a:srgbClr val="C7C2C2"/>
                 </a:solidFill>
               </a:defRPr>
             </a:pPr>
             <a:r>
               <a:rPr sz="1200">
                 <a:solidFill>
-                  <a:srgbClr val="CBD5E1"/>
-                </a:solidFill>
-              </a:rPr>
-              <a:t>Pose akışı filtrelenir, ölçeklenir ve eklem limitleri içinde Inspire el hedeflerine retarget edilir.</a:t>
+                  <a:srgbClr val="C7C2C2"/>
+                </a:solidFill>
+              </a:rPr>
+              <a:t>Der Pose-Stream wird gefiltert, skaliert und innerhalb der Gelenkgrenzen auf Inspire-Handziele abgebildet.</a:t>
             </a:r>
           </a:p>
         </p:txBody>
@@ -1941,10 +1947,12 @@
             <a:avLst/>
           </a:prstGeom>
           <a:solidFill xmlns:a="http://schemas.openxmlformats.org/drawingml/2006/main">
-            <a:srgbClr val="F97316"/>
-          </a:solidFill>
-          <a:ln xmlns:a="http://schemas.openxmlformats.org/drawingml/2006/main" w="0">
-            <a:noFill/>
+            <a:srgbClr val="780000"/>
+          </a:solidFill>
+          <a:ln xmlns:a="http://schemas.openxmlformats.org/drawingml/2006/main" w="0">
+            <a:solidFill>
+              <a:srgbClr val="780000"/>
+            </a:solidFill>
             <a:prstDash val="solid"/>
           </a:ln>
         </p:spPr>
@@ -1985,7 +1993,7 @@
               <a:buNone/>
               <a:defRPr sz="1200" b="1">
                 <a:solidFill>
-                  <a:srgbClr val="FFFFFF"/>
+                  <a:srgbClr val="C7C2C2"/>
                 </a:solidFill>
               </a:defRPr>
             </a:pPr>
@@ -2046,7 +2054,7 @@
                   <a:srgbClr val="F8FAFC"/>
                 </a:solidFill>
               </a:rPr>
-              <a:t>Robot hands in the loop</a:t>
+              <a:t>Roboterhände im Regelkreis</a:t>
             </a:r>
           </a:p>
         </p:txBody>
@@ -2087,17 +2095,17 @@
               <a:buNone/>
               <a:defRPr sz="1200">
                 <a:solidFill>
-                  <a:srgbClr val="CBD5E1"/>
+                  <a:srgbClr val="C7C2C2"/>
                 </a:solidFill>
               </a:defRPr>
             </a:pPr>
             <a:r>
               <a:rPr sz="1200">
                 <a:solidFill>
-                  <a:srgbClr val="CBD5E1"/>
-                </a:solidFill>
-              </a:rPr>
-              <a:t>Kamera ve XR geri beslemesi aynı döngüdedir; operatör robot ellerini kendi elleri gibi görür.</a:t>
+                  <a:srgbClr val="C7C2C2"/>
+                </a:solidFill>
+              </a:rPr>
+              <a:t>Kamera- und XR-Feedback laufen im selben Loop; der Operator sieht die Roboterhände wie die eigenen Hände.</a:t>
             </a:r>
           </a:p>
         </p:txBody>
@@ -2111,7 +2119,7 @@
           <p:nvPr/>
         </p:nvPicPr>
         <p:blipFill>
-          <a:blip xmlns:r="http://schemas.openxmlformats.org/officeDocument/2006/relationships" xmlns:a="http://schemas.openxmlformats.org/drawingml/2006/main" r:embed="R7827df59152b46e0"/>
+          <a:blip xmlns:r="http://schemas.openxmlformats.org/officeDocument/2006/relationships" xmlns:a="http://schemas.openxmlformats.org/drawingml/2006/main" r:embed="Rb51aa68f45174205"/>
           <a:srcRect xmlns:a="http://schemas.openxmlformats.org/drawingml/2006/main" l="2206" t="0" r="2206" b="0"/>
           <a:stretch xmlns:a="http://schemas.openxmlformats.org/drawingml/2006/main">
             <a:fillRect l="0" t="0" r="0" b="0"/>
@@ -2152,7 +2160,7 @@
           <a:noFill xmlns:a="http://schemas.openxmlformats.org/drawingml/2006/main"/>
           <a:ln xmlns:a="http://schemas.openxmlformats.org/drawingml/2006/main" w="19050">
             <a:solidFill>
-              <a:srgbClr val="334155"/>
+              <a:srgbClr val="5B1720"/>
             </a:solidFill>
             <a:prstDash val="solid"/>
           </a:ln>
@@ -2194,17 +2202,17 @@
               <a:buNone/>
               <a:defRPr sz="1350">
                 <a:solidFill>
-                  <a:srgbClr val="E2E8F0"/>
+                  <a:srgbClr val="C7C2C2"/>
                 </a:solidFill>
               </a:defRPr>
             </a:pPr>
             <a:r>
               <a:rPr sz="1350">
                 <a:solidFill>
-                  <a:srgbClr val="E2E8F0"/>
-                </a:solidFill>
-              </a:rPr>
-              <a:t>Canlı robot görünümü: iki robot el, Vision Pro hand tracking girdisiyle operatörün jestlerine eşleniyor.</a:t>
+                  <a:srgbClr val="C7C2C2"/>
+                </a:solidFill>
+              </a:rPr>
+              <a:t>Live-Roboteransicht: Beide Roboterhände werden über Vision-Pro-Handtracking auf die Gesten des Operators gemappt.</a:t>
             </a:r>
           </a:p>
         </p:txBody>
@@ -2234,11 +2242,11 @@
             </a:avLst>
           </a:prstGeom>
           <a:solidFill xmlns:a="http://schemas.openxmlformats.org/drawingml/2006/main">
-            <a:srgbClr val="121923"/>
+            <a:srgbClr val="171012"/>
           </a:solidFill>
           <a:ln xmlns:a="http://schemas.openxmlformats.org/drawingml/2006/main" w="9525">
             <a:solidFill>
-              <a:srgbClr val="1F2937"/>
+              <a:srgbClr val="5B1720"/>
             </a:solidFill>
             <a:prstDash val="solid"/>
           </a:ln>
@@ -2280,17 +2288,17 @@
               <a:buNone/>
               <a:defRPr sz="1275" b="1">
                 <a:solidFill>
-                  <a:srgbClr val="F8FAFC"/>
+                  <a:srgbClr val="C7C2C2"/>
                 </a:solidFill>
               </a:defRPr>
             </a:pPr>
             <a:r>
               <a:rPr sz="1275" b="1">
                 <a:solidFill>
-                  <a:srgbClr val="F8FAFC"/>
-                </a:solidFill>
-              </a:rPr>
-              <a:t>Operatör soyut komut vermiyor; doğal el hareketi güvenli robot hareketine dönüşüyor.</a:t>
+                  <a:srgbClr val="C7C2C2"/>
+                </a:solidFill>
+              </a:rPr>
+              <a:t>Natürliche Handbewegung wird zu sicherer Roboterbewegung.</a:t>
             </a:r>
           </a:p>
         </p:txBody>
@@ -2304,7 +2312,7 @@
           <p:nvPr/>
         </p:nvPicPr>
         <p:blipFill>
-          <a:blip xmlns:r="http://schemas.openxmlformats.org/officeDocument/2006/relationships" xmlns:a="http://schemas.openxmlformats.org/drawingml/2006/main" r:embed="Rb2cb422796ca4766"/>
+          <a:blip xmlns:r="http://schemas.openxmlformats.org/officeDocument/2006/relationships" xmlns:a="http://schemas.openxmlformats.org/drawingml/2006/main" r:embed="Ree4e6ccc18144bfb"/>
           <a:srcRect xmlns:a="http://schemas.openxmlformats.org/drawingml/2006/main" l="2118" t="0" r="2118" b="0"/>
           <a:stretch xmlns:a="http://schemas.openxmlformats.org/drawingml/2006/main">
             <a:fillRect l="0" t="0" r="0" b="0"/>
@@ -2336,7 +2344,7 @@
     <p:bg>
       <p:bgPr>
         <a:solidFill xmlns:a="http://schemas.openxmlformats.org/drawingml/2006/main">
-          <a:srgbClr val="080B0F"/>
+          <a:srgbClr val="050506"/>
         </a:solidFill>
       </p:bgPr>
     </p:bg>
@@ -2372,10 +2380,12 @@
             <a:avLst/>
           </a:prstGeom>
           <a:solidFill xmlns:a="http://schemas.openxmlformats.org/drawingml/2006/main">
-            <a:srgbClr val="111318"/>
-          </a:solidFill>
-          <a:ln xmlns:a="http://schemas.openxmlformats.org/drawingml/2006/main" w="0">
-            <a:noFill/>
+            <a:srgbClr val="0B0B0D"/>
+          </a:solidFill>
+          <a:ln xmlns:a="http://schemas.openxmlformats.org/drawingml/2006/main" w="0">
+            <a:solidFill>
+              <a:srgbClr val="0B0B0D"/>
+            </a:solidFill>
             <a:prstDash val="solid"/>
           </a:ln>
         </p:spPr>
@@ -2416,17 +2426,17 @@
               <a:buNone/>
               <a:defRPr sz="1050" b="1">
                 <a:solidFill>
-                  <a:srgbClr val="22C55E"/>
+                  <a:srgbClr val="FF4D5E"/>
                 </a:solidFill>
               </a:defRPr>
             </a:pPr>
             <a:r>
               <a:rPr sz="1050" b="1">
                 <a:solidFill>
-                  <a:srgbClr val="22C55E"/>
-                </a:solidFill>
-              </a:rPr>
-              <a:t>ROBOT TELEMETRY WORKFLOW</a:t>
+                  <a:srgbClr val="FF4D5E"/>
+                </a:solidFill>
+              </a:rPr>
+              <a:t>ROBOTER-TELEMETRIE-WORKFLOW</a:t>
             </a:r>
           </a:p>
         </p:txBody>
@@ -2467,14 +2477,14 @@
               <a:buNone/>
               <a:defRPr sz="2850" b="1">
                 <a:solidFill>
-                  <a:srgbClr val="FFFFFF"/>
+                  <a:srgbClr val="F8FAFC"/>
                 </a:solidFill>
               </a:defRPr>
             </a:pPr>
             <a:r>
               <a:rPr sz="2850" b="1">
                 <a:solidFill>
-                  <a:srgbClr val="FFFFFF"/>
+                  <a:srgbClr val="F8FAFC"/>
                 </a:solidFill>
               </a:rPr>
               <a:t>Telemetry Recorder</a:t>
@@ -2485,17 +2495,17 @@
               <a:buNone/>
               <a:defRPr sz="2850" b="1">
                 <a:solidFill>
-                  <a:srgbClr val="FFFFFF"/>
+                  <a:srgbClr val="F8FAFC"/>
                 </a:solidFill>
               </a:defRPr>
             </a:pPr>
             <a:r>
               <a:rPr sz="2850" b="1">
                 <a:solidFill>
-                  <a:srgbClr val="FFFFFF"/>
-                </a:solidFill>
-              </a:rPr>
-              <a:t>hareketi doğruluyor</a:t>
+                  <a:srgbClr val="F8FAFC"/>
+                </a:solidFill>
+              </a:rPr>
+              <a:t>validiert Bewegung</a:t>
             </a:r>
           </a:p>
         </p:txBody>
@@ -2536,17 +2546,17 @@
               <a:buNone/>
               <a:defRPr sz="1350">
                 <a:solidFill>
-                  <a:srgbClr val="CBD5E1"/>
+                  <a:srgbClr val="F8FAFC"/>
                 </a:solidFill>
               </a:defRPr>
             </a:pPr>
             <a:r>
               <a:rPr sz="1350">
                 <a:solidFill>
-                  <a:srgbClr val="CBD5E1"/>
-                </a:solidFill>
-              </a:rPr>
-              <a:t>Ekran; motor örneklerinden sequence oluşturma, simülasyonla kontrol etme ve güvenli hareketi gerçek robota kaydetme akışını tek yerde topluyor.</a:t>
+                  <a:srgbClr val="F8FAFC"/>
+                </a:solidFill>
+              </a:rPr>
+              <a:t>Die Ansicht bündelt Sequenzaufbau aus Motor-Samples, Simulationsprüfung und sichere Speicherung echter Roboterbewegung in einem Workflow.</a:t>
             </a:r>
           </a:p>
         </p:txBody>
@@ -2576,10 +2586,12 @@
             </a:avLst>
           </a:prstGeom>
           <a:solidFill xmlns:a="http://schemas.openxmlformats.org/drawingml/2006/main">
-            <a:srgbClr val="22C55E"/>
-          </a:solidFill>
-          <a:ln xmlns:a="http://schemas.openxmlformats.org/drawingml/2006/main" w="0">
-            <a:noFill/>
+            <a:srgbClr val="EF233C"/>
+          </a:solidFill>
+          <a:ln xmlns:a="http://schemas.openxmlformats.org/drawingml/2006/main" w="0">
+            <a:solidFill>
+              <a:srgbClr val="EF233C"/>
+            </a:solidFill>
             <a:prstDash val="solid"/>
           </a:ln>
         </p:spPr>
@@ -2630,7 +2642,7 @@
                   <a:srgbClr val="F8FAFC"/>
                 </a:solidFill>
               </a:rPr>
-              <a:t>Sıralı hareket noktaları</a:t>
+              <a:t>Sequenzierte Bewegungspunkte</a:t>
             </a:r>
           </a:p>
         </p:txBody>
@@ -2671,17 +2683,17 @@
               <a:buNone/>
               <a:defRPr sz="1200">
                 <a:solidFill>
-                  <a:srgbClr val="CBD5E1"/>
+                  <a:srgbClr val="C7C2C2"/>
                 </a:solidFill>
               </a:defRPr>
             </a:pPr>
             <a:r>
               <a:rPr sz="1200">
                 <a:solidFill>
-                  <a:srgbClr val="CBD5E1"/>
-                </a:solidFill>
-              </a:rPr>
-              <a:t>Her point; 27 motor, zaman damgası ve replay sırası ile tutuluyor. Seçili point anında izlenebiliyor.</a:t>
+                  <a:srgbClr val="C7C2C2"/>
+                </a:solidFill>
+              </a:rPr>
+              <a:t>Jeder Punkt speichert 27 Motoren, Zeitstempel und Replay-Reihenfolge; der ausgewählte Punkt ist sofort sichtbar.</a:t>
             </a:r>
           </a:p>
         </p:txBody>
@@ -2711,10 +2723,12 @@
             </a:avLst>
           </a:prstGeom>
           <a:solidFill xmlns:a="http://schemas.openxmlformats.org/drawingml/2006/main">
-            <a:srgbClr val="38BDF8"/>
-          </a:solidFill>
-          <a:ln xmlns:a="http://schemas.openxmlformats.org/drawingml/2006/main" w="0">
-            <a:noFill/>
+            <a:srgbClr val="EF233C"/>
+          </a:solidFill>
+          <a:ln xmlns:a="http://schemas.openxmlformats.org/drawingml/2006/main" w="0">
+            <a:solidFill>
+              <a:srgbClr val="EF233C"/>
+            </a:solidFill>
             <a:prstDash val="solid"/>
           </a:ln>
         </p:spPr>
@@ -2765,7 +2779,7 @@
                   <a:srgbClr val="F8FAFC"/>
                 </a:solidFill>
               </a:rPr>
-              <a:t>IK ve sınır doğrulaması</a:t>
+              <a:t>IK- und Grenzwertprüfung</a:t>
             </a:r>
           </a:p>
         </p:txBody>
@@ -2806,17 +2820,17 @@
               <a:buNone/>
               <a:defRPr sz="1200">
                 <a:solidFill>
-                  <a:srgbClr val="CBD5E1"/>
+                  <a:srgbClr val="C7C2C2"/>
                 </a:solidFill>
               </a:defRPr>
             </a:pPr>
             <a:r>
               <a:rPr sz="1200">
                 <a:solidFill>
-                  <a:srgbClr val="CBD5E1"/>
-                </a:solidFill>
-              </a:rPr>
-              <a:t>IK hatası cm seviyesinde gösteriliyor; bounds açıkken güvenli eklem limitleri korunuyor.</a:t>
+                  <a:srgbClr val="C7C2C2"/>
+                </a:solidFill>
+              </a:rPr>
+              <a:t>IK-Fehler werden auf Zentimeter-Ebene gezeigt; aktive Bounds schützen sichere Gelenklimits.</a:t>
             </a:r>
           </a:p>
         </p:txBody>
@@ -2846,10 +2860,12 @@
             </a:avLst>
           </a:prstGeom>
           <a:solidFill xmlns:a="http://schemas.openxmlformats.org/drawingml/2006/main">
-            <a:srgbClr val="F97316"/>
-          </a:solidFill>
-          <a:ln xmlns:a="http://schemas.openxmlformats.org/drawingml/2006/main" w="0">
-            <a:noFill/>
+            <a:srgbClr val="EF233C"/>
+          </a:solidFill>
+          <a:ln xmlns:a="http://schemas.openxmlformats.org/drawingml/2006/main" w="0">
+            <a:solidFill>
+              <a:srgbClr val="EF233C"/>
+            </a:solidFill>
             <a:prstDash val="solid"/>
           </a:ln>
         </p:spPr>
@@ -2900,7 +2916,7 @@
                   <a:srgbClr val="F8FAFC"/>
                 </a:solidFill>
               </a:rPr>
-              <a:t>Simülasyon ve replay karşılaştırması</a:t>
+              <a:t>Simulation und Replay im Vergleich</a:t>
             </a:r>
           </a:p>
         </p:txBody>
@@ -2941,17 +2957,17 @@
               <a:buNone/>
               <a:defRPr sz="1200">
                 <a:solidFill>
-                  <a:srgbClr val="CBD5E1"/>
+                  <a:srgbClr val="C7C2C2"/>
                 </a:solidFill>
               </a:defRPr>
             </a:pPr>
             <a:r>
               <a:rPr sz="1200">
                 <a:solidFill>
-                  <a:srgbClr val="CBD5E1"/>
-                </a:solidFill>
-              </a:rPr>
-              <a:t>Mavi referans, yeşil simülasyon ve kırmızı hedef hareket aynı sahnede üst üste okunuyor.</a:t>
+                  <a:srgbClr val="C7C2C2"/>
+                </a:solidFill>
+              </a:rPr>
+              <a:t>Referenz, Simulation und Zielbewegung werden in derselben Szene übereinander lesbar.</a:t>
             </a:r>
           </a:p>
         </p:txBody>
@@ -2981,10 +2997,12 @@
             </a:avLst>
           </a:prstGeom>
           <a:solidFill xmlns:a="http://schemas.openxmlformats.org/drawingml/2006/main">
-            <a:srgbClr val="E11D48"/>
-          </a:solidFill>
-          <a:ln xmlns:a="http://schemas.openxmlformats.org/drawingml/2006/main" w="0">
-            <a:noFill/>
+            <a:srgbClr val="EF233C"/>
+          </a:solidFill>
+          <a:ln xmlns:a="http://schemas.openxmlformats.org/drawingml/2006/main" w="0">
+            <a:solidFill>
+              <a:srgbClr val="EF233C"/>
+            </a:solidFill>
             <a:prstDash val="solid"/>
           </a:ln>
         </p:spPr>
@@ -3035,7 +3053,7 @@
                   <a:srgbClr val="F8FAFC"/>
                 </a:solidFill>
               </a:rPr>
-              <a:t>Gerçek robota aktarım kapısı</a:t>
+              <a:t>Übergabe an den realen Roboter</a:t>
             </a:r>
           </a:p>
         </p:txBody>
@@ -3076,17 +3094,17 @@
               <a:buNone/>
               <a:defRPr sz="1200">
                 <a:solidFill>
-                  <a:srgbClr val="CBD5E1"/>
+                  <a:srgbClr val="C7C2C2"/>
                 </a:solidFill>
               </a:defRPr>
             </a:pPr>
             <a:r>
               <a:rPr sz="1200">
                 <a:solidFill>
-                  <a:srgbClr val="CBD5E1"/>
-                </a:solidFill>
-              </a:rPr>
-              <a:t>Add Point, Simulate Trajectory, Move Arms ve Save Real Robot Motion adımları aynı operatör akışında.</a:t>
+                  <a:srgbClr val="C7C2C2"/>
+                </a:solidFill>
+              </a:rPr>
+              <a:t>Add Point, Simulate Trajectory, Move Arms und Save Real Robot Motion bleiben in einem Operator-Flow.</a:t>
             </a:r>
           </a:p>
         </p:txBody>
@@ -3100,7 +3118,7 @@
           <p:nvPr/>
         </p:nvPicPr>
         <p:blipFill>
-          <a:blip xmlns:r="http://schemas.openxmlformats.org/officeDocument/2006/relationships" xmlns:a="http://schemas.openxmlformats.org/drawingml/2006/main" r:embed="R067c94588b164367"/>
+          <a:blip xmlns:r="http://schemas.openxmlformats.org/officeDocument/2006/relationships" xmlns:a="http://schemas.openxmlformats.org/drawingml/2006/main" r:embed="R88832f2d4d414ff9"/>
           <a:stretch xmlns:a="http://schemas.openxmlformats.org/drawingml/2006/main"/>
         </p:blipFill>
         <p:spPr>
@@ -3138,7 +3156,7 @@
           <a:noFill xmlns:a="http://schemas.openxmlformats.org/drawingml/2006/main"/>
           <a:ln xmlns:a="http://schemas.openxmlformats.org/drawingml/2006/main" w="19050">
             <a:solidFill>
-              <a:srgbClr val="334155"/>
+              <a:srgbClr val="5B1720"/>
             </a:solidFill>
             <a:prstDash val="solid"/>
           </a:ln>
@@ -3180,17 +3198,17 @@
               <a:buNone/>
               <a:defRPr sz="1275">
                 <a:solidFill>
-                  <a:srgbClr val="E2E8F0"/>
+                  <a:srgbClr val="C7C2C2"/>
                 </a:solidFill>
               </a:defRPr>
             </a:pPr>
             <a:r>
               <a:rPr sz="1275">
                 <a:solidFill>
-                  <a:srgbClr val="E2E8F0"/>
-                </a:solidFill>
-              </a:rPr>
-              <a:t>Canlı operatör görünümü: solda sequence listesi, ortada 3D robot replay, üstte güvenlik ve kayıt aksiyonları.</a:t>
+                  <a:srgbClr val="C7C2C2"/>
+                </a:solidFill>
+              </a:rPr>
+              <a:t>Live-Operatoransicht: links die Sequenzliste, in der Mitte 3D-Roboter-Replay, oben Sicherheits- und Speicheraktionen.</a:t>
             </a:r>
           </a:p>
         </p:txBody>
@@ -3220,11 +3238,11 @@
             </a:avLst>
           </a:prstGeom>
           <a:solidFill xmlns:a="http://schemas.openxmlformats.org/drawingml/2006/main">
-            <a:srgbClr val="121923"/>
+            <a:srgbClr val="171012"/>
           </a:solidFill>
           <a:ln xmlns:a="http://schemas.openxmlformats.org/drawingml/2006/main" w="9525">
             <a:solidFill>
-              <a:srgbClr val="1F2937"/>
+              <a:srgbClr val="5B1720"/>
             </a:solidFill>
             <a:prstDash val="solid"/>
           </a:ln>
@@ -3266,17 +3284,17 @@
               <a:buNone/>
               <a:defRPr sz="1200" b="1">
                 <a:solidFill>
-                  <a:srgbClr val="F8FAFC"/>
+                  <a:srgbClr val="C7C2C2"/>
                 </a:solidFill>
               </a:defRPr>
             </a:pPr>
             <a:r>
               <a:rPr sz="1200" b="1">
                 <a:solidFill>
-                  <a:srgbClr val="F8FAFC"/>
-                </a:solidFill>
-              </a:rPr>
-              <a:t>Amaç: hareket komutu gerçek robota gitmeden önce kayıt, görünürlük ve simülasyon doğrulaması tamamlanır.</a:t>
+                  <a:srgbClr val="C7C2C2"/>
+                </a:solidFill>
+              </a:rPr>
+              <a:t>Ziel: Aufnahme, Sichtbarkeit und Simulation sind vor der Bewegung validiert.</a:t>
             </a:r>
           </a:p>
         </p:txBody>
@@ -3297,7 +3315,7 @@
     <p:bg>
       <p:bgPr>
         <a:solidFill xmlns:a="http://schemas.openxmlformats.org/drawingml/2006/main">
-          <a:srgbClr val="080B0F"/>
+          <a:srgbClr val="050506"/>
         </a:solidFill>
       </p:bgPr>
     </p:bg>
@@ -3333,10 +3351,12 @@
             <a:avLst/>
           </a:prstGeom>
           <a:solidFill xmlns:a="http://schemas.openxmlformats.org/drawingml/2006/main">
-            <a:srgbClr val="111318"/>
-          </a:solidFill>
-          <a:ln xmlns:a="http://schemas.openxmlformats.org/drawingml/2006/main" w="0">
-            <a:noFill/>
+            <a:srgbClr val="0B0B0D"/>
+          </a:solidFill>
+          <a:ln xmlns:a="http://schemas.openxmlformats.org/drawingml/2006/main" w="0">
+            <a:solidFill>
+              <a:srgbClr val="0B0B0D"/>
+            </a:solidFill>
             <a:prstDash val="solid"/>
           </a:ln>
         </p:spPr>
@@ -3377,17 +3397,17 @@
               <a:buNone/>
               <a:defRPr sz="1050" b="1">
                 <a:solidFill>
-                  <a:srgbClr val="38BDF8"/>
+                  <a:srgbClr val="FF4D5E"/>
                 </a:solidFill>
               </a:defRPr>
             </a:pPr>
             <a:r>
               <a:rPr sz="1050" b="1">
                 <a:solidFill>
-                  <a:srgbClr val="38BDF8"/>
-                </a:solidFill>
-              </a:rPr>
-              <a:t>XR WALKING CONTROL</a:t>
+                  <a:srgbClr val="FF4D5E"/>
+                </a:solidFill>
+              </a:rPr>
+              <a:t>XR-GEHSTEUERUNG</a:t>
             </a:r>
           </a:p>
         </p:txBody>
@@ -3428,17 +3448,17 @@
               <a:buNone/>
               <a:defRPr sz="3150" b="1">
                 <a:solidFill>
-                  <a:srgbClr val="FFFFFF"/>
+                  <a:srgbClr val="F8FAFC"/>
                 </a:solidFill>
               </a:defRPr>
             </a:pPr>
             <a:r>
               <a:rPr sz="3150" b="1">
                 <a:solidFill>
-                  <a:srgbClr val="FFFFFF"/>
-                </a:solidFill>
-              </a:rPr>
-              <a:t>Robotu yürütmenin</a:t>
+                  <a:srgbClr val="F8FAFC"/>
+                </a:solidFill>
+              </a:rPr>
+              <a:t>Drei XR-Modi</a:t>
             </a:r>
           </a:p>
           <a:p xmlns:a="http://schemas.openxmlformats.org/drawingml/2006/main">
@@ -3446,17 +3466,17 @@
               <a:buNone/>
               <a:defRPr sz="3150" b="1">
                 <a:solidFill>
-                  <a:srgbClr val="FFFFFF"/>
+                  <a:srgbClr val="F8FAFC"/>
                 </a:solidFill>
               </a:defRPr>
             </a:pPr>
             <a:r>
               <a:rPr sz="3150" b="1">
                 <a:solidFill>
-                  <a:srgbClr val="FFFFFF"/>
-                </a:solidFill>
-              </a:rPr>
-              <a:t>üç yolu</a:t>
+                  <a:srgbClr val="F8FAFC"/>
+                </a:solidFill>
+              </a:rPr>
+              <a:t>für den Robotergang</a:t>
             </a:r>
           </a:p>
         </p:txBody>
@@ -3497,17 +3517,17 @@
               <a:buNone/>
               <a:defRPr sz="1350">
                 <a:solidFill>
-                  <a:srgbClr val="CBD5E1"/>
+                  <a:srgbClr val="F8FAFC"/>
                 </a:solidFill>
               </a:defRPr>
             </a:pPr>
             <a:r>
               <a:rPr sz="1350">
                 <a:solidFill>
-                  <a:srgbClr val="CBD5E1"/>
-                </a:solidFill>
-              </a:rPr>
-              <a:t>Operatör; hassas manuel komut, baş yönüyle sezgisel sürüş veya pozisyon eşleme arasında geçiş yapabiliyor.</a:t>
+                  <a:srgbClr val="F8FAFC"/>
+                </a:solidFill>
+              </a:rPr>
+              <a:t>Der Operator wechselt zwischen manueller Eingabe, Blickrichtung und Positions-Synchronisation.</a:t>
             </a:r>
           </a:p>
         </p:txBody>
@@ -3535,10 +3555,12 @@
             <a:avLst/>
           </a:prstGeom>
           <a:solidFill xmlns:a="http://schemas.openxmlformats.org/drawingml/2006/main">
-            <a:srgbClr val="22C55E"/>
-          </a:solidFill>
-          <a:ln xmlns:a="http://schemas.openxmlformats.org/drawingml/2006/main" w="0">
-            <a:noFill/>
+            <a:srgbClr val="EF233C"/>
+          </a:solidFill>
+          <a:ln xmlns:a="http://schemas.openxmlformats.org/drawingml/2006/main" w="0">
+            <a:solidFill>
+              <a:srgbClr val="EF233C"/>
+            </a:solidFill>
             <a:prstDash val="solid"/>
           </a:ln>
         </p:spPr>
@@ -3579,7 +3601,7 @@
               <a:buNone/>
               <a:defRPr sz="1200" b="1">
                 <a:solidFill>
-                  <a:srgbClr val="FFFFFF"/>
+                  <a:srgbClr val="C7C2C2"/>
                 </a:solidFill>
               </a:defRPr>
             </a:pPr>
@@ -3681,17 +3703,17 @@
               <a:buNone/>
               <a:defRPr sz="1200">
                 <a:solidFill>
-                  <a:srgbClr val="CBD5E1"/>
+                  <a:srgbClr val="C7C2C2"/>
                 </a:solidFill>
               </a:defRPr>
             </a:pPr>
             <a:r>
               <a:rPr sz="1200">
                 <a:solidFill>
-                  <a:srgbClr val="CBD5E1"/>
-                </a:solidFill>
-              </a:rPr>
-              <a:t>Sanal joystick/pad ile hız ve yön verilir. Demo, dar alan ve hassas manuel sürüş için uygun.</a:t>
+                  <a:srgbClr val="C7C2C2"/>
+                </a:solidFill>
+              </a:rPr>
+              <a:t>Ein virtuelles Pad steuert Geschwindigkeit und Richtung; ideal für Demo, enge Räume und präzise Fahrt.</a:t>
             </a:r>
           </a:p>
         </p:txBody>
@@ -3719,10 +3741,12 @@
             <a:avLst/>
           </a:prstGeom>
           <a:solidFill xmlns:a="http://schemas.openxmlformats.org/drawingml/2006/main">
-            <a:srgbClr val="38BDF8"/>
-          </a:solidFill>
-          <a:ln xmlns:a="http://schemas.openxmlformats.org/drawingml/2006/main" w="0">
-            <a:noFill/>
+            <a:srgbClr val="C1121F"/>
+          </a:solidFill>
+          <a:ln xmlns:a="http://schemas.openxmlformats.org/drawingml/2006/main" w="0">
+            <a:solidFill>
+              <a:srgbClr val="C1121F"/>
+            </a:solidFill>
             <a:prstDash val="solid"/>
           </a:ln>
         </p:spPr>
@@ -3763,7 +3787,7 @@
               <a:buNone/>
               <a:defRPr sz="1200" b="1">
                 <a:solidFill>
-                  <a:srgbClr val="FFFFFF"/>
+                  <a:srgbClr val="C7C2C2"/>
                 </a:solidFill>
               </a:defRPr>
             </a:pPr>
@@ -3865,17 +3889,17 @@
               <a:buNone/>
               <a:defRPr sz="1200">
                 <a:solidFill>
-                  <a:srgbClr val="CBD5E1"/>
+                  <a:srgbClr val="C7C2C2"/>
                 </a:solidFill>
               </a:defRPr>
             </a:pPr>
             <a:r>
               <a:rPr sz="1200">
                 <a:solidFill>
-                  <a:srgbClr val="CBD5E1"/>
-                </a:solidFill>
-              </a:rPr>
-              <a:t>Başın baktığı yön robotun yürüyüş niyetine çevrilir. Operatör robotu bakışla yönlendirir.</a:t>
+                  <a:srgbClr val="C7C2C2"/>
+                </a:solidFill>
+              </a:rPr>
+              <a:t>Die Blickrichtung wird in Gehabsicht übersetzt; der Operator lenkt den Roboter mit dem Kopf.</a:t>
             </a:r>
           </a:p>
         </p:txBody>
@@ -3903,10 +3927,12 @@
             <a:avLst/>
           </a:prstGeom>
           <a:solidFill xmlns:a="http://schemas.openxmlformats.org/drawingml/2006/main">
-            <a:srgbClr val="F97316"/>
-          </a:solidFill>
-          <a:ln xmlns:a="http://schemas.openxmlformats.org/drawingml/2006/main" w="0">
-            <a:noFill/>
+            <a:srgbClr val="780000"/>
+          </a:solidFill>
+          <a:ln xmlns:a="http://schemas.openxmlformats.org/drawingml/2006/main" w="0">
+            <a:solidFill>
+              <a:srgbClr val="780000"/>
+            </a:solidFill>
             <a:prstDash val="solid"/>
           </a:ln>
         </p:spPr>
@@ -3947,7 +3973,7 @@
               <a:buNone/>
               <a:defRPr sz="1200" b="1">
                 <a:solidFill>
-                  <a:srgbClr val="FFFFFF"/>
+                  <a:srgbClr val="C7C2C2"/>
                 </a:solidFill>
               </a:defRPr>
             </a:pPr>
@@ -4049,17 +4075,17 @@
               <a:buNone/>
               <a:defRPr sz="1200">
                 <a:solidFill>
-                  <a:srgbClr val="CBD5E1"/>
+                  <a:srgbClr val="C7C2C2"/>
                 </a:solidFill>
               </a:defRPr>
             </a:pPr>
             <a:r>
               <a:rPr sz="1200">
                 <a:solidFill>
-                  <a:srgbClr val="CBD5E1"/>
-                </a:solidFill>
-              </a:rPr>
-              <a:t>Operatörün pozisyonu ve yönelimi robot hareketine eşlenir. Telepresence hissini güçlendirir.</a:t>
+                  <a:srgbClr val="C7C2C2"/>
+                </a:solidFill>
+              </a:rPr>
+              <a:t>Position und Orientierung des Operators werden auf Roboterbewegung gemappt und stärken Telepresence.</a:t>
             </a:r>
           </a:p>
         </p:txBody>
@@ -4073,7 +4099,7 @@
           <p:nvPr/>
         </p:nvPicPr>
         <p:blipFill>
-          <a:blip xmlns:r="http://schemas.openxmlformats.org/officeDocument/2006/relationships" xmlns:a="http://schemas.openxmlformats.org/drawingml/2006/main" r:embed="Ra77092ffe2e64bd8"/>
+          <a:blip xmlns:r="http://schemas.openxmlformats.org/officeDocument/2006/relationships" xmlns:a="http://schemas.openxmlformats.org/drawingml/2006/main" r:embed="R7eab3f182b5c4af4"/>
           <a:srcRect xmlns:a="http://schemas.openxmlformats.org/drawingml/2006/main" l="28" t="0" r="28" b="0"/>
           <a:stretch xmlns:a="http://schemas.openxmlformats.org/drawingml/2006/main">
             <a:fillRect l="0" t="0" r="0" b="0"/>
@@ -4114,7 +4140,7 @@
           <a:noFill xmlns:a="http://schemas.openxmlformats.org/drawingml/2006/main"/>
           <a:ln xmlns:a="http://schemas.openxmlformats.org/drawingml/2006/main" w="19050">
             <a:solidFill>
-              <a:srgbClr val="334155"/>
+              <a:srgbClr val="5B1720"/>
             </a:solidFill>
             <a:prstDash val="solid"/>
           </a:ln>
@@ -4156,17 +4182,17 @@
               <a:buNone/>
               <a:defRPr sz="1350">
                 <a:solidFill>
-                  <a:srgbClr val="E2E8F0"/>
+                  <a:srgbClr val="C7C2C2"/>
                 </a:solidFill>
               </a:defRPr>
             </a:pPr>
             <a:r>
               <a:rPr sz="1350">
                 <a:solidFill>
-                  <a:srgbClr val="E2E8F0"/>
-                </a:solidFill>
-              </a:rPr>
-              <a:t>Görüntüde Vision Pro arayüzü robot sahnesinin üzerine bindirilmiş: üç kontrol modu aynı seçim ekranında karşılaştırılıyor.</a:t>
+                  <a:srgbClr val="C7C2C2"/>
+                </a:solidFill>
+              </a:rPr>
+              <a:t>Die Vision-Pro-Oberfläche liegt über der Roboterszene; drei Kontrollmodi werden in einer Auswahl verglichen.</a:t>
             </a:r>
           </a:p>
         </p:txBody>
@@ -4196,11 +4222,11 @@
             </a:avLst>
           </a:prstGeom>
           <a:solidFill xmlns:a="http://schemas.openxmlformats.org/drawingml/2006/main">
-            <a:srgbClr val="121923"/>
+            <a:srgbClr val="171012"/>
           </a:solidFill>
           <a:ln xmlns:a="http://schemas.openxmlformats.org/drawingml/2006/main" w="9525">
             <a:solidFill>
-              <a:srgbClr val="1F2937"/>
+              <a:srgbClr val="5B1720"/>
             </a:solidFill>
             <a:prstDash val="solid"/>
           </a:ln>
@@ -4242,17 +4268,17 @@
               <a:buNone/>
               <a:defRPr sz="1275" b="1">
                 <a:solidFill>
-                  <a:srgbClr val="F8FAFC"/>
+                  <a:srgbClr val="C7C2C2"/>
                 </a:solidFill>
               </a:defRPr>
             </a:pPr>
             <a:r>
               <a:rPr sz="1275" b="1">
                 <a:solidFill>
-                  <a:srgbClr val="F8FAFC"/>
-                </a:solidFill>
-              </a:rPr>
-              <a:t>Yürütme katmanı tek bir kontrol biçimine kilitlenmez; görev, ortam ve operatör deneyimine göre mod seçilir.</a:t>
+                  <a:srgbClr val="C7C2C2"/>
+                </a:solidFill>
+              </a:rPr>
+              <a:t>Moduswahl nach Aufgabe, Umgebung und Operator-Erfahrung.</a:t>
             </a:r>
           </a:p>
         </p:txBody>
@@ -4273,7 +4299,7 @@
     <p:bg>
       <p:bgPr>
         <a:solidFill xmlns:a="http://schemas.openxmlformats.org/drawingml/2006/main">
-          <a:srgbClr val="080B0F"/>
+          <a:srgbClr val="050506"/>
         </a:solidFill>
       </p:bgPr>
     </p:bg>
@@ -4322,17 +4348,17 @@
               <a:buNone/>
               <a:defRPr sz="1050" b="1">
                 <a:solidFill>
-                  <a:srgbClr val="22C55E"/>
+                  <a:srgbClr val="FF4D5E"/>
                 </a:solidFill>
               </a:defRPr>
             </a:pPr>
             <a:r>
               <a:rPr sz="1050" b="1">
                 <a:solidFill>
-                  <a:srgbClr val="DC2626"/>
-                </a:solidFill>
-              </a:rPr>
-              <a:t>FEATURE SCOPE</a:t>
+                  <a:srgbClr val="FF4D5E"/>
+                </a:solidFill>
+              </a:rPr>
+              <a:t>FUNKTIONSUMFANG</a:t>
             </a:r>
           </a:p>
         </p:txBody>
@@ -4373,17 +4399,17 @@
               <a:buNone/>
               <a:defRPr sz="2550" b="1">
                 <a:solidFill>
-                  <a:srgbClr val="FFFFFF"/>
+                  <a:srgbClr val="F8FAFC"/>
                 </a:solidFill>
               </a:defRPr>
             </a:pPr>
             <a:r>
               <a:rPr sz="2550" b="1">
                 <a:solidFill>
-                  <a:srgbClr val="0F172A"/>
-                </a:solidFill>
-              </a:rPr>
-              <a:t>Camera Stream, Teleoperation ve kayıt akışları hariç özellikler</a:t>
+                  <a:srgbClr val="F8FAFC"/>
+                </a:solidFill>
+              </a:rPr>
+              <a:t>Funktionen ausser Camera Stream, Teleoperation und Recording-Flows</a:t>
             </a:r>
           </a:p>
         </p:txBody>
@@ -4424,17 +4450,17 @@
               <a:buNone/>
               <a:defRPr sz="1425">
                 <a:solidFill>
-                  <a:srgbClr val="CBD5E1"/>
+                  <a:srgbClr val="F8FAFC"/>
                 </a:solidFill>
               </a:defRPr>
             </a:pPr>
             <a:r>
               <a:rPr sz="1425">
                 <a:solidFill>
-                  <a:srgbClr val="475569"/>
-                </a:solidFill>
-              </a:rPr>
-              <a:t>Robot deneyimini kamera yayını, teleoperation ve kayıt/sequence akışlarına dayanmadan anlatan ürün katmanları.</a:t>
+                  <a:srgbClr val="F8FAFC"/>
+                </a:solidFill>
+              </a:rPr>
+              <a:t>Produktschichten, die das Robotererlebnis ohne Kamera-Stream, Teleoperation und Recording-Sequenzen erklären.</a:t>
             </a:r>
           </a:p>
         </p:txBody>
@@ -4462,10 +4488,12 @@
             <a:avLst/>
           </a:prstGeom>
           <a:solidFill xmlns:a="http://schemas.openxmlformats.org/drawingml/2006/main">
-            <a:srgbClr val="DC2626"/>
-          </a:solidFill>
-          <a:ln xmlns:a="http://schemas.openxmlformats.org/drawingml/2006/main" w="0">
-            <a:noFill/>
+            <a:srgbClr val="EF233C"/>
+          </a:solidFill>
+          <a:ln xmlns:a="http://schemas.openxmlformats.org/drawingml/2006/main" w="0">
+            <a:solidFill>
+              <a:srgbClr val="EF233C"/>
+            </a:solidFill>
             <a:prstDash val="solid"/>
           </a:ln>
         </p:spPr>
@@ -4513,10 +4541,10 @@
             <a:r>
               <a:rPr sz="1650" b="1">
                 <a:solidFill>
-                  <a:srgbClr val="111827"/>
-                </a:solidFill>
-              </a:rPr>
-              <a:t>Cockpit ve AI</a:t>
+                  <a:srgbClr val="F8FAFC"/>
+                </a:solidFill>
+              </a:rPr>
+              <a:t>Cockpit und KI</a:t>
             </a:r>
           </a:p>
         </p:txBody>
@@ -4544,10 +4572,12 @@
             <a:avLst/>
           </a:prstGeom>
           <a:solidFill xmlns:a="http://schemas.openxmlformats.org/drawingml/2006/main">
-            <a:srgbClr val="DC2626"/>
-          </a:solidFill>
-          <a:ln xmlns:a="http://schemas.openxmlformats.org/drawingml/2006/main" w="0">
-            <a:noFill/>
+            <a:srgbClr val="FF4D5E"/>
+          </a:solidFill>
+          <a:ln xmlns:a="http://schemas.openxmlformats.org/drawingml/2006/main" w="0">
+            <a:solidFill>
+              <a:srgbClr val="FF4D5E"/>
+            </a:solidFill>
             <a:prstDash val="solid"/>
           </a:ln>
         </p:spPr>
@@ -4588,17 +4618,17 @@
               <a:buNone/>
               <a:defRPr sz="1275">
                 <a:solidFill>
-                  <a:srgbClr val="CBD5E1"/>
+                  <a:srgbClr val="C7C2C2"/>
                 </a:solidFill>
               </a:defRPr>
             </a:pPr>
             <a:r>
               <a:rPr sz="1275">
                 <a:solidFill>
-                  <a:srgbClr val="374151"/>
-                </a:solidFill>
-              </a:rPr>
-              <a:t>AI Chatbot ile doğal dil komut ve cevap akışı</a:t>
+                  <a:srgbClr val="C7C2C2"/>
+                </a:solidFill>
+              </a:rPr>
+              <a:t>Natürliche Befehle und Antworten über den KI-Chatbot</a:t>
             </a:r>
           </a:p>
         </p:txBody>
@@ -4626,10 +4656,12 @@
             <a:avLst/>
           </a:prstGeom>
           <a:solidFill xmlns:a="http://schemas.openxmlformats.org/drawingml/2006/main">
-            <a:srgbClr val="DC2626"/>
-          </a:solidFill>
-          <a:ln xmlns:a="http://schemas.openxmlformats.org/drawingml/2006/main" w="0">
-            <a:noFill/>
+            <a:srgbClr val="FF4D5E"/>
+          </a:solidFill>
+          <a:ln xmlns:a="http://schemas.openxmlformats.org/drawingml/2006/main" w="0">
+            <a:solidFill>
+              <a:srgbClr val="FF4D5E"/>
+            </a:solidFill>
             <a:prstDash val="solid"/>
           </a:ln>
         </p:spPr>
@@ -4670,17 +4702,17 @@
               <a:buNone/>
               <a:defRPr sz="1275">
                 <a:solidFill>
-                  <a:srgbClr val="CBD5E1"/>
+                  <a:srgbClr val="C7C2C2"/>
                 </a:solidFill>
               </a:defRPr>
             </a:pPr>
             <a:r>
               <a:rPr sz="1275">
                 <a:solidFill>
-                  <a:srgbClr val="374151"/>
-                </a:solidFill>
-              </a:rPr>
-              <a:t>Bilgi akışı / RAG ile robot bağlamını toplama</a:t>
+                  <a:srgbClr val="C7C2C2"/>
+                </a:solidFill>
+              </a:rPr>
+              <a:t>Robot-Kontext über Informationsfluss und RAG bündeln</a:t>
             </a:r>
           </a:p>
         </p:txBody>
@@ -4708,10 +4740,12 @@
             <a:avLst/>
           </a:prstGeom>
           <a:solidFill xmlns:a="http://schemas.openxmlformats.org/drawingml/2006/main">
-            <a:srgbClr val="DC2626"/>
-          </a:solidFill>
-          <a:ln xmlns:a="http://schemas.openxmlformats.org/drawingml/2006/main" w="0">
-            <a:noFill/>
+            <a:srgbClr val="FF4D5E"/>
+          </a:solidFill>
+          <a:ln xmlns:a="http://schemas.openxmlformats.org/drawingml/2006/main" w="0">
+            <a:solidFill>
+              <a:srgbClr val="FF4D5E"/>
+            </a:solidFill>
             <a:prstDash val="solid"/>
           </a:ln>
         </p:spPr>
@@ -4752,17 +4786,17 @@
               <a:buNone/>
               <a:defRPr sz="1275">
                 <a:solidFill>
-                  <a:srgbClr val="CBD5E1"/>
+                  <a:srgbClr val="C7C2C2"/>
                 </a:solidFill>
               </a:defRPr>
             </a:pPr>
             <a:r>
               <a:rPr sz="1275">
                 <a:solidFill>
-                  <a:srgbClr val="374151"/>
-                </a:solidFill>
-              </a:rPr>
-              <a:t>Robot Twin ile dijital sahne ve durum hissi</a:t>
+                  <a:srgbClr val="C7C2C2"/>
+                </a:solidFill>
+              </a:rPr>
+              <a:t>Digitale Szene und Zustandsgefühl über den Robot Twin</a:t>
             </a:r>
           </a:p>
         </p:txBody>
@@ -4790,10 +4824,12 @@
             <a:avLst/>
           </a:prstGeom>
           <a:solidFill xmlns:a="http://schemas.openxmlformats.org/drawingml/2006/main">
-            <a:srgbClr val="DC2626"/>
-          </a:solidFill>
-          <a:ln xmlns:a="http://schemas.openxmlformats.org/drawingml/2006/main" w="0">
-            <a:noFill/>
+            <a:srgbClr val="FF4D5E"/>
+          </a:solidFill>
+          <a:ln xmlns:a="http://schemas.openxmlformats.org/drawingml/2006/main" w="0">
+            <a:solidFill>
+              <a:srgbClr val="FF4D5E"/>
+            </a:solidFill>
             <a:prstDash val="solid"/>
           </a:ln>
         </p:spPr>
@@ -4834,17 +4870,17 @@
               <a:buNone/>
               <a:defRPr sz="1275">
                 <a:solidFill>
-                  <a:srgbClr val="CBD5E1"/>
+                  <a:srgbClr val="C7C2C2"/>
                 </a:solidFill>
               </a:defRPr>
             </a:pPr>
             <a:r>
               <a:rPr sz="1275">
                 <a:solidFill>
-                  <a:srgbClr val="374151"/>
-                </a:solidFill>
-              </a:rPr>
-              <a:t>Tek cockpit içinde operatör karar ekranı</a:t>
+                  <a:srgbClr val="C7C2C2"/>
+                </a:solidFill>
+              </a:rPr>
+              <a:t>Operator-Entscheidungen in einem Cockpit bündeln</a:t>
             </a:r>
           </a:p>
         </p:txBody>
@@ -4872,10 +4908,12 @@
             <a:avLst/>
           </a:prstGeom>
           <a:solidFill xmlns:a="http://schemas.openxmlformats.org/drawingml/2006/main">
-            <a:srgbClr val="0EA5E9"/>
-          </a:solidFill>
-          <a:ln xmlns:a="http://schemas.openxmlformats.org/drawingml/2006/main" w="0">
-            <a:noFill/>
+            <a:srgbClr val="EF233C"/>
+          </a:solidFill>
+          <a:ln xmlns:a="http://schemas.openxmlformats.org/drawingml/2006/main" w="0">
+            <a:solidFill>
+              <a:srgbClr val="EF233C"/>
+            </a:solidFill>
             <a:prstDash val="solid"/>
           </a:ln>
         </p:spPr>
@@ -4923,7 +4961,7 @@
             <a:r>
               <a:rPr sz="1650" b="1">
                 <a:solidFill>
-                  <a:srgbClr val="111827"/>
+                  <a:srgbClr val="F8FAFC"/>
                 </a:solidFill>
               </a:rPr>
               <a:t>Robot Twin</a:t>
@@ -4954,10 +4992,12 @@
             <a:avLst/>
           </a:prstGeom>
           <a:solidFill xmlns:a="http://schemas.openxmlformats.org/drawingml/2006/main">
-            <a:srgbClr val="0EA5E9"/>
-          </a:solidFill>
-          <a:ln xmlns:a="http://schemas.openxmlformats.org/drawingml/2006/main" w="0">
-            <a:noFill/>
+            <a:srgbClr val="FF4D5E"/>
+          </a:solidFill>
+          <a:ln xmlns:a="http://schemas.openxmlformats.org/drawingml/2006/main" w="0">
+            <a:solidFill>
+              <a:srgbClr val="FF4D5E"/>
+            </a:solidFill>
             <a:prstDash val="solid"/>
           </a:ln>
         </p:spPr>
@@ -4998,17 +5038,17 @@
               <a:buNone/>
               <a:defRPr sz="1275">
                 <a:solidFill>
-                  <a:srgbClr val="CBD5E1"/>
+                  <a:srgbClr val="C7C2C2"/>
                 </a:solidFill>
               </a:defRPr>
             </a:pPr>
             <a:r>
               <a:rPr sz="1275">
                 <a:solidFill>
-                  <a:srgbClr val="374151"/>
-                </a:solidFill>
-              </a:rPr>
-              <a:t>Dijital robot görünümüyle sahneyi okuma</a:t>
+                  <a:srgbClr val="C7C2C2"/>
+                </a:solidFill>
+              </a:rPr>
+              <a:t>Die Szene über die digitale Roboteransicht lesen</a:t>
             </a:r>
           </a:p>
         </p:txBody>
@@ -5036,10 +5076,12 @@
             <a:avLst/>
           </a:prstGeom>
           <a:solidFill xmlns:a="http://schemas.openxmlformats.org/drawingml/2006/main">
-            <a:srgbClr val="0EA5E9"/>
-          </a:solidFill>
-          <a:ln xmlns:a="http://schemas.openxmlformats.org/drawingml/2006/main" w="0">
-            <a:noFill/>
+            <a:srgbClr val="FF4D5E"/>
+          </a:solidFill>
+          <a:ln xmlns:a="http://schemas.openxmlformats.org/drawingml/2006/main" w="0">
+            <a:solidFill>
+              <a:srgbClr val="FF4D5E"/>
+            </a:solidFill>
             <a:prstDash val="solid"/>
           </a:ln>
         </p:spPr>
@@ -5080,17 +5122,17 @@
               <a:buNone/>
               <a:defRPr sz="1275">
                 <a:solidFill>
-                  <a:srgbClr val="CBD5E1"/>
+                  <a:srgbClr val="C7C2C2"/>
                 </a:solidFill>
               </a:defRPr>
             </a:pPr>
             <a:r>
               <a:rPr sz="1275">
                 <a:solidFill>
-                  <a:srgbClr val="374151"/>
-                </a:solidFill>
-              </a:rPr>
-              <a:t>Robot durumunu görsel olarak takip etme</a:t>
+                  <a:srgbClr val="C7C2C2"/>
+                </a:solidFill>
+              </a:rPr>
+              <a:t>Roboterzustand visuell verfolgen</a:t>
             </a:r>
           </a:p>
         </p:txBody>
@@ -5118,10 +5160,12 @@
             <a:avLst/>
           </a:prstGeom>
           <a:solidFill xmlns:a="http://schemas.openxmlformats.org/drawingml/2006/main">
-            <a:srgbClr val="0EA5E9"/>
-          </a:solidFill>
-          <a:ln xmlns:a="http://schemas.openxmlformats.org/drawingml/2006/main" w="0">
-            <a:noFill/>
+            <a:srgbClr val="FF4D5E"/>
+          </a:solidFill>
+          <a:ln xmlns:a="http://schemas.openxmlformats.org/drawingml/2006/main" w="0">
+            <a:solidFill>
+              <a:srgbClr val="FF4D5E"/>
+            </a:solidFill>
             <a:prstDash val="solid"/>
           </a:ln>
         </p:spPr>
@@ -5162,17 +5206,17 @@
               <a:buNone/>
               <a:defRPr sz="1275">
                 <a:solidFill>
-                  <a:srgbClr val="CBD5E1"/>
+                  <a:srgbClr val="C7C2C2"/>
                 </a:solidFill>
               </a:defRPr>
             </a:pPr>
             <a:r>
               <a:rPr sz="1275">
                 <a:solidFill>
-                  <a:srgbClr val="374151"/>
-                </a:solidFill>
-              </a:rPr>
-              <a:t>Operatöre tek bakışta sahne farkındalığı verme</a:t>
+                  <a:srgbClr val="C7C2C2"/>
+                </a:solidFill>
+              </a:rPr>
+              <a:t>Situationsbewusstsein auf einen Blick geben</a:t>
             </a:r>
           </a:p>
         </p:txBody>
@@ -5200,10 +5244,12 @@
             <a:avLst/>
           </a:prstGeom>
           <a:solidFill xmlns:a="http://schemas.openxmlformats.org/drawingml/2006/main">
-            <a:srgbClr val="0EA5E9"/>
-          </a:solidFill>
-          <a:ln xmlns:a="http://schemas.openxmlformats.org/drawingml/2006/main" w="0">
-            <a:noFill/>
+            <a:srgbClr val="FF4D5E"/>
+          </a:solidFill>
+          <a:ln xmlns:a="http://schemas.openxmlformats.org/drawingml/2006/main" w="0">
+            <a:solidFill>
+              <a:srgbClr val="FF4D5E"/>
+            </a:solidFill>
             <a:prstDash val="solid"/>
           </a:ln>
         </p:spPr>
@@ -5244,17 +5290,17 @@
               <a:buNone/>
               <a:defRPr sz="1275">
                 <a:solidFill>
-                  <a:srgbClr val="CBD5E1"/>
+                  <a:srgbClr val="C7C2C2"/>
                 </a:solidFill>
               </a:defRPr>
             </a:pPr>
             <a:r>
               <a:rPr sz="1275">
                 <a:solidFill>
-                  <a:srgbClr val="374151"/>
-                </a:solidFill>
-              </a:rPr>
-              <a:t>Gerçek robot ile dijital bağlamı aynı hikayede toplama</a:t>
+                  <a:srgbClr val="C7C2C2"/>
+                </a:solidFill>
+              </a:rPr>
+              <a:t>Realen Roboter und digitalen Kontext zusammenführen</a:t>
             </a:r>
           </a:p>
         </p:txBody>
@@ -5282,10 +5328,12 @@
             <a:avLst/>
           </a:prstGeom>
           <a:solidFill xmlns:a="http://schemas.openxmlformats.org/drawingml/2006/main">
-            <a:srgbClr val="22C55E"/>
-          </a:solidFill>
-          <a:ln xmlns:a="http://schemas.openxmlformats.org/drawingml/2006/main" w="0">
-            <a:noFill/>
+            <a:srgbClr val="EF233C"/>
+          </a:solidFill>
+          <a:ln xmlns:a="http://schemas.openxmlformats.org/drawingml/2006/main" w="0">
+            <a:solidFill>
+              <a:srgbClr val="EF233C"/>
+            </a:solidFill>
             <a:prstDash val="solid"/>
           </a:ln>
         </p:spPr>
@@ -5333,7 +5381,7 @@
             <a:r>
               <a:rPr sz="1650" b="1">
                 <a:solidFill>
-                  <a:srgbClr val="111827"/>
+                  <a:srgbClr val="F8FAFC"/>
                 </a:solidFill>
               </a:rPr>
               <a:t>Live Dashboard</a:t>
@@ -5364,10 +5412,12 @@
             <a:avLst/>
           </a:prstGeom>
           <a:solidFill xmlns:a="http://schemas.openxmlformats.org/drawingml/2006/main">
-            <a:srgbClr val="22C55E"/>
-          </a:solidFill>
-          <a:ln xmlns:a="http://schemas.openxmlformats.org/drawingml/2006/main" w="0">
-            <a:noFill/>
+            <a:srgbClr val="FF4D5E"/>
+          </a:solidFill>
+          <a:ln xmlns:a="http://schemas.openxmlformats.org/drawingml/2006/main" w="0">
+            <a:solidFill>
+              <a:srgbClr val="FF4D5E"/>
+            </a:solidFill>
             <a:prstDash val="solid"/>
           </a:ln>
         </p:spPr>
@@ -5408,17 +5458,17 @@
               <a:buNone/>
               <a:defRPr sz="1275">
                 <a:solidFill>
-                  <a:srgbClr val="CBD5E1"/>
+                  <a:srgbClr val="C7C2C2"/>
                 </a:solidFill>
               </a:defRPr>
             </a:pPr>
             <a:r>
               <a:rPr sz="1275">
                 <a:solidFill>
-                  <a:srgbClr val="374151"/>
-                </a:solidFill>
-              </a:rPr>
-              <a:t>Anlık robot durumunu okunabilir hale getirme</a:t>
+                  <a:srgbClr val="C7C2C2"/>
+                </a:solidFill>
+              </a:rPr>
+              <a:t>Live-Roboterzustand lesbar machen</a:t>
             </a:r>
           </a:p>
         </p:txBody>
@@ -5446,10 +5496,12 @@
             <a:avLst/>
           </a:prstGeom>
           <a:solidFill xmlns:a="http://schemas.openxmlformats.org/drawingml/2006/main">
-            <a:srgbClr val="22C55E"/>
-          </a:solidFill>
-          <a:ln xmlns:a="http://schemas.openxmlformats.org/drawingml/2006/main" w="0">
-            <a:noFill/>
+            <a:srgbClr val="FF4D5E"/>
+          </a:solidFill>
+          <a:ln xmlns:a="http://schemas.openxmlformats.org/drawingml/2006/main" w="0">
+            <a:solidFill>
+              <a:srgbClr val="FF4D5E"/>
+            </a:solidFill>
             <a:prstDash val="solid"/>
           </a:ln>
         </p:spPr>
@@ -5490,17 +5542,17 @@
               <a:buNone/>
               <a:defRPr sz="1275">
                 <a:solidFill>
-                  <a:srgbClr val="CBD5E1"/>
+                  <a:srgbClr val="C7C2C2"/>
                 </a:solidFill>
               </a:defRPr>
             </a:pPr>
             <a:r>
               <a:rPr sz="1275">
                 <a:solidFill>
-                  <a:srgbClr val="374151"/>
-                </a:solidFill>
-              </a:rPr>
-              <a:t>Sistem sağlığı ve bağlantı bilgisini takip etme</a:t>
+                  <a:srgbClr val="C7C2C2"/>
+                </a:solidFill>
+              </a:rPr>
+              <a:t>Systemgesundheit und Verbindung verfolgen</a:t>
             </a:r>
           </a:p>
         </p:txBody>
@@ -5528,10 +5580,12 @@
             <a:avLst/>
           </a:prstGeom>
           <a:solidFill xmlns:a="http://schemas.openxmlformats.org/drawingml/2006/main">
-            <a:srgbClr val="22C55E"/>
-          </a:solidFill>
-          <a:ln xmlns:a="http://schemas.openxmlformats.org/drawingml/2006/main" w="0">
-            <a:noFill/>
+            <a:srgbClr val="FF4D5E"/>
+          </a:solidFill>
+          <a:ln xmlns:a="http://schemas.openxmlformats.org/drawingml/2006/main" w="0">
+            <a:solidFill>
+              <a:srgbClr val="FF4D5E"/>
+            </a:solidFill>
             <a:prstDash val="solid"/>
           </a:ln>
         </p:spPr>
@@ -5572,17 +5626,17 @@
               <a:buNone/>
               <a:defRPr sz="1275">
                 <a:solidFill>
-                  <a:srgbClr val="CBD5E1"/>
+                  <a:srgbClr val="C7C2C2"/>
                 </a:solidFill>
               </a:defRPr>
             </a:pPr>
             <a:r>
               <a:rPr sz="1275">
                 <a:solidFill>
-                  <a:srgbClr val="374151"/>
-                </a:solidFill>
-              </a:rPr>
-              <a:t>Operasyon ekranında hızlı kontrol hissi verme</a:t>
+                  <a:srgbClr val="C7C2C2"/>
+                </a:solidFill>
+              </a:rPr>
+              <a:t>Schnelles Kontrollgefühl im Operator-Screen geben</a:t>
             </a:r>
           </a:p>
         </p:txBody>
@@ -5610,10 +5664,12 @@
             <a:avLst/>
           </a:prstGeom>
           <a:solidFill xmlns:a="http://schemas.openxmlformats.org/drawingml/2006/main">
-            <a:srgbClr val="22C55E"/>
-          </a:solidFill>
-          <a:ln xmlns:a="http://schemas.openxmlformats.org/drawingml/2006/main" w="0">
-            <a:noFill/>
+            <a:srgbClr val="FF4D5E"/>
+          </a:solidFill>
+          <a:ln xmlns:a="http://schemas.openxmlformats.org/drawingml/2006/main" w="0">
+            <a:solidFill>
+              <a:srgbClr val="FF4D5E"/>
+            </a:solidFill>
             <a:prstDash val="solid"/>
           </a:ln>
         </p:spPr>
@@ -5654,17 +5710,17 @@
               <a:buNone/>
               <a:defRPr sz="1275">
                 <a:solidFill>
-                  <a:srgbClr val="CBD5E1"/>
+                  <a:srgbClr val="C7C2C2"/>
                 </a:solidFill>
               </a:defRPr>
             </a:pPr>
             <a:r>
               <a:rPr sz="1275">
                 <a:solidFill>
-                  <a:srgbClr val="374151"/>
-                </a:solidFill>
-              </a:rPr>
-              <a:t>Log, durum ve hata bilgisini tek deneyime bağlama</a:t>
+                  <a:srgbClr val="C7C2C2"/>
+                </a:solidFill>
+              </a:rPr>
+              <a:t>Logs, Status und Fehler in einer Erfahrung verbinden</a:t>
             </a:r>
           </a:p>
         </p:txBody>
@@ -5692,10 +5748,12 @@
             <a:avLst/>
           </a:prstGeom>
           <a:solidFill xmlns:a="http://schemas.openxmlformats.org/drawingml/2006/main">
-            <a:srgbClr val="F97316"/>
-          </a:solidFill>
-          <a:ln xmlns:a="http://schemas.openxmlformats.org/drawingml/2006/main" w="0">
-            <a:noFill/>
+            <a:srgbClr val="EF233C"/>
+          </a:solidFill>
+          <a:ln xmlns:a="http://schemas.openxmlformats.org/drawingml/2006/main" w="0">
+            <a:solidFill>
+              <a:srgbClr val="EF233C"/>
+            </a:solidFill>
             <a:prstDash val="solid"/>
           </a:ln>
         </p:spPr>
@@ -5743,10 +5801,10 @@
             <a:r>
               <a:rPr sz="1500" b="1">
                 <a:solidFill>
-                  <a:srgbClr val="111827"/>
-                </a:solidFill>
-              </a:rPr>
-              <a:t>Entegrasyon ve Demo Hazırlığı</a:t>
+                  <a:srgbClr val="F8FAFC"/>
+                </a:solidFill>
+              </a:rPr>
+              <a:t>Integration und Demo-Vorbereitung</a:t>
             </a:r>
           </a:p>
         </p:txBody>
@@ -5774,10 +5832,12 @@
             <a:avLst/>
           </a:prstGeom>
           <a:solidFill xmlns:a="http://schemas.openxmlformats.org/drawingml/2006/main">
-            <a:srgbClr val="F97316"/>
-          </a:solidFill>
-          <a:ln xmlns:a="http://schemas.openxmlformats.org/drawingml/2006/main" w="0">
-            <a:noFill/>
+            <a:srgbClr val="FF4D5E"/>
+          </a:solidFill>
+          <a:ln xmlns:a="http://schemas.openxmlformats.org/drawingml/2006/main" w="0">
+            <a:solidFill>
+              <a:srgbClr val="FF4D5E"/>
+            </a:solidFill>
             <a:prstDash val="solid"/>
           </a:ln>
         </p:spPr>
@@ -5818,17 +5878,17 @@
               <a:buNone/>
               <a:defRPr sz="1275">
                 <a:solidFill>
-                  <a:srgbClr val="CBD5E1"/>
+                  <a:srgbClr val="C7C2C2"/>
                 </a:solidFill>
               </a:defRPr>
             </a:pPr>
             <a:r>
               <a:rPr sz="1275">
                 <a:solidFill>
-                  <a:srgbClr val="374151"/>
-                </a:solidFill>
-              </a:rPr>
-              <a:t>ROS Visibility ile altyapı görünürlüğü</a:t>
+                  <a:srgbClr val="C7C2C2"/>
+                </a:solidFill>
+              </a:rPr>
+              <a:t>Infrastruktur über ROS Visibility sichtbar machen</a:t>
             </a:r>
           </a:p>
         </p:txBody>
@@ -5856,10 +5916,12 @@
             <a:avLst/>
           </a:prstGeom>
           <a:solidFill xmlns:a="http://schemas.openxmlformats.org/drawingml/2006/main">
-            <a:srgbClr val="F97316"/>
-          </a:solidFill>
-          <a:ln xmlns:a="http://schemas.openxmlformats.org/drawingml/2006/main" w="0">
-            <a:noFill/>
+            <a:srgbClr val="FF4D5E"/>
+          </a:solidFill>
+          <a:ln xmlns:a="http://schemas.openxmlformats.org/drawingml/2006/main" w="0">
+            <a:solidFill>
+              <a:srgbClr val="FF4D5E"/>
+            </a:solidFill>
             <a:prstDash val="solid"/>
           </a:ln>
         </p:spPr>
@@ -5900,17 +5962,17 @@
               <a:buNone/>
               <a:defRPr sz="1275">
                 <a:solidFill>
-                  <a:srgbClr val="CBD5E1"/>
+                  <a:srgbClr val="C7C2C2"/>
                 </a:solidFill>
               </a:defRPr>
             </a:pPr>
             <a:r>
               <a:rPr sz="1275">
                 <a:solidFill>
-                  <a:srgbClr val="374151"/>
-                </a:solidFill>
-              </a:rPr>
-              <a:t>Modüler kontrol katmanları</a:t>
+                  <a:srgbClr val="C7C2C2"/>
+                </a:solidFill>
+              </a:rPr>
+              <a:t>Modulare Steuerungsschichten</a:t>
             </a:r>
           </a:p>
         </p:txBody>
@@ -5938,10 +6000,12 @@
             <a:avLst/>
           </a:prstGeom>
           <a:solidFill xmlns:a="http://schemas.openxmlformats.org/drawingml/2006/main">
-            <a:srgbClr val="F97316"/>
-          </a:solidFill>
-          <a:ln xmlns:a="http://schemas.openxmlformats.org/drawingml/2006/main" w="0">
-            <a:noFill/>
+            <a:srgbClr val="FF4D5E"/>
+          </a:solidFill>
+          <a:ln xmlns:a="http://schemas.openxmlformats.org/drawingml/2006/main" w="0">
+            <a:solidFill>
+              <a:srgbClr val="FF4D5E"/>
+            </a:solidFill>
             <a:prstDash val="solid"/>
           </a:ln>
         </p:spPr>
@@ -5982,17 +6046,17 @@
               <a:buNone/>
               <a:defRPr sz="1275">
                 <a:solidFill>
-                  <a:srgbClr val="CBD5E1"/>
+                  <a:srgbClr val="C7C2C2"/>
                 </a:solidFill>
               </a:defRPr>
             </a:pPr>
             <a:r>
               <a:rPr sz="1275">
                 <a:solidFill>
-                  <a:srgbClr val="374151"/>
-                </a:solidFill>
-              </a:rPr>
-              <a:t>Pilot/demo için tek ekran deneyimi</a:t>
+                  <a:srgbClr val="C7C2C2"/>
+                </a:solidFill>
+              </a:rPr>
+              <a:t>Ein-Screen-Erlebnis für Pilot und Demo</a:t>
             </a:r>
           </a:p>
         </p:txBody>
@@ -6020,10 +6084,12 @@
             <a:avLst/>
           </a:prstGeom>
           <a:solidFill xmlns:a="http://schemas.openxmlformats.org/drawingml/2006/main">
-            <a:srgbClr val="F97316"/>
-          </a:solidFill>
-          <a:ln xmlns:a="http://schemas.openxmlformats.org/drawingml/2006/main" w="0">
-            <a:noFill/>
+            <a:srgbClr val="FF4D5E"/>
+          </a:solidFill>
+          <a:ln xmlns:a="http://schemas.openxmlformats.org/drawingml/2006/main" w="0">
+            <a:solidFill>
+              <a:srgbClr val="FF4D5E"/>
+            </a:solidFill>
             <a:prstDash val="solid"/>
           </a:ln>
         </p:spPr>
@@ -6064,17 +6130,17 @@
               <a:buNone/>
               <a:defRPr sz="1275">
                 <a:solidFill>
-                  <a:srgbClr val="CBD5E1"/>
+                  <a:srgbClr val="C7C2C2"/>
                 </a:solidFill>
               </a:defRPr>
             </a:pPr>
             <a:r>
               <a:rPr sz="1275">
                 <a:solidFill>
-                  <a:srgbClr val="374151"/>
-                </a:solidFill>
-              </a:rPr>
-              <a:t>Premium control layer ile ürün hissi</a:t>
+                  <a:srgbClr val="C7C2C2"/>
+                </a:solidFill>
+              </a:rPr>
+              <a:t>Produktgefühl durch eine Premium-Control-Layer</a:t>
             </a:r>
           </a:p>
         </p:txBody>
@@ -6101,9 +6167,7 @@
           <a:prstGeom xmlns:a="http://schemas.openxmlformats.org/drawingml/2006/main" prst="rect">
             <a:avLst/>
           </a:prstGeom>
-          <a:solidFill xmlns:a="http://schemas.openxmlformats.org/drawingml/2006/main">
-            <a:srgbClr val="1F2937"/>
-          </a:solidFill>
+          <a:noFill xmlns:a="http://schemas.openxmlformats.org/drawingml/2006/main"/>
           <a:ln xmlns:a="http://schemas.openxmlformats.org/drawingml/2006/main" w="0">
             <a:noFill/>
             <a:prstDash val="solid"/>
@@ -6146,17 +6210,17 @@
               <a:buNone/>
               <a:defRPr sz="1200">
                 <a:solidFill>
-                  <a:srgbClr val="94A3B8"/>
+                  <a:srgbClr val="C7C2C2"/>
                 </a:solidFill>
               </a:defRPr>
             </a:pPr>
             <a:r>
               <a:rPr sz="1200">
                 <a:solidFill>
-                  <a:srgbClr val="64748B"/>
-                </a:solidFill>
-              </a:rPr>
-              <a:t>Kapsam dışı: Camera Stream, Teleoperation / Remote Presence, kayıt-sequence akışları, IK/simülasyon ve XR walking control modes.</a:t>
+                  <a:srgbClr val="C7C2C2"/>
+                </a:solidFill>
+              </a:rPr>
+              <a:t>Ausser Umfang: Camera Stream, Teleoperation / Remote Presence, Recording-Sequenzen, IK/Simulation und XR-Gehmodi.</a:t>
             </a:r>
           </a:p>
         </p:txBody>
@@ -6184,10 +6248,12 @@
             <a:avLst/>
           </a:prstGeom>
           <a:solidFill xmlns:a="http://schemas.openxmlformats.org/drawingml/2006/main">
-            <a:srgbClr val="080B0F"/>
-          </a:solidFill>
-          <a:ln xmlns:a="http://schemas.openxmlformats.org/drawingml/2006/main" w="0">
-            <a:noFill/>
+            <a:srgbClr val="0B0B0D"/>
+          </a:solidFill>
+          <a:ln xmlns:a="http://schemas.openxmlformats.org/drawingml/2006/main" w="0">
+            <a:solidFill>
+              <a:srgbClr val="0B0B0D"/>
+            </a:solidFill>
             <a:prstDash val="solid"/>
           </a:ln>
         </p:spPr>
@@ -6228,17 +6294,17 @@
               <a:buNone/>
               <a:defRPr sz="1125" b="1">
                 <a:solidFill>
-                  <a:srgbClr val="22C55E"/>
+                  <a:srgbClr val="FF4D5E"/>
                 </a:solidFill>
               </a:defRPr>
             </a:pPr>
             <a:r>
               <a:rPr sz="1125" b="1">
                 <a:solidFill>
-                  <a:srgbClr val="22C55E"/>
-                </a:solidFill>
-              </a:rPr>
-              <a:t>FEATURE SCOPE</a:t>
+                  <a:srgbClr val="FF4D5E"/>
+                </a:solidFill>
+              </a:rPr>
+              <a:t>FUNKTIONSUMFANG</a:t>
             </a:r>
           </a:p>
         </p:txBody>
@@ -6279,17 +6345,17 @@
               <a:buNone/>
               <a:defRPr sz="3150" b="1">
                 <a:solidFill>
-                  <a:srgbClr val="FFFFFF"/>
+                  <a:srgbClr val="F8FAFC"/>
                 </a:solidFill>
               </a:defRPr>
             </a:pPr>
             <a:r>
               <a:rPr sz="3150" b="1">
                 <a:solidFill>
-                  <a:srgbClr val="FFFFFF"/>
-                </a:solidFill>
-              </a:rPr>
-              <a:t>Kalan ürün özellikleri</a:t>
+                  <a:srgbClr val="F8FAFC"/>
+                </a:solidFill>
+              </a:rPr>
+              <a:t>Weitere Produktfunktionen</a:t>
             </a:r>
           </a:p>
         </p:txBody>
@@ -6330,17 +6396,17 @@
               <a:buNone/>
               <a:defRPr sz="1650">
                 <a:solidFill>
-                  <a:srgbClr val="CBD5E1"/>
+                  <a:srgbClr val="F8FAFC"/>
                 </a:solidFill>
               </a:defRPr>
             </a:pPr>
             <a:r>
               <a:rPr sz="1650">
                 <a:solidFill>
-                  <a:srgbClr val="CBD5E1"/>
-                </a:solidFill>
-              </a:rPr>
-              <a:t>Camera Stream, Teleoperation ve kayıt akışları hariç.</a:t>
+                  <a:srgbClr val="F8FAFC"/>
+                </a:solidFill>
+              </a:rPr>
+              <a:t>Ohne Camera Stream, Teleoperation und Recording-Flows.</a:t>
             </a:r>
           </a:p>
         </p:txBody>
@@ -6370,11 +6436,11 @@
             </a:avLst>
           </a:prstGeom>
           <a:solidFill xmlns:a="http://schemas.openxmlformats.org/drawingml/2006/main">
-            <a:srgbClr val="111822"/>
+            <a:srgbClr val="171012"/>
           </a:solidFill>
           <a:ln xmlns:a="http://schemas.openxmlformats.org/drawingml/2006/main" w="9525">
             <a:solidFill>
-              <a:srgbClr val="1F2937"/>
+              <a:srgbClr val="5B1720"/>
             </a:solidFill>
             <a:prstDash val="solid"/>
           </a:ln>
@@ -6403,10 +6469,12 @@
             <a:avLst/>
           </a:prstGeom>
           <a:solidFill xmlns:a="http://schemas.openxmlformats.org/drawingml/2006/main">
-            <a:srgbClr val="EF4444"/>
-          </a:solidFill>
-          <a:ln xmlns:a="http://schemas.openxmlformats.org/drawingml/2006/main" w="0">
-            <a:noFill/>
+            <a:srgbClr val="EF233C"/>
+          </a:solidFill>
+          <a:ln xmlns:a="http://schemas.openxmlformats.org/drawingml/2006/main" w="0">
+            <a:solidFill>
+              <a:srgbClr val="EF233C"/>
+            </a:solidFill>
             <a:prstDash val="solid"/>
           </a:ln>
         </p:spPr>
@@ -6447,17 +6515,17 @@
               <a:buNone/>
               <a:defRPr sz="1875" b="1">
                 <a:solidFill>
-                  <a:srgbClr val="FFFFFF"/>
+                  <a:srgbClr val="F8FAFC"/>
                 </a:solidFill>
               </a:defRPr>
             </a:pPr>
             <a:r>
               <a:rPr sz="1875" b="1">
                 <a:solidFill>
-                  <a:srgbClr val="FFFFFF"/>
-                </a:solidFill>
-              </a:rPr>
-              <a:t>Cockpit ve AI</a:t>
+                  <a:srgbClr val="F8FAFC"/>
+                </a:solidFill>
+              </a:rPr>
+              <a:t>Cockpit und KI</a:t>
             </a:r>
           </a:p>
         </p:txBody>
@@ -6485,10 +6553,12 @@
             <a:avLst/>
           </a:prstGeom>
           <a:solidFill xmlns:a="http://schemas.openxmlformats.org/drawingml/2006/main">
-            <a:srgbClr val="EF4444"/>
-          </a:solidFill>
-          <a:ln xmlns:a="http://schemas.openxmlformats.org/drawingml/2006/main" w="0">
-            <a:noFill/>
+            <a:srgbClr val="FF4D5E"/>
+          </a:solidFill>
+          <a:ln xmlns:a="http://schemas.openxmlformats.org/drawingml/2006/main" w="0">
+            <a:solidFill>
+              <a:srgbClr val="FF4D5E"/>
+            </a:solidFill>
             <a:prstDash val="solid"/>
           </a:ln>
         </p:spPr>
@@ -6529,17 +6599,17 @@
               <a:buNone/>
               <a:defRPr sz="1500">
                 <a:solidFill>
-                  <a:srgbClr val="DBE4EF"/>
+                  <a:srgbClr val="C7C2C2"/>
                 </a:solidFill>
               </a:defRPr>
             </a:pPr>
             <a:r>
               <a:rPr sz="1500">
                 <a:solidFill>
-                  <a:srgbClr val="DBE4EF"/>
-                </a:solidFill>
-              </a:rPr>
-              <a:t>AI Chatbot</a:t>
+                  <a:srgbClr val="C7C2C2"/>
+                </a:solidFill>
+              </a:rPr>
+              <a:t>KI-Chatbot</a:t>
             </a:r>
           </a:p>
         </p:txBody>
@@ -6567,10 +6637,12 @@
             <a:avLst/>
           </a:prstGeom>
           <a:solidFill xmlns:a="http://schemas.openxmlformats.org/drawingml/2006/main">
-            <a:srgbClr val="EF4444"/>
-          </a:solidFill>
-          <a:ln xmlns:a="http://schemas.openxmlformats.org/drawingml/2006/main" w="0">
-            <a:noFill/>
+            <a:srgbClr val="FF4D5E"/>
+          </a:solidFill>
+          <a:ln xmlns:a="http://schemas.openxmlformats.org/drawingml/2006/main" w="0">
+            <a:solidFill>
+              <a:srgbClr val="FF4D5E"/>
+            </a:solidFill>
             <a:prstDash val="solid"/>
           </a:ln>
         </p:spPr>
@@ -6611,17 +6683,17 @@
               <a:buNone/>
               <a:defRPr sz="1500">
                 <a:solidFill>
-                  <a:srgbClr val="DBE4EF"/>
+                  <a:srgbClr val="C7C2C2"/>
                 </a:solidFill>
               </a:defRPr>
             </a:pPr>
             <a:r>
               <a:rPr sz="1500">
                 <a:solidFill>
-                  <a:srgbClr val="DBE4EF"/>
-                </a:solidFill>
-              </a:rPr>
-              <a:t>Bilgi Akışı / RAG</a:t>
+                  <a:srgbClr val="C7C2C2"/>
+                </a:solidFill>
+              </a:rPr>
+              <a:t>Informationsfluss / RAG</a:t>
             </a:r>
           </a:p>
         </p:txBody>
@@ -6649,10 +6721,12 @@
             <a:avLst/>
           </a:prstGeom>
           <a:solidFill xmlns:a="http://schemas.openxmlformats.org/drawingml/2006/main">
-            <a:srgbClr val="EF4444"/>
-          </a:solidFill>
-          <a:ln xmlns:a="http://schemas.openxmlformats.org/drawingml/2006/main" w="0">
-            <a:noFill/>
+            <a:srgbClr val="FF4D5E"/>
+          </a:solidFill>
+          <a:ln xmlns:a="http://schemas.openxmlformats.org/drawingml/2006/main" w="0">
+            <a:solidFill>
+              <a:srgbClr val="FF4D5E"/>
+            </a:solidFill>
             <a:prstDash val="solid"/>
           </a:ln>
         </p:spPr>
@@ -6693,17 +6767,17 @@
               <a:buNone/>
               <a:defRPr sz="1500">
                 <a:solidFill>
-                  <a:srgbClr val="DBE4EF"/>
+                  <a:srgbClr val="C7C2C2"/>
                 </a:solidFill>
               </a:defRPr>
             </a:pPr>
             <a:r>
               <a:rPr sz="1500">
                 <a:solidFill>
-                  <a:srgbClr val="DBE4EF"/>
-                </a:solidFill>
-              </a:rPr>
-              <a:t>Tek cockpit deneyimi</a:t>
+                  <a:srgbClr val="C7C2C2"/>
+                </a:solidFill>
+              </a:rPr>
+              <a:t>Ein Cockpit-Erlebnis</a:t>
             </a:r>
           </a:p>
         </p:txBody>
@@ -6733,11 +6807,11 @@
             </a:avLst>
           </a:prstGeom>
           <a:solidFill xmlns:a="http://schemas.openxmlformats.org/drawingml/2006/main">
-            <a:srgbClr val="111822"/>
+            <a:srgbClr val="171012"/>
           </a:solidFill>
           <a:ln xmlns:a="http://schemas.openxmlformats.org/drawingml/2006/main" w="9525">
             <a:solidFill>
-              <a:srgbClr val="1F2937"/>
+              <a:srgbClr val="5B1720"/>
             </a:solidFill>
             <a:prstDash val="solid"/>
           </a:ln>
@@ -6766,10 +6840,12 @@
             <a:avLst/>
           </a:prstGeom>
           <a:solidFill xmlns:a="http://schemas.openxmlformats.org/drawingml/2006/main">
-            <a:srgbClr val="38BDF8"/>
-          </a:solidFill>
-          <a:ln xmlns:a="http://schemas.openxmlformats.org/drawingml/2006/main" w="0">
-            <a:noFill/>
+            <a:srgbClr val="EF233C"/>
+          </a:solidFill>
+          <a:ln xmlns:a="http://schemas.openxmlformats.org/drawingml/2006/main" w="0">
+            <a:solidFill>
+              <a:srgbClr val="EF233C"/>
+            </a:solidFill>
             <a:prstDash val="solid"/>
           </a:ln>
         </p:spPr>
@@ -6810,14 +6886,14 @@
               <a:buNone/>
               <a:defRPr sz="1875" b="1">
                 <a:solidFill>
-                  <a:srgbClr val="FFFFFF"/>
+                  <a:srgbClr val="F8FAFC"/>
                 </a:solidFill>
               </a:defRPr>
             </a:pPr>
             <a:r>
               <a:rPr sz="1875" b="1">
                 <a:solidFill>
-                  <a:srgbClr val="FFFFFF"/>
+                  <a:srgbClr val="F8FAFC"/>
                 </a:solidFill>
               </a:rPr>
               <a:t>Robot Twin</a:t>
@@ -6848,10 +6924,12 @@
             <a:avLst/>
           </a:prstGeom>
           <a:solidFill xmlns:a="http://schemas.openxmlformats.org/drawingml/2006/main">
-            <a:srgbClr val="38BDF8"/>
-          </a:solidFill>
-          <a:ln xmlns:a="http://schemas.openxmlformats.org/drawingml/2006/main" w="0">
-            <a:noFill/>
+            <a:srgbClr val="FF4D5E"/>
+          </a:solidFill>
+          <a:ln xmlns:a="http://schemas.openxmlformats.org/drawingml/2006/main" w="0">
+            <a:solidFill>
+              <a:srgbClr val="FF4D5E"/>
+            </a:solidFill>
             <a:prstDash val="solid"/>
           </a:ln>
         </p:spPr>
@@ -6892,17 +6970,17 @@
               <a:buNone/>
               <a:defRPr sz="1500">
                 <a:solidFill>
-                  <a:srgbClr val="DBE4EF"/>
+                  <a:srgbClr val="C7C2C2"/>
                 </a:solidFill>
               </a:defRPr>
             </a:pPr>
             <a:r>
               <a:rPr sz="1500">
                 <a:solidFill>
-                  <a:srgbClr val="DBE4EF"/>
-                </a:solidFill>
-              </a:rPr>
-              <a:t>Dijital robot görünümü</a:t>
+                  <a:srgbClr val="C7C2C2"/>
+                </a:solidFill>
+              </a:rPr>
+              <a:t>Digitale Roboteransicht</a:t>
             </a:r>
           </a:p>
         </p:txBody>
@@ -6930,10 +7008,12 @@
             <a:avLst/>
           </a:prstGeom>
           <a:solidFill xmlns:a="http://schemas.openxmlformats.org/drawingml/2006/main">
-            <a:srgbClr val="38BDF8"/>
-          </a:solidFill>
-          <a:ln xmlns:a="http://schemas.openxmlformats.org/drawingml/2006/main" w="0">
-            <a:noFill/>
+            <a:srgbClr val="FF4D5E"/>
+          </a:solidFill>
+          <a:ln xmlns:a="http://schemas.openxmlformats.org/drawingml/2006/main" w="0">
+            <a:solidFill>
+              <a:srgbClr val="FF4D5E"/>
+            </a:solidFill>
             <a:prstDash val="solid"/>
           </a:ln>
         </p:spPr>
@@ -6974,17 +7054,17 @@
               <a:buNone/>
               <a:defRPr sz="1500">
                 <a:solidFill>
-                  <a:srgbClr val="DBE4EF"/>
+                  <a:srgbClr val="C7C2C2"/>
                 </a:solidFill>
               </a:defRPr>
             </a:pPr>
             <a:r>
               <a:rPr sz="1500">
                 <a:solidFill>
-                  <a:srgbClr val="DBE4EF"/>
-                </a:solidFill>
-              </a:rPr>
-              <a:t>Sahne farkındalığı</a:t>
+                  <a:srgbClr val="C7C2C2"/>
+                </a:solidFill>
+              </a:rPr>
+              <a:t>Situationsbewusstsein</a:t>
             </a:r>
           </a:p>
         </p:txBody>
@@ -7012,10 +7092,12 @@
             <a:avLst/>
           </a:prstGeom>
           <a:solidFill xmlns:a="http://schemas.openxmlformats.org/drawingml/2006/main">
-            <a:srgbClr val="38BDF8"/>
-          </a:solidFill>
-          <a:ln xmlns:a="http://schemas.openxmlformats.org/drawingml/2006/main" w="0">
-            <a:noFill/>
+            <a:srgbClr val="FF4D5E"/>
+          </a:solidFill>
+          <a:ln xmlns:a="http://schemas.openxmlformats.org/drawingml/2006/main" w="0">
+            <a:solidFill>
+              <a:srgbClr val="FF4D5E"/>
+            </a:solidFill>
             <a:prstDash val="solid"/>
           </a:ln>
         </p:spPr>
@@ -7056,17 +7138,17 @@
               <a:buNone/>
               <a:defRPr sz="1500">
                 <a:solidFill>
-                  <a:srgbClr val="DBE4EF"/>
+                  <a:srgbClr val="C7C2C2"/>
                 </a:solidFill>
               </a:defRPr>
             </a:pPr>
             <a:r>
               <a:rPr sz="1500">
                 <a:solidFill>
-                  <a:srgbClr val="DBE4EF"/>
-                </a:solidFill>
-              </a:rPr>
-              <a:t>Robot bağlamını toplama</a:t>
+                  <a:srgbClr val="C7C2C2"/>
+                </a:solidFill>
+              </a:rPr>
+              <a:t>Roboterkontext bündeln</a:t>
             </a:r>
           </a:p>
         </p:txBody>
@@ -7096,11 +7178,11 @@
             </a:avLst>
           </a:prstGeom>
           <a:solidFill xmlns:a="http://schemas.openxmlformats.org/drawingml/2006/main">
-            <a:srgbClr val="111822"/>
+            <a:srgbClr val="171012"/>
           </a:solidFill>
           <a:ln xmlns:a="http://schemas.openxmlformats.org/drawingml/2006/main" w="9525">
             <a:solidFill>
-              <a:srgbClr val="1F2937"/>
+              <a:srgbClr val="5B1720"/>
             </a:solidFill>
             <a:prstDash val="solid"/>
           </a:ln>
@@ -7129,10 +7211,12 @@
             <a:avLst/>
           </a:prstGeom>
           <a:solidFill xmlns:a="http://schemas.openxmlformats.org/drawingml/2006/main">
-            <a:srgbClr val="22C55E"/>
-          </a:solidFill>
-          <a:ln xmlns:a="http://schemas.openxmlformats.org/drawingml/2006/main" w="0">
-            <a:noFill/>
+            <a:srgbClr val="EF233C"/>
+          </a:solidFill>
+          <a:ln xmlns:a="http://schemas.openxmlformats.org/drawingml/2006/main" w="0">
+            <a:solidFill>
+              <a:srgbClr val="EF233C"/>
+            </a:solidFill>
             <a:prstDash val="solid"/>
           </a:ln>
         </p:spPr>
@@ -7173,14 +7257,14 @@
               <a:buNone/>
               <a:defRPr sz="1875" b="1">
                 <a:solidFill>
-                  <a:srgbClr val="FFFFFF"/>
+                  <a:srgbClr val="F8FAFC"/>
                 </a:solidFill>
               </a:defRPr>
             </a:pPr>
             <a:r>
               <a:rPr sz="1875" b="1">
                 <a:solidFill>
-                  <a:srgbClr val="FFFFFF"/>
+                  <a:srgbClr val="F8FAFC"/>
                 </a:solidFill>
               </a:rPr>
               <a:t>Live Dashboard</a:t>
@@ -7211,10 +7295,12 @@
             <a:avLst/>
           </a:prstGeom>
           <a:solidFill xmlns:a="http://schemas.openxmlformats.org/drawingml/2006/main">
-            <a:srgbClr val="22C55E"/>
-          </a:solidFill>
-          <a:ln xmlns:a="http://schemas.openxmlformats.org/drawingml/2006/main" w="0">
-            <a:noFill/>
+            <a:srgbClr val="FF4D5E"/>
+          </a:solidFill>
+          <a:ln xmlns:a="http://schemas.openxmlformats.org/drawingml/2006/main" w="0">
+            <a:solidFill>
+              <a:srgbClr val="FF4D5E"/>
+            </a:solidFill>
             <a:prstDash val="solid"/>
           </a:ln>
         </p:spPr>
@@ -7255,17 +7341,17 @@
               <a:buNone/>
               <a:defRPr sz="1500">
                 <a:solidFill>
-                  <a:srgbClr val="DBE4EF"/>
+                  <a:srgbClr val="C7C2C2"/>
                 </a:solidFill>
               </a:defRPr>
             </a:pPr>
             <a:r>
               <a:rPr sz="1500">
                 <a:solidFill>
-                  <a:srgbClr val="DBE4EF"/>
-                </a:solidFill>
-              </a:rPr>
-              <a:t>Anlık robot durumu</a:t>
+                  <a:srgbClr val="C7C2C2"/>
+                </a:solidFill>
+              </a:rPr>
+              <a:t>Live-Roboterzustand</a:t>
             </a:r>
           </a:p>
         </p:txBody>
@@ -7293,10 +7379,12 @@
             <a:avLst/>
           </a:prstGeom>
           <a:solidFill xmlns:a="http://schemas.openxmlformats.org/drawingml/2006/main">
-            <a:srgbClr val="22C55E"/>
-          </a:solidFill>
-          <a:ln xmlns:a="http://schemas.openxmlformats.org/drawingml/2006/main" w="0">
-            <a:noFill/>
+            <a:srgbClr val="FF4D5E"/>
+          </a:solidFill>
+          <a:ln xmlns:a="http://schemas.openxmlformats.org/drawingml/2006/main" w="0">
+            <a:solidFill>
+              <a:srgbClr val="FF4D5E"/>
+            </a:solidFill>
             <a:prstDash val="solid"/>
           </a:ln>
         </p:spPr>
@@ -7337,17 +7425,17 @@
               <a:buNone/>
               <a:defRPr sz="1500">
                 <a:solidFill>
-                  <a:srgbClr val="DBE4EF"/>
+                  <a:srgbClr val="C7C2C2"/>
                 </a:solidFill>
               </a:defRPr>
             </a:pPr>
             <a:r>
               <a:rPr sz="1500">
                 <a:solidFill>
-                  <a:srgbClr val="DBE4EF"/>
-                </a:solidFill>
-              </a:rPr>
-              <a:t>Sistem sağlığı</a:t>
+                  <a:srgbClr val="C7C2C2"/>
+                </a:solidFill>
+              </a:rPr>
+              <a:t>Systemgesundheit</a:t>
             </a:r>
           </a:p>
         </p:txBody>
@@ -7375,10 +7463,12 @@
             <a:avLst/>
           </a:prstGeom>
           <a:solidFill xmlns:a="http://schemas.openxmlformats.org/drawingml/2006/main">
-            <a:srgbClr val="22C55E"/>
-          </a:solidFill>
-          <a:ln xmlns:a="http://schemas.openxmlformats.org/drawingml/2006/main" w="0">
-            <a:noFill/>
+            <a:srgbClr val="FF4D5E"/>
+          </a:solidFill>
+          <a:ln xmlns:a="http://schemas.openxmlformats.org/drawingml/2006/main" w="0">
+            <a:solidFill>
+              <a:srgbClr val="FF4D5E"/>
+            </a:solidFill>
             <a:prstDash val="solid"/>
           </a:ln>
         </p:spPr>
@@ -7419,17 +7509,17 @@
               <a:buNone/>
               <a:defRPr sz="1500">
                 <a:solidFill>
-                  <a:srgbClr val="DBE4EF"/>
+                  <a:srgbClr val="C7C2C2"/>
                 </a:solidFill>
               </a:defRPr>
             </a:pPr>
             <a:r>
               <a:rPr sz="1500">
                 <a:solidFill>
-                  <a:srgbClr val="DBE4EF"/>
-                </a:solidFill>
-              </a:rPr>
-              <a:t>Log ve hata görünürlüğü</a:t>
+                  <a:srgbClr val="C7C2C2"/>
+                </a:solidFill>
+              </a:rPr>
+              <a:t>Log- und Fehlersichtbarkeit</a:t>
             </a:r>
           </a:p>
         </p:txBody>
@@ -7459,11 +7549,11 @@
             </a:avLst>
           </a:prstGeom>
           <a:solidFill xmlns:a="http://schemas.openxmlformats.org/drawingml/2006/main">
-            <a:srgbClr val="111822"/>
+            <a:srgbClr val="171012"/>
           </a:solidFill>
           <a:ln xmlns:a="http://schemas.openxmlformats.org/drawingml/2006/main" w="9525">
             <a:solidFill>
-              <a:srgbClr val="1F2937"/>
+              <a:srgbClr val="5B1720"/>
             </a:solidFill>
             <a:prstDash val="solid"/>
           </a:ln>
@@ -7492,10 +7582,12 @@
             <a:avLst/>
           </a:prstGeom>
           <a:solidFill xmlns:a="http://schemas.openxmlformats.org/drawingml/2006/main">
-            <a:srgbClr val="F97316"/>
-          </a:solidFill>
-          <a:ln xmlns:a="http://schemas.openxmlformats.org/drawingml/2006/main" w="0">
-            <a:noFill/>
+            <a:srgbClr val="EF233C"/>
+          </a:solidFill>
+          <a:ln xmlns:a="http://schemas.openxmlformats.org/drawingml/2006/main" w="0">
+            <a:solidFill>
+              <a:srgbClr val="EF233C"/>
+            </a:solidFill>
             <a:prstDash val="solid"/>
           </a:ln>
         </p:spPr>
@@ -7536,17 +7628,17 @@
               <a:buNone/>
               <a:defRPr sz="1875" b="1">
                 <a:solidFill>
-                  <a:srgbClr val="FFFFFF"/>
+                  <a:srgbClr val="F8FAFC"/>
                 </a:solidFill>
               </a:defRPr>
             </a:pPr>
             <a:r>
               <a:rPr sz="1875" b="1">
                 <a:solidFill>
-                  <a:srgbClr val="FFFFFF"/>
-                </a:solidFill>
-              </a:rPr>
-              <a:t>Entegrasyon ve Demo</a:t>
+                  <a:srgbClr val="F8FAFC"/>
+                </a:solidFill>
+              </a:rPr>
+              <a:t>Integration und Demo</a:t>
             </a:r>
           </a:p>
         </p:txBody>
@@ -7574,10 +7666,12 @@
             <a:avLst/>
           </a:prstGeom>
           <a:solidFill xmlns:a="http://schemas.openxmlformats.org/drawingml/2006/main">
-            <a:srgbClr val="F97316"/>
-          </a:solidFill>
-          <a:ln xmlns:a="http://schemas.openxmlformats.org/drawingml/2006/main" w="0">
-            <a:noFill/>
+            <a:srgbClr val="FF4D5E"/>
+          </a:solidFill>
+          <a:ln xmlns:a="http://schemas.openxmlformats.org/drawingml/2006/main" w="0">
+            <a:solidFill>
+              <a:srgbClr val="FF4D5E"/>
+            </a:solidFill>
             <a:prstDash val="solid"/>
           </a:ln>
         </p:spPr>
@@ -7618,7 +7712,7 @@
               <a:buNone/>
               <a:defRPr sz="1500">
                 <a:solidFill>
-                  <a:srgbClr val="DBE4EF"/>
+                  <a:srgbClr val="C7C2C2"/>
                 </a:solidFill>
               </a:defRPr>
             </a:pPr>
@@ -7656,10 +7750,12 @@
             <a:avLst/>
           </a:prstGeom>
           <a:solidFill xmlns:a="http://schemas.openxmlformats.org/drawingml/2006/main">
-            <a:srgbClr val="F97316"/>
-          </a:solidFill>
-          <a:ln xmlns:a="http://schemas.openxmlformats.org/drawingml/2006/main" w="0">
-            <a:noFill/>
+            <a:srgbClr val="FF4D5E"/>
+          </a:solidFill>
+          <a:ln xmlns:a="http://schemas.openxmlformats.org/drawingml/2006/main" w="0">
+            <a:solidFill>
+              <a:srgbClr val="FF4D5E"/>
+            </a:solidFill>
             <a:prstDash val="solid"/>
           </a:ln>
         </p:spPr>
@@ -7700,17 +7796,17 @@
               <a:buNone/>
               <a:defRPr sz="1500">
                 <a:solidFill>
-                  <a:srgbClr val="DBE4EF"/>
+                  <a:srgbClr val="C7C2C2"/>
                 </a:solidFill>
               </a:defRPr>
             </a:pPr>
             <a:r>
               <a:rPr sz="1500">
                 <a:solidFill>
-                  <a:srgbClr val="DBE4EF"/>
-                </a:solidFill>
-              </a:rPr>
-              <a:t>Modüler kontrol katmanları</a:t>
+                  <a:srgbClr val="C7C2C2"/>
+                </a:solidFill>
+              </a:rPr>
+              <a:t>Modulare Steuerungsschichten</a:t>
             </a:r>
           </a:p>
         </p:txBody>
@@ -7738,10 +7834,12 @@
             <a:avLst/>
           </a:prstGeom>
           <a:solidFill xmlns:a="http://schemas.openxmlformats.org/drawingml/2006/main">
-            <a:srgbClr val="F97316"/>
-          </a:solidFill>
-          <a:ln xmlns:a="http://schemas.openxmlformats.org/drawingml/2006/main" w="0">
-            <a:noFill/>
+            <a:srgbClr val="FF4D5E"/>
+          </a:solidFill>
+          <a:ln xmlns:a="http://schemas.openxmlformats.org/drawingml/2006/main" w="0">
+            <a:solidFill>
+              <a:srgbClr val="FF4D5E"/>
+            </a:solidFill>
             <a:prstDash val="solid"/>
           </a:ln>
         </p:spPr>
@@ -7782,17 +7880,17 @@
               <a:buNone/>
               <a:defRPr sz="1500">
                 <a:solidFill>
-                  <a:srgbClr val="DBE4EF"/>
+                  <a:srgbClr val="C7C2C2"/>
                 </a:solidFill>
               </a:defRPr>
             </a:pPr>
             <a:r>
               <a:rPr sz="1500">
                 <a:solidFill>
-                  <a:srgbClr val="DBE4EF"/>
-                </a:solidFill>
-              </a:rPr>
-              <a:t>Demo-ready ürün hissi</a:t>
+                  <a:srgbClr val="C7C2C2"/>
+                </a:solidFill>
+              </a:rPr>
+              <a:t>Demo-reifes Produktgefühl</a:t>
             </a:r>
           </a:p>
         </p:txBody>
@@ -7820,10 +7918,12 @@
             <a:avLst/>
           </a:prstGeom>
           <a:solidFill xmlns:a="http://schemas.openxmlformats.org/drawingml/2006/main">
-            <a:srgbClr val="080B0F"/>
-          </a:solidFill>
-          <a:ln xmlns:a="http://schemas.openxmlformats.org/drawingml/2006/main" w="0">
-            <a:noFill/>
+            <a:srgbClr val="0B0B0D"/>
+          </a:solidFill>
+          <a:ln xmlns:a="http://schemas.openxmlformats.org/drawingml/2006/main" w="0">
+            <a:solidFill>
+              <a:srgbClr val="0B0B0D"/>
+            </a:solidFill>
             <a:prstDash val="solid"/>
           </a:ln>
         </p:spPr>
@@ -7864,17 +7964,17 @@
               <a:buNone/>
               <a:defRPr sz="1125" b="1">
                 <a:solidFill>
-                  <a:srgbClr val="22C55E"/>
+                  <a:srgbClr val="FF4D5E"/>
                 </a:solidFill>
               </a:defRPr>
             </a:pPr>
             <a:r>
               <a:rPr sz="1125" b="1">
                 <a:solidFill>
-                  <a:srgbClr val="22C55E"/>
-                </a:solidFill>
-              </a:rPr>
-              <a:t>FEATURE SCOPE</a:t>
+                  <a:srgbClr val="FF4D5E"/>
+                </a:solidFill>
+              </a:rPr>
+              <a:t>FUNKTIONSUMFANG</a:t>
             </a:r>
           </a:p>
         </p:txBody>
@@ -7915,17 +8015,17 @@
               <a:buNone/>
               <a:defRPr sz="3150" b="1">
                 <a:solidFill>
-                  <a:srgbClr val="FFFFFF"/>
+                  <a:srgbClr val="F8FAFC"/>
                 </a:solidFill>
               </a:defRPr>
             </a:pPr>
             <a:r>
               <a:rPr sz="3150" b="1">
                 <a:solidFill>
-                  <a:srgbClr val="FFFFFF"/>
-                </a:solidFill>
-              </a:rPr>
-              <a:t>Kalan ürün özellikleri</a:t>
+                  <a:srgbClr val="F8FAFC"/>
+                </a:solidFill>
+              </a:rPr>
+              <a:t>Weitere Produktfunktionen</a:t>
             </a:r>
           </a:p>
         </p:txBody>
@@ -7966,17 +8066,17 @@
               <a:buNone/>
               <a:defRPr sz="1650">
                 <a:solidFill>
-                  <a:srgbClr val="CBD5E1"/>
+                  <a:srgbClr val="F8FAFC"/>
                 </a:solidFill>
               </a:defRPr>
             </a:pPr>
             <a:r>
               <a:rPr sz="1650">
                 <a:solidFill>
-                  <a:srgbClr val="CBD5E1"/>
-                </a:solidFill>
-              </a:rPr>
-              <a:t>Camera Stream, Teleoperation ve kayıt akışları hariç.</a:t>
+                  <a:srgbClr val="F8FAFC"/>
+                </a:solidFill>
+              </a:rPr>
+              <a:t>Ohne Camera Stream, Teleoperation und Recording-Flows.</a:t>
             </a:r>
           </a:p>
         </p:txBody>
@@ -8006,11 +8106,11 @@
             </a:avLst>
           </a:prstGeom>
           <a:solidFill xmlns:a="http://schemas.openxmlformats.org/drawingml/2006/main">
-            <a:srgbClr val="111822"/>
+            <a:srgbClr val="171012"/>
           </a:solidFill>
           <a:ln xmlns:a="http://schemas.openxmlformats.org/drawingml/2006/main" w="9525">
             <a:solidFill>
-              <a:srgbClr val="1F2937"/>
+              <a:srgbClr val="5B1720"/>
             </a:solidFill>
             <a:prstDash val="solid"/>
           </a:ln>
@@ -8039,10 +8139,12 @@
             <a:avLst/>
           </a:prstGeom>
           <a:solidFill xmlns:a="http://schemas.openxmlformats.org/drawingml/2006/main">
-            <a:srgbClr val="EF4444"/>
-          </a:solidFill>
-          <a:ln xmlns:a="http://schemas.openxmlformats.org/drawingml/2006/main" w="0">
-            <a:noFill/>
+            <a:srgbClr val="EF233C"/>
+          </a:solidFill>
+          <a:ln xmlns:a="http://schemas.openxmlformats.org/drawingml/2006/main" w="0">
+            <a:solidFill>
+              <a:srgbClr val="EF233C"/>
+            </a:solidFill>
             <a:prstDash val="solid"/>
           </a:ln>
         </p:spPr>
@@ -8083,17 +8185,17 @@
               <a:buNone/>
               <a:defRPr sz="1875" b="1">
                 <a:solidFill>
-                  <a:srgbClr val="FFFFFF"/>
+                  <a:srgbClr val="F8FAFC"/>
                 </a:solidFill>
               </a:defRPr>
             </a:pPr>
             <a:r>
               <a:rPr sz="1875" b="1">
                 <a:solidFill>
-                  <a:srgbClr val="FFFFFF"/>
-                </a:solidFill>
-              </a:rPr>
-              <a:t>Cockpit ve AI</a:t>
+                  <a:srgbClr val="F8FAFC"/>
+                </a:solidFill>
+              </a:rPr>
+              <a:t>Cockpit und KI</a:t>
             </a:r>
           </a:p>
         </p:txBody>
@@ -8121,10 +8223,12 @@
             <a:avLst/>
           </a:prstGeom>
           <a:solidFill xmlns:a="http://schemas.openxmlformats.org/drawingml/2006/main">
-            <a:srgbClr val="EF4444"/>
-          </a:solidFill>
-          <a:ln xmlns:a="http://schemas.openxmlformats.org/drawingml/2006/main" w="0">
-            <a:noFill/>
+            <a:srgbClr val="FF4D5E"/>
+          </a:solidFill>
+          <a:ln xmlns:a="http://schemas.openxmlformats.org/drawingml/2006/main" w="0">
+            <a:solidFill>
+              <a:srgbClr val="FF4D5E"/>
+            </a:solidFill>
             <a:prstDash val="solid"/>
           </a:ln>
         </p:spPr>
@@ -8165,17 +8269,17 @@
               <a:buNone/>
               <a:defRPr sz="1500">
                 <a:solidFill>
-                  <a:srgbClr val="DBE4EF"/>
+                  <a:srgbClr val="C7C2C2"/>
                 </a:solidFill>
               </a:defRPr>
             </a:pPr>
             <a:r>
               <a:rPr sz="1500">
                 <a:solidFill>
-                  <a:srgbClr val="DBE4EF"/>
-                </a:solidFill>
-              </a:rPr>
-              <a:t>AI Chatbot</a:t>
+                  <a:srgbClr val="C7C2C2"/>
+                </a:solidFill>
+              </a:rPr>
+              <a:t>KI-Chatbot</a:t>
             </a:r>
           </a:p>
         </p:txBody>
@@ -8203,10 +8307,12 @@
             <a:avLst/>
           </a:prstGeom>
           <a:solidFill xmlns:a="http://schemas.openxmlformats.org/drawingml/2006/main">
-            <a:srgbClr val="EF4444"/>
-          </a:solidFill>
-          <a:ln xmlns:a="http://schemas.openxmlformats.org/drawingml/2006/main" w="0">
-            <a:noFill/>
+            <a:srgbClr val="FF4D5E"/>
+          </a:solidFill>
+          <a:ln xmlns:a="http://schemas.openxmlformats.org/drawingml/2006/main" w="0">
+            <a:solidFill>
+              <a:srgbClr val="FF4D5E"/>
+            </a:solidFill>
             <a:prstDash val="solid"/>
           </a:ln>
         </p:spPr>
@@ -8247,17 +8353,17 @@
               <a:buNone/>
               <a:defRPr sz="1500">
                 <a:solidFill>
-                  <a:srgbClr val="DBE4EF"/>
+                  <a:srgbClr val="C7C2C2"/>
                 </a:solidFill>
               </a:defRPr>
             </a:pPr>
             <a:r>
               <a:rPr sz="1500">
                 <a:solidFill>
-                  <a:srgbClr val="DBE4EF"/>
-                </a:solidFill>
-              </a:rPr>
-              <a:t>Bilgi Akışı / RAG</a:t>
+                  <a:srgbClr val="C7C2C2"/>
+                </a:solidFill>
+              </a:rPr>
+              <a:t>Informationsfluss / RAG</a:t>
             </a:r>
           </a:p>
         </p:txBody>
@@ -8285,10 +8391,12 @@
             <a:avLst/>
           </a:prstGeom>
           <a:solidFill xmlns:a="http://schemas.openxmlformats.org/drawingml/2006/main">
-            <a:srgbClr val="EF4444"/>
-          </a:solidFill>
-          <a:ln xmlns:a="http://schemas.openxmlformats.org/drawingml/2006/main" w="0">
-            <a:noFill/>
+            <a:srgbClr val="FF4D5E"/>
+          </a:solidFill>
+          <a:ln xmlns:a="http://schemas.openxmlformats.org/drawingml/2006/main" w="0">
+            <a:solidFill>
+              <a:srgbClr val="FF4D5E"/>
+            </a:solidFill>
             <a:prstDash val="solid"/>
           </a:ln>
         </p:spPr>
@@ -8329,17 +8437,17 @@
               <a:buNone/>
               <a:defRPr sz="1500">
                 <a:solidFill>
-                  <a:srgbClr val="DBE4EF"/>
+                  <a:srgbClr val="C7C2C2"/>
                 </a:solidFill>
               </a:defRPr>
             </a:pPr>
             <a:r>
               <a:rPr sz="1500">
                 <a:solidFill>
-                  <a:srgbClr val="DBE4EF"/>
-                </a:solidFill>
-              </a:rPr>
-              <a:t>Tek cockpit deneyimi</a:t>
+                  <a:srgbClr val="C7C2C2"/>
+                </a:solidFill>
+              </a:rPr>
+              <a:t>Ein Cockpit-Erlebnis</a:t>
             </a:r>
           </a:p>
         </p:txBody>
@@ -8369,11 +8477,11 @@
             </a:avLst>
           </a:prstGeom>
           <a:solidFill xmlns:a="http://schemas.openxmlformats.org/drawingml/2006/main">
-            <a:srgbClr val="111822"/>
+            <a:srgbClr val="171012"/>
           </a:solidFill>
           <a:ln xmlns:a="http://schemas.openxmlformats.org/drawingml/2006/main" w="9525">
             <a:solidFill>
-              <a:srgbClr val="1F2937"/>
+              <a:srgbClr val="5B1720"/>
             </a:solidFill>
             <a:prstDash val="solid"/>
           </a:ln>
@@ -8402,10 +8510,12 @@
             <a:avLst/>
           </a:prstGeom>
           <a:solidFill xmlns:a="http://schemas.openxmlformats.org/drawingml/2006/main">
-            <a:srgbClr val="38BDF8"/>
-          </a:solidFill>
-          <a:ln xmlns:a="http://schemas.openxmlformats.org/drawingml/2006/main" w="0">
-            <a:noFill/>
+            <a:srgbClr val="EF233C"/>
+          </a:solidFill>
+          <a:ln xmlns:a="http://schemas.openxmlformats.org/drawingml/2006/main" w="0">
+            <a:solidFill>
+              <a:srgbClr val="EF233C"/>
+            </a:solidFill>
             <a:prstDash val="solid"/>
           </a:ln>
         </p:spPr>
@@ -8446,14 +8556,14 @@
               <a:buNone/>
               <a:defRPr sz="1875" b="1">
                 <a:solidFill>
-                  <a:srgbClr val="FFFFFF"/>
+                  <a:srgbClr val="F8FAFC"/>
                 </a:solidFill>
               </a:defRPr>
             </a:pPr>
             <a:r>
               <a:rPr sz="1875" b="1">
                 <a:solidFill>
-                  <a:srgbClr val="FFFFFF"/>
+                  <a:srgbClr val="F8FAFC"/>
                 </a:solidFill>
               </a:rPr>
               <a:t>Robot Twin</a:t>
@@ -8484,10 +8594,12 @@
             <a:avLst/>
           </a:prstGeom>
           <a:solidFill xmlns:a="http://schemas.openxmlformats.org/drawingml/2006/main">
-            <a:srgbClr val="38BDF8"/>
-          </a:solidFill>
-          <a:ln xmlns:a="http://schemas.openxmlformats.org/drawingml/2006/main" w="0">
-            <a:noFill/>
+            <a:srgbClr val="FF4D5E"/>
+          </a:solidFill>
+          <a:ln xmlns:a="http://schemas.openxmlformats.org/drawingml/2006/main" w="0">
+            <a:solidFill>
+              <a:srgbClr val="FF4D5E"/>
+            </a:solidFill>
             <a:prstDash val="solid"/>
           </a:ln>
         </p:spPr>
@@ -8528,17 +8640,17 @@
               <a:buNone/>
               <a:defRPr sz="1500">
                 <a:solidFill>
-                  <a:srgbClr val="DBE4EF"/>
+                  <a:srgbClr val="C7C2C2"/>
                 </a:solidFill>
               </a:defRPr>
             </a:pPr>
             <a:r>
               <a:rPr sz="1500">
                 <a:solidFill>
-                  <a:srgbClr val="DBE4EF"/>
-                </a:solidFill>
-              </a:rPr>
-              <a:t>Dijital robot görünümü</a:t>
+                  <a:srgbClr val="C7C2C2"/>
+                </a:solidFill>
+              </a:rPr>
+              <a:t>Digitale Roboteransicht</a:t>
             </a:r>
           </a:p>
         </p:txBody>
@@ -8566,10 +8678,12 @@
             <a:avLst/>
           </a:prstGeom>
           <a:solidFill xmlns:a="http://schemas.openxmlformats.org/drawingml/2006/main">
-            <a:srgbClr val="38BDF8"/>
-          </a:solidFill>
-          <a:ln xmlns:a="http://schemas.openxmlformats.org/drawingml/2006/main" w="0">
-            <a:noFill/>
+            <a:srgbClr val="FF4D5E"/>
+          </a:solidFill>
+          <a:ln xmlns:a="http://schemas.openxmlformats.org/drawingml/2006/main" w="0">
+            <a:solidFill>
+              <a:srgbClr val="FF4D5E"/>
+            </a:solidFill>
             <a:prstDash val="solid"/>
           </a:ln>
         </p:spPr>
@@ -8610,17 +8724,17 @@
               <a:buNone/>
               <a:defRPr sz="1500">
                 <a:solidFill>
-                  <a:srgbClr val="DBE4EF"/>
+                  <a:srgbClr val="C7C2C2"/>
                 </a:solidFill>
               </a:defRPr>
             </a:pPr>
             <a:r>
               <a:rPr sz="1500">
                 <a:solidFill>
-                  <a:srgbClr val="DBE4EF"/>
-                </a:solidFill>
-              </a:rPr>
-              <a:t>Sahne farkındalığı</a:t>
+                  <a:srgbClr val="C7C2C2"/>
+                </a:solidFill>
+              </a:rPr>
+              <a:t>Situationsbewusstsein</a:t>
             </a:r>
           </a:p>
         </p:txBody>
@@ -8648,10 +8762,12 @@
             <a:avLst/>
           </a:prstGeom>
           <a:solidFill xmlns:a="http://schemas.openxmlformats.org/drawingml/2006/main">
-            <a:srgbClr val="38BDF8"/>
-          </a:solidFill>
-          <a:ln xmlns:a="http://schemas.openxmlformats.org/drawingml/2006/main" w="0">
-            <a:noFill/>
+            <a:srgbClr val="FF4D5E"/>
+          </a:solidFill>
+          <a:ln xmlns:a="http://schemas.openxmlformats.org/drawingml/2006/main" w="0">
+            <a:solidFill>
+              <a:srgbClr val="FF4D5E"/>
+            </a:solidFill>
             <a:prstDash val="solid"/>
           </a:ln>
         </p:spPr>
@@ -8692,17 +8808,17 @@
               <a:buNone/>
               <a:defRPr sz="1500">
                 <a:solidFill>
-                  <a:srgbClr val="DBE4EF"/>
+                  <a:srgbClr val="C7C2C2"/>
                 </a:solidFill>
               </a:defRPr>
             </a:pPr>
             <a:r>
               <a:rPr sz="1500">
                 <a:solidFill>
-                  <a:srgbClr val="DBE4EF"/>
-                </a:solidFill>
-              </a:rPr>
-              <a:t>Robot bağlamını toplama</a:t>
+                  <a:srgbClr val="C7C2C2"/>
+                </a:solidFill>
+              </a:rPr>
+              <a:t>Roboterkontext bündeln</a:t>
             </a:r>
           </a:p>
         </p:txBody>
@@ -8732,11 +8848,11 @@
             </a:avLst>
           </a:prstGeom>
           <a:solidFill xmlns:a="http://schemas.openxmlformats.org/drawingml/2006/main">
-            <a:srgbClr val="111822"/>
+            <a:srgbClr val="171012"/>
           </a:solidFill>
           <a:ln xmlns:a="http://schemas.openxmlformats.org/drawingml/2006/main" w="9525">
             <a:solidFill>
-              <a:srgbClr val="1F2937"/>
+              <a:srgbClr val="5B1720"/>
             </a:solidFill>
             <a:prstDash val="solid"/>
           </a:ln>
@@ -8765,10 +8881,12 @@
             <a:avLst/>
           </a:prstGeom>
           <a:solidFill xmlns:a="http://schemas.openxmlformats.org/drawingml/2006/main">
-            <a:srgbClr val="22C55E"/>
-          </a:solidFill>
-          <a:ln xmlns:a="http://schemas.openxmlformats.org/drawingml/2006/main" w="0">
-            <a:noFill/>
+            <a:srgbClr val="EF233C"/>
+          </a:solidFill>
+          <a:ln xmlns:a="http://schemas.openxmlformats.org/drawingml/2006/main" w="0">
+            <a:solidFill>
+              <a:srgbClr val="EF233C"/>
+            </a:solidFill>
             <a:prstDash val="solid"/>
           </a:ln>
         </p:spPr>
@@ -8809,14 +8927,14 @@
               <a:buNone/>
               <a:defRPr sz="1875" b="1">
                 <a:solidFill>
-                  <a:srgbClr val="FFFFFF"/>
+                  <a:srgbClr val="F8FAFC"/>
                 </a:solidFill>
               </a:defRPr>
             </a:pPr>
             <a:r>
               <a:rPr sz="1875" b="1">
                 <a:solidFill>
-                  <a:srgbClr val="FFFFFF"/>
+                  <a:srgbClr val="F8FAFC"/>
                 </a:solidFill>
               </a:rPr>
               <a:t>Live Dashboard</a:t>
@@ -8847,10 +8965,12 @@
             <a:avLst/>
           </a:prstGeom>
           <a:solidFill xmlns:a="http://schemas.openxmlformats.org/drawingml/2006/main">
-            <a:srgbClr val="22C55E"/>
-          </a:solidFill>
-          <a:ln xmlns:a="http://schemas.openxmlformats.org/drawingml/2006/main" w="0">
-            <a:noFill/>
+            <a:srgbClr val="FF4D5E"/>
+          </a:solidFill>
+          <a:ln xmlns:a="http://schemas.openxmlformats.org/drawingml/2006/main" w="0">
+            <a:solidFill>
+              <a:srgbClr val="FF4D5E"/>
+            </a:solidFill>
             <a:prstDash val="solid"/>
           </a:ln>
         </p:spPr>
@@ -8891,17 +9011,17 @@
               <a:buNone/>
               <a:defRPr sz="1500">
                 <a:solidFill>
-                  <a:srgbClr val="DBE4EF"/>
+                  <a:srgbClr val="C7C2C2"/>
                 </a:solidFill>
               </a:defRPr>
             </a:pPr>
             <a:r>
               <a:rPr sz="1500">
                 <a:solidFill>
-                  <a:srgbClr val="DBE4EF"/>
-                </a:solidFill>
-              </a:rPr>
-              <a:t>Anlık robot durumu</a:t>
+                  <a:srgbClr val="C7C2C2"/>
+                </a:solidFill>
+              </a:rPr>
+              <a:t>Live-Roboterzustand</a:t>
             </a:r>
           </a:p>
         </p:txBody>
@@ -8929,10 +9049,12 @@
             <a:avLst/>
           </a:prstGeom>
           <a:solidFill xmlns:a="http://schemas.openxmlformats.org/drawingml/2006/main">
-            <a:srgbClr val="22C55E"/>
-          </a:solidFill>
-          <a:ln xmlns:a="http://schemas.openxmlformats.org/drawingml/2006/main" w="0">
-            <a:noFill/>
+            <a:srgbClr val="FF4D5E"/>
+          </a:solidFill>
+          <a:ln xmlns:a="http://schemas.openxmlformats.org/drawingml/2006/main" w="0">
+            <a:solidFill>
+              <a:srgbClr val="FF4D5E"/>
+            </a:solidFill>
             <a:prstDash val="solid"/>
           </a:ln>
         </p:spPr>
@@ -8973,17 +9095,17 @@
               <a:buNone/>
               <a:defRPr sz="1500">
                 <a:solidFill>
-                  <a:srgbClr val="DBE4EF"/>
+                  <a:srgbClr val="C7C2C2"/>
                 </a:solidFill>
               </a:defRPr>
             </a:pPr>
             <a:r>
               <a:rPr sz="1500">
                 <a:solidFill>
-                  <a:srgbClr val="DBE4EF"/>
-                </a:solidFill>
-              </a:rPr>
-              <a:t>Sistem sağlığı</a:t>
+                  <a:srgbClr val="C7C2C2"/>
+                </a:solidFill>
+              </a:rPr>
+              <a:t>Systemgesundheit</a:t>
             </a:r>
           </a:p>
         </p:txBody>
@@ -9011,10 +9133,12 @@
             <a:avLst/>
           </a:prstGeom>
           <a:solidFill xmlns:a="http://schemas.openxmlformats.org/drawingml/2006/main">
-            <a:srgbClr val="22C55E"/>
-          </a:solidFill>
-          <a:ln xmlns:a="http://schemas.openxmlformats.org/drawingml/2006/main" w="0">
-            <a:noFill/>
+            <a:srgbClr val="FF4D5E"/>
+          </a:solidFill>
+          <a:ln xmlns:a="http://schemas.openxmlformats.org/drawingml/2006/main" w="0">
+            <a:solidFill>
+              <a:srgbClr val="FF4D5E"/>
+            </a:solidFill>
             <a:prstDash val="solid"/>
           </a:ln>
         </p:spPr>
@@ -9055,17 +9179,17 @@
               <a:buNone/>
               <a:defRPr sz="1500">
                 <a:solidFill>
-                  <a:srgbClr val="DBE4EF"/>
+                  <a:srgbClr val="C7C2C2"/>
                 </a:solidFill>
               </a:defRPr>
             </a:pPr>
             <a:r>
               <a:rPr sz="1500">
                 <a:solidFill>
-                  <a:srgbClr val="DBE4EF"/>
-                </a:solidFill>
-              </a:rPr>
-              <a:t>Log ve hata görünürlüğü</a:t>
+                  <a:srgbClr val="C7C2C2"/>
+                </a:solidFill>
+              </a:rPr>
+              <a:t>Log- und Fehlersichtbarkeit</a:t>
             </a:r>
           </a:p>
         </p:txBody>
@@ -9095,11 +9219,11 @@
             </a:avLst>
           </a:prstGeom>
           <a:solidFill xmlns:a="http://schemas.openxmlformats.org/drawingml/2006/main">
-            <a:srgbClr val="111822"/>
+            <a:srgbClr val="171012"/>
           </a:solidFill>
           <a:ln xmlns:a="http://schemas.openxmlformats.org/drawingml/2006/main" w="9525">
             <a:solidFill>
-              <a:srgbClr val="1F2937"/>
+              <a:srgbClr val="5B1720"/>
             </a:solidFill>
             <a:prstDash val="solid"/>
           </a:ln>
@@ -9128,10 +9252,12 @@
             <a:avLst/>
           </a:prstGeom>
           <a:solidFill xmlns:a="http://schemas.openxmlformats.org/drawingml/2006/main">
-            <a:srgbClr val="F97316"/>
-          </a:solidFill>
-          <a:ln xmlns:a="http://schemas.openxmlformats.org/drawingml/2006/main" w="0">
-            <a:noFill/>
+            <a:srgbClr val="EF233C"/>
+          </a:solidFill>
+          <a:ln xmlns:a="http://schemas.openxmlformats.org/drawingml/2006/main" w="0">
+            <a:solidFill>
+              <a:srgbClr val="EF233C"/>
+            </a:solidFill>
             <a:prstDash val="solid"/>
           </a:ln>
         </p:spPr>
@@ -9172,17 +9298,17 @@
               <a:buNone/>
               <a:defRPr sz="1875" b="1">
                 <a:solidFill>
-                  <a:srgbClr val="FFFFFF"/>
+                  <a:srgbClr val="F8FAFC"/>
                 </a:solidFill>
               </a:defRPr>
             </a:pPr>
             <a:r>
               <a:rPr sz="1875" b="1">
                 <a:solidFill>
-                  <a:srgbClr val="FFFFFF"/>
-                </a:solidFill>
-              </a:rPr>
-              <a:t>Entegrasyon ve Demo</a:t>
+                  <a:srgbClr val="F8FAFC"/>
+                </a:solidFill>
+              </a:rPr>
+              <a:t>Integration und Demo</a:t>
             </a:r>
           </a:p>
         </p:txBody>
@@ -9210,10 +9336,12 @@
             <a:avLst/>
           </a:prstGeom>
           <a:solidFill xmlns:a="http://schemas.openxmlformats.org/drawingml/2006/main">
-            <a:srgbClr val="F97316"/>
-          </a:solidFill>
-          <a:ln xmlns:a="http://schemas.openxmlformats.org/drawingml/2006/main" w="0">
-            <a:noFill/>
+            <a:srgbClr val="FF4D5E"/>
+          </a:solidFill>
+          <a:ln xmlns:a="http://schemas.openxmlformats.org/drawingml/2006/main" w="0">
+            <a:solidFill>
+              <a:srgbClr val="FF4D5E"/>
+            </a:solidFill>
             <a:prstDash val="solid"/>
           </a:ln>
         </p:spPr>
@@ -9254,7 +9382,7 @@
               <a:buNone/>
               <a:defRPr sz="1500">
                 <a:solidFill>
-                  <a:srgbClr val="DBE4EF"/>
+                  <a:srgbClr val="C7C2C2"/>
                 </a:solidFill>
               </a:defRPr>
             </a:pPr>
@@ -9292,10 +9420,12 @@
             <a:avLst/>
           </a:prstGeom>
           <a:solidFill xmlns:a="http://schemas.openxmlformats.org/drawingml/2006/main">
-            <a:srgbClr val="F97316"/>
-          </a:solidFill>
-          <a:ln xmlns:a="http://schemas.openxmlformats.org/drawingml/2006/main" w="0">
-            <a:noFill/>
+            <a:srgbClr val="FF4D5E"/>
+          </a:solidFill>
+          <a:ln xmlns:a="http://schemas.openxmlformats.org/drawingml/2006/main" w="0">
+            <a:solidFill>
+              <a:srgbClr val="FF4D5E"/>
+            </a:solidFill>
             <a:prstDash val="solid"/>
           </a:ln>
         </p:spPr>
@@ -9336,17 +9466,17 @@
               <a:buNone/>
               <a:defRPr sz="1500">
                 <a:solidFill>
-                  <a:srgbClr val="DBE4EF"/>
+                  <a:srgbClr val="C7C2C2"/>
                 </a:solidFill>
               </a:defRPr>
             </a:pPr>
             <a:r>
               <a:rPr sz="1500">
                 <a:solidFill>
-                  <a:srgbClr val="DBE4EF"/>
-                </a:solidFill>
-              </a:rPr>
-              <a:t>Modüler kontrol katmanları</a:t>
+                  <a:srgbClr val="C7C2C2"/>
+                </a:solidFill>
+              </a:rPr>
+              <a:t>Modulare Steuerungsschichten</a:t>
             </a:r>
           </a:p>
         </p:txBody>
@@ -9374,10 +9504,12 @@
             <a:avLst/>
           </a:prstGeom>
           <a:solidFill xmlns:a="http://schemas.openxmlformats.org/drawingml/2006/main">
-            <a:srgbClr val="F97316"/>
-          </a:solidFill>
-          <a:ln xmlns:a="http://schemas.openxmlformats.org/drawingml/2006/main" w="0">
-            <a:noFill/>
+            <a:srgbClr val="FF4D5E"/>
+          </a:solidFill>
+          <a:ln xmlns:a="http://schemas.openxmlformats.org/drawingml/2006/main" w="0">
+            <a:solidFill>
+              <a:srgbClr val="FF4D5E"/>
+            </a:solidFill>
             <a:prstDash val="solid"/>
           </a:ln>
         </p:spPr>
@@ -9418,17 +9550,17 @@
               <a:buNone/>
               <a:defRPr sz="1500">
                 <a:solidFill>
-                  <a:srgbClr val="DBE4EF"/>
+                  <a:srgbClr val="C7C2C2"/>
                 </a:solidFill>
               </a:defRPr>
             </a:pPr>
             <a:r>
               <a:rPr sz="1500">
                 <a:solidFill>
-                  <a:srgbClr val="DBE4EF"/>
-                </a:solidFill>
-              </a:rPr>
-              <a:t>Demo-ready ürün hissi</a:t>
+                  <a:srgbClr val="C7C2C2"/>
+                </a:solidFill>
+              </a:rPr>
+              <a:t>Demo-reifes Produktgefühl</a:t>
             </a:r>
           </a:p>
         </p:txBody>

</xml_diff>